<commit_message>
feat(production): revise ACT 0 typography and demo path
Improve slide readability and package the static TRIAL-001 route for review.
</commit_message>
<xml_diff>
--- a/production/ACT_0.pptx
+++ b/production/ACT_0.pptx
@@ -838,32 +838,138 @@
           <a:lstStyle/>
           <a:p>
             <a:r>
-              <a:rPr lang="en-US" dirty="0"/>
-              <a:t>## S04 — 파일명을 주지 않으면 Agent는 어디부터 볼까?
-Slide ID: S04
-Working Title: 파일명을 주지 않으면 Agent는 어디부터 볼까?
-ACT / Section: ACT 0 / 0D
-Allocated Time: 2 minutes
-Mode Split: Lecture 2 minutes
-Primary Message: Demo에서는 파일을 직접 지정하지 않았을 때의 Search → Read → Trace를 관찰한다.
-Opening Question: “Agent가 Test, 구현, 호출 경로를 어떻게 찾는가?”
-Speaker Flow:
-1. **OPEN (0:00–0:30):** 이번 관찰의 질문을 제시한다.
-2. **SET WATCH FOR (0:30–1:30):** failing Test, 관련 구현, call path 세 가지를 차례로 읽는다. 결과 영역은 비워 둔다.
-3. **SCOPE (1:30–2:00):** 기준 자료가 Codex CLI 0.154.0의 read-only TRIAL-001 기록임을 알리고 S05로 넘긴다.
-Evidence / Source: DEMO-01, STATE-00, TRIAL-001, BEAT-003, OQ-003, OQ-005. 이 장은 Trial setup이며 관찰 결과를 아직 공개하지 않는다.
-Claim Boundary: 기록된 Trial은 격리된 비대화형 Codex CLI 0.154.0, macOS, `--sandbox read-only`, `--ignore-user-config` 조건에서 수행됐다. Codex Desktop, 교육 계정 또는 현재 제품 동작을 입증하지 않는다.
-Beginner Explanation: 결과를 보기 전에 무엇을 관찰할지 정하면 단순히 답만 읽는 것보다 Demo를 따라가기 쉽다.
-Advanced Insight: 답변뿐 아니라 파일 발견과 호출 경로 추적을 관찰 대상으로 둔다.
-C++ Vision Bridge: N/A.
-Demo Operation: DEMO-01 / WATCH. 기본 자료는 TRIAL-001 기록에 기반한 정적 setup이다. 현재 제품 UI를 그리거나 Live/Hybrid 경로를 실행하지 않는다. WATCH FOR는 Test, Implementation, Call path이며 결과는 빈 상태로 둔다. HYBRID 실행은 발표 계정·surface와 runbook을 확인한 뒤에만 활성화한다.
-Audience Interaction: 응답을 요구하지 않는다. 세 관찰 항목을 청중이 마음속으로 따라오게 한다.
-Transition: “실제 기록에서 어떤 Test와 경로가 발견됐을까요?”라고 묻고 S05에서 근거를 연다.
-Time Management: 2분 안에 질문과 세 Watch For를 제시하고 Trial 환경의 범위를 한 문장으로 제한한다.
-Fallback: 화면이 불가능하면 세 관찰 기준만 말로 제시한다. 현재 CLI 또는 Desktop UI를 재현하지 않는다.
-Validation Status: PROVISIONAL — T05-A 첫 구현은 검토함; 현재 제품 surface, 교육 계정, Live/Hybrid 경로와 target display는 미검증.</a:t>
-            </a:r>
-            <a:endParaRPr lang="en-US" dirty="0"/>
+              <a:t>## S04 — 파일명을 주지 않으면 Agent는 어디부터 볼까?</a:t>
+            </a:r>
+          </a:p>
+          <a:p/>
+          <a:p>
+            <a:r>
+              <a:t>Slide ID: S04</a:t>
+            </a:r>
+          </a:p>
+          <a:p/>
+          <a:p>
+            <a:r>
+              <a:t>Working Title: 파일명을 주지 않으면 Agent는 어디부터 볼까?</a:t>
+            </a:r>
+          </a:p>
+          <a:p/>
+          <a:p>
+            <a:r>
+              <a:t>ACT / Section: ACT 0 / 0D</a:t>
+            </a:r>
+          </a:p>
+          <a:p/>
+          <a:p>
+            <a:r>
+              <a:t>Allocated Time: 2 minutes</a:t>
+            </a:r>
+          </a:p>
+          <a:p/>
+          <a:p>
+            <a:r>
+              <a:t>Mode Split: Lecture 2 minutes</a:t>
+            </a:r>
+          </a:p>
+          <a:p/>
+          <a:p>
+            <a:r>
+              <a:t>Primary Message: Demo에서는 파일을 직접 지정하지 않았을 때의 Search → Read → Trace를 관찰한다.</a:t>
+            </a:r>
+          </a:p>
+          <a:p/>
+          <a:p>
+            <a:r>
+              <a:t>Opening Question: “Agent가 Test, 구현, 호출 경로를 어떻게 찾는가?”</a:t>
+            </a:r>
+          </a:p>
+          <a:p/>
+          <a:p>
+            <a:r>
+              <a:t>Speaker Flow:</a:t>
+            </a:r>
+          </a:p>
+          <a:p/>
+          <a:p>
+            <a:r>
+              <a:t>1. **OPEN (0:00–0:30):** 이번 관찰의 질문을 제시한다.</a:t>
+            </a:r>
+          </a:p>
+          <a:p>
+            <a:r>
+              <a:t>2. **SET WATCH FOR (0:30–1:30):** failing Test, 관련 구현, call path 세 가지를 차례로 읽는다. 결과 영역은 비워 둔다.</a:t>
+            </a:r>
+          </a:p>
+          <a:p>
+            <a:r>
+              <a:t>3. **SCOPE (1:30–2:00):** 기준 자료가 Codex CLI 0.154.0의 read-only TRIAL-001 기록임을 알리고 S05로 넘긴다.</a:t>
+            </a:r>
+          </a:p>
+          <a:p/>
+          <a:p>
+            <a:r>
+              <a:t>Evidence / Source: DEMO-01, STATE-00, TRIAL-001, BEAT-003, OQ-003, OQ-005. 이 장은 Trial setup이며 관찰 결과를 아직 공개하지 않는다.</a:t>
+            </a:r>
+          </a:p>
+          <a:p/>
+          <a:p>
+            <a:r>
+              <a:t>Claim Boundary: 기록된 Trial은 격리된 비대화형 Codex CLI 0.154.0, macOS, `--sandbox read-only`, `--ignore-user-config` 조건에서 수행됐다. Codex Desktop, 교육 계정 또는 현재 제품 동작을 입증하지 않는다.</a:t>
+            </a:r>
+          </a:p>
+          <a:p/>
+          <a:p>
+            <a:r>
+              <a:t>Beginner Explanation: 결과를 보기 전에 무엇을 관찰할지 정하면 단순히 답만 읽는 것보다 Demo를 따라가기 쉽다.</a:t>
+            </a:r>
+          </a:p>
+          <a:p/>
+          <a:p>
+            <a:r>
+              <a:t>Advanced Insight: 답변뿐 아니라 파일 발견과 호출 경로 추적을 관찰 대상으로 둔다.</a:t>
+            </a:r>
+          </a:p>
+          <a:p/>
+          <a:p>
+            <a:r>
+              <a:t>C++ Vision Bridge: N/A.</a:t>
+            </a:r>
+          </a:p>
+          <a:p/>
+          <a:p>
+            <a:r>
+              <a:t>Demo Operation: DEMO-01 / WATCH. 기본 경로는 정적 발표다. S04에서 Test, Implementation, Call path의 관찰 기준을 보여 주고 결과 영역은 비워 둔 뒤 S05로 이동한다. 자료는 `production/ACT_0.pptx`의 S04–S06과 `production/preview/act0/S04.png`–`S06.png`다. PNG는 PPT의 정적 렌더이며 실제 CLI 캡처가 아니다. 현재 Desktop·교육 계정 surface와 Live/Hybrid는 미검증이므로 지금 활성화하지 않는다. 향후 활성화하려면 대상 계정·surface, read-only 실행 조건, runbook, 기대 관찰 결과와 복귀 cue를 발표 환경에서 먼저 확인한다.</a:t>
+            </a:r>
+          </a:p>
+          <a:p/>
+          <a:p>
+            <a:r>
+              <a:t>Audience Interaction: 응답을 요구하지 않는다. 세 관찰 항목을 청중이 마음속으로 따라오게 한다.</a:t>
+            </a:r>
+          </a:p>
+          <a:p/>
+          <a:p>
+            <a:r>
+              <a:t>Transition: “실제 기록에서 어떤 Test와 경로가 발견됐을까요?”라고 묻고 S05에서 근거를 연다.</a:t>
+            </a:r>
+          </a:p>
+          <a:p/>
+          <a:p>
+            <a:r>
+              <a:t>Time Management: 2분 안에 질문과 세 Watch For를 제시하고 Trial 환경의 범위를 한 문장으로 제한한다.</a:t>
+            </a:r>
+          </a:p>
+          <a:p/>
+          <a:p>
+            <a:r>
+              <a:t>Fallback: READY — `production/ACT_0.pptx`의 S04 정적 슬라이드와 `production/preview/act0/S04.png`를 기본 발표 자료로 사용한다. 두 파일은 수정된 PPTX의 최종 로컬 렌더 결과다. 화면 공유가 모두 불가능하면 Test → Implementation → Call path를 말로 제시하고 S05의 기록 근거로 이동한다. Live CLI/Desktop을 즉석에서 열지 않는다. Windows·발표 PC·교육장 표시는 미검증이다.</a:t>
+            </a:r>
+          </a:p>
+          <a:p/>
+          <a:p>
+            <a:r>
+              <a:t>Validation Status: REVIEWED — LOCAL STATIC PATH CONFIRMED — PPTX S04와 한글 표시 PNG를 확인함. 시간 리허설, 현재 제품 surface·교육 계정, Windows PowerPoint와 room readability는 UNVERIFIED.</a:t>
+            </a:r>
           </a:p>
         </p:txBody>
       </p:sp>
@@ -948,34 +1054,148 @@
           <a:lstStyle/>
           <a:p>
             <a:r>
-              <a:rPr lang="en-US" dirty="0"/>
-              <a:t>## S05 — Agent가 Test와 호출 경로를 찾았다
-Slide ID: S05
-Working Title: Agent가 Test와 호출 경로를 찾았다
-ACT / Section: ACT 0 / 0D
-Allocated Time: 8 minutes
-Mode Split: Demo 8 minutes (HYBRID in the Slide Map; captured-evidence baseline until the presentation environment is verified)
-Primary Message: TRIAL-001 한 번의 읽기 전용 CLI 조사에서 Agent가 실패 Test, 구현 파일, 계약과 호출 경로를 찾아냈다.
-Opening Question: “지정하지 않은 파일과 호출 경로를 실제로 찾아냈는가?”
-Speaker Flow:
-1. **OPEN (0:00–1:00):** 결과 요약이 TRIAL-001의 재구성 도식임을 먼저 밝힌다. 실제 CLI screenshot처럼 제시하지 않는다.
-2. **SHOW (1:00–3:00):** `tests/test_transform.py::test_crop_excludes_end_coordinate`를 가리킨다.
-3. **TRACE (3:00–5:00):** `cli.main()` → `pipeline.process_image()` → `transform.crop()` 경로를 따라간다.
-4. **INTERPRET (5:00–7:00):** 계약 `[x_start, x_end)`와 관찰된 `row[x_start : x_end + 1]` 구현의 차이를 설명한다. 수정은 아직 하지 않았다고 말한다.
-5. **SCOPE (7:00–8:00):** 이번 관찰은 단일 read-only CLI run이라고 한정하고 S06에서 결과와 환경 오류를 분리한다고 예고한다.
-Evidence / Source: TRIAL-001, DEMO-01, STATE-00, CLM-0002, CLM-0009. 실패 Test 발견, 계약·구현 확인, 호출 경로 추적, extra-column 결과 설명, no-edit 준수는 해당 단일 run 기록에 있다.
-Claim Boundary: Codex CLI 0.154.0의 단일 read-only 조사다. 반복성, Codex Desktop, 교육 계정, 현재 제품 기능 또는 보편적인 탐색 능력을 입증하지 않는다. 도식은 TRIAL-001 기록을 재구성한 설명이며 원본 screenshot이 아니다.
-Beginner Explanation: 파일명을 미리 주지 않은 한 번의 조사에서 실패 Test와 관련 구현·호출 경로가 찾아졌다.
-Advanced Insight: 찾은 경로와 설명은 그 run에서 확인된 범위다. 설명과 수정, 검증은 다른 단계이며 이 Trial에서는 코드를 바꾸지 않았다.
-C++ Vision Bridge: N/A.
-Demo Operation: DEMO-01 / Evidence. CAPTURED 기록과 재구성 도식을 기본으로 사용한다. 화면 Label: `RECONSTRUCTED DIAGRAM · TRIAL-001 RECORD`, `OBSERVED PRODUCT · CODEX CLI 0.154.0 · READ-ONLY`. 실제 터미널 캡처가 없으면 도식을 screenshot처럼 꾸미지 않는다. HYBRID는 발표 환경 확인 전까지 비활성이다.
-Audience Interaction: 청중은 S04의 세 Watch For를 확인한다. 중간 응답이나 실습을 요구하지 않는다.
-Transition: 발견 사실을 다음 장에서 Repository 관찰과 실행 환경 제한으로 나눈다.
-Time Management: 8분을 Test, path, contract, scope 순서로 쓴다. 전체 로그·파일 목록·코드 수정을 읽지 않는다. 마지막 1분을 S06 handoff에 남긴다.
-Fallback: 선택·검증된 capture가 없으면 TRIAL-001의 기록에서 Test, path, contract를 도식으로 재구성한다. `RECONSTRUCTED DIAGRAM`을 보이고 실제 Terminal screenshot으로 주장하지 않는다. 준비된 기록은 승인된 발표 media 자체가 아니므로 fallback은 아직 PLANNED다.
-Validation Status: PROVISIONAL — TRIAL-001 facts와 T07-A first implementation 대조 완료; 최종 media 선택, Hybrid activation, 발표 PC와 target-scale 가독성 미완료.</a:t>
-            </a:r>
-            <a:endParaRPr lang="en-US" dirty="0"/>
+              <a:t>## S05 — Agent가 Test와 호출 경로를 찾았다</a:t>
+            </a:r>
+          </a:p>
+          <a:p/>
+          <a:p>
+            <a:r>
+              <a:t>Slide ID: S05</a:t>
+            </a:r>
+          </a:p>
+          <a:p/>
+          <a:p>
+            <a:r>
+              <a:t>Working Title: Agent가 Test와 호출 경로를 찾았다</a:t>
+            </a:r>
+          </a:p>
+          <a:p/>
+          <a:p>
+            <a:r>
+              <a:t>ACT / Section: ACT 0 / 0D</a:t>
+            </a:r>
+          </a:p>
+          <a:p/>
+          <a:p>
+            <a:r>
+              <a:t>Allocated Time: 8 minutes</a:t>
+            </a:r>
+          </a:p>
+          <a:p/>
+          <a:p>
+            <a:r>
+              <a:t>Mode Split: Demo 8 minutes (정적 TRIAL-001 기록·재구성 도식 기본 경로; HYBRID는 발표 환경 검증 전까지 비활성)</a:t>
+            </a:r>
+          </a:p>
+          <a:p/>
+          <a:p>
+            <a:r>
+              <a:t>Primary Message: TRIAL-001 한 번의 읽기 전용 CLI 조사에서 Agent가 실패 Test, 구현 파일, 계약과 호출 경로를 찾아냈다.</a:t>
+            </a:r>
+          </a:p>
+          <a:p/>
+          <a:p>
+            <a:r>
+              <a:t>Opening Question: “지정하지 않은 파일과 호출 경로를 실제로 찾아냈는가?”</a:t>
+            </a:r>
+          </a:p>
+          <a:p/>
+          <a:p>
+            <a:r>
+              <a:t>Speaker Flow:</a:t>
+            </a:r>
+          </a:p>
+          <a:p/>
+          <a:p>
+            <a:r>
+              <a:t>1. **OPEN (0:00–1:00):** 기록 근거를 사용한 정적 발표임을 밝히고, S05는 TRIAL-001을 재구성한 도식이며 실제 CLI screenshot이 아님을 말한다.</a:t>
+            </a:r>
+          </a:p>
+          <a:p>
+            <a:r>
+              <a:t>2. **SHOW (1:00–3:00):** `tests/test_transform.py::test_crop_excludes_end_coordinate`를 가리킨다.</a:t>
+            </a:r>
+          </a:p>
+          <a:p>
+            <a:r>
+              <a:t>3. **TRACE (3:00–5:00):** `cli.main()` → `pipeline.process_image()` → `transform.crop()` 경로를 따라간다.</a:t>
+            </a:r>
+          </a:p>
+          <a:p>
+            <a:r>
+              <a:t>4. **INTERPRET (5:00–7:00):** 계약 `[x_start, x_end)`와 관찰된 `row[x_start : x_end + 1]` 구현의 차이를 설명한다. 수정은 아직 하지 않았다고 말한다.</a:t>
+            </a:r>
+          </a:p>
+          <a:p>
+            <a:r>
+              <a:t>5. **SCOPE / HANDOFF (7:00–8:00):** 관찰은 단일 read-only CLI run에 한정됨을 다시 말하고 S06에서 결과와 환경 오류를 분리한다. 기본 경로에서는 이 마지막 1분에 Trial 결과를 요약해 handoff한다. 향후 별도 검증 후 Live를 허용해도 7:00에 hard stop하고 기록된 정적 경로로 복귀한다.</a:t>
+            </a:r>
+          </a:p>
+          <a:p/>
+          <a:p>
+            <a:r>
+              <a:t>Evidence / Source: TRIAL-001, DEMO-01, STATE-00, CLM-0002, CLM-0009. 실패 Test 발견, 계약·구현 확인, 호출 경로 추적, extra-column 결과 설명, no-edit 준수는 해당 단일 run 기록에 있다.</a:t>
+            </a:r>
+          </a:p>
+          <a:p/>
+          <a:p>
+            <a:r>
+              <a:t>Claim Boundary: Codex CLI 0.154.0의 단일 read-only 조사다. 반복성, Codex Desktop, 교육 계정, 현재 제품 기능 또는 보편적인 탐색 능력을 입증하지 않는다. 도식은 TRIAL-001 기록을 재구성한 설명이며 원본 screenshot이 아니다.</a:t>
+            </a:r>
+          </a:p>
+          <a:p/>
+          <a:p>
+            <a:r>
+              <a:t>Beginner Explanation: 파일명을 미리 주지 않은 한 번의 조사에서 실패 Test와 관련 구현·호출 경로가 찾아졌다.</a:t>
+            </a:r>
+          </a:p>
+          <a:p/>
+          <a:p>
+            <a:r>
+              <a:t>Advanced Insight: 찾은 경로와 설명은 그 run에서 확인된 범위다. 설명과 수정, 검증은 다른 단계이며 이 Trial에서는 코드를 바꾸지 않았다.</a:t>
+            </a:r>
+          </a:p>
+          <a:p/>
+          <a:p>
+            <a:r>
+              <a:t>C++ Vision Bridge: N/A.</a:t>
+            </a:r>
+          </a:p>
+          <a:p/>
+          <a:p>
+            <a:r>
+              <a:t>Demo Operation: DEMO-01 / 기본 경로는 `production/ACT_0.pptx` S05 또는 `production/preview/act0/S05.png`의 정적 evidence다. 근거는 `plan/DEMO_MATRIX.md`의 TRIAL-001 기록이며, 현재 산출물의 도식은 해당 기록의 재구성이다. Label `RECONSTRUCTED DIAGRAM · TRIAL-001 RECORD`와 `OBSERVED PRODUCT · CODEX CLI 0.154.0 · READ-ONLY`를 유지한다. 원본 터미널 캡처는 없으며 도식을 실제 캡처로 제시하지 않는다. Live/Hybrid는 현재 발표 계정·surface와 실행 조건이 확인되지 않아 비활성이다. 향후 검증을 거쳐 허용된 Live가 기대 결과를 보이지 않거나 권한·setup이 다르면 즉시 중단하고 “현재 환경에서는 이 과정을 확인할 수 없어, 기록된 TRIAL-001로 돌아가겠습니다.”라고 말한 뒤 S05 정적 도식으로 복귀한다. 복귀는 약 15초를 예상하되 실제 운영 시간은 리허설 전까지 미검증이다.</a:t>
+            </a:r>
+          </a:p>
+          <a:p/>
+          <a:p>
+            <a:r>
+              <a:t>Audience Interaction: 청중은 S04의 세 Watch For를 확인한다. 중간 응답이나 실습을 요구하지 않는다.</a:t>
+            </a:r>
+          </a:p>
+          <a:p/>
+          <a:p>
+            <a:r>
+              <a:t>Transition: 발견 사실을 다음 장에서 Repository 관찰과 실행 환경 제한으로 나눈다.</a:t>
+            </a:r>
+          </a:p>
+          <a:p/>
+          <a:p>
+            <a:r>
+              <a:t>Time Management: 8분 배분은 유지한다: 0:00–1:00 범위와 재구성 표시, 1:00–3:00 Test, 3:00–5:00 path, 5:00–7:00 contract/구현 차이, 7:00–8:00 single-run 경계와 S06 handoff. 전체 로그·파일 목록·코드 수정은 보여 주지 않는다. Live를 향후 검증해 허용해도 7:00을 hard stop으로 삼고 총 8분을 넘기지 않는다.</a:t>
+            </a:r>
+          </a:p>
+          <a:p/>
+          <a:p>
+            <a:r>
+              <a:t>Fallback: READY — 기본 발표는 `production/ACT_0.pptx` S05와 `production/preview/act0/S05.png`의 정적 근거를 사용한다. 도식은 TRIAL-001 검증 기록을 재구성한 것이며 실제 terminal screenshot이 아니다. 현재 Live/HYBRID는 활성화하지 않는다. 향후 별도 검증 후 Live를 허용했을 때 권한, setup 또는 예상 관찰이 맞지 않으면 즉시 중단하고 “현재 환경에서는 이 과정을 확인할 수 없어, 기록된 TRIAL-001로 돌아가겠습니다.”라고 말한 뒤 S05 정적 도식으로 복귀한다. 전환은 약 15초로 예상하지만 리허설 전까지 UNVERIFIED. Windows·발표 PC·교육장 적합성은 미검증이다.</a:t>
+            </a:r>
+          </a:p>
+          <a:p/>
+          <a:p>
+            <a:r>
+              <a:t>Validation Status: REVIEWED — LOCAL STATIC PATH CONFIRMED — Trial 기록, 재구성 표시, 수정 PPTX와 최종 S05 PNG를 확인함. 실제 CLI capture는 없으며 Live/HYBRID, 교육 계정/surface, Windows, room readability 및 8분 리허설은 UNVERIFIED.</a:t>
+            </a:r>
           </a:p>
         </p:txBody>
       </p:sp>
@@ -1060,33 +1280,143 @@
           <a:lstStyle/>
           <a:p>
             <a:r>
-              <a:rPr lang="en-US" dirty="0"/>
-              <a:t>## S06 — 관찰 결과와 실행 제한을 분리한다
-Slide ID: S06
-Working Title: 관찰 결과와 실행 제한을 분리한다
-ACT / Section: ACT 0 / 0D
-Allocated Time: 5 minutes
-Mode Split: Case 5 minutes
-Primary Message: TRIAL-001은 Crop의 추가 열을 재현·설명했지만 코드는 수정하지 않았고, 임시 디렉터리를 만들지 못한 3건의 오류는 읽기 전용 환경 제한이었다.
-Opening Question: “어떤 결과가 Repository 관찰이고, 어떤 결과가 실행 환경 제한인가?”
-Speaker Flow:
-1. **OPEN (0:00–0:45):** 두 칸을 한 번에 보여 주되 Repository observation과 environment limitation을 서로 다른 질문으로 읽는다.
-2. **SHOW (0:45–2:15):** 관찰 칸에서 실패 Test, 계약/구현 차이, 코드 미수정을 짚는다.
-3. **SHOW (2:15–3:30):** 환경 칸에서 read-only sandbox가 임시 디렉터리 생성 3건을 막은 것을 짚는다.
-4. **INTERPRET / TRANSFER (3:30–5:00):** 환경 오류를 Crop 또는 Repository 결함으로 분류하지 않고 “관찰 사실과 실행 조건을 나눠 본다”로 마무리한다.
-Evidence / Source: TRIAL-001의 full suite 기록: 7 passing tests, 기대한 crop failure, 임시 디렉터리를 만들 수 없어 발생한 3 errors. Focused command 기록: 2 passing tests와 같은 crop failure. Working tree는 변경되지 않았다.
-Claim Boundary: 세 errors는 read-only 환경의 temp-directory 제한이며 crop bug의 근거가 아니다. TRIAL-001은 코드 수정을 수행하지 않았다. Trial 범위 밖의 테스트 결과, 제품 동작 또는 반복성을 추론하지 않는다.
-Beginner Explanation: 기능의 관찰 결과와 실행 환경의 제한을 서로 다른 원인으로 적는다.
-Advanced Insight: 실제 결함 징후, 권한·환경 오류, 미측정 사항을 분류해 후속 판단이 잘못된 원인에 고정되지 않게 한다.
-C++ Vision Bridge: N/A.
-Demo Operation: DEMO-01 / WHAT HAPPENED. 정적 evidence 요약만 사용한다. 실행이나 새 테스트를 하지 않는다. Observation과 Environment limitation은 다른 frame과 명시적 label로 분리한다.
-Audience Interaction: 질문은 결과 해석을 위한 Case cue다. 응답을 받거나 환경 오류를 해결하게 하지 않는다.
-Transition: “Context를 찾는 주체가 바뀌면 무엇이 달라질까요?”라는 질문으로 S07에 연결한다.
-Time Management: Repo observation과 environment limitation에 시간을 나눠 쓴다. 원인 경계를 줄여 말하더라도 3 errors를 crop 결함으로 부르지 않는다.
-Fallback: 화면을 사용할 수 없으면 두 구분을 말로 설명하고 기록된 숫자만 사용한다. 기억에 의존해 다른 결과를 만들지 않는다.
-Validation Status: PROVISIONAL — Trial record 및 T07-A first implementation 대조 완료; 최종 target display와 발표 속도 미검증.</a:t>
-            </a:r>
-            <a:endParaRPr lang="en-US" dirty="0"/>
+              <a:t>## S06 — 관찰 결과와 실행 제한을 분리한다</a:t>
+            </a:r>
+          </a:p>
+          <a:p/>
+          <a:p>
+            <a:r>
+              <a:t>Slide ID: S06</a:t>
+            </a:r>
+          </a:p>
+          <a:p/>
+          <a:p>
+            <a:r>
+              <a:t>Working Title: 관찰 결과와 실행 제한을 분리한다</a:t>
+            </a:r>
+          </a:p>
+          <a:p/>
+          <a:p>
+            <a:r>
+              <a:t>ACT / Section: ACT 0 / 0D</a:t>
+            </a:r>
+          </a:p>
+          <a:p/>
+          <a:p>
+            <a:r>
+              <a:t>Allocated Time: 5 minutes</a:t>
+            </a:r>
+          </a:p>
+          <a:p/>
+          <a:p>
+            <a:r>
+              <a:t>Mode Split: Case 5 minutes</a:t>
+            </a:r>
+          </a:p>
+          <a:p/>
+          <a:p>
+            <a:r>
+              <a:t>Primary Message: TRIAL-001은 Crop의 추가 열을 재현·설명했지만 코드는 수정하지 않았고, 임시 디렉터리를 만들지 못한 3건의 오류는 읽기 전용 환경 제한이었다.</a:t>
+            </a:r>
+          </a:p>
+          <a:p/>
+          <a:p>
+            <a:r>
+              <a:t>Opening Question: “어떤 결과가 Repository 관찰이고, 어떤 결과가 실행 환경 제한인가?”</a:t>
+            </a:r>
+          </a:p>
+          <a:p/>
+          <a:p>
+            <a:r>
+              <a:t>Speaker Flow:</a:t>
+            </a:r>
+          </a:p>
+          <a:p/>
+          <a:p>
+            <a:r>
+              <a:t>1. **OPEN (0:00–0:45):** 두 칸을 한 번에 보여 주되 Repository observation과 environment limitation을 서로 다른 질문으로 읽는다.</a:t>
+            </a:r>
+          </a:p>
+          <a:p>
+            <a:r>
+              <a:t>2. **SHOW (0:45–2:15):** 관찰 칸에서 실패 Test, 계약/구현 차이, 코드 미수정을 짚는다.</a:t>
+            </a:r>
+          </a:p>
+          <a:p>
+            <a:r>
+              <a:t>3. **SHOW (2:15–3:30):** 환경 칸에서 read-only sandbox가 임시 디렉터리 생성 3건을 막은 것을 짚는다.</a:t>
+            </a:r>
+          </a:p>
+          <a:p>
+            <a:r>
+              <a:t>4. **INTERPRET / TRANSFER (3:30–5:00):** 환경 오류를 Crop 또는 Repository 결함으로 분류하지 않고 “관찰 사실과 실행 조건을 나눠 본다”로 마무리한다.</a:t>
+            </a:r>
+          </a:p>
+          <a:p/>
+          <a:p>
+            <a:r>
+              <a:t>Evidence / Source: TRIAL-001의 full suite 기록: 7 passing tests, 기대한 crop failure, 임시 디렉터리를 만들 수 없어 발생한 3 errors. Focused command 기록: 2 passing tests와 같은 crop failure. Working tree는 변경되지 않았다.</a:t>
+            </a:r>
+          </a:p>
+          <a:p/>
+          <a:p>
+            <a:r>
+              <a:t>Claim Boundary: 세 errors는 read-only 환경의 temp-directory 제한이며 crop bug의 근거가 아니다. TRIAL-001은 코드 수정을 수행하지 않았다. Trial 범위 밖의 테스트 결과, 제품 동작 또는 반복성을 추론하지 않는다.</a:t>
+            </a:r>
+          </a:p>
+          <a:p/>
+          <a:p>
+            <a:r>
+              <a:t>Beginner Explanation: 기능의 관찰 결과와 실행 환경의 제한을 서로 다른 원인으로 적는다.</a:t>
+            </a:r>
+          </a:p>
+          <a:p/>
+          <a:p>
+            <a:r>
+              <a:t>Advanced Insight: 실제 결함 징후, 권한·환경 오류, 미측정 사항을 분류해 후속 판단이 잘못된 원인에 고정되지 않게 한다.</a:t>
+            </a:r>
+          </a:p>
+          <a:p/>
+          <a:p>
+            <a:r>
+              <a:t>C++ Vision Bridge: N/A.</a:t>
+            </a:r>
+          </a:p>
+          <a:p/>
+          <a:p>
+            <a:r>
+              <a:t>Demo Operation: DEMO-01 / WHAT HAPPENED. `production/ACT_0.pptx` S06 또는 `production/preview/act0/S06.png`로 관찰과 환경 제한을 정적으로 설명한다. 0:00–0:45 두 frame, 0:45–2:15 Repository observation, 2:15–3:30 environment limitation, 3:30–5:00 원인 경계와 S07 전이를 운영한다. 실행·새 테스트는 하지 않는다. Observation과 Environment limitation은 서로 다른 frame과 label로 유지한다.</a:t>
+            </a:r>
+          </a:p>
+          <a:p/>
+          <a:p>
+            <a:r>
+              <a:t>Audience Interaction: 질문은 결과 해석을 위한 Case cue다. 응답을 받거나 환경 오류를 해결하게 하지 않는다.</a:t>
+            </a:r>
+          </a:p>
+          <a:p/>
+          <a:p>
+            <a:r>
+              <a:t>Transition: “Context를 찾는 주체가 바뀌면 무엇이 달라질까요?”라는 질문으로 S07에 연결한다.</a:t>
+            </a:r>
+          </a:p>
+          <a:p/>
+          <a:p>
+            <a:r>
+              <a:t>Time Management: Repo observation과 environment limitation에 시간을 나눠 쓴다. 원인 경계를 줄여 말하더라도 3 errors를 crop 결함으로 부르지 않는다.</a:t>
+            </a:r>
+          </a:p>
+          <a:p/>
+          <a:p>
+            <a:r>
+              <a:t>Fallback: READY — 기본 발표는 `production/ACT_0.pptx` S06과 `production/preview/act0/S06.png`의 정적 화면을 사용한다. 화면이 안 보이면 TRIAL-001의 기록된 숫자와 Repository observation / environment limitation 두 범주만 말로 설명하고 새 결과를 보태지 않는다. S05에서 복귀한 경우 약 15초 뒤 S06으로 이어가며, 5분 Case time과 다음 Slide handoff를 지킨다. 전환 시간은 리허설 전까지 UNVERIFIED. Windows와 room visibility는 UNVERIFIED.</a:t>
+            </a:r>
+          </a:p>
+          <a:p/>
+          <a:p>
+            <a:r>
+              <a:t>Validation Status: REVIEWED — LOCAL STATIC PATH CONFIRMED — 수정 PPTX와 최종 한글 표시 S06 PNG를 확인함. 5분 운영 리허설, Windows PowerPoint 및 room readability는 UNVERIFIED.</a:t>
+            </a:r>
           </a:p>
         </p:txBody>
       </p:sp>
@@ -1887,7 +2217,7 @@
         <p:spPr>
           <a:xfrm>
             <a:off x="658368" y="384048"/>
-            <a:ext cx="3200400" cy="201168"/>
+            <a:ext cx="3200400" cy="237744"/>
           </a:xfrm>
           <a:prstGeom prst="rect">
             <a:avLst/>
@@ -1905,7 +2235,7 @@
               <a:buNone/>
             </a:pPr>
             <a:r>
-              <a:rPr lang="en-US" sz="1000" b="1" spc="30" kern="0" dirty="0">
+              <a:rPr lang="en-US" sz="1400" b="1" spc="30" kern="0" dirty="0">
                 <a:solidFill>
                   <a:srgbClr val="0B6172"/>
                 </a:solidFill>
@@ -1946,7 +2276,7 @@
               <a:buNone/>
             </a:pPr>
             <a:r>
-              <a:rPr lang="en-US" sz="3000" b="1" dirty="0">
+              <a:rPr lang="en-US" sz="3400" b="1" dirty="0">
                 <a:solidFill>
                   <a:srgbClr val="17212B"/>
                 </a:solidFill>
@@ -1968,8 +2298,8 @@
         </p:nvSpPr>
         <p:spPr>
           <a:xfrm>
-            <a:off x="9738360" y="6428232"/>
-            <a:ext cx="1783080" cy="182880"/>
+            <a:off x="9418320" y="6181344"/>
+            <a:ext cx="2103120" cy="228600"/>
           </a:xfrm>
           <a:prstGeom prst="rect">
             <a:avLst/>
@@ -1987,7 +2317,7 @@
               <a:buNone/>
             </a:pPr>
             <a:r>
-              <a:rPr lang="en-US" sz="900" dirty="0">
+              <a:rPr lang="en-US" sz="1400" dirty="0">
                 <a:solidFill>
                   <a:srgbClr val="5B6570"/>
                 </a:solidFill>
@@ -2010,7 +2340,7 @@
         <p:spPr>
           <a:xfrm>
             <a:off x="822960" y="1874520"/>
-            <a:ext cx="6400800" cy="201168"/>
+            <a:ext cx="6400800" cy="256032"/>
           </a:xfrm>
           <a:prstGeom prst="rect">
             <a:avLst/>
@@ -2028,7 +2358,7 @@
               <a:buNone/>
             </a:pPr>
             <a:r>
-              <a:rPr lang="en-US" sz="1000" b="1" spc="30" kern="0" dirty="0">
+              <a:rPr lang="en-US" sz="1400" b="1" spc="30" kern="0" dirty="0">
                 <a:solidFill>
                   <a:srgbClr val="5B6570"/>
                 </a:solidFill>
@@ -2567,7 +2897,7 @@
         <p:spPr>
           <a:xfrm>
             <a:off x="658368" y="384048"/>
-            <a:ext cx="3200400" cy="201168"/>
+            <a:ext cx="3200400" cy="237744"/>
           </a:xfrm>
           <a:prstGeom prst="rect">
             <a:avLst/>
@@ -2585,7 +2915,7 @@
               <a:buNone/>
             </a:pPr>
             <a:r>
-              <a:rPr lang="en-US" sz="1000" b="1" spc="30" kern="0" dirty="0">
+              <a:rPr lang="en-US" sz="1400" b="1" spc="30" kern="0" dirty="0">
                 <a:solidFill>
                   <a:srgbClr val="0B6172"/>
                 </a:solidFill>
@@ -2626,7 +2956,7 @@
               <a:buNone/>
             </a:pPr>
             <a:r>
-              <a:rPr lang="en-US" sz="3000" b="1" dirty="0">
+              <a:rPr lang="en-US" sz="3400" b="1" dirty="0">
                 <a:solidFill>
                   <a:srgbClr val="17212B"/>
                 </a:solidFill>
@@ -2648,8 +2978,8 @@
         </p:nvSpPr>
         <p:spPr>
           <a:xfrm>
-            <a:off x="9738360" y="6428232"/>
-            <a:ext cx="1783080" cy="182880"/>
+            <a:off x="9418320" y="6181344"/>
+            <a:ext cx="2103120" cy="228600"/>
           </a:xfrm>
           <a:prstGeom prst="rect">
             <a:avLst/>
@@ -2667,7 +2997,7 @@
               <a:buNone/>
             </a:pPr>
             <a:r>
-              <a:rPr lang="en-US" sz="900" dirty="0">
+              <a:rPr lang="en-US" sz="1400" dirty="0">
                 <a:solidFill>
                   <a:srgbClr val="5B6570"/>
                 </a:solidFill>
@@ -2717,7 +3047,7 @@
         <p:spPr>
           <a:xfrm>
             <a:off x="804672" y="2404872"/>
-            <a:ext cx="292608" cy="256032"/>
+            <a:ext cx="292608" cy="274320"/>
           </a:xfrm>
           <a:prstGeom prst="rect">
             <a:avLst/>
@@ -2735,7 +3065,7 @@
               <a:buNone/>
             </a:pPr>
             <a:r>
-              <a:rPr lang="en-US" sz="1200" b="1" dirty="0">
+              <a:rPr lang="en-US" sz="1400" b="1" dirty="0">
                 <a:solidFill>
                   <a:srgbClr val="0B6172"/>
                 </a:solidFill>
@@ -2776,7 +3106,7 @@
               <a:buNone/>
             </a:pPr>
             <a:r>
-              <a:rPr lang="en-US" sz="1700" b="1" dirty="0">
+              <a:rPr lang="en-US" sz="1800" b="1" dirty="0">
                 <a:solidFill>
                   <a:srgbClr val="17212B"/>
                 </a:solidFill>
@@ -2799,7 +3129,7 @@
         <p:spPr>
           <a:xfrm>
             <a:off x="786384" y="3163824"/>
-            <a:ext cx="1773936" cy="219456"/>
+            <a:ext cx="1773936" cy="256032"/>
           </a:xfrm>
           <a:prstGeom prst="rect">
             <a:avLst/>
@@ -2817,7 +3147,7 @@
               <a:buNone/>
             </a:pPr>
             <a:r>
-              <a:rPr lang="en-US" sz="1200" dirty="0">
+              <a:rPr lang="en-US" sz="1400" dirty="0">
                 <a:solidFill>
                   <a:srgbClr val="4D5A68"/>
                 </a:solidFill>
@@ -2908,7 +3238,7 @@
         <p:spPr>
           <a:xfrm>
             <a:off x="2999232" y="2404872"/>
-            <a:ext cx="292608" cy="256032"/>
+            <a:ext cx="292608" cy="274320"/>
           </a:xfrm>
           <a:prstGeom prst="rect">
             <a:avLst/>
@@ -2926,7 +3256,7 @@
               <a:buNone/>
             </a:pPr>
             <a:r>
-              <a:rPr lang="en-US" sz="1200" b="1" dirty="0">
+              <a:rPr lang="en-US" sz="1400" b="1" dirty="0">
                 <a:solidFill>
                   <a:srgbClr val="0B6172"/>
                 </a:solidFill>
@@ -2967,7 +3297,7 @@
               <a:buNone/>
             </a:pPr>
             <a:r>
-              <a:rPr lang="en-US" sz="1700" b="1" dirty="0">
+              <a:rPr lang="en-US" sz="1800" b="1" dirty="0">
                 <a:solidFill>
                   <a:srgbClr val="17212B"/>
                 </a:solidFill>
@@ -2990,7 +3320,7 @@
         <p:spPr>
           <a:xfrm>
             <a:off x="2980944" y="3163824"/>
-            <a:ext cx="1773936" cy="219456"/>
+            <a:ext cx="1773936" cy="256032"/>
           </a:xfrm>
           <a:prstGeom prst="rect">
             <a:avLst/>
@@ -3008,7 +3338,7 @@
               <a:buNone/>
             </a:pPr>
             <a:r>
-              <a:rPr lang="en-US" sz="1200" dirty="0">
+              <a:rPr lang="en-US" sz="1400" dirty="0">
                 <a:solidFill>
                   <a:srgbClr val="4D5A68"/>
                 </a:solidFill>
@@ -3099,7 +3429,7 @@
         <p:spPr>
           <a:xfrm>
             <a:off x="5193792" y="2404872"/>
-            <a:ext cx="292608" cy="256032"/>
+            <a:ext cx="292608" cy="274320"/>
           </a:xfrm>
           <a:prstGeom prst="rect">
             <a:avLst/>
@@ -3117,7 +3447,7 @@
               <a:buNone/>
             </a:pPr>
             <a:r>
-              <a:rPr lang="en-US" sz="1200" b="1" dirty="0">
+              <a:rPr lang="en-US" sz="1400" b="1" dirty="0">
                 <a:solidFill>
                   <a:srgbClr val="0B6172"/>
                 </a:solidFill>
@@ -3158,7 +3488,7 @@
               <a:buNone/>
             </a:pPr>
             <a:r>
-              <a:rPr lang="en-US" sz="1700" b="1" dirty="0">
+              <a:rPr lang="en-US" sz="1800" b="1" dirty="0">
                 <a:solidFill>
                   <a:srgbClr val="17212B"/>
                 </a:solidFill>
@@ -3181,7 +3511,7 @@
         <p:spPr>
           <a:xfrm>
             <a:off x="5175504" y="3163824"/>
-            <a:ext cx="1773936" cy="219456"/>
+            <a:ext cx="1773936" cy="256032"/>
           </a:xfrm>
           <a:prstGeom prst="rect">
             <a:avLst/>
@@ -3199,7 +3529,7 @@
               <a:buNone/>
             </a:pPr>
             <a:r>
-              <a:rPr lang="en-US" sz="1200" dirty="0">
+              <a:rPr lang="en-US" sz="1400" dirty="0">
                 <a:solidFill>
                   <a:srgbClr val="4D5A68"/>
                 </a:solidFill>
@@ -3290,7 +3620,7 @@
         <p:spPr>
           <a:xfrm>
             <a:off x="7388352" y="2404872"/>
-            <a:ext cx="292608" cy="256032"/>
+            <a:ext cx="292608" cy="274320"/>
           </a:xfrm>
           <a:prstGeom prst="rect">
             <a:avLst/>
@@ -3308,7 +3638,7 @@
               <a:buNone/>
             </a:pPr>
             <a:r>
-              <a:rPr lang="en-US" sz="1200" b="1" dirty="0">
+              <a:rPr lang="en-US" sz="1400" b="1" dirty="0">
                 <a:solidFill>
                   <a:srgbClr val="0B6172"/>
                 </a:solidFill>
@@ -3349,7 +3679,7 @@
               <a:buNone/>
             </a:pPr>
             <a:r>
-              <a:rPr lang="en-US" sz="1700" b="1" dirty="0">
+              <a:rPr lang="en-US" sz="1800" b="1" dirty="0">
                 <a:solidFill>
                   <a:srgbClr val="17212B"/>
                 </a:solidFill>
@@ -3372,7 +3702,7 @@
         <p:spPr>
           <a:xfrm>
             <a:off x="7370064" y="3163824"/>
-            <a:ext cx="1773936" cy="219456"/>
+            <a:ext cx="1773936" cy="256032"/>
           </a:xfrm>
           <a:prstGeom prst="rect">
             <a:avLst/>
@@ -3390,7 +3720,7 @@
               <a:buNone/>
             </a:pPr>
             <a:r>
-              <a:rPr lang="en-US" sz="1200" dirty="0">
+              <a:rPr lang="en-US" sz="1400" dirty="0">
                 <a:solidFill>
                   <a:srgbClr val="4D5A68"/>
                 </a:solidFill>
@@ -3481,7 +3811,7 @@
         <p:spPr>
           <a:xfrm>
             <a:off x="9582912" y="2404872"/>
-            <a:ext cx="292608" cy="256032"/>
+            <a:ext cx="292608" cy="274320"/>
           </a:xfrm>
           <a:prstGeom prst="rect">
             <a:avLst/>
@@ -3499,7 +3829,7 @@
               <a:buNone/>
             </a:pPr>
             <a:r>
-              <a:rPr lang="en-US" sz="1200" b="1" dirty="0">
+              <a:rPr lang="en-US" sz="1400" b="1" dirty="0">
                 <a:solidFill>
                   <a:srgbClr val="0B6172"/>
                 </a:solidFill>
@@ -3540,7 +3870,7 @@
               <a:buNone/>
             </a:pPr>
             <a:r>
-              <a:rPr lang="en-US" sz="1700" b="1" dirty="0">
+              <a:rPr lang="en-US" sz="1800" b="1" dirty="0">
                 <a:solidFill>
                   <a:srgbClr val="17212B"/>
                 </a:solidFill>
@@ -3563,7 +3893,7 @@
         <p:spPr>
           <a:xfrm>
             <a:off x="9564624" y="3163824"/>
-            <a:ext cx="1773936" cy="219456"/>
+            <a:ext cx="1773936" cy="256032"/>
           </a:xfrm>
           <a:prstGeom prst="rect">
             <a:avLst/>
@@ -3581,7 +3911,7 @@
               <a:buNone/>
             </a:pPr>
             <a:r>
-              <a:rPr lang="en-US" sz="1200" dirty="0">
+              <a:rPr lang="en-US" sz="1400" dirty="0">
                 <a:solidFill>
                   <a:srgbClr val="4D5A68"/>
                 </a:solidFill>
@@ -3672,7 +4002,7 @@
         <p:spPr>
           <a:xfrm>
             <a:off x="1115568" y="5394960"/>
-            <a:ext cx="6400800" cy="201168"/>
+            <a:ext cx="6400800" cy="256032"/>
           </a:xfrm>
           <a:prstGeom prst="rect">
             <a:avLst/>
@@ -3690,7 +4020,7 @@
               <a:buNone/>
             </a:pPr>
             <a:r>
-              <a:rPr lang="en-US" sz="1000" b="1" spc="30" kern="0" dirty="0">
+              <a:rPr lang="en-US" sz="1400" b="1" spc="30" kern="0" dirty="0">
                 <a:solidFill>
                   <a:srgbClr val="5B6570"/>
                 </a:solidFill>
@@ -3738,7 +4068,7 @@
         <p:spPr>
           <a:xfrm>
             <a:off x="658368" y="384048"/>
-            <a:ext cx="3200400" cy="201168"/>
+            <a:ext cx="3200400" cy="237744"/>
           </a:xfrm>
           <a:prstGeom prst="rect">
             <a:avLst/>
@@ -3756,7 +4086,7 @@
               <a:buNone/>
             </a:pPr>
             <a:r>
-              <a:rPr lang="en-US" sz="1000" b="1" spc="30" kern="0" dirty="0">
+              <a:rPr lang="en-US" sz="1400" b="1" spc="30" kern="0" dirty="0">
                 <a:solidFill>
                   <a:srgbClr val="0B6172"/>
                 </a:solidFill>
@@ -3797,7 +4127,7 @@
               <a:buNone/>
             </a:pPr>
             <a:r>
-              <a:rPr lang="en-US" sz="3000" b="1" dirty="0">
+              <a:rPr lang="en-US" sz="3400" b="1" dirty="0">
                 <a:solidFill>
                   <a:srgbClr val="17212B"/>
                 </a:solidFill>
@@ -3819,8 +4149,8 @@
         </p:nvSpPr>
         <p:spPr>
           <a:xfrm>
-            <a:off x="9738360" y="6428232"/>
-            <a:ext cx="1783080" cy="182880"/>
+            <a:off x="9418320" y="6181344"/>
+            <a:ext cx="2103120" cy="228600"/>
           </a:xfrm>
           <a:prstGeom prst="rect">
             <a:avLst/>
@@ -3838,7 +4168,7 @@
               <a:buNone/>
             </a:pPr>
             <a:r>
-              <a:rPr lang="en-US" sz="900" dirty="0">
+              <a:rPr lang="en-US" sz="1400" dirty="0">
                 <a:solidFill>
                   <a:srgbClr val="5B6570"/>
                 </a:solidFill>
@@ -3906,7 +4236,7 @@
               <a:buNone/>
             </a:pPr>
             <a:r>
-              <a:rPr lang="en-US" sz="1000" b="1" dirty="0">
+              <a:rPr lang="en-US" sz="1400" b="1" dirty="0">
                 <a:solidFill>
                   <a:srgbClr val="4D5A68"/>
                 </a:solidFill>
@@ -3956,7 +4286,7 @@
         <p:spPr>
           <a:xfrm>
             <a:off x="1024128" y="2542032"/>
-            <a:ext cx="1920240" cy="201168"/>
+            <a:ext cx="1920240" cy="256032"/>
           </a:xfrm>
           <a:prstGeom prst="rect">
             <a:avLst/>
@@ -3974,7 +4304,7 @@
               <a:buNone/>
             </a:pPr>
             <a:r>
-              <a:rPr lang="en-US" sz="1000" b="1" spc="30" kern="0" dirty="0">
+              <a:rPr lang="en-US" sz="1400" b="1" spc="30" kern="0" dirty="0">
                 <a:solidFill>
                   <a:srgbClr val="0B6172"/>
                 </a:solidFill>
@@ -4055,7 +4385,7 @@
         <p:spPr>
           <a:xfrm>
             <a:off x="1005840" y="4041648"/>
-            <a:ext cx="1975104" cy="347472"/>
+            <a:ext cx="1975104" cy="365760"/>
           </a:xfrm>
           <a:prstGeom prst="rect">
             <a:avLst/>
@@ -4073,7 +4403,7 @@
               <a:buNone/>
             </a:pPr>
             <a:r>
-              <a:rPr lang="en-US" sz="1300" dirty="0">
+              <a:rPr lang="en-US" sz="1500" dirty="0">
                 <a:solidFill>
                   <a:srgbClr val="4D5A68"/>
                 </a:solidFill>
@@ -4137,7 +4467,7 @@
         <p:spPr>
           <a:xfrm>
             <a:off x="3950208" y="2075688"/>
-            <a:ext cx="4114800" cy="201168"/>
+            <a:ext cx="4114800" cy="256032"/>
           </a:xfrm>
           <a:prstGeom prst="rect">
             <a:avLst/>
@@ -4155,7 +4485,7 @@
               <a:buNone/>
             </a:pPr>
             <a:r>
-              <a:rPr lang="en-US" sz="1000" b="1" spc="30" kern="0" dirty="0">
+              <a:rPr lang="en-US" sz="1400" b="1" spc="30" kern="0" dirty="0">
                 <a:solidFill>
                   <a:srgbClr val="5B6570"/>
                 </a:solidFill>
@@ -4223,7 +4553,7 @@
               <a:buNone/>
             </a:pPr>
             <a:r>
-              <a:rPr lang="en-US" sz="1600" b="1" dirty="0">
+              <a:rPr lang="en-US" sz="1700" b="1" dirty="0">
                 <a:solidFill>
                   <a:srgbClr val="17212B"/>
                 </a:solidFill>
@@ -4246,7 +4576,7 @@
         <p:spPr>
           <a:xfrm>
             <a:off x="4059936" y="2926080"/>
-            <a:ext cx="1609344" cy="201168"/>
+            <a:ext cx="1609344" cy="237744"/>
           </a:xfrm>
           <a:prstGeom prst="rect">
             <a:avLst/>
@@ -4264,7 +4594,7 @@
               <a:buNone/>
             </a:pPr>
             <a:r>
-              <a:rPr lang="en-US" sz="1100" dirty="0">
+              <a:rPr lang="en-US" sz="1400" dirty="0">
                 <a:solidFill>
                   <a:srgbClr val="4D5A68"/>
                 </a:solidFill>
@@ -4332,7 +4662,7 @@
               <a:buNone/>
             </a:pPr>
             <a:r>
-              <a:rPr lang="en-US" sz="1600" b="1" dirty="0">
+              <a:rPr lang="en-US" sz="1700" b="1" dirty="0">
                 <a:solidFill>
                   <a:srgbClr val="17212B"/>
                 </a:solidFill>
@@ -4355,7 +4685,7 @@
         <p:spPr>
           <a:xfrm>
             <a:off x="6071616" y="2926080"/>
-            <a:ext cx="1609344" cy="201168"/>
+            <a:ext cx="1609344" cy="237744"/>
           </a:xfrm>
           <a:prstGeom prst="rect">
             <a:avLst/>
@@ -4373,7 +4703,7 @@
               <a:buNone/>
             </a:pPr>
             <a:r>
-              <a:rPr lang="en-US" sz="1100" dirty="0">
+              <a:rPr lang="en-US" sz="1400" dirty="0">
                 <a:solidFill>
                   <a:srgbClr val="4D5A68"/>
                 </a:solidFill>
@@ -4441,7 +4771,7 @@
               <a:buNone/>
             </a:pPr>
             <a:r>
-              <a:rPr lang="en-US" sz="1600" b="1" dirty="0">
+              <a:rPr lang="en-US" sz="1700" b="1" dirty="0">
                 <a:solidFill>
                   <a:srgbClr val="17212B"/>
                 </a:solidFill>
@@ -4464,7 +4794,7 @@
         <p:spPr>
           <a:xfrm>
             <a:off x="4059936" y="4206240"/>
-            <a:ext cx="1609344" cy="201168"/>
+            <a:ext cx="1609344" cy="237744"/>
           </a:xfrm>
           <a:prstGeom prst="rect">
             <a:avLst/>
@@ -4482,7 +4812,7 @@
               <a:buNone/>
             </a:pPr>
             <a:r>
-              <a:rPr lang="en-US" sz="1100" dirty="0">
+              <a:rPr lang="en-US" sz="1400" dirty="0">
                 <a:solidFill>
                   <a:srgbClr val="4D5A68"/>
                 </a:solidFill>
@@ -4550,7 +4880,7 @@
               <a:buNone/>
             </a:pPr>
             <a:r>
-              <a:rPr lang="en-US" sz="1600" b="1" dirty="0">
+              <a:rPr lang="en-US" sz="1700" b="1" dirty="0">
                 <a:solidFill>
                   <a:srgbClr val="17212B"/>
                 </a:solidFill>
@@ -4573,7 +4903,7 @@
         <p:spPr>
           <a:xfrm>
             <a:off x="6071616" y="4206240"/>
-            <a:ext cx="1609344" cy="201168"/>
+            <a:ext cx="1609344" cy="237744"/>
           </a:xfrm>
           <a:prstGeom prst="rect">
             <a:avLst/>
@@ -4591,7 +4921,7 @@
               <a:buNone/>
             </a:pPr>
             <a:r>
-              <a:rPr lang="en-US" sz="1100" dirty="0">
+              <a:rPr lang="en-US" sz="1400" dirty="0">
                 <a:solidFill>
                   <a:srgbClr val="4D5A68"/>
                 </a:solidFill>
@@ -4682,7 +5012,7 @@
         <p:spPr>
           <a:xfrm>
             <a:off x="8750808" y="2578608"/>
-            <a:ext cx="2331720" cy="201168"/>
+            <a:ext cx="2331720" cy="256032"/>
           </a:xfrm>
           <a:prstGeom prst="rect">
             <a:avLst/>
@@ -4700,7 +5030,7 @@
               <a:buNone/>
             </a:pPr>
             <a:r>
-              <a:rPr lang="en-US" sz="1000" b="1" spc="30" kern="0" dirty="0">
+              <a:rPr lang="en-US" sz="1400" b="1" spc="30" kern="0" dirty="0">
                 <a:solidFill>
                   <a:srgbClr val="0B6172"/>
                 </a:solidFill>
@@ -4781,7 +5111,7 @@
         <p:spPr>
           <a:xfrm>
             <a:off x="8705088" y="4160520"/>
-            <a:ext cx="2414016" cy="274320"/>
+            <a:ext cx="2414016" cy="256032"/>
           </a:xfrm>
           <a:prstGeom prst="rect">
             <a:avLst/>
@@ -4799,7 +5129,7 @@
               <a:buNone/>
             </a:pPr>
             <a:r>
-              <a:rPr lang="en-US" sz="1200" dirty="0">
+              <a:rPr lang="en-US" sz="1400" dirty="0">
                 <a:solidFill>
                   <a:srgbClr val="4D5A68"/>
                 </a:solidFill>
@@ -4847,7 +5177,7 @@
         <p:spPr>
           <a:xfrm>
             <a:off x="658368" y="384048"/>
-            <a:ext cx="3200400" cy="201168"/>
+            <a:ext cx="3200400" cy="237744"/>
           </a:xfrm>
           <a:prstGeom prst="rect">
             <a:avLst/>
@@ -4865,7 +5195,7 @@
               <a:buNone/>
             </a:pPr>
             <a:r>
-              <a:rPr lang="en-US" sz="1000" b="1" spc="30" kern="0" dirty="0">
+              <a:rPr lang="en-US" sz="1400" b="1" spc="30" kern="0" dirty="0">
                 <a:solidFill>
                   <a:srgbClr val="0B6172"/>
                 </a:solidFill>
@@ -4906,7 +5236,7 @@
               <a:buNone/>
             </a:pPr>
             <a:r>
-              <a:rPr lang="en-US" sz="3000" b="1" dirty="0">
+              <a:rPr lang="en-US" sz="3400" b="1" dirty="0">
                 <a:solidFill>
                   <a:srgbClr val="17212B"/>
                 </a:solidFill>
@@ -4928,8 +5258,8 @@
         </p:nvSpPr>
         <p:spPr>
           <a:xfrm>
-            <a:off x="9738360" y="6428232"/>
-            <a:ext cx="1783080" cy="182880"/>
+            <a:off x="9418320" y="6181344"/>
+            <a:ext cx="2103120" cy="228600"/>
           </a:xfrm>
           <a:prstGeom prst="rect">
             <a:avLst/>
@@ -4947,7 +5277,7 @@
               <a:buNone/>
             </a:pPr>
             <a:r>
-              <a:rPr lang="en-US" sz="900" dirty="0">
+              <a:rPr lang="en-US" sz="1400" dirty="0">
                 <a:solidFill>
                   <a:srgbClr val="5B6570"/>
                 </a:solidFill>
@@ -4970,7 +5300,7 @@
         <p:spPr>
           <a:xfrm>
             <a:off x="786384" y="1664208"/>
-            <a:ext cx="1188720" cy="201168"/>
+            <a:ext cx="1188720" cy="256032"/>
           </a:xfrm>
           <a:prstGeom prst="rect">
             <a:avLst/>
@@ -4988,7 +5318,7 @@
               <a:buNone/>
             </a:pPr>
             <a:r>
-              <a:rPr lang="en-US" sz="1000" b="1" spc="30" kern="0" dirty="0">
+              <a:rPr lang="en-US" sz="1400" b="1" spc="30" kern="0" dirty="0">
                 <a:solidFill>
                   <a:srgbClr val="0B6172"/>
                 </a:solidFill>
@@ -5052,7 +5382,7 @@
         <p:spPr>
           <a:xfrm>
             <a:off x="786384" y="2514600"/>
-            <a:ext cx="2194560" cy="201168"/>
+            <a:ext cx="2194560" cy="256032"/>
           </a:xfrm>
           <a:prstGeom prst="rect">
             <a:avLst/>
@@ -5070,7 +5400,7 @@
               <a:buNone/>
             </a:pPr>
             <a:r>
-              <a:rPr lang="en-US" sz="1000" b="1" spc="30" kern="0" dirty="0">
+              <a:rPr lang="en-US" sz="1400" b="1" spc="30" kern="0" dirty="0">
                 <a:solidFill>
                   <a:srgbClr val="0B6172"/>
                 </a:solidFill>
@@ -5120,7 +5450,7 @@
         <p:spPr>
           <a:xfrm>
             <a:off x="950976" y="3063240"/>
-            <a:ext cx="402336" cy="274320"/>
+            <a:ext cx="402336" cy="292608"/>
           </a:xfrm>
           <a:prstGeom prst="rect">
             <a:avLst/>
@@ -5138,7 +5468,7 @@
               <a:buNone/>
             </a:pPr>
             <a:r>
-              <a:rPr lang="en-US" sz="1400" b="1" dirty="0">
+              <a:rPr lang="en-US" sz="1600" b="1" dirty="0">
                 <a:solidFill>
                   <a:srgbClr val="0B6172"/>
                 </a:solidFill>
@@ -5161,7 +5491,7 @@
         <p:spPr>
           <a:xfrm>
             <a:off x="1499616" y="3035808"/>
-            <a:ext cx="2450592" cy="329184"/>
+            <a:ext cx="2450592" cy="365760"/>
           </a:xfrm>
           <a:prstGeom prst="rect">
             <a:avLst/>
@@ -5179,7 +5509,7 @@
               <a:buNone/>
             </a:pPr>
             <a:r>
-              <a:rPr lang="en-US" sz="1900" b="1" dirty="0">
+              <a:rPr lang="en-US" sz="2000" b="1" dirty="0">
                 <a:solidFill>
                   <a:srgbClr val="17212B"/>
                 </a:solidFill>
@@ -5229,7 +5559,7 @@
         <p:spPr>
           <a:xfrm>
             <a:off x="4681728" y="3063240"/>
-            <a:ext cx="402336" cy="274320"/>
+            <a:ext cx="402336" cy="292608"/>
           </a:xfrm>
           <a:prstGeom prst="rect">
             <a:avLst/>
@@ -5247,7 +5577,7 @@
               <a:buNone/>
             </a:pPr>
             <a:r>
-              <a:rPr lang="en-US" sz="1400" b="1" dirty="0">
+              <a:rPr lang="en-US" sz="1600" b="1" dirty="0">
                 <a:solidFill>
                   <a:srgbClr val="0B6172"/>
                 </a:solidFill>
@@ -5270,7 +5600,7 @@
         <p:spPr>
           <a:xfrm>
             <a:off x="5230368" y="3035808"/>
-            <a:ext cx="2450592" cy="329184"/>
+            <a:ext cx="2450592" cy="365760"/>
           </a:xfrm>
           <a:prstGeom prst="rect">
             <a:avLst/>
@@ -5288,7 +5618,7 @@
               <a:buNone/>
             </a:pPr>
             <a:r>
-              <a:rPr lang="en-US" sz="1900" b="1" dirty="0">
+              <a:rPr lang="en-US" sz="2000" b="1" dirty="0">
                 <a:solidFill>
                   <a:srgbClr val="17212B"/>
                 </a:solidFill>
@@ -5338,7 +5668,7 @@
         <p:spPr>
           <a:xfrm>
             <a:off x="8412480" y="3063240"/>
-            <a:ext cx="402336" cy="274320"/>
+            <a:ext cx="402336" cy="292608"/>
           </a:xfrm>
           <a:prstGeom prst="rect">
             <a:avLst/>
@@ -5356,7 +5686,7 @@
               <a:buNone/>
             </a:pPr>
             <a:r>
-              <a:rPr lang="en-US" sz="1400" b="1" dirty="0">
+              <a:rPr lang="en-US" sz="1600" b="1" dirty="0">
                 <a:solidFill>
                   <a:srgbClr val="0B6172"/>
                 </a:solidFill>
@@ -5379,7 +5709,7 @@
         <p:spPr>
           <a:xfrm>
             <a:off x="8961120" y="3035808"/>
-            <a:ext cx="2450592" cy="329184"/>
+            <a:ext cx="2450592" cy="365760"/>
           </a:xfrm>
           <a:prstGeom prst="rect">
             <a:avLst/>
@@ -5397,7 +5727,7 @@
               <a:buNone/>
             </a:pPr>
             <a:r>
-              <a:rPr lang="en-US" sz="1900" b="1" dirty="0">
+              <a:rPr lang="en-US" sz="2000" b="1" dirty="0">
                 <a:solidFill>
                   <a:srgbClr val="17212B"/>
                 </a:solidFill>
@@ -5447,7 +5777,7 @@
         <p:spPr>
           <a:xfrm>
             <a:off x="1024128" y="4032504"/>
-            <a:ext cx="10405872" cy="274320"/>
+            <a:ext cx="10405872" cy="310896"/>
           </a:xfrm>
           <a:prstGeom prst="rect">
             <a:avLst/>
@@ -5465,7 +5795,7 @@
               <a:buNone/>
             </a:pPr>
             <a:r>
-              <a:rPr lang="en-US" sz="1500" b="1" dirty="0">
+              <a:rPr lang="en-US" sz="1600" b="1" dirty="0">
                 <a:solidFill>
                   <a:srgbClr val="17212B"/>
                 </a:solidFill>
@@ -5515,7 +5845,7 @@
         <p:spPr>
           <a:xfrm>
             <a:off x="1024128" y="5010912"/>
-            <a:ext cx="1143000" cy="201168"/>
+            <a:ext cx="1143000" cy="256032"/>
           </a:xfrm>
           <a:prstGeom prst="rect">
             <a:avLst/>
@@ -5533,7 +5863,7 @@
               <a:buNone/>
             </a:pPr>
             <a:r>
-              <a:rPr lang="en-US" sz="1000" b="1" spc="30" kern="0" dirty="0">
+              <a:rPr lang="en-US" sz="1400" b="1" spc="30" kern="0" dirty="0">
                 <a:solidFill>
                   <a:srgbClr val="5B6570"/>
                 </a:solidFill>
@@ -5555,8 +5885,8 @@
         </p:nvSpPr>
         <p:spPr>
           <a:xfrm>
-            <a:off x="822960" y="5742432"/>
-            <a:ext cx="10789920" cy="219456"/>
+            <a:off x="822960" y="5705856"/>
+            <a:ext cx="10789920" cy="292608"/>
           </a:xfrm>
           <a:prstGeom prst="rect">
             <a:avLst/>
@@ -5574,7 +5904,7 @@
               <a:buNone/>
             </a:pPr>
             <a:r>
-              <a:rPr lang="en-US" sz="1100" dirty="0">
+              <a:rPr lang="en-US" sz="1600" dirty="0">
                 <a:solidFill>
                   <a:srgbClr val="5B6570"/>
                 </a:solidFill>
@@ -5622,7 +5952,7 @@
         <p:spPr>
           <a:xfrm>
             <a:off x="658368" y="384048"/>
-            <a:ext cx="3200400" cy="201168"/>
+            <a:ext cx="3200400" cy="237744"/>
           </a:xfrm>
           <a:prstGeom prst="rect">
             <a:avLst/>
@@ -5640,7 +5970,7 @@
               <a:buNone/>
             </a:pPr>
             <a:r>
-              <a:rPr lang="en-US" sz="1000" b="1" spc="30" kern="0" dirty="0">
+              <a:rPr lang="en-US" sz="1400" b="1" spc="30" kern="0" dirty="0">
                 <a:solidFill>
                   <a:srgbClr val="0B6172"/>
                 </a:solidFill>
@@ -5681,7 +6011,7 @@
               <a:buNone/>
             </a:pPr>
             <a:r>
-              <a:rPr lang="en-US" sz="3000" b="1" dirty="0">
+              <a:rPr lang="en-US" sz="3400" b="1" dirty="0">
                 <a:solidFill>
                   <a:srgbClr val="17212B"/>
                 </a:solidFill>
@@ -5703,8 +6033,8 @@
         </p:nvSpPr>
         <p:spPr>
           <a:xfrm>
-            <a:off x="9738360" y="6428232"/>
-            <a:ext cx="1783080" cy="182880"/>
+            <a:off x="9418320" y="6181344"/>
+            <a:ext cx="2103120" cy="228600"/>
           </a:xfrm>
           <a:prstGeom prst="rect">
             <a:avLst/>
@@ -5722,7 +6052,7 @@
               <a:buNone/>
             </a:pPr>
             <a:r>
-              <a:rPr lang="en-US" sz="900" dirty="0">
+              <a:rPr lang="en-US" sz="1400" dirty="0">
                 <a:solidFill>
                   <a:srgbClr val="5B6570"/>
                 </a:solidFill>
@@ -5772,7 +6102,7 @@
         <p:spPr>
           <a:xfrm>
             <a:off x="896112" y="1746504"/>
-            <a:ext cx="3063240" cy="347472"/>
+            <a:ext cx="3520440" cy="347472"/>
           </a:xfrm>
           <a:prstGeom prst="roundRect">
             <a:avLst>
@@ -5799,7 +6129,7 @@
         <p:spPr>
           <a:xfrm>
             <a:off x="987552" y="1783080"/>
-            <a:ext cx="2880360" cy="256032"/>
+            <a:ext cx="3337560" cy="274320"/>
           </a:xfrm>
           <a:prstGeom prst="rect">
             <a:avLst/>
@@ -5817,7 +6147,7 @@
               <a:buNone/>
             </a:pPr>
             <a:r>
-              <a:rPr lang="en-US" sz="1000" b="1" dirty="0">
+              <a:rPr lang="en-US" sz="1400" b="1" dirty="0">
                 <a:solidFill>
                   <a:srgbClr val="176B4D"/>
                 </a:solidFill>
@@ -5839,8 +6169,8 @@
         </p:nvSpPr>
         <p:spPr>
           <a:xfrm>
-            <a:off x="7251192" y="1746504"/>
-            <a:ext cx="3968496" cy="347472"/>
+            <a:off x="6793992" y="1746504"/>
+            <a:ext cx="4425696" cy="347472"/>
           </a:xfrm>
           <a:prstGeom prst="roundRect">
             <a:avLst>
@@ -5866,8 +6196,8 @@
         </p:nvSpPr>
         <p:spPr>
           <a:xfrm>
-            <a:off x="7342632" y="1783080"/>
-            <a:ext cx="3785616" cy="256032"/>
+            <a:off x="6885432" y="1783080"/>
+            <a:ext cx="4242816" cy="274320"/>
           </a:xfrm>
           <a:prstGeom prst="rect">
             <a:avLst/>
@@ -5885,7 +6215,7 @@
               <a:buNone/>
             </a:pPr>
             <a:r>
-              <a:rPr lang="en-US" sz="1000" b="1" dirty="0">
+              <a:rPr lang="en-US" sz="1400" b="1" dirty="0">
                 <a:solidFill>
                   <a:srgbClr val="4D5A68"/>
                 </a:solidFill>
@@ -5908,7 +6238,7 @@
         <p:spPr>
           <a:xfrm>
             <a:off x="914400" y="2221992"/>
-            <a:ext cx="10369296" cy="237744"/>
+            <a:ext cx="10369296" cy="292608"/>
           </a:xfrm>
           <a:prstGeom prst="rect">
             <a:avLst/>
@@ -5926,7 +6256,7 @@
               <a:buNone/>
             </a:pPr>
             <a:r>
-              <a:rPr lang="en-US" sz="1200" dirty="0">
+              <a:rPr lang="en-US" sz="1600" dirty="0">
                 <a:solidFill>
                   <a:srgbClr val="5B6570"/>
                 </a:solidFill>
@@ -5949,7 +6279,7 @@
         <p:spPr>
           <a:xfrm>
             <a:off x="914400" y="2651760"/>
-            <a:ext cx="2743200" cy="201168"/>
+            <a:ext cx="2743200" cy="256032"/>
           </a:xfrm>
           <a:prstGeom prst="rect">
             <a:avLst/>
@@ -5967,7 +6297,7 @@
               <a:buNone/>
             </a:pPr>
             <a:r>
-              <a:rPr lang="en-US" sz="1000" b="1" spc="30" kern="0" dirty="0">
+              <a:rPr lang="en-US" sz="1400" b="1" spc="30" kern="0" dirty="0">
                 <a:solidFill>
                   <a:srgbClr val="0B6172"/>
                 </a:solidFill>
@@ -6017,7 +6347,7 @@
         <p:spPr>
           <a:xfrm>
             <a:off x="1143000" y="3054096"/>
-            <a:ext cx="9912096" cy="310896"/>
+            <a:ext cx="9912096" cy="347472"/>
           </a:xfrm>
           <a:prstGeom prst="rect">
             <a:avLst/>
@@ -6035,7 +6365,7 @@
               <a:buNone/>
             </a:pPr>
             <a:r>
-              <a:rPr lang="en-US" sz="1800" b="1" dirty="0">
+              <a:rPr lang="en-US" sz="2000" b="1" dirty="0">
                 <a:solidFill>
                   <a:srgbClr val="17212B"/>
                 </a:solidFill>
@@ -6058,7 +6388,7 @@
         <p:spPr>
           <a:xfrm>
             <a:off x="914400" y="3730752"/>
-            <a:ext cx="2743200" cy="201168"/>
+            <a:ext cx="2743200" cy="256032"/>
           </a:xfrm>
           <a:prstGeom prst="rect">
             <a:avLst/>
@@ -6076,7 +6406,7 @@
               <a:buNone/>
             </a:pPr>
             <a:r>
-              <a:rPr lang="en-US" sz="1000" b="1" spc="30" kern="0" dirty="0">
+              <a:rPr lang="en-US" sz="1400" b="1" spc="30" kern="0" dirty="0">
                 <a:solidFill>
                   <a:srgbClr val="0B6172"/>
                 </a:solidFill>
@@ -6125,8 +6455,8 @@
         </p:nvSpPr>
         <p:spPr>
           <a:xfrm>
-            <a:off x="1024128" y="4142232"/>
-            <a:ext cx="3026664" cy="292608"/>
+            <a:off x="1024128" y="4114800"/>
+            <a:ext cx="3026664" cy="347472"/>
           </a:xfrm>
           <a:prstGeom prst="rect">
             <a:avLst/>
@@ -6144,7 +6474,7 @@
               <a:buNone/>
             </a:pPr>
             <a:r>
-              <a:rPr lang="en-US" sz="1400" b="1" dirty="0">
+              <a:rPr lang="en-US" sz="1600" b="1" dirty="0">
                 <a:solidFill>
                   <a:srgbClr val="17212B"/>
                 </a:solidFill>
@@ -6234,8 +6564,8 @@
         </p:nvSpPr>
         <p:spPr>
           <a:xfrm>
-            <a:off x="4681728" y="4142232"/>
-            <a:ext cx="3026664" cy="292608"/>
+            <a:off x="4681728" y="4114800"/>
+            <a:ext cx="3026664" cy="347472"/>
           </a:xfrm>
           <a:prstGeom prst="rect">
             <a:avLst/>
@@ -6253,7 +6583,7 @@
               <a:buNone/>
             </a:pPr>
             <a:r>
-              <a:rPr lang="en-US" sz="1400" b="1" dirty="0">
+              <a:rPr lang="en-US" sz="1600" b="1" dirty="0">
                 <a:solidFill>
                   <a:srgbClr val="17212B"/>
                 </a:solidFill>
@@ -6343,8 +6673,8 @@
         </p:nvSpPr>
         <p:spPr>
           <a:xfrm>
-            <a:off x="8339328" y="4142232"/>
-            <a:ext cx="3026664" cy="292608"/>
+            <a:off x="8339328" y="4114800"/>
+            <a:ext cx="3026664" cy="347472"/>
           </a:xfrm>
           <a:prstGeom prst="rect">
             <a:avLst/>
@@ -6362,7 +6692,7 @@
               <a:buNone/>
             </a:pPr>
             <a:r>
-              <a:rPr lang="en-US" sz="1400" b="1" dirty="0">
+              <a:rPr lang="en-US" sz="1600" b="1" dirty="0">
                 <a:solidFill>
                   <a:srgbClr val="17212B"/>
                 </a:solidFill>
@@ -6412,7 +6742,7 @@
         <p:spPr>
           <a:xfrm>
             <a:off x="1097280" y="5038344"/>
-            <a:ext cx="1371600" cy="201168"/>
+            <a:ext cx="1371600" cy="256032"/>
           </a:xfrm>
           <a:prstGeom prst="rect">
             <a:avLst/>
@@ -6430,7 +6760,7 @@
               <a:buNone/>
             </a:pPr>
             <a:r>
-              <a:rPr lang="en-US" sz="1000" b="1" spc="30" kern="0" dirty="0">
+              <a:rPr lang="en-US" sz="1400" b="1" spc="30" kern="0" dirty="0">
                 <a:solidFill>
                   <a:srgbClr val="805400"/>
                 </a:solidFill>
@@ -6452,8 +6782,8 @@
         </p:nvSpPr>
         <p:spPr>
           <a:xfrm>
-            <a:off x="1097280" y="5285232"/>
-            <a:ext cx="4590288" cy="283464"/>
+            <a:off x="1097280" y="5271516"/>
+            <a:ext cx="4590288" cy="329184"/>
           </a:xfrm>
           <a:prstGeom prst="rect">
             <a:avLst/>
@@ -6471,7 +6801,7 @@
               <a:buNone/>
             </a:pPr>
             <a:r>
-              <a:rPr lang="en-US" sz="1500" b="1" dirty="0">
+              <a:rPr lang="en-US" sz="1800" b="1" dirty="0">
                 <a:solidFill>
                   <a:srgbClr val="17212B"/>
                 </a:solidFill>
@@ -6521,7 +6851,7 @@
         <p:spPr>
           <a:xfrm>
             <a:off x="6492240" y="5038344"/>
-            <a:ext cx="2743200" cy="201168"/>
+            <a:ext cx="2743200" cy="256032"/>
           </a:xfrm>
           <a:prstGeom prst="rect">
             <a:avLst/>
@@ -6539,7 +6869,7 @@
               <a:buNone/>
             </a:pPr>
             <a:r>
-              <a:rPr lang="en-US" sz="1000" b="1" spc="30" kern="0" dirty="0">
+              <a:rPr lang="en-US" sz="1400" b="1" spc="30" kern="0" dirty="0">
                 <a:solidFill>
                   <a:srgbClr val="B42318"/>
                 </a:solidFill>
@@ -6561,8 +6891,8 @@
         </p:nvSpPr>
         <p:spPr>
           <a:xfrm>
-            <a:off x="6492240" y="5285232"/>
-            <a:ext cx="4590288" cy="283464"/>
+            <a:off x="6492240" y="5271516"/>
+            <a:ext cx="4590288" cy="329184"/>
           </a:xfrm>
           <a:prstGeom prst="rect">
             <a:avLst/>
@@ -6580,7 +6910,7 @@
               <a:buNone/>
             </a:pPr>
             <a:r>
-              <a:rPr lang="en-US" sz="1500" b="1" dirty="0">
+              <a:rPr lang="en-US" sz="1800" b="1" dirty="0">
                 <a:solidFill>
                   <a:srgbClr val="17212B"/>
                 </a:solidFill>
@@ -6628,7 +6958,7 @@
         <p:spPr>
           <a:xfrm>
             <a:off x="658368" y="384048"/>
-            <a:ext cx="3200400" cy="201168"/>
+            <a:ext cx="3200400" cy="237744"/>
           </a:xfrm>
           <a:prstGeom prst="rect">
             <a:avLst/>
@@ -6646,7 +6976,7 @@
               <a:buNone/>
             </a:pPr>
             <a:r>
-              <a:rPr lang="en-US" sz="1000" b="1" spc="30" kern="0" dirty="0">
+              <a:rPr lang="en-US" sz="1400" b="1" spc="30" kern="0" dirty="0">
                 <a:solidFill>
                   <a:srgbClr val="0B6172"/>
                 </a:solidFill>
@@ -6687,7 +7017,7 @@
               <a:buNone/>
             </a:pPr>
             <a:r>
-              <a:rPr lang="en-US" sz="3000" b="1" dirty="0">
+              <a:rPr lang="en-US" sz="3400" b="1" dirty="0">
                 <a:solidFill>
                   <a:srgbClr val="17212B"/>
                 </a:solidFill>
@@ -6709,8 +7039,8 @@
         </p:nvSpPr>
         <p:spPr>
           <a:xfrm>
-            <a:off x="9738360" y="6428232"/>
-            <a:ext cx="1783080" cy="182880"/>
+            <a:off x="9418320" y="6181344"/>
+            <a:ext cx="2103120" cy="228600"/>
           </a:xfrm>
           <a:prstGeom prst="rect">
             <a:avLst/>
@@ -6728,7 +7058,7 @@
               <a:buNone/>
             </a:pPr>
             <a:r>
-              <a:rPr lang="en-US" sz="900" dirty="0">
+              <a:rPr lang="en-US" sz="1400" dirty="0">
                 <a:solidFill>
                   <a:srgbClr val="5B6570"/>
                 </a:solidFill>
@@ -6751,7 +7081,7 @@
         <p:spPr>
           <a:xfrm>
             <a:off x="786384" y="1664208"/>
-            <a:ext cx="4114800" cy="201168"/>
+            <a:ext cx="4114800" cy="256032"/>
           </a:xfrm>
           <a:prstGeom prst="rect">
             <a:avLst/>
@@ -6769,7 +7099,7 @@
               <a:buNone/>
             </a:pPr>
             <a:r>
-              <a:rPr lang="en-US" sz="1000" b="1" spc="30" kern="0" dirty="0">
+              <a:rPr lang="en-US" sz="1400" b="1" spc="30" kern="0" dirty="0">
                 <a:solidFill>
                   <a:srgbClr val="176B4D"/>
                 </a:solidFill>
@@ -6819,7 +7149,7 @@
         <p:spPr>
           <a:xfrm>
             <a:off x="1078992" y="2267712"/>
-            <a:ext cx="4480560" cy="201168"/>
+            <a:ext cx="4480560" cy="256032"/>
           </a:xfrm>
           <a:prstGeom prst="rect">
             <a:avLst/>
@@ -6837,7 +7167,7 @@
               <a:buNone/>
             </a:pPr>
             <a:r>
-              <a:rPr lang="en-US" sz="1000" b="1" spc="30" kern="0" dirty="0">
+              <a:rPr lang="en-US" sz="1400" b="1" spc="30" kern="0" dirty="0">
                 <a:solidFill>
                   <a:srgbClr val="0B6172"/>
                 </a:solidFill>
@@ -7001,7 +7331,7 @@
               <a:buNone/>
             </a:pPr>
             <a:r>
-              <a:rPr lang="en-US" sz="1500" dirty="0">
+              <a:rPr lang="en-US" sz="1600" dirty="0">
                 <a:solidFill>
                   <a:srgbClr val="4D5A68"/>
                 </a:solidFill>
@@ -7024,7 +7354,7 @@
         <p:spPr>
           <a:xfrm>
             <a:off x="6236208" y="1664208"/>
-            <a:ext cx="4206240" cy="201168"/>
+            <a:ext cx="4206240" cy="256032"/>
           </a:xfrm>
           <a:prstGeom prst="rect">
             <a:avLst/>
@@ -7042,7 +7372,7 @@
               <a:buNone/>
             </a:pPr>
             <a:r>
-              <a:rPr lang="en-US" sz="1000" b="1" spc="30" kern="0" dirty="0">
+              <a:rPr lang="en-US" sz="1400" b="1" spc="30" kern="0" dirty="0">
                 <a:solidFill>
                   <a:srgbClr val="805400"/>
                 </a:solidFill>
@@ -7133,7 +7463,7 @@
         <p:spPr>
           <a:xfrm>
             <a:off x="7525512" y="2898648"/>
-            <a:ext cx="3520440" cy="292608"/>
+            <a:ext cx="3520440" cy="329184"/>
           </a:xfrm>
           <a:prstGeom prst="rect">
             <a:avLst/>
@@ -7174,7 +7504,7 @@
         <p:spPr>
           <a:xfrm>
             <a:off x="6547104" y="3611880"/>
-            <a:ext cx="4480560" cy="658368"/>
+            <a:ext cx="4709160" cy="658368"/>
           </a:xfrm>
           <a:prstGeom prst="rect">
             <a:avLst/>
@@ -7192,7 +7522,7 @@
               <a:buNone/>
             </a:pPr>
             <a:r>
-              <a:rPr lang="en-US" sz="1700" b="1" dirty="0">
+              <a:rPr lang="en-US" sz="1600" b="1" dirty="0">
                 <a:solidFill>
                   <a:srgbClr val="17212B"/>
                 </a:solidFill>
@@ -7233,7 +7563,7 @@
               <a:buNone/>
             </a:pPr>
             <a:r>
-              <a:rPr lang="en-US" sz="1500" dirty="0">
+              <a:rPr lang="en-US" sz="1600" dirty="0">
                 <a:solidFill>
                   <a:srgbClr val="4D5A68"/>
                 </a:solidFill>
@@ -7282,8 +7612,8 @@
         </p:nvSpPr>
         <p:spPr>
           <a:xfrm>
-            <a:off x="1325880" y="5614416"/>
-            <a:ext cx="9537192" cy="256032"/>
+            <a:off x="1325880" y="5586984"/>
+            <a:ext cx="9537192" cy="310896"/>
           </a:xfrm>
           <a:prstGeom prst="rect">
             <a:avLst/>
@@ -7301,7 +7631,7 @@
               <a:buNone/>
             </a:pPr>
             <a:r>
-              <a:rPr lang="en-US" sz="1400" b="1" dirty="0">
+              <a:rPr lang="en-US" sz="1600" b="1" dirty="0">
                 <a:solidFill>
                   <a:srgbClr val="17212B"/>
                 </a:solidFill>
@@ -7349,7 +7679,7 @@
         <p:spPr>
           <a:xfrm>
             <a:off x="658368" y="384048"/>
-            <a:ext cx="3200400" cy="201168"/>
+            <a:ext cx="3200400" cy="237744"/>
           </a:xfrm>
           <a:prstGeom prst="rect">
             <a:avLst/>
@@ -7367,7 +7697,7 @@
               <a:buNone/>
             </a:pPr>
             <a:r>
-              <a:rPr lang="en-US" sz="1000" b="1" spc="30" kern="0" dirty="0">
+              <a:rPr lang="en-US" sz="1400" b="1" spc="30" kern="0" dirty="0">
                 <a:solidFill>
                   <a:srgbClr val="0B6172"/>
                 </a:solidFill>
@@ -7408,7 +7738,7 @@
               <a:buNone/>
             </a:pPr>
             <a:r>
-              <a:rPr lang="en-US" sz="3000" b="1" dirty="0">
+              <a:rPr lang="en-US" sz="3400" b="1" dirty="0">
                 <a:solidFill>
                   <a:srgbClr val="17212B"/>
                 </a:solidFill>
@@ -7430,8 +7760,8 @@
         </p:nvSpPr>
         <p:spPr>
           <a:xfrm>
-            <a:off x="9738360" y="6428232"/>
-            <a:ext cx="1783080" cy="182880"/>
+            <a:off x="9418320" y="6181344"/>
+            <a:ext cx="2103120" cy="228600"/>
           </a:xfrm>
           <a:prstGeom prst="rect">
             <a:avLst/>
@@ -7449,7 +7779,7 @@
               <a:buNone/>
             </a:pPr>
             <a:r>
-              <a:rPr lang="en-US" sz="900" dirty="0">
+              <a:rPr lang="en-US" sz="1400" dirty="0">
                 <a:solidFill>
                   <a:srgbClr val="5B6570"/>
                 </a:solidFill>
@@ -7472,7 +7802,7 @@
         <p:spPr>
           <a:xfrm>
             <a:off x="786384" y="1609344"/>
-            <a:ext cx="3840480" cy="201168"/>
+            <a:ext cx="3840480" cy="274320"/>
           </a:xfrm>
           <a:prstGeom prst="rect">
             <a:avLst/>
@@ -7490,7 +7820,7 @@
               <a:buNone/>
             </a:pPr>
             <a:r>
-              <a:rPr lang="en-US" sz="1000" b="1" spc="30" kern="0" dirty="0">
+              <a:rPr lang="en-US" sz="1400" b="1" spc="30" kern="0" dirty="0">
                 <a:solidFill>
                   <a:srgbClr val="0B6172"/>
                 </a:solidFill>
@@ -7540,7 +7870,7 @@
         <p:spPr>
           <a:xfrm>
             <a:off x="1060704" y="2231136"/>
-            <a:ext cx="3383280" cy="201168"/>
+            <a:ext cx="3383280" cy="274320"/>
           </a:xfrm>
           <a:prstGeom prst="rect">
             <a:avLst/>
@@ -7558,7 +7888,7 @@
               <a:buNone/>
             </a:pPr>
             <a:r>
-              <a:rPr lang="en-US" sz="1000" b="1" spc="30" kern="0" dirty="0">
+              <a:rPr lang="en-US" sz="1400" b="1" spc="30" kern="0" dirty="0">
                 <a:solidFill>
                   <a:srgbClr val="5B6570"/>
                 </a:solidFill>
@@ -7707,7 +8037,7 @@
         <p:spPr>
           <a:xfrm>
             <a:off x="6693408" y="2231136"/>
-            <a:ext cx="3931920" cy="201168"/>
+            <a:ext cx="3931920" cy="274320"/>
           </a:xfrm>
           <a:prstGeom prst="rect">
             <a:avLst/>
@@ -7725,7 +8055,7 @@
               <a:buNone/>
             </a:pPr>
             <a:r>
-              <a:rPr lang="en-US" sz="1000" b="1" spc="30" kern="0" dirty="0">
+              <a:rPr lang="en-US" sz="1400" b="1" spc="30" kern="0" dirty="0">
                 <a:solidFill>
                   <a:srgbClr val="0B6172"/>
                 </a:solidFill>
@@ -7860,7 +8190,7 @@
         <p:spPr>
           <a:xfrm>
             <a:off x="1078992" y="4453128"/>
-            <a:ext cx="1773936" cy="256032"/>
+            <a:ext cx="1773936" cy="274320"/>
           </a:xfrm>
           <a:prstGeom prst="rect">
             <a:avLst/>
@@ -7878,7 +8208,7 @@
               <a:buNone/>
             </a:pPr>
             <a:r>
-              <a:rPr lang="en-US" sz="1000" b="1" dirty="0">
+              <a:rPr lang="en-US" sz="1400" b="1" dirty="0">
                 <a:solidFill>
                   <a:srgbClr val="176B4D"/>
                 </a:solidFill>
@@ -7919,7 +8249,7 @@
               <a:buNone/>
             </a:pPr>
             <a:r>
-              <a:rPr lang="en-US" sz="1500" b="1" dirty="0">
+              <a:rPr lang="en-US" sz="1600" b="1" dirty="0">
                 <a:solidFill>
                   <a:srgbClr val="17212B"/>
                 </a:solidFill>
@@ -7942,7 +8272,7 @@
         <p:spPr>
           <a:xfrm>
             <a:off x="1024128" y="5303520"/>
-            <a:ext cx="5029200" cy="201168"/>
+            <a:ext cx="5029200" cy="274320"/>
           </a:xfrm>
           <a:prstGeom prst="rect">
             <a:avLst/>
@@ -7960,7 +8290,7 @@
               <a:buNone/>
             </a:pPr>
             <a:r>
-              <a:rPr lang="en-US" sz="1000" dirty="0">
+              <a:rPr lang="en-US" sz="1400" dirty="0">
                 <a:solidFill>
                   <a:srgbClr val="5B6570"/>
                 </a:solidFill>
@@ -8037,7 +8367,7 @@
         <p:spPr>
           <a:xfrm>
             <a:off x="6876288" y="4453128"/>
-            <a:ext cx="2450592" cy="256032"/>
+            <a:ext cx="2450592" cy="274320"/>
           </a:xfrm>
           <a:prstGeom prst="rect">
             <a:avLst/>
@@ -8055,7 +8385,7 @@
               <a:buNone/>
             </a:pPr>
             <a:r>
-              <a:rPr lang="en-US" sz="1000" b="1" dirty="0">
+              <a:rPr lang="en-US" sz="1400" b="1" dirty="0">
                 <a:solidFill>
                   <a:srgbClr val="0B6172"/>
                 </a:solidFill>
@@ -8078,7 +8408,7 @@
         <p:spPr>
           <a:xfrm>
             <a:off x="6821424" y="4892040"/>
-            <a:ext cx="4169664" cy="475488"/>
+            <a:ext cx="4169664" cy="566928"/>
           </a:xfrm>
           <a:prstGeom prst="rect">
             <a:avLst/>
@@ -8096,7 +8426,7 @@
               <a:buNone/>
             </a:pPr>
             <a:r>
-              <a:rPr lang="en-US" sz="1400" b="1" dirty="0">
+              <a:rPr lang="en-US" sz="1600" b="1" dirty="0">
                 <a:solidFill>
                   <a:srgbClr val="17212B"/>
                 </a:solidFill>
@@ -8113,7 +8443,7 @@
               <a:buNone/>
             </a:pPr>
             <a:r>
-              <a:rPr lang="en-US" sz="1400" b="1" dirty="0">
+              <a:rPr lang="en-US" sz="1600" b="1" dirty="0">
                 <a:solidFill>
                   <a:srgbClr val="17212B"/>
                 </a:solidFill>
@@ -8161,7 +8491,7 @@
         <p:spPr>
           <a:xfrm>
             <a:off x="658368" y="384048"/>
-            <a:ext cx="3200400" cy="201168"/>
+            <a:ext cx="3200400" cy="237744"/>
           </a:xfrm>
           <a:prstGeom prst="rect">
             <a:avLst/>
@@ -8179,7 +8509,7 @@
               <a:buNone/>
             </a:pPr>
             <a:r>
-              <a:rPr lang="en-US" sz="1000" b="1" spc="30" kern="0" dirty="0">
+              <a:rPr lang="en-US" sz="1400" b="1" spc="30" kern="0" dirty="0">
                 <a:solidFill>
                   <a:srgbClr val="0B6172"/>
                 </a:solidFill>
@@ -8220,7 +8550,7 @@
               <a:buNone/>
             </a:pPr>
             <a:r>
-              <a:rPr lang="en-US" sz="3000" b="1" dirty="0">
+              <a:rPr lang="en-US" sz="3400" b="1" dirty="0">
                 <a:solidFill>
                   <a:srgbClr val="17212B"/>
                 </a:solidFill>
@@ -8242,8 +8572,8 @@
         </p:nvSpPr>
         <p:spPr>
           <a:xfrm>
-            <a:off x="9738360" y="6428232"/>
-            <a:ext cx="1783080" cy="182880"/>
+            <a:off x="9418320" y="6181344"/>
+            <a:ext cx="2103120" cy="228600"/>
           </a:xfrm>
           <a:prstGeom prst="rect">
             <a:avLst/>
@@ -8261,7 +8591,7 @@
               <a:buNone/>
             </a:pPr>
             <a:r>
-              <a:rPr lang="en-US" sz="900" dirty="0">
+              <a:rPr lang="en-US" sz="1400" dirty="0">
                 <a:solidFill>
                   <a:srgbClr val="5B6570"/>
                 </a:solidFill>
@@ -8284,7 +8614,7 @@
         <p:spPr>
           <a:xfrm>
             <a:off x="786384" y="1664208"/>
-            <a:ext cx="2743200" cy="201168"/>
+            <a:ext cx="2743200" cy="256032"/>
           </a:xfrm>
           <a:prstGeom prst="rect">
             <a:avLst/>
@@ -8302,7 +8632,7 @@
               <a:buNone/>
             </a:pPr>
             <a:r>
-              <a:rPr lang="en-US" sz="1000" b="1" spc="30" kern="0" dirty="0">
+              <a:rPr lang="en-US" sz="1400" b="1" spc="30" kern="0" dirty="0">
                 <a:solidFill>
                   <a:srgbClr val="0B6172"/>
                 </a:solidFill>
@@ -8352,7 +8682,7 @@
         <p:spPr>
           <a:xfrm>
             <a:off x="1078992" y="2395728"/>
-            <a:ext cx="3200400" cy="201168"/>
+            <a:ext cx="3200400" cy="256032"/>
           </a:xfrm>
           <a:prstGeom prst="rect">
             <a:avLst/>
@@ -8370,7 +8700,7 @@
               <a:buNone/>
             </a:pPr>
             <a:r>
-              <a:rPr lang="en-US" sz="1000" b="1" spc="30" kern="0" dirty="0">
+              <a:rPr lang="en-US" sz="1400" b="1" spc="30" kern="0" dirty="0">
                 <a:solidFill>
                   <a:srgbClr val="5B6570"/>
                 </a:solidFill>
@@ -8434,7 +8764,7 @@
         <p:spPr>
           <a:xfrm>
             <a:off x="1078992" y="3547872"/>
-            <a:ext cx="3767328" cy="420624"/>
+            <a:ext cx="3767328" cy="438912"/>
           </a:xfrm>
           <a:prstGeom prst="rect">
             <a:avLst/>
@@ -8452,7 +8782,7 @@
               <a:buNone/>
             </a:pPr>
             <a:r>
-              <a:rPr lang="en-US" sz="1700" dirty="0">
+              <a:rPr lang="en-US" sz="1800" dirty="0">
                 <a:solidFill>
                   <a:srgbClr val="4D5A68"/>
                 </a:solidFill>
@@ -8543,7 +8873,7 @@
         <p:spPr>
           <a:xfrm>
             <a:off x="6821424" y="2395728"/>
-            <a:ext cx="3200400" cy="201168"/>
+            <a:ext cx="3200400" cy="256032"/>
           </a:xfrm>
           <a:prstGeom prst="rect">
             <a:avLst/>
@@ -8561,7 +8891,7 @@
               <a:buNone/>
             </a:pPr>
             <a:r>
-              <a:rPr lang="en-US" sz="1000" b="1" spc="30" kern="0" dirty="0">
+              <a:rPr lang="en-US" sz="1400" b="1" spc="30" kern="0" dirty="0">
                 <a:solidFill>
                   <a:srgbClr val="0B6172"/>
                 </a:solidFill>
@@ -8625,7 +8955,7 @@
         <p:spPr>
           <a:xfrm>
             <a:off x="6821424" y="3547872"/>
-            <a:ext cx="4078224" cy="420624"/>
+            <a:ext cx="4078224" cy="438912"/>
           </a:xfrm>
           <a:prstGeom prst="rect">
             <a:avLst/>
@@ -8643,7 +8973,7 @@
               <a:buNone/>
             </a:pPr>
             <a:r>
-              <a:rPr lang="en-US" sz="1700" dirty="0">
+              <a:rPr lang="en-US" sz="1800" dirty="0">
                 <a:solidFill>
                   <a:srgbClr val="4D5A68"/>
                 </a:solidFill>
@@ -8693,7 +9023,7 @@
         <p:spPr>
           <a:xfrm>
             <a:off x="2103120" y="5202936"/>
-            <a:ext cx="7982712" cy="310896"/>
+            <a:ext cx="7982712" cy="347472"/>
           </a:xfrm>
           <a:prstGeom prst="rect">
             <a:avLst/>
@@ -8711,7 +9041,7 @@
               <a:buNone/>
             </a:pPr>
             <a:r>
-              <a:rPr lang="en-US" sz="1700" b="1" dirty="0">
+              <a:rPr lang="en-US" sz="1800" b="1" dirty="0">
                 <a:solidFill>
                   <a:srgbClr val="17212B"/>
                 </a:solidFill>
@@ -8759,7 +9089,7 @@
         <p:spPr>
           <a:xfrm>
             <a:off x="658368" y="384048"/>
-            <a:ext cx="3200400" cy="201168"/>
+            <a:ext cx="3200400" cy="237744"/>
           </a:xfrm>
           <a:prstGeom prst="rect">
             <a:avLst/>
@@ -8777,7 +9107,7 @@
               <a:buNone/>
             </a:pPr>
             <a:r>
-              <a:rPr lang="en-US" sz="1000" b="1" spc="30" kern="0" dirty="0">
+              <a:rPr lang="en-US" sz="1400" b="1" spc="30" kern="0" dirty="0">
                 <a:solidFill>
                   <a:srgbClr val="0B6172"/>
                 </a:solidFill>
@@ -8818,7 +9148,7 @@
               <a:buNone/>
             </a:pPr>
             <a:r>
-              <a:rPr lang="en-US" sz="3000" b="1" dirty="0">
+              <a:rPr lang="en-US" sz="3400" b="1" dirty="0">
                 <a:solidFill>
                   <a:srgbClr val="17212B"/>
                 </a:solidFill>
@@ -8840,8 +9170,8 @@
         </p:nvSpPr>
         <p:spPr>
           <a:xfrm>
-            <a:off x="9738360" y="6428232"/>
-            <a:ext cx="1783080" cy="182880"/>
+            <a:off x="9418320" y="6181344"/>
+            <a:ext cx="2103120" cy="228600"/>
           </a:xfrm>
           <a:prstGeom prst="rect">
             <a:avLst/>
@@ -8859,7 +9189,7 @@
               <a:buNone/>
             </a:pPr>
             <a:r>
-              <a:rPr lang="en-US" sz="900" dirty="0">
+              <a:rPr lang="en-US" sz="1400" dirty="0">
                 <a:solidFill>
                   <a:srgbClr val="5B6570"/>
                 </a:solidFill>
@@ -8909,7 +9239,7 @@
         <p:spPr>
           <a:xfrm>
             <a:off x="1115568" y="2167128"/>
-            <a:ext cx="2377440" cy="201168"/>
+            <a:ext cx="2377440" cy="274320"/>
           </a:xfrm>
           <a:prstGeom prst="rect">
             <a:avLst/>
@@ -8927,7 +9257,7 @@
               <a:buNone/>
             </a:pPr>
             <a:r>
-              <a:rPr lang="en-US" sz="1000" b="1" spc="30" kern="0" dirty="0">
+              <a:rPr lang="en-US" sz="1400" b="1" spc="30" kern="0" dirty="0">
                 <a:solidFill>
                   <a:srgbClr val="5B6570"/>
                 </a:solidFill>
@@ -9059,7 +9389,7 @@
         <p:spPr>
           <a:xfrm>
             <a:off x="5340096" y="2039112"/>
-            <a:ext cx="3108960" cy="201168"/>
+            <a:ext cx="3108960" cy="274320"/>
           </a:xfrm>
           <a:prstGeom prst="rect">
             <a:avLst/>
@@ -9077,7 +9407,7 @@
               <a:buNone/>
             </a:pPr>
             <a:r>
-              <a:rPr lang="en-US" sz="1000" b="1" spc="30" kern="0" dirty="0">
+              <a:rPr lang="en-US" sz="1400" b="1" spc="30" kern="0" dirty="0">
                 <a:solidFill>
                   <a:srgbClr val="0B6172"/>
                 </a:solidFill>
@@ -9141,7 +9471,7 @@
         <p:spPr>
           <a:xfrm>
             <a:off x="5340096" y="3063240"/>
-            <a:ext cx="5440680" cy="219456"/>
+            <a:ext cx="5440680" cy="274320"/>
           </a:xfrm>
           <a:prstGeom prst="rect">
             <a:avLst/>
@@ -9159,7 +9489,7 @@
               <a:buNone/>
             </a:pPr>
             <a:r>
-              <a:rPr lang="en-US" sz="1200" dirty="0">
+              <a:rPr lang="en-US" sz="1600" dirty="0">
                 <a:solidFill>
                   <a:srgbClr val="4D5A68"/>
                 </a:solidFill>
@@ -9277,7 +9607,7 @@
         <p:spPr>
           <a:xfrm>
             <a:off x="4078224" y="5449824"/>
-            <a:ext cx="4041648" cy="256032"/>
+            <a:ext cx="4041648" cy="274320"/>
           </a:xfrm>
           <a:prstGeom prst="rect">
             <a:avLst/>
@@ -9295,7 +9625,7 @@
               <a:buNone/>
             </a:pPr>
             <a:r>
-              <a:rPr lang="en-US" sz="1000" b="1" dirty="0">
+              <a:rPr lang="en-US" sz="1400" b="1" dirty="0">
                 <a:solidFill>
                   <a:srgbClr val="4D5A68"/>
                 </a:solidFill>

</xml_diff>

<commit_message>
feat(slides): integrate four illustrated slides into full deck
Apply the approved image pilot and expand S72 text boxes so the production
deck matches the reviewed direction without changing story or claim scope.
</commit_message>
<xml_diff>
--- a/production/ACT_0.pptx
+++ b/production/ACT_0.pptx
@@ -2,21 +2,21 @@
 <file path=ppt/presentation.xml><?xml version="1.0" encoding="utf-8"?>
 <p:presentation xmlns:p="http://schemas.openxmlformats.org/presentationml/2006/main">
   <p:sldMasterIdLst>
-    <p:sldMasterId xmlns:r="http://schemas.openxmlformats.org/officeDocument/2006/relationships" id="2147483648" r:id="R181fbfcfd7f444e8"/>
+    <p:sldMasterId xmlns:r="http://schemas.openxmlformats.org/officeDocument/2006/relationships" id="2147483648" r:id="Rcfd6545bab244fac"/>
   </p:sldMasterIdLst>
   <p:notesMasterIdLst>
-    <p:notesMasterId xmlns:r="http://schemas.openxmlformats.org/officeDocument/2006/relationships" r:id="R08973efd2f904e72"/>
+    <p:notesMasterId xmlns:r="http://schemas.openxmlformats.org/officeDocument/2006/relationships" r:id="R350057a401cd4097"/>
   </p:notesMasterIdLst>
   <p:sldIdLst>
-    <p:sldId xmlns:r="http://schemas.openxmlformats.org/officeDocument/2006/relationships" id="256" r:id="Re4f251785f6a47ab"/>
-    <p:sldId xmlns:r="http://schemas.openxmlformats.org/officeDocument/2006/relationships" id="257" r:id="Rabc2fbe354804f9e"/>
-    <p:sldId xmlns:r="http://schemas.openxmlformats.org/officeDocument/2006/relationships" id="258" r:id="Rcb6ab11be9504592"/>
-    <p:sldId xmlns:r="http://schemas.openxmlformats.org/officeDocument/2006/relationships" id="259" r:id="R750adaabec674bcb"/>
-    <p:sldId xmlns:r="http://schemas.openxmlformats.org/officeDocument/2006/relationships" id="260" r:id="R9087f672cc634105"/>
-    <p:sldId xmlns:r="http://schemas.openxmlformats.org/officeDocument/2006/relationships" id="261" r:id="R62cfd5ac15c9483c"/>
-    <p:sldId xmlns:r="http://schemas.openxmlformats.org/officeDocument/2006/relationships" id="262" r:id="Rbc050e588c0a4ba1"/>
-    <p:sldId xmlns:r="http://schemas.openxmlformats.org/officeDocument/2006/relationships" id="263" r:id="R4befc3877e93419e"/>
-    <p:sldId xmlns:r="http://schemas.openxmlformats.org/officeDocument/2006/relationships" id="264" r:id="Ra318d8a0adc94f26"/>
+    <p:sldId xmlns:r="http://schemas.openxmlformats.org/officeDocument/2006/relationships" id="256" r:id="R8aa5610ce38e47a7"/>
+    <p:sldId xmlns:r="http://schemas.openxmlformats.org/officeDocument/2006/relationships" id="257" r:id="Rc8664a6622f84cc2"/>
+    <p:sldId xmlns:r="http://schemas.openxmlformats.org/officeDocument/2006/relationships" id="258" r:id="R3307bd078a3b4b3d"/>
+    <p:sldId xmlns:r="http://schemas.openxmlformats.org/officeDocument/2006/relationships" id="259" r:id="R2742a3743ca94081"/>
+    <p:sldId xmlns:r="http://schemas.openxmlformats.org/officeDocument/2006/relationships" id="260" r:id="Rf6b8b11adf524050"/>
+    <p:sldId xmlns:r="http://schemas.openxmlformats.org/officeDocument/2006/relationships" id="261" r:id="R02b04352c9514a53"/>
+    <p:sldId xmlns:r="http://schemas.openxmlformats.org/officeDocument/2006/relationships" id="262" r:id="R88fd7c0275744020"/>
+    <p:sldId xmlns:r="http://schemas.openxmlformats.org/officeDocument/2006/relationships" id="263" r:id="R720eb58830fb4207"/>
+    <p:sldId xmlns:r="http://schemas.openxmlformats.org/officeDocument/2006/relationships" id="264" r:id="Rd0f438ce06e842fc"/>
   </p:sldIdLst>
   <p:sldSz cx="12192000" cy="6858000"/>
   <p:notesSz cx="6858000" cy="9144000"/>
@@ -2230,12 +2230,12 @@
           </a:p>
           <a:p xmlns:a="http://schemas.openxmlformats.org/drawingml/2006/main">
             <a:r>
-              <a:t>1. **CALL BACK (0:00–0:45):** 위쪽 Repository → 개발자 선택·복사 → AI 관계로 S02를 짧게 회수한다.</a:t>
-            </a:r>
-          </a:p>
-          <a:p xmlns:a="http://schemas.openxmlformats.org/drawingml/2006/main">
-            <a:r>
-              <a:t>2. **TRANSFER (0:45–2:00):** 아래쪽 개발자 조사 요청 → Agent ↔ Repository로 시선을 옮긴다. 바뀌는 것은 Context를 찾는 주체의 일부이며 목표와 검증 책임을 전부 넘긴다는 뜻이 아니다.</a:t>
+              <a:t>1. **CALL BACK (0:00–0:45):** 왼쪽 Repository → 개발자 선택·복사 → AI 관계로 S02를 짧게 회수한다.</a:t>
+            </a:r>
+          </a:p>
+          <a:p xmlns:a="http://schemas.openxmlformats.org/drawingml/2006/main">
+            <a:r>
+              <a:t>2. **TRANSFER (0:45–2:00):** 오른쪽 개발자 조사 요청 → Agent ↔ Repository로 시선을 옮긴다. 바뀌는 것은 Context를 찾는 주체의 일부이며 목표와 검증 책임을 전부 넘긴다는 뜻이 아니다.</a:t>
             </a:r>
           </a:p>
           <a:p xmlns:a="http://schemas.openxmlformats.org/drawingml/2006/main">
@@ -2250,7 +2250,7 @@
           </a:p>
           <a:p xmlns:a="http://schemas.openxmlformats.org/drawingml/2006/main">
             <a:r>
-              <a:t>Evidence / Source: DEMO-01 / TRIAL-001 단일 CLI 관찰; BEAT-003, CLM-0002, CLM-0009. 본문은 Context 수집 역할을 비교하는 TEACHING_MODEL이며 하단에 연결된 과거 관찰의 범위를 별도로 표시한다.</a:t>
+              <a:t>Evidence / Source: DEMO-01 / TRIAL-001 단일 CLI 관찰; BEAT-003, CLM-0002, CLM-0009. 본문은 Context 수집 역할을 비교하는 TEACHING_MODEL이며 하단에 연결된 과거 관찰의 범위를 별도로 표시한다. 삽화 출처: prototype/image-illustration-pilot/assets/S07.png, built-in image_gen, 2026-10-18. 생성 프롬프트: prototype/image-illustration-pilot/PROMPTS.md. 실제 화면·현장 사진·관찰 자료가 아니다.</a:t>
             </a:r>
           </a:p>
           <a:p xmlns:a="http://schemas.openxmlformats.org/drawingml/2006/main">
@@ -2300,7 +2300,7 @@
           </a:p>
           <a:p xmlns:a="http://schemas.openxmlformats.org/drawingml/2006/main">
             <a:r>
-              <a:t>Demo Operation: DEMO-01 bounded callback. 본문 화살표는 교육 모델이고 새 제품 동작 관찰이 아니다. S05에서 본 단일 CLI 기록을 근거로 한 가능성을 설명하며 새 UI나 실행을 보여 주지 않는다.</a:t>
+              <a:t>Demo Operation: DEMO-01 bounded callback. 본문 삽화는 교육 모델이고 새 제품 동작 관찰이 아니다. S05에서 본 단일 CLI 기록을 근거로 한 가능성을 설명하며 새 UI나 실행을 보여 주지 않는다.</a:t>
             </a:r>
           </a:p>
           <a:p xmlns:a="http://schemas.openxmlformats.org/drawingml/2006/main">
@@ -2330,7 +2330,7 @@
           </a:p>
           <a:p xmlns:a="http://schemas.openxmlformats.org/drawingml/2006/main">
             <a:r>
-              <a:t>Time Management: 위·아래 관계의 변화에 집중한다. Trial 상세와 수치를 반복하지 않는다. C++ 연결은 선택적인 한 문장이며 3분 안에 S08로 이동한다.</a:t>
+              <a:t>Time Management: 좌·우 관계의 변화에 집중한다. Trial 상세와 수치를 반복하지 않는다. C++ 연결은 선택적인 한 문장이며 3분 안에 S08로 이동한다.</a:t>
             </a:r>
           </a:p>
           <a:p xmlns:a="http://schemas.openxmlformats.org/drawingml/2006/main">
@@ -2340,7 +2340,7 @@
           </a:p>
           <a:p xmlns:a="http://schemas.openxmlformats.org/drawingml/2006/main">
             <a:r>
-              <a:t>Fallback: Trial record를 표시할 수 없으면 Mental Shift만 Teaching Model로 설명한다. 제품 전반의 사실처럼 말하지 않는다.</a:t>
+              <a:t>Fallback: Trial record를 표시할 수 없으면 Mental Shift만 Teaching Model로 설명한다. 제품 전반의 사실처럼 말하지 않는다. 정적 파일: production/preview/act0/S07.png 및 production/preview/full/S07.png.</a:t>
             </a:r>
           </a:p>
           <a:p xmlns:a="http://schemas.openxmlformats.org/drawingml/2006/main">
@@ -2350,7 +2350,7 @@
           </a:p>
           <a:p xmlns:a="http://schemas.openxmlformats.org/drawingml/2006/main">
             <a:r>
-              <a:t>Validation Status: REVIEWED — 원문·Claim 경계, 화면의 설명 순서와 운영 지침을 대조했다. 최종 PPT/Notes/PNG 대조 결과는 production/evaluation/FULL_DECK_PRESENTATION_REVISION.md에 기록한다. Windows PowerPoint, 발표 PC 글꼴, 교육장 투사, 실제 시간 리허설은 UNVERIFIED.</a:t>
+              <a:t>Validation Status: REVIEWED — 사용자 승인 삽화를 전체 제작본에 반영했다. PPT/Notes/PNG 대조와 S72 잘림 재검토 결과는 production/evaluation/FULL_DECK_IMAGE_INTEGRATION.md에 기록한다. Windows PowerPoint, 발표 PC 글꼴, 교육장 투사, 실제 시간 리허설은 UNVERIFIED.</a:t>
             </a:r>
           </a:p>
         </p:txBody>
@@ -2952,7 +2952,7 @@
           <p:cNvPr id="3" name="Title">
             <a:extLst xmlns:a="http://schemas.openxmlformats.org/drawingml/2006/main">
               <a:ext uri="{FF2B5EF4-FFF2-40B4-BE49-F238E27FC236}">
-                <a16:creationId xmlns:a16="http://schemas.microsoft.com/office/drawing/2014/main" id="{0F6397C8-BA58-4FB1-97AE-C3824E99516F}"/>
+                <a16:creationId xmlns:a16="http://schemas.microsoft.com/office/drawing/2014/main" id="{94110EEA-940A-4AD2-BBE7-968E0EF24364}"/>
               </a:ext>
             </a:extLst>
           </p:cNvPr>
@@ -3181,7 +3181,7 @@
           <p:cNvPr id="2" name="Subtitle">
             <a:extLst xmlns:a="http://schemas.openxmlformats.org/drawingml/2006/main">
               <a:ext uri="{FF2B5EF4-FFF2-40B4-BE49-F238E27FC236}">
-                <a16:creationId xmlns:a16="http://schemas.microsoft.com/office/drawing/2014/main" id="{884C2596-C325-40DE-97C3-56C298C4DF4A}"/>
+                <a16:creationId xmlns:a16="http://schemas.microsoft.com/office/drawing/2014/main" id="{7FA1BB11-8B66-49D0-BE34-290F1A19EFD3}"/>
               </a:ext>
             </a:extLst>
           </p:cNvPr>
@@ -3427,7 +3427,7 @@
           <p:cNvPr id="2" name="Section title">
             <a:extLst xmlns:a="http://schemas.openxmlformats.org/drawingml/2006/main">
               <a:ext uri="{FF2B5EF4-FFF2-40B4-BE49-F238E27FC236}">
-                <a16:creationId xmlns:a16="http://schemas.microsoft.com/office/drawing/2014/main" id="{9A50FD74-C8F5-440C-8B77-42D38B58F9E1}"/>
+                <a16:creationId xmlns:a16="http://schemas.microsoft.com/office/drawing/2014/main" id="{AB2C153A-C5DF-40FF-8852-848EDDCBEFF7}"/>
               </a:ext>
             </a:extLst>
           </p:cNvPr>
@@ -3673,7 +3673,7 @@
           <p:cNvPr id="3" name="Title">
             <a:extLst xmlns:a="http://schemas.openxmlformats.org/drawingml/2006/main">
               <a:ext uri="{FF2B5EF4-FFF2-40B4-BE49-F238E27FC236}">
-                <a16:creationId xmlns:a16="http://schemas.microsoft.com/office/drawing/2014/main" id="{AAC0D9B6-CED3-4F63-8044-8A2732096003}"/>
+                <a16:creationId xmlns:a16="http://schemas.microsoft.com/office/drawing/2014/main" id="{6F7D2F4B-5F3F-4C2E-8BD9-81D76AD7834A}"/>
               </a:ext>
             </a:extLst>
           </p:cNvPr>
@@ -3902,7 +3902,7 @@
           <p:cNvPr id="2" name="Body">
             <a:extLst xmlns:a="http://schemas.openxmlformats.org/drawingml/2006/main">
               <a:ext uri="{FF2B5EF4-FFF2-40B4-BE49-F238E27FC236}">
-                <a16:creationId xmlns:a16="http://schemas.microsoft.com/office/drawing/2014/main" id="{5970F2DC-7AC5-4DC0-BDE8-F4C905DB4B5B}"/>
+                <a16:creationId xmlns:a16="http://schemas.microsoft.com/office/drawing/2014/main" id="{EDA97300-1F49-4EA0-AE6B-264659C21BD9}"/>
               </a:ext>
             </a:extLst>
           </p:cNvPr>
@@ -4148,7 +4148,7 @@
           <p:cNvPr id="4" name="Title">
             <a:extLst xmlns:a="http://schemas.openxmlformats.org/drawingml/2006/main">
               <a:ext uri="{FF2B5EF4-FFF2-40B4-BE49-F238E27FC236}">
-                <a16:creationId xmlns:a16="http://schemas.microsoft.com/office/drawing/2014/main" id="{6AE504CA-646C-4EF7-8041-59CD9E73742B}"/>
+                <a16:creationId xmlns:a16="http://schemas.microsoft.com/office/drawing/2014/main" id="{EAFD4979-0372-49B7-A350-B633B5F69312}"/>
               </a:ext>
             </a:extLst>
           </p:cNvPr>
@@ -4377,7 +4377,7 @@
           <p:cNvPr id="2" name="Left column">
             <a:extLst xmlns:a="http://schemas.openxmlformats.org/drawingml/2006/main">
               <a:ext uri="{FF2B5EF4-FFF2-40B4-BE49-F238E27FC236}">
-                <a16:creationId xmlns:a16="http://schemas.microsoft.com/office/drawing/2014/main" id="{4F570224-FBE1-4777-8022-2846F1FED69E}"/>
+                <a16:creationId xmlns:a16="http://schemas.microsoft.com/office/drawing/2014/main" id="{86E7BFDC-6B98-4669-9567-B7C8FDE753A7}"/>
               </a:ext>
             </a:extLst>
           </p:cNvPr>
@@ -4606,7 +4606,7 @@
           <p:cNvPr id="3" name="Right column">
             <a:extLst xmlns:a="http://schemas.openxmlformats.org/drawingml/2006/main">
               <a:ext uri="{FF2B5EF4-FFF2-40B4-BE49-F238E27FC236}">
-                <a16:creationId xmlns:a16="http://schemas.microsoft.com/office/drawing/2014/main" id="{39F2A6FA-F76F-4CFD-94F1-DD2C5F8ADAD3}"/>
+                <a16:creationId xmlns:a16="http://schemas.microsoft.com/office/drawing/2014/main" id="{E36A8AF9-84CB-4594-8BEE-60A04A7591C5}"/>
               </a:ext>
             </a:extLst>
           </p:cNvPr>
@@ -4852,7 +4852,7 @@
           <p:cNvPr id="3" name="Title">
             <a:extLst xmlns:a="http://schemas.openxmlformats.org/drawingml/2006/main">
               <a:ext uri="{FF2B5EF4-FFF2-40B4-BE49-F238E27FC236}">
-                <a16:creationId xmlns:a16="http://schemas.microsoft.com/office/drawing/2014/main" id="{7FABA1AF-0674-4073-B5BA-E38D032139AC}"/>
+                <a16:creationId xmlns:a16="http://schemas.microsoft.com/office/drawing/2014/main" id="{1DC08E22-0AEB-43A5-A962-53D304376F3A}"/>
               </a:ext>
             </a:extLst>
           </p:cNvPr>
@@ -5081,7 +5081,7 @@
           <p:cNvPr id="2" name="Left column">
             <a:extLst xmlns:a="http://schemas.openxmlformats.org/drawingml/2006/main">
               <a:ext uri="{FF2B5EF4-FFF2-40B4-BE49-F238E27FC236}">
-                <a16:creationId xmlns:a16="http://schemas.microsoft.com/office/drawing/2014/main" id="{64E7D74E-5666-4598-8B90-AE05415A086A}"/>
+                <a16:creationId xmlns:a16="http://schemas.microsoft.com/office/drawing/2014/main" id="{950C57F3-BD06-4430-BC23-7BFAC09ACB12}"/>
               </a:ext>
             </a:extLst>
           </p:cNvPr>
@@ -5348,12 +5348,12 @@
   </p:cSld>
   <p:clrMap bg1="lt1" tx1="dk1" bg2="lt2" tx2="dk2" accent1="accent1" accent2="accent2" accent3="accent3" accent4="accent4" accent5="accent5" accent6="accent6" hlink="hlink" folHlink="folHlink"/>
   <p:sldLayoutIdLst>
-    <p:sldLayoutId xmlns:r="http://schemas.openxmlformats.org/officeDocument/2006/relationships" id="2147483649" r:id="Rc11899a5584f4993"/>
-    <p:sldLayoutId xmlns:r="http://schemas.openxmlformats.org/officeDocument/2006/relationships" id="2147483650" r:id="R7e189d64db2644d1"/>
-    <p:sldLayoutId xmlns:r="http://schemas.openxmlformats.org/officeDocument/2006/relationships" id="2147483651" r:id="Rddc01e430abf4daa"/>
-    <p:sldLayoutId xmlns:r="http://schemas.openxmlformats.org/officeDocument/2006/relationships" id="2147483652" r:id="R8f01799c1a44404e"/>
-    <p:sldLayoutId xmlns:r="http://schemas.openxmlformats.org/officeDocument/2006/relationships" id="2147483653" r:id="Rd7918ddd1ebb410f"/>
-    <p:sldLayoutId xmlns:r="http://schemas.openxmlformats.org/officeDocument/2006/relationships" id="2147483654" r:id="Rf16b138183d64295"/>
+    <p:sldLayoutId xmlns:r="http://schemas.openxmlformats.org/officeDocument/2006/relationships" id="2147483649" r:id="Rb752b259b5e24bff"/>
+    <p:sldLayoutId xmlns:r="http://schemas.openxmlformats.org/officeDocument/2006/relationships" id="2147483650" r:id="R0705ceca7eac4600"/>
+    <p:sldLayoutId xmlns:r="http://schemas.openxmlformats.org/officeDocument/2006/relationships" id="2147483651" r:id="Rb61348a9444347e0"/>
+    <p:sldLayoutId xmlns:r="http://schemas.openxmlformats.org/officeDocument/2006/relationships" id="2147483652" r:id="Rb80442465c9846ba"/>
+    <p:sldLayoutId xmlns:r="http://schemas.openxmlformats.org/officeDocument/2006/relationships" id="2147483653" r:id="R1e1f8b93462c4dd7"/>
+    <p:sldLayoutId xmlns:r="http://schemas.openxmlformats.org/officeDocument/2006/relationships" id="2147483654" r:id="R0dc66cb90aed4f23"/>
   </p:sldLayoutIdLst>
   <p:txStyles>
     <p:titleStyle>
@@ -5904,7 +5904,7 @@
           <p:cNvPr id="12" name="ACT 0 · 익숙한 사용에서 시작하기">
             <a:extLst xmlns:a="http://schemas.openxmlformats.org/drawingml/2006/main">
               <a:ext uri="{FF2B5EF4-FFF2-40B4-BE49-F238E27FC236}">
-                <a16:creationId xmlns:a16="http://schemas.microsoft.com/office/drawing/2014/main" id="{DFEEEE41-D005-4BAE-BF69-BCA3B5604D83}"/>
+                <a16:creationId xmlns:a16="http://schemas.microsoft.com/office/drawing/2014/main" id="{794B5716-827F-4FDA-9F7C-ECF6CE773359}"/>
               </a:ext>
             </a:extLst>
           </p:cNvPr>
@@ -6062,7 +6062,7 @@
           <p:cNvPr id="2" name="S01">
             <a:extLst xmlns:a="http://schemas.openxmlformats.org/drawingml/2006/main">
               <a:ext uri="{FF2B5EF4-FFF2-40B4-BE49-F238E27FC236}">
-                <a16:creationId xmlns:a16="http://schemas.microsoft.com/office/drawing/2014/main" id="{CB2CA460-D20C-41EE-BBE0-CFBE051F43A3}"/>
+                <a16:creationId xmlns:a16="http://schemas.microsoft.com/office/drawing/2014/main" id="{2330EF03-A4D6-4625-A968-C24E56F042E1}"/>
               </a:ext>
             </a:extLst>
           </p:cNvPr>
@@ -6220,7 +6220,7 @@
           <p:cNvPr id="3" name="AI에게 지금 무엇을 맡기고 있는가?">
             <a:extLst xmlns:a="http://schemas.openxmlformats.org/drawingml/2006/main">
               <a:ext uri="{FF2B5EF4-FFF2-40B4-BE49-F238E27FC236}">
-                <a16:creationId xmlns:a16="http://schemas.microsoft.com/office/drawing/2014/main" id="{9CCEFD00-0304-4947-B688-13C585524EE4}"/>
+                <a16:creationId xmlns:a16="http://schemas.microsoft.com/office/drawing/2014/main" id="{97302C9F-50E4-4822-AC83-CB89C3498065}"/>
               </a:ext>
             </a:extLst>
           </p:cNvPr>
@@ -6378,7 +6378,7 @@
           <p:cNvPr id="4" name="">
             <a:extLst xmlns:a="http://schemas.openxmlformats.org/drawingml/2006/main">
               <a:ext uri="{FF2B5EF4-FFF2-40B4-BE49-F238E27FC236}">
-                <a16:creationId xmlns:a16="http://schemas.microsoft.com/office/drawing/2014/main" id="{ED53C485-96AF-4F44-B060-46940A7BA256}"/>
+                <a16:creationId xmlns:a16="http://schemas.microsoft.com/office/drawing/2014/main" id="{31B379DF-65B3-40B9-8EB3-D094F89FEC8D}"/>
               </a:ext>
             </a:extLst>
           </p:cNvPr>
@@ -6409,7 +6409,7 @@
           <p:cNvPr id="5" name="생각해 보기 · 이 과정의 교육 모델">
             <a:extLst xmlns:a="http://schemas.openxmlformats.org/drawingml/2006/main">
               <a:ext uri="{FF2B5EF4-FFF2-40B4-BE49-F238E27FC236}">
-                <a16:creationId xmlns:a16="http://schemas.microsoft.com/office/drawing/2014/main" id="{EDB0722F-322A-4BD4-A16F-A086FB157015}"/>
+                <a16:creationId xmlns:a16="http://schemas.microsoft.com/office/drawing/2014/main" id="{B60C50D0-DC58-4AF3-A952-C6494D58A60B}"/>
               </a:ext>
             </a:extLst>
           </p:cNvPr>
@@ -6567,7 +6567,7 @@
           <p:cNvPr id="6" name="자신의 경험 하나만 떠올려 보세요. 사용 수준을 평가하는 질문이 아닙니다.">
             <a:extLst xmlns:a="http://schemas.openxmlformats.org/drawingml/2006/main">
               <a:ext uri="{FF2B5EF4-FFF2-40B4-BE49-F238E27FC236}">
-                <a16:creationId xmlns:a16="http://schemas.microsoft.com/office/drawing/2014/main" id="{49635723-3D87-45CC-8DE5-EB13749796AA}"/>
+                <a16:creationId xmlns:a16="http://schemas.microsoft.com/office/drawing/2014/main" id="{581A929F-54A3-438F-B150-6F2F1C173480}"/>
               </a:ext>
             </a:extLst>
           </p:cNvPr>
@@ -6725,7 +6725,7 @@
           <p:cNvPr id="7" name="가장 최근에 AI에게 맡긴 일 하나">
             <a:extLst xmlns:a="http://schemas.openxmlformats.org/drawingml/2006/main">
               <a:ext uri="{FF2B5EF4-FFF2-40B4-BE49-F238E27FC236}">
-                <a16:creationId xmlns:a16="http://schemas.microsoft.com/office/drawing/2014/main" id="{98A5C025-5E65-4F65-81C5-F5BCD6C43290}"/>
+                <a16:creationId xmlns:a16="http://schemas.microsoft.com/office/drawing/2014/main" id="{51B5D4AC-28A6-4A21-A0B6-E744F7F3E040}"/>
               </a:ext>
             </a:extLst>
           </p:cNvPr>
@@ -6883,7 +6883,7 @@
           <p:cNvPr id="8" name="오류 설명을 들었나요?&#10;관련 코드를 조사하게 했나요?&#10;수정한 결과까지 확인하게 했나요?">
             <a:extLst xmlns:a="http://schemas.openxmlformats.org/drawingml/2006/main">
               <a:ext uri="{FF2B5EF4-FFF2-40B4-BE49-F238E27FC236}">
-                <a16:creationId xmlns:a16="http://schemas.microsoft.com/office/drawing/2014/main" id="{A906EEFD-05F9-4286-977A-2A9FB37A0054}"/>
+                <a16:creationId xmlns:a16="http://schemas.microsoft.com/office/drawing/2014/main" id="{79C38499-9C13-4711-AF29-3AF8CD9166AB}"/>
               </a:ext>
             </a:extLst>
           </p:cNvPr>
@@ -7087,7 +7087,7 @@
           <p:cNvPr id="9" name="">
             <a:extLst xmlns:a="http://schemas.openxmlformats.org/drawingml/2006/main">
               <a:ext uri="{FF2B5EF4-FFF2-40B4-BE49-F238E27FC236}">
-                <a16:creationId xmlns:a16="http://schemas.microsoft.com/office/drawing/2014/main" id="{FA937596-6A54-4B5C-ACE9-AF5600A9ADC9}"/>
+                <a16:creationId xmlns:a16="http://schemas.microsoft.com/office/drawing/2014/main" id="{7FFA8CE1-DF2E-4C54-BBF0-E731A658DA0B}"/>
               </a:ext>
             </a:extLst>
           </p:cNvPr>
@@ -7118,7 +7118,7 @@
           <p:cNvPr id="10" name="질문 · 생성&#10;조사 · 변경&#10;검증 · 작업 방식 개선">
             <a:extLst xmlns:a="http://schemas.openxmlformats.org/drawingml/2006/main">
               <a:ext uri="{FF2B5EF4-FFF2-40B4-BE49-F238E27FC236}">
-                <a16:creationId xmlns:a16="http://schemas.microsoft.com/office/drawing/2014/main" id="{F2D0ABAE-6517-4A90-A124-DEFD7CE888EB}"/>
+                <a16:creationId xmlns:a16="http://schemas.microsoft.com/office/drawing/2014/main" id="{8E5FD42F-9A0D-4175-A752-3EC9BAEDC141}"/>
               </a:ext>
             </a:extLst>
           </p:cNvPr>
@@ -7322,7 +7322,7 @@
           <p:cNvPr id="11" name="익숙한 방식에서 출발해도 괜찮습니다.">
             <a:extLst xmlns:a="http://schemas.openxmlformats.org/drawingml/2006/main">
               <a:ext uri="{FF2B5EF4-FFF2-40B4-BE49-F238E27FC236}">
-                <a16:creationId xmlns:a16="http://schemas.microsoft.com/office/drawing/2014/main" id="{589C132A-A71F-4A40-896F-62276C3652FC}"/>
+                <a16:creationId xmlns:a16="http://schemas.microsoft.com/office/drawing/2014/main" id="{2DC890F4-E3B1-4B31-90EA-6763310B9F5C}"/>
               </a:ext>
             </a:extLst>
           </p:cNvPr>
@@ -7478,7 +7478,7 @@
     </p:spTree>
     <p:extLst>
       <p:ext uri="{BB962C8B-B14F-4D97-AF65-F5344CB8AC3E}">
-        <p14:creationId xmlns:p14="http://schemas.microsoft.com/office/powerpoint/2010/main" val="1420439844"/>
+        <p14:creationId xmlns:p14="http://schemas.microsoft.com/office/powerpoint/2010/main" val="290401250"/>
       </p:ext>
     </p:extLst>
   </p:cSld>
@@ -7509,7 +7509,7 @@
           <p:cNvPr id="23" name="ACT 0 · 작은 코드 질문">
             <a:extLst xmlns:a="http://schemas.openxmlformats.org/drawingml/2006/main">
               <a:ext uri="{FF2B5EF4-FFF2-40B4-BE49-F238E27FC236}">
-                <a16:creationId xmlns:a16="http://schemas.microsoft.com/office/drawing/2014/main" id="{8979F82F-B11F-4229-A54F-F26EB8CEA400}"/>
+                <a16:creationId xmlns:a16="http://schemas.microsoft.com/office/drawing/2014/main" id="{55A384A2-849B-4D39-9B4D-D609DC471474}"/>
               </a:ext>
             </a:extLst>
           </p:cNvPr>
@@ -7667,7 +7667,7 @@
           <p:cNvPr id="2" name="S02">
             <a:extLst xmlns:a="http://schemas.openxmlformats.org/drawingml/2006/main">
               <a:ext uri="{FF2B5EF4-FFF2-40B4-BE49-F238E27FC236}">
-                <a16:creationId xmlns:a16="http://schemas.microsoft.com/office/drawing/2014/main" id="{59D2CE75-782B-4902-B01A-DCB48C8E0518}"/>
+                <a16:creationId xmlns:a16="http://schemas.microsoft.com/office/drawing/2014/main" id="{28F0E739-6A89-4667-A373-FEA4D4C27D74}"/>
               </a:ext>
             </a:extLst>
           </p:cNvPr>
@@ -7825,7 +7825,7 @@
           <p:cNvPr id="3" name="작은 질문에는 Chatbot이 유용하다">
             <a:extLst xmlns:a="http://schemas.openxmlformats.org/drawingml/2006/main">
               <a:ext uri="{FF2B5EF4-FFF2-40B4-BE49-F238E27FC236}">
-                <a16:creationId xmlns:a16="http://schemas.microsoft.com/office/drawing/2014/main" id="{F735B182-7EF1-4FFA-BD89-56CF0DC2FAF4}"/>
+                <a16:creationId xmlns:a16="http://schemas.microsoft.com/office/drawing/2014/main" id="{B8F20E60-BFC1-4F07-B6B5-2A10CDD04338}"/>
               </a:ext>
             </a:extLst>
           </p:cNvPr>
@@ -7983,7 +7983,7 @@
           <p:cNvPr id="4" name="">
             <a:extLst xmlns:a="http://schemas.openxmlformats.org/drawingml/2006/main">
               <a:ext uri="{FF2B5EF4-FFF2-40B4-BE49-F238E27FC236}">
-                <a16:creationId xmlns:a16="http://schemas.microsoft.com/office/drawing/2014/main" id="{570057A1-8844-4818-9153-040017783FDD}"/>
+                <a16:creationId xmlns:a16="http://schemas.microsoft.com/office/drawing/2014/main" id="{60077921-AFDD-4307-8D19-2408BC8A2947}"/>
               </a:ext>
             </a:extLst>
           </p:cNvPr>
@@ -8014,7 +8014,7 @@
           <p:cNvPr id="5" name="교육용 예시 · 실제 ChatGPT 대화 캡처가 아님">
             <a:extLst xmlns:a="http://schemas.openxmlformats.org/drawingml/2006/main">
               <a:ext uri="{FF2B5EF4-FFF2-40B4-BE49-F238E27FC236}">
-                <a16:creationId xmlns:a16="http://schemas.microsoft.com/office/drawing/2014/main" id="{EB0DAA43-AD48-4D98-BAD6-AA0B76F7D01C}"/>
+                <a16:creationId xmlns:a16="http://schemas.microsoft.com/office/drawing/2014/main" id="{A89D04C8-B19C-40B8-B0FB-99D659A29C52}"/>
               </a:ext>
             </a:extLst>
           </p:cNvPr>
@@ -8172,7 +8172,7 @@
           <p:cNvPr id="6" name="일반적인 질문 흐름을 설명하며 특정 제품의 정확도나 우월성을 주장하지 않습니다.">
             <a:extLst xmlns:a="http://schemas.openxmlformats.org/drawingml/2006/main">
               <a:ext uri="{FF2B5EF4-FFF2-40B4-BE49-F238E27FC236}">
-                <a16:creationId xmlns:a16="http://schemas.microsoft.com/office/drawing/2014/main" id="{FAAA8596-5321-4FAB-A26F-F76AFA36A572}"/>
+                <a16:creationId xmlns:a16="http://schemas.microsoft.com/office/drawing/2014/main" id="{0D7D3CB7-9180-4ACF-A35E-B1AC5982B5FA}"/>
               </a:ext>
             </a:extLst>
           </p:cNvPr>
@@ -8330,7 +8330,7 @@
           <p:cNvPr id="7" name="“이 코드에서 무엇이 남을까?”">
             <a:extLst xmlns:a="http://schemas.openxmlformats.org/drawingml/2006/main">
               <a:ext uri="{FF2B5EF4-FFF2-40B4-BE49-F238E27FC236}">
-                <a16:creationId xmlns:a16="http://schemas.microsoft.com/office/drawing/2014/main" id="{6667156C-362D-4A2F-A778-C7B8DC961A5C}"/>
+                <a16:creationId xmlns:a16="http://schemas.microsoft.com/office/drawing/2014/main" id="{6BA89199-33BE-4A2A-AC25-D055D0D67900}"/>
               </a:ext>
             </a:extLst>
           </p:cNvPr>
@@ -8488,7 +8488,7 @@
           <p:cNvPr id="8" name="">
             <a:extLst xmlns:a="http://schemas.openxmlformats.org/drawingml/2006/main">
               <a:ext uri="{FF2B5EF4-FFF2-40B4-BE49-F238E27FC236}">
-                <a16:creationId xmlns:a16="http://schemas.microsoft.com/office/drawing/2014/main" id="{E7CE4B47-91FA-4370-9E7D-9D280F538C0E}"/>
+                <a16:creationId xmlns:a16="http://schemas.microsoft.com/office/drawing/2014/main" id="{40C40B88-24A0-4D1C-8F90-8A4DB51FB187}"/>
               </a:ext>
             </a:extLst>
           </p:cNvPr>
@@ -8519,7 +8519,7 @@
           <p:cNvPr id="9" name="row = [1, 2, 3, 4]&#10;row[1:3]">
             <a:extLst xmlns:a="http://schemas.openxmlformats.org/drawingml/2006/main">
               <a:ext uri="{FF2B5EF4-FFF2-40B4-BE49-F238E27FC236}">
-                <a16:creationId xmlns:a16="http://schemas.microsoft.com/office/drawing/2014/main" id="{41D454DA-D081-40A8-B28E-8F55F0D62A90}"/>
+                <a16:creationId xmlns:a16="http://schemas.microsoft.com/office/drawing/2014/main" id="{DF82A4D6-4358-4B10-ABFC-B82CF68A5AA2}"/>
               </a:ext>
             </a:extLst>
           </p:cNvPr>
@@ -8700,7 +8700,7 @@
           <p:cNvPr id="10" name="">
             <a:extLst xmlns:a="http://schemas.openxmlformats.org/drawingml/2006/main">
               <a:ext uri="{FF2B5EF4-FFF2-40B4-BE49-F238E27FC236}">
-                <a16:creationId xmlns:a16="http://schemas.microsoft.com/office/drawing/2014/main" id="{6D9EFBE5-3D03-406D-B862-0702C3E4AA5A}"/>
+                <a16:creationId xmlns:a16="http://schemas.microsoft.com/office/drawing/2014/main" id="{A10D5A97-2A13-4A4D-B763-9EAB7B80B770}"/>
               </a:ext>
             </a:extLst>
           </p:cNvPr>
@@ -8730,7 +8730,7 @@
           <p:cNvPr id="11" name="[2, 3]">
             <a:extLst xmlns:a="http://schemas.openxmlformats.org/drawingml/2006/main">
               <a:ext uri="{FF2B5EF4-FFF2-40B4-BE49-F238E27FC236}">
-                <a16:creationId xmlns:a16="http://schemas.microsoft.com/office/drawing/2014/main" id="{DFA05C67-DC95-4EA2-B831-C5BF0E0C6407}"/>
+                <a16:creationId xmlns:a16="http://schemas.microsoft.com/office/drawing/2014/main" id="{B6D3240D-7C45-4554-9EF2-D5919991F953}"/>
               </a:ext>
             </a:extLst>
           </p:cNvPr>
@@ -8888,7 +8888,7 @@
           <p:cNvPr id="12" name="끝 index 3은 포함하지 않습니다.">
             <a:extLst xmlns:a="http://schemas.openxmlformats.org/drawingml/2006/main">
               <a:ext uri="{FF2B5EF4-FFF2-40B4-BE49-F238E27FC236}">
-                <a16:creationId xmlns:a16="http://schemas.microsoft.com/office/drawing/2014/main" id="{D5AC0D1C-FD3A-4A66-AB9D-3C66C220F0B9}"/>
+                <a16:creationId xmlns:a16="http://schemas.microsoft.com/office/drawing/2014/main" id="{D14B5AF2-D564-4C9B-A3FA-92250A79EF8C}"/>
               </a:ext>
             </a:extLst>
           </p:cNvPr>
@@ -9046,7 +9046,7 @@
           <p:cNvPr id="13" name="코드·오류">
             <a:extLst xmlns:a="http://schemas.openxmlformats.org/drawingml/2006/main">
               <a:ext uri="{FF2B5EF4-FFF2-40B4-BE49-F238E27FC236}">
-                <a16:creationId xmlns:a16="http://schemas.microsoft.com/office/drawing/2014/main" id="{8111CAE2-A6D0-48C6-8457-6E1245E9ED29}"/>
+                <a16:creationId xmlns:a16="http://schemas.microsoft.com/office/drawing/2014/main" id="{4A9F775C-7F12-4773-8AFF-911AA6FF2EF7}"/>
               </a:ext>
             </a:extLst>
           </p:cNvPr>
@@ -9204,7 +9204,7 @@
           <p:cNvPr id="14" name="">
             <a:extLst xmlns:a="http://schemas.openxmlformats.org/drawingml/2006/main">
               <a:ext uri="{FF2B5EF4-FFF2-40B4-BE49-F238E27FC236}">
-                <a16:creationId xmlns:a16="http://schemas.microsoft.com/office/drawing/2014/main" id="{7FD878AF-E131-49B8-88F4-B30BDAB78A09}"/>
+                <a16:creationId xmlns:a16="http://schemas.microsoft.com/office/drawing/2014/main" id="{B9E4DD11-52B4-4868-BB8B-49AEC113667A}"/>
               </a:ext>
             </a:extLst>
           </p:cNvPr>
@@ -9234,7 +9234,7 @@
           <p:cNvPr id="15" name="복사">
             <a:extLst xmlns:a="http://schemas.openxmlformats.org/drawingml/2006/main">
               <a:ext uri="{FF2B5EF4-FFF2-40B4-BE49-F238E27FC236}">
-                <a16:creationId xmlns:a16="http://schemas.microsoft.com/office/drawing/2014/main" id="{03B82AB6-6FCA-4167-9581-23210DA5FDE0}"/>
+                <a16:creationId xmlns:a16="http://schemas.microsoft.com/office/drawing/2014/main" id="{2D64D5A7-B267-425A-B017-EA76F4F2B37C}"/>
               </a:ext>
             </a:extLst>
           </p:cNvPr>
@@ -9392,7 +9392,7 @@
           <p:cNvPr id="16" name="">
             <a:extLst xmlns:a="http://schemas.openxmlformats.org/drawingml/2006/main">
               <a:ext uri="{FF2B5EF4-FFF2-40B4-BE49-F238E27FC236}">
-                <a16:creationId xmlns:a16="http://schemas.microsoft.com/office/drawing/2014/main" id="{67F25E0F-43D4-496C-B2F3-6982444BEC72}"/>
+                <a16:creationId xmlns:a16="http://schemas.microsoft.com/office/drawing/2014/main" id="{551080FC-4440-483F-A120-81F1FD82F825}"/>
               </a:ext>
             </a:extLst>
           </p:cNvPr>
@@ -9422,7 +9422,7 @@
           <p:cNvPr id="17" name="질문">
             <a:extLst xmlns:a="http://schemas.openxmlformats.org/drawingml/2006/main">
               <a:ext uri="{FF2B5EF4-FFF2-40B4-BE49-F238E27FC236}">
-                <a16:creationId xmlns:a16="http://schemas.microsoft.com/office/drawing/2014/main" id="{3D4CF0A2-DEAD-4A1D-BB82-608F757501B3}"/>
+                <a16:creationId xmlns:a16="http://schemas.microsoft.com/office/drawing/2014/main" id="{6531BE24-4005-48B4-9464-E4B7195C1605}"/>
               </a:ext>
             </a:extLst>
           </p:cNvPr>
@@ -9580,7 +9580,7 @@
           <p:cNvPr id="18" name="">
             <a:extLst xmlns:a="http://schemas.openxmlformats.org/drawingml/2006/main">
               <a:ext uri="{FF2B5EF4-FFF2-40B4-BE49-F238E27FC236}">
-                <a16:creationId xmlns:a16="http://schemas.microsoft.com/office/drawing/2014/main" id="{DEAEE93D-783F-4A54-9B0C-365F03BB2817}"/>
+                <a16:creationId xmlns:a16="http://schemas.microsoft.com/office/drawing/2014/main" id="{F9AA33F4-7ED8-4BE1-A09C-125560393EE3}"/>
               </a:ext>
             </a:extLst>
           </p:cNvPr>
@@ -9610,7 +9610,7 @@
           <p:cNvPr id="19" name="답 확인">
             <a:extLst xmlns:a="http://schemas.openxmlformats.org/drawingml/2006/main">
               <a:ext uri="{FF2B5EF4-FFF2-40B4-BE49-F238E27FC236}">
-                <a16:creationId xmlns:a16="http://schemas.microsoft.com/office/drawing/2014/main" id="{92A0087B-F9E9-42F7-98F9-4F98A5E5B36C}"/>
+                <a16:creationId xmlns:a16="http://schemas.microsoft.com/office/drawing/2014/main" id="{50F9C3C0-90FB-4D54-9396-550C408B278B}"/>
               </a:ext>
             </a:extLst>
           </p:cNvPr>
@@ -9768,7 +9768,7 @@
           <p:cNvPr id="20" name="">
             <a:extLst xmlns:a="http://schemas.openxmlformats.org/drawingml/2006/main">
               <a:ext uri="{FF2B5EF4-FFF2-40B4-BE49-F238E27FC236}">
-                <a16:creationId xmlns:a16="http://schemas.microsoft.com/office/drawing/2014/main" id="{590FFC41-8A63-4B13-8445-FAF5F8FB61F1}"/>
+                <a16:creationId xmlns:a16="http://schemas.microsoft.com/office/drawing/2014/main" id="{1D78FEF0-DC4C-48D6-AE0C-155FA355F85B}"/>
               </a:ext>
             </a:extLst>
           </p:cNvPr>
@@ -9798,7 +9798,7 @@
           <p:cNvPr id="21" name="IDE로 복귀">
             <a:extLst xmlns:a="http://schemas.openxmlformats.org/drawingml/2006/main">
               <a:ext uri="{FF2B5EF4-FFF2-40B4-BE49-F238E27FC236}">
-                <a16:creationId xmlns:a16="http://schemas.microsoft.com/office/drawing/2014/main" id="{5FA6D124-3A53-4E8B-94C9-206155FEF259}"/>
+                <a16:creationId xmlns:a16="http://schemas.microsoft.com/office/drawing/2014/main" id="{D1457468-9A74-4A54-8EFF-336E645FEFBA}"/>
               </a:ext>
             </a:extLst>
           </p:cNvPr>
@@ -9956,7 +9956,7 @@
           <p:cNvPr id="22" name="">
             <a:extLst xmlns:a="http://schemas.openxmlformats.org/drawingml/2006/main">
               <a:ext uri="{FF2B5EF4-FFF2-40B4-BE49-F238E27FC236}">
-                <a16:creationId xmlns:a16="http://schemas.microsoft.com/office/drawing/2014/main" id="{6A245F98-2184-41BB-9C7A-66CE6CFF85D5}"/>
+                <a16:creationId xmlns:a16="http://schemas.microsoft.com/office/drawing/2014/main" id="{31A1B519-7DDA-4D1B-8F45-C8384A666540}"/>
               </a:ext>
             </a:extLst>
           </p:cNvPr>
@@ -9985,7 +9985,7 @@
     </p:spTree>
     <p:extLst>
       <p:ext uri="{BB962C8B-B14F-4D97-AF65-F5344CB8AC3E}">
-        <p14:creationId xmlns:p14="http://schemas.microsoft.com/office/powerpoint/2010/main" val="640138592"/>
+        <p14:creationId xmlns:p14="http://schemas.microsoft.com/office/powerpoint/2010/main" val="75978775"/>
       </p:ext>
     </p:extLst>
   </p:cSld>
@@ -10016,7 +10016,7 @@
           <p:cNvPr id="24" name="ACT 0 · 여러 파일을 가로지르는 질문">
             <a:extLst xmlns:a="http://schemas.openxmlformats.org/drawingml/2006/main">
               <a:ext uri="{FF2B5EF4-FFF2-40B4-BE49-F238E27FC236}">
-                <a16:creationId xmlns:a16="http://schemas.microsoft.com/office/drawing/2014/main" id="{20C9B3CC-79A6-4877-A46B-C909EC51B98F}"/>
+                <a16:creationId xmlns:a16="http://schemas.microsoft.com/office/drawing/2014/main" id="{6EF967D4-6E49-4D0B-894B-1C696D2560D5}"/>
               </a:ext>
             </a:extLst>
           </p:cNvPr>
@@ -10174,7 +10174,7 @@
           <p:cNvPr id="2" name="S03">
             <a:extLst xmlns:a="http://schemas.openxmlformats.org/drawingml/2006/main">
               <a:ext uri="{FF2B5EF4-FFF2-40B4-BE49-F238E27FC236}">
-                <a16:creationId xmlns:a16="http://schemas.microsoft.com/office/drawing/2014/main" id="{82B18227-23E9-4407-B5B2-A2FB23D92E6D}"/>
+                <a16:creationId xmlns:a16="http://schemas.microsoft.com/office/drawing/2014/main" id="{F735BAD6-3051-4CDA-BEC7-1303F9995D5D}"/>
               </a:ext>
             </a:extLst>
           </p:cNvPr>
@@ -10332,7 +10332,7 @@
           <p:cNvPr id="3" name="질문이 커지면 Context를 모으는 일이 생긴다">
             <a:extLst xmlns:a="http://schemas.openxmlformats.org/drawingml/2006/main">
               <a:ext uri="{FF2B5EF4-FFF2-40B4-BE49-F238E27FC236}">
-                <a16:creationId xmlns:a16="http://schemas.microsoft.com/office/drawing/2014/main" id="{79E15B9F-6A09-41D3-8392-A26A5619E4E1}"/>
+                <a16:creationId xmlns:a16="http://schemas.microsoft.com/office/drawing/2014/main" id="{4803C8E1-FBA3-4300-87B7-DDDCA44A62C2}"/>
               </a:ext>
             </a:extLst>
           </p:cNvPr>
@@ -10490,7 +10490,7 @@
           <p:cNvPr id="4" name="">
             <a:extLst xmlns:a="http://schemas.openxmlformats.org/drawingml/2006/main">
               <a:ext uri="{FF2B5EF4-FFF2-40B4-BE49-F238E27FC236}">
-                <a16:creationId xmlns:a16="http://schemas.microsoft.com/office/drawing/2014/main" id="{4C506AA8-70E9-4883-B945-C892D0D430F4}"/>
+                <a16:creationId xmlns:a16="http://schemas.microsoft.com/office/drawing/2014/main" id="{E75CC2B1-A7CB-4B07-BDA8-D72076B620E0}"/>
               </a:ext>
             </a:extLst>
           </p:cNvPr>
@@ -10521,7 +10521,7 @@
           <p:cNvPr id="5" name="개념 사례 · Repository 수준의 질문을 설명하는 관계도">
             <a:extLst xmlns:a="http://schemas.openxmlformats.org/drawingml/2006/main">
               <a:ext uri="{FF2B5EF4-FFF2-40B4-BE49-F238E27FC236}">
-                <a16:creationId xmlns:a16="http://schemas.microsoft.com/office/drawing/2014/main" id="{74D2709C-9A22-4BAC-A3DF-FDAE2C2B1321}"/>
+                <a16:creationId xmlns:a16="http://schemas.microsoft.com/office/drawing/2014/main" id="{70BC8169-016A-4181-883C-BC235264E458}"/>
               </a:ext>
             </a:extLst>
           </p:cNvPr>
@@ -10679,7 +10679,7 @@
           <p:cNvPr id="6" name="특정 Trial에서 실제로 발생한 비용이나 실패를 뜻하지 않습니다.">
             <a:extLst xmlns:a="http://schemas.openxmlformats.org/drawingml/2006/main">
               <a:ext uri="{FF2B5EF4-FFF2-40B4-BE49-F238E27FC236}">
-                <a16:creationId xmlns:a16="http://schemas.microsoft.com/office/drawing/2014/main" id="{3FDDB3BD-C34E-415E-831C-5A471362E0FB}"/>
+                <a16:creationId xmlns:a16="http://schemas.microsoft.com/office/drawing/2014/main" id="{7DEB3097-D1D6-4215-9D13-25B0C6F7D75E}"/>
               </a:ext>
             </a:extLst>
           </p:cNvPr>
@@ -10837,7 +10837,7 @@
           <p:cNvPr id="7" name="“CLI 결과가 기대와 다른데, 어디서부터 봐야 할까?”">
             <a:extLst xmlns:a="http://schemas.openxmlformats.org/drawingml/2006/main">
               <a:ext uri="{FF2B5EF4-FFF2-40B4-BE49-F238E27FC236}">
-                <a16:creationId xmlns:a16="http://schemas.microsoft.com/office/drawing/2014/main" id="{EA4344A5-99F5-4E85-A6A8-676B965B1BD2}"/>
+                <a16:creationId xmlns:a16="http://schemas.microsoft.com/office/drawing/2014/main" id="{B3EDA43F-4CC6-4CF3-8922-961C91359502}"/>
               </a:ext>
             </a:extLst>
           </p:cNvPr>
@@ -10995,7 +10995,7 @@
           <p:cNvPr id="8" name="">
             <a:extLst xmlns:a="http://schemas.openxmlformats.org/drawingml/2006/main">
               <a:ext uri="{FF2B5EF4-FFF2-40B4-BE49-F238E27FC236}">
-                <a16:creationId xmlns:a16="http://schemas.microsoft.com/office/drawing/2014/main" id="{77206CB0-CD58-43AD-BDFD-2D2A42875550}"/>
+                <a16:creationId xmlns:a16="http://schemas.microsoft.com/office/drawing/2014/main" id="{4C381C7E-110E-4F96-A6F7-1615A4D5B8C3}"/>
               </a:ext>
             </a:extLst>
           </p:cNvPr>
@@ -11028,7 +11028,7 @@
           <p:cNvPr id="9" name="CLI">
             <a:extLst xmlns:a="http://schemas.openxmlformats.org/drawingml/2006/main">
               <a:ext uri="{FF2B5EF4-FFF2-40B4-BE49-F238E27FC236}">
-                <a16:creationId xmlns:a16="http://schemas.microsoft.com/office/drawing/2014/main" id="{DB7D2555-52AF-4638-B261-F462AD112B6B}"/>
+                <a16:creationId xmlns:a16="http://schemas.microsoft.com/office/drawing/2014/main" id="{AE2B4DE8-2D4D-45C1-9EB1-F3C8C6318351}"/>
               </a:ext>
             </a:extLst>
           </p:cNvPr>
@@ -11186,7 +11186,7 @@
           <p:cNvPr id="10" name="입력은 어떻게 받나?">
             <a:extLst xmlns:a="http://schemas.openxmlformats.org/drawingml/2006/main">
               <a:ext uri="{FF2B5EF4-FFF2-40B4-BE49-F238E27FC236}">
-                <a16:creationId xmlns:a16="http://schemas.microsoft.com/office/drawing/2014/main" id="{ADE71B36-6CF6-4A11-B985-5C79C22FBB99}"/>
+                <a16:creationId xmlns:a16="http://schemas.microsoft.com/office/drawing/2014/main" id="{F2EB3C2F-3ED9-4815-9928-56598E1C87F2}"/>
               </a:ext>
             </a:extLst>
           </p:cNvPr>
@@ -11344,7 +11344,7 @@
           <p:cNvPr id="11" name="">
             <a:extLst xmlns:a="http://schemas.openxmlformats.org/drawingml/2006/main">
               <a:ext uri="{FF2B5EF4-FFF2-40B4-BE49-F238E27FC236}">
-                <a16:creationId xmlns:a16="http://schemas.microsoft.com/office/drawing/2014/main" id="{B1457122-1345-4CD9-B1A2-1C6C2B028BF5}"/>
+                <a16:creationId xmlns:a16="http://schemas.microsoft.com/office/drawing/2014/main" id="{DD165A6B-0CBE-40B2-A3CF-00C0C285173D}"/>
               </a:ext>
             </a:extLst>
           </p:cNvPr>
@@ -11374,7 +11374,7 @@
           <p:cNvPr id="12" name="">
             <a:extLst xmlns:a="http://schemas.openxmlformats.org/drawingml/2006/main">
               <a:ext uri="{FF2B5EF4-FFF2-40B4-BE49-F238E27FC236}">
-                <a16:creationId xmlns:a16="http://schemas.microsoft.com/office/drawing/2014/main" id="{9913B79C-D304-4197-83FA-AD1547916B7A}"/>
+                <a16:creationId xmlns:a16="http://schemas.microsoft.com/office/drawing/2014/main" id="{3D63E960-787B-4993-B5AB-C133C8CB6DE3}"/>
               </a:ext>
             </a:extLst>
           </p:cNvPr>
@@ -11407,7 +11407,7 @@
           <p:cNvPr id="13" name="처리 흐름">
             <a:extLst xmlns:a="http://schemas.openxmlformats.org/drawingml/2006/main">
               <a:ext uri="{FF2B5EF4-FFF2-40B4-BE49-F238E27FC236}">
-                <a16:creationId xmlns:a16="http://schemas.microsoft.com/office/drawing/2014/main" id="{D62CB819-F154-40A9-8156-61A5CEE082C9}"/>
+                <a16:creationId xmlns:a16="http://schemas.microsoft.com/office/drawing/2014/main" id="{CBD3D4F9-F692-42D1-BB9B-18ABC532F4DB}"/>
               </a:ext>
             </a:extLst>
           </p:cNvPr>
@@ -11565,7 +11565,7 @@
           <p:cNvPr id="14" name="어떤 연산을 호출하나?">
             <a:extLst xmlns:a="http://schemas.openxmlformats.org/drawingml/2006/main">
               <a:ext uri="{FF2B5EF4-FFF2-40B4-BE49-F238E27FC236}">
-                <a16:creationId xmlns:a16="http://schemas.microsoft.com/office/drawing/2014/main" id="{18BD5504-6A7B-4DCC-AFA3-FACE93CD5289}"/>
+                <a16:creationId xmlns:a16="http://schemas.microsoft.com/office/drawing/2014/main" id="{58B50DFE-C171-4EAA-9240-5CB7BA403ECE}"/>
               </a:ext>
             </a:extLst>
           </p:cNvPr>
@@ -11723,7 +11723,7 @@
           <p:cNvPr id="15" name="">
             <a:extLst xmlns:a="http://schemas.openxmlformats.org/drawingml/2006/main">
               <a:ext uri="{FF2B5EF4-FFF2-40B4-BE49-F238E27FC236}">
-                <a16:creationId xmlns:a16="http://schemas.microsoft.com/office/drawing/2014/main" id="{7DCDB5C6-A149-466B-96B3-E3F5B8EF3432}"/>
+                <a16:creationId xmlns:a16="http://schemas.microsoft.com/office/drawing/2014/main" id="{0F7F459F-01C0-4876-AA36-2EDAADC229CA}"/>
               </a:ext>
             </a:extLst>
           </p:cNvPr>
@@ -11753,7 +11753,7 @@
           <p:cNvPr id="16" name="">
             <a:extLst xmlns:a="http://schemas.openxmlformats.org/drawingml/2006/main">
               <a:ext uri="{FF2B5EF4-FFF2-40B4-BE49-F238E27FC236}">
-                <a16:creationId xmlns:a16="http://schemas.microsoft.com/office/drawing/2014/main" id="{534206B7-BA7C-4D17-A614-AFD30DD53452}"/>
+                <a16:creationId xmlns:a16="http://schemas.microsoft.com/office/drawing/2014/main" id="{2DB830D5-0934-4335-BD02-2BBABB1E27C9}"/>
               </a:ext>
             </a:extLst>
           </p:cNvPr>
@@ -11786,7 +11786,7 @@
           <p:cNvPr id="17" name="이미지 연산">
             <a:extLst xmlns:a="http://schemas.openxmlformats.org/drawingml/2006/main">
               <a:ext uri="{FF2B5EF4-FFF2-40B4-BE49-F238E27FC236}">
-                <a16:creationId xmlns:a16="http://schemas.microsoft.com/office/drawing/2014/main" id="{7827A661-AEDA-4B6E-8EEC-60093B3598D4}"/>
+                <a16:creationId xmlns:a16="http://schemas.microsoft.com/office/drawing/2014/main" id="{0A6C6DA3-5BBD-4D0E-A798-62F0384106A9}"/>
               </a:ext>
             </a:extLst>
           </p:cNvPr>
@@ -11944,7 +11944,7 @@
           <p:cNvPr id="18" name="구현은 어떻게 생겼나?">
             <a:extLst xmlns:a="http://schemas.openxmlformats.org/drawingml/2006/main">
               <a:ext uri="{FF2B5EF4-FFF2-40B4-BE49-F238E27FC236}">
-                <a16:creationId xmlns:a16="http://schemas.microsoft.com/office/drawing/2014/main" id="{49AF0C83-6214-473D-A60C-D406305B66A4}"/>
+                <a16:creationId xmlns:a16="http://schemas.microsoft.com/office/drawing/2014/main" id="{95E7D3E8-ED4C-4849-8E5A-47088D52C280}"/>
               </a:ext>
             </a:extLst>
           </p:cNvPr>
@@ -12102,7 +12102,7 @@
           <p:cNvPr id="19" name="">
             <a:extLst xmlns:a="http://schemas.openxmlformats.org/drawingml/2006/main">
               <a:ext uri="{FF2B5EF4-FFF2-40B4-BE49-F238E27FC236}">
-                <a16:creationId xmlns:a16="http://schemas.microsoft.com/office/drawing/2014/main" id="{D265AC1C-2138-4122-B60A-5CDF4B9BCA31}"/>
+                <a16:creationId xmlns:a16="http://schemas.microsoft.com/office/drawing/2014/main" id="{7782C34F-9AB7-4B8E-8D4A-CBF7A2345B82}"/>
               </a:ext>
             </a:extLst>
           </p:cNvPr>
@@ -12133,7 +12133,7 @@
           <p:cNvPr id="20" name="테스트">
             <a:extLst xmlns:a="http://schemas.openxmlformats.org/drawingml/2006/main">
               <a:ext uri="{FF2B5EF4-FFF2-40B4-BE49-F238E27FC236}">
-                <a16:creationId xmlns:a16="http://schemas.microsoft.com/office/drawing/2014/main" id="{D59A9E7F-3DC8-425A-85A1-C8C4E7813B01}"/>
+                <a16:creationId xmlns:a16="http://schemas.microsoft.com/office/drawing/2014/main" id="{934D07B6-4F69-424F-A939-04B3D6DD893B}"/>
               </a:ext>
             </a:extLst>
           </p:cNvPr>
@@ -12291,7 +12291,7 @@
           <p:cNvPr id="21" name="어떤 조건에서 실패했나?">
             <a:extLst xmlns:a="http://schemas.openxmlformats.org/drawingml/2006/main">
               <a:ext uri="{FF2B5EF4-FFF2-40B4-BE49-F238E27FC236}">
-                <a16:creationId xmlns:a16="http://schemas.microsoft.com/office/drawing/2014/main" id="{87ED4527-80D7-42C7-A5E5-85A4FC253052}"/>
+                <a16:creationId xmlns:a16="http://schemas.microsoft.com/office/drawing/2014/main" id="{5A3D9022-B80D-4BB4-86A8-8B2903D84FBB}"/>
               </a:ext>
             </a:extLst>
           </p:cNvPr>
@@ -12449,7 +12449,7 @@
           <p:cNvPr id="22" name="계약">
             <a:extLst xmlns:a="http://schemas.openxmlformats.org/drawingml/2006/main">
               <a:ext uri="{FF2B5EF4-FFF2-40B4-BE49-F238E27FC236}">
-                <a16:creationId xmlns:a16="http://schemas.microsoft.com/office/drawing/2014/main" id="{D11D6791-94A3-4933-A8DB-EA08A9A8D52B}"/>
+                <a16:creationId xmlns:a16="http://schemas.microsoft.com/office/drawing/2014/main" id="{EAF5AB63-9B7B-4E84-AA84-2BCDA14872F4}"/>
               </a:ext>
             </a:extLst>
           </p:cNvPr>
@@ -12607,7 +12607,7 @@
           <p:cNvPr id="23" name="원래 기대한 동작은?">
             <a:extLst xmlns:a="http://schemas.openxmlformats.org/drawingml/2006/main">
               <a:ext uri="{FF2B5EF4-FFF2-40B4-BE49-F238E27FC236}">
-                <a16:creationId xmlns:a16="http://schemas.microsoft.com/office/drawing/2014/main" id="{983FF6EF-DEF0-41D2-971A-A957C09D6E31}"/>
+                <a16:creationId xmlns:a16="http://schemas.microsoft.com/office/drawing/2014/main" id="{DA242F5F-855A-4097-A095-30B68471B7EF}"/>
               </a:ext>
             </a:extLst>
           </p:cNvPr>
@@ -12763,7 +12763,7 @@
     </p:spTree>
     <p:extLst>
       <p:ext uri="{BB962C8B-B14F-4D97-AF65-F5344CB8AC3E}">
-        <p14:creationId xmlns:p14="http://schemas.microsoft.com/office/powerpoint/2010/main" val="89141231"/>
+        <p14:creationId xmlns:p14="http://schemas.microsoft.com/office/powerpoint/2010/main" val="482290962"/>
       </p:ext>
     </p:extLst>
   </p:cSld>
@@ -12794,7 +12794,7 @@
           <p:cNvPr id="13" name="ACT 0 · Repository 조사 관찰">
             <a:extLst xmlns:a="http://schemas.openxmlformats.org/drawingml/2006/main">
               <a:ext uri="{FF2B5EF4-FFF2-40B4-BE49-F238E27FC236}">
-                <a16:creationId xmlns:a16="http://schemas.microsoft.com/office/drawing/2014/main" id="{755733BE-67C6-4C5B-AA5D-C5513FA5E7F5}"/>
+                <a16:creationId xmlns:a16="http://schemas.microsoft.com/office/drawing/2014/main" id="{870E97A9-6A78-4471-B1FF-2ADED3AD836E}"/>
               </a:ext>
             </a:extLst>
           </p:cNvPr>
@@ -12952,7 +12952,7 @@
           <p:cNvPr id="2" name="S04">
             <a:extLst xmlns:a="http://schemas.openxmlformats.org/drawingml/2006/main">
               <a:ext uri="{FF2B5EF4-FFF2-40B4-BE49-F238E27FC236}">
-                <a16:creationId xmlns:a16="http://schemas.microsoft.com/office/drawing/2014/main" id="{6DBB672B-7F0A-4791-A550-F33A88B55712}"/>
+                <a16:creationId xmlns:a16="http://schemas.microsoft.com/office/drawing/2014/main" id="{83CE539E-0BC0-4534-B11A-CF82D43DE9FF}"/>
               </a:ext>
             </a:extLst>
           </p:cNvPr>
@@ -13110,7 +13110,7 @@
           <p:cNvPr id="3" name="파일명을 주지 않으면 Agent는 어디부터 볼까?">
             <a:extLst xmlns:a="http://schemas.openxmlformats.org/drawingml/2006/main">
               <a:ext uri="{FF2B5EF4-FFF2-40B4-BE49-F238E27FC236}">
-                <a16:creationId xmlns:a16="http://schemas.microsoft.com/office/drawing/2014/main" id="{6033ECAE-D0CD-4DEC-8ED6-C287ABD7930D}"/>
+                <a16:creationId xmlns:a16="http://schemas.microsoft.com/office/drawing/2014/main" id="{BA7AC396-982B-4F91-90E7-DFC026798779}"/>
               </a:ext>
             </a:extLst>
           </p:cNvPr>
@@ -13268,7 +13268,7 @@
           <p:cNvPr id="4" name="">
             <a:extLst xmlns:a="http://schemas.openxmlformats.org/drawingml/2006/main">
               <a:ext uri="{FF2B5EF4-FFF2-40B4-BE49-F238E27FC236}">
-                <a16:creationId xmlns:a16="http://schemas.microsoft.com/office/drawing/2014/main" id="{775D51B3-6792-409B-A31C-2200DC374344}"/>
+                <a16:creationId xmlns:a16="http://schemas.microsoft.com/office/drawing/2014/main" id="{D6857545-9336-49B1-8216-2EFB585705AA}"/>
               </a:ext>
             </a:extLst>
           </p:cNvPr>
@@ -13299,7 +13299,7 @@
           <p:cNvPr id="5" name="TRIAL-001 실제 요청 발췌 · Codex CLI 0.154.0 · macOS · 읽기 전용">
             <a:extLst xmlns:a="http://schemas.openxmlformats.org/drawingml/2006/main">
               <a:ext uri="{FF2B5EF4-FFF2-40B4-BE49-F238E27FC236}">
-                <a16:creationId xmlns:a16="http://schemas.microsoft.com/office/drawing/2014/main" id="{CE88BD4D-92D0-4106-B95C-91801726B761}"/>
+                <a16:creationId xmlns:a16="http://schemas.microsoft.com/office/drawing/2014/main" id="{09294517-2C43-4042-954E-86F78C7028AC}"/>
               </a:ext>
             </a:extLst>
           </p:cNvPr>
@@ -13457,7 +13457,7 @@
           <p:cNvPr id="6" name="과거 단일 실행의 기록을 살펴봅니다. 현재 Desktop 동작은 미검증입니다.">
             <a:extLst xmlns:a="http://schemas.openxmlformats.org/drawingml/2006/main">
               <a:ext uri="{FF2B5EF4-FFF2-40B4-BE49-F238E27FC236}">
-                <a16:creationId xmlns:a16="http://schemas.microsoft.com/office/drawing/2014/main" id="{A03818A7-F4D7-40BD-ABC9-B4E72E0F1A69}"/>
+                <a16:creationId xmlns:a16="http://schemas.microsoft.com/office/drawing/2014/main" id="{3CED6BA1-E533-4104-A973-702A261D9206}"/>
               </a:ext>
             </a:extLst>
           </p:cNvPr>
@@ -13615,7 +13615,7 @@
           <p:cNvPr id="7" name="“현재 이 저장소에서 테스트 하나가 실패하고 있다.&#10;실패 원인을 조사해줘. 관련 구현과 호출 경로,&#10;실패하는">
             <a:extLst xmlns:a="http://schemas.openxmlformats.org/drawingml/2006/main">
               <a:ext uri="{FF2B5EF4-FFF2-40B4-BE49-F238E27FC236}">
-                <a16:creationId xmlns:a16="http://schemas.microsoft.com/office/drawing/2014/main" id="{41B86B5C-256B-4059-A045-DAC3EA287D8B}"/>
+                <a16:creationId xmlns:a16="http://schemas.microsoft.com/office/drawing/2014/main" id="{C0030077-35DC-43EC-8416-3914313C8CF4}"/>
               </a:ext>
             </a:extLst>
           </p:cNvPr>
@@ -13842,7 +13842,7 @@
           <p:cNvPr id="8" name="">
             <a:extLst xmlns:a="http://schemas.openxmlformats.org/drawingml/2006/main">
               <a:ext uri="{FF2B5EF4-FFF2-40B4-BE49-F238E27FC236}">
-                <a16:creationId xmlns:a16="http://schemas.microsoft.com/office/drawing/2014/main" id="{D6765482-B178-447D-A678-767AF9A351AA}"/>
+                <a16:creationId xmlns:a16="http://schemas.microsoft.com/office/drawing/2014/main" id="{CC8BED9E-11D6-479E-833A-E0EF9D8D1B7F}"/>
               </a:ext>
             </a:extLst>
           </p:cNvPr>
@@ -13873,7 +13873,7 @@
           <p:cNvPr id="9" name="찾았는지 확인할 세 가지">
             <a:extLst xmlns:a="http://schemas.openxmlformats.org/drawingml/2006/main">
               <a:ext uri="{FF2B5EF4-FFF2-40B4-BE49-F238E27FC236}">
-                <a16:creationId xmlns:a16="http://schemas.microsoft.com/office/drawing/2014/main" id="{A22D14D9-10BE-4E82-B288-B975C314E3E5}"/>
+                <a16:creationId xmlns:a16="http://schemas.microsoft.com/office/drawing/2014/main" id="{0FC283F8-73C6-451C-93D6-506327AF6FC5}"/>
               </a:ext>
             </a:extLst>
           </p:cNvPr>
@@ -14031,7 +14031,7 @@
           <p:cNvPr id="10" name="01  실패하는 테스트">
             <a:extLst xmlns:a="http://schemas.openxmlformats.org/drawingml/2006/main">
               <a:ext uri="{FF2B5EF4-FFF2-40B4-BE49-F238E27FC236}">
-                <a16:creationId xmlns:a16="http://schemas.microsoft.com/office/drawing/2014/main" id="{FBC26B72-87B3-418B-B0CA-A46302609F98}"/>
+                <a16:creationId xmlns:a16="http://schemas.microsoft.com/office/drawing/2014/main" id="{71936572-BB34-4ED8-989A-E5D57FD6446D}"/>
               </a:ext>
             </a:extLst>
           </p:cNvPr>
@@ -14189,7 +14189,7 @@
           <p:cNvPr id="11" name="02  관련 구현">
             <a:extLst xmlns:a="http://schemas.openxmlformats.org/drawingml/2006/main">
               <a:ext uri="{FF2B5EF4-FFF2-40B4-BE49-F238E27FC236}">
-                <a16:creationId xmlns:a16="http://schemas.microsoft.com/office/drawing/2014/main" id="{96A3F463-2D6F-43FA-8D4B-6662077C75D4}"/>
+                <a16:creationId xmlns:a16="http://schemas.microsoft.com/office/drawing/2014/main" id="{8499124B-9CD3-44B8-8B24-C28767814088}"/>
               </a:ext>
             </a:extLst>
           </p:cNvPr>
@@ -14347,7 +14347,7 @@
           <p:cNvPr id="12" name="03  제품의 호출 경로">
             <a:extLst xmlns:a="http://schemas.openxmlformats.org/drawingml/2006/main">
               <a:ext uri="{FF2B5EF4-FFF2-40B4-BE49-F238E27FC236}">
-                <a16:creationId xmlns:a16="http://schemas.microsoft.com/office/drawing/2014/main" id="{E6EAC86B-7868-4DE7-8BC1-14D5E0E3CC23}"/>
+                <a16:creationId xmlns:a16="http://schemas.microsoft.com/office/drawing/2014/main" id="{02D41078-7CBC-4858-AB59-7004CA088818}"/>
               </a:ext>
             </a:extLst>
           </p:cNvPr>
@@ -14503,7 +14503,7 @@
     </p:spTree>
     <p:extLst>
       <p:ext uri="{BB962C8B-B14F-4D97-AF65-F5344CB8AC3E}">
-        <p14:creationId xmlns:p14="http://schemas.microsoft.com/office/powerpoint/2010/main" val="521511032"/>
+        <p14:creationId xmlns:p14="http://schemas.microsoft.com/office/powerpoint/2010/main" val="1273137831"/>
       </p:ext>
     </p:extLst>
   </p:cSld>
@@ -14534,7 +14534,7 @@
           <p:cNvPr id="63" name="ACT 0  ·  Repository 탐색">
             <a:extLst xmlns:a="http://schemas.openxmlformats.org/drawingml/2006/main">
               <a:ext uri="{FF2B5EF4-FFF2-40B4-BE49-F238E27FC236}">
-                <a16:creationId xmlns:a16="http://schemas.microsoft.com/office/drawing/2014/main" id="{9FACE76E-7B57-42F9-89BD-6C522FD6100D}"/>
+                <a16:creationId xmlns:a16="http://schemas.microsoft.com/office/drawing/2014/main" id="{8518F184-3E73-43DA-88BD-143CF3885CAC}"/>
               </a:ext>
             </a:extLst>
           </p:cNvPr>
@@ -14692,7 +14692,7 @@
           <p:cNvPr id="2" name="S05">
             <a:extLst xmlns:a="http://schemas.openxmlformats.org/drawingml/2006/main">
               <a:ext uri="{FF2B5EF4-FFF2-40B4-BE49-F238E27FC236}">
-                <a16:creationId xmlns:a16="http://schemas.microsoft.com/office/drawing/2014/main" id="{A4ADC61D-9B13-43CE-839E-C91861CF9DE9}"/>
+                <a16:creationId xmlns:a16="http://schemas.microsoft.com/office/drawing/2014/main" id="{5DCCF0F2-4CD9-4B37-8D91-7D661579346A}"/>
               </a:ext>
             </a:extLst>
           </p:cNvPr>
@@ -14850,7 +14850,7 @@
           <p:cNvPr id="3" name="Agent가 Test와 호출 경로를 찾았다">
             <a:extLst xmlns:a="http://schemas.openxmlformats.org/drawingml/2006/main">
               <a:ext uri="{FF2B5EF4-FFF2-40B4-BE49-F238E27FC236}">
-                <a16:creationId xmlns:a16="http://schemas.microsoft.com/office/drawing/2014/main" id="{C1A174EE-8155-49DB-AB65-339C1131C6A4}"/>
+                <a16:creationId xmlns:a16="http://schemas.microsoft.com/office/drawing/2014/main" id="{A011AC77-0E82-4CE1-A15A-4D14E261FF25}"/>
               </a:ext>
             </a:extLst>
           </p:cNvPr>
@@ -15008,7 +15008,7 @@
           <p:cNvPr id="4" name="">
             <a:extLst xmlns:a="http://schemas.openxmlformats.org/drawingml/2006/main">
               <a:ext uri="{FF2B5EF4-FFF2-40B4-BE49-F238E27FC236}">
-                <a16:creationId xmlns:a16="http://schemas.microsoft.com/office/drawing/2014/main" id="{E04062D7-24FB-4251-81E4-F68194945901}"/>
+                <a16:creationId xmlns:a16="http://schemas.microsoft.com/office/drawing/2014/main" id="{053CCAAD-E6D9-46E3-8A8A-0238D746A431}"/>
               </a:ext>
             </a:extLst>
           </p:cNvPr>
@@ -15039,7 +15039,7 @@
           <p:cNvPr id="5" name="TRIAL-001 기록·STATE-00 테스트 재구성  |  Codex CLI 0.154.0 · 읽기 전용">
             <a:extLst xmlns:a="http://schemas.openxmlformats.org/drawingml/2006/main">
               <a:ext uri="{FF2B5EF4-FFF2-40B4-BE49-F238E27FC236}">
-                <a16:creationId xmlns:a16="http://schemas.microsoft.com/office/drawing/2014/main" id="{4409C441-D49C-4510-9DA9-05886094005E}"/>
+                <a16:creationId xmlns:a16="http://schemas.microsoft.com/office/drawing/2014/main" id="{8909BD09-9120-4284-8BB0-318E9F80FBAF}"/>
               </a:ext>
             </a:extLst>
           </p:cNvPr>
@@ -15197,7 +15197,7 @@
           <p:cNvPr id="6" name="실제 실행 화면이 아님 · 이 조사에서는 코드 수정 없음 · 현재 Desktop 동작 미검증">
             <a:extLst xmlns:a="http://schemas.openxmlformats.org/drawingml/2006/main">
               <a:ext uri="{FF2B5EF4-FFF2-40B4-BE49-F238E27FC236}">
-                <a16:creationId xmlns:a16="http://schemas.microsoft.com/office/drawing/2014/main" id="{ACEC5FC5-A2AA-474B-953F-F1C59433737E}"/>
+                <a16:creationId xmlns:a16="http://schemas.microsoft.com/office/drawing/2014/main" id="{736FAF93-8F1F-4383-8E24-BD9708564BDD}"/>
               </a:ext>
             </a:extLst>
           </p:cNvPr>
@@ -15355,7 +15355,7 @@
           <p:cNvPr id="7" name="crop(image, 1, 3)">
             <a:extLst xmlns:a="http://schemas.openxmlformats.org/drawingml/2006/main">
               <a:ext uri="{FF2B5EF4-FFF2-40B4-BE49-F238E27FC236}">
-                <a16:creationId xmlns:a16="http://schemas.microsoft.com/office/drawing/2014/main" id="{460EBF11-4378-4EB8-9084-AAF06E69895B}"/>
+                <a16:creationId xmlns:a16="http://schemas.microsoft.com/office/drawing/2014/main" id="{88D63B04-C9FF-43ED-A023-6370965471FE}"/>
               </a:ext>
             </a:extLst>
           </p:cNvPr>
@@ -15513,7 +15513,7 @@
           <p:cNvPr id="8" name="끝 좌표 3은 포함하지 않는 계약">
             <a:extLst xmlns:a="http://schemas.openxmlformats.org/drawingml/2006/main">
               <a:ext uri="{FF2B5EF4-FFF2-40B4-BE49-F238E27FC236}">
-                <a16:creationId xmlns:a16="http://schemas.microsoft.com/office/drawing/2014/main" id="{A1156D34-1BDA-444A-A3A3-AC113F0D493F}"/>
+                <a16:creationId xmlns:a16="http://schemas.microsoft.com/office/drawing/2014/main" id="{2D677F69-3CAC-48E8-A486-D261FFDB1E76}"/>
               </a:ext>
             </a:extLst>
           </p:cNvPr>
@@ -15671,7 +15671,7 @@
           <p:cNvPr id="9" name="입력">
             <a:extLst xmlns:a="http://schemas.openxmlformats.org/drawingml/2006/main">
               <a:ext uri="{FF2B5EF4-FFF2-40B4-BE49-F238E27FC236}">
-                <a16:creationId xmlns:a16="http://schemas.microsoft.com/office/drawing/2014/main" id="{A847EADF-1CA8-4198-8FAA-AE4A51D01B11}"/>
+                <a16:creationId xmlns:a16="http://schemas.microsoft.com/office/drawing/2014/main" id="{0B41E804-D694-4B0E-86E7-BFC516A096B7}"/>
               </a:ext>
             </a:extLst>
           </p:cNvPr>
@@ -15829,7 +15829,7 @@
           <p:cNvPr id="10" name="0">
             <a:extLst xmlns:a="http://schemas.openxmlformats.org/drawingml/2006/main">
               <a:ext uri="{FF2B5EF4-FFF2-40B4-BE49-F238E27FC236}">
-                <a16:creationId xmlns:a16="http://schemas.microsoft.com/office/drawing/2014/main" id="{B593020C-1C4D-4040-8FEF-64ACD8C6C02D}"/>
+                <a16:creationId xmlns:a16="http://schemas.microsoft.com/office/drawing/2014/main" id="{D53B8266-F181-4DFA-A396-B90925895EF2}"/>
               </a:ext>
             </a:extLst>
           </p:cNvPr>
@@ -15987,7 +15987,7 @@
           <p:cNvPr id="11" name="1">
             <a:extLst xmlns:a="http://schemas.openxmlformats.org/drawingml/2006/main">
               <a:ext uri="{FF2B5EF4-FFF2-40B4-BE49-F238E27FC236}">
-                <a16:creationId xmlns:a16="http://schemas.microsoft.com/office/drawing/2014/main" id="{A43CF62C-9078-49E4-9B85-B726B81A63EF}"/>
+                <a16:creationId xmlns:a16="http://schemas.microsoft.com/office/drawing/2014/main" id="{507702EC-5944-421C-BDB8-E2776D6C7909}"/>
               </a:ext>
             </a:extLst>
           </p:cNvPr>
@@ -16145,7 +16145,7 @@
           <p:cNvPr id="12" name="2">
             <a:extLst xmlns:a="http://schemas.openxmlformats.org/drawingml/2006/main">
               <a:ext uri="{FF2B5EF4-FFF2-40B4-BE49-F238E27FC236}">
-                <a16:creationId xmlns:a16="http://schemas.microsoft.com/office/drawing/2014/main" id="{A083641A-B939-42CE-8454-F91580B0269C}"/>
+                <a16:creationId xmlns:a16="http://schemas.microsoft.com/office/drawing/2014/main" id="{BD907127-30BF-410A-B4B2-6E8953470AAF}"/>
               </a:ext>
             </a:extLst>
           </p:cNvPr>
@@ -16303,7 +16303,7 @@
           <p:cNvPr id="13" name="3">
             <a:extLst xmlns:a="http://schemas.openxmlformats.org/drawingml/2006/main">
               <a:ext uri="{FF2B5EF4-FFF2-40B4-BE49-F238E27FC236}">
-                <a16:creationId xmlns:a16="http://schemas.microsoft.com/office/drawing/2014/main" id="{6CA58E3A-FF63-402E-9D9E-2A81B33C7019}"/>
+                <a16:creationId xmlns:a16="http://schemas.microsoft.com/office/drawing/2014/main" id="{D6B6F232-6B81-467D-ACE8-8AE17EBF32DE}"/>
               </a:ext>
             </a:extLst>
           </p:cNvPr>
@@ -16461,7 +16461,7 @@
           <p:cNvPr id="14" name="">
             <a:extLst xmlns:a="http://schemas.openxmlformats.org/drawingml/2006/main">
               <a:ext uri="{FF2B5EF4-FFF2-40B4-BE49-F238E27FC236}">
-                <a16:creationId xmlns:a16="http://schemas.microsoft.com/office/drawing/2014/main" id="{0D4E60B3-3B39-4190-960B-2B321D2CAA05}"/>
+                <a16:creationId xmlns:a16="http://schemas.microsoft.com/office/drawing/2014/main" id="{887C240B-E5BD-4E5F-8F73-426ED04D8302}"/>
               </a:ext>
             </a:extLst>
           </p:cNvPr>
@@ -16494,7 +16494,7 @@
           <p:cNvPr id="15" name="1">
             <a:extLst xmlns:a="http://schemas.openxmlformats.org/drawingml/2006/main">
               <a:ext uri="{FF2B5EF4-FFF2-40B4-BE49-F238E27FC236}">
-                <a16:creationId xmlns:a16="http://schemas.microsoft.com/office/drawing/2014/main" id="{10D29338-878B-4488-9B92-81152174B1BA}"/>
+                <a16:creationId xmlns:a16="http://schemas.microsoft.com/office/drawing/2014/main" id="{C4CDABD1-70F5-4F8D-B15E-252732857E29}"/>
               </a:ext>
             </a:extLst>
           </p:cNvPr>
@@ -16652,7 +16652,7 @@
           <p:cNvPr id="16" name="">
             <a:extLst xmlns:a="http://schemas.openxmlformats.org/drawingml/2006/main">
               <a:ext uri="{FF2B5EF4-FFF2-40B4-BE49-F238E27FC236}">
-                <a16:creationId xmlns:a16="http://schemas.microsoft.com/office/drawing/2014/main" id="{BAE9A808-3681-4D31-B00D-66A9A5E54B2E}"/>
+                <a16:creationId xmlns:a16="http://schemas.microsoft.com/office/drawing/2014/main" id="{E9853536-03AF-421D-9175-8D9B03014043}"/>
               </a:ext>
             </a:extLst>
           </p:cNvPr>
@@ -16685,7 +16685,7 @@
           <p:cNvPr id="17" name="2">
             <a:extLst xmlns:a="http://schemas.openxmlformats.org/drawingml/2006/main">
               <a:ext uri="{FF2B5EF4-FFF2-40B4-BE49-F238E27FC236}">
-                <a16:creationId xmlns:a16="http://schemas.microsoft.com/office/drawing/2014/main" id="{402F948E-8273-4564-9DAB-0BB4A27F4A8C}"/>
+                <a16:creationId xmlns:a16="http://schemas.microsoft.com/office/drawing/2014/main" id="{C56C962D-F0ED-4A2C-9CBB-5AC8080171B6}"/>
               </a:ext>
             </a:extLst>
           </p:cNvPr>
@@ -16843,7 +16843,7 @@
           <p:cNvPr id="18" name="">
             <a:extLst xmlns:a="http://schemas.openxmlformats.org/drawingml/2006/main">
               <a:ext uri="{FF2B5EF4-FFF2-40B4-BE49-F238E27FC236}">
-                <a16:creationId xmlns:a16="http://schemas.microsoft.com/office/drawing/2014/main" id="{ADF1CE69-4209-4306-AC91-DD8A6BC411A0}"/>
+                <a16:creationId xmlns:a16="http://schemas.microsoft.com/office/drawing/2014/main" id="{AF01D817-2B67-48CD-BC99-655B56BBC24D}"/>
               </a:ext>
             </a:extLst>
           </p:cNvPr>
@@ -16876,7 +16876,7 @@
           <p:cNvPr id="19" name="3">
             <a:extLst xmlns:a="http://schemas.openxmlformats.org/drawingml/2006/main">
               <a:ext uri="{FF2B5EF4-FFF2-40B4-BE49-F238E27FC236}">
-                <a16:creationId xmlns:a16="http://schemas.microsoft.com/office/drawing/2014/main" id="{145C15FA-7578-4E2B-8651-468463F33A93}"/>
+                <a16:creationId xmlns:a16="http://schemas.microsoft.com/office/drawing/2014/main" id="{6F1472AA-1F5A-4775-A0B1-31A5B838AB7D}"/>
               </a:ext>
             </a:extLst>
           </p:cNvPr>
@@ -17034,7 +17034,7 @@
           <p:cNvPr id="20" name="">
             <a:extLst xmlns:a="http://schemas.openxmlformats.org/drawingml/2006/main">
               <a:ext uri="{FF2B5EF4-FFF2-40B4-BE49-F238E27FC236}">
-                <a16:creationId xmlns:a16="http://schemas.microsoft.com/office/drawing/2014/main" id="{F863ABEF-44D0-4588-A9B5-A986EBDEFCE9}"/>
+                <a16:creationId xmlns:a16="http://schemas.microsoft.com/office/drawing/2014/main" id="{980EDBBC-4B84-45E0-8197-C1D77A240A56}"/>
               </a:ext>
             </a:extLst>
           </p:cNvPr>
@@ -17067,7 +17067,7 @@
           <p:cNvPr id="21" name="4">
             <a:extLst xmlns:a="http://schemas.openxmlformats.org/drawingml/2006/main">
               <a:ext uri="{FF2B5EF4-FFF2-40B4-BE49-F238E27FC236}">
-                <a16:creationId xmlns:a16="http://schemas.microsoft.com/office/drawing/2014/main" id="{6F08BF28-9AAA-474C-9EBE-50EEA8F69323}"/>
+                <a16:creationId xmlns:a16="http://schemas.microsoft.com/office/drawing/2014/main" id="{9EAC9726-E74B-4DD6-A8C7-181EC88A7782}"/>
               </a:ext>
             </a:extLst>
           </p:cNvPr>
@@ -17225,7 +17225,7 @@
           <p:cNvPr id="22" name="">
             <a:extLst xmlns:a="http://schemas.openxmlformats.org/drawingml/2006/main">
               <a:ext uri="{FF2B5EF4-FFF2-40B4-BE49-F238E27FC236}">
-                <a16:creationId xmlns:a16="http://schemas.microsoft.com/office/drawing/2014/main" id="{9601A62E-F1B6-479F-B489-79DAE63734E9}"/>
+                <a16:creationId xmlns:a16="http://schemas.microsoft.com/office/drawing/2014/main" id="{6CBA4ECA-7CBC-4AA0-9A37-A86F169B1733}"/>
               </a:ext>
             </a:extLst>
           </p:cNvPr>
@@ -17258,7 +17258,7 @@
           <p:cNvPr id="23" name="5">
             <a:extLst xmlns:a="http://schemas.openxmlformats.org/drawingml/2006/main">
               <a:ext uri="{FF2B5EF4-FFF2-40B4-BE49-F238E27FC236}">
-                <a16:creationId xmlns:a16="http://schemas.microsoft.com/office/drawing/2014/main" id="{80067ED4-B72D-4110-86CE-BC676D0773E0}"/>
+                <a16:creationId xmlns:a16="http://schemas.microsoft.com/office/drawing/2014/main" id="{09A51057-F701-4ED1-B2BE-7A129845B9E6}"/>
               </a:ext>
             </a:extLst>
           </p:cNvPr>
@@ -17416,7 +17416,7 @@
           <p:cNvPr id="24" name="">
             <a:extLst xmlns:a="http://schemas.openxmlformats.org/drawingml/2006/main">
               <a:ext uri="{FF2B5EF4-FFF2-40B4-BE49-F238E27FC236}">
-                <a16:creationId xmlns:a16="http://schemas.microsoft.com/office/drawing/2014/main" id="{1B619C0C-4191-4390-A792-1EFC7F34BDA2}"/>
+                <a16:creationId xmlns:a16="http://schemas.microsoft.com/office/drawing/2014/main" id="{9811364F-E849-4DFC-8A9E-264B96839C02}"/>
               </a:ext>
             </a:extLst>
           </p:cNvPr>
@@ -17449,7 +17449,7 @@
           <p:cNvPr id="25" name="6">
             <a:extLst xmlns:a="http://schemas.openxmlformats.org/drawingml/2006/main">
               <a:ext uri="{FF2B5EF4-FFF2-40B4-BE49-F238E27FC236}">
-                <a16:creationId xmlns:a16="http://schemas.microsoft.com/office/drawing/2014/main" id="{4247990D-8CE6-4D4A-B92E-5612CF4A43FC}"/>
+                <a16:creationId xmlns:a16="http://schemas.microsoft.com/office/drawing/2014/main" id="{D120C28E-B3EB-4291-9D16-2C99067243F5}"/>
               </a:ext>
             </a:extLst>
           </p:cNvPr>
@@ -17607,7 +17607,7 @@
           <p:cNvPr id="26" name="">
             <a:extLst xmlns:a="http://schemas.openxmlformats.org/drawingml/2006/main">
               <a:ext uri="{FF2B5EF4-FFF2-40B4-BE49-F238E27FC236}">
-                <a16:creationId xmlns:a16="http://schemas.microsoft.com/office/drawing/2014/main" id="{CA1180B8-9809-48AC-955F-CE112D86504B}"/>
+                <a16:creationId xmlns:a16="http://schemas.microsoft.com/office/drawing/2014/main" id="{65A69F10-9287-41B5-8306-9361E506ACA5}"/>
               </a:ext>
             </a:extLst>
           </p:cNvPr>
@@ -17640,7 +17640,7 @@
           <p:cNvPr id="27" name="7">
             <a:extLst xmlns:a="http://schemas.openxmlformats.org/drawingml/2006/main">
               <a:ext uri="{FF2B5EF4-FFF2-40B4-BE49-F238E27FC236}">
-                <a16:creationId xmlns:a16="http://schemas.microsoft.com/office/drawing/2014/main" id="{99A01CED-B880-4A5B-933F-5B6071B40364}"/>
+                <a16:creationId xmlns:a16="http://schemas.microsoft.com/office/drawing/2014/main" id="{1338A769-7105-46C1-9792-8AA5E8D9144B}"/>
               </a:ext>
             </a:extLst>
           </p:cNvPr>
@@ -17798,7 +17798,7 @@
           <p:cNvPr id="28" name="">
             <a:extLst xmlns:a="http://schemas.openxmlformats.org/drawingml/2006/main">
               <a:ext uri="{FF2B5EF4-FFF2-40B4-BE49-F238E27FC236}">
-                <a16:creationId xmlns:a16="http://schemas.microsoft.com/office/drawing/2014/main" id="{EC2E324F-FC10-4C70-A2B5-8CA9F7144DD0}"/>
+                <a16:creationId xmlns:a16="http://schemas.microsoft.com/office/drawing/2014/main" id="{F924E3FE-4227-4995-B94A-1A4407E4C673}"/>
               </a:ext>
             </a:extLst>
           </p:cNvPr>
@@ -17831,7 +17831,7 @@
           <p:cNvPr id="29" name="8">
             <a:extLst xmlns:a="http://schemas.openxmlformats.org/drawingml/2006/main">
               <a:ext uri="{FF2B5EF4-FFF2-40B4-BE49-F238E27FC236}">
-                <a16:creationId xmlns:a16="http://schemas.microsoft.com/office/drawing/2014/main" id="{0D56F148-3DA4-4C0A-979B-FD75545FBF55}"/>
+                <a16:creationId xmlns:a16="http://schemas.microsoft.com/office/drawing/2014/main" id="{D494C8EC-9321-45F9-AFDD-354C3428D4BA}"/>
               </a:ext>
             </a:extLst>
           </p:cNvPr>
@@ -17989,7 +17989,7 @@
           <p:cNvPr id="30" name="열 index">
             <a:extLst xmlns:a="http://schemas.openxmlformats.org/drawingml/2006/main">
               <a:ext uri="{FF2B5EF4-FFF2-40B4-BE49-F238E27FC236}">
-                <a16:creationId xmlns:a16="http://schemas.microsoft.com/office/drawing/2014/main" id="{8E10F026-F97E-49EC-9A75-67B83DE237E9}"/>
+                <a16:creationId xmlns:a16="http://schemas.microsoft.com/office/drawing/2014/main" id="{C10D3F5A-178D-431D-A326-C73D0835FC37}"/>
               </a:ext>
             </a:extLst>
           </p:cNvPr>
@@ -18147,7 +18147,7 @@
           <p:cNvPr id="31" name="기대">
             <a:extLst xmlns:a="http://schemas.openxmlformats.org/drawingml/2006/main">
               <a:ext uri="{FF2B5EF4-FFF2-40B4-BE49-F238E27FC236}">
-                <a16:creationId xmlns:a16="http://schemas.microsoft.com/office/drawing/2014/main" id="{E3ECAAFD-5C30-4047-BB27-240CC90C9743}"/>
+                <a16:creationId xmlns:a16="http://schemas.microsoft.com/office/drawing/2014/main" id="{FAA145FD-57DF-4F69-AD0B-3170054C5CD2}"/>
               </a:ext>
             </a:extLst>
           </p:cNvPr>
@@ -18305,7 +18305,7 @@
           <p:cNvPr id="32" name="">
             <a:extLst xmlns:a="http://schemas.openxmlformats.org/drawingml/2006/main">
               <a:ext uri="{FF2B5EF4-FFF2-40B4-BE49-F238E27FC236}">
-                <a16:creationId xmlns:a16="http://schemas.microsoft.com/office/drawing/2014/main" id="{629A9BFA-B1B4-4FDC-BF58-3B9CC4DBE66A}"/>
+                <a16:creationId xmlns:a16="http://schemas.microsoft.com/office/drawing/2014/main" id="{05C8A3D9-A103-4DE3-AB48-32F77364B67B}"/>
               </a:ext>
             </a:extLst>
           </p:cNvPr>
@@ -18338,7 +18338,7 @@
           <p:cNvPr id="33" name="2">
             <a:extLst xmlns:a="http://schemas.openxmlformats.org/drawingml/2006/main">
               <a:ext uri="{FF2B5EF4-FFF2-40B4-BE49-F238E27FC236}">
-                <a16:creationId xmlns:a16="http://schemas.microsoft.com/office/drawing/2014/main" id="{7C322986-1E95-4AF2-9FF1-4A0498338B55}"/>
+                <a16:creationId xmlns:a16="http://schemas.microsoft.com/office/drawing/2014/main" id="{D8F04A78-9CB8-4E73-BF07-EB8555166235}"/>
               </a:ext>
             </a:extLst>
           </p:cNvPr>
@@ -18496,7 +18496,7 @@
           <p:cNvPr id="34" name="">
             <a:extLst xmlns:a="http://schemas.openxmlformats.org/drawingml/2006/main">
               <a:ext uri="{FF2B5EF4-FFF2-40B4-BE49-F238E27FC236}">
-                <a16:creationId xmlns:a16="http://schemas.microsoft.com/office/drawing/2014/main" id="{7595719E-865C-4A39-9BE2-2ABC1A9F1CB8}"/>
+                <a16:creationId xmlns:a16="http://schemas.microsoft.com/office/drawing/2014/main" id="{01F9C932-CF4C-4405-8B76-236B6260F7B0}"/>
               </a:ext>
             </a:extLst>
           </p:cNvPr>
@@ -18529,7 +18529,7 @@
           <p:cNvPr id="35" name="3">
             <a:extLst xmlns:a="http://schemas.openxmlformats.org/drawingml/2006/main">
               <a:ext uri="{FF2B5EF4-FFF2-40B4-BE49-F238E27FC236}">
-                <a16:creationId xmlns:a16="http://schemas.microsoft.com/office/drawing/2014/main" id="{4D33C8E2-AE6B-444A-A8BA-5463A5E37BA5}"/>
+                <a16:creationId xmlns:a16="http://schemas.microsoft.com/office/drawing/2014/main" id="{53C04F83-C59E-42CE-A15F-6F7D9C7837FE}"/>
               </a:ext>
             </a:extLst>
           </p:cNvPr>
@@ -18687,7 +18687,7 @@
           <p:cNvPr id="36" name="">
             <a:extLst xmlns:a="http://schemas.openxmlformats.org/drawingml/2006/main">
               <a:ext uri="{FF2B5EF4-FFF2-40B4-BE49-F238E27FC236}">
-                <a16:creationId xmlns:a16="http://schemas.microsoft.com/office/drawing/2014/main" id="{EA497666-C54E-4AC5-A04E-26AC7D119433}"/>
+                <a16:creationId xmlns:a16="http://schemas.microsoft.com/office/drawing/2014/main" id="{E50278CC-5072-4236-8CC3-0DA27DF1EBF8}"/>
               </a:ext>
             </a:extLst>
           </p:cNvPr>
@@ -18720,7 +18720,7 @@
           <p:cNvPr id="37" name="6">
             <a:extLst xmlns:a="http://schemas.openxmlformats.org/drawingml/2006/main">
               <a:ext uri="{FF2B5EF4-FFF2-40B4-BE49-F238E27FC236}">
-                <a16:creationId xmlns:a16="http://schemas.microsoft.com/office/drawing/2014/main" id="{7E5A69C0-1DA9-4055-968C-D5CFD462AC84}"/>
+                <a16:creationId xmlns:a16="http://schemas.microsoft.com/office/drawing/2014/main" id="{B340A21E-B368-49A0-9A7E-9E198DF61667}"/>
               </a:ext>
             </a:extLst>
           </p:cNvPr>
@@ -18878,7 +18878,7 @@
           <p:cNvPr id="38" name="">
             <a:extLst xmlns:a="http://schemas.openxmlformats.org/drawingml/2006/main">
               <a:ext uri="{FF2B5EF4-FFF2-40B4-BE49-F238E27FC236}">
-                <a16:creationId xmlns:a16="http://schemas.microsoft.com/office/drawing/2014/main" id="{AE9FBB0B-45F7-4F82-B531-E93A5A10710B}"/>
+                <a16:creationId xmlns:a16="http://schemas.microsoft.com/office/drawing/2014/main" id="{8F42283F-50A1-4B2A-AE41-95321A9ABCCE}"/>
               </a:ext>
             </a:extLst>
           </p:cNvPr>
@@ -18911,7 +18911,7 @@
           <p:cNvPr id="39" name="7">
             <a:extLst xmlns:a="http://schemas.openxmlformats.org/drawingml/2006/main">
               <a:ext uri="{FF2B5EF4-FFF2-40B4-BE49-F238E27FC236}">
-                <a16:creationId xmlns:a16="http://schemas.microsoft.com/office/drawing/2014/main" id="{0EFCF640-43E0-4067-8750-D45D5B4B13FD}"/>
+                <a16:creationId xmlns:a16="http://schemas.microsoft.com/office/drawing/2014/main" id="{D640C229-6D45-4D19-A3B6-A8868A072AF7}"/>
               </a:ext>
             </a:extLst>
           </p:cNvPr>
@@ -19069,7 +19069,7 @@
           <p:cNvPr id="40" name="구현 결과">
             <a:extLst xmlns:a="http://schemas.openxmlformats.org/drawingml/2006/main">
               <a:ext uri="{FF2B5EF4-FFF2-40B4-BE49-F238E27FC236}">
-                <a16:creationId xmlns:a16="http://schemas.microsoft.com/office/drawing/2014/main" id="{E0B60AB8-BF6E-46E9-99D1-B3EFC57BED6B}"/>
+                <a16:creationId xmlns:a16="http://schemas.microsoft.com/office/drawing/2014/main" id="{B1160814-1D9F-428A-973B-F39C07F19A3D}"/>
               </a:ext>
             </a:extLst>
           </p:cNvPr>
@@ -19227,7 +19227,7 @@
           <p:cNvPr id="41" name="">
             <a:extLst xmlns:a="http://schemas.openxmlformats.org/drawingml/2006/main">
               <a:ext uri="{FF2B5EF4-FFF2-40B4-BE49-F238E27FC236}">
-                <a16:creationId xmlns:a16="http://schemas.microsoft.com/office/drawing/2014/main" id="{C1810931-58CD-4435-8102-9BCA40A57FC3}"/>
+                <a16:creationId xmlns:a16="http://schemas.microsoft.com/office/drawing/2014/main" id="{F40404C2-8686-4AC4-96DD-088314B1138F}"/>
               </a:ext>
             </a:extLst>
           </p:cNvPr>
@@ -19260,7 +19260,7 @@
           <p:cNvPr id="42" name="2">
             <a:extLst xmlns:a="http://schemas.openxmlformats.org/drawingml/2006/main">
               <a:ext uri="{FF2B5EF4-FFF2-40B4-BE49-F238E27FC236}">
-                <a16:creationId xmlns:a16="http://schemas.microsoft.com/office/drawing/2014/main" id="{C912A7CA-B71F-4042-82F8-CFF6CDD872D0}"/>
+                <a16:creationId xmlns:a16="http://schemas.microsoft.com/office/drawing/2014/main" id="{933262DC-D8D7-4AE8-8CDF-0A7A6037337C}"/>
               </a:ext>
             </a:extLst>
           </p:cNvPr>
@@ -19418,7 +19418,7 @@
           <p:cNvPr id="43" name="">
             <a:extLst xmlns:a="http://schemas.openxmlformats.org/drawingml/2006/main">
               <a:ext uri="{FF2B5EF4-FFF2-40B4-BE49-F238E27FC236}">
-                <a16:creationId xmlns:a16="http://schemas.microsoft.com/office/drawing/2014/main" id="{7B59658B-D809-4A04-89B2-6CB83DAC7E8D}"/>
+                <a16:creationId xmlns:a16="http://schemas.microsoft.com/office/drawing/2014/main" id="{116C401B-937F-4584-9175-B39A65946217}"/>
               </a:ext>
             </a:extLst>
           </p:cNvPr>
@@ -19451,7 +19451,7 @@
           <p:cNvPr id="44" name="3">
             <a:extLst xmlns:a="http://schemas.openxmlformats.org/drawingml/2006/main">
               <a:ext uri="{FF2B5EF4-FFF2-40B4-BE49-F238E27FC236}">
-                <a16:creationId xmlns:a16="http://schemas.microsoft.com/office/drawing/2014/main" id="{0CAE9F55-BB2B-465C-84F2-1973AD9F4BE1}"/>
+                <a16:creationId xmlns:a16="http://schemas.microsoft.com/office/drawing/2014/main" id="{9A276D30-D3EC-4611-8EA0-9A56AF98924F}"/>
               </a:ext>
             </a:extLst>
           </p:cNvPr>
@@ -19609,7 +19609,7 @@
           <p:cNvPr id="45" name="">
             <a:extLst xmlns:a="http://schemas.openxmlformats.org/drawingml/2006/main">
               <a:ext uri="{FF2B5EF4-FFF2-40B4-BE49-F238E27FC236}">
-                <a16:creationId xmlns:a16="http://schemas.microsoft.com/office/drawing/2014/main" id="{CD124092-80B3-4781-87BB-A469A378DC06}"/>
+                <a16:creationId xmlns:a16="http://schemas.microsoft.com/office/drawing/2014/main" id="{45690614-BF26-4F43-BF6F-7FCE5CBF93FE}"/>
               </a:ext>
             </a:extLst>
           </p:cNvPr>
@@ -19642,7 +19642,7 @@
           <p:cNvPr id="46" name="4">
             <a:extLst xmlns:a="http://schemas.openxmlformats.org/drawingml/2006/main">
               <a:ext uri="{FF2B5EF4-FFF2-40B4-BE49-F238E27FC236}">
-                <a16:creationId xmlns:a16="http://schemas.microsoft.com/office/drawing/2014/main" id="{91D093EA-7D43-4C64-BF26-57A808D92C34}"/>
+                <a16:creationId xmlns:a16="http://schemas.microsoft.com/office/drawing/2014/main" id="{6C24387B-EA59-4B0B-9903-2EC01CCA5040}"/>
               </a:ext>
             </a:extLst>
           </p:cNvPr>
@@ -19800,7 +19800,7 @@
           <p:cNvPr id="47" name="">
             <a:extLst xmlns:a="http://schemas.openxmlformats.org/drawingml/2006/main">
               <a:ext uri="{FF2B5EF4-FFF2-40B4-BE49-F238E27FC236}">
-                <a16:creationId xmlns:a16="http://schemas.microsoft.com/office/drawing/2014/main" id="{8A88E31C-1A7B-4065-9CE6-BB6EE99F034D}"/>
+                <a16:creationId xmlns:a16="http://schemas.microsoft.com/office/drawing/2014/main" id="{3904D452-B58A-4F19-A275-A846E98F828F}"/>
               </a:ext>
             </a:extLst>
           </p:cNvPr>
@@ -19833,7 +19833,7 @@
           <p:cNvPr id="48" name="6">
             <a:extLst xmlns:a="http://schemas.openxmlformats.org/drawingml/2006/main">
               <a:ext uri="{FF2B5EF4-FFF2-40B4-BE49-F238E27FC236}">
-                <a16:creationId xmlns:a16="http://schemas.microsoft.com/office/drawing/2014/main" id="{F96B2B3C-A9A3-474E-A572-4804E8C1F3BB}"/>
+                <a16:creationId xmlns:a16="http://schemas.microsoft.com/office/drawing/2014/main" id="{06F88A1B-FE47-472F-9889-C71F99CECAD7}"/>
               </a:ext>
             </a:extLst>
           </p:cNvPr>
@@ -19991,7 +19991,7 @@
           <p:cNvPr id="49" name="">
             <a:extLst xmlns:a="http://schemas.openxmlformats.org/drawingml/2006/main">
               <a:ext uri="{FF2B5EF4-FFF2-40B4-BE49-F238E27FC236}">
-                <a16:creationId xmlns:a16="http://schemas.microsoft.com/office/drawing/2014/main" id="{4F21079D-A133-4471-A1D1-F6062B742ABE}"/>
+                <a16:creationId xmlns:a16="http://schemas.microsoft.com/office/drawing/2014/main" id="{104392A5-4430-4DFD-95C7-ADB065146F26}"/>
               </a:ext>
             </a:extLst>
           </p:cNvPr>
@@ -20024,7 +20024,7 @@
           <p:cNvPr id="50" name="7">
             <a:extLst xmlns:a="http://schemas.openxmlformats.org/drawingml/2006/main">
               <a:ext uri="{FF2B5EF4-FFF2-40B4-BE49-F238E27FC236}">
-                <a16:creationId xmlns:a16="http://schemas.microsoft.com/office/drawing/2014/main" id="{B6477658-FB3A-455A-9524-A3DB8E856900}"/>
+                <a16:creationId xmlns:a16="http://schemas.microsoft.com/office/drawing/2014/main" id="{E7004BD7-64BB-4992-BB55-A5D213132CCA}"/>
               </a:ext>
             </a:extLst>
           </p:cNvPr>
@@ -20182,7 +20182,7 @@
           <p:cNvPr id="51" name="">
             <a:extLst xmlns:a="http://schemas.openxmlformats.org/drawingml/2006/main">
               <a:ext uri="{FF2B5EF4-FFF2-40B4-BE49-F238E27FC236}">
-                <a16:creationId xmlns:a16="http://schemas.microsoft.com/office/drawing/2014/main" id="{8A119B3B-990F-41E8-8C92-F670CFAC7C5B}"/>
+                <a16:creationId xmlns:a16="http://schemas.microsoft.com/office/drawing/2014/main" id="{DCC959C9-BB83-4D07-9950-C7740DACDC96}"/>
               </a:ext>
             </a:extLst>
           </p:cNvPr>
@@ -20215,7 +20215,7 @@
           <p:cNvPr id="52" name="8">
             <a:extLst xmlns:a="http://schemas.openxmlformats.org/drawingml/2006/main">
               <a:ext uri="{FF2B5EF4-FFF2-40B4-BE49-F238E27FC236}">
-                <a16:creationId xmlns:a16="http://schemas.microsoft.com/office/drawing/2014/main" id="{39256F7E-6684-42D5-B735-BCC927ADD05D}"/>
+                <a16:creationId xmlns:a16="http://schemas.microsoft.com/office/drawing/2014/main" id="{4B97DAF4-AA31-4B73-89BD-1181DBD649ED}"/>
               </a:ext>
             </a:extLst>
           </p:cNvPr>
@@ -20373,7 +20373,7 @@
           <p:cNvPr id="53" name="한 열이 더 포함됨">
             <a:extLst xmlns:a="http://schemas.openxmlformats.org/drawingml/2006/main">
               <a:ext uri="{FF2B5EF4-FFF2-40B4-BE49-F238E27FC236}">
-                <a16:creationId xmlns:a16="http://schemas.microsoft.com/office/drawing/2014/main" id="{9AD94C41-1290-499E-9BD6-04E7F04ED9BB}"/>
+                <a16:creationId xmlns:a16="http://schemas.microsoft.com/office/drawing/2014/main" id="{E27BC1FF-D7E8-464C-A80F-B951B829030F}"/>
               </a:ext>
             </a:extLst>
           </p:cNvPr>
@@ -20531,7 +20531,7 @@
           <p:cNvPr id="54" name="">
             <a:extLst xmlns:a="http://schemas.openxmlformats.org/drawingml/2006/main">
               <a:ext uri="{FF2B5EF4-FFF2-40B4-BE49-F238E27FC236}">
-                <a16:creationId xmlns:a16="http://schemas.microsoft.com/office/drawing/2014/main" id="{05339DD0-56F3-480C-A6F6-35105360ADD5}"/>
+                <a16:creationId xmlns:a16="http://schemas.microsoft.com/office/drawing/2014/main" id="{9EDB1D1A-86C6-48A0-B366-470B94189752}"/>
               </a:ext>
             </a:extLst>
           </p:cNvPr>
@@ -20562,7 +20562,7 @@
           <p:cNvPr id="55" name="조사에서 연결한 근거">
             <a:extLst xmlns:a="http://schemas.openxmlformats.org/drawingml/2006/main">
               <a:ext uri="{FF2B5EF4-FFF2-40B4-BE49-F238E27FC236}">
-                <a16:creationId xmlns:a16="http://schemas.microsoft.com/office/drawing/2014/main" id="{18BB63CD-9A9F-457D-86A4-100B518B621E}"/>
+                <a16:creationId xmlns:a16="http://schemas.microsoft.com/office/drawing/2014/main" id="{B7883911-6A00-4DE3-9A81-3B5A2F033CD9}"/>
               </a:ext>
             </a:extLst>
           </p:cNvPr>
@@ -20720,7 +20720,7 @@
           <p:cNvPr id="56" name="01  실패 테스트">
             <a:extLst xmlns:a="http://schemas.openxmlformats.org/drawingml/2006/main">
               <a:ext uri="{FF2B5EF4-FFF2-40B4-BE49-F238E27FC236}">
-                <a16:creationId xmlns:a16="http://schemas.microsoft.com/office/drawing/2014/main" id="{44FFFAFF-23A5-4558-BC02-414F1EF7902A}"/>
+                <a16:creationId xmlns:a16="http://schemas.microsoft.com/office/drawing/2014/main" id="{99F822DD-99DC-4DFE-A19E-6C82E0A495FF}"/>
               </a:ext>
             </a:extLst>
           </p:cNvPr>
@@ -20878,7 +20878,7 @@
           <p:cNvPr id="57" name="test_crop_excludes_&#10;end_coordinate">
             <a:extLst xmlns:a="http://schemas.openxmlformats.org/drawingml/2006/main">
               <a:ext uri="{FF2B5EF4-FFF2-40B4-BE49-F238E27FC236}">
-                <a16:creationId xmlns:a16="http://schemas.microsoft.com/office/drawing/2014/main" id="{68A92D7F-CFE2-41F1-BA01-EEFB3D8F042F}"/>
+                <a16:creationId xmlns:a16="http://schemas.microsoft.com/office/drawing/2014/main" id="{3DEA5A3D-922A-48EE-9772-834BF3AFE22B}"/>
               </a:ext>
             </a:extLst>
           </p:cNvPr>
@@ -21059,7 +21059,7 @@
           <p:cNvPr id="58" name="02  제품의 호출 경로">
             <a:extLst xmlns:a="http://schemas.openxmlformats.org/drawingml/2006/main">
               <a:ext uri="{FF2B5EF4-FFF2-40B4-BE49-F238E27FC236}">
-                <a16:creationId xmlns:a16="http://schemas.microsoft.com/office/drawing/2014/main" id="{34EBC5D3-6C84-4804-BA45-AFEE5FE1836B}"/>
+                <a16:creationId xmlns:a16="http://schemas.microsoft.com/office/drawing/2014/main" id="{280132EC-5F58-48C7-BDB9-5BF2F60C1D81}"/>
               </a:ext>
             </a:extLst>
           </p:cNvPr>
@@ -21217,7 +21217,7 @@
           <p:cNvPr id="59" name="cli.main → process_image → crop">
             <a:extLst xmlns:a="http://schemas.openxmlformats.org/drawingml/2006/main">
               <a:ext uri="{FF2B5EF4-FFF2-40B4-BE49-F238E27FC236}">
-                <a16:creationId xmlns:a16="http://schemas.microsoft.com/office/drawing/2014/main" id="{2C8AF3A3-A02E-4323-8E0A-9E2123DF28A0}"/>
+                <a16:creationId xmlns:a16="http://schemas.microsoft.com/office/drawing/2014/main" id="{F49729DB-294A-472F-9312-601049F1B592}"/>
               </a:ext>
             </a:extLst>
           </p:cNvPr>
@@ -21375,7 +21375,7 @@
           <p:cNvPr id="60" name="03  계약과 다른 구현">
             <a:extLst xmlns:a="http://schemas.openxmlformats.org/drawingml/2006/main">
               <a:ext uri="{FF2B5EF4-FFF2-40B4-BE49-F238E27FC236}">
-                <a16:creationId xmlns:a16="http://schemas.microsoft.com/office/drawing/2014/main" id="{4AC1F69F-5C16-482D-A904-FC8D91265466}"/>
+                <a16:creationId xmlns:a16="http://schemas.microsoft.com/office/drawing/2014/main" id="{40CD9D22-3169-43DA-89C1-9B78DFD53A3A}"/>
               </a:ext>
             </a:extLst>
           </p:cNvPr>
@@ -21533,7 +21533,7 @@
           <p:cNvPr id="61" name="row[x_start : x_end + 1]">
             <a:extLst xmlns:a="http://schemas.openxmlformats.org/drawingml/2006/main">
               <a:ext uri="{FF2B5EF4-FFF2-40B4-BE49-F238E27FC236}">
-                <a16:creationId xmlns:a16="http://schemas.microsoft.com/office/drawing/2014/main" id="{8B56F0EB-F48C-4C7B-B4FC-590141313623}"/>
+                <a16:creationId xmlns:a16="http://schemas.microsoft.com/office/drawing/2014/main" id="{7EF1B601-F658-4C30-BE0C-297894BECEC3}"/>
               </a:ext>
             </a:extLst>
           </p:cNvPr>
@@ -21691,7 +21691,7 @@
           <p:cNvPr id="62" name="계약: [x_start, x_end)">
             <a:extLst xmlns:a="http://schemas.openxmlformats.org/drawingml/2006/main">
               <a:ext uri="{FF2B5EF4-FFF2-40B4-BE49-F238E27FC236}">
-                <a16:creationId xmlns:a16="http://schemas.microsoft.com/office/drawing/2014/main" id="{59C25C2A-4174-4803-8D71-05DDEDC3859C}"/>
+                <a16:creationId xmlns:a16="http://schemas.microsoft.com/office/drawing/2014/main" id="{B56B41A5-F04C-4F46-B35E-2E6C78AB3218}"/>
               </a:ext>
             </a:extLst>
           </p:cNvPr>
@@ -21847,7 +21847,7 @@
     </p:spTree>
     <p:extLst>
       <p:ext uri="{BB962C8B-B14F-4D97-AF65-F5344CB8AC3E}">
-        <p14:creationId xmlns:p14="http://schemas.microsoft.com/office/powerpoint/2010/main" val="1603699594"/>
+        <p14:creationId xmlns:p14="http://schemas.microsoft.com/office/powerpoint/2010/main" val="148551870"/>
       </p:ext>
     </p:extLst>
   </p:cSld>
@@ -21878,7 +21878,7 @@
           <p:cNvPr id="17" name="ACT 0 · 조사 결과 읽기">
             <a:extLst xmlns:a="http://schemas.openxmlformats.org/drawingml/2006/main">
               <a:ext uri="{FF2B5EF4-FFF2-40B4-BE49-F238E27FC236}">
-                <a16:creationId xmlns:a16="http://schemas.microsoft.com/office/drawing/2014/main" id="{7D794C63-7A43-45B2-8025-B04CE6834ECD}"/>
+                <a16:creationId xmlns:a16="http://schemas.microsoft.com/office/drawing/2014/main" id="{9CB89B9A-3E07-4942-A5AF-9CD7678E5149}"/>
               </a:ext>
             </a:extLst>
           </p:cNvPr>
@@ -22036,7 +22036,7 @@
           <p:cNvPr id="2" name="S06">
             <a:extLst xmlns:a="http://schemas.openxmlformats.org/drawingml/2006/main">
               <a:ext uri="{FF2B5EF4-FFF2-40B4-BE49-F238E27FC236}">
-                <a16:creationId xmlns:a16="http://schemas.microsoft.com/office/drawing/2014/main" id="{A1E32591-4F3E-4002-A5C0-2F48DE229C30}"/>
+                <a16:creationId xmlns:a16="http://schemas.microsoft.com/office/drawing/2014/main" id="{2673C32F-E530-4C52-9D97-99614F22CAF9}"/>
               </a:ext>
             </a:extLst>
           </p:cNvPr>
@@ -22194,7 +22194,7 @@
           <p:cNvPr id="3" name="관찰 결과와 실행 제한을 분리한다">
             <a:extLst xmlns:a="http://schemas.openxmlformats.org/drawingml/2006/main">
               <a:ext uri="{FF2B5EF4-FFF2-40B4-BE49-F238E27FC236}">
-                <a16:creationId xmlns:a16="http://schemas.microsoft.com/office/drawing/2014/main" id="{9676E8EB-A793-4571-B048-04E4A27E7A47}"/>
+                <a16:creationId xmlns:a16="http://schemas.microsoft.com/office/drawing/2014/main" id="{93E87592-96B5-4118-9669-4AD934C8E402}"/>
               </a:ext>
             </a:extLst>
           </p:cNvPr>
@@ -22352,7 +22352,7 @@
           <p:cNvPr id="4" name="">
             <a:extLst xmlns:a="http://schemas.openxmlformats.org/drawingml/2006/main">
               <a:ext uri="{FF2B5EF4-FFF2-40B4-BE49-F238E27FC236}">
-                <a16:creationId xmlns:a16="http://schemas.microsoft.com/office/drawing/2014/main" id="{DB84AA2C-EDAD-46EB-AA66-D5100A3FF8D2}"/>
+                <a16:creationId xmlns:a16="http://schemas.microsoft.com/office/drawing/2014/main" id="{41A0E2F7-A08A-4C4D-BADF-43972C5DE4A2}"/>
               </a:ext>
             </a:extLst>
           </p:cNvPr>
@@ -22383,7 +22383,7 @@
           <p:cNvPr id="5" name="TRIAL-001 기록 재구성 · Codex CLI 0.154.0 · 단일 읽기 전용 조사">
             <a:extLst xmlns:a="http://schemas.openxmlformats.org/drawingml/2006/main">
               <a:ext uri="{FF2B5EF4-FFF2-40B4-BE49-F238E27FC236}">
-                <a16:creationId xmlns:a16="http://schemas.microsoft.com/office/drawing/2014/main" id="{232B7CEE-370B-40A9-9F37-C08AFEC59C1C}"/>
+                <a16:creationId xmlns:a16="http://schemas.microsoft.com/office/drawing/2014/main" id="{323208BF-3A17-4FE2-AF9C-BF34077A09FD}"/>
               </a:ext>
             </a:extLst>
           </p:cNvPr>
@@ -22541,7 +22541,7 @@
           <p:cNvPr id="6" name="환경 오류 3건은 crop 결함의 증거가 아닙니다. 이 조사에서 코드는 수정하지 않았습니다.">
             <a:extLst xmlns:a="http://schemas.openxmlformats.org/drawingml/2006/main">
               <a:ext uri="{FF2B5EF4-FFF2-40B4-BE49-F238E27FC236}">
-                <a16:creationId xmlns:a16="http://schemas.microsoft.com/office/drawing/2014/main" id="{F2364938-B962-48D7-AE21-8AC1BE60C555}"/>
+                <a16:creationId xmlns:a16="http://schemas.microsoft.com/office/drawing/2014/main" id="{A66FF0D7-C3A7-49EC-9C9B-5130DA1D3498}"/>
               </a:ext>
             </a:extLst>
           </p:cNvPr>
@@ -22699,7 +22699,7 @@
           <p:cNvPr id="7" name="코드에서 확인한 문제">
             <a:extLst xmlns:a="http://schemas.openxmlformats.org/drawingml/2006/main">
               <a:ext uri="{FF2B5EF4-FFF2-40B4-BE49-F238E27FC236}">
-                <a16:creationId xmlns:a16="http://schemas.microsoft.com/office/drawing/2014/main" id="{E55B2ACE-816C-429B-B86B-FEBC95AB3865}"/>
+                <a16:creationId xmlns:a16="http://schemas.microsoft.com/office/drawing/2014/main" id="{E2A9F7F7-B20D-41BC-B32F-E68A419107AA}"/>
               </a:ext>
             </a:extLst>
           </p:cNvPr>
@@ -22857,7 +22857,7 @@
           <p:cNvPr id="8" name="실행 환경에서 생긴 제한">
             <a:extLst xmlns:a="http://schemas.openxmlformats.org/drawingml/2006/main">
               <a:ext uri="{FF2B5EF4-FFF2-40B4-BE49-F238E27FC236}">
-                <a16:creationId xmlns:a16="http://schemas.microsoft.com/office/drawing/2014/main" id="{387AC485-CB73-43FE-8CE1-A7F577C8E97B}"/>
+                <a16:creationId xmlns:a16="http://schemas.microsoft.com/office/drawing/2014/main" id="{A226862D-9AB1-475E-AC93-9A2F0CBD1E25}"/>
               </a:ext>
             </a:extLst>
           </p:cNvPr>
@@ -23015,7 +23015,7 @@
           <p:cNvPr id="9" name="">
             <a:extLst xmlns:a="http://schemas.openxmlformats.org/drawingml/2006/main">
               <a:ext uri="{FF2B5EF4-FFF2-40B4-BE49-F238E27FC236}">
-                <a16:creationId xmlns:a16="http://schemas.microsoft.com/office/drawing/2014/main" id="{A418CAC2-0A88-41ED-A51C-3842DFBE140C}"/>
+                <a16:creationId xmlns:a16="http://schemas.microsoft.com/office/drawing/2014/main" id="{F3C1701F-F204-471E-81FF-D860D1FEAF38}"/>
               </a:ext>
             </a:extLst>
           </p:cNvPr>
@@ -23048,7 +23048,7 @@
           <p:cNvPr id="10" name="">
             <a:extLst xmlns:a="http://schemas.openxmlformats.org/drawingml/2006/main">
               <a:ext uri="{FF2B5EF4-FFF2-40B4-BE49-F238E27FC236}">
-                <a16:creationId xmlns:a16="http://schemas.microsoft.com/office/drawing/2014/main" id="{6E2772FD-00DF-4982-9B97-7E1E39633180}"/>
+                <a16:creationId xmlns:a16="http://schemas.microsoft.com/office/drawing/2014/main" id="{05047DB2-A099-4369-B679-198FF856A984}"/>
               </a:ext>
             </a:extLst>
           </p:cNvPr>
@@ -23079,7 +23079,7 @@
           <p:cNvPr id="11" name="crop에 한 열이 더 포함됨">
             <a:extLst xmlns:a="http://schemas.openxmlformats.org/drawingml/2006/main">
               <a:ext uri="{FF2B5EF4-FFF2-40B4-BE49-F238E27FC236}">
-                <a16:creationId xmlns:a16="http://schemas.microsoft.com/office/drawing/2014/main" id="{FE95396A-54F2-4E7C-8DC6-2B5CFC462FB8}"/>
+                <a16:creationId xmlns:a16="http://schemas.microsoft.com/office/drawing/2014/main" id="{224AF0A5-DA88-4A9A-93A5-3DE6010776CB}"/>
               </a:ext>
             </a:extLst>
           </p:cNvPr>
@@ -23237,7 +23237,7 @@
           <p:cNvPr id="12" name="테스트·호출 경로·계약 연결&#10;원인 설명 / 코드 수정 없음">
             <a:extLst xmlns:a="http://schemas.openxmlformats.org/drawingml/2006/main">
               <a:ext uri="{FF2B5EF4-FFF2-40B4-BE49-F238E27FC236}">
-                <a16:creationId xmlns:a16="http://schemas.microsoft.com/office/drawing/2014/main" id="{BFC47FB8-9700-4966-B5CC-283132DF0E0F}"/>
+                <a16:creationId xmlns:a16="http://schemas.microsoft.com/office/drawing/2014/main" id="{B83FD470-C275-4684-9872-400182C0265A}"/>
               </a:ext>
             </a:extLst>
           </p:cNvPr>
@@ -23418,7 +23418,7 @@
           <p:cNvPr id="13" name="임시 디렉터리를 만들 수 없음">
             <a:extLst xmlns:a="http://schemas.openxmlformats.org/drawingml/2006/main">
               <a:ext uri="{FF2B5EF4-FFF2-40B4-BE49-F238E27FC236}">
-                <a16:creationId xmlns:a16="http://schemas.microsoft.com/office/drawing/2014/main" id="{ADF68B0F-E31F-45DE-97B7-66C7FED92668}"/>
+                <a16:creationId xmlns:a16="http://schemas.microsoft.com/office/drawing/2014/main" id="{77FEFDDF-35B0-4234-B7DA-F09D4E9571DB}"/>
               </a:ext>
             </a:extLst>
           </p:cNvPr>
@@ -23576,7 +23576,7 @@
           <p:cNvPr id="14" name="읽기 전용 권한 때문에&#10;서로 다른 테스트 3건이 오류">
             <a:extLst xmlns:a="http://schemas.openxmlformats.org/drawingml/2006/main">
               <a:ext uri="{FF2B5EF4-FFF2-40B4-BE49-F238E27FC236}">
-                <a16:creationId xmlns:a16="http://schemas.microsoft.com/office/drawing/2014/main" id="{E9A4387C-22DC-4CAF-A525-5E627AD5DA73}"/>
+                <a16:creationId xmlns:a16="http://schemas.microsoft.com/office/drawing/2014/main" id="{50E122C1-4388-4FC8-AB52-8988E8D78503}"/>
               </a:ext>
             </a:extLst>
           </p:cNvPr>
@@ -23757,7 +23757,7 @@
           <p:cNvPr id="15" name="">
             <a:extLst xmlns:a="http://schemas.openxmlformats.org/drawingml/2006/main">
               <a:ext uri="{FF2B5EF4-FFF2-40B4-BE49-F238E27FC236}">
-                <a16:creationId xmlns:a16="http://schemas.microsoft.com/office/drawing/2014/main" id="{A35F19E9-C27A-483F-B8D5-2C9F0A3A9904}"/>
+                <a16:creationId xmlns:a16="http://schemas.microsoft.com/office/drawing/2014/main" id="{C90765A1-8207-473D-9482-786A36DD9BFD}"/>
               </a:ext>
             </a:extLst>
           </p:cNvPr>
@@ -23788,7 +23788,7 @@
           <p:cNvPr id="16" name="전체 실행 기록: 7개 통과 + crop 실패 + 환경 오류 3건">
             <a:extLst xmlns:a="http://schemas.openxmlformats.org/drawingml/2006/main">
               <a:ext uri="{FF2B5EF4-FFF2-40B4-BE49-F238E27FC236}">
-                <a16:creationId xmlns:a16="http://schemas.microsoft.com/office/drawing/2014/main" id="{2CB9EEE1-1A34-4F2A-9645-42CD1AA6B780}"/>
+                <a16:creationId xmlns:a16="http://schemas.microsoft.com/office/drawing/2014/main" id="{EF9E5F0C-08D2-44C2-A469-574D5BD8790D}"/>
               </a:ext>
             </a:extLst>
           </p:cNvPr>
@@ -23944,7 +23944,7 @@
     </p:spTree>
     <p:extLst>
       <p:ext uri="{BB962C8B-B14F-4D97-AF65-F5344CB8AC3E}">
-        <p14:creationId xmlns:p14="http://schemas.microsoft.com/office/powerpoint/2010/main" val="807368928"/>
+        <p14:creationId xmlns:p14="http://schemas.microsoft.com/office/powerpoint/2010/main" val="1556357695"/>
       </p:ext>
     </p:extLst>
   </p:cSld>
@@ -23972,10 +23972,10 @@
       </p:grpSpPr>
       <p:sp>
         <p:nvSpPr>
-          <p:cNvPr id="19" name="ACT 0 · Context를 찾는 주체">
+          <p:cNvPr id="12" name="ACT 0 · Context를 찾는 주체">
             <a:extLst xmlns:a="http://schemas.openxmlformats.org/drawingml/2006/main">
               <a:ext uri="{FF2B5EF4-FFF2-40B4-BE49-F238E27FC236}">
-                <a16:creationId xmlns:a16="http://schemas.microsoft.com/office/drawing/2014/main" id="{D81E54E1-D30E-47D9-82F0-B7F990FCA44F}"/>
+                <a16:creationId xmlns:a16="http://schemas.microsoft.com/office/drawing/2014/main" id="{13FC8076-79D0-4DEC-8993-FB44772D9249}"/>
               </a:ext>
             </a:extLst>
           </p:cNvPr>
@@ -24133,7 +24133,7 @@
           <p:cNvPr id="2" name="S07">
             <a:extLst xmlns:a="http://schemas.openxmlformats.org/drawingml/2006/main">
               <a:ext uri="{FF2B5EF4-FFF2-40B4-BE49-F238E27FC236}">
-                <a16:creationId xmlns:a16="http://schemas.microsoft.com/office/drawing/2014/main" id="{3CE6CF3C-95EA-4AD2-8ADD-5DE02BC10A47}"/>
+                <a16:creationId xmlns:a16="http://schemas.microsoft.com/office/drawing/2014/main" id="{01BFBD3C-6B4D-4C79-957B-4184617EC34F}"/>
               </a:ext>
             </a:extLst>
           </p:cNvPr>
@@ -24291,7 +24291,7 @@
           <p:cNvPr id="3" name="코드를 AI에게 가져가는 대신&#10;AI를 Repository로 데려간다">
             <a:extLst xmlns:a="http://schemas.openxmlformats.org/drawingml/2006/main">
               <a:ext uri="{FF2B5EF4-FFF2-40B4-BE49-F238E27FC236}">
-                <a16:creationId xmlns:a16="http://schemas.microsoft.com/office/drawing/2014/main" id="{0546D1AB-33CB-4055-80BC-FD392056A7E5}"/>
+                <a16:creationId xmlns:a16="http://schemas.microsoft.com/office/drawing/2014/main" id="{A3AD61F3-891E-4E58-BD98-F9F8FCD2DF33}"/>
               </a:ext>
             </a:extLst>
           </p:cNvPr>
@@ -24472,7 +24472,7 @@
           <p:cNvPr id="4" name="">
             <a:extLst xmlns:a="http://schemas.openxmlformats.org/drawingml/2006/main">
               <a:ext uri="{FF2B5EF4-FFF2-40B4-BE49-F238E27FC236}">
-                <a16:creationId xmlns:a16="http://schemas.microsoft.com/office/drawing/2014/main" id="{D0BDA96A-628A-48E8-A215-1CE43F4731DD}"/>
+                <a16:creationId xmlns:a16="http://schemas.microsoft.com/office/drawing/2014/main" id="{93102F3E-CBA5-41F4-AED7-389C6F2655F4}"/>
               </a:ext>
             </a:extLst>
           </p:cNvPr>
@@ -24500,10 +24500,10 @@
       </p:sp>
       <p:sp>
         <p:nvSpPr>
-          <p:cNvPr id="5" name="교육 모델 · 연결된 관찰: TRIAL-001에서 테스트·구현·호출 경로를 확인">
+          <p:cNvPr id="5" name="교육 모델 · TRIAL-001 단일 CLI 관찰과 연결 · AI 생성 설명용 삽화">
             <a:extLst xmlns:a="http://schemas.openxmlformats.org/drawingml/2006/main">
               <a:ext uri="{FF2B5EF4-FFF2-40B4-BE49-F238E27FC236}">
-                <a16:creationId xmlns:a16="http://schemas.microsoft.com/office/drawing/2014/main" id="{AC988D66-0729-487B-9A46-E89683469FF0}"/>
+                <a16:creationId xmlns:a16="http://schemas.microsoft.com/office/drawing/2014/main" id="{5AA366D2-9468-4C99-B214-C34BF10A13C0}"/>
               </a:ext>
             </a:extLst>
           </p:cNvPr>
@@ -24651,17 +24651,17 @@
                 <a:ea typeface="Malgun Gothic"/>
                 <a:cs typeface="Malgun Gothic"/>
               </a:rPr>
-              <a:t>교육 모델 · 연결된 관찰: TRIAL-001에서 테스트·구현·호출 경로를 확인</a:t>
+              <a:t>교육 모델 · TRIAL-001 단일 CLI 관찰과 연결 · AI 생성 설명용 삽화</a:t>
             </a:r>
           </a:p>
         </p:txBody>
       </p:sp>
       <p:sp>
         <p:nvSpPr>
-          <p:cNvPr id="6" name="관찰은 단일 CLI 조사에 한정됩니다. Repository 접근이 작업의 목표까지 정하지는 않습니다.">
+          <p:cNvPr id="6" name="목표 설정과 근거 검토는 개발자에게 남습니다. Repository 접근이 Task 의도를 정하지는 않습니다.">
             <a:extLst xmlns:a="http://schemas.openxmlformats.org/drawingml/2006/main">
               <a:ext uri="{FF2B5EF4-FFF2-40B4-BE49-F238E27FC236}">
-                <a16:creationId xmlns:a16="http://schemas.microsoft.com/office/drawing/2014/main" id="{3F9A02B1-B11F-471E-9986-6794CB180685}"/>
+                <a16:creationId xmlns:a16="http://schemas.microsoft.com/office/drawing/2014/main" id="{641C2680-2797-4E78-ABBB-9C9A7FDA3EDE}"/>
               </a:ext>
             </a:extLst>
           </p:cNvPr>
@@ -24809,17 +24809,17 @@
                 <a:ea typeface="Malgun Gothic"/>
                 <a:cs typeface="Malgun Gothic"/>
               </a:rPr>
-              <a:t>관찰은 단일 CLI 조사에 한정됩니다. Repository 접근이 작업의 목표까지 정하지는 않습니다.</a:t>
+              <a:t>목표 설정과 근거 검토는 개발자에게 남습니다. Repository 접근이 Task 의도를 정하지는 않습니다.</a:t>
             </a:r>
           </a:p>
         </p:txBody>
       </p:sp>
       <p:sp>
         <p:nvSpPr>
-          <p:cNvPr id="7" name="내가 관련 코드를 모아 전달">
+          <p:cNvPr id="7" name="내가 골라 전달하는 Context">
             <a:extLst xmlns:a="http://schemas.openxmlformats.org/drawingml/2006/main">
               <a:ext uri="{FF2B5EF4-FFF2-40B4-BE49-F238E27FC236}">
-                <a16:creationId xmlns:a16="http://schemas.microsoft.com/office/drawing/2014/main" id="{D467F06D-861A-4184-9339-A489C765B31F}"/>
+                <a16:creationId xmlns:a16="http://schemas.microsoft.com/office/drawing/2014/main" id="{73FB7380-49C3-4AE4-BF00-B26AEF41747D}"/>
               </a:ext>
             </a:extLst>
           </p:cNvPr>
@@ -24830,8 +24830,8 @@
         </p:nvSpPr>
         <p:spPr>
           <a:xfrm xmlns:a="http://schemas.openxmlformats.org/drawingml/2006/main">
-            <a:off x="609600" y="2257425"/>
-            <a:ext cx="10972800" cy="400050"/>
+            <a:off x="609600" y="2038350"/>
+            <a:ext cx="5238750" cy="323850"/>
           </a:xfrm>
           <a:prstGeom xmlns:a="http://schemas.openxmlformats.org/drawingml/2006/main" prst="rect">
             <a:avLst/>
@@ -24847,7 +24847,7 @@
           </a:bodyPr>
           <a:lstStyle xmlns:a="http://schemas.openxmlformats.org/drawingml/2006/main">
             <a:defPPr algn="l">
-              <a:defRPr sz="2325" b="1">
+              <a:defRPr sz="2100" b="1">
                 <a:solidFill>
                   <a:srgbClr val="4D5A68"/>
                 </a:solidFill>
@@ -24857,7 +24857,7 @@
               </a:defRPr>
             </a:defPPr>
             <a:lvl1pPr algn="l">
-              <a:defRPr sz="2325" b="1">
+              <a:defRPr sz="2100" b="1">
                 <a:solidFill>
                   <a:srgbClr val="4D5A68"/>
                 </a:solidFill>
@@ -24867,7 +24867,7 @@
               </a:defRPr>
             </a:lvl1pPr>
             <a:lvl2pPr algn="l">
-              <a:defRPr sz="2325" b="1">
+              <a:defRPr sz="2100" b="1">
                 <a:solidFill>
                   <a:srgbClr val="4D5A68"/>
                 </a:solidFill>
@@ -24877,7 +24877,7 @@
               </a:defRPr>
             </a:lvl2pPr>
             <a:lvl3pPr algn="l">
-              <a:defRPr sz="2325" b="1">
+              <a:defRPr sz="2100" b="1">
                 <a:solidFill>
                   <a:srgbClr val="4D5A68"/>
                 </a:solidFill>
@@ -24887,7 +24887,7 @@
               </a:defRPr>
             </a:lvl3pPr>
             <a:lvl4pPr algn="l">
-              <a:defRPr sz="2325" b="1">
+              <a:defRPr sz="2100" b="1">
                 <a:solidFill>
                   <a:srgbClr val="4D5A68"/>
                 </a:solidFill>
@@ -24897,7 +24897,7 @@
               </a:defRPr>
             </a:lvl4pPr>
             <a:lvl5pPr algn="l">
-              <a:defRPr sz="2325" b="1">
+              <a:defRPr sz="2100" b="1">
                 <a:solidFill>
                   <a:srgbClr val="4D5A68"/>
                 </a:solidFill>
@@ -24907,7 +24907,7 @@
               </a:defRPr>
             </a:lvl5pPr>
             <a:lvl6pPr algn="l">
-              <a:defRPr sz="2325" b="1">
+              <a:defRPr sz="2100" b="1">
                 <a:solidFill>
                   <a:srgbClr val="4D5A68"/>
                 </a:solidFill>
@@ -24917,7 +24917,7 @@
               </a:defRPr>
             </a:lvl6pPr>
             <a:lvl7pPr algn="l">
-              <a:defRPr sz="2325" b="1">
+              <a:defRPr sz="2100" b="1">
                 <a:solidFill>
                   <a:srgbClr val="4D5A68"/>
                 </a:solidFill>
@@ -24927,7 +24927,7 @@
               </a:defRPr>
             </a:lvl7pPr>
             <a:lvl8pPr algn="l">
-              <a:defRPr sz="2325" b="1">
+              <a:defRPr sz="2100" b="1">
                 <a:solidFill>
                   <a:srgbClr val="4D5A68"/>
                 </a:solidFill>
@@ -24937,7 +24937,7 @@
               </a:defRPr>
             </a:lvl8pPr>
             <a:lvl9pPr algn="l">
-              <a:defRPr sz="2325" b="1">
+              <a:defRPr sz="2100" b="1">
                 <a:solidFill>
                   <a:srgbClr val="4D5A68"/>
                 </a:solidFill>
@@ -24949,7 +24949,7 @@
           </a:lstStyle>
           <a:p xmlns:a="http://schemas.openxmlformats.org/drawingml/2006/main">
             <a:pPr algn="l">
-              <a:defRPr sz="2325" b="1">
+              <a:defRPr sz="2100" b="1">
                 <a:solidFill>
                   <a:srgbClr val="4D5A68"/>
                 </a:solidFill>
@@ -24959,7 +24959,7 @@
               </a:defRPr>
             </a:pPr>
             <a:r>
-              <a:rPr sz="2325" b="1">
+              <a:rPr sz="2100" b="1">
                 <a:solidFill>
                   <a:srgbClr val="4D5A68"/>
                 </a:solidFill>
@@ -24967,17 +24967,17 @@
                 <a:ea typeface="Malgun Gothic"/>
                 <a:cs typeface="Malgun Gothic"/>
               </a:rPr>
-              <a:t>내가 관련 코드를 모아 전달</a:t>
+              <a:t>내가 골라 전달하는 Context</a:t>
             </a:r>
           </a:p>
         </p:txBody>
       </p:sp>
       <p:sp>
         <p:nvSpPr>
-          <p:cNvPr id="8" name="Repository">
+          <p:cNvPr id="8" name="조사를 맡기고 근거를 확인">
             <a:extLst xmlns:a="http://schemas.openxmlformats.org/drawingml/2006/main">
               <a:ext uri="{FF2B5EF4-FFF2-40B4-BE49-F238E27FC236}">
-                <a16:creationId xmlns:a16="http://schemas.microsoft.com/office/drawing/2014/main" id="{9004D112-4C54-457F-8DC6-D3B7EDE4F467}"/>
+                <a16:creationId xmlns:a16="http://schemas.microsoft.com/office/drawing/2014/main" id="{40B489DA-5337-44CC-AB7B-982D2CB47FBD}"/>
               </a:ext>
             </a:extLst>
           </p:cNvPr>
@@ -24988,8 +24988,8 @@
         </p:nvSpPr>
         <p:spPr>
           <a:xfrm xmlns:a="http://schemas.openxmlformats.org/drawingml/2006/main">
-            <a:off x="609600" y="2924175"/>
-            <a:ext cx="2647950" cy="476250"/>
+            <a:off x="6381750" y="2038350"/>
+            <a:ext cx="5200650" cy="323850"/>
           </a:xfrm>
           <a:prstGeom xmlns:a="http://schemas.openxmlformats.org/drawingml/2006/main" prst="rect">
             <a:avLst/>
@@ -25005,9 +25005,9 @@
           </a:bodyPr>
           <a:lstStyle xmlns:a="http://schemas.openxmlformats.org/drawingml/2006/main">
             <a:defPPr algn="l">
-              <a:defRPr sz="2550" b="1">
-                <a:solidFill>
-                  <a:srgbClr val="17212B"/>
+              <a:defRPr sz="2100" b="1">
+                <a:solidFill>
+                  <a:srgbClr val="0B6172"/>
                 </a:solidFill>
                 <a:latin typeface="Malgun Gothic"/>
                 <a:ea typeface="Malgun Gothic"/>
@@ -25015,9 +25015,9 @@
               </a:defRPr>
             </a:defPPr>
             <a:lvl1pPr algn="l">
-              <a:defRPr sz="2550" b="1">
-                <a:solidFill>
-                  <a:srgbClr val="17212B"/>
+              <a:defRPr sz="2100" b="1">
+                <a:solidFill>
+                  <a:srgbClr val="0B6172"/>
                 </a:solidFill>
                 <a:latin typeface="Malgun Gothic"/>
                 <a:ea typeface="Malgun Gothic"/>
@@ -25025,9 +25025,9 @@
               </a:defRPr>
             </a:lvl1pPr>
             <a:lvl2pPr algn="l">
-              <a:defRPr sz="2550" b="1">
-                <a:solidFill>
-                  <a:srgbClr val="17212B"/>
+              <a:defRPr sz="2100" b="1">
+                <a:solidFill>
+                  <a:srgbClr val="0B6172"/>
                 </a:solidFill>
                 <a:latin typeface="Malgun Gothic"/>
                 <a:ea typeface="Malgun Gothic"/>
@@ -25035,9 +25035,9 @@
               </a:defRPr>
             </a:lvl2pPr>
             <a:lvl3pPr algn="l">
-              <a:defRPr sz="2550" b="1">
-                <a:solidFill>
-                  <a:srgbClr val="17212B"/>
+              <a:defRPr sz="2100" b="1">
+                <a:solidFill>
+                  <a:srgbClr val="0B6172"/>
                 </a:solidFill>
                 <a:latin typeface="Malgun Gothic"/>
                 <a:ea typeface="Malgun Gothic"/>
@@ -25045,9 +25045,9 @@
               </a:defRPr>
             </a:lvl3pPr>
             <a:lvl4pPr algn="l">
-              <a:defRPr sz="2550" b="1">
-                <a:solidFill>
-                  <a:srgbClr val="17212B"/>
+              <a:defRPr sz="2100" b="1">
+                <a:solidFill>
+                  <a:srgbClr val="0B6172"/>
                 </a:solidFill>
                 <a:latin typeface="Malgun Gothic"/>
                 <a:ea typeface="Malgun Gothic"/>
@@ -25055,9 +25055,9 @@
               </a:defRPr>
             </a:lvl4pPr>
             <a:lvl5pPr algn="l">
-              <a:defRPr sz="2550" b="1">
-                <a:solidFill>
-                  <a:srgbClr val="17212B"/>
+              <a:defRPr sz="2100" b="1">
+                <a:solidFill>
+                  <a:srgbClr val="0B6172"/>
                 </a:solidFill>
                 <a:latin typeface="Malgun Gothic"/>
                 <a:ea typeface="Malgun Gothic"/>
@@ -25065,9 +25065,9 @@
               </a:defRPr>
             </a:lvl5pPr>
             <a:lvl6pPr algn="l">
-              <a:defRPr sz="2550" b="1">
-                <a:solidFill>
-                  <a:srgbClr val="17212B"/>
+              <a:defRPr sz="2100" b="1">
+                <a:solidFill>
+                  <a:srgbClr val="0B6172"/>
                 </a:solidFill>
                 <a:latin typeface="Malgun Gothic"/>
                 <a:ea typeface="Malgun Gothic"/>
@@ -25075,9 +25075,9 @@
               </a:defRPr>
             </a:lvl6pPr>
             <a:lvl7pPr algn="l">
-              <a:defRPr sz="2550" b="1">
-                <a:solidFill>
-                  <a:srgbClr val="17212B"/>
+              <a:defRPr sz="2100" b="1">
+                <a:solidFill>
+                  <a:srgbClr val="0B6172"/>
                 </a:solidFill>
                 <a:latin typeface="Malgun Gothic"/>
                 <a:ea typeface="Malgun Gothic"/>
@@ -25085,9 +25085,9 @@
               </a:defRPr>
             </a:lvl7pPr>
             <a:lvl8pPr algn="l">
-              <a:defRPr sz="2550" b="1">
-                <a:solidFill>
-                  <a:srgbClr val="17212B"/>
+              <a:defRPr sz="2100" b="1">
+                <a:solidFill>
+                  <a:srgbClr val="0B6172"/>
                 </a:solidFill>
                 <a:latin typeface="Malgun Gothic"/>
                 <a:ea typeface="Malgun Gothic"/>
@@ -25095,9 +25095,9 @@
               </a:defRPr>
             </a:lvl8pPr>
             <a:lvl9pPr algn="l">
-              <a:defRPr sz="2550" b="1">
-                <a:solidFill>
-                  <a:srgbClr val="17212B"/>
+              <a:defRPr sz="2100" b="1">
+                <a:solidFill>
+                  <a:srgbClr val="0B6172"/>
                 </a:solidFill>
                 <a:latin typeface="Malgun Gothic"/>
                 <a:ea typeface="Malgun Gothic"/>
@@ -25107,9 +25107,9 @@
           </a:lstStyle>
           <a:p xmlns:a="http://schemas.openxmlformats.org/drawingml/2006/main">
             <a:pPr algn="l">
-              <a:defRPr sz="2550" b="1">
-                <a:solidFill>
-                  <a:srgbClr val="17212B"/>
+              <a:defRPr sz="2100" b="1">
+                <a:solidFill>
+                  <a:srgbClr val="0B6172"/>
                 </a:solidFill>
                 <a:latin typeface="Malgun Gothic"/>
                 <a:ea typeface="Malgun Gothic"/>
@@ -25117,25 +25117,54 @@
               </a:defRPr>
             </a:pPr>
             <a:r>
-              <a:rPr sz="2550" b="1">
-                <a:solidFill>
-                  <a:srgbClr val="17212B"/>
+              <a:rPr sz="2100" b="1">
+                <a:solidFill>
+                  <a:srgbClr val="0B6172"/>
                 </a:solidFill>
                 <a:latin typeface="Malgun Gothic"/>
                 <a:ea typeface="Malgun Gothic"/>
                 <a:cs typeface="Malgun Gothic"/>
               </a:rPr>
-              <a:t>Repository</a:t>
+              <a:t>조사를 맡기고 근거를 확인</a:t>
             </a:r>
           </a:p>
         </p:txBody>
       </p:sp>
-      <p:sp>
-        <p:nvSpPr>
+      <p:pic>
+        <p:nvPicPr>
           <p:cNvPr id="9" name="">
             <a:extLst xmlns:a="http://schemas.openxmlformats.org/drawingml/2006/main">
               <a:ext uri="{FF2B5EF4-FFF2-40B4-BE49-F238E27FC236}">
-                <a16:creationId xmlns:a16="http://schemas.microsoft.com/office/drawing/2014/main" id="{FB6F6ABF-A2D5-4893-B017-79D30EF4125F}"/>
+                <a16:creationId xmlns:a16="http://schemas.microsoft.com/office/drawing/2014/main" id="{867EA41E-7698-4507-A11F-84E39FFB02E2}"/>
+              </a:ext>
+            </a:extLst>
+          </p:cNvPr>
+          <p:cNvPicPr>
+            <a:picLocks xmlns:a="http://schemas.openxmlformats.org/drawingml/2006/main" noChangeAspect="1"/>
+          </p:cNvPicPr>
+          <p:nvPr/>
+        </p:nvPicPr>
+        <p:blipFill>
+          <a:blip xmlns:r="http://schemas.openxmlformats.org/officeDocument/2006/relationships" xmlns:a="http://schemas.openxmlformats.org/drawingml/2006/main" r:embed="R869af1ec4cca4bc7"/>
+          <a:srcRect xmlns:a="http://schemas.openxmlformats.org/drawingml/2006/main" l="0" t="18000" r="0" b="15000"/>
+          <a:stretch xmlns:a="http://schemas.openxmlformats.org/drawingml/2006/main"/>
+        </p:blipFill>
+        <p:spPr>
+          <a:xfrm xmlns:a="http://schemas.openxmlformats.org/drawingml/2006/main">
+            <a:off x="1562100" y="2343150"/>
+            <a:ext cx="9067800" cy="3038475"/>
+          </a:xfrm>
+          <a:prstGeom xmlns:a="http://schemas.openxmlformats.org/drawingml/2006/main" prst="rect">
+            <a:avLst/>
+          </a:prstGeom>
+        </p:spPr>
+      </p:pic>
+      <p:sp>
+        <p:nvSpPr>
+          <p:cNvPr id="10" name="코드 조각을 선택·복사">
+            <a:extLst xmlns:a="http://schemas.openxmlformats.org/drawingml/2006/main">
+              <a:ext uri="{FF2B5EF4-FFF2-40B4-BE49-F238E27FC236}">
+                <a16:creationId xmlns:a16="http://schemas.microsoft.com/office/drawing/2014/main" id="{46B9CBEB-295E-43ED-95C1-E83C0153656A}"/>
               </a:ext>
             </a:extLst>
           </p:cNvPr>
@@ -25146,71 +25175,8 @@
         </p:nvSpPr>
         <p:spPr>
           <a:xfrm xmlns:a="http://schemas.openxmlformats.org/drawingml/2006/main">
-            <a:off x="3324225" y="3057525"/>
-            <a:ext cx="533400" cy="228600"/>
-          </a:xfrm>
-          <a:prstGeom xmlns:a="http://schemas.openxmlformats.org/drawingml/2006/main" prst="rightArrow">
-            <a:avLst/>
-          </a:prstGeom>
-          <a:solidFill xmlns:a="http://schemas.openxmlformats.org/drawingml/2006/main">
-            <a:srgbClr val="0B6172"/>
-          </a:solidFill>
-          <a:ln xmlns:a="http://schemas.openxmlformats.org/drawingml/2006/main" w="0">
-            <a:noFill/>
-          </a:ln>
-        </p:spPr>
-      </p:sp>
-      <p:sp>
-        <p:nvSpPr>
-          <p:cNvPr id="10" name="">
-            <a:extLst xmlns:a="http://schemas.openxmlformats.org/drawingml/2006/main">
-              <a:ext uri="{FF2B5EF4-FFF2-40B4-BE49-F238E27FC236}">
-                <a16:creationId xmlns:a16="http://schemas.microsoft.com/office/drawing/2014/main" id="{078C194B-2F5D-412A-8D40-89765FAE4899}"/>
-              </a:ext>
-            </a:extLst>
-          </p:cNvPr>
-          <p:cNvSpPr>
-            <a:spLocks xmlns:a="http://schemas.openxmlformats.org/drawingml/2006/main" noGrp="1"/>
-          </p:cNvSpPr>
-          <p:nvPr/>
-        </p:nvSpPr>
-        <p:spPr>
-          <a:xfrm xmlns:a="http://schemas.openxmlformats.org/drawingml/2006/main">
-            <a:off x="4095750" y="2800350"/>
-            <a:ext cx="3286125" cy="742950"/>
-          </a:xfrm>
-          <a:prstGeom xmlns:a="http://schemas.openxmlformats.org/drawingml/2006/main" prst="rect">
-            <a:avLst/>
-          </a:prstGeom>
-          <a:solidFill xmlns:a="http://schemas.openxmlformats.org/drawingml/2006/main">
-            <a:srgbClr val="FFFFFF"/>
-          </a:solidFill>
-          <a:ln xmlns:a="http://schemas.openxmlformats.org/drawingml/2006/main" w="9525">
-            <a:solidFill>
-              <a:srgbClr val="C7D0DA"/>
-            </a:solidFill>
-            <a:prstDash val="solid"/>
-          </a:ln>
-        </p:spPr>
-      </p:sp>
-      <p:sp>
-        <p:nvSpPr>
-          <p:cNvPr id="11" name="개발자: 선택·복사">
-            <a:extLst xmlns:a="http://schemas.openxmlformats.org/drawingml/2006/main">
-              <a:ext uri="{FF2B5EF4-FFF2-40B4-BE49-F238E27FC236}">
-                <a16:creationId xmlns:a16="http://schemas.microsoft.com/office/drawing/2014/main" id="{3062FF7D-4359-450B-9304-16CDD4ABB1B0}"/>
-              </a:ext>
-            </a:extLst>
-          </p:cNvPr>
-          <p:cNvSpPr>
-            <a:spLocks xmlns:a="http://schemas.openxmlformats.org/drawingml/2006/main" noGrp="1"/>
-          </p:cNvSpPr>
-          <p:nvPr/>
-        </p:nvSpPr>
-        <p:spPr>
-          <a:xfrm xmlns:a="http://schemas.openxmlformats.org/drawingml/2006/main">
-            <a:off x="4324350" y="2952750"/>
-            <a:ext cx="2828925" cy="438150"/>
+            <a:off x="609600" y="5314950"/>
+            <a:ext cx="5238750" cy="342900"/>
           </a:xfrm>
           <a:prstGeom xmlns:a="http://schemas.openxmlformats.org/drawingml/2006/main" prst="rect">
             <a:avLst/>
@@ -25226,7 +25192,7 @@
           </a:bodyPr>
           <a:lstStyle xmlns:a="http://schemas.openxmlformats.org/drawingml/2006/main">
             <a:defPPr algn="l">
-              <a:defRPr sz="2175" b="1">
+              <a:defRPr sz="2100" b="1">
                 <a:solidFill>
                   <a:srgbClr val="17212B"/>
                 </a:solidFill>
@@ -25236,7 +25202,7 @@
               </a:defRPr>
             </a:defPPr>
             <a:lvl1pPr algn="l">
-              <a:defRPr sz="2175" b="1">
+              <a:defRPr sz="2100" b="1">
                 <a:solidFill>
                   <a:srgbClr val="17212B"/>
                 </a:solidFill>
@@ -25246,7 +25212,7 @@
               </a:defRPr>
             </a:lvl1pPr>
             <a:lvl2pPr algn="l">
-              <a:defRPr sz="2175" b="1">
+              <a:defRPr sz="2100" b="1">
                 <a:solidFill>
                   <a:srgbClr val="17212B"/>
                 </a:solidFill>
@@ -25256,7 +25222,7 @@
               </a:defRPr>
             </a:lvl2pPr>
             <a:lvl3pPr algn="l">
-              <a:defRPr sz="2175" b="1">
+              <a:defRPr sz="2100" b="1">
                 <a:solidFill>
                   <a:srgbClr val="17212B"/>
                 </a:solidFill>
@@ -25266,7 +25232,7 @@
               </a:defRPr>
             </a:lvl3pPr>
             <a:lvl4pPr algn="l">
-              <a:defRPr sz="2175" b="1">
+              <a:defRPr sz="2100" b="1">
                 <a:solidFill>
                   <a:srgbClr val="17212B"/>
                 </a:solidFill>
@@ -25276,7 +25242,7 @@
               </a:defRPr>
             </a:lvl4pPr>
             <a:lvl5pPr algn="l">
-              <a:defRPr sz="2175" b="1">
+              <a:defRPr sz="2100" b="1">
                 <a:solidFill>
                   <a:srgbClr val="17212B"/>
                 </a:solidFill>
@@ -25286,7 +25252,7 @@
               </a:defRPr>
             </a:lvl5pPr>
             <a:lvl6pPr algn="l">
-              <a:defRPr sz="2175" b="1">
+              <a:defRPr sz="2100" b="1">
                 <a:solidFill>
                   <a:srgbClr val="17212B"/>
                 </a:solidFill>
@@ -25296,7 +25262,7 @@
               </a:defRPr>
             </a:lvl6pPr>
             <a:lvl7pPr algn="l">
-              <a:defRPr sz="2175" b="1">
+              <a:defRPr sz="2100" b="1">
                 <a:solidFill>
                   <a:srgbClr val="17212B"/>
                 </a:solidFill>
@@ -25306,7 +25272,7 @@
               </a:defRPr>
             </a:lvl7pPr>
             <a:lvl8pPr algn="l">
-              <a:defRPr sz="2175" b="1">
+              <a:defRPr sz="2100" b="1">
                 <a:solidFill>
                   <a:srgbClr val="17212B"/>
                 </a:solidFill>
@@ -25316,7 +25282,7 @@
               </a:defRPr>
             </a:lvl8pPr>
             <a:lvl9pPr algn="l">
-              <a:defRPr sz="2175" b="1">
+              <a:defRPr sz="2100" b="1">
                 <a:solidFill>
                   <a:srgbClr val="17212B"/>
                 </a:solidFill>
@@ -25328,7 +25294,7 @@
           </a:lstStyle>
           <a:p xmlns:a="http://schemas.openxmlformats.org/drawingml/2006/main">
             <a:pPr algn="l">
-              <a:defRPr sz="2175" b="1">
+              <a:defRPr sz="2100" b="1">
                 <a:solidFill>
                   <a:srgbClr val="17212B"/>
                 </a:solidFill>
@@ -25338,7 +25304,7 @@
               </a:defRPr>
             </a:pPr>
             <a:r>
-              <a:rPr sz="2175" b="1">
+              <a:rPr sz="2100" b="1">
                 <a:solidFill>
                   <a:srgbClr val="17212B"/>
                 </a:solidFill>
@@ -25346,17 +25312,17 @@
                 <a:ea typeface="Malgun Gothic"/>
                 <a:cs typeface="Malgun Gothic"/>
               </a:rPr>
-              <a:t>개발자: 선택·복사</a:t>
+              <a:t>코드 조각을 선택·복사</a:t>
             </a:r>
           </a:p>
         </p:txBody>
       </p:sp>
       <p:sp>
         <p:nvSpPr>
-          <p:cNvPr id="12" name="">
+          <p:cNvPr id="11" name="목표는 사람이, 탐색은 Agent와">
             <a:extLst xmlns:a="http://schemas.openxmlformats.org/drawingml/2006/main">
               <a:ext uri="{FF2B5EF4-FFF2-40B4-BE49-F238E27FC236}">
-                <a16:creationId xmlns:a16="http://schemas.microsoft.com/office/drawing/2014/main" id="{08E53FBA-8F04-4981-81A1-D3588394C703}"/>
+                <a16:creationId xmlns:a16="http://schemas.microsoft.com/office/drawing/2014/main" id="{0453DBC3-CA8B-472E-BD2F-49F6F610491D}"/>
               </a:ext>
             </a:extLst>
           </p:cNvPr>
@@ -25367,38 +25333,8 @@
         </p:nvSpPr>
         <p:spPr>
           <a:xfrm xmlns:a="http://schemas.openxmlformats.org/drawingml/2006/main">
-            <a:off x="7648575" y="3057525"/>
-            <a:ext cx="533400" cy="228600"/>
-          </a:xfrm>
-          <a:prstGeom xmlns:a="http://schemas.openxmlformats.org/drawingml/2006/main" prst="rightArrow">
-            <a:avLst/>
-          </a:prstGeom>
-          <a:solidFill xmlns:a="http://schemas.openxmlformats.org/drawingml/2006/main">
-            <a:srgbClr val="0B6172"/>
-          </a:solidFill>
-          <a:ln xmlns:a="http://schemas.openxmlformats.org/drawingml/2006/main" w="0">
-            <a:noFill/>
-          </a:ln>
-        </p:spPr>
-      </p:sp>
-      <p:sp>
-        <p:nvSpPr>
-          <p:cNvPr id="13" name="AI">
-            <a:extLst xmlns:a="http://schemas.openxmlformats.org/drawingml/2006/main">
-              <a:ext uri="{FF2B5EF4-FFF2-40B4-BE49-F238E27FC236}">
-                <a16:creationId xmlns:a16="http://schemas.microsoft.com/office/drawing/2014/main" id="{EBB9F12C-4609-4632-A0A5-6EDC6C941FC9}"/>
-              </a:ext>
-            </a:extLst>
-          </p:cNvPr>
-          <p:cNvSpPr>
-            <a:spLocks xmlns:a="http://schemas.openxmlformats.org/drawingml/2006/main" noGrp="1"/>
-          </p:cNvSpPr>
-          <p:nvPr/>
-        </p:nvSpPr>
-        <p:spPr>
-          <a:xfrm xmlns:a="http://schemas.openxmlformats.org/drawingml/2006/main">
-            <a:off x="8667750" y="2924175"/>
-            <a:ext cx="2628900" cy="476250"/>
+            <a:off x="6381750" y="5314950"/>
+            <a:ext cx="5200650" cy="342900"/>
           </a:xfrm>
           <a:prstGeom xmlns:a="http://schemas.openxmlformats.org/drawingml/2006/main" prst="rect">
             <a:avLst/>
@@ -25414,9 +25350,9 @@
           </a:bodyPr>
           <a:lstStyle xmlns:a="http://schemas.openxmlformats.org/drawingml/2006/main">
             <a:defPPr algn="l">
-              <a:defRPr sz="2550" b="1">
-                <a:solidFill>
-                  <a:srgbClr val="17212B"/>
+              <a:defRPr sz="2100" b="1">
+                <a:solidFill>
+                  <a:srgbClr val="0B6172"/>
                 </a:solidFill>
                 <a:latin typeface="Malgun Gothic"/>
                 <a:ea typeface="Malgun Gothic"/>
@@ -25424,9 +25360,9 @@
               </a:defRPr>
             </a:defPPr>
             <a:lvl1pPr algn="l">
-              <a:defRPr sz="2550" b="1">
-                <a:solidFill>
-                  <a:srgbClr val="17212B"/>
+              <a:defRPr sz="2100" b="1">
+                <a:solidFill>
+                  <a:srgbClr val="0B6172"/>
                 </a:solidFill>
                 <a:latin typeface="Malgun Gothic"/>
                 <a:ea typeface="Malgun Gothic"/>
@@ -25434,9 +25370,9 @@
               </a:defRPr>
             </a:lvl1pPr>
             <a:lvl2pPr algn="l">
-              <a:defRPr sz="2550" b="1">
-                <a:solidFill>
-                  <a:srgbClr val="17212B"/>
+              <a:defRPr sz="2100" b="1">
+                <a:solidFill>
+                  <a:srgbClr val="0B6172"/>
                 </a:solidFill>
                 <a:latin typeface="Malgun Gothic"/>
                 <a:ea typeface="Malgun Gothic"/>
@@ -25444,9 +25380,9 @@
               </a:defRPr>
             </a:lvl2pPr>
             <a:lvl3pPr algn="l">
-              <a:defRPr sz="2550" b="1">
-                <a:solidFill>
-                  <a:srgbClr val="17212B"/>
+              <a:defRPr sz="2100" b="1">
+                <a:solidFill>
+                  <a:srgbClr val="0B6172"/>
                 </a:solidFill>
                 <a:latin typeface="Malgun Gothic"/>
                 <a:ea typeface="Malgun Gothic"/>
@@ -25454,9 +25390,9 @@
               </a:defRPr>
             </a:lvl3pPr>
             <a:lvl4pPr algn="l">
-              <a:defRPr sz="2550" b="1">
-                <a:solidFill>
-                  <a:srgbClr val="17212B"/>
+              <a:defRPr sz="2100" b="1">
+                <a:solidFill>
+                  <a:srgbClr val="0B6172"/>
                 </a:solidFill>
                 <a:latin typeface="Malgun Gothic"/>
                 <a:ea typeface="Malgun Gothic"/>
@@ -25464,9 +25400,9 @@
               </a:defRPr>
             </a:lvl4pPr>
             <a:lvl5pPr algn="l">
-              <a:defRPr sz="2550" b="1">
-                <a:solidFill>
-                  <a:srgbClr val="17212B"/>
+              <a:defRPr sz="2100" b="1">
+                <a:solidFill>
+                  <a:srgbClr val="0B6172"/>
                 </a:solidFill>
                 <a:latin typeface="Malgun Gothic"/>
                 <a:ea typeface="Malgun Gothic"/>
@@ -25474,9 +25410,9 @@
               </a:defRPr>
             </a:lvl5pPr>
             <a:lvl6pPr algn="l">
-              <a:defRPr sz="2550" b="1">
-                <a:solidFill>
-                  <a:srgbClr val="17212B"/>
+              <a:defRPr sz="2100" b="1">
+                <a:solidFill>
+                  <a:srgbClr val="0B6172"/>
                 </a:solidFill>
                 <a:latin typeface="Malgun Gothic"/>
                 <a:ea typeface="Malgun Gothic"/>
@@ -25484,9 +25420,9 @@
               </a:defRPr>
             </a:lvl6pPr>
             <a:lvl7pPr algn="l">
-              <a:defRPr sz="2550" b="1">
-                <a:solidFill>
-                  <a:srgbClr val="17212B"/>
+              <a:defRPr sz="2100" b="1">
+                <a:solidFill>
+                  <a:srgbClr val="0B6172"/>
                 </a:solidFill>
                 <a:latin typeface="Malgun Gothic"/>
                 <a:ea typeface="Malgun Gothic"/>
@@ -25494,9 +25430,9 @@
               </a:defRPr>
             </a:lvl7pPr>
             <a:lvl8pPr algn="l">
-              <a:defRPr sz="2550" b="1">
-                <a:solidFill>
-                  <a:srgbClr val="17212B"/>
+              <a:defRPr sz="2100" b="1">
+                <a:solidFill>
+                  <a:srgbClr val="0B6172"/>
                 </a:solidFill>
                 <a:latin typeface="Malgun Gothic"/>
                 <a:ea typeface="Malgun Gothic"/>
@@ -25504,9 +25440,9 @@
               </a:defRPr>
             </a:lvl8pPr>
             <a:lvl9pPr algn="l">
-              <a:defRPr sz="2550" b="1">
-                <a:solidFill>
-                  <a:srgbClr val="17212B"/>
+              <a:defRPr sz="2100" b="1">
+                <a:solidFill>
+                  <a:srgbClr val="0B6172"/>
                 </a:solidFill>
                 <a:latin typeface="Malgun Gothic"/>
                 <a:ea typeface="Malgun Gothic"/>
@@ -25516,9 +25452,9 @@
           </a:lstStyle>
           <a:p xmlns:a="http://schemas.openxmlformats.org/drawingml/2006/main">
             <a:pPr algn="l">
-              <a:defRPr sz="2550" b="1">
-                <a:solidFill>
-                  <a:srgbClr val="17212B"/>
+              <a:defRPr sz="2100" b="1">
+                <a:solidFill>
+                  <a:srgbClr val="0B6172"/>
                 </a:solidFill>
                 <a:latin typeface="Malgun Gothic"/>
                 <a:ea typeface="Malgun Gothic"/>
@@ -25526,550 +25462,15 @@
               </a:defRPr>
             </a:pPr>
             <a:r>
-              <a:rPr sz="2550" b="1">
-                <a:solidFill>
-                  <a:srgbClr val="17212B"/>
+              <a:rPr sz="2100" b="1">
+                <a:solidFill>
+                  <a:srgbClr val="0B6172"/>
                 </a:solidFill>
                 <a:latin typeface="Malgun Gothic"/>
                 <a:ea typeface="Malgun Gothic"/>
                 <a:cs typeface="Malgun Gothic"/>
               </a:rPr>
-              <a:t>AI</a:t>
-            </a:r>
-          </a:p>
-        </p:txBody>
-      </p:sp>
-      <p:sp>
-        <p:nvSpPr>
-          <p:cNvPr id="14" name="">
-            <a:extLst xmlns:a="http://schemas.openxmlformats.org/drawingml/2006/main">
-              <a:ext uri="{FF2B5EF4-FFF2-40B4-BE49-F238E27FC236}">
-                <a16:creationId xmlns:a16="http://schemas.microsoft.com/office/drawing/2014/main" id="{ECF3A8DA-DEB0-4005-96C0-D9AA6568B81F}"/>
-              </a:ext>
-            </a:extLst>
-          </p:cNvPr>
-          <p:cNvSpPr>
-            <a:spLocks xmlns:a="http://schemas.openxmlformats.org/drawingml/2006/main" noGrp="1"/>
-          </p:cNvSpPr>
-          <p:nvPr/>
-        </p:nvSpPr>
-        <p:spPr>
-          <a:xfrm xmlns:a="http://schemas.openxmlformats.org/drawingml/2006/main">
-            <a:off x="609600" y="3905250"/>
-            <a:ext cx="10972800" cy="0"/>
-          </a:xfrm>
-          <a:prstGeom xmlns:a="http://schemas.openxmlformats.org/drawingml/2006/main" prst="line">
-            <a:avLst/>
-          </a:prstGeom>
-          <a:noFill xmlns:a="http://schemas.openxmlformats.org/drawingml/2006/main"/>
-          <a:ln xmlns:a="http://schemas.openxmlformats.org/drawingml/2006/main" w="9525">
-            <a:solidFill>
-              <a:srgbClr val="C7D0DA"/>
-            </a:solidFill>
-            <a:prstDash val="solid"/>
-          </a:ln>
-        </p:spPr>
-      </p:sp>
-      <p:sp>
-        <p:nvSpPr>
-          <p:cNvPr id="15" name="조사할 일을 맡기고 근거를 확인">
-            <a:extLst xmlns:a="http://schemas.openxmlformats.org/drawingml/2006/main">
-              <a:ext uri="{FF2B5EF4-FFF2-40B4-BE49-F238E27FC236}">
-                <a16:creationId xmlns:a16="http://schemas.microsoft.com/office/drawing/2014/main" id="{0A8EB831-3CB9-46C6-B1E1-2C554EE145FD}"/>
-              </a:ext>
-            </a:extLst>
-          </p:cNvPr>
-          <p:cNvSpPr>
-            <a:spLocks xmlns:a="http://schemas.openxmlformats.org/drawingml/2006/main" noGrp="1"/>
-          </p:cNvSpPr>
-          <p:nvPr/>
-        </p:nvSpPr>
-        <p:spPr>
-          <a:xfrm xmlns:a="http://schemas.openxmlformats.org/drawingml/2006/main">
-            <a:off x="609600" y="4210050"/>
-            <a:ext cx="10972800" cy="409575"/>
-          </a:xfrm>
-          <a:prstGeom xmlns:a="http://schemas.openxmlformats.org/drawingml/2006/main" prst="rect">
-            <a:avLst/>
-          </a:prstGeom>
-          <a:noFill xmlns:a="http://schemas.openxmlformats.org/drawingml/2006/main"/>
-          <a:ln xmlns:a="http://schemas.openxmlformats.org/drawingml/2006/main" w="0">
-            <a:noFill/>
-          </a:ln>
-        </p:spPr>
-        <p:txBody>
-          <a:bodyPr xmlns:a="http://schemas.openxmlformats.org/drawingml/2006/main" wrap="none" lIns="0" tIns="0" rIns="0" bIns="0" anchor="ctr">
-            <a:noAutofit/>
-          </a:bodyPr>
-          <a:lstStyle xmlns:a="http://schemas.openxmlformats.org/drawingml/2006/main">
-            <a:defPPr algn="l">
-              <a:defRPr sz="2325" b="1">
-                <a:solidFill>
-                  <a:srgbClr val="0B6172"/>
-                </a:solidFill>
-                <a:latin typeface="Malgun Gothic"/>
-                <a:ea typeface="Malgun Gothic"/>
-                <a:cs typeface="Malgun Gothic"/>
-              </a:defRPr>
-            </a:defPPr>
-            <a:lvl1pPr algn="l">
-              <a:defRPr sz="2325" b="1">
-                <a:solidFill>
-                  <a:srgbClr val="0B6172"/>
-                </a:solidFill>
-                <a:latin typeface="Malgun Gothic"/>
-                <a:ea typeface="Malgun Gothic"/>
-                <a:cs typeface="Malgun Gothic"/>
-              </a:defRPr>
-            </a:lvl1pPr>
-            <a:lvl2pPr algn="l">
-              <a:defRPr sz="2325" b="1">
-                <a:solidFill>
-                  <a:srgbClr val="0B6172"/>
-                </a:solidFill>
-                <a:latin typeface="Malgun Gothic"/>
-                <a:ea typeface="Malgun Gothic"/>
-                <a:cs typeface="Malgun Gothic"/>
-              </a:defRPr>
-            </a:lvl2pPr>
-            <a:lvl3pPr algn="l">
-              <a:defRPr sz="2325" b="1">
-                <a:solidFill>
-                  <a:srgbClr val="0B6172"/>
-                </a:solidFill>
-                <a:latin typeface="Malgun Gothic"/>
-                <a:ea typeface="Malgun Gothic"/>
-                <a:cs typeface="Malgun Gothic"/>
-              </a:defRPr>
-            </a:lvl3pPr>
-            <a:lvl4pPr algn="l">
-              <a:defRPr sz="2325" b="1">
-                <a:solidFill>
-                  <a:srgbClr val="0B6172"/>
-                </a:solidFill>
-                <a:latin typeface="Malgun Gothic"/>
-                <a:ea typeface="Malgun Gothic"/>
-                <a:cs typeface="Malgun Gothic"/>
-              </a:defRPr>
-            </a:lvl4pPr>
-            <a:lvl5pPr algn="l">
-              <a:defRPr sz="2325" b="1">
-                <a:solidFill>
-                  <a:srgbClr val="0B6172"/>
-                </a:solidFill>
-                <a:latin typeface="Malgun Gothic"/>
-                <a:ea typeface="Malgun Gothic"/>
-                <a:cs typeface="Malgun Gothic"/>
-              </a:defRPr>
-            </a:lvl5pPr>
-            <a:lvl6pPr algn="l">
-              <a:defRPr sz="2325" b="1">
-                <a:solidFill>
-                  <a:srgbClr val="0B6172"/>
-                </a:solidFill>
-                <a:latin typeface="Malgun Gothic"/>
-                <a:ea typeface="Malgun Gothic"/>
-                <a:cs typeface="Malgun Gothic"/>
-              </a:defRPr>
-            </a:lvl6pPr>
-            <a:lvl7pPr algn="l">
-              <a:defRPr sz="2325" b="1">
-                <a:solidFill>
-                  <a:srgbClr val="0B6172"/>
-                </a:solidFill>
-                <a:latin typeface="Malgun Gothic"/>
-                <a:ea typeface="Malgun Gothic"/>
-                <a:cs typeface="Malgun Gothic"/>
-              </a:defRPr>
-            </a:lvl7pPr>
-            <a:lvl8pPr algn="l">
-              <a:defRPr sz="2325" b="1">
-                <a:solidFill>
-                  <a:srgbClr val="0B6172"/>
-                </a:solidFill>
-                <a:latin typeface="Malgun Gothic"/>
-                <a:ea typeface="Malgun Gothic"/>
-                <a:cs typeface="Malgun Gothic"/>
-              </a:defRPr>
-            </a:lvl8pPr>
-            <a:lvl9pPr algn="l">
-              <a:defRPr sz="2325" b="1">
-                <a:solidFill>
-                  <a:srgbClr val="0B6172"/>
-                </a:solidFill>
-                <a:latin typeface="Malgun Gothic"/>
-                <a:ea typeface="Malgun Gothic"/>
-                <a:cs typeface="Malgun Gothic"/>
-              </a:defRPr>
-            </a:lvl9pPr>
-          </a:lstStyle>
-          <a:p xmlns:a="http://schemas.openxmlformats.org/drawingml/2006/main">
-            <a:pPr algn="l">
-              <a:defRPr sz="2325" b="1">
-                <a:solidFill>
-                  <a:srgbClr val="0B6172"/>
-                </a:solidFill>
-                <a:latin typeface="Malgun Gothic"/>
-                <a:ea typeface="Malgun Gothic"/>
-                <a:cs typeface="Malgun Gothic"/>
-              </a:defRPr>
-            </a:pPr>
-            <a:r>
-              <a:rPr sz="2325" b="1">
-                <a:solidFill>
-                  <a:srgbClr val="0B6172"/>
-                </a:solidFill>
-                <a:latin typeface="Malgun Gothic"/>
-                <a:ea typeface="Malgun Gothic"/>
-                <a:cs typeface="Malgun Gothic"/>
-              </a:rPr>
-              <a:t>조사할 일을 맡기고 근거를 확인</a:t>
-            </a:r>
-          </a:p>
-        </p:txBody>
-      </p:sp>
-      <p:sp>
-        <p:nvSpPr>
-          <p:cNvPr id="16" name="개발자: 조사 요청">
-            <a:extLst xmlns:a="http://schemas.openxmlformats.org/drawingml/2006/main">
-              <a:ext uri="{FF2B5EF4-FFF2-40B4-BE49-F238E27FC236}">
-                <a16:creationId xmlns:a16="http://schemas.microsoft.com/office/drawing/2014/main" id="{78F3283B-AEA2-4709-90C1-E09DDCE9ABF3}"/>
-              </a:ext>
-            </a:extLst>
-          </p:cNvPr>
-          <p:cNvSpPr>
-            <a:spLocks xmlns:a="http://schemas.openxmlformats.org/drawingml/2006/main" noGrp="1"/>
-          </p:cNvSpPr>
-          <p:nvPr/>
-        </p:nvSpPr>
-        <p:spPr>
-          <a:xfrm xmlns:a="http://schemas.openxmlformats.org/drawingml/2006/main">
-            <a:off x="609600" y="4933950"/>
-            <a:ext cx="3333750" cy="457200"/>
-          </a:xfrm>
-          <a:prstGeom xmlns:a="http://schemas.openxmlformats.org/drawingml/2006/main" prst="rect">
-            <a:avLst/>
-          </a:prstGeom>
-          <a:noFill xmlns:a="http://schemas.openxmlformats.org/drawingml/2006/main"/>
-          <a:ln xmlns:a="http://schemas.openxmlformats.org/drawingml/2006/main" w="0">
-            <a:noFill/>
-          </a:ln>
-        </p:spPr>
-        <p:txBody>
-          <a:bodyPr xmlns:a="http://schemas.openxmlformats.org/drawingml/2006/main" wrap="none" lIns="0" tIns="0" rIns="0" bIns="0" anchor="ctr">
-            <a:noAutofit/>
-          </a:bodyPr>
-          <a:lstStyle xmlns:a="http://schemas.openxmlformats.org/drawingml/2006/main">
-            <a:defPPr algn="l">
-              <a:defRPr sz="2175" b="1">
-                <a:solidFill>
-                  <a:srgbClr val="17212B"/>
-                </a:solidFill>
-                <a:latin typeface="Malgun Gothic"/>
-                <a:ea typeface="Malgun Gothic"/>
-                <a:cs typeface="Malgun Gothic"/>
-              </a:defRPr>
-            </a:defPPr>
-            <a:lvl1pPr algn="l">
-              <a:defRPr sz="2175" b="1">
-                <a:solidFill>
-                  <a:srgbClr val="17212B"/>
-                </a:solidFill>
-                <a:latin typeface="Malgun Gothic"/>
-                <a:ea typeface="Malgun Gothic"/>
-                <a:cs typeface="Malgun Gothic"/>
-              </a:defRPr>
-            </a:lvl1pPr>
-            <a:lvl2pPr algn="l">
-              <a:defRPr sz="2175" b="1">
-                <a:solidFill>
-                  <a:srgbClr val="17212B"/>
-                </a:solidFill>
-                <a:latin typeface="Malgun Gothic"/>
-                <a:ea typeface="Malgun Gothic"/>
-                <a:cs typeface="Malgun Gothic"/>
-              </a:defRPr>
-            </a:lvl2pPr>
-            <a:lvl3pPr algn="l">
-              <a:defRPr sz="2175" b="1">
-                <a:solidFill>
-                  <a:srgbClr val="17212B"/>
-                </a:solidFill>
-                <a:latin typeface="Malgun Gothic"/>
-                <a:ea typeface="Malgun Gothic"/>
-                <a:cs typeface="Malgun Gothic"/>
-              </a:defRPr>
-            </a:lvl3pPr>
-            <a:lvl4pPr algn="l">
-              <a:defRPr sz="2175" b="1">
-                <a:solidFill>
-                  <a:srgbClr val="17212B"/>
-                </a:solidFill>
-                <a:latin typeface="Malgun Gothic"/>
-                <a:ea typeface="Malgun Gothic"/>
-                <a:cs typeface="Malgun Gothic"/>
-              </a:defRPr>
-            </a:lvl4pPr>
-            <a:lvl5pPr algn="l">
-              <a:defRPr sz="2175" b="1">
-                <a:solidFill>
-                  <a:srgbClr val="17212B"/>
-                </a:solidFill>
-                <a:latin typeface="Malgun Gothic"/>
-                <a:ea typeface="Malgun Gothic"/>
-                <a:cs typeface="Malgun Gothic"/>
-              </a:defRPr>
-            </a:lvl5pPr>
-            <a:lvl6pPr algn="l">
-              <a:defRPr sz="2175" b="1">
-                <a:solidFill>
-                  <a:srgbClr val="17212B"/>
-                </a:solidFill>
-                <a:latin typeface="Malgun Gothic"/>
-                <a:ea typeface="Malgun Gothic"/>
-                <a:cs typeface="Malgun Gothic"/>
-              </a:defRPr>
-            </a:lvl6pPr>
-            <a:lvl7pPr algn="l">
-              <a:defRPr sz="2175" b="1">
-                <a:solidFill>
-                  <a:srgbClr val="17212B"/>
-                </a:solidFill>
-                <a:latin typeface="Malgun Gothic"/>
-                <a:ea typeface="Malgun Gothic"/>
-                <a:cs typeface="Malgun Gothic"/>
-              </a:defRPr>
-            </a:lvl7pPr>
-            <a:lvl8pPr algn="l">
-              <a:defRPr sz="2175" b="1">
-                <a:solidFill>
-                  <a:srgbClr val="17212B"/>
-                </a:solidFill>
-                <a:latin typeface="Malgun Gothic"/>
-                <a:ea typeface="Malgun Gothic"/>
-                <a:cs typeface="Malgun Gothic"/>
-              </a:defRPr>
-            </a:lvl8pPr>
-            <a:lvl9pPr algn="l">
-              <a:defRPr sz="2175" b="1">
-                <a:solidFill>
-                  <a:srgbClr val="17212B"/>
-                </a:solidFill>
-                <a:latin typeface="Malgun Gothic"/>
-                <a:ea typeface="Malgun Gothic"/>
-                <a:cs typeface="Malgun Gothic"/>
-              </a:defRPr>
-            </a:lvl9pPr>
-          </a:lstStyle>
-          <a:p xmlns:a="http://schemas.openxmlformats.org/drawingml/2006/main">
-            <a:pPr algn="l">
-              <a:defRPr sz="2175" b="1">
-                <a:solidFill>
-                  <a:srgbClr val="17212B"/>
-                </a:solidFill>
-                <a:latin typeface="Malgun Gothic"/>
-                <a:ea typeface="Malgun Gothic"/>
-                <a:cs typeface="Malgun Gothic"/>
-              </a:defRPr>
-            </a:pPr>
-            <a:r>
-              <a:rPr sz="2175" b="1">
-                <a:solidFill>
-                  <a:srgbClr val="17212B"/>
-                </a:solidFill>
-                <a:latin typeface="Malgun Gothic"/>
-                <a:ea typeface="Malgun Gothic"/>
-                <a:cs typeface="Malgun Gothic"/>
-              </a:rPr>
-              <a:t>개발자: 조사 요청</a:t>
-            </a:r>
-          </a:p>
-        </p:txBody>
-      </p:sp>
-      <p:sp>
-        <p:nvSpPr>
-          <p:cNvPr id="17" name="">
-            <a:extLst xmlns:a="http://schemas.openxmlformats.org/drawingml/2006/main">
-              <a:ext uri="{FF2B5EF4-FFF2-40B4-BE49-F238E27FC236}">
-                <a16:creationId xmlns:a16="http://schemas.microsoft.com/office/drawing/2014/main" id="{2D086AF5-CB4E-45A4-933A-704A91E57DA0}"/>
-              </a:ext>
-            </a:extLst>
-          </p:cNvPr>
-          <p:cNvSpPr>
-            <a:spLocks xmlns:a="http://schemas.openxmlformats.org/drawingml/2006/main" noGrp="1"/>
-          </p:cNvSpPr>
-          <p:nvPr/>
-        </p:nvSpPr>
-        <p:spPr>
-          <a:xfrm xmlns:a="http://schemas.openxmlformats.org/drawingml/2006/main">
-            <a:off x="4000500" y="5067300"/>
-            <a:ext cx="533400" cy="228600"/>
-          </a:xfrm>
-          <a:prstGeom xmlns:a="http://schemas.openxmlformats.org/drawingml/2006/main" prst="rightArrow">
-            <a:avLst/>
-          </a:prstGeom>
-          <a:solidFill xmlns:a="http://schemas.openxmlformats.org/drawingml/2006/main">
-            <a:srgbClr val="0B6172"/>
-          </a:solidFill>
-          <a:ln xmlns:a="http://schemas.openxmlformats.org/drawingml/2006/main" w="0">
-            <a:noFill/>
-          </a:ln>
-        </p:spPr>
-      </p:sp>
-      <p:sp>
-        <p:nvSpPr>
-          <p:cNvPr id="18" name="Agent ↔ Repository">
-            <a:extLst xmlns:a="http://schemas.openxmlformats.org/drawingml/2006/main">
-              <a:ext uri="{FF2B5EF4-FFF2-40B4-BE49-F238E27FC236}">
-                <a16:creationId xmlns:a16="http://schemas.microsoft.com/office/drawing/2014/main" id="{792B88CB-44B5-439E-881A-EA53837B1EF0}"/>
-              </a:ext>
-            </a:extLst>
-          </p:cNvPr>
-          <p:cNvSpPr>
-            <a:spLocks xmlns:a="http://schemas.openxmlformats.org/drawingml/2006/main" noGrp="1"/>
-          </p:cNvSpPr>
-          <p:nvPr/>
-        </p:nvSpPr>
-        <p:spPr>
-          <a:xfrm xmlns:a="http://schemas.openxmlformats.org/drawingml/2006/main">
-            <a:off x="4991100" y="4848225"/>
-            <a:ext cx="6591300" cy="638175"/>
-          </a:xfrm>
-          <a:prstGeom xmlns:a="http://schemas.openxmlformats.org/drawingml/2006/main" prst="rect">
-            <a:avLst/>
-          </a:prstGeom>
-          <a:noFill xmlns:a="http://schemas.openxmlformats.org/drawingml/2006/main"/>
-          <a:ln xmlns:a="http://schemas.openxmlformats.org/drawingml/2006/main" w="0">
-            <a:noFill/>
-          </a:ln>
-        </p:spPr>
-        <p:txBody>
-          <a:bodyPr xmlns:a="http://schemas.openxmlformats.org/drawingml/2006/main" wrap="none" lIns="0" tIns="0" rIns="0" bIns="0" anchor="ctr">
-            <a:noAutofit/>
-          </a:bodyPr>
-          <a:lstStyle xmlns:a="http://schemas.openxmlformats.org/drawingml/2006/main">
-            <a:defPPr algn="l">
-              <a:defRPr sz="2850" b="1">
-                <a:solidFill>
-                  <a:srgbClr val="0B6172"/>
-                </a:solidFill>
-                <a:latin typeface="Malgun Gothic"/>
-                <a:ea typeface="Malgun Gothic"/>
-                <a:cs typeface="Malgun Gothic"/>
-              </a:defRPr>
-            </a:defPPr>
-            <a:lvl1pPr algn="l">
-              <a:defRPr sz="2850" b="1">
-                <a:solidFill>
-                  <a:srgbClr val="0B6172"/>
-                </a:solidFill>
-                <a:latin typeface="Malgun Gothic"/>
-                <a:ea typeface="Malgun Gothic"/>
-                <a:cs typeface="Malgun Gothic"/>
-              </a:defRPr>
-            </a:lvl1pPr>
-            <a:lvl2pPr algn="l">
-              <a:defRPr sz="2850" b="1">
-                <a:solidFill>
-                  <a:srgbClr val="0B6172"/>
-                </a:solidFill>
-                <a:latin typeface="Malgun Gothic"/>
-                <a:ea typeface="Malgun Gothic"/>
-                <a:cs typeface="Malgun Gothic"/>
-              </a:defRPr>
-            </a:lvl2pPr>
-            <a:lvl3pPr algn="l">
-              <a:defRPr sz="2850" b="1">
-                <a:solidFill>
-                  <a:srgbClr val="0B6172"/>
-                </a:solidFill>
-                <a:latin typeface="Malgun Gothic"/>
-                <a:ea typeface="Malgun Gothic"/>
-                <a:cs typeface="Malgun Gothic"/>
-              </a:defRPr>
-            </a:lvl3pPr>
-            <a:lvl4pPr algn="l">
-              <a:defRPr sz="2850" b="1">
-                <a:solidFill>
-                  <a:srgbClr val="0B6172"/>
-                </a:solidFill>
-                <a:latin typeface="Malgun Gothic"/>
-                <a:ea typeface="Malgun Gothic"/>
-                <a:cs typeface="Malgun Gothic"/>
-              </a:defRPr>
-            </a:lvl4pPr>
-            <a:lvl5pPr algn="l">
-              <a:defRPr sz="2850" b="1">
-                <a:solidFill>
-                  <a:srgbClr val="0B6172"/>
-                </a:solidFill>
-                <a:latin typeface="Malgun Gothic"/>
-                <a:ea typeface="Malgun Gothic"/>
-                <a:cs typeface="Malgun Gothic"/>
-              </a:defRPr>
-            </a:lvl5pPr>
-            <a:lvl6pPr algn="l">
-              <a:defRPr sz="2850" b="1">
-                <a:solidFill>
-                  <a:srgbClr val="0B6172"/>
-                </a:solidFill>
-                <a:latin typeface="Malgun Gothic"/>
-                <a:ea typeface="Malgun Gothic"/>
-                <a:cs typeface="Malgun Gothic"/>
-              </a:defRPr>
-            </a:lvl6pPr>
-            <a:lvl7pPr algn="l">
-              <a:defRPr sz="2850" b="1">
-                <a:solidFill>
-                  <a:srgbClr val="0B6172"/>
-                </a:solidFill>
-                <a:latin typeface="Malgun Gothic"/>
-                <a:ea typeface="Malgun Gothic"/>
-                <a:cs typeface="Malgun Gothic"/>
-              </a:defRPr>
-            </a:lvl7pPr>
-            <a:lvl8pPr algn="l">
-              <a:defRPr sz="2850" b="1">
-                <a:solidFill>
-                  <a:srgbClr val="0B6172"/>
-                </a:solidFill>
-                <a:latin typeface="Malgun Gothic"/>
-                <a:ea typeface="Malgun Gothic"/>
-                <a:cs typeface="Malgun Gothic"/>
-              </a:defRPr>
-            </a:lvl8pPr>
-            <a:lvl9pPr algn="l">
-              <a:defRPr sz="2850" b="1">
-                <a:solidFill>
-                  <a:srgbClr val="0B6172"/>
-                </a:solidFill>
-                <a:latin typeface="Malgun Gothic"/>
-                <a:ea typeface="Malgun Gothic"/>
-                <a:cs typeface="Malgun Gothic"/>
-              </a:defRPr>
-            </a:lvl9pPr>
-          </a:lstStyle>
-          <a:p xmlns:a="http://schemas.openxmlformats.org/drawingml/2006/main">
-            <a:pPr algn="l">
-              <a:defRPr sz="2850" b="1">
-                <a:solidFill>
-                  <a:srgbClr val="0B6172"/>
-                </a:solidFill>
-                <a:latin typeface="Malgun Gothic"/>
-                <a:ea typeface="Malgun Gothic"/>
-                <a:cs typeface="Malgun Gothic"/>
-              </a:defRPr>
-            </a:pPr>
-            <a:r>
-              <a:rPr sz="2850" b="1">
-                <a:solidFill>
-                  <a:srgbClr val="0B6172"/>
-                </a:solidFill>
-                <a:latin typeface="Malgun Gothic"/>
-                <a:ea typeface="Malgun Gothic"/>
-                <a:cs typeface="Malgun Gothic"/>
-              </a:rPr>
-              <a:t>Agent ↔ Repository</a:t>
+              <a:t>목표는 사람이, 탐색은 Agent와</a:t>
             </a:r>
           </a:p>
         </p:txBody>
@@ -26077,7 +25478,7 @@
     </p:spTree>
     <p:extLst>
       <p:ext uri="{BB962C8B-B14F-4D97-AF65-F5344CB8AC3E}">
-        <p14:creationId xmlns:p14="http://schemas.microsoft.com/office/powerpoint/2010/main" val="1102795099"/>
+        <p14:creationId xmlns:p14="http://schemas.microsoft.com/office/powerpoint/2010/main" val="801953783"/>
       </p:ext>
     </p:extLst>
   </p:cSld>
@@ -26108,7 +25509,7 @@
           <p:cNvPr id="15" name="ACT 0 · 접근할 정보와 정할 목표">
             <a:extLst xmlns:a="http://schemas.openxmlformats.org/drawingml/2006/main">
               <a:ext uri="{FF2B5EF4-FFF2-40B4-BE49-F238E27FC236}">
-                <a16:creationId xmlns:a16="http://schemas.microsoft.com/office/drawing/2014/main" id="{5308952F-1E1F-4C79-8CE0-ECE7641160F8}"/>
+                <a16:creationId xmlns:a16="http://schemas.microsoft.com/office/drawing/2014/main" id="{736312E8-09FD-4AA7-97B4-EF62BE1E0069}"/>
               </a:ext>
             </a:extLst>
           </p:cNvPr>
@@ -26266,7 +25667,7 @@
           <p:cNvPr id="2" name="S08">
             <a:extLst xmlns:a="http://schemas.openxmlformats.org/drawingml/2006/main">
               <a:ext uri="{FF2B5EF4-FFF2-40B4-BE49-F238E27FC236}">
-                <a16:creationId xmlns:a16="http://schemas.microsoft.com/office/drawing/2014/main" id="{BC730E58-F8FC-4518-80E4-1131A96C399D}"/>
+                <a16:creationId xmlns:a16="http://schemas.microsoft.com/office/drawing/2014/main" id="{B0714574-E7BB-4EB3-846B-C8E6322E9574}"/>
               </a:ext>
             </a:extLst>
           </p:cNvPr>
@@ -26424,7 +25825,7 @@
           <p:cNvPr id="3" name="Repository 접근과 Task 의도는 별개다">
             <a:extLst xmlns:a="http://schemas.openxmlformats.org/drawingml/2006/main">
               <a:ext uri="{FF2B5EF4-FFF2-40B4-BE49-F238E27FC236}">
-                <a16:creationId xmlns:a16="http://schemas.microsoft.com/office/drawing/2014/main" id="{D77C5C35-C51E-46A7-94FD-E4FA3A59A6DA}"/>
+                <a16:creationId xmlns:a16="http://schemas.microsoft.com/office/drawing/2014/main" id="{2317D594-8238-4154-B9B2-BF209B3E5B3B}"/>
               </a:ext>
             </a:extLst>
           </p:cNvPr>
@@ -26582,7 +25983,7 @@
           <p:cNvPr id="4" name="">
             <a:extLst xmlns:a="http://schemas.openxmlformats.org/drawingml/2006/main">
               <a:ext uri="{FF2B5EF4-FFF2-40B4-BE49-F238E27FC236}">
-                <a16:creationId xmlns:a16="http://schemas.microsoft.com/office/drawing/2014/main" id="{18222A7C-0BED-4B04-89B7-8695DBA64D18}"/>
+                <a16:creationId xmlns:a16="http://schemas.microsoft.com/office/drawing/2014/main" id="{B6DF42F4-B249-4BFC-8269-9DD558281ACC}"/>
               </a:ext>
             </a:extLst>
           </p:cNvPr>
@@ -26613,7 +26014,7 @@
           <p:cNvPr id="5" name="이 과정의 교육 모델 · Repository 접근과 작업 의도의 관계">
             <a:extLst xmlns:a="http://schemas.openxmlformats.org/drawingml/2006/main">
               <a:ext uri="{FF2B5EF4-FFF2-40B4-BE49-F238E27FC236}">
-                <a16:creationId xmlns:a16="http://schemas.microsoft.com/office/drawing/2014/main" id="{7804C0D4-D88E-40E2-95AD-A9909F19CBB2}"/>
+                <a16:creationId xmlns:a16="http://schemas.microsoft.com/office/drawing/2014/main" id="{86655B16-5A10-4071-9E6E-17A4EA419802}"/>
               </a:ext>
             </a:extLst>
           </p:cNvPr>
@@ -26771,7 +26172,7 @@
           <p:cNvPr id="6" name="모든 제품이나 환경의 기능을 설명하는 공식 분류가 아닙니다.">
             <a:extLst xmlns:a="http://schemas.openxmlformats.org/drawingml/2006/main">
               <a:ext uri="{FF2B5EF4-FFF2-40B4-BE49-F238E27FC236}">
-                <a16:creationId xmlns:a16="http://schemas.microsoft.com/office/drawing/2014/main" id="{E3C8C4C7-8A13-4EE8-B536-06746E2BA9A7}"/>
+                <a16:creationId xmlns:a16="http://schemas.microsoft.com/office/drawing/2014/main" id="{B6966F82-C238-495D-A45E-384E6CC283D5}"/>
               </a:ext>
             </a:extLst>
           </p:cNvPr>
@@ -26929,7 +26330,7 @@
           <p:cNvPr id="7" name="볼 수 있는 것">
             <a:extLst xmlns:a="http://schemas.openxmlformats.org/drawingml/2006/main">
               <a:ext uri="{FF2B5EF4-FFF2-40B4-BE49-F238E27FC236}">
-                <a16:creationId xmlns:a16="http://schemas.microsoft.com/office/drawing/2014/main" id="{6161C70E-9E59-48B5-887E-75DDB9CEBCC3}"/>
+                <a16:creationId xmlns:a16="http://schemas.microsoft.com/office/drawing/2014/main" id="{075735BF-D4F9-41AF-BB15-3E6F48ECED2F}"/>
               </a:ext>
             </a:extLst>
           </p:cNvPr>
@@ -27087,7 +26488,7 @@
           <p:cNvPr id="8" name="정해야 하는 것">
             <a:extLst xmlns:a="http://schemas.openxmlformats.org/drawingml/2006/main">
               <a:ext uri="{FF2B5EF4-FFF2-40B4-BE49-F238E27FC236}">
-                <a16:creationId xmlns:a16="http://schemas.microsoft.com/office/drawing/2014/main" id="{3643B274-994E-4719-B1BA-4023B871C38E}"/>
+                <a16:creationId xmlns:a16="http://schemas.microsoft.com/office/drawing/2014/main" id="{B4C9DDD8-55B1-4482-84CF-5A35EE6C9279}"/>
               </a:ext>
             </a:extLst>
           </p:cNvPr>
@@ -27245,7 +26646,7 @@
           <p:cNvPr id="9" name="">
             <a:extLst xmlns:a="http://schemas.openxmlformats.org/drawingml/2006/main">
               <a:ext uri="{FF2B5EF4-FFF2-40B4-BE49-F238E27FC236}">
-                <a16:creationId xmlns:a16="http://schemas.microsoft.com/office/drawing/2014/main" id="{0D37C7BC-BA01-4BD6-A46D-A811B90959AB}"/>
+                <a16:creationId xmlns:a16="http://schemas.microsoft.com/office/drawing/2014/main" id="{CE59D22A-4C11-4D74-BF38-6178BBC89D0E}"/>
               </a:ext>
             </a:extLst>
           </p:cNvPr>
@@ -27276,7 +26677,7 @@
           <p:cNvPr id="10" name="">
             <a:extLst xmlns:a="http://schemas.openxmlformats.org/drawingml/2006/main">
               <a:ext uri="{FF2B5EF4-FFF2-40B4-BE49-F238E27FC236}">
-                <a16:creationId xmlns:a16="http://schemas.microsoft.com/office/drawing/2014/main" id="{5335E5CE-3822-4BBA-8397-B5328FBE410B}"/>
+                <a16:creationId xmlns:a16="http://schemas.microsoft.com/office/drawing/2014/main" id="{DE6D561E-BE9D-4A8C-BD7D-3BAF4FE4CC14}"/>
               </a:ext>
             </a:extLst>
           </p:cNvPr>
@@ -27307,7 +26708,7 @@
           <p:cNvPr id="11" name="파일&#10;구현&#10;테스트">
             <a:extLst xmlns:a="http://schemas.openxmlformats.org/drawingml/2006/main">
               <a:ext uri="{FF2B5EF4-FFF2-40B4-BE49-F238E27FC236}">
-                <a16:creationId xmlns:a16="http://schemas.microsoft.com/office/drawing/2014/main" id="{0813E547-6E6D-4A78-B800-20A2C5DB5F85}"/>
+                <a16:creationId xmlns:a16="http://schemas.microsoft.com/office/drawing/2014/main" id="{A4114561-53EF-4DE2-969E-826652E90CD4}"/>
               </a:ext>
             </a:extLst>
           </p:cNvPr>
@@ -27511,7 +26912,7 @@
           <p:cNvPr id="12" name="원하는 변화&#10;허용할 범위&#10;완료 판단">
             <a:extLst xmlns:a="http://schemas.openxmlformats.org/drawingml/2006/main">
               <a:ext uri="{FF2B5EF4-FFF2-40B4-BE49-F238E27FC236}">
-                <a16:creationId xmlns:a16="http://schemas.microsoft.com/office/drawing/2014/main" id="{4E12C489-D705-4062-BE7F-3438AD585A85}"/>
+                <a16:creationId xmlns:a16="http://schemas.microsoft.com/office/drawing/2014/main" id="{8F58E778-6CCF-4601-AAFF-26EABE3EE8D9}"/>
               </a:ext>
             </a:extLst>
           </p:cNvPr>
@@ -27715,7 +27116,7 @@
           <p:cNvPr id="13" name="≠">
             <a:extLst xmlns:a="http://schemas.openxmlformats.org/drawingml/2006/main">
               <a:ext uri="{FF2B5EF4-FFF2-40B4-BE49-F238E27FC236}">
-                <a16:creationId xmlns:a16="http://schemas.microsoft.com/office/drawing/2014/main" id="{B2B132CD-B49C-4C5C-961C-086855E6D1AF}"/>
+                <a16:creationId xmlns:a16="http://schemas.microsoft.com/office/drawing/2014/main" id="{2EF81E67-F72A-41A1-BAF8-17CA10D941AA}"/>
               </a:ext>
             </a:extLst>
           </p:cNvPr>
@@ -27873,7 +27274,7 @@
           <p:cNvPr id="14" name="코드가 보여도, 원하는 일은 따로 전달해야 한다.">
             <a:extLst xmlns:a="http://schemas.openxmlformats.org/drawingml/2006/main">
               <a:ext uri="{FF2B5EF4-FFF2-40B4-BE49-F238E27FC236}">
-                <a16:creationId xmlns:a16="http://schemas.microsoft.com/office/drawing/2014/main" id="{4F977953-ECC5-4485-B0C8-78BD23018E38}"/>
+                <a16:creationId xmlns:a16="http://schemas.microsoft.com/office/drawing/2014/main" id="{3FA6128A-CB7F-424B-A75C-51433F7CEDFB}"/>
               </a:ext>
             </a:extLst>
           </p:cNvPr>
@@ -28029,7 +27430,7 @@
     </p:spTree>
     <p:extLst>
       <p:ext uri="{BB962C8B-B14F-4D97-AF65-F5344CB8AC3E}">
-        <p14:creationId xmlns:p14="http://schemas.microsoft.com/office/powerpoint/2010/main" val="1637417503"/>
+        <p14:creationId xmlns:p14="http://schemas.microsoft.com/office/powerpoint/2010/main" val="1031975324"/>
       </p:ext>
     </p:extLst>
   </p:cSld>
@@ -28060,7 +27461,7 @@
           <p:cNvPr id="11" name="ACT 0 · 다음 질문">
             <a:extLst xmlns:a="http://schemas.openxmlformats.org/drawingml/2006/main">
               <a:ext uri="{FF2B5EF4-FFF2-40B4-BE49-F238E27FC236}">
-                <a16:creationId xmlns:a16="http://schemas.microsoft.com/office/drawing/2014/main" id="{D1D65604-89A1-4D5B-990A-11D966443DC8}"/>
+                <a16:creationId xmlns:a16="http://schemas.microsoft.com/office/drawing/2014/main" id="{4110378D-0819-4B6A-AD54-411BA2F37EE9}"/>
               </a:ext>
             </a:extLst>
           </p:cNvPr>
@@ -28218,7 +27619,7 @@
           <p:cNvPr id="2" name="S09">
             <a:extLst xmlns:a="http://schemas.openxmlformats.org/drawingml/2006/main">
               <a:ext uri="{FF2B5EF4-FFF2-40B4-BE49-F238E27FC236}">
-                <a16:creationId xmlns:a16="http://schemas.microsoft.com/office/drawing/2014/main" id="{31B2FDD3-0E8D-4501-9F15-FD6F73B657A5}"/>
+                <a16:creationId xmlns:a16="http://schemas.microsoft.com/office/drawing/2014/main" id="{6F410E56-9FBA-48D4-B4D3-DBFC65C2056C}"/>
               </a:ext>
             </a:extLst>
           </p:cNvPr>
@@ -28376,7 +27777,7 @@
           <p:cNvPr id="3" name="Repository를 보면 내가 원하는 것까지 알까?">
             <a:extLst xmlns:a="http://schemas.openxmlformats.org/drawingml/2006/main">
               <a:ext uri="{FF2B5EF4-FFF2-40B4-BE49-F238E27FC236}">
-                <a16:creationId xmlns:a16="http://schemas.microsoft.com/office/drawing/2014/main" id="{4AADDDEB-FCD2-4C12-BDB9-6BA3743068D9}"/>
+                <a16:creationId xmlns:a16="http://schemas.microsoft.com/office/drawing/2014/main" id="{0EE21C5F-1F68-40FE-B709-6C3C1C7640EC}"/>
               </a:ext>
             </a:extLst>
           </p:cNvPr>
@@ -28534,7 +27935,7 @@
           <p:cNvPr id="4" name="">
             <a:extLst xmlns:a="http://schemas.openxmlformats.org/drawingml/2006/main">
               <a:ext uri="{FF2B5EF4-FFF2-40B4-BE49-F238E27FC236}">
-                <a16:creationId xmlns:a16="http://schemas.microsoft.com/office/drawing/2014/main" id="{CAD60898-055D-46F2-90AA-B8479D266EA2}"/>
+                <a16:creationId xmlns:a16="http://schemas.microsoft.com/office/drawing/2014/main" id="{9E8D6EA4-A8E9-4004-B97E-E3C48686C750}"/>
               </a:ext>
             </a:extLst>
           </p:cNvPr>
@@ -28565,7 +27966,7 @@
           <p:cNvPr id="5" name="함께 생각해 보기 · 교육 모델">
             <a:extLst xmlns:a="http://schemas.openxmlformats.org/drawingml/2006/main">
               <a:ext uri="{FF2B5EF4-FFF2-40B4-BE49-F238E27FC236}">
-                <a16:creationId xmlns:a16="http://schemas.microsoft.com/office/drawing/2014/main" id="{C8D3E784-C8E2-42A9-9910-A7EBEB0070D4}"/>
+                <a16:creationId xmlns:a16="http://schemas.microsoft.com/office/drawing/2014/main" id="{38F2D000-33AD-4F1D-8C88-854667B5F97E}"/>
               </a:ext>
             </a:extLst>
           </p:cNvPr>
@@ -28723,7 +28124,7 @@
           <p:cNvPr id="6" name="현재 맡기고 싶은 일을 떠올려 보세요. 질문과 경험 공유는 자발적으로 진행합니다.">
             <a:extLst xmlns:a="http://schemas.openxmlformats.org/drawingml/2006/main">
               <a:ext uri="{FF2B5EF4-FFF2-40B4-BE49-F238E27FC236}">
-                <a16:creationId xmlns:a16="http://schemas.microsoft.com/office/drawing/2014/main" id="{711D75FD-E2C6-4668-B924-7A421A3B9B50}"/>
+                <a16:creationId xmlns:a16="http://schemas.microsoft.com/office/drawing/2014/main" id="{FFFABE36-7EE0-4299-8791-3EACD886F95A}"/>
               </a:ext>
             </a:extLst>
           </p:cNvPr>
@@ -28881,7 +28282,7 @@
           <p:cNvPr id="7" name="지금 이 저장소에&#10;어떤 일을 맡기고 싶으신가요?">
             <a:extLst xmlns:a="http://schemas.openxmlformats.org/drawingml/2006/main">
               <a:ext uri="{FF2B5EF4-FFF2-40B4-BE49-F238E27FC236}">
-                <a16:creationId xmlns:a16="http://schemas.microsoft.com/office/drawing/2014/main" id="{08D734E1-A595-4042-9023-C77786C8C6A5}"/>
+                <a16:creationId xmlns:a16="http://schemas.microsoft.com/office/drawing/2014/main" id="{E368DECD-EC4B-476F-A27D-46EFACB2F518}"/>
               </a:ext>
             </a:extLst>
           </p:cNvPr>
@@ -29062,7 +28463,7 @@
           <p:cNvPr id="8" name="?">
             <a:extLst xmlns:a="http://schemas.openxmlformats.org/drawingml/2006/main">
               <a:ext uri="{FF2B5EF4-FFF2-40B4-BE49-F238E27FC236}">
-                <a16:creationId xmlns:a16="http://schemas.microsoft.com/office/drawing/2014/main" id="{ADB4C4E6-5F5B-430B-9B31-D3C62F5F8DA2}"/>
+                <a16:creationId xmlns:a16="http://schemas.microsoft.com/office/drawing/2014/main" id="{3C1A6E4F-B4A2-4DC8-9DD2-187E546ED4D8}"/>
               </a:ext>
             </a:extLst>
           </p:cNvPr>
@@ -29220,7 +28621,7 @@
           <p:cNvPr id="9" name="">
             <a:extLst xmlns:a="http://schemas.openxmlformats.org/drawingml/2006/main">
               <a:ext uri="{FF2B5EF4-FFF2-40B4-BE49-F238E27FC236}">
-                <a16:creationId xmlns:a16="http://schemas.microsoft.com/office/drawing/2014/main" id="{5F1DB834-61D3-4381-A018-431CD5B121B1}"/>
+                <a16:creationId xmlns:a16="http://schemas.microsoft.com/office/drawing/2014/main" id="{FE6ECC70-592E-4656-BA0C-A0668993086A}"/>
               </a:ext>
             </a:extLst>
           </p:cNvPr>
@@ -29251,7 +28652,7 @@
           <p:cNvPr id="10" name="그 원하는 결과까지&#10;코드에 적혀 있을까요?">
             <a:extLst xmlns:a="http://schemas.openxmlformats.org/drawingml/2006/main">
               <a:ext uri="{FF2B5EF4-FFF2-40B4-BE49-F238E27FC236}">
-                <a16:creationId xmlns:a16="http://schemas.microsoft.com/office/drawing/2014/main" id="{1DC55DB4-D661-4650-ABCA-3DBABFAD99FC}"/>
+                <a16:creationId xmlns:a16="http://schemas.microsoft.com/office/drawing/2014/main" id="{13518D1C-7D8B-424E-BB0E-3080084A0DF0}"/>
               </a:ext>
             </a:extLst>
           </p:cNvPr>
@@ -29430,7 +28831,7 @@
     </p:spTree>
     <p:extLst>
       <p:ext uri="{BB962C8B-B14F-4D97-AF65-F5344CB8AC3E}">
-        <p14:creationId xmlns:p14="http://schemas.microsoft.com/office/powerpoint/2010/main" val="1127780549"/>
+        <p14:creationId xmlns:p14="http://schemas.microsoft.com/office/powerpoint/2010/main" val="754504573"/>
       </p:ext>
     </p:extLst>
   </p:cSld>

</xml_diff>

<commit_message>
feat(slides): complete approved image placements across deck
Make context collection, test scope, and repository evolution visible while
preserving the approved story and scoped evidence in the full deck.
</commit_message>
<xml_diff>
--- a/production/ACT_0.pptx
+++ b/production/ACT_0.pptx
@@ -2,21 +2,21 @@
 <file path=ppt/presentation.xml><?xml version="1.0" encoding="utf-8"?>
 <p:presentation xmlns:p="http://schemas.openxmlformats.org/presentationml/2006/main">
   <p:sldMasterIdLst>
-    <p:sldMasterId xmlns:r="http://schemas.openxmlformats.org/officeDocument/2006/relationships" id="2147483648" r:id="Rcfd6545bab244fac"/>
+    <p:sldMasterId xmlns:r="http://schemas.openxmlformats.org/officeDocument/2006/relationships" id="2147483648" r:id="Rbde8ed4e0f7e4171"/>
   </p:sldMasterIdLst>
   <p:notesMasterIdLst>
-    <p:notesMasterId xmlns:r="http://schemas.openxmlformats.org/officeDocument/2006/relationships" r:id="R350057a401cd4097"/>
+    <p:notesMasterId xmlns:r="http://schemas.openxmlformats.org/officeDocument/2006/relationships" r:id="R7890dc169501488c"/>
   </p:notesMasterIdLst>
   <p:sldIdLst>
-    <p:sldId xmlns:r="http://schemas.openxmlformats.org/officeDocument/2006/relationships" id="256" r:id="R8aa5610ce38e47a7"/>
-    <p:sldId xmlns:r="http://schemas.openxmlformats.org/officeDocument/2006/relationships" id="257" r:id="Rc8664a6622f84cc2"/>
-    <p:sldId xmlns:r="http://schemas.openxmlformats.org/officeDocument/2006/relationships" id="258" r:id="R3307bd078a3b4b3d"/>
-    <p:sldId xmlns:r="http://schemas.openxmlformats.org/officeDocument/2006/relationships" id="259" r:id="R2742a3743ca94081"/>
-    <p:sldId xmlns:r="http://schemas.openxmlformats.org/officeDocument/2006/relationships" id="260" r:id="Rf6b8b11adf524050"/>
-    <p:sldId xmlns:r="http://schemas.openxmlformats.org/officeDocument/2006/relationships" id="261" r:id="R02b04352c9514a53"/>
-    <p:sldId xmlns:r="http://schemas.openxmlformats.org/officeDocument/2006/relationships" id="262" r:id="R88fd7c0275744020"/>
-    <p:sldId xmlns:r="http://schemas.openxmlformats.org/officeDocument/2006/relationships" id="263" r:id="R720eb58830fb4207"/>
-    <p:sldId xmlns:r="http://schemas.openxmlformats.org/officeDocument/2006/relationships" id="264" r:id="Rd0f438ce06e842fc"/>
+    <p:sldId xmlns:r="http://schemas.openxmlformats.org/officeDocument/2006/relationships" id="256" r:id="Rcf54a016f06f409c"/>
+    <p:sldId xmlns:r="http://schemas.openxmlformats.org/officeDocument/2006/relationships" id="257" r:id="R066b0f0225a843ae"/>
+    <p:sldId xmlns:r="http://schemas.openxmlformats.org/officeDocument/2006/relationships" id="258" r:id="R03386f7911ee4a5c"/>
+    <p:sldId xmlns:r="http://schemas.openxmlformats.org/officeDocument/2006/relationships" id="259" r:id="R2f7d86f2eb934a6f"/>
+    <p:sldId xmlns:r="http://schemas.openxmlformats.org/officeDocument/2006/relationships" id="260" r:id="R8a2da33828c3498d"/>
+    <p:sldId xmlns:r="http://schemas.openxmlformats.org/officeDocument/2006/relationships" id="261" r:id="Rf58b438d8f4848fd"/>
+    <p:sldId xmlns:r="http://schemas.openxmlformats.org/officeDocument/2006/relationships" id="262" r:id="R219d7eb1d7704c80"/>
+    <p:sldId xmlns:r="http://schemas.openxmlformats.org/officeDocument/2006/relationships" id="263" r:id="R70ce4b244ce645c7"/>
+    <p:sldId xmlns:r="http://schemas.openxmlformats.org/officeDocument/2006/relationships" id="264" r:id="Rd0bd723886b348e4"/>
   </p:sldIdLst>
   <p:sldSz cx="12192000" cy="6858000"/>
   <p:notesSz cx="6858000" cy="9144000"/>
@@ -1100,7 +1100,7 @@
           </a:p>
           <a:p xmlns:a="http://schemas.openxmlformats.org/drawingml/2006/main">
             <a:r>
-              <a:t>2. **SHOW (1:00–2:30):** CLI → 처리 흐름 → 이미지 연산 관계를 따라간 뒤 아래의 테스트와 계약 질문을 짚는다. 실제 제품 호출 기록을 그대로 그린 화면이라고 하지 않는다.</a:t>
+              <a:t>2. **SHOW (1:00–2:30):** 사람이 여러 자료를 골라 모으는 삽화를 가리킨다. 오른쪽 구현·호출 경로(CLI → 처리 흐름 → 연산), 테스트, 계약의 세 질문을 차례로 짚는다. 실제 제품 호출 기록을 그대로 그린 화면이라고 하지 않는다.</a:t>
             </a:r>
           </a:p>
           <a:p xmlns:a="http://schemas.openxmlformats.org/drawingml/2006/main">
@@ -1115,7 +1115,7 @@
           </a:p>
           <a:p xmlns:a="http://schemas.openxmlformats.org/drawingml/2006/main">
             <a:r>
-              <a:t>Evidence / Source: BEAT-002, CLM-0004, CLM-0009. TEACHING_MODEL / CONCEPTUAL.</a:t>
+              <a:t>Evidence / Source: BEAT-002, CLM-0004, CLM-0009. TEACHING_MODEL / CONCEPTUAL. 삽화: assets/slide-illustrations/S03-context-collection.png, built-in image_gen, 2026-10-18. 생성 프롬프트: assets/slide-illustrations/PROMPTS.md. 실제 인물·작업 장면·제품 실행 자료가 아니다.</a:t>
             </a:r>
           </a:p>
           <a:p xmlns:a="http://schemas.openxmlformats.org/drawingml/2006/main">
@@ -1205,7 +1205,7 @@
           </a:p>
           <a:p xmlns:a="http://schemas.openxmlformats.org/drawingml/2006/main">
             <a:r>
-              <a:t>Fallback: 도식이 보이지 않으면 CLI 입력, 처리 흐름, 연산 구현의 세 관계와 테스트·계약 질문을 말로 연결한다. 이 사례를 특정 Trial의 실제 실패로 표현하지 않는다.</a:t>
+              <a:t>Fallback: production/preview/full/S03.png 또는 production/preview/act0/S03.png를 사용한다. 삽화가 보이지 않으면 CLI 입력, 처리 흐름, 연산 구현의 세 관계와 테스트·계약 질문을 말로 연결한다. 이 사례를 특정 Trial의 실제 실패로 표현하지 않는다.</a:t>
             </a:r>
           </a:p>
           <a:p xmlns:a="http://schemas.openxmlformats.org/drawingml/2006/main">
@@ -1215,7 +1215,7 @@
           </a:p>
           <a:p xmlns:a="http://schemas.openxmlformats.org/drawingml/2006/main">
             <a:r>
-              <a:t>Validation Status: REVIEWED — 원문·Claim 경계, 화면의 설명 순서와 운영 지침을 대조했다. 최종 PPT/Notes/PNG 대조 결과는 production/evaluation/FULL_DECK_PRESENTATION_REVISION.md에 기록한다. Windows PowerPoint, 발표 PC 글꼴, 교육장 투사, 실제 시간 리허설은 UNVERIFIED.</a:t>
+              <a:t>Validation Status: REVIEWED — 승인된 전체 이미지 후보의 반영과 로컬 렌더링 결과는 production/evaluation/FULL_DECK_IMAGE_EXPANSION.md에 기록한다. Windows PowerPoint, 발표 PC 글꼴, 교육장 투사, 실제 시간 리허설은 UNVERIFIED.</a:t>
             </a:r>
           </a:p>
         </p:txBody>
@@ -2952,7 +2952,7 @@
           <p:cNvPr id="3" name="Title">
             <a:extLst xmlns:a="http://schemas.openxmlformats.org/drawingml/2006/main">
               <a:ext uri="{FF2B5EF4-FFF2-40B4-BE49-F238E27FC236}">
-                <a16:creationId xmlns:a16="http://schemas.microsoft.com/office/drawing/2014/main" id="{94110EEA-940A-4AD2-BBE7-968E0EF24364}"/>
+                <a16:creationId xmlns:a16="http://schemas.microsoft.com/office/drawing/2014/main" id="{6B42B9B9-C82D-43A2-821F-7D81F4AABFDF}"/>
               </a:ext>
             </a:extLst>
           </p:cNvPr>
@@ -3181,7 +3181,7 @@
           <p:cNvPr id="2" name="Subtitle">
             <a:extLst xmlns:a="http://schemas.openxmlformats.org/drawingml/2006/main">
               <a:ext uri="{FF2B5EF4-FFF2-40B4-BE49-F238E27FC236}">
-                <a16:creationId xmlns:a16="http://schemas.microsoft.com/office/drawing/2014/main" id="{7FA1BB11-8B66-49D0-BE34-290F1A19EFD3}"/>
+                <a16:creationId xmlns:a16="http://schemas.microsoft.com/office/drawing/2014/main" id="{8F0D60A5-81DF-46A3-ACC4-4098114035BA}"/>
               </a:ext>
             </a:extLst>
           </p:cNvPr>
@@ -3427,7 +3427,7 @@
           <p:cNvPr id="2" name="Section title">
             <a:extLst xmlns:a="http://schemas.openxmlformats.org/drawingml/2006/main">
               <a:ext uri="{FF2B5EF4-FFF2-40B4-BE49-F238E27FC236}">
-                <a16:creationId xmlns:a16="http://schemas.microsoft.com/office/drawing/2014/main" id="{AB2C153A-C5DF-40FF-8852-848EDDCBEFF7}"/>
+                <a16:creationId xmlns:a16="http://schemas.microsoft.com/office/drawing/2014/main" id="{C0088B39-ED82-4D4B-94E3-0F64D32EEFEF}"/>
               </a:ext>
             </a:extLst>
           </p:cNvPr>
@@ -3673,7 +3673,7 @@
           <p:cNvPr id="3" name="Title">
             <a:extLst xmlns:a="http://schemas.openxmlformats.org/drawingml/2006/main">
               <a:ext uri="{FF2B5EF4-FFF2-40B4-BE49-F238E27FC236}">
-                <a16:creationId xmlns:a16="http://schemas.microsoft.com/office/drawing/2014/main" id="{6F7D2F4B-5F3F-4C2E-8BD9-81D76AD7834A}"/>
+                <a16:creationId xmlns:a16="http://schemas.microsoft.com/office/drawing/2014/main" id="{F47E57A8-D696-44C5-87AD-06CCC6A0F8BE}"/>
               </a:ext>
             </a:extLst>
           </p:cNvPr>
@@ -3902,7 +3902,7 @@
           <p:cNvPr id="2" name="Body">
             <a:extLst xmlns:a="http://schemas.openxmlformats.org/drawingml/2006/main">
               <a:ext uri="{FF2B5EF4-FFF2-40B4-BE49-F238E27FC236}">
-                <a16:creationId xmlns:a16="http://schemas.microsoft.com/office/drawing/2014/main" id="{EDA97300-1F49-4EA0-AE6B-264659C21BD9}"/>
+                <a16:creationId xmlns:a16="http://schemas.microsoft.com/office/drawing/2014/main" id="{BD11460E-7EDE-4DC4-B245-E5D286D75594}"/>
               </a:ext>
             </a:extLst>
           </p:cNvPr>
@@ -4148,7 +4148,7 @@
           <p:cNvPr id="4" name="Title">
             <a:extLst xmlns:a="http://schemas.openxmlformats.org/drawingml/2006/main">
               <a:ext uri="{FF2B5EF4-FFF2-40B4-BE49-F238E27FC236}">
-                <a16:creationId xmlns:a16="http://schemas.microsoft.com/office/drawing/2014/main" id="{EAFD4979-0372-49B7-A350-B633B5F69312}"/>
+                <a16:creationId xmlns:a16="http://schemas.microsoft.com/office/drawing/2014/main" id="{E276F02D-0E41-4A79-9B25-D94FC6D9810C}"/>
               </a:ext>
             </a:extLst>
           </p:cNvPr>
@@ -4377,7 +4377,7 @@
           <p:cNvPr id="2" name="Left column">
             <a:extLst xmlns:a="http://schemas.openxmlformats.org/drawingml/2006/main">
               <a:ext uri="{FF2B5EF4-FFF2-40B4-BE49-F238E27FC236}">
-                <a16:creationId xmlns:a16="http://schemas.microsoft.com/office/drawing/2014/main" id="{86E7BFDC-6B98-4669-9567-B7C8FDE753A7}"/>
+                <a16:creationId xmlns:a16="http://schemas.microsoft.com/office/drawing/2014/main" id="{71CD0E1A-3D9F-46B7-A1AE-D35468F2FC53}"/>
               </a:ext>
             </a:extLst>
           </p:cNvPr>
@@ -4606,7 +4606,7 @@
           <p:cNvPr id="3" name="Right column">
             <a:extLst xmlns:a="http://schemas.openxmlformats.org/drawingml/2006/main">
               <a:ext uri="{FF2B5EF4-FFF2-40B4-BE49-F238E27FC236}">
-                <a16:creationId xmlns:a16="http://schemas.microsoft.com/office/drawing/2014/main" id="{E36A8AF9-84CB-4594-8BEE-60A04A7591C5}"/>
+                <a16:creationId xmlns:a16="http://schemas.microsoft.com/office/drawing/2014/main" id="{1F769DE5-73BD-422E-857C-1C8DEE78146C}"/>
               </a:ext>
             </a:extLst>
           </p:cNvPr>
@@ -4852,7 +4852,7 @@
           <p:cNvPr id="3" name="Title">
             <a:extLst xmlns:a="http://schemas.openxmlformats.org/drawingml/2006/main">
               <a:ext uri="{FF2B5EF4-FFF2-40B4-BE49-F238E27FC236}">
-                <a16:creationId xmlns:a16="http://schemas.microsoft.com/office/drawing/2014/main" id="{1DC08E22-0AEB-43A5-A962-53D304376F3A}"/>
+                <a16:creationId xmlns:a16="http://schemas.microsoft.com/office/drawing/2014/main" id="{BC6D5CFF-C1F6-40A3-8CF2-EF8B8AC8FD33}"/>
               </a:ext>
             </a:extLst>
           </p:cNvPr>
@@ -5081,7 +5081,7 @@
           <p:cNvPr id="2" name="Left column">
             <a:extLst xmlns:a="http://schemas.openxmlformats.org/drawingml/2006/main">
               <a:ext uri="{FF2B5EF4-FFF2-40B4-BE49-F238E27FC236}">
-                <a16:creationId xmlns:a16="http://schemas.microsoft.com/office/drawing/2014/main" id="{950C57F3-BD06-4430-BC23-7BFAC09ACB12}"/>
+                <a16:creationId xmlns:a16="http://schemas.microsoft.com/office/drawing/2014/main" id="{F22C23BF-344B-40E8-8549-0018EBC5CBFF}"/>
               </a:ext>
             </a:extLst>
           </p:cNvPr>
@@ -5348,12 +5348,12 @@
   </p:cSld>
   <p:clrMap bg1="lt1" tx1="dk1" bg2="lt2" tx2="dk2" accent1="accent1" accent2="accent2" accent3="accent3" accent4="accent4" accent5="accent5" accent6="accent6" hlink="hlink" folHlink="folHlink"/>
   <p:sldLayoutIdLst>
-    <p:sldLayoutId xmlns:r="http://schemas.openxmlformats.org/officeDocument/2006/relationships" id="2147483649" r:id="Rb752b259b5e24bff"/>
-    <p:sldLayoutId xmlns:r="http://schemas.openxmlformats.org/officeDocument/2006/relationships" id="2147483650" r:id="R0705ceca7eac4600"/>
-    <p:sldLayoutId xmlns:r="http://schemas.openxmlformats.org/officeDocument/2006/relationships" id="2147483651" r:id="Rb61348a9444347e0"/>
-    <p:sldLayoutId xmlns:r="http://schemas.openxmlformats.org/officeDocument/2006/relationships" id="2147483652" r:id="Rb80442465c9846ba"/>
-    <p:sldLayoutId xmlns:r="http://schemas.openxmlformats.org/officeDocument/2006/relationships" id="2147483653" r:id="R1e1f8b93462c4dd7"/>
-    <p:sldLayoutId xmlns:r="http://schemas.openxmlformats.org/officeDocument/2006/relationships" id="2147483654" r:id="R0dc66cb90aed4f23"/>
+    <p:sldLayoutId xmlns:r="http://schemas.openxmlformats.org/officeDocument/2006/relationships" id="2147483649" r:id="R93f90dacae85418b"/>
+    <p:sldLayoutId xmlns:r="http://schemas.openxmlformats.org/officeDocument/2006/relationships" id="2147483650" r:id="R65e31a878c2446b0"/>
+    <p:sldLayoutId xmlns:r="http://schemas.openxmlformats.org/officeDocument/2006/relationships" id="2147483651" r:id="R3d6173e105c14914"/>
+    <p:sldLayoutId xmlns:r="http://schemas.openxmlformats.org/officeDocument/2006/relationships" id="2147483652" r:id="R78f48415b30c422e"/>
+    <p:sldLayoutId xmlns:r="http://schemas.openxmlformats.org/officeDocument/2006/relationships" id="2147483653" r:id="Rfd1580ee1c0c4d5a"/>
+    <p:sldLayoutId xmlns:r="http://schemas.openxmlformats.org/officeDocument/2006/relationships" id="2147483654" r:id="R5ab352659bdc46c8"/>
   </p:sldLayoutIdLst>
   <p:txStyles>
     <p:titleStyle>
@@ -5904,7 +5904,7 @@
           <p:cNvPr id="12" name="ACT 0 · 익숙한 사용에서 시작하기">
             <a:extLst xmlns:a="http://schemas.openxmlformats.org/drawingml/2006/main">
               <a:ext uri="{FF2B5EF4-FFF2-40B4-BE49-F238E27FC236}">
-                <a16:creationId xmlns:a16="http://schemas.microsoft.com/office/drawing/2014/main" id="{794B5716-827F-4FDA-9F7C-ECF6CE773359}"/>
+                <a16:creationId xmlns:a16="http://schemas.microsoft.com/office/drawing/2014/main" id="{7B1E21FB-939D-410B-A049-5EBB07770680}"/>
               </a:ext>
             </a:extLst>
           </p:cNvPr>
@@ -6062,7 +6062,7 @@
           <p:cNvPr id="2" name="S01">
             <a:extLst xmlns:a="http://schemas.openxmlformats.org/drawingml/2006/main">
               <a:ext uri="{FF2B5EF4-FFF2-40B4-BE49-F238E27FC236}">
-                <a16:creationId xmlns:a16="http://schemas.microsoft.com/office/drawing/2014/main" id="{2330EF03-A4D6-4625-A968-C24E56F042E1}"/>
+                <a16:creationId xmlns:a16="http://schemas.microsoft.com/office/drawing/2014/main" id="{0D500242-1780-453D-90F4-D89A4F369E84}"/>
               </a:ext>
             </a:extLst>
           </p:cNvPr>
@@ -6220,7 +6220,7 @@
           <p:cNvPr id="3" name="AI에게 지금 무엇을 맡기고 있는가?">
             <a:extLst xmlns:a="http://schemas.openxmlformats.org/drawingml/2006/main">
               <a:ext uri="{FF2B5EF4-FFF2-40B4-BE49-F238E27FC236}">
-                <a16:creationId xmlns:a16="http://schemas.microsoft.com/office/drawing/2014/main" id="{97302C9F-50E4-4822-AC83-CB89C3498065}"/>
+                <a16:creationId xmlns:a16="http://schemas.microsoft.com/office/drawing/2014/main" id="{CC1CBF9B-08A7-4A33-AF72-73EEAEA5954F}"/>
               </a:ext>
             </a:extLst>
           </p:cNvPr>
@@ -6378,7 +6378,7 @@
           <p:cNvPr id="4" name="">
             <a:extLst xmlns:a="http://schemas.openxmlformats.org/drawingml/2006/main">
               <a:ext uri="{FF2B5EF4-FFF2-40B4-BE49-F238E27FC236}">
-                <a16:creationId xmlns:a16="http://schemas.microsoft.com/office/drawing/2014/main" id="{31B379DF-65B3-40B9-8EB3-D094F89FEC8D}"/>
+                <a16:creationId xmlns:a16="http://schemas.microsoft.com/office/drawing/2014/main" id="{DCE81CDB-E407-4EFF-B2C7-36CFA13563B6}"/>
               </a:ext>
             </a:extLst>
           </p:cNvPr>
@@ -6409,7 +6409,7 @@
           <p:cNvPr id="5" name="생각해 보기 · 이 과정의 교육 모델">
             <a:extLst xmlns:a="http://schemas.openxmlformats.org/drawingml/2006/main">
               <a:ext uri="{FF2B5EF4-FFF2-40B4-BE49-F238E27FC236}">
-                <a16:creationId xmlns:a16="http://schemas.microsoft.com/office/drawing/2014/main" id="{B60C50D0-DC58-4AF3-A952-C6494D58A60B}"/>
+                <a16:creationId xmlns:a16="http://schemas.microsoft.com/office/drawing/2014/main" id="{0D34FB7E-372E-42C7-AC2C-CFBEB4990376}"/>
               </a:ext>
             </a:extLst>
           </p:cNvPr>
@@ -6567,7 +6567,7 @@
           <p:cNvPr id="6" name="자신의 경험 하나만 떠올려 보세요. 사용 수준을 평가하는 질문이 아닙니다.">
             <a:extLst xmlns:a="http://schemas.openxmlformats.org/drawingml/2006/main">
               <a:ext uri="{FF2B5EF4-FFF2-40B4-BE49-F238E27FC236}">
-                <a16:creationId xmlns:a16="http://schemas.microsoft.com/office/drawing/2014/main" id="{581A929F-54A3-438F-B150-6F2F1C173480}"/>
+                <a16:creationId xmlns:a16="http://schemas.microsoft.com/office/drawing/2014/main" id="{9A008C5B-CED9-4270-AF8B-7588D38BAB6C}"/>
               </a:ext>
             </a:extLst>
           </p:cNvPr>
@@ -6725,7 +6725,7 @@
           <p:cNvPr id="7" name="가장 최근에 AI에게 맡긴 일 하나">
             <a:extLst xmlns:a="http://schemas.openxmlformats.org/drawingml/2006/main">
               <a:ext uri="{FF2B5EF4-FFF2-40B4-BE49-F238E27FC236}">
-                <a16:creationId xmlns:a16="http://schemas.microsoft.com/office/drawing/2014/main" id="{51B5D4AC-28A6-4A21-A0B6-E744F7F3E040}"/>
+                <a16:creationId xmlns:a16="http://schemas.microsoft.com/office/drawing/2014/main" id="{BFDF4C03-67E6-4124-B5C0-9184571DD32D}"/>
               </a:ext>
             </a:extLst>
           </p:cNvPr>
@@ -6883,7 +6883,7 @@
           <p:cNvPr id="8" name="오류 설명을 들었나요?&#10;관련 코드를 조사하게 했나요?&#10;수정한 결과까지 확인하게 했나요?">
             <a:extLst xmlns:a="http://schemas.openxmlformats.org/drawingml/2006/main">
               <a:ext uri="{FF2B5EF4-FFF2-40B4-BE49-F238E27FC236}">
-                <a16:creationId xmlns:a16="http://schemas.microsoft.com/office/drawing/2014/main" id="{79C38499-9C13-4711-AF29-3AF8CD9166AB}"/>
+                <a16:creationId xmlns:a16="http://schemas.microsoft.com/office/drawing/2014/main" id="{81DE875A-2B17-446A-A771-528D6FBCADD1}"/>
               </a:ext>
             </a:extLst>
           </p:cNvPr>
@@ -7087,7 +7087,7 @@
           <p:cNvPr id="9" name="">
             <a:extLst xmlns:a="http://schemas.openxmlformats.org/drawingml/2006/main">
               <a:ext uri="{FF2B5EF4-FFF2-40B4-BE49-F238E27FC236}">
-                <a16:creationId xmlns:a16="http://schemas.microsoft.com/office/drawing/2014/main" id="{7FFA8CE1-DF2E-4C54-BBF0-E731A658DA0B}"/>
+                <a16:creationId xmlns:a16="http://schemas.microsoft.com/office/drawing/2014/main" id="{D18049FF-B0B5-4967-9F49-47401D53DBB7}"/>
               </a:ext>
             </a:extLst>
           </p:cNvPr>
@@ -7118,7 +7118,7 @@
           <p:cNvPr id="10" name="질문 · 생성&#10;조사 · 변경&#10;검증 · 작업 방식 개선">
             <a:extLst xmlns:a="http://schemas.openxmlformats.org/drawingml/2006/main">
               <a:ext uri="{FF2B5EF4-FFF2-40B4-BE49-F238E27FC236}">
-                <a16:creationId xmlns:a16="http://schemas.microsoft.com/office/drawing/2014/main" id="{8E5FD42F-9A0D-4175-A752-3EC9BAEDC141}"/>
+                <a16:creationId xmlns:a16="http://schemas.microsoft.com/office/drawing/2014/main" id="{7C988389-38EE-4E13-8F6C-4ADB0A599CAB}"/>
               </a:ext>
             </a:extLst>
           </p:cNvPr>
@@ -7322,7 +7322,7 @@
           <p:cNvPr id="11" name="익숙한 방식에서 출발해도 괜찮습니다.">
             <a:extLst xmlns:a="http://schemas.openxmlformats.org/drawingml/2006/main">
               <a:ext uri="{FF2B5EF4-FFF2-40B4-BE49-F238E27FC236}">
-                <a16:creationId xmlns:a16="http://schemas.microsoft.com/office/drawing/2014/main" id="{2DC890F4-E3B1-4B31-90EA-6763310B9F5C}"/>
+                <a16:creationId xmlns:a16="http://schemas.microsoft.com/office/drawing/2014/main" id="{4CE2BEF0-86B7-4F89-8CEC-B93952B42BE5}"/>
               </a:ext>
             </a:extLst>
           </p:cNvPr>
@@ -7478,7 +7478,7 @@
     </p:spTree>
     <p:extLst>
       <p:ext uri="{BB962C8B-B14F-4D97-AF65-F5344CB8AC3E}">
-        <p14:creationId xmlns:p14="http://schemas.microsoft.com/office/powerpoint/2010/main" val="290401250"/>
+        <p14:creationId xmlns:p14="http://schemas.microsoft.com/office/powerpoint/2010/main" val="738171509"/>
       </p:ext>
     </p:extLst>
   </p:cSld>
@@ -7509,7 +7509,7 @@
           <p:cNvPr id="23" name="ACT 0 · 작은 코드 질문">
             <a:extLst xmlns:a="http://schemas.openxmlformats.org/drawingml/2006/main">
               <a:ext uri="{FF2B5EF4-FFF2-40B4-BE49-F238E27FC236}">
-                <a16:creationId xmlns:a16="http://schemas.microsoft.com/office/drawing/2014/main" id="{55A384A2-849B-4D39-9B4D-D609DC471474}"/>
+                <a16:creationId xmlns:a16="http://schemas.microsoft.com/office/drawing/2014/main" id="{EBA624AF-013A-4756-AD03-A080891D9D3B}"/>
               </a:ext>
             </a:extLst>
           </p:cNvPr>
@@ -7667,7 +7667,7 @@
           <p:cNvPr id="2" name="S02">
             <a:extLst xmlns:a="http://schemas.openxmlformats.org/drawingml/2006/main">
               <a:ext uri="{FF2B5EF4-FFF2-40B4-BE49-F238E27FC236}">
-                <a16:creationId xmlns:a16="http://schemas.microsoft.com/office/drawing/2014/main" id="{28F0E739-6A89-4667-A373-FEA4D4C27D74}"/>
+                <a16:creationId xmlns:a16="http://schemas.microsoft.com/office/drawing/2014/main" id="{300256B8-EF47-4BE8-AE70-1F0830290B13}"/>
               </a:ext>
             </a:extLst>
           </p:cNvPr>
@@ -7825,7 +7825,7 @@
           <p:cNvPr id="3" name="작은 질문에는 Chatbot이 유용하다">
             <a:extLst xmlns:a="http://schemas.openxmlformats.org/drawingml/2006/main">
               <a:ext uri="{FF2B5EF4-FFF2-40B4-BE49-F238E27FC236}">
-                <a16:creationId xmlns:a16="http://schemas.microsoft.com/office/drawing/2014/main" id="{B8F20E60-BFC1-4F07-B6B5-2A10CDD04338}"/>
+                <a16:creationId xmlns:a16="http://schemas.microsoft.com/office/drawing/2014/main" id="{CE8DD933-7BF0-4D3C-9EE1-FC9FE1B6FD74}"/>
               </a:ext>
             </a:extLst>
           </p:cNvPr>
@@ -7983,7 +7983,7 @@
           <p:cNvPr id="4" name="">
             <a:extLst xmlns:a="http://schemas.openxmlformats.org/drawingml/2006/main">
               <a:ext uri="{FF2B5EF4-FFF2-40B4-BE49-F238E27FC236}">
-                <a16:creationId xmlns:a16="http://schemas.microsoft.com/office/drawing/2014/main" id="{60077921-AFDD-4307-8D19-2408BC8A2947}"/>
+                <a16:creationId xmlns:a16="http://schemas.microsoft.com/office/drawing/2014/main" id="{B4D3C240-DD10-4B3E-8CC2-990C4B81D370}"/>
               </a:ext>
             </a:extLst>
           </p:cNvPr>
@@ -8014,7 +8014,7 @@
           <p:cNvPr id="5" name="교육용 예시 · 실제 ChatGPT 대화 캡처가 아님">
             <a:extLst xmlns:a="http://schemas.openxmlformats.org/drawingml/2006/main">
               <a:ext uri="{FF2B5EF4-FFF2-40B4-BE49-F238E27FC236}">
-                <a16:creationId xmlns:a16="http://schemas.microsoft.com/office/drawing/2014/main" id="{A89D04C8-B19C-40B8-B0FB-99D659A29C52}"/>
+                <a16:creationId xmlns:a16="http://schemas.microsoft.com/office/drawing/2014/main" id="{FEC4FA66-2512-4CAA-8681-D0B6AB5FC100}"/>
               </a:ext>
             </a:extLst>
           </p:cNvPr>
@@ -8172,7 +8172,7 @@
           <p:cNvPr id="6" name="일반적인 질문 흐름을 설명하며 특정 제품의 정확도나 우월성을 주장하지 않습니다.">
             <a:extLst xmlns:a="http://schemas.openxmlformats.org/drawingml/2006/main">
               <a:ext uri="{FF2B5EF4-FFF2-40B4-BE49-F238E27FC236}">
-                <a16:creationId xmlns:a16="http://schemas.microsoft.com/office/drawing/2014/main" id="{0D7D3CB7-9180-4ACF-A35E-B1AC5982B5FA}"/>
+                <a16:creationId xmlns:a16="http://schemas.microsoft.com/office/drawing/2014/main" id="{1108AAD9-1002-401B-8A6C-C324793A0F32}"/>
               </a:ext>
             </a:extLst>
           </p:cNvPr>
@@ -8330,7 +8330,7 @@
           <p:cNvPr id="7" name="“이 코드에서 무엇이 남을까?”">
             <a:extLst xmlns:a="http://schemas.openxmlformats.org/drawingml/2006/main">
               <a:ext uri="{FF2B5EF4-FFF2-40B4-BE49-F238E27FC236}">
-                <a16:creationId xmlns:a16="http://schemas.microsoft.com/office/drawing/2014/main" id="{6BA89199-33BE-4A2A-AC25-D055D0D67900}"/>
+                <a16:creationId xmlns:a16="http://schemas.microsoft.com/office/drawing/2014/main" id="{FE88DCBA-D5A2-40E8-AF01-78E57EF3CE1B}"/>
               </a:ext>
             </a:extLst>
           </p:cNvPr>
@@ -8488,7 +8488,7 @@
           <p:cNvPr id="8" name="">
             <a:extLst xmlns:a="http://schemas.openxmlformats.org/drawingml/2006/main">
               <a:ext uri="{FF2B5EF4-FFF2-40B4-BE49-F238E27FC236}">
-                <a16:creationId xmlns:a16="http://schemas.microsoft.com/office/drawing/2014/main" id="{40C40B88-24A0-4D1C-8F90-8A4DB51FB187}"/>
+                <a16:creationId xmlns:a16="http://schemas.microsoft.com/office/drawing/2014/main" id="{6531F4FA-6278-46C9-896D-3314A8CAFA53}"/>
               </a:ext>
             </a:extLst>
           </p:cNvPr>
@@ -8519,7 +8519,7 @@
           <p:cNvPr id="9" name="row = [1, 2, 3, 4]&#10;row[1:3]">
             <a:extLst xmlns:a="http://schemas.openxmlformats.org/drawingml/2006/main">
               <a:ext uri="{FF2B5EF4-FFF2-40B4-BE49-F238E27FC236}">
-                <a16:creationId xmlns:a16="http://schemas.microsoft.com/office/drawing/2014/main" id="{DF82A4D6-4358-4B10-ABFC-B82CF68A5AA2}"/>
+                <a16:creationId xmlns:a16="http://schemas.microsoft.com/office/drawing/2014/main" id="{66DFF1C4-6EE1-46F7-B8E0-996B80CD33FA}"/>
               </a:ext>
             </a:extLst>
           </p:cNvPr>
@@ -8700,7 +8700,7 @@
           <p:cNvPr id="10" name="">
             <a:extLst xmlns:a="http://schemas.openxmlformats.org/drawingml/2006/main">
               <a:ext uri="{FF2B5EF4-FFF2-40B4-BE49-F238E27FC236}">
-                <a16:creationId xmlns:a16="http://schemas.microsoft.com/office/drawing/2014/main" id="{A10D5A97-2A13-4A4D-B763-9EAB7B80B770}"/>
+                <a16:creationId xmlns:a16="http://schemas.microsoft.com/office/drawing/2014/main" id="{7201C793-D2BB-4E9A-8193-DE4B0A7CF676}"/>
               </a:ext>
             </a:extLst>
           </p:cNvPr>
@@ -8730,7 +8730,7 @@
           <p:cNvPr id="11" name="[2, 3]">
             <a:extLst xmlns:a="http://schemas.openxmlformats.org/drawingml/2006/main">
               <a:ext uri="{FF2B5EF4-FFF2-40B4-BE49-F238E27FC236}">
-                <a16:creationId xmlns:a16="http://schemas.microsoft.com/office/drawing/2014/main" id="{B6D3240D-7C45-4554-9EF2-D5919991F953}"/>
+                <a16:creationId xmlns:a16="http://schemas.microsoft.com/office/drawing/2014/main" id="{91A883A1-2325-40D9-8E01-A7CF02BE6DF5}"/>
               </a:ext>
             </a:extLst>
           </p:cNvPr>
@@ -8888,7 +8888,7 @@
           <p:cNvPr id="12" name="끝 index 3은 포함하지 않습니다.">
             <a:extLst xmlns:a="http://schemas.openxmlformats.org/drawingml/2006/main">
               <a:ext uri="{FF2B5EF4-FFF2-40B4-BE49-F238E27FC236}">
-                <a16:creationId xmlns:a16="http://schemas.microsoft.com/office/drawing/2014/main" id="{D14B5AF2-D564-4C9B-A3FA-92250A79EF8C}"/>
+                <a16:creationId xmlns:a16="http://schemas.microsoft.com/office/drawing/2014/main" id="{68FC4D55-140C-4010-BC8F-99BDBA754429}"/>
               </a:ext>
             </a:extLst>
           </p:cNvPr>
@@ -9046,7 +9046,7 @@
           <p:cNvPr id="13" name="코드·오류">
             <a:extLst xmlns:a="http://schemas.openxmlformats.org/drawingml/2006/main">
               <a:ext uri="{FF2B5EF4-FFF2-40B4-BE49-F238E27FC236}">
-                <a16:creationId xmlns:a16="http://schemas.microsoft.com/office/drawing/2014/main" id="{4A9F775C-7F12-4773-8AFF-911AA6FF2EF7}"/>
+                <a16:creationId xmlns:a16="http://schemas.microsoft.com/office/drawing/2014/main" id="{64202124-A1E8-482B-8BFD-8F99E90183BD}"/>
               </a:ext>
             </a:extLst>
           </p:cNvPr>
@@ -9204,7 +9204,7 @@
           <p:cNvPr id="14" name="">
             <a:extLst xmlns:a="http://schemas.openxmlformats.org/drawingml/2006/main">
               <a:ext uri="{FF2B5EF4-FFF2-40B4-BE49-F238E27FC236}">
-                <a16:creationId xmlns:a16="http://schemas.microsoft.com/office/drawing/2014/main" id="{B9E4DD11-52B4-4868-BB8B-49AEC113667A}"/>
+                <a16:creationId xmlns:a16="http://schemas.microsoft.com/office/drawing/2014/main" id="{7804D775-6FA6-4A82-96E4-19E16D080016}"/>
               </a:ext>
             </a:extLst>
           </p:cNvPr>
@@ -9234,7 +9234,7 @@
           <p:cNvPr id="15" name="복사">
             <a:extLst xmlns:a="http://schemas.openxmlformats.org/drawingml/2006/main">
               <a:ext uri="{FF2B5EF4-FFF2-40B4-BE49-F238E27FC236}">
-                <a16:creationId xmlns:a16="http://schemas.microsoft.com/office/drawing/2014/main" id="{2D64D5A7-B267-425A-B017-EA76F4F2B37C}"/>
+                <a16:creationId xmlns:a16="http://schemas.microsoft.com/office/drawing/2014/main" id="{D7283F99-3CA7-475A-9EC9-846ABF375AAF}"/>
               </a:ext>
             </a:extLst>
           </p:cNvPr>
@@ -9392,7 +9392,7 @@
           <p:cNvPr id="16" name="">
             <a:extLst xmlns:a="http://schemas.openxmlformats.org/drawingml/2006/main">
               <a:ext uri="{FF2B5EF4-FFF2-40B4-BE49-F238E27FC236}">
-                <a16:creationId xmlns:a16="http://schemas.microsoft.com/office/drawing/2014/main" id="{551080FC-4440-483F-A120-81F1FD82F825}"/>
+                <a16:creationId xmlns:a16="http://schemas.microsoft.com/office/drawing/2014/main" id="{5389E282-C107-4BFF-9033-4A75BA7BE998}"/>
               </a:ext>
             </a:extLst>
           </p:cNvPr>
@@ -9422,7 +9422,7 @@
           <p:cNvPr id="17" name="질문">
             <a:extLst xmlns:a="http://schemas.openxmlformats.org/drawingml/2006/main">
               <a:ext uri="{FF2B5EF4-FFF2-40B4-BE49-F238E27FC236}">
-                <a16:creationId xmlns:a16="http://schemas.microsoft.com/office/drawing/2014/main" id="{6531BE24-4005-48B4-9464-E4B7195C1605}"/>
+                <a16:creationId xmlns:a16="http://schemas.microsoft.com/office/drawing/2014/main" id="{6B2E9E8D-2F96-4674-BCA0-AF9CA481918E}"/>
               </a:ext>
             </a:extLst>
           </p:cNvPr>
@@ -9580,7 +9580,7 @@
           <p:cNvPr id="18" name="">
             <a:extLst xmlns:a="http://schemas.openxmlformats.org/drawingml/2006/main">
               <a:ext uri="{FF2B5EF4-FFF2-40B4-BE49-F238E27FC236}">
-                <a16:creationId xmlns:a16="http://schemas.microsoft.com/office/drawing/2014/main" id="{F9AA33F4-7ED8-4BE1-A09C-125560393EE3}"/>
+                <a16:creationId xmlns:a16="http://schemas.microsoft.com/office/drawing/2014/main" id="{2C15C240-2FB3-4250-BE29-83B6DD1484F1}"/>
               </a:ext>
             </a:extLst>
           </p:cNvPr>
@@ -9610,7 +9610,7 @@
           <p:cNvPr id="19" name="답 확인">
             <a:extLst xmlns:a="http://schemas.openxmlformats.org/drawingml/2006/main">
               <a:ext uri="{FF2B5EF4-FFF2-40B4-BE49-F238E27FC236}">
-                <a16:creationId xmlns:a16="http://schemas.microsoft.com/office/drawing/2014/main" id="{50F9C3C0-90FB-4D54-9396-550C408B278B}"/>
+                <a16:creationId xmlns:a16="http://schemas.microsoft.com/office/drawing/2014/main" id="{66E122F9-68C5-418E-BF85-06AD3DD35C2A}"/>
               </a:ext>
             </a:extLst>
           </p:cNvPr>
@@ -9768,7 +9768,7 @@
           <p:cNvPr id="20" name="">
             <a:extLst xmlns:a="http://schemas.openxmlformats.org/drawingml/2006/main">
               <a:ext uri="{FF2B5EF4-FFF2-40B4-BE49-F238E27FC236}">
-                <a16:creationId xmlns:a16="http://schemas.microsoft.com/office/drawing/2014/main" id="{1D78FEF0-DC4C-48D6-AE0C-155FA355F85B}"/>
+                <a16:creationId xmlns:a16="http://schemas.microsoft.com/office/drawing/2014/main" id="{F79E3DF2-2854-4C1E-BDF5-5F6FFFEED77C}"/>
               </a:ext>
             </a:extLst>
           </p:cNvPr>
@@ -9798,7 +9798,7 @@
           <p:cNvPr id="21" name="IDE로 복귀">
             <a:extLst xmlns:a="http://schemas.openxmlformats.org/drawingml/2006/main">
               <a:ext uri="{FF2B5EF4-FFF2-40B4-BE49-F238E27FC236}">
-                <a16:creationId xmlns:a16="http://schemas.microsoft.com/office/drawing/2014/main" id="{D1457468-9A74-4A54-8EFF-336E645FEFBA}"/>
+                <a16:creationId xmlns:a16="http://schemas.microsoft.com/office/drawing/2014/main" id="{FDB5D05A-8A76-4CB8-93DE-1F567C8183E3}"/>
               </a:ext>
             </a:extLst>
           </p:cNvPr>
@@ -9956,7 +9956,7 @@
           <p:cNvPr id="22" name="">
             <a:extLst xmlns:a="http://schemas.openxmlformats.org/drawingml/2006/main">
               <a:ext uri="{FF2B5EF4-FFF2-40B4-BE49-F238E27FC236}">
-                <a16:creationId xmlns:a16="http://schemas.microsoft.com/office/drawing/2014/main" id="{31A1B519-7DDA-4D1B-8F45-C8384A666540}"/>
+                <a16:creationId xmlns:a16="http://schemas.microsoft.com/office/drawing/2014/main" id="{92E589A4-FE4E-4C69-8B20-8CC8EB424B2B}"/>
               </a:ext>
             </a:extLst>
           </p:cNvPr>
@@ -9985,7 +9985,7 @@
     </p:spTree>
     <p:extLst>
       <p:ext uri="{BB962C8B-B14F-4D97-AF65-F5344CB8AC3E}">
-        <p14:creationId xmlns:p14="http://schemas.microsoft.com/office/powerpoint/2010/main" val="75978775"/>
+        <p14:creationId xmlns:p14="http://schemas.microsoft.com/office/powerpoint/2010/main" val="781278197"/>
       </p:ext>
     </p:extLst>
   </p:cSld>
@@ -10013,10 +10013,10 @@
       </p:grpSpPr>
       <p:sp>
         <p:nvSpPr>
-          <p:cNvPr id="24" name="ACT 0 · 여러 파일을 가로지르는 질문">
+          <p:cNvPr id="16" name="ACT 0 · 여러 파일을 가로지르는 질문">
             <a:extLst xmlns:a="http://schemas.openxmlformats.org/drawingml/2006/main">
               <a:ext uri="{FF2B5EF4-FFF2-40B4-BE49-F238E27FC236}">
-                <a16:creationId xmlns:a16="http://schemas.microsoft.com/office/drawing/2014/main" id="{6EF967D4-6E49-4D0B-894B-1C696D2560D5}"/>
+                <a16:creationId xmlns:a16="http://schemas.microsoft.com/office/drawing/2014/main" id="{8C879627-BB46-4FBD-80BD-EA04F24602AE}"/>
               </a:ext>
             </a:extLst>
           </p:cNvPr>
@@ -10174,7 +10174,7 @@
           <p:cNvPr id="2" name="S03">
             <a:extLst xmlns:a="http://schemas.openxmlformats.org/drawingml/2006/main">
               <a:ext uri="{FF2B5EF4-FFF2-40B4-BE49-F238E27FC236}">
-                <a16:creationId xmlns:a16="http://schemas.microsoft.com/office/drawing/2014/main" id="{F735BAD6-3051-4CDA-BEC7-1303F9995D5D}"/>
+                <a16:creationId xmlns:a16="http://schemas.microsoft.com/office/drawing/2014/main" id="{746155A7-8827-485B-A89A-8B05D7133DE2}"/>
               </a:ext>
             </a:extLst>
           </p:cNvPr>
@@ -10332,7 +10332,7 @@
           <p:cNvPr id="3" name="질문이 커지면 Context를 모으는 일이 생긴다">
             <a:extLst xmlns:a="http://schemas.openxmlformats.org/drawingml/2006/main">
               <a:ext uri="{FF2B5EF4-FFF2-40B4-BE49-F238E27FC236}">
-                <a16:creationId xmlns:a16="http://schemas.microsoft.com/office/drawing/2014/main" id="{4803C8E1-FBA3-4300-87B7-DDDCA44A62C2}"/>
+                <a16:creationId xmlns:a16="http://schemas.microsoft.com/office/drawing/2014/main" id="{D0DEF59A-DFB3-45FD-8F43-903F19418367}"/>
               </a:ext>
             </a:extLst>
           </p:cNvPr>
@@ -10490,7 +10490,7 @@
           <p:cNvPr id="4" name="">
             <a:extLst xmlns:a="http://schemas.openxmlformats.org/drawingml/2006/main">
               <a:ext uri="{FF2B5EF4-FFF2-40B4-BE49-F238E27FC236}">
-                <a16:creationId xmlns:a16="http://schemas.microsoft.com/office/drawing/2014/main" id="{E75CC2B1-A7CB-4B07-BDA8-D72076B620E0}"/>
+                <a16:creationId xmlns:a16="http://schemas.microsoft.com/office/drawing/2014/main" id="{D5FEF454-2656-4201-8446-E19C228B7C48}"/>
               </a:ext>
             </a:extLst>
           </p:cNvPr>
@@ -10518,10 +10518,10 @@
       </p:sp>
       <p:sp>
         <p:nvSpPr>
-          <p:cNvPr id="5" name="개념 사례 · Repository 수준의 질문을 설명하는 관계도">
+          <p:cNvPr id="5" name="개념 사례 · 사람이 Context를 모으는 장면 · AI 생성 설명용 삽화">
             <a:extLst xmlns:a="http://schemas.openxmlformats.org/drawingml/2006/main">
               <a:ext uri="{FF2B5EF4-FFF2-40B4-BE49-F238E27FC236}">
-                <a16:creationId xmlns:a16="http://schemas.microsoft.com/office/drawing/2014/main" id="{70BC8169-016A-4181-883C-BC235264E458}"/>
+                <a16:creationId xmlns:a16="http://schemas.microsoft.com/office/drawing/2014/main" id="{EFEF0493-FD3D-4594-9AF4-F77EFA167FE3}"/>
               </a:ext>
             </a:extLst>
           </p:cNvPr>
@@ -10669,7 +10669,7 @@
                 <a:ea typeface="Malgun Gothic"/>
                 <a:cs typeface="Malgun Gothic"/>
               </a:rPr>
-              <a:t>개념 사례 · Repository 수준의 질문을 설명하는 관계도</a:t>
+              <a:t>개념 사례 · 사람이 Context를 모으는 장면 · AI 생성 설명용 삽화</a:t>
             </a:r>
           </a:p>
         </p:txBody>
@@ -10679,7 +10679,7 @@
           <p:cNvPr id="6" name="특정 Trial에서 실제로 발생한 비용이나 실패를 뜻하지 않습니다.">
             <a:extLst xmlns:a="http://schemas.openxmlformats.org/drawingml/2006/main">
               <a:ext uri="{FF2B5EF4-FFF2-40B4-BE49-F238E27FC236}">
-                <a16:creationId xmlns:a16="http://schemas.microsoft.com/office/drawing/2014/main" id="{7DEB3097-D1D6-4215-9D13-25B0C6F7D75E}"/>
+                <a16:creationId xmlns:a16="http://schemas.microsoft.com/office/drawing/2014/main" id="{E80AFD1A-3B23-4DB6-BD70-581367672CB9}"/>
               </a:ext>
             </a:extLst>
           </p:cNvPr>
@@ -10691,7 +10691,7 @@
         <p:spPr>
           <a:xfrm xmlns:a="http://schemas.openxmlformats.org/drawingml/2006/main">
             <a:off x="609600" y="6191250"/>
-            <a:ext cx="10972800" cy="209550"/>
+            <a:ext cx="10972800" cy="285750"/>
           </a:xfrm>
           <a:prstGeom xmlns:a="http://schemas.openxmlformats.org/drawingml/2006/main" prst="rect">
             <a:avLst/>
@@ -10837,7 +10837,7 @@
           <p:cNvPr id="7" name="“CLI 결과가 기대와 다른데, 어디서부터 봐야 할까?”">
             <a:extLst xmlns:a="http://schemas.openxmlformats.org/drawingml/2006/main">
               <a:ext uri="{FF2B5EF4-FFF2-40B4-BE49-F238E27FC236}">
-                <a16:creationId xmlns:a16="http://schemas.microsoft.com/office/drawing/2014/main" id="{B3EDA43F-4CC6-4CF3-8922-961C91359502}"/>
+                <a16:creationId xmlns:a16="http://schemas.microsoft.com/office/drawing/2014/main" id="{4E06622F-010C-476D-8C7E-6500B58E930B}"/>
               </a:ext>
             </a:extLst>
           </p:cNvPr>
@@ -10848,8 +10848,8 @@
         </p:nvSpPr>
         <p:spPr>
           <a:xfrm xmlns:a="http://schemas.openxmlformats.org/drawingml/2006/main">
-            <a:off x="609600" y="2152650"/>
-            <a:ext cx="10972800" cy="457200"/>
+            <a:off x="609600" y="1628775"/>
+            <a:ext cx="10972800" cy="438150"/>
           </a:xfrm>
           <a:prstGeom xmlns:a="http://schemas.openxmlformats.org/drawingml/2006/main" prst="rect">
             <a:avLst/>
@@ -10865,7 +10865,7 @@
           </a:bodyPr>
           <a:lstStyle xmlns:a="http://schemas.openxmlformats.org/drawingml/2006/main">
             <a:defPPr algn="l">
-              <a:defRPr sz="2475" b="1">
+              <a:defRPr sz="2400" b="1">
                 <a:solidFill>
                   <a:srgbClr val="0B6172"/>
                 </a:solidFill>
@@ -10875,7 +10875,7 @@
               </a:defRPr>
             </a:defPPr>
             <a:lvl1pPr algn="l">
-              <a:defRPr sz="2475" b="1">
+              <a:defRPr sz="2400" b="1">
                 <a:solidFill>
                   <a:srgbClr val="0B6172"/>
                 </a:solidFill>
@@ -10885,7 +10885,7 @@
               </a:defRPr>
             </a:lvl1pPr>
             <a:lvl2pPr algn="l">
-              <a:defRPr sz="2475" b="1">
+              <a:defRPr sz="2400" b="1">
                 <a:solidFill>
                   <a:srgbClr val="0B6172"/>
                 </a:solidFill>
@@ -10895,7 +10895,7 @@
               </a:defRPr>
             </a:lvl2pPr>
             <a:lvl3pPr algn="l">
-              <a:defRPr sz="2475" b="1">
+              <a:defRPr sz="2400" b="1">
                 <a:solidFill>
                   <a:srgbClr val="0B6172"/>
                 </a:solidFill>
@@ -10905,7 +10905,7 @@
               </a:defRPr>
             </a:lvl3pPr>
             <a:lvl4pPr algn="l">
-              <a:defRPr sz="2475" b="1">
+              <a:defRPr sz="2400" b="1">
                 <a:solidFill>
                   <a:srgbClr val="0B6172"/>
                 </a:solidFill>
@@ -10915,7 +10915,7 @@
               </a:defRPr>
             </a:lvl4pPr>
             <a:lvl5pPr algn="l">
-              <a:defRPr sz="2475" b="1">
+              <a:defRPr sz="2400" b="1">
                 <a:solidFill>
                   <a:srgbClr val="0B6172"/>
                 </a:solidFill>
@@ -10925,7 +10925,7 @@
               </a:defRPr>
             </a:lvl5pPr>
             <a:lvl6pPr algn="l">
-              <a:defRPr sz="2475" b="1">
+              <a:defRPr sz="2400" b="1">
                 <a:solidFill>
                   <a:srgbClr val="0B6172"/>
                 </a:solidFill>
@@ -10935,7 +10935,7 @@
               </a:defRPr>
             </a:lvl6pPr>
             <a:lvl7pPr algn="l">
-              <a:defRPr sz="2475" b="1">
+              <a:defRPr sz="2400" b="1">
                 <a:solidFill>
                   <a:srgbClr val="0B6172"/>
                 </a:solidFill>
@@ -10945,7 +10945,7 @@
               </a:defRPr>
             </a:lvl7pPr>
             <a:lvl8pPr algn="l">
-              <a:defRPr sz="2475" b="1">
+              <a:defRPr sz="2400" b="1">
                 <a:solidFill>
                   <a:srgbClr val="0B6172"/>
                 </a:solidFill>
@@ -10955,7 +10955,7 @@
               </a:defRPr>
             </a:lvl8pPr>
             <a:lvl9pPr algn="l">
-              <a:defRPr sz="2475" b="1">
+              <a:defRPr sz="2400" b="1">
                 <a:solidFill>
                   <a:srgbClr val="0B6172"/>
                 </a:solidFill>
@@ -10967,7 +10967,7 @@
           </a:lstStyle>
           <a:p xmlns:a="http://schemas.openxmlformats.org/drawingml/2006/main">
             <a:pPr algn="l">
-              <a:defRPr sz="2475" b="1">
+              <a:defRPr sz="2400" b="1">
                 <a:solidFill>
                   <a:srgbClr val="0B6172"/>
                 </a:solidFill>
@@ -10977,7 +10977,7 @@
               </a:defRPr>
             </a:pPr>
             <a:r>
-              <a:rPr sz="2475" b="1">
+              <a:rPr sz="2400" b="1">
                 <a:solidFill>
                   <a:srgbClr val="0B6172"/>
                 </a:solidFill>
@@ -10990,12 +10990,40 @@
           </a:p>
         </p:txBody>
       </p:sp>
-      <p:sp>
-        <p:nvSpPr>
+      <p:pic>
+        <p:nvPicPr>
           <p:cNvPr id="8" name="">
             <a:extLst xmlns:a="http://schemas.openxmlformats.org/drawingml/2006/main">
               <a:ext uri="{FF2B5EF4-FFF2-40B4-BE49-F238E27FC236}">
-                <a16:creationId xmlns:a16="http://schemas.microsoft.com/office/drawing/2014/main" id="{4C381C7E-110E-4F96-A6F7-1615A4D5B8C3}"/>
+                <a16:creationId xmlns:a16="http://schemas.microsoft.com/office/drawing/2014/main" id="{31BC5AE2-9BBA-4B7B-B9DF-9CE20B7021DC}"/>
+              </a:ext>
+            </a:extLst>
+          </p:cNvPr>
+          <p:cNvPicPr>
+            <a:picLocks xmlns:a="http://schemas.openxmlformats.org/drawingml/2006/main" noChangeAspect="1"/>
+          </p:cNvPicPr>
+          <p:nvPr/>
+        </p:nvPicPr>
+        <p:blipFill>
+          <a:blip xmlns:r="http://schemas.openxmlformats.org/officeDocument/2006/relationships" xmlns:a="http://schemas.openxmlformats.org/drawingml/2006/main" r:embed="R99cd477771fd497a"/>
+          <a:stretch xmlns:a="http://schemas.openxmlformats.org/drawingml/2006/main"/>
+        </p:blipFill>
+        <p:spPr>
+          <a:xfrm xmlns:a="http://schemas.openxmlformats.org/drawingml/2006/main">
+            <a:off x="609600" y="2124075"/>
+            <a:ext cx="7086600" cy="3543300"/>
+          </a:xfrm>
+          <a:prstGeom xmlns:a="http://schemas.openxmlformats.org/drawingml/2006/main" prst="rect">
+            <a:avLst/>
+          </a:prstGeom>
+        </p:spPr>
+      </p:pic>
+      <p:sp>
+        <p:nvSpPr>
+          <p:cNvPr id="9" name="구현 · 호출 경로">
+            <a:extLst xmlns:a="http://schemas.openxmlformats.org/drawingml/2006/main">
+              <a:ext uri="{FF2B5EF4-FFF2-40B4-BE49-F238E27FC236}">
+                <a16:creationId xmlns:a16="http://schemas.microsoft.com/office/drawing/2014/main" id="{A45039C8-AF19-43E1-93A3-519A607418F5}"/>
               </a:ext>
             </a:extLst>
           </p:cNvPr>
@@ -11006,41 +11034,8 @@
         </p:nvSpPr>
         <p:spPr>
           <a:xfrm xmlns:a="http://schemas.openxmlformats.org/drawingml/2006/main">
-            <a:off x="609600" y="2981325"/>
-            <a:ext cx="3429000" cy="1200150"/>
-          </a:xfrm>
-          <a:prstGeom xmlns:a="http://schemas.openxmlformats.org/drawingml/2006/main" prst="rect">
-            <a:avLst/>
-          </a:prstGeom>
-          <a:solidFill xmlns:a="http://schemas.openxmlformats.org/drawingml/2006/main">
-            <a:srgbClr val="FFFFFF"/>
-          </a:solidFill>
-          <a:ln xmlns:a="http://schemas.openxmlformats.org/drawingml/2006/main" w="9525">
-            <a:solidFill>
-              <a:srgbClr val="C7D0DA"/>
-            </a:solidFill>
-            <a:prstDash val="solid"/>
-          </a:ln>
-        </p:spPr>
-      </p:sp>
-      <p:sp>
-        <p:nvSpPr>
-          <p:cNvPr id="9" name="CLI">
-            <a:extLst xmlns:a="http://schemas.openxmlformats.org/drawingml/2006/main">
-              <a:ext uri="{FF2B5EF4-FFF2-40B4-BE49-F238E27FC236}">
-                <a16:creationId xmlns:a16="http://schemas.microsoft.com/office/drawing/2014/main" id="{AE2B4DE8-2D4D-45C1-9EB1-F3C8C6318351}"/>
-              </a:ext>
-            </a:extLst>
-          </p:cNvPr>
-          <p:cNvSpPr>
-            <a:spLocks xmlns:a="http://schemas.openxmlformats.org/drawingml/2006/main" noGrp="1"/>
-          </p:cNvSpPr>
-          <p:nvPr/>
-        </p:nvSpPr>
-        <p:spPr>
-          <a:xfrm xmlns:a="http://schemas.openxmlformats.org/drawingml/2006/main">
-            <a:off x="838200" y="3133725"/>
-            <a:ext cx="2971800" cy="390525"/>
+            <a:off x="8096250" y="2295525"/>
+            <a:ext cx="3486150" cy="361950"/>
           </a:xfrm>
           <a:prstGeom xmlns:a="http://schemas.openxmlformats.org/drawingml/2006/main" prst="rect">
             <a:avLst/>
@@ -11056,9 +11051,9 @@
           </a:bodyPr>
           <a:lstStyle xmlns:a="http://schemas.openxmlformats.org/drawingml/2006/main">
             <a:defPPr algn="l">
-              <a:defRPr sz="2475" b="1">
-                <a:solidFill>
-                  <a:srgbClr val="17212B"/>
+              <a:defRPr sz="2100" b="1">
+                <a:solidFill>
+                  <a:srgbClr val="0B6172"/>
                 </a:solidFill>
                 <a:latin typeface="Malgun Gothic"/>
                 <a:ea typeface="Malgun Gothic"/>
@@ -11066,9 +11061,9 @@
               </a:defRPr>
             </a:defPPr>
             <a:lvl1pPr algn="l">
-              <a:defRPr sz="2475" b="1">
-                <a:solidFill>
-                  <a:srgbClr val="17212B"/>
+              <a:defRPr sz="2100" b="1">
+                <a:solidFill>
+                  <a:srgbClr val="0B6172"/>
                 </a:solidFill>
                 <a:latin typeface="Malgun Gothic"/>
                 <a:ea typeface="Malgun Gothic"/>
@@ -11076,9 +11071,9 @@
               </a:defRPr>
             </a:lvl1pPr>
             <a:lvl2pPr algn="l">
-              <a:defRPr sz="2475" b="1">
-                <a:solidFill>
-                  <a:srgbClr val="17212B"/>
+              <a:defRPr sz="2100" b="1">
+                <a:solidFill>
+                  <a:srgbClr val="0B6172"/>
                 </a:solidFill>
                 <a:latin typeface="Malgun Gothic"/>
                 <a:ea typeface="Malgun Gothic"/>
@@ -11086,9 +11081,9 @@
               </a:defRPr>
             </a:lvl2pPr>
             <a:lvl3pPr algn="l">
-              <a:defRPr sz="2475" b="1">
-                <a:solidFill>
-                  <a:srgbClr val="17212B"/>
+              <a:defRPr sz="2100" b="1">
+                <a:solidFill>
+                  <a:srgbClr val="0B6172"/>
                 </a:solidFill>
                 <a:latin typeface="Malgun Gothic"/>
                 <a:ea typeface="Malgun Gothic"/>
@@ -11096,9 +11091,9 @@
               </a:defRPr>
             </a:lvl3pPr>
             <a:lvl4pPr algn="l">
-              <a:defRPr sz="2475" b="1">
-                <a:solidFill>
-                  <a:srgbClr val="17212B"/>
+              <a:defRPr sz="2100" b="1">
+                <a:solidFill>
+                  <a:srgbClr val="0B6172"/>
                 </a:solidFill>
                 <a:latin typeface="Malgun Gothic"/>
                 <a:ea typeface="Malgun Gothic"/>
@@ -11106,9 +11101,9 @@
               </a:defRPr>
             </a:lvl4pPr>
             <a:lvl5pPr algn="l">
-              <a:defRPr sz="2475" b="1">
-                <a:solidFill>
-                  <a:srgbClr val="17212B"/>
+              <a:defRPr sz="2100" b="1">
+                <a:solidFill>
+                  <a:srgbClr val="0B6172"/>
                 </a:solidFill>
                 <a:latin typeface="Malgun Gothic"/>
                 <a:ea typeface="Malgun Gothic"/>
@@ -11116,9 +11111,9 @@
               </a:defRPr>
             </a:lvl5pPr>
             <a:lvl6pPr algn="l">
-              <a:defRPr sz="2475" b="1">
-                <a:solidFill>
-                  <a:srgbClr val="17212B"/>
+              <a:defRPr sz="2100" b="1">
+                <a:solidFill>
+                  <a:srgbClr val="0B6172"/>
                 </a:solidFill>
                 <a:latin typeface="Malgun Gothic"/>
                 <a:ea typeface="Malgun Gothic"/>
@@ -11126,9 +11121,9 @@
               </a:defRPr>
             </a:lvl6pPr>
             <a:lvl7pPr algn="l">
-              <a:defRPr sz="2475" b="1">
-                <a:solidFill>
-                  <a:srgbClr val="17212B"/>
+              <a:defRPr sz="2100" b="1">
+                <a:solidFill>
+                  <a:srgbClr val="0B6172"/>
                 </a:solidFill>
                 <a:latin typeface="Malgun Gothic"/>
                 <a:ea typeface="Malgun Gothic"/>
@@ -11136,9 +11131,9 @@
               </a:defRPr>
             </a:lvl7pPr>
             <a:lvl8pPr algn="l">
-              <a:defRPr sz="2475" b="1">
-                <a:solidFill>
-                  <a:srgbClr val="17212B"/>
+              <a:defRPr sz="2100" b="1">
+                <a:solidFill>
+                  <a:srgbClr val="0B6172"/>
                 </a:solidFill>
                 <a:latin typeface="Malgun Gothic"/>
                 <a:ea typeface="Malgun Gothic"/>
@@ -11146,9 +11141,9 @@
               </a:defRPr>
             </a:lvl8pPr>
             <a:lvl9pPr algn="l">
-              <a:defRPr sz="2475" b="1">
-                <a:solidFill>
-                  <a:srgbClr val="17212B"/>
+              <a:defRPr sz="2100" b="1">
+                <a:solidFill>
+                  <a:srgbClr val="0B6172"/>
                 </a:solidFill>
                 <a:latin typeface="Malgun Gothic"/>
                 <a:ea typeface="Malgun Gothic"/>
@@ -11158,9 +11153,9 @@
           </a:lstStyle>
           <a:p xmlns:a="http://schemas.openxmlformats.org/drawingml/2006/main">
             <a:pPr algn="l">
-              <a:defRPr sz="2475" b="1">
-                <a:solidFill>
-                  <a:srgbClr val="17212B"/>
+              <a:defRPr sz="2100" b="1">
+                <a:solidFill>
+                  <a:srgbClr val="0B6172"/>
                 </a:solidFill>
                 <a:latin typeface="Malgun Gothic"/>
                 <a:ea typeface="Malgun Gothic"/>
@@ -11168,25 +11163,25 @@
               </a:defRPr>
             </a:pPr>
             <a:r>
-              <a:rPr sz="2475" b="1">
-                <a:solidFill>
-                  <a:srgbClr val="17212B"/>
+              <a:rPr sz="2100" b="1">
+                <a:solidFill>
+                  <a:srgbClr val="0B6172"/>
                 </a:solidFill>
                 <a:latin typeface="Malgun Gothic"/>
                 <a:ea typeface="Malgun Gothic"/>
                 <a:cs typeface="Malgun Gothic"/>
               </a:rPr>
-              <a:t>CLI</a:t>
+              <a:t>구현 · 호출 경로</a:t>
             </a:r>
           </a:p>
         </p:txBody>
       </p:sp>
       <p:sp>
         <p:nvSpPr>
-          <p:cNvPr id="10" name="입력은 어떻게 받나?">
+          <p:cNvPr id="10" name="CLI → 처리 흐름 → 연산">
             <a:extLst xmlns:a="http://schemas.openxmlformats.org/drawingml/2006/main">
               <a:ext uri="{FF2B5EF4-FFF2-40B4-BE49-F238E27FC236}">
-                <a16:creationId xmlns:a16="http://schemas.microsoft.com/office/drawing/2014/main" id="{F2EB3C2F-3ED9-4815-9928-56598E1C87F2}"/>
+                <a16:creationId xmlns:a16="http://schemas.microsoft.com/office/drawing/2014/main" id="{EFB894D7-24E9-4B46-B0F0-BE41CABE6705}"/>
               </a:ext>
             </a:extLst>
           </p:cNvPr>
@@ -11197,8 +11192,8 @@
         </p:nvSpPr>
         <p:spPr>
           <a:xfrm xmlns:a="http://schemas.openxmlformats.org/drawingml/2006/main">
-            <a:off x="838200" y="3648075"/>
-            <a:ext cx="2971800" cy="342900"/>
+            <a:off x="8096250" y="2705100"/>
+            <a:ext cx="3486150" cy="342900"/>
           </a:xfrm>
           <a:prstGeom xmlns:a="http://schemas.openxmlformats.org/drawingml/2006/main" prst="rect">
             <a:avLst/>
@@ -11214,7 +11209,7 @@
           </a:bodyPr>
           <a:lstStyle xmlns:a="http://schemas.openxmlformats.org/drawingml/2006/main">
             <a:defPPr algn="l">
-              <a:defRPr sz="2100" b="0">
+              <a:defRPr sz="1800" b="0">
                 <a:solidFill>
                   <a:srgbClr val="4D5A68"/>
                 </a:solidFill>
@@ -11224,7 +11219,7 @@
               </a:defRPr>
             </a:defPPr>
             <a:lvl1pPr algn="l">
-              <a:defRPr sz="2100" b="0">
+              <a:defRPr sz="1800" b="0">
                 <a:solidFill>
                   <a:srgbClr val="4D5A68"/>
                 </a:solidFill>
@@ -11234,7 +11229,7 @@
               </a:defRPr>
             </a:lvl1pPr>
             <a:lvl2pPr algn="l">
-              <a:defRPr sz="2100" b="0">
+              <a:defRPr sz="1800" b="0">
                 <a:solidFill>
                   <a:srgbClr val="4D5A68"/>
                 </a:solidFill>
@@ -11244,7 +11239,7 @@
               </a:defRPr>
             </a:lvl2pPr>
             <a:lvl3pPr algn="l">
-              <a:defRPr sz="2100" b="0">
+              <a:defRPr sz="1800" b="0">
                 <a:solidFill>
                   <a:srgbClr val="4D5A68"/>
                 </a:solidFill>
@@ -11254,7 +11249,7 @@
               </a:defRPr>
             </a:lvl3pPr>
             <a:lvl4pPr algn="l">
-              <a:defRPr sz="2100" b="0">
+              <a:defRPr sz="1800" b="0">
                 <a:solidFill>
                   <a:srgbClr val="4D5A68"/>
                 </a:solidFill>
@@ -11264,7 +11259,7 @@
               </a:defRPr>
             </a:lvl4pPr>
             <a:lvl5pPr algn="l">
-              <a:defRPr sz="2100" b="0">
+              <a:defRPr sz="1800" b="0">
                 <a:solidFill>
                   <a:srgbClr val="4D5A68"/>
                 </a:solidFill>
@@ -11274,7 +11269,7 @@
               </a:defRPr>
             </a:lvl5pPr>
             <a:lvl6pPr algn="l">
-              <a:defRPr sz="2100" b="0">
+              <a:defRPr sz="1800" b="0">
                 <a:solidFill>
                   <a:srgbClr val="4D5A68"/>
                 </a:solidFill>
@@ -11284,7 +11279,7 @@
               </a:defRPr>
             </a:lvl6pPr>
             <a:lvl7pPr algn="l">
-              <a:defRPr sz="2100" b="0">
+              <a:defRPr sz="1800" b="0">
                 <a:solidFill>
                   <a:srgbClr val="4D5A68"/>
                 </a:solidFill>
@@ -11294,7 +11289,7 @@
               </a:defRPr>
             </a:lvl7pPr>
             <a:lvl8pPr algn="l">
-              <a:defRPr sz="2100" b="0">
+              <a:defRPr sz="1800" b="0">
                 <a:solidFill>
                   <a:srgbClr val="4D5A68"/>
                 </a:solidFill>
@@ -11304,7 +11299,7 @@
               </a:defRPr>
             </a:lvl8pPr>
             <a:lvl9pPr algn="l">
-              <a:defRPr sz="2100" b="0">
+              <a:defRPr sz="1800" b="0">
                 <a:solidFill>
                   <a:srgbClr val="4D5A68"/>
                 </a:solidFill>
@@ -11316,7 +11311,7 @@
           </a:lstStyle>
           <a:p xmlns:a="http://schemas.openxmlformats.org/drawingml/2006/main">
             <a:pPr algn="l">
-              <a:defRPr sz="2100" b="0">
+              <a:defRPr sz="1800" b="0">
                 <a:solidFill>
                   <a:srgbClr val="4D5A68"/>
                 </a:solidFill>
@@ -11326,7 +11321,7 @@
               </a:defRPr>
             </a:pPr>
             <a:r>
-              <a:rPr sz="2100" b="0">
+              <a:rPr sz="1800" b="0">
                 <a:solidFill>
                   <a:srgbClr val="4D5A68"/>
                 </a:solidFill>
@@ -11334,17 +11329,17 @@
                 <a:ea typeface="Malgun Gothic"/>
                 <a:cs typeface="Malgun Gothic"/>
               </a:rPr>
-              <a:t>입력은 어떻게 받나?</a:t>
+              <a:t>CLI → 처리 흐름 → 연산</a:t>
             </a:r>
           </a:p>
         </p:txBody>
       </p:sp>
       <p:sp>
         <p:nvSpPr>
-          <p:cNvPr id="11" name="">
+          <p:cNvPr id="11" name="테스트">
             <a:extLst xmlns:a="http://schemas.openxmlformats.org/drawingml/2006/main">
               <a:ext uri="{FF2B5EF4-FFF2-40B4-BE49-F238E27FC236}">
-                <a16:creationId xmlns:a16="http://schemas.microsoft.com/office/drawing/2014/main" id="{DD165A6B-0CBE-40B2-A3CF-00C0C285173D}"/>
+                <a16:creationId xmlns:a16="http://schemas.microsoft.com/office/drawing/2014/main" id="{2920A941-A578-4C5B-B130-547B3284560F}"/>
               </a:ext>
             </a:extLst>
           </p:cNvPr>
@@ -11355,71 +11350,8 @@
         </p:nvSpPr>
         <p:spPr>
           <a:xfrm xmlns:a="http://schemas.openxmlformats.org/drawingml/2006/main">
-            <a:off x="4105275" y="3448050"/>
-            <a:ext cx="219075" cy="171450"/>
-          </a:xfrm>
-          <a:prstGeom xmlns:a="http://schemas.openxmlformats.org/drawingml/2006/main" prst="rightArrow">
-            <a:avLst/>
-          </a:prstGeom>
-          <a:solidFill xmlns:a="http://schemas.openxmlformats.org/drawingml/2006/main">
-            <a:srgbClr val="0B6172"/>
-          </a:solidFill>
-          <a:ln xmlns:a="http://schemas.openxmlformats.org/drawingml/2006/main" w="0">
-            <a:noFill/>
-          </a:ln>
-        </p:spPr>
-      </p:sp>
-      <p:sp>
-        <p:nvSpPr>
-          <p:cNvPr id="12" name="">
-            <a:extLst xmlns:a="http://schemas.openxmlformats.org/drawingml/2006/main">
-              <a:ext uri="{FF2B5EF4-FFF2-40B4-BE49-F238E27FC236}">
-                <a16:creationId xmlns:a16="http://schemas.microsoft.com/office/drawing/2014/main" id="{3D63E960-787B-4993-B5AB-C133C8CB6DE3}"/>
-              </a:ext>
-            </a:extLst>
-          </p:cNvPr>
-          <p:cNvSpPr>
-            <a:spLocks xmlns:a="http://schemas.openxmlformats.org/drawingml/2006/main" noGrp="1"/>
-          </p:cNvSpPr>
-          <p:nvPr/>
-        </p:nvSpPr>
-        <p:spPr>
-          <a:xfrm xmlns:a="http://schemas.openxmlformats.org/drawingml/2006/main">
-            <a:off x="4381500" y="2981325"/>
-            <a:ext cx="3429000" cy="1200150"/>
-          </a:xfrm>
-          <a:prstGeom xmlns:a="http://schemas.openxmlformats.org/drawingml/2006/main" prst="rect">
-            <a:avLst/>
-          </a:prstGeom>
-          <a:solidFill xmlns:a="http://schemas.openxmlformats.org/drawingml/2006/main">
-            <a:srgbClr val="FFFFFF"/>
-          </a:solidFill>
-          <a:ln xmlns:a="http://schemas.openxmlformats.org/drawingml/2006/main" w="9525">
-            <a:solidFill>
-              <a:srgbClr val="C7D0DA"/>
-            </a:solidFill>
-            <a:prstDash val="solid"/>
-          </a:ln>
-        </p:spPr>
-      </p:sp>
-      <p:sp>
-        <p:nvSpPr>
-          <p:cNvPr id="13" name="처리 흐름">
-            <a:extLst xmlns:a="http://schemas.openxmlformats.org/drawingml/2006/main">
-              <a:ext uri="{FF2B5EF4-FFF2-40B4-BE49-F238E27FC236}">
-                <a16:creationId xmlns:a16="http://schemas.microsoft.com/office/drawing/2014/main" id="{CBD3D4F9-F692-42D1-BB9B-18ABC532F4DB}"/>
-              </a:ext>
-            </a:extLst>
-          </p:cNvPr>
-          <p:cNvSpPr>
-            <a:spLocks xmlns:a="http://schemas.openxmlformats.org/drawingml/2006/main" noGrp="1"/>
-          </p:cNvSpPr>
-          <p:nvPr/>
-        </p:nvSpPr>
-        <p:spPr>
-          <a:xfrm xmlns:a="http://schemas.openxmlformats.org/drawingml/2006/main">
-            <a:off x="4610100" y="3133725"/>
-            <a:ext cx="2971800" cy="390525"/>
+            <a:off x="8096250" y="3333750"/>
+            <a:ext cx="3486150" cy="361950"/>
           </a:xfrm>
           <a:prstGeom xmlns:a="http://schemas.openxmlformats.org/drawingml/2006/main" prst="rect">
             <a:avLst/>
@@ -11435,9 +11367,9 @@
           </a:bodyPr>
           <a:lstStyle xmlns:a="http://schemas.openxmlformats.org/drawingml/2006/main">
             <a:defPPr algn="l">
-              <a:defRPr sz="2475" b="1">
-                <a:solidFill>
-                  <a:srgbClr val="17212B"/>
+              <a:defRPr sz="2100" b="1">
+                <a:solidFill>
+                  <a:srgbClr val="0B6172"/>
                 </a:solidFill>
                 <a:latin typeface="Malgun Gothic"/>
                 <a:ea typeface="Malgun Gothic"/>
@@ -11445,9 +11377,9 @@
               </a:defRPr>
             </a:defPPr>
             <a:lvl1pPr algn="l">
-              <a:defRPr sz="2475" b="1">
-                <a:solidFill>
-                  <a:srgbClr val="17212B"/>
+              <a:defRPr sz="2100" b="1">
+                <a:solidFill>
+                  <a:srgbClr val="0B6172"/>
                 </a:solidFill>
                 <a:latin typeface="Malgun Gothic"/>
                 <a:ea typeface="Malgun Gothic"/>
@@ -11455,9 +11387,9 @@
               </a:defRPr>
             </a:lvl1pPr>
             <a:lvl2pPr algn="l">
-              <a:defRPr sz="2475" b="1">
-                <a:solidFill>
-                  <a:srgbClr val="17212B"/>
+              <a:defRPr sz="2100" b="1">
+                <a:solidFill>
+                  <a:srgbClr val="0B6172"/>
                 </a:solidFill>
                 <a:latin typeface="Malgun Gothic"/>
                 <a:ea typeface="Malgun Gothic"/>
@@ -11465,9 +11397,9 @@
               </a:defRPr>
             </a:lvl2pPr>
             <a:lvl3pPr algn="l">
-              <a:defRPr sz="2475" b="1">
-                <a:solidFill>
-                  <a:srgbClr val="17212B"/>
+              <a:defRPr sz="2100" b="1">
+                <a:solidFill>
+                  <a:srgbClr val="0B6172"/>
                 </a:solidFill>
                 <a:latin typeface="Malgun Gothic"/>
                 <a:ea typeface="Malgun Gothic"/>
@@ -11475,9 +11407,9 @@
               </a:defRPr>
             </a:lvl3pPr>
             <a:lvl4pPr algn="l">
-              <a:defRPr sz="2475" b="1">
-                <a:solidFill>
-                  <a:srgbClr val="17212B"/>
+              <a:defRPr sz="2100" b="1">
+                <a:solidFill>
+                  <a:srgbClr val="0B6172"/>
                 </a:solidFill>
                 <a:latin typeface="Malgun Gothic"/>
                 <a:ea typeface="Malgun Gothic"/>
@@ -11485,9 +11417,9 @@
               </a:defRPr>
             </a:lvl4pPr>
             <a:lvl5pPr algn="l">
-              <a:defRPr sz="2475" b="1">
-                <a:solidFill>
-                  <a:srgbClr val="17212B"/>
+              <a:defRPr sz="2100" b="1">
+                <a:solidFill>
+                  <a:srgbClr val="0B6172"/>
                 </a:solidFill>
                 <a:latin typeface="Malgun Gothic"/>
                 <a:ea typeface="Malgun Gothic"/>
@@ -11495,9 +11427,9 @@
               </a:defRPr>
             </a:lvl5pPr>
             <a:lvl6pPr algn="l">
-              <a:defRPr sz="2475" b="1">
-                <a:solidFill>
-                  <a:srgbClr val="17212B"/>
+              <a:defRPr sz="2100" b="1">
+                <a:solidFill>
+                  <a:srgbClr val="0B6172"/>
                 </a:solidFill>
                 <a:latin typeface="Malgun Gothic"/>
                 <a:ea typeface="Malgun Gothic"/>
@@ -11505,9 +11437,9 @@
               </a:defRPr>
             </a:lvl6pPr>
             <a:lvl7pPr algn="l">
-              <a:defRPr sz="2475" b="1">
-                <a:solidFill>
-                  <a:srgbClr val="17212B"/>
+              <a:defRPr sz="2100" b="1">
+                <a:solidFill>
+                  <a:srgbClr val="0B6172"/>
                 </a:solidFill>
                 <a:latin typeface="Malgun Gothic"/>
                 <a:ea typeface="Malgun Gothic"/>
@@ -11515,9 +11447,9 @@
               </a:defRPr>
             </a:lvl7pPr>
             <a:lvl8pPr algn="l">
-              <a:defRPr sz="2475" b="1">
-                <a:solidFill>
-                  <a:srgbClr val="17212B"/>
+              <a:defRPr sz="2100" b="1">
+                <a:solidFill>
+                  <a:srgbClr val="0B6172"/>
                 </a:solidFill>
                 <a:latin typeface="Malgun Gothic"/>
                 <a:ea typeface="Malgun Gothic"/>
@@ -11525,9 +11457,9 @@
               </a:defRPr>
             </a:lvl8pPr>
             <a:lvl9pPr algn="l">
-              <a:defRPr sz="2475" b="1">
-                <a:solidFill>
-                  <a:srgbClr val="17212B"/>
+              <a:defRPr sz="2100" b="1">
+                <a:solidFill>
+                  <a:srgbClr val="0B6172"/>
                 </a:solidFill>
                 <a:latin typeface="Malgun Gothic"/>
                 <a:ea typeface="Malgun Gothic"/>
@@ -11537,9 +11469,9 @@
           </a:lstStyle>
           <a:p xmlns:a="http://schemas.openxmlformats.org/drawingml/2006/main">
             <a:pPr algn="l">
-              <a:defRPr sz="2475" b="1">
-                <a:solidFill>
-                  <a:srgbClr val="17212B"/>
+              <a:defRPr sz="2100" b="1">
+                <a:solidFill>
+                  <a:srgbClr val="0B6172"/>
                 </a:solidFill>
                 <a:latin typeface="Malgun Gothic"/>
                 <a:ea typeface="Malgun Gothic"/>
@@ -11547,25 +11479,25 @@
               </a:defRPr>
             </a:pPr>
             <a:r>
-              <a:rPr sz="2475" b="1">
-                <a:solidFill>
-                  <a:srgbClr val="17212B"/>
+              <a:rPr sz="2100" b="1">
+                <a:solidFill>
+                  <a:srgbClr val="0B6172"/>
                 </a:solidFill>
                 <a:latin typeface="Malgun Gothic"/>
                 <a:ea typeface="Malgun Gothic"/>
                 <a:cs typeface="Malgun Gothic"/>
               </a:rPr>
-              <a:t>처리 흐름</a:t>
+              <a:t>테스트</a:t>
             </a:r>
           </a:p>
         </p:txBody>
       </p:sp>
       <p:sp>
         <p:nvSpPr>
-          <p:cNvPr id="14" name="어떤 연산을 호출하나?">
+          <p:cNvPr id="12" name="어떤 조건에서 실패했나?">
             <a:extLst xmlns:a="http://schemas.openxmlformats.org/drawingml/2006/main">
               <a:ext uri="{FF2B5EF4-FFF2-40B4-BE49-F238E27FC236}">
-                <a16:creationId xmlns:a16="http://schemas.microsoft.com/office/drawing/2014/main" id="{58B50DFE-C171-4EAA-9240-5CB7BA403ECE}"/>
+                <a16:creationId xmlns:a16="http://schemas.microsoft.com/office/drawing/2014/main" id="{606DEFAE-F6A4-4412-8F93-EAB43071C812}"/>
               </a:ext>
             </a:extLst>
           </p:cNvPr>
@@ -11576,8 +11508,8 @@
         </p:nvSpPr>
         <p:spPr>
           <a:xfrm xmlns:a="http://schemas.openxmlformats.org/drawingml/2006/main">
-            <a:off x="4610100" y="3648075"/>
-            <a:ext cx="2971800" cy="342900"/>
+            <a:off x="8096250" y="3743325"/>
+            <a:ext cx="3486150" cy="342900"/>
           </a:xfrm>
           <a:prstGeom xmlns:a="http://schemas.openxmlformats.org/drawingml/2006/main" prst="rect">
             <a:avLst/>
@@ -11593,7 +11525,7 @@
           </a:bodyPr>
           <a:lstStyle xmlns:a="http://schemas.openxmlformats.org/drawingml/2006/main">
             <a:defPPr algn="l">
-              <a:defRPr sz="2100" b="0">
+              <a:defRPr sz="1800" b="0">
                 <a:solidFill>
                   <a:srgbClr val="4D5A68"/>
                 </a:solidFill>
@@ -11603,7 +11535,7 @@
               </a:defRPr>
             </a:defPPr>
             <a:lvl1pPr algn="l">
-              <a:defRPr sz="2100" b="0">
+              <a:defRPr sz="1800" b="0">
                 <a:solidFill>
                   <a:srgbClr val="4D5A68"/>
                 </a:solidFill>
@@ -11613,7 +11545,7 @@
               </a:defRPr>
             </a:lvl1pPr>
             <a:lvl2pPr algn="l">
-              <a:defRPr sz="2100" b="0">
+              <a:defRPr sz="1800" b="0">
                 <a:solidFill>
                   <a:srgbClr val="4D5A68"/>
                 </a:solidFill>
@@ -11623,7 +11555,7 @@
               </a:defRPr>
             </a:lvl2pPr>
             <a:lvl3pPr algn="l">
-              <a:defRPr sz="2100" b="0">
+              <a:defRPr sz="1800" b="0">
                 <a:solidFill>
                   <a:srgbClr val="4D5A68"/>
                 </a:solidFill>
@@ -11633,7 +11565,7 @@
               </a:defRPr>
             </a:lvl3pPr>
             <a:lvl4pPr algn="l">
-              <a:defRPr sz="2100" b="0">
+              <a:defRPr sz="1800" b="0">
                 <a:solidFill>
                   <a:srgbClr val="4D5A68"/>
                 </a:solidFill>
@@ -11643,7 +11575,7 @@
               </a:defRPr>
             </a:lvl4pPr>
             <a:lvl5pPr algn="l">
-              <a:defRPr sz="2100" b="0">
+              <a:defRPr sz="1800" b="0">
                 <a:solidFill>
                   <a:srgbClr val="4D5A68"/>
                 </a:solidFill>
@@ -11653,7 +11585,7 @@
               </a:defRPr>
             </a:lvl5pPr>
             <a:lvl6pPr algn="l">
-              <a:defRPr sz="2100" b="0">
+              <a:defRPr sz="1800" b="0">
                 <a:solidFill>
                   <a:srgbClr val="4D5A68"/>
                 </a:solidFill>
@@ -11663,7 +11595,7 @@
               </a:defRPr>
             </a:lvl6pPr>
             <a:lvl7pPr algn="l">
-              <a:defRPr sz="2100" b="0">
+              <a:defRPr sz="1800" b="0">
                 <a:solidFill>
                   <a:srgbClr val="4D5A68"/>
                 </a:solidFill>
@@ -11673,7 +11605,7 @@
               </a:defRPr>
             </a:lvl7pPr>
             <a:lvl8pPr algn="l">
-              <a:defRPr sz="2100" b="0">
+              <a:defRPr sz="1800" b="0">
                 <a:solidFill>
                   <a:srgbClr val="4D5A68"/>
                 </a:solidFill>
@@ -11683,7 +11615,7 @@
               </a:defRPr>
             </a:lvl8pPr>
             <a:lvl9pPr algn="l">
-              <a:defRPr sz="2100" b="0">
+              <a:defRPr sz="1800" b="0">
                 <a:solidFill>
                   <a:srgbClr val="4D5A68"/>
                 </a:solidFill>
@@ -11695,7 +11627,7 @@
           </a:lstStyle>
           <a:p xmlns:a="http://schemas.openxmlformats.org/drawingml/2006/main">
             <a:pPr algn="l">
-              <a:defRPr sz="2100" b="0">
+              <a:defRPr sz="1800" b="0">
                 <a:solidFill>
                   <a:srgbClr val="4D5A68"/>
                 </a:solidFill>
@@ -11705,7 +11637,7 @@
               </a:defRPr>
             </a:pPr>
             <a:r>
-              <a:rPr sz="2100" b="0">
+              <a:rPr sz="1800" b="0">
                 <a:solidFill>
                   <a:srgbClr val="4D5A68"/>
                 </a:solidFill>
@@ -11713,17 +11645,17 @@
                 <a:ea typeface="Malgun Gothic"/>
                 <a:cs typeface="Malgun Gothic"/>
               </a:rPr>
-              <a:t>어떤 연산을 호출하나?</a:t>
+              <a:t>어떤 조건에서 실패했나?</a:t>
             </a:r>
           </a:p>
         </p:txBody>
       </p:sp>
       <p:sp>
         <p:nvSpPr>
-          <p:cNvPr id="15" name="">
+          <p:cNvPr id="13" name="계약">
             <a:extLst xmlns:a="http://schemas.openxmlformats.org/drawingml/2006/main">
               <a:ext uri="{FF2B5EF4-FFF2-40B4-BE49-F238E27FC236}">
-                <a16:creationId xmlns:a16="http://schemas.microsoft.com/office/drawing/2014/main" id="{0F7F459F-01C0-4876-AA36-2EDAADC229CA}"/>
+                <a16:creationId xmlns:a16="http://schemas.microsoft.com/office/drawing/2014/main" id="{00F20D52-212C-489C-A04D-1B77FAEAF952}"/>
               </a:ext>
             </a:extLst>
           </p:cNvPr>
@@ -11734,71 +11666,8 @@
         </p:nvSpPr>
         <p:spPr>
           <a:xfrm xmlns:a="http://schemas.openxmlformats.org/drawingml/2006/main">
-            <a:off x="7877175" y="3448050"/>
-            <a:ext cx="219075" cy="171450"/>
-          </a:xfrm>
-          <a:prstGeom xmlns:a="http://schemas.openxmlformats.org/drawingml/2006/main" prst="rightArrow">
-            <a:avLst/>
-          </a:prstGeom>
-          <a:solidFill xmlns:a="http://schemas.openxmlformats.org/drawingml/2006/main">
-            <a:srgbClr val="0B6172"/>
-          </a:solidFill>
-          <a:ln xmlns:a="http://schemas.openxmlformats.org/drawingml/2006/main" w="0">
-            <a:noFill/>
-          </a:ln>
-        </p:spPr>
-      </p:sp>
-      <p:sp>
-        <p:nvSpPr>
-          <p:cNvPr id="16" name="">
-            <a:extLst xmlns:a="http://schemas.openxmlformats.org/drawingml/2006/main">
-              <a:ext uri="{FF2B5EF4-FFF2-40B4-BE49-F238E27FC236}">
-                <a16:creationId xmlns:a16="http://schemas.microsoft.com/office/drawing/2014/main" id="{2DB830D5-0934-4335-BD02-2BBABB1E27C9}"/>
-              </a:ext>
-            </a:extLst>
-          </p:cNvPr>
-          <p:cNvSpPr>
-            <a:spLocks xmlns:a="http://schemas.openxmlformats.org/drawingml/2006/main" noGrp="1"/>
-          </p:cNvSpPr>
-          <p:nvPr/>
-        </p:nvSpPr>
-        <p:spPr>
-          <a:xfrm xmlns:a="http://schemas.openxmlformats.org/drawingml/2006/main">
-            <a:off x="8153400" y="2981325"/>
-            <a:ext cx="3429000" cy="1200150"/>
-          </a:xfrm>
-          <a:prstGeom xmlns:a="http://schemas.openxmlformats.org/drawingml/2006/main" prst="rect">
-            <a:avLst/>
-          </a:prstGeom>
-          <a:solidFill xmlns:a="http://schemas.openxmlformats.org/drawingml/2006/main">
-            <a:srgbClr val="E0EFF0"/>
-          </a:solidFill>
-          <a:ln xmlns:a="http://schemas.openxmlformats.org/drawingml/2006/main" w="9525">
-            <a:solidFill>
-              <a:srgbClr val="C7D0DA"/>
-            </a:solidFill>
-            <a:prstDash val="solid"/>
-          </a:ln>
-        </p:spPr>
-      </p:sp>
-      <p:sp>
-        <p:nvSpPr>
-          <p:cNvPr id="17" name="이미지 연산">
-            <a:extLst xmlns:a="http://schemas.openxmlformats.org/drawingml/2006/main">
-              <a:ext uri="{FF2B5EF4-FFF2-40B4-BE49-F238E27FC236}">
-                <a16:creationId xmlns:a16="http://schemas.microsoft.com/office/drawing/2014/main" id="{0A6C6DA3-5BBD-4D0E-A798-62F0384106A9}"/>
-              </a:ext>
-            </a:extLst>
-          </p:cNvPr>
-          <p:cNvSpPr>
-            <a:spLocks xmlns:a="http://schemas.openxmlformats.org/drawingml/2006/main" noGrp="1"/>
-          </p:cNvSpPr>
-          <p:nvPr/>
-        </p:nvSpPr>
-        <p:spPr>
-          <a:xfrm xmlns:a="http://schemas.openxmlformats.org/drawingml/2006/main">
-            <a:off x="8382000" y="3133725"/>
-            <a:ext cx="2971800" cy="390525"/>
+            <a:off x="8096250" y="4371975"/>
+            <a:ext cx="3486150" cy="361950"/>
           </a:xfrm>
           <a:prstGeom xmlns:a="http://schemas.openxmlformats.org/drawingml/2006/main" prst="rect">
             <a:avLst/>
@@ -11814,9 +11683,9 @@
           </a:bodyPr>
           <a:lstStyle xmlns:a="http://schemas.openxmlformats.org/drawingml/2006/main">
             <a:defPPr algn="l">
-              <a:defRPr sz="2475" b="1">
-                <a:solidFill>
-                  <a:srgbClr val="17212B"/>
+              <a:defRPr sz="2100" b="1">
+                <a:solidFill>
+                  <a:srgbClr val="0B6172"/>
                 </a:solidFill>
                 <a:latin typeface="Malgun Gothic"/>
                 <a:ea typeface="Malgun Gothic"/>
@@ -11824,9 +11693,9 @@
               </a:defRPr>
             </a:defPPr>
             <a:lvl1pPr algn="l">
-              <a:defRPr sz="2475" b="1">
-                <a:solidFill>
-                  <a:srgbClr val="17212B"/>
+              <a:defRPr sz="2100" b="1">
+                <a:solidFill>
+                  <a:srgbClr val="0B6172"/>
                 </a:solidFill>
                 <a:latin typeface="Malgun Gothic"/>
                 <a:ea typeface="Malgun Gothic"/>
@@ -11834,9 +11703,9 @@
               </a:defRPr>
             </a:lvl1pPr>
             <a:lvl2pPr algn="l">
-              <a:defRPr sz="2475" b="1">
-                <a:solidFill>
-                  <a:srgbClr val="17212B"/>
+              <a:defRPr sz="2100" b="1">
+                <a:solidFill>
+                  <a:srgbClr val="0B6172"/>
                 </a:solidFill>
                 <a:latin typeface="Malgun Gothic"/>
                 <a:ea typeface="Malgun Gothic"/>
@@ -11844,9 +11713,9 @@
               </a:defRPr>
             </a:lvl2pPr>
             <a:lvl3pPr algn="l">
-              <a:defRPr sz="2475" b="1">
-                <a:solidFill>
-                  <a:srgbClr val="17212B"/>
+              <a:defRPr sz="2100" b="1">
+                <a:solidFill>
+                  <a:srgbClr val="0B6172"/>
                 </a:solidFill>
                 <a:latin typeface="Malgun Gothic"/>
                 <a:ea typeface="Malgun Gothic"/>
@@ -11854,9 +11723,9 @@
               </a:defRPr>
             </a:lvl3pPr>
             <a:lvl4pPr algn="l">
-              <a:defRPr sz="2475" b="1">
-                <a:solidFill>
-                  <a:srgbClr val="17212B"/>
+              <a:defRPr sz="2100" b="1">
+                <a:solidFill>
+                  <a:srgbClr val="0B6172"/>
                 </a:solidFill>
                 <a:latin typeface="Malgun Gothic"/>
                 <a:ea typeface="Malgun Gothic"/>
@@ -11864,9 +11733,9 @@
               </a:defRPr>
             </a:lvl4pPr>
             <a:lvl5pPr algn="l">
-              <a:defRPr sz="2475" b="1">
-                <a:solidFill>
-                  <a:srgbClr val="17212B"/>
+              <a:defRPr sz="2100" b="1">
+                <a:solidFill>
+                  <a:srgbClr val="0B6172"/>
                 </a:solidFill>
                 <a:latin typeface="Malgun Gothic"/>
                 <a:ea typeface="Malgun Gothic"/>
@@ -11874,9 +11743,9 @@
               </a:defRPr>
             </a:lvl5pPr>
             <a:lvl6pPr algn="l">
-              <a:defRPr sz="2475" b="1">
-                <a:solidFill>
-                  <a:srgbClr val="17212B"/>
+              <a:defRPr sz="2100" b="1">
+                <a:solidFill>
+                  <a:srgbClr val="0B6172"/>
                 </a:solidFill>
                 <a:latin typeface="Malgun Gothic"/>
                 <a:ea typeface="Malgun Gothic"/>
@@ -11884,9 +11753,9 @@
               </a:defRPr>
             </a:lvl6pPr>
             <a:lvl7pPr algn="l">
-              <a:defRPr sz="2475" b="1">
-                <a:solidFill>
-                  <a:srgbClr val="17212B"/>
+              <a:defRPr sz="2100" b="1">
+                <a:solidFill>
+                  <a:srgbClr val="0B6172"/>
                 </a:solidFill>
                 <a:latin typeface="Malgun Gothic"/>
                 <a:ea typeface="Malgun Gothic"/>
@@ -11894,9 +11763,9 @@
               </a:defRPr>
             </a:lvl7pPr>
             <a:lvl8pPr algn="l">
-              <a:defRPr sz="2475" b="1">
-                <a:solidFill>
-                  <a:srgbClr val="17212B"/>
+              <a:defRPr sz="2100" b="1">
+                <a:solidFill>
+                  <a:srgbClr val="0B6172"/>
                 </a:solidFill>
                 <a:latin typeface="Malgun Gothic"/>
                 <a:ea typeface="Malgun Gothic"/>
@@ -11904,9 +11773,9 @@
               </a:defRPr>
             </a:lvl8pPr>
             <a:lvl9pPr algn="l">
-              <a:defRPr sz="2475" b="1">
-                <a:solidFill>
-                  <a:srgbClr val="17212B"/>
+              <a:defRPr sz="2100" b="1">
+                <a:solidFill>
+                  <a:srgbClr val="0B6172"/>
                 </a:solidFill>
                 <a:latin typeface="Malgun Gothic"/>
                 <a:ea typeface="Malgun Gothic"/>
@@ -11916,9 +11785,9 @@
           </a:lstStyle>
           <a:p xmlns:a="http://schemas.openxmlformats.org/drawingml/2006/main">
             <a:pPr algn="l">
-              <a:defRPr sz="2475" b="1">
-                <a:solidFill>
-                  <a:srgbClr val="17212B"/>
+              <a:defRPr sz="2100" b="1">
+                <a:solidFill>
+                  <a:srgbClr val="0B6172"/>
                 </a:solidFill>
                 <a:latin typeface="Malgun Gothic"/>
                 <a:ea typeface="Malgun Gothic"/>
@@ -11926,25 +11795,25 @@
               </a:defRPr>
             </a:pPr>
             <a:r>
-              <a:rPr sz="2475" b="1">
-                <a:solidFill>
-                  <a:srgbClr val="17212B"/>
+              <a:rPr sz="2100" b="1">
+                <a:solidFill>
+                  <a:srgbClr val="0B6172"/>
                 </a:solidFill>
                 <a:latin typeface="Malgun Gothic"/>
                 <a:ea typeface="Malgun Gothic"/>
                 <a:cs typeface="Malgun Gothic"/>
               </a:rPr>
-              <a:t>이미지 연산</a:t>
+              <a:t>계약</a:t>
             </a:r>
           </a:p>
         </p:txBody>
       </p:sp>
       <p:sp>
         <p:nvSpPr>
-          <p:cNvPr id="18" name="구현은 어떻게 생겼나?">
+          <p:cNvPr id="14" name="원래 기대한 동작은?">
             <a:extLst xmlns:a="http://schemas.openxmlformats.org/drawingml/2006/main">
               <a:ext uri="{FF2B5EF4-FFF2-40B4-BE49-F238E27FC236}">
-                <a16:creationId xmlns:a16="http://schemas.microsoft.com/office/drawing/2014/main" id="{95E7D3E8-ED4C-4849-8E5A-47088D52C280}"/>
+                <a16:creationId xmlns:a16="http://schemas.microsoft.com/office/drawing/2014/main" id="{05EA532B-8889-4B2A-B594-FE56F22014D1}"/>
               </a:ext>
             </a:extLst>
           </p:cNvPr>
@@ -11955,8 +11824,8 @@
         </p:nvSpPr>
         <p:spPr>
           <a:xfrm xmlns:a="http://schemas.openxmlformats.org/drawingml/2006/main">
-            <a:off x="8382000" y="3648075"/>
-            <a:ext cx="2971800" cy="342900"/>
+            <a:off x="8096250" y="4781550"/>
+            <a:ext cx="3486150" cy="342900"/>
           </a:xfrm>
           <a:prstGeom xmlns:a="http://schemas.openxmlformats.org/drawingml/2006/main" prst="rect">
             <a:avLst/>
@@ -11972,7 +11841,7 @@
           </a:bodyPr>
           <a:lstStyle xmlns:a="http://schemas.openxmlformats.org/drawingml/2006/main">
             <a:defPPr algn="l">
-              <a:defRPr sz="2100" b="0">
+              <a:defRPr sz="1800" b="0">
                 <a:solidFill>
                   <a:srgbClr val="4D5A68"/>
                 </a:solidFill>
@@ -11982,7 +11851,7 @@
               </a:defRPr>
             </a:defPPr>
             <a:lvl1pPr algn="l">
-              <a:defRPr sz="2100" b="0">
+              <a:defRPr sz="1800" b="0">
                 <a:solidFill>
                   <a:srgbClr val="4D5A68"/>
                 </a:solidFill>
@@ -11992,7 +11861,7 @@
               </a:defRPr>
             </a:lvl1pPr>
             <a:lvl2pPr algn="l">
-              <a:defRPr sz="2100" b="0">
+              <a:defRPr sz="1800" b="0">
                 <a:solidFill>
                   <a:srgbClr val="4D5A68"/>
                 </a:solidFill>
@@ -12002,7 +11871,7 @@
               </a:defRPr>
             </a:lvl2pPr>
             <a:lvl3pPr algn="l">
-              <a:defRPr sz="2100" b="0">
+              <a:defRPr sz="1800" b="0">
                 <a:solidFill>
                   <a:srgbClr val="4D5A68"/>
                 </a:solidFill>
@@ -12012,7 +11881,7 @@
               </a:defRPr>
             </a:lvl3pPr>
             <a:lvl4pPr algn="l">
-              <a:defRPr sz="2100" b="0">
+              <a:defRPr sz="1800" b="0">
                 <a:solidFill>
                   <a:srgbClr val="4D5A68"/>
                 </a:solidFill>
@@ -12022,7 +11891,7 @@
               </a:defRPr>
             </a:lvl4pPr>
             <a:lvl5pPr algn="l">
-              <a:defRPr sz="2100" b="0">
+              <a:defRPr sz="1800" b="0">
                 <a:solidFill>
                   <a:srgbClr val="4D5A68"/>
                 </a:solidFill>
@@ -12032,7 +11901,7 @@
               </a:defRPr>
             </a:lvl5pPr>
             <a:lvl6pPr algn="l">
-              <a:defRPr sz="2100" b="0">
+              <a:defRPr sz="1800" b="0">
                 <a:solidFill>
                   <a:srgbClr val="4D5A68"/>
                 </a:solidFill>
@@ -12042,7 +11911,7 @@
               </a:defRPr>
             </a:lvl6pPr>
             <a:lvl7pPr algn="l">
-              <a:defRPr sz="2100" b="0">
+              <a:defRPr sz="1800" b="0">
                 <a:solidFill>
                   <a:srgbClr val="4D5A68"/>
                 </a:solidFill>
@@ -12052,7 +11921,7 @@
               </a:defRPr>
             </a:lvl7pPr>
             <a:lvl8pPr algn="l">
-              <a:defRPr sz="2100" b="0">
+              <a:defRPr sz="1800" b="0">
                 <a:solidFill>
                   <a:srgbClr val="4D5A68"/>
                 </a:solidFill>
@@ -12062,7 +11931,7 @@
               </a:defRPr>
             </a:lvl8pPr>
             <a:lvl9pPr algn="l">
-              <a:defRPr sz="2100" b="0">
+              <a:defRPr sz="1800" b="0">
                 <a:solidFill>
                   <a:srgbClr val="4D5A68"/>
                 </a:solidFill>
@@ -12074,7 +11943,7 @@
           </a:lstStyle>
           <a:p xmlns:a="http://schemas.openxmlformats.org/drawingml/2006/main">
             <a:pPr algn="l">
-              <a:defRPr sz="2100" b="0">
+              <a:defRPr sz="1800" b="0">
                 <a:solidFill>
                   <a:srgbClr val="4D5A68"/>
                 </a:solidFill>
@@ -12084,7 +11953,7 @@
               </a:defRPr>
             </a:pPr>
             <a:r>
-              <a:rPr sz="2100" b="0">
+              <a:rPr sz="1800" b="0">
                 <a:solidFill>
                   <a:srgbClr val="4D5A68"/>
                 </a:solidFill>
@@ -12092,17 +11961,17 @@
                 <a:ea typeface="Malgun Gothic"/>
                 <a:cs typeface="Malgun Gothic"/>
               </a:rPr>
-              <a:t>구현은 어떻게 생겼나?</a:t>
+              <a:t>원래 기대한 동작은?</a:t>
             </a:r>
           </a:p>
         </p:txBody>
       </p:sp>
       <p:sp>
         <p:nvSpPr>
-          <p:cNvPr id="19" name="">
+          <p:cNvPr id="15" name="질문에 옮길 자료는?">
             <a:extLst xmlns:a="http://schemas.openxmlformats.org/drawingml/2006/main">
               <a:ext uri="{FF2B5EF4-FFF2-40B4-BE49-F238E27FC236}">
-                <a16:creationId xmlns:a16="http://schemas.microsoft.com/office/drawing/2014/main" id="{7782C34F-9AB7-4B8E-8D4A-CBF7A2345B82}"/>
+                <a16:creationId xmlns:a16="http://schemas.microsoft.com/office/drawing/2014/main" id="{AED84CD0-EAA2-4877-A7F3-97560EE6A595}"/>
               </a:ext>
             </a:extLst>
           </p:cNvPr>
@@ -12113,39 +11982,8 @@
         </p:nvSpPr>
         <p:spPr>
           <a:xfrm xmlns:a="http://schemas.openxmlformats.org/drawingml/2006/main">
-            <a:off x="609600" y="4581525"/>
-            <a:ext cx="10972800" cy="0"/>
-          </a:xfrm>
-          <a:prstGeom xmlns:a="http://schemas.openxmlformats.org/drawingml/2006/main" prst="line">
-            <a:avLst/>
-          </a:prstGeom>
-          <a:noFill xmlns:a="http://schemas.openxmlformats.org/drawingml/2006/main"/>
-          <a:ln xmlns:a="http://schemas.openxmlformats.org/drawingml/2006/main" w="9525">
-            <a:solidFill>
-              <a:srgbClr val="C7D0DA"/>
-            </a:solidFill>
-            <a:prstDash val="solid"/>
-          </a:ln>
-        </p:spPr>
-      </p:sp>
-      <p:sp>
-        <p:nvSpPr>
-          <p:cNvPr id="20" name="테스트">
-            <a:extLst xmlns:a="http://schemas.openxmlformats.org/drawingml/2006/main">
-              <a:ext uri="{FF2B5EF4-FFF2-40B4-BE49-F238E27FC236}">
-                <a16:creationId xmlns:a16="http://schemas.microsoft.com/office/drawing/2014/main" id="{934D07B6-4F69-424F-A939-04B3D6DD893B}"/>
-              </a:ext>
-            </a:extLst>
-          </p:cNvPr>
-          <p:cNvSpPr>
-            <a:spLocks xmlns:a="http://schemas.openxmlformats.org/drawingml/2006/main" noGrp="1"/>
-          </p:cNvSpPr>
-          <p:nvPr/>
-        </p:nvSpPr>
-        <p:spPr>
-          <a:xfrm xmlns:a="http://schemas.openxmlformats.org/drawingml/2006/main">
-            <a:off x="609600" y="4876800"/>
-            <a:ext cx="1524000" cy="381000"/>
+            <a:off x="8096250" y="5314950"/>
+            <a:ext cx="3486150" cy="361950"/>
           </a:xfrm>
           <a:prstGeom xmlns:a="http://schemas.openxmlformats.org/drawingml/2006/main" prst="rect">
             <a:avLst/>
@@ -12161,9 +11999,9 @@
           </a:bodyPr>
           <a:lstStyle xmlns:a="http://schemas.openxmlformats.org/drawingml/2006/main">
             <a:defPPr algn="l">
-              <a:defRPr sz="2250" b="1">
-                <a:solidFill>
-                  <a:srgbClr val="0B6172"/>
+              <a:defRPr sz="2025" b="1">
+                <a:solidFill>
+                  <a:srgbClr val="17212B"/>
                 </a:solidFill>
                 <a:latin typeface="Malgun Gothic"/>
                 <a:ea typeface="Malgun Gothic"/>
@@ -12171,9 +12009,9 @@
               </a:defRPr>
             </a:defPPr>
             <a:lvl1pPr algn="l">
-              <a:defRPr sz="2250" b="1">
-                <a:solidFill>
-                  <a:srgbClr val="0B6172"/>
+              <a:defRPr sz="2025" b="1">
+                <a:solidFill>
+                  <a:srgbClr val="17212B"/>
                 </a:solidFill>
                 <a:latin typeface="Malgun Gothic"/>
                 <a:ea typeface="Malgun Gothic"/>
@@ -12181,9 +12019,9 @@
               </a:defRPr>
             </a:lvl1pPr>
             <a:lvl2pPr algn="l">
-              <a:defRPr sz="2250" b="1">
-                <a:solidFill>
-                  <a:srgbClr val="0B6172"/>
+              <a:defRPr sz="2025" b="1">
+                <a:solidFill>
+                  <a:srgbClr val="17212B"/>
                 </a:solidFill>
                 <a:latin typeface="Malgun Gothic"/>
                 <a:ea typeface="Malgun Gothic"/>
@@ -12191,9 +12029,9 @@
               </a:defRPr>
             </a:lvl2pPr>
             <a:lvl3pPr algn="l">
-              <a:defRPr sz="2250" b="1">
-                <a:solidFill>
-                  <a:srgbClr val="0B6172"/>
+              <a:defRPr sz="2025" b="1">
+                <a:solidFill>
+                  <a:srgbClr val="17212B"/>
                 </a:solidFill>
                 <a:latin typeface="Malgun Gothic"/>
                 <a:ea typeface="Malgun Gothic"/>
@@ -12201,9 +12039,9 @@
               </a:defRPr>
             </a:lvl3pPr>
             <a:lvl4pPr algn="l">
-              <a:defRPr sz="2250" b="1">
-                <a:solidFill>
-                  <a:srgbClr val="0B6172"/>
+              <a:defRPr sz="2025" b="1">
+                <a:solidFill>
+                  <a:srgbClr val="17212B"/>
                 </a:solidFill>
                 <a:latin typeface="Malgun Gothic"/>
                 <a:ea typeface="Malgun Gothic"/>
@@ -12211,9 +12049,9 @@
               </a:defRPr>
             </a:lvl4pPr>
             <a:lvl5pPr algn="l">
-              <a:defRPr sz="2250" b="1">
-                <a:solidFill>
-                  <a:srgbClr val="0B6172"/>
+              <a:defRPr sz="2025" b="1">
+                <a:solidFill>
+                  <a:srgbClr val="17212B"/>
                 </a:solidFill>
                 <a:latin typeface="Malgun Gothic"/>
                 <a:ea typeface="Malgun Gothic"/>
@@ -12221,9 +12059,9 @@
               </a:defRPr>
             </a:lvl5pPr>
             <a:lvl6pPr algn="l">
-              <a:defRPr sz="2250" b="1">
-                <a:solidFill>
-                  <a:srgbClr val="0B6172"/>
+              <a:defRPr sz="2025" b="1">
+                <a:solidFill>
+                  <a:srgbClr val="17212B"/>
                 </a:solidFill>
                 <a:latin typeface="Malgun Gothic"/>
                 <a:ea typeface="Malgun Gothic"/>
@@ -12231,9 +12069,9 @@
               </a:defRPr>
             </a:lvl6pPr>
             <a:lvl7pPr algn="l">
-              <a:defRPr sz="2250" b="1">
-                <a:solidFill>
-                  <a:srgbClr val="0B6172"/>
+              <a:defRPr sz="2025" b="1">
+                <a:solidFill>
+                  <a:srgbClr val="17212B"/>
                 </a:solidFill>
                 <a:latin typeface="Malgun Gothic"/>
                 <a:ea typeface="Malgun Gothic"/>
@@ -12241,9 +12079,9 @@
               </a:defRPr>
             </a:lvl7pPr>
             <a:lvl8pPr algn="l">
-              <a:defRPr sz="2250" b="1">
-                <a:solidFill>
-                  <a:srgbClr val="0B6172"/>
+              <a:defRPr sz="2025" b="1">
+                <a:solidFill>
+                  <a:srgbClr val="17212B"/>
                 </a:solidFill>
                 <a:latin typeface="Malgun Gothic"/>
                 <a:ea typeface="Malgun Gothic"/>
@@ -12251,9 +12089,9 @@
               </a:defRPr>
             </a:lvl8pPr>
             <a:lvl9pPr algn="l">
-              <a:defRPr sz="2250" b="1">
-                <a:solidFill>
-                  <a:srgbClr val="0B6172"/>
+              <a:defRPr sz="2025" b="1">
+                <a:solidFill>
+                  <a:srgbClr val="17212B"/>
                 </a:solidFill>
                 <a:latin typeface="Malgun Gothic"/>
                 <a:ea typeface="Malgun Gothic"/>
@@ -12263,9 +12101,9 @@
           </a:lstStyle>
           <a:p xmlns:a="http://schemas.openxmlformats.org/drawingml/2006/main">
             <a:pPr algn="l">
-              <a:defRPr sz="2250" b="1">
-                <a:solidFill>
-                  <a:srgbClr val="0B6172"/>
+              <a:defRPr sz="2025" b="1">
+                <a:solidFill>
+                  <a:srgbClr val="17212B"/>
                 </a:solidFill>
                 <a:latin typeface="Malgun Gothic"/>
                 <a:ea typeface="Malgun Gothic"/>
@@ -12273,489 +12111,15 @@
               </a:defRPr>
             </a:pPr>
             <a:r>
-              <a:rPr sz="2250" b="1">
-                <a:solidFill>
-                  <a:srgbClr val="0B6172"/>
+              <a:rPr sz="2025" b="1">
+                <a:solidFill>
+                  <a:srgbClr val="17212B"/>
                 </a:solidFill>
                 <a:latin typeface="Malgun Gothic"/>
                 <a:ea typeface="Malgun Gothic"/>
                 <a:cs typeface="Malgun Gothic"/>
               </a:rPr>
-              <a:t>테스트</a:t>
-            </a:r>
-          </a:p>
-        </p:txBody>
-      </p:sp>
-      <p:sp>
-        <p:nvSpPr>
-          <p:cNvPr id="21" name="어떤 조건에서 실패했나?">
-            <a:extLst xmlns:a="http://schemas.openxmlformats.org/drawingml/2006/main">
-              <a:ext uri="{FF2B5EF4-FFF2-40B4-BE49-F238E27FC236}">
-                <a16:creationId xmlns:a16="http://schemas.microsoft.com/office/drawing/2014/main" id="{5A3D9022-B80D-4BB4-86A8-8B2903D84FBB}"/>
-              </a:ext>
-            </a:extLst>
-          </p:cNvPr>
-          <p:cNvSpPr>
-            <a:spLocks xmlns:a="http://schemas.openxmlformats.org/drawingml/2006/main" noGrp="1"/>
-          </p:cNvSpPr>
-          <p:nvPr/>
-        </p:nvSpPr>
-        <p:spPr>
-          <a:xfrm xmlns:a="http://schemas.openxmlformats.org/drawingml/2006/main">
-            <a:off x="2181225" y="4876800"/>
-            <a:ext cx="3962400" cy="381000"/>
-          </a:xfrm>
-          <a:prstGeom xmlns:a="http://schemas.openxmlformats.org/drawingml/2006/main" prst="rect">
-            <a:avLst/>
-          </a:prstGeom>
-          <a:noFill xmlns:a="http://schemas.openxmlformats.org/drawingml/2006/main"/>
-          <a:ln xmlns:a="http://schemas.openxmlformats.org/drawingml/2006/main" w="0">
-            <a:noFill/>
-          </a:ln>
-        </p:spPr>
-        <p:txBody>
-          <a:bodyPr xmlns:a="http://schemas.openxmlformats.org/drawingml/2006/main" wrap="none" lIns="0" tIns="0" rIns="0" bIns="0" anchor="ctr">
-            <a:noAutofit/>
-          </a:bodyPr>
-          <a:lstStyle xmlns:a="http://schemas.openxmlformats.org/drawingml/2006/main">
-            <a:defPPr algn="l">
-              <a:defRPr sz="2175" b="0">
-                <a:solidFill>
-                  <a:srgbClr val="17212B"/>
-                </a:solidFill>
-                <a:latin typeface="Malgun Gothic"/>
-                <a:ea typeface="Malgun Gothic"/>
-                <a:cs typeface="Malgun Gothic"/>
-              </a:defRPr>
-            </a:defPPr>
-            <a:lvl1pPr algn="l">
-              <a:defRPr sz="2175" b="0">
-                <a:solidFill>
-                  <a:srgbClr val="17212B"/>
-                </a:solidFill>
-                <a:latin typeface="Malgun Gothic"/>
-                <a:ea typeface="Malgun Gothic"/>
-                <a:cs typeface="Malgun Gothic"/>
-              </a:defRPr>
-            </a:lvl1pPr>
-            <a:lvl2pPr algn="l">
-              <a:defRPr sz="2175" b="0">
-                <a:solidFill>
-                  <a:srgbClr val="17212B"/>
-                </a:solidFill>
-                <a:latin typeface="Malgun Gothic"/>
-                <a:ea typeface="Malgun Gothic"/>
-                <a:cs typeface="Malgun Gothic"/>
-              </a:defRPr>
-            </a:lvl2pPr>
-            <a:lvl3pPr algn="l">
-              <a:defRPr sz="2175" b="0">
-                <a:solidFill>
-                  <a:srgbClr val="17212B"/>
-                </a:solidFill>
-                <a:latin typeface="Malgun Gothic"/>
-                <a:ea typeface="Malgun Gothic"/>
-                <a:cs typeface="Malgun Gothic"/>
-              </a:defRPr>
-            </a:lvl3pPr>
-            <a:lvl4pPr algn="l">
-              <a:defRPr sz="2175" b="0">
-                <a:solidFill>
-                  <a:srgbClr val="17212B"/>
-                </a:solidFill>
-                <a:latin typeface="Malgun Gothic"/>
-                <a:ea typeface="Malgun Gothic"/>
-                <a:cs typeface="Malgun Gothic"/>
-              </a:defRPr>
-            </a:lvl4pPr>
-            <a:lvl5pPr algn="l">
-              <a:defRPr sz="2175" b="0">
-                <a:solidFill>
-                  <a:srgbClr val="17212B"/>
-                </a:solidFill>
-                <a:latin typeface="Malgun Gothic"/>
-                <a:ea typeface="Malgun Gothic"/>
-                <a:cs typeface="Malgun Gothic"/>
-              </a:defRPr>
-            </a:lvl5pPr>
-            <a:lvl6pPr algn="l">
-              <a:defRPr sz="2175" b="0">
-                <a:solidFill>
-                  <a:srgbClr val="17212B"/>
-                </a:solidFill>
-                <a:latin typeface="Malgun Gothic"/>
-                <a:ea typeface="Malgun Gothic"/>
-                <a:cs typeface="Malgun Gothic"/>
-              </a:defRPr>
-            </a:lvl6pPr>
-            <a:lvl7pPr algn="l">
-              <a:defRPr sz="2175" b="0">
-                <a:solidFill>
-                  <a:srgbClr val="17212B"/>
-                </a:solidFill>
-                <a:latin typeface="Malgun Gothic"/>
-                <a:ea typeface="Malgun Gothic"/>
-                <a:cs typeface="Malgun Gothic"/>
-              </a:defRPr>
-            </a:lvl7pPr>
-            <a:lvl8pPr algn="l">
-              <a:defRPr sz="2175" b="0">
-                <a:solidFill>
-                  <a:srgbClr val="17212B"/>
-                </a:solidFill>
-                <a:latin typeface="Malgun Gothic"/>
-                <a:ea typeface="Malgun Gothic"/>
-                <a:cs typeface="Malgun Gothic"/>
-              </a:defRPr>
-            </a:lvl8pPr>
-            <a:lvl9pPr algn="l">
-              <a:defRPr sz="2175" b="0">
-                <a:solidFill>
-                  <a:srgbClr val="17212B"/>
-                </a:solidFill>
-                <a:latin typeface="Malgun Gothic"/>
-                <a:ea typeface="Malgun Gothic"/>
-                <a:cs typeface="Malgun Gothic"/>
-              </a:defRPr>
-            </a:lvl9pPr>
-          </a:lstStyle>
-          <a:p xmlns:a="http://schemas.openxmlformats.org/drawingml/2006/main">
-            <a:pPr algn="l">
-              <a:defRPr sz="2175" b="0">
-                <a:solidFill>
-                  <a:srgbClr val="17212B"/>
-                </a:solidFill>
-                <a:latin typeface="Malgun Gothic"/>
-                <a:ea typeface="Malgun Gothic"/>
-                <a:cs typeface="Malgun Gothic"/>
-              </a:defRPr>
-            </a:pPr>
-            <a:r>
-              <a:rPr sz="2175" b="0">
-                <a:solidFill>
-                  <a:srgbClr val="17212B"/>
-                </a:solidFill>
-                <a:latin typeface="Malgun Gothic"/>
-                <a:ea typeface="Malgun Gothic"/>
-                <a:cs typeface="Malgun Gothic"/>
-              </a:rPr>
-              <a:t>어떤 조건에서 실패했나?</a:t>
-            </a:r>
-          </a:p>
-        </p:txBody>
-      </p:sp>
-      <p:sp>
-        <p:nvSpPr>
-          <p:cNvPr id="22" name="계약">
-            <a:extLst xmlns:a="http://schemas.openxmlformats.org/drawingml/2006/main">
-              <a:ext uri="{FF2B5EF4-FFF2-40B4-BE49-F238E27FC236}">
-                <a16:creationId xmlns:a16="http://schemas.microsoft.com/office/drawing/2014/main" id="{EAF5AB63-9B7B-4E84-AA84-2BCDA14872F4}"/>
-              </a:ext>
-            </a:extLst>
-          </p:cNvPr>
-          <p:cNvSpPr>
-            <a:spLocks xmlns:a="http://schemas.openxmlformats.org/drawingml/2006/main" noGrp="1"/>
-          </p:cNvSpPr>
-          <p:nvPr/>
-        </p:nvSpPr>
-        <p:spPr>
-          <a:xfrm xmlns:a="http://schemas.openxmlformats.org/drawingml/2006/main">
-            <a:off x="6705600" y="4876800"/>
-            <a:ext cx="1047750" cy="381000"/>
-          </a:xfrm>
-          <a:prstGeom xmlns:a="http://schemas.openxmlformats.org/drawingml/2006/main" prst="rect">
-            <a:avLst/>
-          </a:prstGeom>
-          <a:noFill xmlns:a="http://schemas.openxmlformats.org/drawingml/2006/main"/>
-          <a:ln xmlns:a="http://schemas.openxmlformats.org/drawingml/2006/main" w="0">
-            <a:noFill/>
-          </a:ln>
-        </p:spPr>
-        <p:txBody>
-          <a:bodyPr xmlns:a="http://schemas.openxmlformats.org/drawingml/2006/main" wrap="none" lIns="0" tIns="0" rIns="0" bIns="0" anchor="ctr">
-            <a:noAutofit/>
-          </a:bodyPr>
-          <a:lstStyle xmlns:a="http://schemas.openxmlformats.org/drawingml/2006/main">
-            <a:defPPr algn="l">
-              <a:defRPr sz="2250" b="1">
-                <a:solidFill>
-                  <a:srgbClr val="0B6172"/>
-                </a:solidFill>
-                <a:latin typeface="Malgun Gothic"/>
-                <a:ea typeface="Malgun Gothic"/>
-                <a:cs typeface="Malgun Gothic"/>
-              </a:defRPr>
-            </a:defPPr>
-            <a:lvl1pPr algn="l">
-              <a:defRPr sz="2250" b="1">
-                <a:solidFill>
-                  <a:srgbClr val="0B6172"/>
-                </a:solidFill>
-                <a:latin typeface="Malgun Gothic"/>
-                <a:ea typeface="Malgun Gothic"/>
-                <a:cs typeface="Malgun Gothic"/>
-              </a:defRPr>
-            </a:lvl1pPr>
-            <a:lvl2pPr algn="l">
-              <a:defRPr sz="2250" b="1">
-                <a:solidFill>
-                  <a:srgbClr val="0B6172"/>
-                </a:solidFill>
-                <a:latin typeface="Malgun Gothic"/>
-                <a:ea typeface="Malgun Gothic"/>
-                <a:cs typeface="Malgun Gothic"/>
-              </a:defRPr>
-            </a:lvl2pPr>
-            <a:lvl3pPr algn="l">
-              <a:defRPr sz="2250" b="1">
-                <a:solidFill>
-                  <a:srgbClr val="0B6172"/>
-                </a:solidFill>
-                <a:latin typeface="Malgun Gothic"/>
-                <a:ea typeface="Malgun Gothic"/>
-                <a:cs typeface="Malgun Gothic"/>
-              </a:defRPr>
-            </a:lvl3pPr>
-            <a:lvl4pPr algn="l">
-              <a:defRPr sz="2250" b="1">
-                <a:solidFill>
-                  <a:srgbClr val="0B6172"/>
-                </a:solidFill>
-                <a:latin typeface="Malgun Gothic"/>
-                <a:ea typeface="Malgun Gothic"/>
-                <a:cs typeface="Malgun Gothic"/>
-              </a:defRPr>
-            </a:lvl4pPr>
-            <a:lvl5pPr algn="l">
-              <a:defRPr sz="2250" b="1">
-                <a:solidFill>
-                  <a:srgbClr val="0B6172"/>
-                </a:solidFill>
-                <a:latin typeface="Malgun Gothic"/>
-                <a:ea typeface="Malgun Gothic"/>
-                <a:cs typeface="Malgun Gothic"/>
-              </a:defRPr>
-            </a:lvl5pPr>
-            <a:lvl6pPr algn="l">
-              <a:defRPr sz="2250" b="1">
-                <a:solidFill>
-                  <a:srgbClr val="0B6172"/>
-                </a:solidFill>
-                <a:latin typeface="Malgun Gothic"/>
-                <a:ea typeface="Malgun Gothic"/>
-                <a:cs typeface="Malgun Gothic"/>
-              </a:defRPr>
-            </a:lvl6pPr>
-            <a:lvl7pPr algn="l">
-              <a:defRPr sz="2250" b="1">
-                <a:solidFill>
-                  <a:srgbClr val="0B6172"/>
-                </a:solidFill>
-                <a:latin typeface="Malgun Gothic"/>
-                <a:ea typeface="Malgun Gothic"/>
-                <a:cs typeface="Malgun Gothic"/>
-              </a:defRPr>
-            </a:lvl7pPr>
-            <a:lvl8pPr algn="l">
-              <a:defRPr sz="2250" b="1">
-                <a:solidFill>
-                  <a:srgbClr val="0B6172"/>
-                </a:solidFill>
-                <a:latin typeface="Malgun Gothic"/>
-                <a:ea typeface="Malgun Gothic"/>
-                <a:cs typeface="Malgun Gothic"/>
-              </a:defRPr>
-            </a:lvl8pPr>
-            <a:lvl9pPr algn="l">
-              <a:defRPr sz="2250" b="1">
-                <a:solidFill>
-                  <a:srgbClr val="0B6172"/>
-                </a:solidFill>
-                <a:latin typeface="Malgun Gothic"/>
-                <a:ea typeface="Malgun Gothic"/>
-                <a:cs typeface="Malgun Gothic"/>
-              </a:defRPr>
-            </a:lvl9pPr>
-          </a:lstStyle>
-          <a:p xmlns:a="http://schemas.openxmlformats.org/drawingml/2006/main">
-            <a:pPr algn="l">
-              <a:defRPr sz="2250" b="1">
-                <a:solidFill>
-                  <a:srgbClr val="0B6172"/>
-                </a:solidFill>
-                <a:latin typeface="Malgun Gothic"/>
-                <a:ea typeface="Malgun Gothic"/>
-                <a:cs typeface="Malgun Gothic"/>
-              </a:defRPr>
-            </a:pPr>
-            <a:r>
-              <a:rPr sz="2250" b="1">
-                <a:solidFill>
-                  <a:srgbClr val="0B6172"/>
-                </a:solidFill>
-                <a:latin typeface="Malgun Gothic"/>
-                <a:ea typeface="Malgun Gothic"/>
-                <a:cs typeface="Malgun Gothic"/>
-              </a:rPr>
-              <a:t>계약</a:t>
-            </a:r>
-          </a:p>
-        </p:txBody>
-      </p:sp>
-      <p:sp>
-        <p:nvSpPr>
-          <p:cNvPr id="23" name="원래 기대한 동작은?">
-            <a:extLst xmlns:a="http://schemas.openxmlformats.org/drawingml/2006/main">
-              <a:ext uri="{FF2B5EF4-FFF2-40B4-BE49-F238E27FC236}">
-                <a16:creationId xmlns:a16="http://schemas.microsoft.com/office/drawing/2014/main" id="{DA242F5F-855A-4097-A095-30B68471B7EF}"/>
-              </a:ext>
-            </a:extLst>
-          </p:cNvPr>
-          <p:cNvSpPr>
-            <a:spLocks xmlns:a="http://schemas.openxmlformats.org/drawingml/2006/main" noGrp="1"/>
-          </p:cNvSpPr>
-          <p:nvPr/>
-        </p:nvSpPr>
-        <p:spPr>
-          <a:xfrm xmlns:a="http://schemas.openxmlformats.org/drawingml/2006/main">
-            <a:off x="7867650" y="4876800"/>
-            <a:ext cx="3714750" cy="381000"/>
-          </a:xfrm>
-          <a:prstGeom xmlns:a="http://schemas.openxmlformats.org/drawingml/2006/main" prst="rect">
-            <a:avLst/>
-          </a:prstGeom>
-          <a:noFill xmlns:a="http://schemas.openxmlformats.org/drawingml/2006/main"/>
-          <a:ln xmlns:a="http://schemas.openxmlformats.org/drawingml/2006/main" w="0">
-            <a:noFill/>
-          </a:ln>
-        </p:spPr>
-        <p:txBody>
-          <a:bodyPr xmlns:a="http://schemas.openxmlformats.org/drawingml/2006/main" wrap="none" lIns="0" tIns="0" rIns="0" bIns="0" anchor="ctr">
-            <a:noAutofit/>
-          </a:bodyPr>
-          <a:lstStyle xmlns:a="http://schemas.openxmlformats.org/drawingml/2006/main">
-            <a:defPPr algn="l">
-              <a:defRPr sz="2175" b="0">
-                <a:solidFill>
-                  <a:srgbClr val="17212B"/>
-                </a:solidFill>
-                <a:latin typeface="Malgun Gothic"/>
-                <a:ea typeface="Malgun Gothic"/>
-                <a:cs typeface="Malgun Gothic"/>
-              </a:defRPr>
-            </a:defPPr>
-            <a:lvl1pPr algn="l">
-              <a:defRPr sz="2175" b="0">
-                <a:solidFill>
-                  <a:srgbClr val="17212B"/>
-                </a:solidFill>
-                <a:latin typeface="Malgun Gothic"/>
-                <a:ea typeface="Malgun Gothic"/>
-                <a:cs typeface="Malgun Gothic"/>
-              </a:defRPr>
-            </a:lvl1pPr>
-            <a:lvl2pPr algn="l">
-              <a:defRPr sz="2175" b="0">
-                <a:solidFill>
-                  <a:srgbClr val="17212B"/>
-                </a:solidFill>
-                <a:latin typeface="Malgun Gothic"/>
-                <a:ea typeface="Malgun Gothic"/>
-                <a:cs typeface="Malgun Gothic"/>
-              </a:defRPr>
-            </a:lvl2pPr>
-            <a:lvl3pPr algn="l">
-              <a:defRPr sz="2175" b="0">
-                <a:solidFill>
-                  <a:srgbClr val="17212B"/>
-                </a:solidFill>
-                <a:latin typeface="Malgun Gothic"/>
-                <a:ea typeface="Malgun Gothic"/>
-                <a:cs typeface="Malgun Gothic"/>
-              </a:defRPr>
-            </a:lvl3pPr>
-            <a:lvl4pPr algn="l">
-              <a:defRPr sz="2175" b="0">
-                <a:solidFill>
-                  <a:srgbClr val="17212B"/>
-                </a:solidFill>
-                <a:latin typeface="Malgun Gothic"/>
-                <a:ea typeface="Malgun Gothic"/>
-                <a:cs typeface="Malgun Gothic"/>
-              </a:defRPr>
-            </a:lvl4pPr>
-            <a:lvl5pPr algn="l">
-              <a:defRPr sz="2175" b="0">
-                <a:solidFill>
-                  <a:srgbClr val="17212B"/>
-                </a:solidFill>
-                <a:latin typeface="Malgun Gothic"/>
-                <a:ea typeface="Malgun Gothic"/>
-                <a:cs typeface="Malgun Gothic"/>
-              </a:defRPr>
-            </a:lvl5pPr>
-            <a:lvl6pPr algn="l">
-              <a:defRPr sz="2175" b="0">
-                <a:solidFill>
-                  <a:srgbClr val="17212B"/>
-                </a:solidFill>
-                <a:latin typeface="Malgun Gothic"/>
-                <a:ea typeface="Malgun Gothic"/>
-                <a:cs typeface="Malgun Gothic"/>
-              </a:defRPr>
-            </a:lvl6pPr>
-            <a:lvl7pPr algn="l">
-              <a:defRPr sz="2175" b="0">
-                <a:solidFill>
-                  <a:srgbClr val="17212B"/>
-                </a:solidFill>
-                <a:latin typeface="Malgun Gothic"/>
-                <a:ea typeface="Malgun Gothic"/>
-                <a:cs typeface="Malgun Gothic"/>
-              </a:defRPr>
-            </a:lvl7pPr>
-            <a:lvl8pPr algn="l">
-              <a:defRPr sz="2175" b="0">
-                <a:solidFill>
-                  <a:srgbClr val="17212B"/>
-                </a:solidFill>
-                <a:latin typeface="Malgun Gothic"/>
-                <a:ea typeface="Malgun Gothic"/>
-                <a:cs typeface="Malgun Gothic"/>
-              </a:defRPr>
-            </a:lvl8pPr>
-            <a:lvl9pPr algn="l">
-              <a:defRPr sz="2175" b="0">
-                <a:solidFill>
-                  <a:srgbClr val="17212B"/>
-                </a:solidFill>
-                <a:latin typeface="Malgun Gothic"/>
-                <a:ea typeface="Malgun Gothic"/>
-                <a:cs typeface="Malgun Gothic"/>
-              </a:defRPr>
-            </a:lvl9pPr>
-          </a:lstStyle>
-          <a:p xmlns:a="http://schemas.openxmlformats.org/drawingml/2006/main">
-            <a:pPr algn="l">
-              <a:defRPr sz="2175" b="0">
-                <a:solidFill>
-                  <a:srgbClr val="17212B"/>
-                </a:solidFill>
-                <a:latin typeface="Malgun Gothic"/>
-                <a:ea typeface="Malgun Gothic"/>
-                <a:cs typeface="Malgun Gothic"/>
-              </a:defRPr>
-            </a:pPr>
-            <a:r>
-              <a:rPr sz="2175" b="0">
-                <a:solidFill>
-                  <a:srgbClr val="17212B"/>
-                </a:solidFill>
-                <a:latin typeface="Malgun Gothic"/>
-                <a:ea typeface="Malgun Gothic"/>
-                <a:cs typeface="Malgun Gothic"/>
-              </a:rPr>
-              <a:t>원래 기대한 동작은?</a:t>
+              <a:t>질문에 옮길 자료는?</a:t>
             </a:r>
           </a:p>
         </p:txBody>
@@ -12763,7 +12127,7 @@
     </p:spTree>
     <p:extLst>
       <p:ext uri="{BB962C8B-B14F-4D97-AF65-F5344CB8AC3E}">
-        <p14:creationId xmlns:p14="http://schemas.microsoft.com/office/powerpoint/2010/main" val="482290962"/>
+        <p14:creationId xmlns:p14="http://schemas.microsoft.com/office/powerpoint/2010/main" val="1222811546"/>
       </p:ext>
     </p:extLst>
   </p:cSld>
@@ -12794,7 +12158,7 @@
           <p:cNvPr id="13" name="ACT 0 · Repository 조사 관찰">
             <a:extLst xmlns:a="http://schemas.openxmlformats.org/drawingml/2006/main">
               <a:ext uri="{FF2B5EF4-FFF2-40B4-BE49-F238E27FC236}">
-                <a16:creationId xmlns:a16="http://schemas.microsoft.com/office/drawing/2014/main" id="{870E97A9-6A78-4471-B1FF-2ADED3AD836E}"/>
+                <a16:creationId xmlns:a16="http://schemas.microsoft.com/office/drawing/2014/main" id="{0C94E3FA-8A54-4FCF-AF0D-E8560DC5CC83}"/>
               </a:ext>
             </a:extLst>
           </p:cNvPr>
@@ -12952,7 +12316,7 @@
           <p:cNvPr id="2" name="S04">
             <a:extLst xmlns:a="http://schemas.openxmlformats.org/drawingml/2006/main">
               <a:ext uri="{FF2B5EF4-FFF2-40B4-BE49-F238E27FC236}">
-                <a16:creationId xmlns:a16="http://schemas.microsoft.com/office/drawing/2014/main" id="{83CE539E-0BC0-4534-B11A-CF82D43DE9FF}"/>
+                <a16:creationId xmlns:a16="http://schemas.microsoft.com/office/drawing/2014/main" id="{93425AA1-2B1D-4671-99D0-89126C0FD630}"/>
               </a:ext>
             </a:extLst>
           </p:cNvPr>
@@ -13110,7 +12474,7 @@
           <p:cNvPr id="3" name="파일명을 주지 않으면 Agent는 어디부터 볼까?">
             <a:extLst xmlns:a="http://schemas.openxmlformats.org/drawingml/2006/main">
               <a:ext uri="{FF2B5EF4-FFF2-40B4-BE49-F238E27FC236}">
-                <a16:creationId xmlns:a16="http://schemas.microsoft.com/office/drawing/2014/main" id="{BA7AC396-982B-4F91-90E7-DFC026798779}"/>
+                <a16:creationId xmlns:a16="http://schemas.microsoft.com/office/drawing/2014/main" id="{E89C87DE-7F44-4B7A-BFF0-8A2BF94733F6}"/>
               </a:ext>
             </a:extLst>
           </p:cNvPr>
@@ -13268,7 +12632,7 @@
           <p:cNvPr id="4" name="">
             <a:extLst xmlns:a="http://schemas.openxmlformats.org/drawingml/2006/main">
               <a:ext uri="{FF2B5EF4-FFF2-40B4-BE49-F238E27FC236}">
-                <a16:creationId xmlns:a16="http://schemas.microsoft.com/office/drawing/2014/main" id="{D6857545-9336-49B1-8216-2EFB585705AA}"/>
+                <a16:creationId xmlns:a16="http://schemas.microsoft.com/office/drawing/2014/main" id="{63BF2002-FA0F-4655-B6C4-ABDD379380C5}"/>
               </a:ext>
             </a:extLst>
           </p:cNvPr>
@@ -13299,7 +12663,7 @@
           <p:cNvPr id="5" name="TRIAL-001 실제 요청 발췌 · Codex CLI 0.154.0 · macOS · 읽기 전용">
             <a:extLst xmlns:a="http://schemas.openxmlformats.org/drawingml/2006/main">
               <a:ext uri="{FF2B5EF4-FFF2-40B4-BE49-F238E27FC236}">
-                <a16:creationId xmlns:a16="http://schemas.microsoft.com/office/drawing/2014/main" id="{09294517-2C43-4042-954E-86F78C7028AC}"/>
+                <a16:creationId xmlns:a16="http://schemas.microsoft.com/office/drawing/2014/main" id="{1C8ABAD6-F002-4C43-806F-D96E636F02B6}"/>
               </a:ext>
             </a:extLst>
           </p:cNvPr>
@@ -13457,7 +12821,7 @@
           <p:cNvPr id="6" name="과거 단일 실행의 기록을 살펴봅니다. 현재 Desktop 동작은 미검증입니다.">
             <a:extLst xmlns:a="http://schemas.openxmlformats.org/drawingml/2006/main">
               <a:ext uri="{FF2B5EF4-FFF2-40B4-BE49-F238E27FC236}">
-                <a16:creationId xmlns:a16="http://schemas.microsoft.com/office/drawing/2014/main" id="{3CED6BA1-E533-4104-A973-702A261D9206}"/>
+                <a16:creationId xmlns:a16="http://schemas.microsoft.com/office/drawing/2014/main" id="{E7D748CC-038C-4EE7-9008-0C878149FEB3}"/>
               </a:ext>
             </a:extLst>
           </p:cNvPr>
@@ -13615,7 +12979,7 @@
           <p:cNvPr id="7" name="“현재 이 저장소에서 테스트 하나가 실패하고 있다.&#10;실패 원인을 조사해줘. 관련 구현과 호출 경로,&#10;실패하는">
             <a:extLst xmlns:a="http://schemas.openxmlformats.org/drawingml/2006/main">
               <a:ext uri="{FF2B5EF4-FFF2-40B4-BE49-F238E27FC236}">
-                <a16:creationId xmlns:a16="http://schemas.microsoft.com/office/drawing/2014/main" id="{C0030077-35DC-43EC-8416-3914313C8CF4}"/>
+                <a16:creationId xmlns:a16="http://schemas.microsoft.com/office/drawing/2014/main" id="{F33304CB-EA6D-4D18-9FEF-10B2714AEE55}"/>
               </a:ext>
             </a:extLst>
           </p:cNvPr>
@@ -13842,7 +13206,7 @@
           <p:cNvPr id="8" name="">
             <a:extLst xmlns:a="http://schemas.openxmlformats.org/drawingml/2006/main">
               <a:ext uri="{FF2B5EF4-FFF2-40B4-BE49-F238E27FC236}">
-                <a16:creationId xmlns:a16="http://schemas.microsoft.com/office/drawing/2014/main" id="{CC8BED9E-11D6-479E-833A-E0EF9D8D1B7F}"/>
+                <a16:creationId xmlns:a16="http://schemas.microsoft.com/office/drawing/2014/main" id="{3BDA4F60-1E1A-4795-916D-1A43BC8E48BE}"/>
               </a:ext>
             </a:extLst>
           </p:cNvPr>
@@ -13873,7 +13237,7 @@
           <p:cNvPr id="9" name="찾았는지 확인할 세 가지">
             <a:extLst xmlns:a="http://schemas.openxmlformats.org/drawingml/2006/main">
               <a:ext uri="{FF2B5EF4-FFF2-40B4-BE49-F238E27FC236}">
-                <a16:creationId xmlns:a16="http://schemas.microsoft.com/office/drawing/2014/main" id="{0FC283F8-73C6-451C-93D6-506327AF6FC5}"/>
+                <a16:creationId xmlns:a16="http://schemas.microsoft.com/office/drawing/2014/main" id="{D9D3927F-54D8-44B6-A80C-0BE7384D5059}"/>
               </a:ext>
             </a:extLst>
           </p:cNvPr>
@@ -14031,7 +13395,7 @@
           <p:cNvPr id="10" name="01  실패하는 테스트">
             <a:extLst xmlns:a="http://schemas.openxmlformats.org/drawingml/2006/main">
               <a:ext uri="{FF2B5EF4-FFF2-40B4-BE49-F238E27FC236}">
-                <a16:creationId xmlns:a16="http://schemas.microsoft.com/office/drawing/2014/main" id="{71936572-BB34-4ED8-989A-E5D57FD6446D}"/>
+                <a16:creationId xmlns:a16="http://schemas.microsoft.com/office/drawing/2014/main" id="{9F0FC140-FDE4-43AF-9684-75E807966FF4}"/>
               </a:ext>
             </a:extLst>
           </p:cNvPr>
@@ -14189,7 +13553,7 @@
           <p:cNvPr id="11" name="02  관련 구현">
             <a:extLst xmlns:a="http://schemas.openxmlformats.org/drawingml/2006/main">
               <a:ext uri="{FF2B5EF4-FFF2-40B4-BE49-F238E27FC236}">
-                <a16:creationId xmlns:a16="http://schemas.microsoft.com/office/drawing/2014/main" id="{8499124B-9CD3-44B8-8B24-C28767814088}"/>
+                <a16:creationId xmlns:a16="http://schemas.microsoft.com/office/drawing/2014/main" id="{285D67A6-2F13-4D13-A090-DC715DC50182}"/>
               </a:ext>
             </a:extLst>
           </p:cNvPr>
@@ -14347,7 +13711,7 @@
           <p:cNvPr id="12" name="03  제품의 호출 경로">
             <a:extLst xmlns:a="http://schemas.openxmlformats.org/drawingml/2006/main">
               <a:ext uri="{FF2B5EF4-FFF2-40B4-BE49-F238E27FC236}">
-                <a16:creationId xmlns:a16="http://schemas.microsoft.com/office/drawing/2014/main" id="{02D41078-7CBC-4858-AB59-7004CA088818}"/>
+                <a16:creationId xmlns:a16="http://schemas.microsoft.com/office/drawing/2014/main" id="{347F9352-DBDE-45F0-89EF-FA4CFCF091D5}"/>
               </a:ext>
             </a:extLst>
           </p:cNvPr>
@@ -14503,7 +13867,7 @@
     </p:spTree>
     <p:extLst>
       <p:ext uri="{BB962C8B-B14F-4D97-AF65-F5344CB8AC3E}">
-        <p14:creationId xmlns:p14="http://schemas.microsoft.com/office/powerpoint/2010/main" val="1273137831"/>
+        <p14:creationId xmlns:p14="http://schemas.microsoft.com/office/powerpoint/2010/main" val="249993681"/>
       </p:ext>
     </p:extLst>
   </p:cSld>
@@ -14534,7 +13898,7 @@
           <p:cNvPr id="63" name="ACT 0  ·  Repository 탐색">
             <a:extLst xmlns:a="http://schemas.openxmlformats.org/drawingml/2006/main">
               <a:ext uri="{FF2B5EF4-FFF2-40B4-BE49-F238E27FC236}">
-                <a16:creationId xmlns:a16="http://schemas.microsoft.com/office/drawing/2014/main" id="{8518F184-3E73-43DA-88BD-143CF3885CAC}"/>
+                <a16:creationId xmlns:a16="http://schemas.microsoft.com/office/drawing/2014/main" id="{090F1E7B-AC3F-474E-AC57-6BBF7A36D465}"/>
               </a:ext>
             </a:extLst>
           </p:cNvPr>
@@ -14692,7 +14056,7 @@
           <p:cNvPr id="2" name="S05">
             <a:extLst xmlns:a="http://schemas.openxmlformats.org/drawingml/2006/main">
               <a:ext uri="{FF2B5EF4-FFF2-40B4-BE49-F238E27FC236}">
-                <a16:creationId xmlns:a16="http://schemas.microsoft.com/office/drawing/2014/main" id="{5DCCF0F2-4CD9-4B37-8D91-7D661579346A}"/>
+                <a16:creationId xmlns:a16="http://schemas.microsoft.com/office/drawing/2014/main" id="{E2CFC4B5-B1EF-4E68-B7AE-C40E03220E09}"/>
               </a:ext>
             </a:extLst>
           </p:cNvPr>
@@ -14850,7 +14214,7 @@
           <p:cNvPr id="3" name="Agent가 Test와 호출 경로를 찾았다">
             <a:extLst xmlns:a="http://schemas.openxmlformats.org/drawingml/2006/main">
               <a:ext uri="{FF2B5EF4-FFF2-40B4-BE49-F238E27FC236}">
-                <a16:creationId xmlns:a16="http://schemas.microsoft.com/office/drawing/2014/main" id="{A011AC77-0E82-4CE1-A15A-4D14E261FF25}"/>
+                <a16:creationId xmlns:a16="http://schemas.microsoft.com/office/drawing/2014/main" id="{7D7864AB-A953-4429-9689-0084D5401266}"/>
               </a:ext>
             </a:extLst>
           </p:cNvPr>
@@ -15008,7 +14372,7 @@
           <p:cNvPr id="4" name="">
             <a:extLst xmlns:a="http://schemas.openxmlformats.org/drawingml/2006/main">
               <a:ext uri="{FF2B5EF4-FFF2-40B4-BE49-F238E27FC236}">
-                <a16:creationId xmlns:a16="http://schemas.microsoft.com/office/drawing/2014/main" id="{053CCAAD-E6D9-46E3-8A8A-0238D746A431}"/>
+                <a16:creationId xmlns:a16="http://schemas.microsoft.com/office/drawing/2014/main" id="{336FE0C9-A711-43A9-8CC6-359E3CE0CE72}"/>
               </a:ext>
             </a:extLst>
           </p:cNvPr>
@@ -15039,7 +14403,7 @@
           <p:cNvPr id="5" name="TRIAL-001 기록·STATE-00 테스트 재구성  |  Codex CLI 0.154.0 · 읽기 전용">
             <a:extLst xmlns:a="http://schemas.openxmlformats.org/drawingml/2006/main">
               <a:ext uri="{FF2B5EF4-FFF2-40B4-BE49-F238E27FC236}">
-                <a16:creationId xmlns:a16="http://schemas.microsoft.com/office/drawing/2014/main" id="{8909BD09-9120-4284-8BB0-318E9F80FBAF}"/>
+                <a16:creationId xmlns:a16="http://schemas.microsoft.com/office/drawing/2014/main" id="{8EBB4BD6-7E05-45F6-9CF3-9B5718AE64A2}"/>
               </a:ext>
             </a:extLst>
           </p:cNvPr>
@@ -15197,7 +14561,7 @@
           <p:cNvPr id="6" name="실제 실행 화면이 아님 · 이 조사에서는 코드 수정 없음 · 현재 Desktop 동작 미검증">
             <a:extLst xmlns:a="http://schemas.openxmlformats.org/drawingml/2006/main">
               <a:ext uri="{FF2B5EF4-FFF2-40B4-BE49-F238E27FC236}">
-                <a16:creationId xmlns:a16="http://schemas.microsoft.com/office/drawing/2014/main" id="{736FAF93-8F1F-4383-8E24-BD9708564BDD}"/>
+                <a16:creationId xmlns:a16="http://schemas.microsoft.com/office/drawing/2014/main" id="{BBC3DCE3-4C52-435E-82ED-6567189FA892}"/>
               </a:ext>
             </a:extLst>
           </p:cNvPr>
@@ -15355,7 +14719,7 @@
           <p:cNvPr id="7" name="crop(image, 1, 3)">
             <a:extLst xmlns:a="http://schemas.openxmlformats.org/drawingml/2006/main">
               <a:ext uri="{FF2B5EF4-FFF2-40B4-BE49-F238E27FC236}">
-                <a16:creationId xmlns:a16="http://schemas.microsoft.com/office/drawing/2014/main" id="{88D63B04-C9FF-43ED-A023-6370965471FE}"/>
+                <a16:creationId xmlns:a16="http://schemas.microsoft.com/office/drawing/2014/main" id="{6460E3CE-B598-443E-AFB3-5B07821FD00C}"/>
               </a:ext>
             </a:extLst>
           </p:cNvPr>
@@ -15513,7 +14877,7 @@
           <p:cNvPr id="8" name="끝 좌표 3은 포함하지 않는 계약">
             <a:extLst xmlns:a="http://schemas.openxmlformats.org/drawingml/2006/main">
               <a:ext uri="{FF2B5EF4-FFF2-40B4-BE49-F238E27FC236}">
-                <a16:creationId xmlns:a16="http://schemas.microsoft.com/office/drawing/2014/main" id="{2D677F69-3CAC-48E8-A486-D261FFDB1E76}"/>
+                <a16:creationId xmlns:a16="http://schemas.microsoft.com/office/drawing/2014/main" id="{29A31DD0-D499-4D0D-B7BB-AB8450A1AF85}"/>
               </a:ext>
             </a:extLst>
           </p:cNvPr>
@@ -15671,7 +15035,7 @@
           <p:cNvPr id="9" name="입력">
             <a:extLst xmlns:a="http://schemas.openxmlformats.org/drawingml/2006/main">
               <a:ext uri="{FF2B5EF4-FFF2-40B4-BE49-F238E27FC236}">
-                <a16:creationId xmlns:a16="http://schemas.microsoft.com/office/drawing/2014/main" id="{0B41E804-D694-4B0E-86E7-BFC516A096B7}"/>
+                <a16:creationId xmlns:a16="http://schemas.microsoft.com/office/drawing/2014/main" id="{656005C9-4127-40CA-BEC7-6DAF2A7A7807}"/>
               </a:ext>
             </a:extLst>
           </p:cNvPr>
@@ -15829,7 +15193,7 @@
           <p:cNvPr id="10" name="0">
             <a:extLst xmlns:a="http://schemas.openxmlformats.org/drawingml/2006/main">
               <a:ext uri="{FF2B5EF4-FFF2-40B4-BE49-F238E27FC236}">
-                <a16:creationId xmlns:a16="http://schemas.microsoft.com/office/drawing/2014/main" id="{D53B8266-F181-4DFA-A396-B90925895EF2}"/>
+                <a16:creationId xmlns:a16="http://schemas.microsoft.com/office/drawing/2014/main" id="{8115D241-58CA-41A5-843B-20AF1EC8F022}"/>
               </a:ext>
             </a:extLst>
           </p:cNvPr>
@@ -15987,7 +15351,7 @@
           <p:cNvPr id="11" name="1">
             <a:extLst xmlns:a="http://schemas.openxmlformats.org/drawingml/2006/main">
               <a:ext uri="{FF2B5EF4-FFF2-40B4-BE49-F238E27FC236}">
-                <a16:creationId xmlns:a16="http://schemas.microsoft.com/office/drawing/2014/main" id="{507702EC-5944-421C-BDB8-E2776D6C7909}"/>
+                <a16:creationId xmlns:a16="http://schemas.microsoft.com/office/drawing/2014/main" id="{83EFCE0B-F3EE-42BE-B320-15BE3F75771E}"/>
               </a:ext>
             </a:extLst>
           </p:cNvPr>
@@ -16145,7 +15509,7 @@
           <p:cNvPr id="12" name="2">
             <a:extLst xmlns:a="http://schemas.openxmlformats.org/drawingml/2006/main">
               <a:ext uri="{FF2B5EF4-FFF2-40B4-BE49-F238E27FC236}">
-                <a16:creationId xmlns:a16="http://schemas.microsoft.com/office/drawing/2014/main" id="{BD907127-30BF-410A-B4B2-6E8953470AAF}"/>
+                <a16:creationId xmlns:a16="http://schemas.microsoft.com/office/drawing/2014/main" id="{E3C82293-C0AF-43D4-B886-36D501B2C790}"/>
               </a:ext>
             </a:extLst>
           </p:cNvPr>
@@ -16303,7 +15667,7 @@
           <p:cNvPr id="13" name="3">
             <a:extLst xmlns:a="http://schemas.openxmlformats.org/drawingml/2006/main">
               <a:ext uri="{FF2B5EF4-FFF2-40B4-BE49-F238E27FC236}">
-                <a16:creationId xmlns:a16="http://schemas.microsoft.com/office/drawing/2014/main" id="{D6B6F232-6B81-467D-ACE8-8AE17EBF32DE}"/>
+                <a16:creationId xmlns:a16="http://schemas.microsoft.com/office/drawing/2014/main" id="{CCE1593C-8530-4113-ABB4-0B8DC21F0193}"/>
               </a:ext>
             </a:extLst>
           </p:cNvPr>
@@ -16461,7 +15825,7 @@
           <p:cNvPr id="14" name="">
             <a:extLst xmlns:a="http://schemas.openxmlformats.org/drawingml/2006/main">
               <a:ext uri="{FF2B5EF4-FFF2-40B4-BE49-F238E27FC236}">
-                <a16:creationId xmlns:a16="http://schemas.microsoft.com/office/drawing/2014/main" id="{887C240B-E5BD-4E5F-8F73-426ED04D8302}"/>
+                <a16:creationId xmlns:a16="http://schemas.microsoft.com/office/drawing/2014/main" id="{8418689C-BE8F-4E87-A5C1-C4B08BE77565}"/>
               </a:ext>
             </a:extLst>
           </p:cNvPr>
@@ -16494,7 +15858,7 @@
           <p:cNvPr id="15" name="1">
             <a:extLst xmlns:a="http://schemas.openxmlformats.org/drawingml/2006/main">
               <a:ext uri="{FF2B5EF4-FFF2-40B4-BE49-F238E27FC236}">
-                <a16:creationId xmlns:a16="http://schemas.microsoft.com/office/drawing/2014/main" id="{C4CDABD1-70F5-4F8D-B15E-252732857E29}"/>
+                <a16:creationId xmlns:a16="http://schemas.microsoft.com/office/drawing/2014/main" id="{C5E30B15-C5C6-4597-AB39-1D48E5455880}"/>
               </a:ext>
             </a:extLst>
           </p:cNvPr>
@@ -16652,7 +16016,7 @@
           <p:cNvPr id="16" name="">
             <a:extLst xmlns:a="http://schemas.openxmlformats.org/drawingml/2006/main">
               <a:ext uri="{FF2B5EF4-FFF2-40B4-BE49-F238E27FC236}">
-                <a16:creationId xmlns:a16="http://schemas.microsoft.com/office/drawing/2014/main" id="{E9853536-03AF-421D-9175-8D9B03014043}"/>
+                <a16:creationId xmlns:a16="http://schemas.microsoft.com/office/drawing/2014/main" id="{1FBAE4A4-D62E-4FBC-A250-CAA09D21E763}"/>
               </a:ext>
             </a:extLst>
           </p:cNvPr>
@@ -16685,7 +16049,7 @@
           <p:cNvPr id="17" name="2">
             <a:extLst xmlns:a="http://schemas.openxmlformats.org/drawingml/2006/main">
               <a:ext uri="{FF2B5EF4-FFF2-40B4-BE49-F238E27FC236}">
-                <a16:creationId xmlns:a16="http://schemas.microsoft.com/office/drawing/2014/main" id="{C56C962D-F0ED-4A2C-9CBB-5AC8080171B6}"/>
+                <a16:creationId xmlns:a16="http://schemas.microsoft.com/office/drawing/2014/main" id="{1D788CAB-352A-4FAA-B7E5-80C21011EA3A}"/>
               </a:ext>
             </a:extLst>
           </p:cNvPr>
@@ -16843,7 +16207,7 @@
           <p:cNvPr id="18" name="">
             <a:extLst xmlns:a="http://schemas.openxmlformats.org/drawingml/2006/main">
               <a:ext uri="{FF2B5EF4-FFF2-40B4-BE49-F238E27FC236}">
-                <a16:creationId xmlns:a16="http://schemas.microsoft.com/office/drawing/2014/main" id="{AF01D817-2B67-48CD-BC99-655B56BBC24D}"/>
+                <a16:creationId xmlns:a16="http://schemas.microsoft.com/office/drawing/2014/main" id="{F9080762-9141-4081-A626-61853B1A6A3C}"/>
               </a:ext>
             </a:extLst>
           </p:cNvPr>
@@ -16876,7 +16240,7 @@
           <p:cNvPr id="19" name="3">
             <a:extLst xmlns:a="http://schemas.openxmlformats.org/drawingml/2006/main">
               <a:ext uri="{FF2B5EF4-FFF2-40B4-BE49-F238E27FC236}">
-                <a16:creationId xmlns:a16="http://schemas.microsoft.com/office/drawing/2014/main" id="{6F1472AA-1F5A-4775-A0B1-31A5B838AB7D}"/>
+                <a16:creationId xmlns:a16="http://schemas.microsoft.com/office/drawing/2014/main" id="{1A42FC53-5F54-414F-9827-82C7D7159170}"/>
               </a:ext>
             </a:extLst>
           </p:cNvPr>
@@ -17034,7 +16398,7 @@
           <p:cNvPr id="20" name="">
             <a:extLst xmlns:a="http://schemas.openxmlformats.org/drawingml/2006/main">
               <a:ext uri="{FF2B5EF4-FFF2-40B4-BE49-F238E27FC236}">
-                <a16:creationId xmlns:a16="http://schemas.microsoft.com/office/drawing/2014/main" id="{980EDBBC-4B84-45E0-8197-C1D77A240A56}"/>
+                <a16:creationId xmlns:a16="http://schemas.microsoft.com/office/drawing/2014/main" id="{7C82B4DF-4B13-4F7D-B414-5BF549794C9B}"/>
               </a:ext>
             </a:extLst>
           </p:cNvPr>
@@ -17067,7 +16431,7 @@
           <p:cNvPr id="21" name="4">
             <a:extLst xmlns:a="http://schemas.openxmlformats.org/drawingml/2006/main">
               <a:ext uri="{FF2B5EF4-FFF2-40B4-BE49-F238E27FC236}">
-                <a16:creationId xmlns:a16="http://schemas.microsoft.com/office/drawing/2014/main" id="{9EAC9726-E74B-4DD6-A8C7-181EC88A7782}"/>
+                <a16:creationId xmlns:a16="http://schemas.microsoft.com/office/drawing/2014/main" id="{C1B0E5F4-EB34-44F4-B787-34187B62622D}"/>
               </a:ext>
             </a:extLst>
           </p:cNvPr>
@@ -17225,7 +16589,7 @@
           <p:cNvPr id="22" name="">
             <a:extLst xmlns:a="http://schemas.openxmlformats.org/drawingml/2006/main">
               <a:ext uri="{FF2B5EF4-FFF2-40B4-BE49-F238E27FC236}">
-                <a16:creationId xmlns:a16="http://schemas.microsoft.com/office/drawing/2014/main" id="{6CBA4ECA-7CBC-4AA0-9A37-A86F169B1733}"/>
+                <a16:creationId xmlns:a16="http://schemas.microsoft.com/office/drawing/2014/main" id="{CEC51832-DE41-4838-AB12-6FCB7C1778A4}"/>
               </a:ext>
             </a:extLst>
           </p:cNvPr>
@@ -17258,7 +16622,7 @@
           <p:cNvPr id="23" name="5">
             <a:extLst xmlns:a="http://schemas.openxmlformats.org/drawingml/2006/main">
               <a:ext uri="{FF2B5EF4-FFF2-40B4-BE49-F238E27FC236}">
-                <a16:creationId xmlns:a16="http://schemas.microsoft.com/office/drawing/2014/main" id="{09A51057-F701-4ED1-B2BE-7A129845B9E6}"/>
+                <a16:creationId xmlns:a16="http://schemas.microsoft.com/office/drawing/2014/main" id="{A42E62B6-603C-4DB0-8B6B-550ED1C8F522}"/>
               </a:ext>
             </a:extLst>
           </p:cNvPr>
@@ -17416,7 +16780,7 @@
           <p:cNvPr id="24" name="">
             <a:extLst xmlns:a="http://schemas.openxmlformats.org/drawingml/2006/main">
               <a:ext uri="{FF2B5EF4-FFF2-40B4-BE49-F238E27FC236}">
-                <a16:creationId xmlns:a16="http://schemas.microsoft.com/office/drawing/2014/main" id="{9811364F-E849-4DFC-8A9E-264B96839C02}"/>
+                <a16:creationId xmlns:a16="http://schemas.microsoft.com/office/drawing/2014/main" id="{3EB64767-877B-4A19-968F-2090724BE4AC}"/>
               </a:ext>
             </a:extLst>
           </p:cNvPr>
@@ -17449,7 +16813,7 @@
           <p:cNvPr id="25" name="6">
             <a:extLst xmlns:a="http://schemas.openxmlformats.org/drawingml/2006/main">
               <a:ext uri="{FF2B5EF4-FFF2-40B4-BE49-F238E27FC236}">
-                <a16:creationId xmlns:a16="http://schemas.microsoft.com/office/drawing/2014/main" id="{D120C28E-B3EB-4291-9D16-2C99067243F5}"/>
+                <a16:creationId xmlns:a16="http://schemas.microsoft.com/office/drawing/2014/main" id="{F38596DA-F253-42C1-8185-91605B1FE62E}"/>
               </a:ext>
             </a:extLst>
           </p:cNvPr>
@@ -17607,7 +16971,7 @@
           <p:cNvPr id="26" name="">
             <a:extLst xmlns:a="http://schemas.openxmlformats.org/drawingml/2006/main">
               <a:ext uri="{FF2B5EF4-FFF2-40B4-BE49-F238E27FC236}">
-                <a16:creationId xmlns:a16="http://schemas.microsoft.com/office/drawing/2014/main" id="{65A69F10-9287-41B5-8306-9361E506ACA5}"/>
+                <a16:creationId xmlns:a16="http://schemas.microsoft.com/office/drawing/2014/main" id="{1F9655AD-D56F-4D51-BC4B-288BA1A76547}"/>
               </a:ext>
             </a:extLst>
           </p:cNvPr>
@@ -17640,7 +17004,7 @@
           <p:cNvPr id="27" name="7">
             <a:extLst xmlns:a="http://schemas.openxmlformats.org/drawingml/2006/main">
               <a:ext uri="{FF2B5EF4-FFF2-40B4-BE49-F238E27FC236}">
-                <a16:creationId xmlns:a16="http://schemas.microsoft.com/office/drawing/2014/main" id="{1338A769-7105-46C1-9792-8AA5E8D9144B}"/>
+                <a16:creationId xmlns:a16="http://schemas.microsoft.com/office/drawing/2014/main" id="{E0524178-0849-4876-9FE5-DAE2FC5FFA48}"/>
               </a:ext>
             </a:extLst>
           </p:cNvPr>
@@ -17798,7 +17162,7 @@
           <p:cNvPr id="28" name="">
             <a:extLst xmlns:a="http://schemas.openxmlformats.org/drawingml/2006/main">
               <a:ext uri="{FF2B5EF4-FFF2-40B4-BE49-F238E27FC236}">
-                <a16:creationId xmlns:a16="http://schemas.microsoft.com/office/drawing/2014/main" id="{F924E3FE-4227-4995-B94A-1A4407E4C673}"/>
+                <a16:creationId xmlns:a16="http://schemas.microsoft.com/office/drawing/2014/main" id="{C5840843-6F69-4702-96DF-924F272D7918}"/>
               </a:ext>
             </a:extLst>
           </p:cNvPr>
@@ -17831,7 +17195,7 @@
           <p:cNvPr id="29" name="8">
             <a:extLst xmlns:a="http://schemas.openxmlformats.org/drawingml/2006/main">
               <a:ext uri="{FF2B5EF4-FFF2-40B4-BE49-F238E27FC236}">
-                <a16:creationId xmlns:a16="http://schemas.microsoft.com/office/drawing/2014/main" id="{D494C8EC-9321-45F9-AFDD-354C3428D4BA}"/>
+                <a16:creationId xmlns:a16="http://schemas.microsoft.com/office/drawing/2014/main" id="{0F56AFBA-11A2-4D18-B114-57F257FC0B0A}"/>
               </a:ext>
             </a:extLst>
           </p:cNvPr>
@@ -17989,7 +17353,7 @@
           <p:cNvPr id="30" name="열 index">
             <a:extLst xmlns:a="http://schemas.openxmlformats.org/drawingml/2006/main">
               <a:ext uri="{FF2B5EF4-FFF2-40B4-BE49-F238E27FC236}">
-                <a16:creationId xmlns:a16="http://schemas.microsoft.com/office/drawing/2014/main" id="{C10D3F5A-178D-431D-A326-C73D0835FC37}"/>
+                <a16:creationId xmlns:a16="http://schemas.microsoft.com/office/drawing/2014/main" id="{A4ECD5E3-1C72-420D-9BD3-869353E5B3E7}"/>
               </a:ext>
             </a:extLst>
           </p:cNvPr>
@@ -18147,7 +17511,7 @@
           <p:cNvPr id="31" name="기대">
             <a:extLst xmlns:a="http://schemas.openxmlformats.org/drawingml/2006/main">
               <a:ext uri="{FF2B5EF4-FFF2-40B4-BE49-F238E27FC236}">
-                <a16:creationId xmlns:a16="http://schemas.microsoft.com/office/drawing/2014/main" id="{FAA145FD-57DF-4F69-AD0B-3170054C5CD2}"/>
+                <a16:creationId xmlns:a16="http://schemas.microsoft.com/office/drawing/2014/main" id="{462D7073-485C-4A26-950B-D66C0F8AC2D2}"/>
               </a:ext>
             </a:extLst>
           </p:cNvPr>
@@ -18305,7 +17669,7 @@
           <p:cNvPr id="32" name="">
             <a:extLst xmlns:a="http://schemas.openxmlformats.org/drawingml/2006/main">
               <a:ext uri="{FF2B5EF4-FFF2-40B4-BE49-F238E27FC236}">
-                <a16:creationId xmlns:a16="http://schemas.microsoft.com/office/drawing/2014/main" id="{05C8A3D9-A103-4DE3-AB48-32F77364B67B}"/>
+                <a16:creationId xmlns:a16="http://schemas.microsoft.com/office/drawing/2014/main" id="{A7B0616E-A5E2-41E4-AFDD-35888CF4878A}"/>
               </a:ext>
             </a:extLst>
           </p:cNvPr>
@@ -18338,7 +17702,7 @@
           <p:cNvPr id="33" name="2">
             <a:extLst xmlns:a="http://schemas.openxmlformats.org/drawingml/2006/main">
               <a:ext uri="{FF2B5EF4-FFF2-40B4-BE49-F238E27FC236}">
-                <a16:creationId xmlns:a16="http://schemas.microsoft.com/office/drawing/2014/main" id="{D8F04A78-9CB8-4E73-BF07-EB8555166235}"/>
+                <a16:creationId xmlns:a16="http://schemas.microsoft.com/office/drawing/2014/main" id="{2313EDFB-7A10-48E0-A37F-9ACCFD8A01EC}"/>
               </a:ext>
             </a:extLst>
           </p:cNvPr>
@@ -18496,7 +17860,7 @@
           <p:cNvPr id="34" name="">
             <a:extLst xmlns:a="http://schemas.openxmlformats.org/drawingml/2006/main">
               <a:ext uri="{FF2B5EF4-FFF2-40B4-BE49-F238E27FC236}">
-                <a16:creationId xmlns:a16="http://schemas.microsoft.com/office/drawing/2014/main" id="{01F9C932-CF4C-4405-8B76-236B6260F7B0}"/>
+                <a16:creationId xmlns:a16="http://schemas.microsoft.com/office/drawing/2014/main" id="{A5002CE8-B117-42A9-9A9F-FA7407D5947A}"/>
               </a:ext>
             </a:extLst>
           </p:cNvPr>
@@ -18529,7 +17893,7 @@
           <p:cNvPr id="35" name="3">
             <a:extLst xmlns:a="http://schemas.openxmlformats.org/drawingml/2006/main">
               <a:ext uri="{FF2B5EF4-FFF2-40B4-BE49-F238E27FC236}">
-                <a16:creationId xmlns:a16="http://schemas.microsoft.com/office/drawing/2014/main" id="{53C04F83-C59E-42CE-A15F-6F7D9C7837FE}"/>
+                <a16:creationId xmlns:a16="http://schemas.microsoft.com/office/drawing/2014/main" id="{15BE8618-4BD6-4F13-BB8F-17ABB8D7E3D7}"/>
               </a:ext>
             </a:extLst>
           </p:cNvPr>
@@ -18687,7 +18051,7 @@
           <p:cNvPr id="36" name="">
             <a:extLst xmlns:a="http://schemas.openxmlformats.org/drawingml/2006/main">
               <a:ext uri="{FF2B5EF4-FFF2-40B4-BE49-F238E27FC236}">
-                <a16:creationId xmlns:a16="http://schemas.microsoft.com/office/drawing/2014/main" id="{E50278CC-5072-4236-8CC3-0DA27DF1EBF8}"/>
+                <a16:creationId xmlns:a16="http://schemas.microsoft.com/office/drawing/2014/main" id="{2B9841AC-CF75-4D2F-85F1-A4FBADDE6212}"/>
               </a:ext>
             </a:extLst>
           </p:cNvPr>
@@ -18720,7 +18084,7 @@
           <p:cNvPr id="37" name="6">
             <a:extLst xmlns:a="http://schemas.openxmlformats.org/drawingml/2006/main">
               <a:ext uri="{FF2B5EF4-FFF2-40B4-BE49-F238E27FC236}">
-                <a16:creationId xmlns:a16="http://schemas.microsoft.com/office/drawing/2014/main" id="{B340A21E-B368-49A0-9A7E-9E198DF61667}"/>
+                <a16:creationId xmlns:a16="http://schemas.microsoft.com/office/drawing/2014/main" id="{3D2DAF53-9205-4B3F-A9BC-4B78BFB210E7}"/>
               </a:ext>
             </a:extLst>
           </p:cNvPr>
@@ -18878,7 +18242,7 @@
           <p:cNvPr id="38" name="">
             <a:extLst xmlns:a="http://schemas.openxmlformats.org/drawingml/2006/main">
               <a:ext uri="{FF2B5EF4-FFF2-40B4-BE49-F238E27FC236}">
-                <a16:creationId xmlns:a16="http://schemas.microsoft.com/office/drawing/2014/main" id="{8F42283F-50A1-4B2A-AE41-95321A9ABCCE}"/>
+                <a16:creationId xmlns:a16="http://schemas.microsoft.com/office/drawing/2014/main" id="{5E19EB09-CC62-497B-A00B-717345CECC52}"/>
               </a:ext>
             </a:extLst>
           </p:cNvPr>
@@ -18911,7 +18275,7 @@
           <p:cNvPr id="39" name="7">
             <a:extLst xmlns:a="http://schemas.openxmlformats.org/drawingml/2006/main">
               <a:ext uri="{FF2B5EF4-FFF2-40B4-BE49-F238E27FC236}">
-                <a16:creationId xmlns:a16="http://schemas.microsoft.com/office/drawing/2014/main" id="{D640C229-6D45-4D19-A3B6-A8868A072AF7}"/>
+                <a16:creationId xmlns:a16="http://schemas.microsoft.com/office/drawing/2014/main" id="{7E11F8BA-4543-4E48-99D8-CE07B83FB98A}"/>
               </a:ext>
             </a:extLst>
           </p:cNvPr>
@@ -19069,7 +18433,7 @@
           <p:cNvPr id="40" name="구현 결과">
             <a:extLst xmlns:a="http://schemas.openxmlformats.org/drawingml/2006/main">
               <a:ext uri="{FF2B5EF4-FFF2-40B4-BE49-F238E27FC236}">
-                <a16:creationId xmlns:a16="http://schemas.microsoft.com/office/drawing/2014/main" id="{B1160814-1D9F-428A-973B-F39C07F19A3D}"/>
+                <a16:creationId xmlns:a16="http://schemas.microsoft.com/office/drawing/2014/main" id="{65E48E6F-00D7-4539-B0AC-FC891F66B808}"/>
               </a:ext>
             </a:extLst>
           </p:cNvPr>
@@ -19227,7 +18591,7 @@
           <p:cNvPr id="41" name="">
             <a:extLst xmlns:a="http://schemas.openxmlformats.org/drawingml/2006/main">
               <a:ext uri="{FF2B5EF4-FFF2-40B4-BE49-F238E27FC236}">
-                <a16:creationId xmlns:a16="http://schemas.microsoft.com/office/drawing/2014/main" id="{F40404C2-8686-4AC4-96DD-088314B1138F}"/>
+                <a16:creationId xmlns:a16="http://schemas.microsoft.com/office/drawing/2014/main" id="{094BD095-598D-4840-8C8F-BCC2D81893FC}"/>
               </a:ext>
             </a:extLst>
           </p:cNvPr>
@@ -19260,7 +18624,7 @@
           <p:cNvPr id="42" name="2">
             <a:extLst xmlns:a="http://schemas.openxmlformats.org/drawingml/2006/main">
               <a:ext uri="{FF2B5EF4-FFF2-40B4-BE49-F238E27FC236}">
-                <a16:creationId xmlns:a16="http://schemas.microsoft.com/office/drawing/2014/main" id="{933262DC-D8D7-4AE8-8CDF-0A7A6037337C}"/>
+                <a16:creationId xmlns:a16="http://schemas.microsoft.com/office/drawing/2014/main" id="{6588BB52-AA11-4BA3-AC73-632961FAC18B}"/>
               </a:ext>
             </a:extLst>
           </p:cNvPr>
@@ -19418,7 +18782,7 @@
           <p:cNvPr id="43" name="">
             <a:extLst xmlns:a="http://schemas.openxmlformats.org/drawingml/2006/main">
               <a:ext uri="{FF2B5EF4-FFF2-40B4-BE49-F238E27FC236}">
-                <a16:creationId xmlns:a16="http://schemas.microsoft.com/office/drawing/2014/main" id="{116C401B-937F-4584-9175-B39A65946217}"/>
+                <a16:creationId xmlns:a16="http://schemas.microsoft.com/office/drawing/2014/main" id="{063FA254-AA32-4B1B-B349-3A53659A9832}"/>
               </a:ext>
             </a:extLst>
           </p:cNvPr>
@@ -19451,7 +18815,7 @@
           <p:cNvPr id="44" name="3">
             <a:extLst xmlns:a="http://schemas.openxmlformats.org/drawingml/2006/main">
               <a:ext uri="{FF2B5EF4-FFF2-40B4-BE49-F238E27FC236}">
-                <a16:creationId xmlns:a16="http://schemas.microsoft.com/office/drawing/2014/main" id="{9A276D30-D3EC-4611-8EA0-9A56AF98924F}"/>
+                <a16:creationId xmlns:a16="http://schemas.microsoft.com/office/drawing/2014/main" id="{E93124AD-E5B9-418A-A611-E4B0952E0470}"/>
               </a:ext>
             </a:extLst>
           </p:cNvPr>
@@ -19609,7 +18973,7 @@
           <p:cNvPr id="45" name="">
             <a:extLst xmlns:a="http://schemas.openxmlformats.org/drawingml/2006/main">
               <a:ext uri="{FF2B5EF4-FFF2-40B4-BE49-F238E27FC236}">
-                <a16:creationId xmlns:a16="http://schemas.microsoft.com/office/drawing/2014/main" id="{45690614-BF26-4F43-BF6F-7FCE5CBF93FE}"/>
+                <a16:creationId xmlns:a16="http://schemas.microsoft.com/office/drawing/2014/main" id="{97DFC535-4D87-4FD4-ADEC-E4457429C3D5}"/>
               </a:ext>
             </a:extLst>
           </p:cNvPr>
@@ -19642,7 +19006,7 @@
           <p:cNvPr id="46" name="4">
             <a:extLst xmlns:a="http://schemas.openxmlformats.org/drawingml/2006/main">
               <a:ext uri="{FF2B5EF4-FFF2-40B4-BE49-F238E27FC236}">
-                <a16:creationId xmlns:a16="http://schemas.microsoft.com/office/drawing/2014/main" id="{6C24387B-EA59-4B0B-9903-2EC01CCA5040}"/>
+                <a16:creationId xmlns:a16="http://schemas.microsoft.com/office/drawing/2014/main" id="{36F245BC-876B-4537-9BCE-AF9DA6D1D955}"/>
               </a:ext>
             </a:extLst>
           </p:cNvPr>
@@ -19800,7 +19164,7 @@
           <p:cNvPr id="47" name="">
             <a:extLst xmlns:a="http://schemas.openxmlformats.org/drawingml/2006/main">
               <a:ext uri="{FF2B5EF4-FFF2-40B4-BE49-F238E27FC236}">
-                <a16:creationId xmlns:a16="http://schemas.microsoft.com/office/drawing/2014/main" id="{3904D452-B58A-4F19-A275-A846E98F828F}"/>
+                <a16:creationId xmlns:a16="http://schemas.microsoft.com/office/drawing/2014/main" id="{44215016-85A3-41B0-8955-42AEEECBEE49}"/>
               </a:ext>
             </a:extLst>
           </p:cNvPr>
@@ -19833,7 +19197,7 @@
           <p:cNvPr id="48" name="6">
             <a:extLst xmlns:a="http://schemas.openxmlformats.org/drawingml/2006/main">
               <a:ext uri="{FF2B5EF4-FFF2-40B4-BE49-F238E27FC236}">
-                <a16:creationId xmlns:a16="http://schemas.microsoft.com/office/drawing/2014/main" id="{06F88A1B-FE47-472F-9889-C71F99CECAD7}"/>
+                <a16:creationId xmlns:a16="http://schemas.microsoft.com/office/drawing/2014/main" id="{C40DC2BB-466B-4DCE-8E34-7B1E56C0437C}"/>
               </a:ext>
             </a:extLst>
           </p:cNvPr>
@@ -19991,7 +19355,7 @@
           <p:cNvPr id="49" name="">
             <a:extLst xmlns:a="http://schemas.openxmlformats.org/drawingml/2006/main">
               <a:ext uri="{FF2B5EF4-FFF2-40B4-BE49-F238E27FC236}">
-                <a16:creationId xmlns:a16="http://schemas.microsoft.com/office/drawing/2014/main" id="{104392A5-4430-4DFD-95C7-ADB065146F26}"/>
+                <a16:creationId xmlns:a16="http://schemas.microsoft.com/office/drawing/2014/main" id="{5D22134E-A5DB-476A-9533-85C50F6412E5}"/>
               </a:ext>
             </a:extLst>
           </p:cNvPr>
@@ -20024,7 +19388,7 @@
           <p:cNvPr id="50" name="7">
             <a:extLst xmlns:a="http://schemas.openxmlformats.org/drawingml/2006/main">
               <a:ext uri="{FF2B5EF4-FFF2-40B4-BE49-F238E27FC236}">
-                <a16:creationId xmlns:a16="http://schemas.microsoft.com/office/drawing/2014/main" id="{E7004BD7-64BB-4992-BB55-A5D213132CCA}"/>
+                <a16:creationId xmlns:a16="http://schemas.microsoft.com/office/drawing/2014/main" id="{BC1BE0B9-F544-4424-84FC-F28EF2020BB9}"/>
               </a:ext>
             </a:extLst>
           </p:cNvPr>
@@ -20182,7 +19546,7 @@
           <p:cNvPr id="51" name="">
             <a:extLst xmlns:a="http://schemas.openxmlformats.org/drawingml/2006/main">
               <a:ext uri="{FF2B5EF4-FFF2-40B4-BE49-F238E27FC236}">
-                <a16:creationId xmlns:a16="http://schemas.microsoft.com/office/drawing/2014/main" id="{DCC959C9-BB83-4D07-9950-C7740DACDC96}"/>
+                <a16:creationId xmlns:a16="http://schemas.microsoft.com/office/drawing/2014/main" id="{B3E59BC5-6E48-4B48-B28C-710764BC7C12}"/>
               </a:ext>
             </a:extLst>
           </p:cNvPr>
@@ -20215,7 +19579,7 @@
           <p:cNvPr id="52" name="8">
             <a:extLst xmlns:a="http://schemas.openxmlformats.org/drawingml/2006/main">
               <a:ext uri="{FF2B5EF4-FFF2-40B4-BE49-F238E27FC236}">
-                <a16:creationId xmlns:a16="http://schemas.microsoft.com/office/drawing/2014/main" id="{4B97DAF4-AA31-4B73-89BD-1181DBD649ED}"/>
+                <a16:creationId xmlns:a16="http://schemas.microsoft.com/office/drawing/2014/main" id="{1B62E5B8-0B47-47FE-9438-F8FD208D288A}"/>
               </a:ext>
             </a:extLst>
           </p:cNvPr>
@@ -20373,7 +19737,7 @@
           <p:cNvPr id="53" name="한 열이 더 포함됨">
             <a:extLst xmlns:a="http://schemas.openxmlformats.org/drawingml/2006/main">
               <a:ext uri="{FF2B5EF4-FFF2-40B4-BE49-F238E27FC236}">
-                <a16:creationId xmlns:a16="http://schemas.microsoft.com/office/drawing/2014/main" id="{E27BC1FF-D7E8-464C-A80F-B951B829030F}"/>
+                <a16:creationId xmlns:a16="http://schemas.microsoft.com/office/drawing/2014/main" id="{3ED942C9-F930-4532-A542-FF74116B3A9C}"/>
               </a:ext>
             </a:extLst>
           </p:cNvPr>
@@ -20531,7 +19895,7 @@
           <p:cNvPr id="54" name="">
             <a:extLst xmlns:a="http://schemas.openxmlformats.org/drawingml/2006/main">
               <a:ext uri="{FF2B5EF4-FFF2-40B4-BE49-F238E27FC236}">
-                <a16:creationId xmlns:a16="http://schemas.microsoft.com/office/drawing/2014/main" id="{9EDB1D1A-86C6-48A0-B366-470B94189752}"/>
+                <a16:creationId xmlns:a16="http://schemas.microsoft.com/office/drawing/2014/main" id="{6996C952-64D7-4B6B-834D-4E7BF00082B6}"/>
               </a:ext>
             </a:extLst>
           </p:cNvPr>
@@ -20562,7 +19926,7 @@
           <p:cNvPr id="55" name="조사에서 연결한 근거">
             <a:extLst xmlns:a="http://schemas.openxmlformats.org/drawingml/2006/main">
               <a:ext uri="{FF2B5EF4-FFF2-40B4-BE49-F238E27FC236}">
-                <a16:creationId xmlns:a16="http://schemas.microsoft.com/office/drawing/2014/main" id="{B7883911-6A00-4DE3-9A81-3B5A2F033CD9}"/>
+                <a16:creationId xmlns:a16="http://schemas.microsoft.com/office/drawing/2014/main" id="{92FA8907-ED0F-4B84-8292-FC949057D154}"/>
               </a:ext>
             </a:extLst>
           </p:cNvPr>
@@ -20720,7 +20084,7 @@
           <p:cNvPr id="56" name="01  실패 테스트">
             <a:extLst xmlns:a="http://schemas.openxmlformats.org/drawingml/2006/main">
               <a:ext uri="{FF2B5EF4-FFF2-40B4-BE49-F238E27FC236}">
-                <a16:creationId xmlns:a16="http://schemas.microsoft.com/office/drawing/2014/main" id="{99F822DD-99DC-4DFE-A19E-6C82E0A495FF}"/>
+                <a16:creationId xmlns:a16="http://schemas.microsoft.com/office/drawing/2014/main" id="{CEB216B4-1C24-4FA0-9789-667398868AA0}"/>
               </a:ext>
             </a:extLst>
           </p:cNvPr>
@@ -20878,7 +20242,7 @@
           <p:cNvPr id="57" name="test_crop_excludes_&#10;end_coordinate">
             <a:extLst xmlns:a="http://schemas.openxmlformats.org/drawingml/2006/main">
               <a:ext uri="{FF2B5EF4-FFF2-40B4-BE49-F238E27FC236}">
-                <a16:creationId xmlns:a16="http://schemas.microsoft.com/office/drawing/2014/main" id="{3DEA5A3D-922A-48EE-9772-834BF3AFE22B}"/>
+                <a16:creationId xmlns:a16="http://schemas.microsoft.com/office/drawing/2014/main" id="{18FBE978-B234-422F-8756-C7EC1B873239}"/>
               </a:ext>
             </a:extLst>
           </p:cNvPr>
@@ -21059,7 +20423,7 @@
           <p:cNvPr id="58" name="02  제품의 호출 경로">
             <a:extLst xmlns:a="http://schemas.openxmlformats.org/drawingml/2006/main">
               <a:ext uri="{FF2B5EF4-FFF2-40B4-BE49-F238E27FC236}">
-                <a16:creationId xmlns:a16="http://schemas.microsoft.com/office/drawing/2014/main" id="{280132EC-5F58-48C7-BDB9-5BF2F60C1D81}"/>
+                <a16:creationId xmlns:a16="http://schemas.microsoft.com/office/drawing/2014/main" id="{A70E908C-8B80-41A3-B765-B817350F416A}"/>
               </a:ext>
             </a:extLst>
           </p:cNvPr>
@@ -21217,7 +20581,7 @@
           <p:cNvPr id="59" name="cli.main → process_image → crop">
             <a:extLst xmlns:a="http://schemas.openxmlformats.org/drawingml/2006/main">
               <a:ext uri="{FF2B5EF4-FFF2-40B4-BE49-F238E27FC236}">
-                <a16:creationId xmlns:a16="http://schemas.microsoft.com/office/drawing/2014/main" id="{F49729DB-294A-472F-9312-601049F1B592}"/>
+                <a16:creationId xmlns:a16="http://schemas.microsoft.com/office/drawing/2014/main" id="{A9549513-8CD6-41A0-A952-6E0B9F45DB8B}"/>
               </a:ext>
             </a:extLst>
           </p:cNvPr>
@@ -21375,7 +20739,7 @@
           <p:cNvPr id="60" name="03  계약과 다른 구현">
             <a:extLst xmlns:a="http://schemas.openxmlformats.org/drawingml/2006/main">
               <a:ext uri="{FF2B5EF4-FFF2-40B4-BE49-F238E27FC236}">
-                <a16:creationId xmlns:a16="http://schemas.microsoft.com/office/drawing/2014/main" id="{40CD9D22-3169-43DA-89C1-9B78DFD53A3A}"/>
+                <a16:creationId xmlns:a16="http://schemas.microsoft.com/office/drawing/2014/main" id="{A2EC5EEE-86DB-42CF-9B34-10A1DA2750DF}"/>
               </a:ext>
             </a:extLst>
           </p:cNvPr>
@@ -21533,7 +20897,7 @@
           <p:cNvPr id="61" name="row[x_start : x_end + 1]">
             <a:extLst xmlns:a="http://schemas.openxmlformats.org/drawingml/2006/main">
               <a:ext uri="{FF2B5EF4-FFF2-40B4-BE49-F238E27FC236}">
-                <a16:creationId xmlns:a16="http://schemas.microsoft.com/office/drawing/2014/main" id="{7EF1B601-F658-4C30-BE0C-297894BECEC3}"/>
+                <a16:creationId xmlns:a16="http://schemas.microsoft.com/office/drawing/2014/main" id="{6340E590-298C-4B57-A1D2-F8F3D16E7123}"/>
               </a:ext>
             </a:extLst>
           </p:cNvPr>
@@ -21691,7 +21055,7 @@
           <p:cNvPr id="62" name="계약: [x_start, x_end)">
             <a:extLst xmlns:a="http://schemas.openxmlformats.org/drawingml/2006/main">
               <a:ext uri="{FF2B5EF4-FFF2-40B4-BE49-F238E27FC236}">
-                <a16:creationId xmlns:a16="http://schemas.microsoft.com/office/drawing/2014/main" id="{B56B41A5-F04C-4F46-B35E-2E6C78AB3218}"/>
+                <a16:creationId xmlns:a16="http://schemas.microsoft.com/office/drawing/2014/main" id="{856CED10-E19A-4E82-B03F-C0F295370BF0}"/>
               </a:ext>
             </a:extLst>
           </p:cNvPr>
@@ -21847,7 +21211,7 @@
     </p:spTree>
     <p:extLst>
       <p:ext uri="{BB962C8B-B14F-4D97-AF65-F5344CB8AC3E}">
-        <p14:creationId xmlns:p14="http://schemas.microsoft.com/office/powerpoint/2010/main" val="148551870"/>
+        <p14:creationId xmlns:p14="http://schemas.microsoft.com/office/powerpoint/2010/main" val="365614759"/>
       </p:ext>
     </p:extLst>
   </p:cSld>
@@ -21878,7 +21242,7 @@
           <p:cNvPr id="17" name="ACT 0 · 조사 결과 읽기">
             <a:extLst xmlns:a="http://schemas.openxmlformats.org/drawingml/2006/main">
               <a:ext uri="{FF2B5EF4-FFF2-40B4-BE49-F238E27FC236}">
-                <a16:creationId xmlns:a16="http://schemas.microsoft.com/office/drawing/2014/main" id="{9CB89B9A-3E07-4942-A5AF-9CD7678E5149}"/>
+                <a16:creationId xmlns:a16="http://schemas.microsoft.com/office/drawing/2014/main" id="{061204E5-7505-4BAA-BE70-5A72058C10F3}"/>
               </a:ext>
             </a:extLst>
           </p:cNvPr>
@@ -22036,7 +21400,7 @@
           <p:cNvPr id="2" name="S06">
             <a:extLst xmlns:a="http://schemas.openxmlformats.org/drawingml/2006/main">
               <a:ext uri="{FF2B5EF4-FFF2-40B4-BE49-F238E27FC236}">
-                <a16:creationId xmlns:a16="http://schemas.microsoft.com/office/drawing/2014/main" id="{2673C32F-E530-4C52-9D97-99614F22CAF9}"/>
+                <a16:creationId xmlns:a16="http://schemas.microsoft.com/office/drawing/2014/main" id="{7C505121-B7E4-4F75-AB78-4869F663CA37}"/>
               </a:ext>
             </a:extLst>
           </p:cNvPr>
@@ -22194,7 +21558,7 @@
           <p:cNvPr id="3" name="관찰 결과와 실행 제한을 분리한다">
             <a:extLst xmlns:a="http://schemas.openxmlformats.org/drawingml/2006/main">
               <a:ext uri="{FF2B5EF4-FFF2-40B4-BE49-F238E27FC236}">
-                <a16:creationId xmlns:a16="http://schemas.microsoft.com/office/drawing/2014/main" id="{93E87592-96B5-4118-9669-4AD934C8E402}"/>
+                <a16:creationId xmlns:a16="http://schemas.microsoft.com/office/drawing/2014/main" id="{E5AE4D75-9C63-43D9-903B-80D781B0A840}"/>
               </a:ext>
             </a:extLst>
           </p:cNvPr>
@@ -22352,7 +21716,7 @@
           <p:cNvPr id="4" name="">
             <a:extLst xmlns:a="http://schemas.openxmlformats.org/drawingml/2006/main">
               <a:ext uri="{FF2B5EF4-FFF2-40B4-BE49-F238E27FC236}">
-                <a16:creationId xmlns:a16="http://schemas.microsoft.com/office/drawing/2014/main" id="{41A0E2F7-A08A-4C4D-BADF-43972C5DE4A2}"/>
+                <a16:creationId xmlns:a16="http://schemas.microsoft.com/office/drawing/2014/main" id="{1A740151-9A07-4B91-A0EF-2CC2282403A8}"/>
               </a:ext>
             </a:extLst>
           </p:cNvPr>
@@ -22383,7 +21747,7 @@
           <p:cNvPr id="5" name="TRIAL-001 기록 재구성 · Codex CLI 0.154.0 · 단일 읽기 전용 조사">
             <a:extLst xmlns:a="http://schemas.openxmlformats.org/drawingml/2006/main">
               <a:ext uri="{FF2B5EF4-FFF2-40B4-BE49-F238E27FC236}">
-                <a16:creationId xmlns:a16="http://schemas.microsoft.com/office/drawing/2014/main" id="{323208BF-3A17-4FE2-AF9C-BF34077A09FD}"/>
+                <a16:creationId xmlns:a16="http://schemas.microsoft.com/office/drawing/2014/main" id="{C211EB60-46FA-4316-AD9E-25A3C4539C20}"/>
               </a:ext>
             </a:extLst>
           </p:cNvPr>
@@ -22541,7 +21905,7 @@
           <p:cNvPr id="6" name="환경 오류 3건은 crop 결함의 증거가 아닙니다. 이 조사에서 코드는 수정하지 않았습니다.">
             <a:extLst xmlns:a="http://schemas.openxmlformats.org/drawingml/2006/main">
               <a:ext uri="{FF2B5EF4-FFF2-40B4-BE49-F238E27FC236}">
-                <a16:creationId xmlns:a16="http://schemas.microsoft.com/office/drawing/2014/main" id="{A66FF0D7-C3A7-49EC-9C9B-5130DA1D3498}"/>
+                <a16:creationId xmlns:a16="http://schemas.microsoft.com/office/drawing/2014/main" id="{C1822762-E6B5-4B54-8916-195736D8CF84}"/>
               </a:ext>
             </a:extLst>
           </p:cNvPr>
@@ -22699,7 +22063,7 @@
           <p:cNvPr id="7" name="코드에서 확인한 문제">
             <a:extLst xmlns:a="http://schemas.openxmlformats.org/drawingml/2006/main">
               <a:ext uri="{FF2B5EF4-FFF2-40B4-BE49-F238E27FC236}">
-                <a16:creationId xmlns:a16="http://schemas.microsoft.com/office/drawing/2014/main" id="{E2A9F7F7-B20D-41BC-B32F-E68A419107AA}"/>
+                <a16:creationId xmlns:a16="http://schemas.microsoft.com/office/drawing/2014/main" id="{C3442315-78A5-44F8-895D-81508985A250}"/>
               </a:ext>
             </a:extLst>
           </p:cNvPr>
@@ -22857,7 +22221,7 @@
           <p:cNvPr id="8" name="실행 환경에서 생긴 제한">
             <a:extLst xmlns:a="http://schemas.openxmlformats.org/drawingml/2006/main">
               <a:ext uri="{FF2B5EF4-FFF2-40B4-BE49-F238E27FC236}">
-                <a16:creationId xmlns:a16="http://schemas.microsoft.com/office/drawing/2014/main" id="{A226862D-9AB1-475E-AC93-9A2F0CBD1E25}"/>
+                <a16:creationId xmlns:a16="http://schemas.microsoft.com/office/drawing/2014/main" id="{5C6D6161-DCF6-4C50-9B35-E8499E460FDD}"/>
               </a:ext>
             </a:extLst>
           </p:cNvPr>
@@ -23015,7 +22379,7 @@
           <p:cNvPr id="9" name="">
             <a:extLst xmlns:a="http://schemas.openxmlformats.org/drawingml/2006/main">
               <a:ext uri="{FF2B5EF4-FFF2-40B4-BE49-F238E27FC236}">
-                <a16:creationId xmlns:a16="http://schemas.microsoft.com/office/drawing/2014/main" id="{F3C1701F-F204-471E-81FF-D860D1FEAF38}"/>
+                <a16:creationId xmlns:a16="http://schemas.microsoft.com/office/drawing/2014/main" id="{F02E316E-7359-419B-8ED5-706F683A14F5}"/>
               </a:ext>
             </a:extLst>
           </p:cNvPr>
@@ -23048,7 +22412,7 @@
           <p:cNvPr id="10" name="">
             <a:extLst xmlns:a="http://schemas.openxmlformats.org/drawingml/2006/main">
               <a:ext uri="{FF2B5EF4-FFF2-40B4-BE49-F238E27FC236}">
-                <a16:creationId xmlns:a16="http://schemas.microsoft.com/office/drawing/2014/main" id="{05047DB2-A099-4369-B679-198FF856A984}"/>
+                <a16:creationId xmlns:a16="http://schemas.microsoft.com/office/drawing/2014/main" id="{67C16D64-73A7-4CFF-B515-17C613D7D32B}"/>
               </a:ext>
             </a:extLst>
           </p:cNvPr>
@@ -23079,7 +22443,7 @@
           <p:cNvPr id="11" name="crop에 한 열이 더 포함됨">
             <a:extLst xmlns:a="http://schemas.openxmlformats.org/drawingml/2006/main">
               <a:ext uri="{FF2B5EF4-FFF2-40B4-BE49-F238E27FC236}">
-                <a16:creationId xmlns:a16="http://schemas.microsoft.com/office/drawing/2014/main" id="{224AF0A5-DA88-4A9A-93A5-3DE6010776CB}"/>
+                <a16:creationId xmlns:a16="http://schemas.microsoft.com/office/drawing/2014/main" id="{CC94824A-C8F8-42DC-983C-4013DE9A36E5}"/>
               </a:ext>
             </a:extLst>
           </p:cNvPr>
@@ -23237,7 +22601,7 @@
           <p:cNvPr id="12" name="테스트·호출 경로·계약 연결&#10;원인 설명 / 코드 수정 없음">
             <a:extLst xmlns:a="http://schemas.openxmlformats.org/drawingml/2006/main">
               <a:ext uri="{FF2B5EF4-FFF2-40B4-BE49-F238E27FC236}">
-                <a16:creationId xmlns:a16="http://schemas.microsoft.com/office/drawing/2014/main" id="{B83FD470-C275-4684-9872-400182C0265A}"/>
+                <a16:creationId xmlns:a16="http://schemas.microsoft.com/office/drawing/2014/main" id="{6161DBBD-5A0B-4537-8306-3A9FEA4B8339}"/>
               </a:ext>
             </a:extLst>
           </p:cNvPr>
@@ -23418,7 +22782,7 @@
           <p:cNvPr id="13" name="임시 디렉터리를 만들 수 없음">
             <a:extLst xmlns:a="http://schemas.openxmlformats.org/drawingml/2006/main">
               <a:ext uri="{FF2B5EF4-FFF2-40B4-BE49-F238E27FC236}">
-                <a16:creationId xmlns:a16="http://schemas.microsoft.com/office/drawing/2014/main" id="{77FEFDDF-35B0-4234-B7DA-F09D4E9571DB}"/>
+                <a16:creationId xmlns:a16="http://schemas.microsoft.com/office/drawing/2014/main" id="{B4D7F965-6598-4543-B93A-8F46642B602F}"/>
               </a:ext>
             </a:extLst>
           </p:cNvPr>
@@ -23576,7 +22940,7 @@
           <p:cNvPr id="14" name="읽기 전용 권한 때문에&#10;서로 다른 테스트 3건이 오류">
             <a:extLst xmlns:a="http://schemas.openxmlformats.org/drawingml/2006/main">
               <a:ext uri="{FF2B5EF4-FFF2-40B4-BE49-F238E27FC236}">
-                <a16:creationId xmlns:a16="http://schemas.microsoft.com/office/drawing/2014/main" id="{50E122C1-4388-4FC8-AB52-8988E8D78503}"/>
+                <a16:creationId xmlns:a16="http://schemas.microsoft.com/office/drawing/2014/main" id="{6C27689F-52D5-46C3-AD54-505585388ED9}"/>
               </a:ext>
             </a:extLst>
           </p:cNvPr>
@@ -23757,7 +23121,7 @@
           <p:cNvPr id="15" name="">
             <a:extLst xmlns:a="http://schemas.openxmlformats.org/drawingml/2006/main">
               <a:ext uri="{FF2B5EF4-FFF2-40B4-BE49-F238E27FC236}">
-                <a16:creationId xmlns:a16="http://schemas.microsoft.com/office/drawing/2014/main" id="{C90765A1-8207-473D-9482-786A36DD9BFD}"/>
+                <a16:creationId xmlns:a16="http://schemas.microsoft.com/office/drawing/2014/main" id="{34A29DBC-5C8C-4738-A809-D06ED5CF7D03}"/>
               </a:ext>
             </a:extLst>
           </p:cNvPr>
@@ -23788,7 +23152,7 @@
           <p:cNvPr id="16" name="전체 실행 기록: 7개 통과 + crop 실패 + 환경 오류 3건">
             <a:extLst xmlns:a="http://schemas.openxmlformats.org/drawingml/2006/main">
               <a:ext uri="{FF2B5EF4-FFF2-40B4-BE49-F238E27FC236}">
-                <a16:creationId xmlns:a16="http://schemas.microsoft.com/office/drawing/2014/main" id="{EF9E5F0C-08D2-44C2-A469-574D5BD8790D}"/>
+                <a16:creationId xmlns:a16="http://schemas.microsoft.com/office/drawing/2014/main" id="{1DE94CDA-3614-4528-96B0-A8637DDCA81C}"/>
               </a:ext>
             </a:extLst>
           </p:cNvPr>
@@ -23944,7 +23308,7 @@
     </p:spTree>
     <p:extLst>
       <p:ext uri="{BB962C8B-B14F-4D97-AF65-F5344CB8AC3E}">
-        <p14:creationId xmlns:p14="http://schemas.microsoft.com/office/powerpoint/2010/main" val="1556357695"/>
+        <p14:creationId xmlns:p14="http://schemas.microsoft.com/office/powerpoint/2010/main" val="53074992"/>
       </p:ext>
     </p:extLst>
   </p:cSld>
@@ -23975,7 +23339,7 @@
           <p:cNvPr id="12" name="ACT 0 · Context를 찾는 주체">
             <a:extLst xmlns:a="http://schemas.openxmlformats.org/drawingml/2006/main">
               <a:ext uri="{FF2B5EF4-FFF2-40B4-BE49-F238E27FC236}">
-                <a16:creationId xmlns:a16="http://schemas.microsoft.com/office/drawing/2014/main" id="{13FC8076-79D0-4DEC-8993-FB44772D9249}"/>
+                <a16:creationId xmlns:a16="http://schemas.microsoft.com/office/drawing/2014/main" id="{DF261AA8-ED77-46F7-B672-12D4935686C4}"/>
               </a:ext>
             </a:extLst>
           </p:cNvPr>
@@ -24133,7 +23497,7 @@
           <p:cNvPr id="2" name="S07">
             <a:extLst xmlns:a="http://schemas.openxmlformats.org/drawingml/2006/main">
               <a:ext uri="{FF2B5EF4-FFF2-40B4-BE49-F238E27FC236}">
-                <a16:creationId xmlns:a16="http://schemas.microsoft.com/office/drawing/2014/main" id="{01BFBD3C-6B4D-4C79-957B-4184617EC34F}"/>
+                <a16:creationId xmlns:a16="http://schemas.microsoft.com/office/drawing/2014/main" id="{ACEC01B8-67D5-4591-8A50-F356683974A6}"/>
               </a:ext>
             </a:extLst>
           </p:cNvPr>
@@ -24291,7 +23655,7 @@
           <p:cNvPr id="3" name="코드를 AI에게 가져가는 대신&#10;AI를 Repository로 데려간다">
             <a:extLst xmlns:a="http://schemas.openxmlformats.org/drawingml/2006/main">
               <a:ext uri="{FF2B5EF4-FFF2-40B4-BE49-F238E27FC236}">
-                <a16:creationId xmlns:a16="http://schemas.microsoft.com/office/drawing/2014/main" id="{A3AD61F3-891E-4E58-BD98-F9F8FCD2DF33}"/>
+                <a16:creationId xmlns:a16="http://schemas.microsoft.com/office/drawing/2014/main" id="{FD4A72AF-E326-4C6C-A7B7-A3086501A9DF}"/>
               </a:ext>
             </a:extLst>
           </p:cNvPr>
@@ -24472,7 +23836,7 @@
           <p:cNvPr id="4" name="">
             <a:extLst xmlns:a="http://schemas.openxmlformats.org/drawingml/2006/main">
               <a:ext uri="{FF2B5EF4-FFF2-40B4-BE49-F238E27FC236}">
-                <a16:creationId xmlns:a16="http://schemas.microsoft.com/office/drawing/2014/main" id="{93102F3E-CBA5-41F4-AED7-389C6F2655F4}"/>
+                <a16:creationId xmlns:a16="http://schemas.microsoft.com/office/drawing/2014/main" id="{CB75F9E7-F0AA-4EBB-A4E5-FBE748BF0B92}"/>
               </a:ext>
             </a:extLst>
           </p:cNvPr>
@@ -24503,7 +23867,7 @@
           <p:cNvPr id="5" name="교육 모델 · TRIAL-001 단일 CLI 관찰과 연결 · AI 생성 설명용 삽화">
             <a:extLst xmlns:a="http://schemas.openxmlformats.org/drawingml/2006/main">
               <a:ext uri="{FF2B5EF4-FFF2-40B4-BE49-F238E27FC236}">
-                <a16:creationId xmlns:a16="http://schemas.microsoft.com/office/drawing/2014/main" id="{5AA366D2-9468-4C99-B214-C34BF10A13C0}"/>
+                <a16:creationId xmlns:a16="http://schemas.microsoft.com/office/drawing/2014/main" id="{8FC7F62C-6807-4AB6-B984-8FC595B8980C}"/>
               </a:ext>
             </a:extLst>
           </p:cNvPr>
@@ -24661,7 +24025,7 @@
           <p:cNvPr id="6" name="목표 설정과 근거 검토는 개발자에게 남습니다. Repository 접근이 Task 의도를 정하지는 않습니다.">
             <a:extLst xmlns:a="http://schemas.openxmlformats.org/drawingml/2006/main">
               <a:ext uri="{FF2B5EF4-FFF2-40B4-BE49-F238E27FC236}">
-                <a16:creationId xmlns:a16="http://schemas.microsoft.com/office/drawing/2014/main" id="{641C2680-2797-4E78-ABBB-9C9A7FDA3EDE}"/>
+                <a16:creationId xmlns:a16="http://schemas.microsoft.com/office/drawing/2014/main" id="{28AA34C9-8ECA-4507-89CF-57BAA80395B7}"/>
               </a:ext>
             </a:extLst>
           </p:cNvPr>
@@ -24819,7 +24183,7 @@
           <p:cNvPr id="7" name="내가 골라 전달하는 Context">
             <a:extLst xmlns:a="http://schemas.openxmlformats.org/drawingml/2006/main">
               <a:ext uri="{FF2B5EF4-FFF2-40B4-BE49-F238E27FC236}">
-                <a16:creationId xmlns:a16="http://schemas.microsoft.com/office/drawing/2014/main" id="{73FB7380-49C3-4AE4-BF00-B26AEF41747D}"/>
+                <a16:creationId xmlns:a16="http://schemas.microsoft.com/office/drawing/2014/main" id="{1C13C35E-77D9-4BC1-A6CE-51AE79E943DE}"/>
               </a:ext>
             </a:extLst>
           </p:cNvPr>
@@ -24977,7 +24341,7 @@
           <p:cNvPr id="8" name="조사를 맡기고 근거를 확인">
             <a:extLst xmlns:a="http://schemas.openxmlformats.org/drawingml/2006/main">
               <a:ext uri="{FF2B5EF4-FFF2-40B4-BE49-F238E27FC236}">
-                <a16:creationId xmlns:a16="http://schemas.microsoft.com/office/drawing/2014/main" id="{40B489DA-5337-44CC-AB7B-982D2CB47FBD}"/>
+                <a16:creationId xmlns:a16="http://schemas.microsoft.com/office/drawing/2014/main" id="{7B450BA3-63B0-4C3D-A26A-FE4210293D8A}"/>
               </a:ext>
             </a:extLst>
           </p:cNvPr>
@@ -25135,7 +24499,7 @@
           <p:cNvPr id="9" name="">
             <a:extLst xmlns:a="http://schemas.openxmlformats.org/drawingml/2006/main">
               <a:ext uri="{FF2B5EF4-FFF2-40B4-BE49-F238E27FC236}">
-                <a16:creationId xmlns:a16="http://schemas.microsoft.com/office/drawing/2014/main" id="{867EA41E-7698-4507-A11F-84E39FFB02E2}"/>
+                <a16:creationId xmlns:a16="http://schemas.microsoft.com/office/drawing/2014/main" id="{C4F72CA0-BE39-4180-84AA-C782D51FE60C}"/>
               </a:ext>
             </a:extLst>
           </p:cNvPr>
@@ -25145,7 +24509,7 @@
           <p:nvPr/>
         </p:nvPicPr>
         <p:blipFill>
-          <a:blip xmlns:r="http://schemas.openxmlformats.org/officeDocument/2006/relationships" xmlns:a="http://schemas.openxmlformats.org/drawingml/2006/main" r:embed="R869af1ec4cca4bc7"/>
+          <a:blip xmlns:r="http://schemas.openxmlformats.org/officeDocument/2006/relationships" xmlns:a="http://schemas.openxmlformats.org/drawingml/2006/main" r:embed="Rf0977a8fc8ce46b4"/>
           <a:srcRect xmlns:a="http://schemas.openxmlformats.org/drawingml/2006/main" l="0" t="18000" r="0" b="15000"/>
           <a:stretch xmlns:a="http://schemas.openxmlformats.org/drawingml/2006/main"/>
         </p:blipFill>
@@ -25164,7 +24528,7 @@
           <p:cNvPr id="10" name="코드 조각을 선택·복사">
             <a:extLst xmlns:a="http://schemas.openxmlformats.org/drawingml/2006/main">
               <a:ext uri="{FF2B5EF4-FFF2-40B4-BE49-F238E27FC236}">
-                <a16:creationId xmlns:a16="http://schemas.microsoft.com/office/drawing/2014/main" id="{46B9CBEB-295E-43ED-95C1-E83C0153656A}"/>
+                <a16:creationId xmlns:a16="http://schemas.microsoft.com/office/drawing/2014/main" id="{AC18A833-21FC-4EFA-BEA8-5DD9D7F58017}"/>
               </a:ext>
             </a:extLst>
           </p:cNvPr>
@@ -25322,7 +24686,7 @@
           <p:cNvPr id="11" name="목표는 사람이, 탐색은 Agent와">
             <a:extLst xmlns:a="http://schemas.openxmlformats.org/drawingml/2006/main">
               <a:ext uri="{FF2B5EF4-FFF2-40B4-BE49-F238E27FC236}">
-                <a16:creationId xmlns:a16="http://schemas.microsoft.com/office/drawing/2014/main" id="{0453DBC3-CA8B-472E-BD2F-49F6F610491D}"/>
+                <a16:creationId xmlns:a16="http://schemas.microsoft.com/office/drawing/2014/main" id="{594D53E0-3778-4E4C-8AA6-45A3CA8FE13A}"/>
               </a:ext>
             </a:extLst>
           </p:cNvPr>
@@ -25478,7 +24842,7 @@
     </p:spTree>
     <p:extLst>
       <p:ext uri="{BB962C8B-B14F-4D97-AF65-F5344CB8AC3E}">
-        <p14:creationId xmlns:p14="http://schemas.microsoft.com/office/powerpoint/2010/main" val="801953783"/>
+        <p14:creationId xmlns:p14="http://schemas.microsoft.com/office/powerpoint/2010/main" val="1643376365"/>
       </p:ext>
     </p:extLst>
   </p:cSld>
@@ -25509,7 +24873,7 @@
           <p:cNvPr id="15" name="ACT 0 · 접근할 정보와 정할 목표">
             <a:extLst xmlns:a="http://schemas.openxmlformats.org/drawingml/2006/main">
               <a:ext uri="{FF2B5EF4-FFF2-40B4-BE49-F238E27FC236}">
-                <a16:creationId xmlns:a16="http://schemas.microsoft.com/office/drawing/2014/main" id="{736312E8-09FD-4AA7-97B4-EF62BE1E0069}"/>
+                <a16:creationId xmlns:a16="http://schemas.microsoft.com/office/drawing/2014/main" id="{E2BF1C1E-2682-4A05-90BF-202D7D9C0809}"/>
               </a:ext>
             </a:extLst>
           </p:cNvPr>
@@ -25667,7 +25031,7 @@
           <p:cNvPr id="2" name="S08">
             <a:extLst xmlns:a="http://schemas.openxmlformats.org/drawingml/2006/main">
               <a:ext uri="{FF2B5EF4-FFF2-40B4-BE49-F238E27FC236}">
-                <a16:creationId xmlns:a16="http://schemas.microsoft.com/office/drawing/2014/main" id="{B0714574-E7BB-4EB3-846B-C8E6322E9574}"/>
+                <a16:creationId xmlns:a16="http://schemas.microsoft.com/office/drawing/2014/main" id="{D136EF37-B68C-455C-9E48-9D217D6EAD60}"/>
               </a:ext>
             </a:extLst>
           </p:cNvPr>
@@ -25825,7 +25189,7 @@
           <p:cNvPr id="3" name="Repository 접근과 Task 의도는 별개다">
             <a:extLst xmlns:a="http://schemas.openxmlformats.org/drawingml/2006/main">
               <a:ext uri="{FF2B5EF4-FFF2-40B4-BE49-F238E27FC236}">
-                <a16:creationId xmlns:a16="http://schemas.microsoft.com/office/drawing/2014/main" id="{2317D594-8238-4154-B9B2-BF209B3E5B3B}"/>
+                <a16:creationId xmlns:a16="http://schemas.microsoft.com/office/drawing/2014/main" id="{C5E995D3-3939-4652-A8E7-5626163A662B}"/>
               </a:ext>
             </a:extLst>
           </p:cNvPr>
@@ -25983,7 +25347,7 @@
           <p:cNvPr id="4" name="">
             <a:extLst xmlns:a="http://schemas.openxmlformats.org/drawingml/2006/main">
               <a:ext uri="{FF2B5EF4-FFF2-40B4-BE49-F238E27FC236}">
-                <a16:creationId xmlns:a16="http://schemas.microsoft.com/office/drawing/2014/main" id="{B6DF42F4-B249-4BFC-8269-9DD558281ACC}"/>
+                <a16:creationId xmlns:a16="http://schemas.microsoft.com/office/drawing/2014/main" id="{AA364CE8-4531-45E3-B4BB-5FAA63521EAC}"/>
               </a:ext>
             </a:extLst>
           </p:cNvPr>
@@ -26014,7 +25378,7 @@
           <p:cNvPr id="5" name="이 과정의 교육 모델 · Repository 접근과 작업 의도의 관계">
             <a:extLst xmlns:a="http://schemas.openxmlformats.org/drawingml/2006/main">
               <a:ext uri="{FF2B5EF4-FFF2-40B4-BE49-F238E27FC236}">
-                <a16:creationId xmlns:a16="http://schemas.microsoft.com/office/drawing/2014/main" id="{86655B16-5A10-4071-9E6E-17A4EA419802}"/>
+                <a16:creationId xmlns:a16="http://schemas.microsoft.com/office/drawing/2014/main" id="{D7AB7F99-DC2B-4F91-A05F-615638B09509}"/>
               </a:ext>
             </a:extLst>
           </p:cNvPr>
@@ -26172,7 +25536,7 @@
           <p:cNvPr id="6" name="모든 제품이나 환경의 기능을 설명하는 공식 분류가 아닙니다.">
             <a:extLst xmlns:a="http://schemas.openxmlformats.org/drawingml/2006/main">
               <a:ext uri="{FF2B5EF4-FFF2-40B4-BE49-F238E27FC236}">
-                <a16:creationId xmlns:a16="http://schemas.microsoft.com/office/drawing/2014/main" id="{B6966F82-C238-495D-A45E-384E6CC283D5}"/>
+                <a16:creationId xmlns:a16="http://schemas.microsoft.com/office/drawing/2014/main" id="{316C8112-E0E6-4809-92E5-EC48DD643AB5}"/>
               </a:ext>
             </a:extLst>
           </p:cNvPr>
@@ -26330,7 +25694,7 @@
           <p:cNvPr id="7" name="볼 수 있는 것">
             <a:extLst xmlns:a="http://schemas.openxmlformats.org/drawingml/2006/main">
               <a:ext uri="{FF2B5EF4-FFF2-40B4-BE49-F238E27FC236}">
-                <a16:creationId xmlns:a16="http://schemas.microsoft.com/office/drawing/2014/main" id="{075735BF-D4F9-41AF-BB15-3E6F48ECED2F}"/>
+                <a16:creationId xmlns:a16="http://schemas.microsoft.com/office/drawing/2014/main" id="{A3DC94D2-F3FA-4C0C-B64C-4E0C6694573F}"/>
               </a:ext>
             </a:extLst>
           </p:cNvPr>
@@ -26488,7 +25852,7 @@
           <p:cNvPr id="8" name="정해야 하는 것">
             <a:extLst xmlns:a="http://schemas.openxmlformats.org/drawingml/2006/main">
               <a:ext uri="{FF2B5EF4-FFF2-40B4-BE49-F238E27FC236}">
-                <a16:creationId xmlns:a16="http://schemas.microsoft.com/office/drawing/2014/main" id="{B4C9DDD8-55B1-4482-84CF-5A35EE6C9279}"/>
+                <a16:creationId xmlns:a16="http://schemas.microsoft.com/office/drawing/2014/main" id="{707F1DBA-02C1-4BA1-9AE0-55F4696DD5F8}"/>
               </a:ext>
             </a:extLst>
           </p:cNvPr>
@@ -26646,7 +26010,7 @@
           <p:cNvPr id="9" name="">
             <a:extLst xmlns:a="http://schemas.openxmlformats.org/drawingml/2006/main">
               <a:ext uri="{FF2B5EF4-FFF2-40B4-BE49-F238E27FC236}">
-                <a16:creationId xmlns:a16="http://schemas.microsoft.com/office/drawing/2014/main" id="{CE59D22A-4C11-4D74-BF38-6178BBC89D0E}"/>
+                <a16:creationId xmlns:a16="http://schemas.microsoft.com/office/drawing/2014/main" id="{5A538ABC-7BEF-4DC1-B6FA-D5B09721F180}"/>
               </a:ext>
             </a:extLst>
           </p:cNvPr>
@@ -26677,7 +26041,7 @@
           <p:cNvPr id="10" name="">
             <a:extLst xmlns:a="http://schemas.openxmlformats.org/drawingml/2006/main">
               <a:ext uri="{FF2B5EF4-FFF2-40B4-BE49-F238E27FC236}">
-                <a16:creationId xmlns:a16="http://schemas.microsoft.com/office/drawing/2014/main" id="{DE6D561E-BE9D-4A8C-BD7D-3BAF4FE4CC14}"/>
+                <a16:creationId xmlns:a16="http://schemas.microsoft.com/office/drawing/2014/main" id="{820BF176-6974-4D94-A527-624043348ECF}"/>
               </a:ext>
             </a:extLst>
           </p:cNvPr>
@@ -26708,7 +26072,7 @@
           <p:cNvPr id="11" name="파일&#10;구현&#10;테스트">
             <a:extLst xmlns:a="http://schemas.openxmlformats.org/drawingml/2006/main">
               <a:ext uri="{FF2B5EF4-FFF2-40B4-BE49-F238E27FC236}">
-                <a16:creationId xmlns:a16="http://schemas.microsoft.com/office/drawing/2014/main" id="{A4114561-53EF-4DE2-969E-826652E90CD4}"/>
+                <a16:creationId xmlns:a16="http://schemas.microsoft.com/office/drawing/2014/main" id="{226DF72D-27AC-4A69-82B7-BDE7F428DBA9}"/>
               </a:ext>
             </a:extLst>
           </p:cNvPr>
@@ -26912,7 +26276,7 @@
           <p:cNvPr id="12" name="원하는 변화&#10;허용할 범위&#10;완료 판단">
             <a:extLst xmlns:a="http://schemas.openxmlformats.org/drawingml/2006/main">
               <a:ext uri="{FF2B5EF4-FFF2-40B4-BE49-F238E27FC236}">
-                <a16:creationId xmlns:a16="http://schemas.microsoft.com/office/drawing/2014/main" id="{8F58E778-6CCF-4601-AAFF-26EABE3EE8D9}"/>
+                <a16:creationId xmlns:a16="http://schemas.microsoft.com/office/drawing/2014/main" id="{82BAA65C-3D99-4A4B-A253-8FC278733F15}"/>
               </a:ext>
             </a:extLst>
           </p:cNvPr>
@@ -27116,7 +26480,7 @@
           <p:cNvPr id="13" name="≠">
             <a:extLst xmlns:a="http://schemas.openxmlformats.org/drawingml/2006/main">
               <a:ext uri="{FF2B5EF4-FFF2-40B4-BE49-F238E27FC236}">
-                <a16:creationId xmlns:a16="http://schemas.microsoft.com/office/drawing/2014/main" id="{2EF81E67-F72A-41A1-BAF8-17CA10D941AA}"/>
+                <a16:creationId xmlns:a16="http://schemas.microsoft.com/office/drawing/2014/main" id="{9BCA4971-33E6-44CF-B7B1-F5536C7980AF}"/>
               </a:ext>
             </a:extLst>
           </p:cNvPr>
@@ -27274,7 +26638,7 @@
           <p:cNvPr id="14" name="코드가 보여도, 원하는 일은 따로 전달해야 한다.">
             <a:extLst xmlns:a="http://schemas.openxmlformats.org/drawingml/2006/main">
               <a:ext uri="{FF2B5EF4-FFF2-40B4-BE49-F238E27FC236}">
-                <a16:creationId xmlns:a16="http://schemas.microsoft.com/office/drawing/2014/main" id="{3FA6128A-CB7F-424B-A75C-51433F7CEDFB}"/>
+                <a16:creationId xmlns:a16="http://schemas.microsoft.com/office/drawing/2014/main" id="{FB7130CE-9204-4DC1-B315-129107083A9C}"/>
               </a:ext>
             </a:extLst>
           </p:cNvPr>
@@ -27430,7 +26794,7 @@
     </p:spTree>
     <p:extLst>
       <p:ext uri="{BB962C8B-B14F-4D97-AF65-F5344CB8AC3E}">
-        <p14:creationId xmlns:p14="http://schemas.microsoft.com/office/powerpoint/2010/main" val="1031975324"/>
+        <p14:creationId xmlns:p14="http://schemas.microsoft.com/office/powerpoint/2010/main" val="1575183741"/>
       </p:ext>
     </p:extLst>
   </p:cSld>
@@ -27461,7 +26825,7 @@
           <p:cNvPr id="11" name="ACT 0 · 다음 질문">
             <a:extLst xmlns:a="http://schemas.openxmlformats.org/drawingml/2006/main">
               <a:ext uri="{FF2B5EF4-FFF2-40B4-BE49-F238E27FC236}">
-                <a16:creationId xmlns:a16="http://schemas.microsoft.com/office/drawing/2014/main" id="{4110378D-0819-4B6A-AD54-411BA2F37EE9}"/>
+                <a16:creationId xmlns:a16="http://schemas.microsoft.com/office/drawing/2014/main" id="{0715B9A0-45A6-4958-99B4-1BDB162D32D8}"/>
               </a:ext>
             </a:extLst>
           </p:cNvPr>
@@ -27619,7 +26983,7 @@
           <p:cNvPr id="2" name="S09">
             <a:extLst xmlns:a="http://schemas.openxmlformats.org/drawingml/2006/main">
               <a:ext uri="{FF2B5EF4-FFF2-40B4-BE49-F238E27FC236}">
-                <a16:creationId xmlns:a16="http://schemas.microsoft.com/office/drawing/2014/main" id="{6F410E56-9FBA-48D4-B4D3-DBFC65C2056C}"/>
+                <a16:creationId xmlns:a16="http://schemas.microsoft.com/office/drawing/2014/main" id="{C68B83E7-86AA-4194-BA87-E5377044B362}"/>
               </a:ext>
             </a:extLst>
           </p:cNvPr>
@@ -27777,7 +27141,7 @@
           <p:cNvPr id="3" name="Repository를 보면 내가 원하는 것까지 알까?">
             <a:extLst xmlns:a="http://schemas.openxmlformats.org/drawingml/2006/main">
               <a:ext uri="{FF2B5EF4-FFF2-40B4-BE49-F238E27FC236}">
-                <a16:creationId xmlns:a16="http://schemas.microsoft.com/office/drawing/2014/main" id="{0EE21C5F-1F68-40FE-B709-6C3C1C7640EC}"/>
+                <a16:creationId xmlns:a16="http://schemas.microsoft.com/office/drawing/2014/main" id="{1E213C83-0153-4C08-96BB-46326CDF6832}"/>
               </a:ext>
             </a:extLst>
           </p:cNvPr>
@@ -27935,7 +27299,7 @@
           <p:cNvPr id="4" name="">
             <a:extLst xmlns:a="http://schemas.openxmlformats.org/drawingml/2006/main">
               <a:ext uri="{FF2B5EF4-FFF2-40B4-BE49-F238E27FC236}">
-                <a16:creationId xmlns:a16="http://schemas.microsoft.com/office/drawing/2014/main" id="{9E8D6EA4-A8E9-4004-B97E-E3C48686C750}"/>
+                <a16:creationId xmlns:a16="http://schemas.microsoft.com/office/drawing/2014/main" id="{80728951-3F89-4D7C-83AF-C75DDD44FB02}"/>
               </a:ext>
             </a:extLst>
           </p:cNvPr>
@@ -27966,7 +27330,7 @@
           <p:cNvPr id="5" name="함께 생각해 보기 · 교육 모델">
             <a:extLst xmlns:a="http://schemas.openxmlformats.org/drawingml/2006/main">
               <a:ext uri="{FF2B5EF4-FFF2-40B4-BE49-F238E27FC236}">
-                <a16:creationId xmlns:a16="http://schemas.microsoft.com/office/drawing/2014/main" id="{38F2D000-33AD-4F1D-8C88-854667B5F97E}"/>
+                <a16:creationId xmlns:a16="http://schemas.microsoft.com/office/drawing/2014/main" id="{0D81BD3E-91DF-46ED-999D-78BE3DD71DAC}"/>
               </a:ext>
             </a:extLst>
           </p:cNvPr>
@@ -28124,7 +27488,7 @@
           <p:cNvPr id="6" name="현재 맡기고 싶은 일을 떠올려 보세요. 질문과 경험 공유는 자발적으로 진행합니다.">
             <a:extLst xmlns:a="http://schemas.openxmlformats.org/drawingml/2006/main">
               <a:ext uri="{FF2B5EF4-FFF2-40B4-BE49-F238E27FC236}">
-                <a16:creationId xmlns:a16="http://schemas.microsoft.com/office/drawing/2014/main" id="{FFFABE36-7EE0-4299-8791-3EACD886F95A}"/>
+                <a16:creationId xmlns:a16="http://schemas.microsoft.com/office/drawing/2014/main" id="{D409D152-2A2B-4ABF-B286-3DBD11B08DEF}"/>
               </a:ext>
             </a:extLst>
           </p:cNvPr>
@@ -28282,7 +27646,7 @@
           <p:cNvPr id="7" name="지금 이 저장소에&#10;어떤 일을 맡기고 싶으신가요?">
             <a:extLst xmlns:a="http://schemas.openxmlformats.org/drawingml/2006/main">
               <a:ext uri="{FF2B5EF4-FFF2-40B4-BE49-F238E27FC236}">
-                <a16:creationId xmlns:a16="http://schemas.microsoft.com/office/drawing/2014/main" id="{E368DECD-EC4B-476F-A27D-46EFACB2F518}"/>
+                <a16:creationId xmlns:a16="http://schemas.microsoft.com/office/drawing/2014/main" id="{ED521D85-7A30-4169-90ED-191D3FBCE05D}"/>
               </a:ext>
             </a:extLst>
           </p:cNvPr>
@@ -28463,7 +27827,7 @@
           <p:cNvPr id="8" name="?">
             <a:extLst xmlns:a="http://schemas.openxmlformats.org/drawingml/2006/main">
               <a:ext uri="{FF2B5EF4-FFF2-40B4-BE49-F238E27FC236}">
-                <a16:creationId xmlns:a16="http://schemas.microsoft.com/office/drawing/2014/main" id="{3C1A6E4F-B4A2-4DC8-9DD2-187E546ED4D8}"/>
+                <a16:creationId xmlns:a16="http://schemas.microsoft.com/office/drawing/2014/main" id="{FA9A1F3D-E627-4190-894E-CF1CD514D720}"/>
               </a:ext>
             </a:extLst>
           </p:cNvPr>
@@ -28621,7 +27985,7 @@
           <p:cNvPr id="9" name="">
             <a:extLst xmlns:a="http://schemas.openxmlformats.org/drawingml/2006/main">
               <a:ext uri="{FF2B5EF4-FFF2-40B4-BE49-F238E27FC236}">
-                <a16:creationId xmlns:a16="http://schemas.microsoft.com/office/drawing/2014/main" id="{FE6ECC70-592E-4656-BA0C-A0668993086A}"/>
+                <a16:creationId xmlns:a16="http://schemas.microsoft.com/office/drawing/2014/main" id="{5CA54179-2021-43E2-82F3-EDA96C5A6CE9}"/>
               </a:ext>
             </a:extLst>
           </p:cNvPr>
@@ -28652,7 +28016,7 @@
           <p:cNvPr id="10" name="그 원하는 결과까지&#10;코드에 적혀 있을까요?">
             <a:extLst xmlns:a="http://schemas.openxmlformats.org/drawingml/2006/main">
               <a:ext uri="{FF2B5EF4-FFF2-40B4-BE49-F238E27FC236}">
-                <a16:creationId xmlns:a16="http://schemas.microsoft.com/office/drawing/2014/main" id="{13518D1C-7D8B-424E-BB0E-3080084A0DF0}"/>
+                <a16:creationId xmlns:a16="http://schemas.microsoft.com/office/drawing/2014/main" id="{E0982958-9045-405D-A133-A2A634935E56}"/>
               </a:ext>
             </a:extLst>
           </p:cNvPr>
@@ -28831,7 +28195,7 @@
     </p:spTree>
     <p:extLst>
       <p:ext uri="{BB962C8B-B14F-4D97-AF65-F5344CB8AC3E}">
-        <p14:creationId xmlns:p14="http://schemas.microsoft.com/office/powerpoint/2010/main" val="754504573"/>
+        <p14:creationId xmlns:p14="http://schemas.microsoft.com/office/powerpoint/2010/main" val="780849956"/>
       </p:ext>
     </p:extLst>
   </p:cSld>

</xml_diff>

<commit_message>
feat(slides): polish full-deck presentation flow
Clarify the approved reading order, bilingual excerpts and evidence labels
across 32 slides while preserving the 80-slide, 360-minute course.

Align native slide objects, speaker cues, ACT packages and fallback renders
with the final full-deck review.
</commit_message>
<xml_diff>
--- a/production/ACT_0.pptx
+++ b/production/ACT_0.pptx
@@ -2,21 +2,21 @@
 <file path=ppt/presentation.xml><?xml version="1.0" encoding="utf-8"?>
 <p:presentation xmlns:p="http://schemas.openxmlformats.org/presentationml/2006/main">
   <p:sldMasterIdLst>
-    <p:sldMasterId xmlns:r="http://schemas.openxmlformats.org/officeDocument/2006/relationships" id="2147483648" r:id="Rbde8ed4e0f7e4171"/>
+    <p:sldMasterId xmlns:r="http://schemas.openxmlformats.org/officeDocument/2006/relationships" id="2147483648" r:id="Rbdbfeafa66684e10"/>
   </p:sldMasterIdLst>
   <p:notesMasterIdLst>
-    <p:notesMasterId xmlns:r="http://schemas.openxmlformats.org/officeDocument/2006/relationships" r:id="R7890dc169501488c"/>
+    <p:notesMasterId xmlns:r="http://schemas.openxmlformats.org/officeDocument/2006/relationships" r:id="Rbde1282568e4442b"/>
   </p:notesMasterIdLst>
   <p:sldIdLst>
-    <p:sldId xmlns:r="http://schemas.openxmlformats.org/officeDocument/2006/relationships" id="256" r:id="Rcf54a016f06f409c"/>
-    <p:sldId xmlns:r="http://schemas.openxmlformats.org/officeDocument/2006/relationships" id="257" r:id="R066b0f0225a843ae"/>
-    <p:sldId xmlns:r="http://schemas.openxmlformats.org/officeDocument/2006/relationships" id="258" r:id="R03386f7911ee4a5c"/>
-    <p:sldId xmlns:r="http://schemas.openxmlformats.org/officeDocument/2006/relationships" id="259" r:id="R2f7d86f2eb934a6f"/>
-    <p:sldId xmlns:r="http://schemas.openxmlformats.org/officeDocument/2006/relationships" id="260" r:id="R8a2da33828c3498d"/>
-    <p:sldId xmlns:r="http://schemas.openxmlformats.org/officeDocument/2006/relationships" id="261" r:id="Rf58b438d8f4848fd"/>
-    <p:sldId xmlns:r="http://schemas.openxmlformats.org/officeDocument/2006/relationships" id="262" r:id="R219d7eb1d7704c80"/>
-    <p:sldId xmlns:r="http://schemas.openxmlformats.org/officeDocument/2006/relationships" id="263" r:id="R70ce4b244ce645c7"/>
-    <p:sldId xmlns:r="http://schemas.openxmlformats.org/officeDocument/2006/relationships" id="264" r:id="Rd0bd723886b348e4"/>
+    <p:sldId xmlns:r="http://schemas.openxmlformats.org/officeDocument/2006/relationships" id="256" r:id="Re25ba3eaa5e7449f"/>
+    <p:sldId xmlns:r="http://schemas.openxmlformats.org/officeDocument/2006/relationships" id="257" r:id="Rf86159611443443a"/>
+    <p:sldId xmlns:r="http://schemas.openxmlformats.org/officeDocument/2006/relationships" id="258" r:id="Ra0feeb9f4c4843d4"/>
+    <p:sldId xmlns:r="http://schemas.openxmlformats.org/officeDocument/2006/relationships" id="259" r:id="Re282c6bbb06a4c8d"/>
+    <p:sldId xmlns:r="http://schemas.openxmlformats.org/officeDocument/2006/relationships" id="260" r:id="R7f0ce758eaba4e2b"/>
+    <p:sldId xmlns:r="http://schemas.openxmlformats.org/officeDocument/2006/relationships" id="261" r:id="Rc20c590bffc44f96"/>
+    <p:sldId xmlns:r="http://schemas.openxmlformats.org/officeDocument/2006/relationships" id="262" r:id="Rc8df4fc184e04353"/>
+    <p:sldId xmlns:r="http://schemas.openxmlformats.org/officeDocument/2006/relationships" id="263" r:id="R870e1f9c893a401b"/>
+    <p:sldId xmlns:r="http://schemas.openxmlformats.org/officeDocument/2006/relationships" id="264" r:id="R0772e28dabd64f86"/>
   </p:sldIdLst>
   <p:sldSz cx="12192000" cy="6858000"/>
   <p:notesSz cx="6858000" cy="9144000"/>
@@ -2952,7 +2952,7 @@
           <p:cNvPr id="3" name="Title">
             <a:extLst xmlns:a="http://schemas.openxmlformats.org/drawingml/2006/main">
               <a:ext uri="{FF2B5EF4-FFF2-40B4-BE49-F238E27FC236}">
-                <a16:creationId xmlns:a16="http://schemas.microsoft.com/office/drawing/2014/main" id="{6B42B9B9-C82D-43A2-821F-7D81F4AABFDF}"/>
+                <a16:creationId xmlns:a16="http://schemas.microsoft.com/office/drawing/2014/main" id="{56B82EC1-4702-4D17-ABC7-6FC1B9832792}"/>
               </a:ext>
             </a:extLst>
           </p:cNvPr>
@@ -3181,7 +3181,7 @@
           <p:cNvPr id="2" name="Subtitle">
             <a:extLst xmlns:a="http://schemas.openxmlformats.org/drawingml/2006/main">
               <a:ext uri="{FF2B5EF4-FFF2-40B4-BE49-F238E27FC236}">
-                <a16:creationId xmlns:a16="http://schemas.microsoft.com/office/drawing/2014/main" id="{8F0D60A5-81DF-46A3-ACC4-4098114035BA}"/>
+                <a16:creationId xmlns:a16="http://schemas.microsoft.com/office/drawing/2014/main" id="{B09A683E-4342-470B-8D9B-7BAA6D2F7BE6}"/>
               </a:ext>
             </a:extLst>
           </p:cNvPr>
@@ -3427,7 +3427,7 @@
           <p:cNvPr id="2" name="Section title">
             <a:extLst xmlns:a="http://schemas.openxmlformats.org/drawingml/2006/main">
               <a:ext uri="{FF2B5EF4-FFF2-40B4-BE49-F238E27FC236}">
-                <a16:creationId xmlns:a16="http://schemas.microsoft.com/office/drawing/2014/main" id="{C0088B39-ED82-4D4B-94E3-0F64D32EEFEF}"/>
+                <a16:creationId xmlns:a16="http://schemas.microsoft.com/office/drawing/2014/main" id="{A9C251AF-C835-4DB8-92E8-52DCADAFD9CC}"/>
               </a:ext>
             </a:extLst>
           </p:cNvPr>
@@ -3673,7 +3673,7 @@
           <p:cNvPr id="3" name="Title">
             <a:extLst xmlns:a="http://schemas.openxmlformats.org/drawingml/2006/main">
               <a:ext uri="{FF2B5EF4-FFF2-40B4-BE49-F238E27FC236}">
-                <a16:creationId xmlns:a16="http://schemas.microsoft.com/office/drawing/2014/main" id="{F47E57A8-D696-44C5-87AD-06CCC6A0F8BE}"/>
+                <a16:creationId xmlns:a16="http://schemas.microsoft.com/office/drawing/2014/main" id="{7AEAAD17-B335-48B9-8EA1-5304E3647D04}"/>
               </a:ext>
             </a:extLst>
           </p:cNvPr>
@@ -3902,7 +3902,7 @@
           <p:cNvPr id="2" name="Body">
             <a:extLst xmlns:a="http://schemas.openxmlformats.org/drawingml/2006/main">
               <a:ext uri="{FF2B5EF4-FFF2-40B4-BE49-F238E27FC236}">
-                <a16:creationId xmlns:a16="http://schemas.microsoft.com/office/drawing/2014/main" id="{BD11460E-7EDE-4DC4-B245-E5D286D75594}"/>
+                <a16:creationId xmlns:a16="http://schemas.microsoft.com/office/drawing/2014/main" id="{711547CA-25E8-4812-87AA-B975B12E9300}"/>
               </a:ext>
             </a:extLst>
           </p:cNvPr>
@@ -4148,7 +4148,7 @@
           <p:cNvPr id="4" name="Title">
             <a:extLst xmlns:a="http://schemas.openxmlformats.org/drawingml/2006/main">
               <a:ext uri="{FF2B5EF4-FFF2-40B4-BE49-F238E27FC236}">
-                <a16:creationId xmlns:a16="http://schemas.microsoft.com/office/drawing/2014/main" id="{E276F02D-0E41-4A79-9B25-D94FC6D9810C}"/>
+                <a16:creationId xmlns:a16="http://schemas.microsoft.com/office/drawing/2014/main" id="{069A56BA-2EF7-4D13-9EC1-B006E6A69479}"/>
               </a:ext>
             </a:extLst>
           </p:cNvPr>
@@ -4377,7 +4377,7 @@
           <p:cNvPr id="2" name="Left column">
             <a:extLst xmlns:a="http://schemas.openxmlformats.org/drawingml/2006/main">
               <a:ext uri="{FF2B5EF4-FFF2-40B4-BE49-F238E27FC236}">
-                <a16:creationId xmlns:a16="http://schemas.microsoft.com/office/drawing/2014/main" id="{71CD0E1A-3D9F-46B7-A1AE-D35468F2FC53}"/>
+                <a16:creationId xmlns:a16="http://schemas.microsoft.com/office/drawing/2014/main" id="{8E71181F-D300-42FD-8582-8DFE40FCBF70}"/>
               </a:ext>
             </a:extLst>
           </p:cNvPr>
@@ -4606,7 +4606,7 @@
           <p:cNvPr id="3" name="Right column">
             <a:extLst xmlns:a="http://schemas.openxmlformats.org/drawingml/2006/main">
               <a:ext uri="{FF2B5EF4-FFF2-40B4-BE49-F238E27FC236}">
-                <a16:creationId xmlns:a16="http://schemas.microsoft.com/office/drawing/2014/main" id="{1F769DE5-73BD-422E-857C-1C8DEE78146C}"/>
+                <a16:creationId xmlns:a16="http://schemas.microsoft.com/office/drawing/2014/main" id="{7AE94604-D544-41DF-A0DF-DC057E7FF1AC}"/>
               </a:ext>
             </a:extLst>
           </p:cNvPr>
@@ -4852,7 +4852,7 @@
           <p:cNvPr id="3" name="Title">
             <a:extLst xmlns:a="http://schemas.openxmlformats.org/drawingml/2006/main">
               <a:ext uri="{FF2B5EF4-FFF2-40B4-BE49-F238E27FC236}">
-                <a16:creationId xmlns:a16="http://schemas.microsoft.com/office/drawing/2014/main" id="{BC6D5CFF-C1F6-40A3-8CF2-EF8B8AC8FD33}"/>
+                <a16:creationId xmlns:a16="http://schemas.microsoft.com/office/drawing/2014/main" id="{52D3C4D7-0563-45C3-BE24-42B315BFF3DF}"/>
               </a:ext>
             </a:extLst>
           </p:cNvPr>
@@ -5081,7 +5081,7 @@
           <p:cNvPr id="2" name="Left column">
             <a:extLst xmlns:a="http://schemas.openxmlformats.org/drawingml/2006/main">
               <a:ext uri="{FF2B5EF4-FFF2-40B4-BE49-F238E27FC236}">
-                <a16:creationId xmlns:a16="http://schemas.microsoft.com/office/drawing/2014/main" id="{F22C23BF-344B-40E8-8549-0018EBC5CBFF}"/>
+                <a16:creationId xmlns:a16="http://schemas.microsoft.com/office/drawing/2014/main" id="{F6838C4E-3A01-4DB3-92B1-9476BB0F7B19}"/>
               </a:ext>
             </a:extLst>
           </p:cNvPr>
@@ -5348,12 +5348,12 @@
   </p:cSld>
   <p:clrMap bg1="lt1" tx1="dk1" bg2="lt2" tx2="dk2" accent1="accent1" accent2="accent2" accent3="accent3" accent4="accent4" accent5="accent5" accent6="accent6" hlink="hlink" folHlink="folHlink"/>
   <p:sldLayoutIdLst>
-    <p:sldLayoutId xmlns:r="http://schemas.openxmlformats.org/officeDocument/2006/relationships" id="2147483649" r:id="R93f90dacae85418b"/>
-    <p:sldLayoutId xmlns:r="http://schemas.openxmlformats.org/officeDocument/2006/relationships" id="2147483650" r:id="R65e31a878c2446b0"/>
-    <p:sldLayoutId xmlns:r="http://schemas.openxmlformats.org/officeDocument/2006/relationships" id="2147483651" r:id="R3d6173e105c14914"/>
-    <p:sldLayoutId xmlns:r="http://schemas.openxmlformats.org/officeDocument/2006/relationships" id="2147483652" r:id="R78f48415b30c422e"/>
-    <p:sldLayoutId xmlns:r="http://schemas.openxmlformats.org/officeDocument/2006/relationships" id="2147483653" r:id="Rfd1580ee1c0c4d5a"/>
-    <p:sldLayoutId xmlns:r="http://schemas.openxmlformats.org/officeDocument/2006/relationships" id="2147483654" r:id="R5ab352659bdc46c8"/>
+    <p:sldLayoutId xmlns:r="http://schemas.openxmlformats.org/officeDocument/2006/relationships" id="2147483649" r:id="R760eeeebe00e4854"/>
+    <p:sldLayoutId xmlns:r="http://schemas.openxmlformats.org/officeDocument/2006/relationships" id="2147483650" r:id="Rb89cff5448d849ef"/>
+    <p:sldLayoutId xmlns:r="http://schemas.openxmlformats.org/officeDocument/2006/relationships" id="2147483651" r:id="R3869a27fa66c42ac"/>
+    <p:sldLayoutId xmlns:r="http://schemas.openxmlformats.org/officeDocument/2006/relationships" id="2147483652" r:id="R4ab4eb98220b4dd1"/>
+    <p:sldLayoutId xmlns:r="http://schemas.openxmlformats.org/officeDocument/2006/relationships" id="2147483653" r:id="R5fdcce939a084bb4"/>
+    <p:sldLayoutId xmlns:r="http://schemas.openxmlformats.org/officeDocument/2006/relationships" id="2147483654" r:id="Rd21e8ce8c73348d7"/>
   </p:sldLayoutIdLst>
   <p:txStyles>
     <p:titleStyle>
@@ -5904,7 +5904,7 @@
           <p:cNvPr id="12" name="ACT 0 · 익숙한 사용에서 시작하기">
             <a:extLst xmlns:a="http://schemas.openxmlformats.org/drawingml/2006/main">
               <a:ext uri="{FF2B5EF4-FFF2-40B4-BE49-F238E27FC236}">
-                <a16:creationId xmlns:a16="http://schemas.microsoft.com/office/drawing/2014/main" id="{7B1E21FB-939D-410B-A049-5EBB07770680}"/>
+                <a16:creationId xmlns:a16="http://schemas.microsoft.com/office/drawing/2014/main" id="{B0E71037-44E2-4D2E-860B-04216000CEFD}"/>
               </a:ext>
             </a:extLst>
           </p:cNvPr>
@@ -6062,7 +6062,7 @@
           <p:cNvPr id="2" name="S01">
             <a:extLst xmlns:a="http://schemas.openxmlformats.org/drawingml/2006/main">
               <a:ext uri="{FF2B5EF4-FFF2-40B4-BE49-F238E27FC236}">
-                <a16:creationId xmlns:a16="http://schemas.microsoft.com/office/drawing/2014/main" id="{0D500242-1780-453D-90F4-D89A4F369E84}"/>
+                <a16:creationId xmlns:a16="http://schemas.microsoft.com/office/drawing/2014/main" id="{59EE76F0-CFBA-4037-9619-BDDA16E10F2E}"/>
               </a:ext>
             </a:extLst>
           </p:cNvPr>
@@ -6220,7 +6220,7 @@
           <p:cNvPr id="3" name="AI에게 지금 무엇을 맡기고 있는가?">
             <a:extLst xmlns:a="http://schemas.openxmlformats.org/drawingml/2006/main">
               <a:ext uri="{FF2B5EF4-FFF2-40B4-BE49-F238E27FC236}">
-                <a16:creationId xmlns:a16="http://schemas.microsoft.com/office/drawing/2014/main" id="{CC1CBF9B-08A7-4A33-AF72-73EEAEA5954F}"/>
+                <a16:creationId xmlns:a16="http://schemas.microsoft.com/office/drawing/2014/main" id="{A7591E0F-2ACF-4232-854E-4CECA34CFF12}"/>
               </a:ext>
             </a:extLst>
           </p:cNvPr>
@@ -6378,7 +6378,7 @@
           <p:cNvPr id="4" name="">
             <a:extLst xmlns:a="http://schemas.openxmlformats.org/drawingml/2006/main">
               <a:ext uri="{FF2B5EF4-FFF2-40B4-BE49-F238E27FC236}">
-                <a16:creationId xmlns:a16="http://schemas.microsoft.com/office/drawing/2014/main" id="{DCE81CDB-E407-4EFF-B2C7-36CFA13563B6}"/>
+                <a16:creationId xmlns:a16="http://schemas.microsoft.com/office/drawing/2014/main" id="{DAFEEFB8-FA25-4212-AFDA-69C9791B95DA}"/>
               </a:ext>
             </a:extLst>
           </p:cNvPr>
@@ -6409,7 +6409,7 @@
           <p:cNvPr id="5" name="생각해 보기 · 이 과정의 교육 모델">
             <a:extLst xmlns:a="http://schemas.openxmlformats.org/drawingml/2006/main">
               <a:ext uri="{FF2B5EF4-FFF2-40B4-BE49-F238E27FC236}">
-                <a16:creationId xmlns:a16="http://schemas.microsoft.com/office/drawing/2014/main" id="{0D34FB7E-372E-42C7-AC2C-CFBEB4990376}"/>
+                <a16:creationId xmlns:a16="http://schemas.microsoft.com/office/drawing/2014/main" id="{D09B0A56-2E9C-4838-A214-BB8BD60F8E50}"/>
               </a:ext>
             </a:extLst>
           </p:cNvPr>
@@ -6567,7 +6567,7 @@
           <p:cNvPr id="6" name="자신의 경험 하나만 떠올려 보세요. 사용 수준을 평가하는 질문이 아닙니다.">
             <a:extLst xmlns:a="http://schemas.openxmlformats.org/drawingml/2006/main">
               <a:ext uri="{FF2B5EF4-FFF2-40B4-BE49-F238E27FC236}">
-                <a16:creationId xmlns:a16="http://schemas.microsoft.com/office/drawing/2014/main" id="{9A008C5B-CED9-4270-AF8B-7588D38BAB6C}"/>
+                <a16:creationId xmlns:a16="http://schemas.microsoft.com/office/drawing/2014/main" id="{29AB6231-4CA2-4F31-A542-219CA173BE7C}"/>
               </a:ext>
             </a:extLst>
           </p:cNvPr>
@@ -6725,7 +6725,7 @@
           <p:cNvPr id="7" name="가장 최근에 AI에게 맡긴 일 하나">
             <a:extLst xmlns:a="http://schemas.openxmlformats.org/drawingml/2006/main">
               <a:ext uri="{FF2B5EF4-FFF2-40B4-BE49-F238E27FC236}">
-                <a16:creationId xmlns:a16="http://schemas.microsoft.com/office/drawing/2014/main" id="{BFDF4C03-67E6-4124-B5C0-9184571DD32D}"/>
+                <a16:creationId xmlns:a16="http://schemas.microsoft.com/office/drawing/2014/main" id="{B626279D-700C-4752-AAB4-7BDE5B5A2E39}"/>
               </a:ext>
             </a:extLst>
           </p:cNvPr>
@@ -6883,7 +6883,7 @@
           <p:cNvPr id="8" name="오류 설명을 들었나요?&#10;관련 코드를 조사하게 했나요?&#10;수정한 결과까지 확인하게 했나요?">
             <a:extLst xmlns:a="http://schemas.openxmlformats.org/drawingml/2006/main">
               <a:ext uri="{FF2B5EF4-FFF2-40B4-BE49-F238E27FC236}">
-                <a16:creationId xmlns:a16="http://schemas.microsoft.com/office/drawing/2014/main" id="{81DE875A-2B17-446A-A771-528D6FBCADD1}"/>
+                <a16:creationId xmlns:a16="http://schemas.microsoft.com/office/drawing/2014/main" id="{1DE8D726-A6BB-47F9-B477-D7BAF21DD1C8}"/>
               </a:ext>
             </a:extLst>
           </p:cNvPr>
@@ -7087,7 +7087,7 @@
           <p:cNvPr id="9" name="">
             <a:extLst xmlns:a="http://schemas.openxmlformats.org/drawingml/2006/main">
               <a:ext uri="{FF2B5EF4-FFF2-40B4-BE49-F238E27FC236}">
-                <a16:creationId xmlns:a16="http://schemas.microsoft.com/office/drawing/2014/main" id="{D18049FF-B0B5-4967-9F49-47401D53DBB7}"/>
+                <a16:creationId xmlns:a16="http://schemas.microsoft.com/office/drawing/2014/main" id="{01CFB95B-5A7D-4FFD-AF8D-C853A8BFC425}"/>
               </a:ext>
             </a:extLst>
           </p:cNvPr>
@@ -7118,7 +7118,7 @@
           <p:cNvPr id="10" name="질문 · 생성&#10;조사 · 변경&#10;검증 · 작업 방식 개선">
             <a:extLst xmlns:a="http://schemas.openxmlformats.org/drawingml/2006/main">
               <a:ext uri="{FF2B5EF4-FFF2-40B4-BE49-F238E27FC236}">
-                <a16:creationId xmlns:a16="http://schemas.microsoft.com/office/drawing/2014/main" id="{7C988389-38EE-4E13-8F6C-4ADB0A599CAB}"/>
+                <a16:creationId xmlns:a16="http://schemas.microsoft.com/office/drawing/2014/main" id="{35CC1EAD-0ED3-4339-9252-D507E540DA1F}"/>
               </a:ext>
             </a:extLst>
           </p:cNvPr>
@@ -7322,7 +7322,7 @@
           <p:cNvPr id="11" name="익숙한 방식에서 출발해도 괜찮습니다.">
             <a:extLst xmlns:a="http://schemas.openxmlformats.org/drawingml/2006/main">
               <a:ext uri="{FF2B5EF4-FFF2-40B4-BE49-F238E27FC236}">
-                <a16:creationId xmlns:a16="http://schemas.microsoft.com/office/drawing/2014/main" id="{4CE2BEF0-86B7-4F89-8CEC-B93952B42BE5}"/>
+                <a16:creationId xmlns:a16="http://schemas.microsoft.com/office/drawing/2014/main" id="{6BA06903-C1D5-48A2-9443-AA6C6EB1384A}"/>
               </a:ext>
             </a:extLst>
           </p:cNvPr>
@@ -7478,7 +7478,7 @@
     </p:spTree>
     <p:extLst>
       <p:ext uri="{BB962C8B-B14F-4D97-AF65-F5344CB8AC3E}">
-        <p14:creationId xmlns:p14="http://schemas.microsoft.com/office/powerpoint/2010/main" val="738171509"/>
+        <p14:creationId xmlns:p14="http://schemas.microsoft.com/office/powerpoint/2010/main" val="643857892"/>
       </p:ext>
     </p:extLst>
   </p:cSld>
@@ -7509,7 +7509,7 @@
           <p:cNvPr id="23" name="ACT 0 · 작은 코드 질문">
             <a:extLst xmlns:a="http://schemas.openxmlformats.org/drawingml/2006/main">
               <a:ext uri="{FF2B5EF4-FFF2-40B4-BE49-F238E27FC236}">
-                <a16:creationId xmlns:a16="http://schemas.microsoft.com/office/drawing/2014/main" id="{EBA624AF-013A-4756-AD03-A080891D9D3B}"/>
+                <a16:creationId xmlns:a16="http://schemas.microsoft.com/office/drawing/2014/main" id="{D4250985-CFB0-4A92-A960-7C2CA8A7356B}"/>
               </a:ext>
             </a:extLst>
           </p:cNvPr>
@@ -7667,7 +7667,7 @@
           <p:cNvPr id="2" name="S02">
             <a:extLst xmlns:a="http://schemas.openxmlformats.org/drawingml/2006/main">
               <a:ext uri="{FF2B5EF4-FFF2-40B4-BE49-F238E27FC236}">
-                <a16:creationId xmlns:a16="http://schemas.microsoft.com/office/drawing/2014/main" id="{300256B8-EF47-4BE8-AE70-1F0830290B13}"/>
+                <a16:creationId xmlns:a16="http://schemas.microsoft.com/office/drawing/2014/main" id="{F833CB1B-8FC1-4516-8417-CE54F25AF518}"/>
               </a:ext>
             </a:extLst>
           </p:cNvPr>
@@ -7825,7 +7825,7 @@
           <p:cNvPr id="3" name="작은 질문에는 Chatbot이 유용하다">
             <a:extLst xmlns:a="http://schemas.openxmlformats.org/drawingml/2006/main">
               <a:ext uri="{FF2B5EF4-FFF2-40B4-BE49-F238E27FC236}">
-                <a16:creationId xmlns:a16="http://schemas.microsoft.com/office/drawing/2014/main" id="{CE8DD933-7BF0-4D3C-9EE1-FC9FE1B6FD74}"/>
+                <a16:creationId xmlns:a16="http://schemas.microsoft.com/office/drawing/2014/main" id="{E0AE5EA2-A16F-461A-B92D-85C55D3AA66F}"/>
               </a:ext>
             </a:extLst>
           </p:cNvPr>
@@ -7983,7 +7983,7 @@
           <p:cNvPr id="4" name="">
             <a:extLst xmlns:a="http://schemas.openxmlformats.org/drawingml/2006/main">
               <a:ext uri="{FF2B5EF4-FFF2-40B4-BE49-F238E27FC236}">
-                <a16:creationId xmlns:a16="http://schemas.microsoft.com/office/drawing/2014/main" id="{B4D3C240-DD10-4B3E-8CC2-990C4B81D370}"/>
+                <a16:creationId xmlns:a16="http://schemas.microsoft.com/office/drawing/2014/main" id="{EAD31D19-9B29-40A2-80FD-0CE6C8E02B41}"/>
               </a:ext>
             </a:extLst>
           </p:cNvPr>
@@ -8014,7 +8014,7 @@
           <p:cNvPr id="5" name="교육용 예시 · 실제 ChatGPT 대화 캡처가 아님">
             <a:extLst xmlns:a="http://schemas.openxmlformats.org/drawingml/2006/main">
               <a:ext uri="{FF2B5EF4-FFF2-40B4-BE49-F238E27FC236}">
-                <a16:creationId xmlns:a16="http://schemas.microsoft.com/office/drawing/2014/main" id="{FEC4FA66-2512-4CAA-8681-D0B6AB5FC100}"/>
+                <a16:creationId xmlns:a16="http://schemas.microsoft.com/office/drawing/2014/main" id="{19727E38-45C0-4ABD-BFC9-47FE8178C40E}"/>
               </a:ext>
             </a:extLst>
           </p:cNvPr>
@@ -8172,7 +8172,7 @@
           <p:cNvPr id="6" name="일반적인 질문 흐름을 설명하며 특정 제품의 정확도나 우월성을 주장하지 않습니다.">
             <a:extLst xmlns:a="http://schemas.openxmlformats.org/drawingml/2006/main">
               <a:ext uri="{FF2B5EF4-FFF2-40B4-BE49-F238E27FC236}">
-                <a16:creationId xmlns:a16="http://schemas.microsoft.com/office/drawing/2014/main" id="{1108AAD9-1002-401B-8A6C-C324793A0F32}"/>
+                <a16:creationId xmlns:a16="http://schemas.microsoft.com/office/drawing/2014/main" id="{A34330F6-4345-4B40-8A49-0DE5010FA880}"/>
               </a:ext>
             </a:extLst>
           </p:cNvPr>
@@ -8330,7 +8330,7 @@
           <p:cNvPr id="7" name="“이 코드에서 무엇이 남을까?”">
             <a:extLst xmlns:a="http://schemas.openxmlformats.org/drawingml/2006/main">
               <a:ext uri="{FF2B5EF4-FFF2-40B4-BE49-F238E27FC236}">
-                <a16:creationId xmlns:a16="http://schemas.microsoft.com/office/drawing/2014/main" id="{FE88DCBA-D5A2-40E8-AF01-78E57EF3CE1B}"/>
+                <a16:creationId xmlns:a16="http://schemas.microsoft.com/office/drawing/2014/main" id="{F9383DBB-ACEC-432B-97F7-21C79447C244}"/>
               </a:ext>
             </a:extLst>
           </p:cNvPr>
@@ -8488,7 +8488,7 @@
           <p:cNvPr id="8" name="">
             <a:extLst xmlns:a="http://schemas.openxmlformats.org/drawingml/2006/main">
               <a:ext uri="{FF2B5EF4-FFF2-40B4-BE49-F238E27FC236}">
-                <a16:creationId xmlns:a16="http://schemas.microsoft.com/office/drawing/2014/main" id="{6531F4FA-6278-46C9-896D-3314A8CAFA53}"/>
+                <a16:creationId xmlns:a16="http://schemas.microsoft.com/office/drawing/2014/main" id="{3849AAD5-1CA3-49EB-8D83-EECB17F88314}"/>
               </a:ext>
             </a:extLst>
           </p:cNvPr>
@@ -8519,7 +8519,7 @@
           <p:cNvPr id="9" name="row = [1, 2, 3, 4]&#10;row[1:3]">
             <a:extLst xmlns:a="http://schemas.openxmlformats.org/drawingml/2006/main">
               <a:ext uri="{FF2B5EF4-FFF2-40B4-BE49-F238E27FC236}">
-                <a16:creationId xmlns:a16="http://schemas.microsoft.com/office/drawing/2014/main" id="{66DFF1C4-6EE1-46F7-B8E0-996B80CD33FA}"/>
+                <a16:creationId xmlns:a16="http://schemas.microsoft.com/office/drawing/2014/main" id="{86BD8B17-4C87-47E7-BE95-4497D634CB2C}"/>
               </a:ext>
             </a:extLst>
           </p:cNvPr>
@@ -8700,7 +8700,7 @@
           <p:cNvPr id="10" name="">
             <a:extLst xmlns:a="http://schemas.openxmlformats.org/drawingml/2006/main">
               <a:ext uri="{FF2B5EF4-FFF2-40B4-BE49-F238E27FC236}">
-                <a16:creationId xmlns:a16="http://schemas.microsoft.com/office/drawing/2014/main" id="{7201C793-D2BB-4E9A-8193-DE4B0A7CF676}"/>
+                <a16:creationId xmlns:a16="http://schemas.microsoft.com/office/drawing/2014/main" id="{3058AC4F-325A-440C-BB96-31818B32CDAC}"/>
               </a:ext>
             </a:extLst>
           </p:cNvPr>
@@ -8730,7 +8730,7 @@
           <p:cNvPr id="11" name="[2, 3]">
             <a:extLst xmlns:a="http://schemas.openxmlformats.org/drawingml/2006/main">
               <a:ext uri="{FF2B5EF4-FFF2-40B4-BE49-F238E27FC236}">
-                <a16:creationId xmlns:a16="http://schemas.microsoft.com/office/drawing/2014/main" id="{91A883A1-2325-40D9-8E01-A7CF02BE6DF5}"/>
+                <a16:creationId xmlns:a16="http://schemas.microsoft.com/office/drawing/2014/main" id="{7822315C-5EBF-4165-A77B-6BF8FE925D68}"/>
               </a:ext>
             </a:extLst>
           </p:cNvPr>
@@ -8888,7 +8888,7 @@
           <p:cNvPr id="12" name="끝 index 3은 포함하지 않습니다.">
             <a:extLst xmlns:a="http://schemas.openxmlformats.org/drawingml/2006/main">
               <a:ext uri="{FF2B5EF4-FFF2-40B4-BE49-F238E27FC236}">
-                <a16:creationId xmlns:a16="http://schemas.microsoft.com/office/drawing/2014/main" id="{68FC4D55-140C-4010-BC8F-99BDBA754429}"/>
+                <a16:creationId xmlns:a16="http://schemas.microsoft.com/office/drawing/2014/main" id="{1A55F59F-11E1-4D3E-A84E-77D28E48229D}"/>
               </a:ext>
             </a:extLst>
           </p:cNvPr>
@@ -9046,7 +9046,7 @@
           <p:cNvPr id="13" name="코드·오류">
             <a:extLst xmlns:a="http://schemas.openxmlformats.org/drawingml/2006/main">
               <a:ext uri="{FF2B5EF4-FFF2-40B4-BE49-F238E27FC236}">
-                <a16:creationId xmlns:a16="http://schemas.microsoft.com/office/drawing/2014/main" id="{64202124-A1E8-482B-8BFD-8F99E90183BD}"/>
+                <a16:creationId xmlns:a16="http://schemas.microsoft.com/office/drawing/2014/main" id="{E4446420-ECBA-48F7-BA36-A13D344AA09C}"/>
               </a:ext>
             </a:extLst>
           </p:cNvPr>
@@ -9204,7 +9204,7 @@
           <p:cNvPr id="14" name="">
             <a:extLst xmlns:a="http://schemas.openxmlformats.org/drawingml/2006/main">
               <a:ext uri="{FF2B5EF4-FFF2-40B4-BE49-F238E27FC236}">
-                <a16:creationId xmlns:a16="http://schemas.microsoft.com/office/drawing/2014/main" id="{7804D775-6FA6-4A82-96E4-19E16D080016}"/>
+                <a16:creationId xmlns:a16="http://schemas.microsoft.com/office/drawing/2014/main" id="{35989B9F-9C4C-45FA-927E-274982805298}"/>
               </a:ext>
             </a:extLst>
           </p:cNvPr>
@@ -9234,7 +9234,7 @@
           <p:cNvPr id="15" name="복사">
             <a:extLst xmlns:a="http://schemas.openxmlformats.org/drawingml/2006/main">
               <a:ext uri="{FF2B5EF4-FFF2-40B4-BE49-F238E27FC236}">
-                <a16:creationId xmlns:a16="http://schemas.microsoft.com/office/drawing/2014/main" id="{D7283F99-3CA7-475A-9EC9-846ABF375AAF}"/>
+                <a16:creationId xmlns:a16="http://schemas.microsoft.com/office/drawing/2014/main" id="{F85ED7BB-4F8E-483C-92C7-ED71A02CF75E}"/>
               </a:ext>
             </a:extLst>
           </p:cNvPr>
@@ -9392,7 +9392,7 @@
           <p:cNvPr id="16" name="">
             <a:extLst xmlns:a="http://schemas.openxmlformats.org/drawingml/2006/main">
               <a:ext uri="{FF2B5EF4-FFF2-40B4-BE49-F238E27FC236}">
-                <a16:creationId xmlns:a16="http://schemas.microsoft.com/office/drawing/2014/main" id="{5389E282-C107-4BFF-9033-4A75BA7BE998}"/>
+                <a16:creationId xmlns:a16="http://schemas.microsoft.com/office/drawing/2014/main" id="{8B41D2D2-71DF-47DB-96BA-A5879297188C}"/>
               </a:ext>
             </a:extLst>
           </p:cNvPr>
@@ -9422,7 +9422,7 @@
           <p:cNvPr id="17" name="질문">
             <a:extLst xmlns:a="http://schemas.openxmlformats.org/drawingml/2006/main">
               <a:ext uri="{FF2B5EF4-FFF2-40B4-BE49-F238E27FC236}">
-                <a16:creationId xmlns:a16="http://schemas.microsoft.com/office/drawing/2014/main" id="{6B2E9E8D-2F96-4674-BCA0-AF9CA481918E}"/>
+                <a16:creationId xmlns:a16="http://schemas.microsoft.com/office/drawing/2014/main" id="{13E48595-F03E-4F16-804C-5C1ECCADA6A7}"/>
               </a:ext>
             </a:extLst>
           </p:cNvPr>
@@ -9580,7 +9580,7 @@
           <p:cNvPr id="18" name="">
             <a:extLst xmlns:a="http://schemas.openxmlformats.org/drawingml/2006/main">
               <a:ext uri="{FF2B5EF4-FFF2-40B4-BE49-F238E27FC236}">
-                <a16:creationId xmlns:a16="http://schemas.microsoft.com/office/drawing/2014/main" id="{2C15C240-2FB3-4250-BE29-83B6DD1484F1}"/>
+                <a16:creationId xmlns:a16="http://schemas.microsoft.com/office/drawing/2014/main" id="{2F5D97A5-BB1D-4BD3-89F4-FAABC382A967}"/>
               </a:ext>
             </a:extLst>
           </p:cNvPr>
@@ -9610,7 +9610,7 @@
           <p:cNvPr id="19" name="답 확인">
             <a:extLst xmlns:a="http://schemas.openxmlformats.org/drawingml/2006/main">
               <a:ext uri="{FF2B5EF4-FFF2-40B4-BE49-F238E27FC236}">
-                <a16:creationId xmlns:a16="http://schemas.microsoft.com/office/drawing/2014/main" id="{66E122F9-68C5-418E-BF85-06AD3DD35C2A}"/>
+                <a16:creationId xmlns:a16="http://schemas.microsoft.com/office/drawing/2014/main" id="{E441FCA2-2E19-4B2C-B8B1-DD0E19724CE7}"/>
               </a:ext>
             </a:extLst>
           </p:cNvPr>
@@ -9768,7 +9768,7 @@
           <p:cNvPr id="20" name="">
             <a:extLst xmlns:a="http://schemas.openxmlformats.org/drawingml/2006/main">
               <a:ext uri="{FF2B5EF4-FFF2-40B4-BE49-F238E27FC236}">
-                <a16:creationId xmlns:a16="http://schemas.microsoft.com/office/drawing/2014/main" id="{F79E3DF2-2854-4C1E-BDF5-5F6FFFEED77C}"/>
+                <a16:creationId xmlns:a16="http://schemas.microsoft.com/office/drawing/2014/main" id="{F240AE65-6744-4A7B-B356-7FAED59A57EA}"/>
               </a:ext>
             </a:extLst>
           </p:cNvPr>
@@ -9798,7 +9798,7 @@
           <p:cNvPr id="21" name="IDE로 복귀">
             <a:extLst xmlns:a="http://schemas.openxmlformats.org/drawingml/2006/main">
               <a:ext uri="{FF2B5EF4-FFF2-40B4-BE49-F238E27FC236}">
-                <a16:creationId xmlns:a16="http://schemas.microsoft.com/office/drawing/2014/main" id="{FDB5D05A-8A76-4CB8-93DE-1F567C8183E3}"/>
+                <a16:creationId xmlns:a16="http://schemas.microsoft.com/office/drawing/2014/main" id="{B47814E5-7E72-4625-827B-2EB24A04D2BA}"/>
               </a:ext>
             </a:extLst>
           </p:cNvPr>
@@ -9956,7 +9956,7 @@
           <p:cNvPr id="22" name="">
             <a:extLst xmlns:a="http://schemas.openxmlformats.org/drawingml/2006/main">
               <a:ext uri="{FF2B5EF4-FFF2-40B4-BE49-F238E27FC236}">
-                <a16:creationId xmlns:a16="http://schemas.microsoft.com/office/drawing/2014/main" id="{92E589A4-FE4E-4C69-8B20-8CC8EB424B2B}"/>
+                <a16:creationId xmlns:a16="http://schemas.microsoft.com/office/drawing/2014/main" id="{89C19AF1-013B-4FC6-897A-608504B363F4}"/>
               </a:ext>
             </a:extLst>
           </p:cNvPr>
@@ -9985,7 +9985,7 @@
     </p:spTree>
     <p:extLst>
       <p:ext uri="{BB962C8B-B14F-4D97-AF65-F5344CB8AC3E}">
-        <p14:creationId xmlns:p14="http://schemas.microsoft.com/office/powerpoint/2010/main" val="781278197"/>
+        <p14:creationId xmlns:p14="http://schemas.microsoft.com/office/powerpoint/2010/main" val="1296655413"/>
       </p:ext>
     </p:extLst>
   </p:cSld>
@@ -10016,7 +10016,7 @@
           <p:cNvPr id="16" name="ACT 0 · 여러 파일을 가로지르는 질문">
             <a:extLst xmlns:a="http://schemas.openxmlformats.org/drawingml/2006/main">
               <a:ext uri="{FF2B5EF4-FFF2-40B4-BE49-F238E27FC236}">
-                <a16:creationId xmlns:a16="http://schemas.microsoft.com/office/drawing/2014/main" id="{8C879627-BB46-4FBD-80BD-EA04F24602AE}"/>
+                <a16:creationId xmlns:a16="http://schemas.microsoft.com/office/drawing/2014/main" id="{781825B7-CD47-46B0-B733-1B345B946DD4}"/>
               </a:ext>
             </a:extLst>
           </p:cNvPr>
@@ -10174,7 +10174,7 @@
           <p:cNvPr id="2" name="S03">
             <a:extLst xmlns:a="http://schemas.openxmlformats.org/drawingml/2006/main">
               <a:ext uri="{FF2B5EF4-FFF2-40B4-BE49-F238E27FC236}">
-                <a16:creationId xmlns:a16="http://schemas.microsoft.com/office/drawing/2014/main" id="{746155A7-8827-485B-A89A-8B05D7133DE2}"/>
+                <a16:creationId xmlns:a16="http://schemas.microsoft.com/office/drawing/2014/main" id="{AE7B40F9-66F0-4FA4-B61E-97F81955E77B}"/>
               </a:ext>
             </a:extLst>
           </p:cNvPr>
@@ -10332,7 +10332,7 @@
           <p:cNvPr id="3" name="질문이 커지면 Context를 모으는 일이 생긴다">
             <a:extLst xmlns:a="http://schemas.openxmlformats.org/drawingml/2006/main">
               <a:ext uri="{FF2B5EF4-FFF2-40B4-BE49-F238E27FC236}">
-                <a16:creationId xmlns:a16="http://schemas.microsoft.com/office/drawing/2014/main" id="{D0DEF59A-DFB3-45FD-8F43-903F19418367}"/>
+                <a16:creationId xmlns:a16="http://schemas.microsoft.com/office/drawing/2014/main" id="{94C7CC41-B3FC-48B1-BA09-A4DACA1BCE2E}"/>
               </a:ext>
             </a:extLst>
           </p:cNvPr>
@@ -10490,7 +10490,7 @@
           <p:cNvPr id="4" name="">
             <a:extLst xmlns:a="http://schemas.openxmlformats.org/drawingml/2006/main">
               <a:ext uri="{FF2B5EF4-FFF2-40B4-BE49-F238E27FC236}">
-                <a16:creationId xmlns:a16="http://schemas.microsoft.com/office/drawing/2014/main" id="{D5FEF454-2656-4201-8446-E19C228B7C48}"/>
+                <a16:creationId xmlns:a16="http://schemas.microsoft.com/office/drawing/2014/main" id="{075B7535-7053-4A2D-BA25-5E08B61484B7}"/>
               </a:ext>
             </a:extLst>
           </p:cNvPr>
@@ -10521,7 +10521,7 @@
           <p:cNvPr id="5" name="개념 사례 · 사람이 Context를 모으는 장면 · AI 생성 설명용 삽화">
             <a:extLst xmlns:a="http://schemas.openxmlformats.org/drawingml/2006/main">
               <a:ext uri="{FF2B5EF4-FFF2-40B4-BE49-F238E27FC236}">
-                <a16:creationId xmlns:a16="http://schemas.microsoft.com/office/drawing/2014/main" id="{EFEF0493-FD3D-4594-9AF4-F77EFA167FE3}"/>
+                <a16:creationId xmlns:a16="http://schemas.microsoft.com/office/drawing/2014/main" id="{541EAB7A-5813-478E-94B8-AF2FD15FAA17}"/>
               </a:ext>
             </a:extLst>
           </p:cNvPr>
@@ -10679,7 +10679,7 @@
           <p:cNvPr id="6" name="특정 Trial에서 실제로 발생한 비용이나 실패를 뜻하지 않습니다.">
             <a:extLst xmlns:a="http://schemas.openxmlformats.org/drawingml/2006/main">
               <a:ext uri="{FF2B5EF4-FFF2-40B4-BE49-F238E27FC236}">
-                <a16:creationId xmlns:a16="http://schemas.microsoft.com/office/drawing/2014/main" id="{E80AFD1A-3B23-4DB6-BD70-581367672CB9}"/>
+                <a16:creationId xmlns:a16="http://schemas.microsoft.com/office/drawing/2014/main" id="{DCD3D4E0-B37F-4520-8ED4-98DD98DA571E}"/>
               </a:ext>
             </a:extLst>
           </p:cNvPr>
@@ -10837,7 +10837,7 @@
           <p:cNvPr id="7" name="“CLI 결과가 기대와 다른데, 어디서부터 봐야 할까?”">
             <a:extLst xmlns:a="http://schemas.openxmlformats.org/drawingml/2006/main">
               <a:ext uri="{FF2B5EF4-FFF2-40B4-BE49-F238E27FC236}">
-                <a16:creationId xmlns:a16="http://schemas.microsoft.com/office/drawing/2014/main" id="{4E06622F-010C-476D-8C7E-6500B58E930B}"/>
+                <a16:creationId xmlns:a16="http://schemas.microsoft.com/office/drawing/2014/main" id="{8EDAF773-7FA9-474E-ADC3-11D3E5E7312E}"/>
               </a:ext>
             </a:extLst>
           </p:cNvPr>
@@ -10995,7 +10995,7 @@
           <p:cNvPr id="8" name="">
             <a:extLst xmlns:a="http://schemas.openxmlformats.org/drawingml/2006/main">
               <a:ext uri="{FF2B5EF4-FFF2-40B4-BE49-F238E27FC236}">
-                <a16:creationId xmlns:a16="http://schemas.microsoft.com/office/drawing/2014/main" id="{31BC5AE2-9BBA-4B7B-B9DF-9CE20B7021DC}"/>
+                <a16:creationId xmlns:a16="http://schemas.microsoft.com/office/drawing/2014/main" id="{2AA22F74-7536-423C-AEBC-5068EC2724BD}"/>
               </a:ext>
             </a:extLst>
           </p:cNvPr>
@@ -11005,7 +11005,7 @@
           <p:nvPr/>
         </p:nvPicPr>
         <p:blipFill>
-          <a:blip xmlns:r="http://schemas.openxmlformats.org/officeDocument/2006/relationships" xmlns:a="http://schemas.openxmlformats.org/drawingml/2006/main" r:embed="R99cd477771fd497a"/>
+          <a:blip xmlns:r="http://schemas.openxmlformats.org/officeDocument/2006/relationships" xmlns:a="http://schemas.openxmlformats.org/drawingml/2006/main" r:embed="Rb22c8ee1771e477c"/>
           <a:stretch xmlns:a="http://schemas.openxmlformats.org/drawingml/2006/main"/>
         </p:blipFill>
         <p:spPr>
@@ -11023,7 +11023,7 @@
           <p:cNvPr id="9" name="구현 · 호출 경로">
             <a:extLst xmlns:a="http://schemas.openxmlformats.org/drawingml/2006/main">
               <a:ext uri="{FF2B5EF4-FFF2-40B4-BE49-F238E27FC236}">
-                <a16:creationId xmlns:a16="http://schemas.microsoft.com/office/drawing/2014/main" id="{A45039C8-AF19-43E1-93A3-519A607418F5}"/>
+                <a16:creationId xmlns:a16="http://schemas.microsoft.com/office/drawing/2014/main" id="{D3C7E384-8480-4F02-B736-C696FA471798}"/>
               </a:ext>
             </a:extLst>
           </p:cNvPr>
@@ -11181,7 +11181,7 @@
           <p:cNvPr id="10" name="CLI → 처리 흐름 → 연산">
             <a:extLst xmlns:a="http://schemas.openxmlformats.org/drawingml/2006/main">
               <a:ext uri="{FF2B5EF4-FFF2-40B4-BE49-F238E27FC236}">
-                <a16:creationId xmlns:a16="http://schemas.microsoft.com/office/drawing/2014/main" id="{EFB894D7-24E9-4B46-B0F0-BE41CABE6705}"/>
+                <a16:creationId xmlns:a16="http://schemas.microsoft.com/office/drawing/2014/main" id="{441122E2-36AD-48F3-AD62-320CAF13F242}"/>
               </a:ext>
             </a:extLst>
           </p:cNvPr>
@@ -11339,7 +11339,7 @@
           <p:cNvPr id="11" name="테스트">
             <a:extLst xmlns:a="http://schemas.openxmlformats.org/drawingml/2006/main">
               <a:ext uri="{FF2B5EF4-FFF2-40B4-BE49-F238E27FC236}">
-                <a16:creationId xmlns:a16="http://schemas.microsoft.com/office/drawing/2014/main" id="{2920A941-A578-4C5B-B130-547B3284560F}"/>
+                <a16:creationId xmlns:a16="http://schemas.microsoft.com/office/drawing/2014/main" id="{5C76FA18-B0E2-44DE-A22C-862857DA2208}"/>
               </a:ext>
             </a:extLst>
           </p:cNvPr>
@@ -11497,7 +11497,7 @@
           <p:cNvPr id="12" name="어떤 조건에서 실패했나?">
             <a:extLst xmlns:a="http://schemas.openxmlformats.org/drawingml/2006/main">
               <a:ext uri="{FF2B5EF4-FFF2-40B4-BE49-F238E27FC236}">
-                <a16:creationId xmlns:a16="http://schemas.microsoft.com/office/drawing/2014/main" id="{606DEFAE-F6A4-4412-8F93-EAB43071C812}"/>
+                <a16:creationId xmlns:a16="http://schemas.microsoft.com/office/drawing/2014/main" id="{2DD66CC1-4CC6-427C-98E8-053F1B7DAD19}"/>
               </a:ext>
             </a:extLst>
           </p:cNvPr>
@@ -11655,7 +11655,7 @@
           <p:cNvPr id="13" name="계약">
             <a:extLst xmlns:a="http://schemas.openxmlformats.org/drawingml/2006/main">
               <a:ext uri="{FF2B5EF4-FFF2-40B4-BE49-F238E27FC236}">
-                <a16:creationId xmlns:a16="http://schemas.microsoft.com/office/drawing/2014/main" id="{00F20D52-212C-489C-A04D-1B77FAEAF952}"/>
+                <a16:creationId xmlns:a16="http://schemas.microsoft.com/office/drawing/2014/main" id="{0EA742D7-BE50-4A05-B050-972CBD2F5559}"/>
               </a:ext>
             </a:extLst>
           </p:cNvPr>
@@ -11813,7 +11813,7 @@
           <p:cNvPr id="14" name="원래 기대한 동작은?">
             <a:extLst xmlns:a="http://schemas.openxmlformats.org/drawingml/2006/main">
               <a:ext uri="{FF2B5EF4-FFF2-40B4-BE49-F238E27FC236}">
-                <a16:creationId xmlns:a16="http://schemas.microsoft.com/office/drawing/2014/main" id="{05EA532B-8889-4B2A-B594-FE56F22014D1}"/>
+                <a16:creationId xmlns:a16="http://schemas.microsoft.com/office/drawing/2014/main" id="{692B0987-0C2D-4554-94FA-B65F08A0A9B6}"/>
               </a:ext>
             </a:extLst>
           </p:cNvPr>
@@ -11971,7 +11971,7 @@
           <p:cNvPr id="15" name="질문에 옮길 자료는?">
             <a:extLst xmlns:a="http://schemas.openxmlformats.org/drawingml/2006/main">
               <a:ext uri="{FF2B5EF4-FFF2-40B4-BE49-F238E27FC236}">
-                <a16:creationId xmlns:a16="http://schemas.microsoft.com/office/drawing/2014/main" id="{AED84CD0-EAA2-4877-A7F3-97560EE6A595}"/>
+                <a16:creationId xmlns:a16="http://schemas.microsoft.com/office/drawing/2014/main" id="{CC3D8A4F-4D56-4AA1-BB78-2FF306FBD3B8}"/>
               </a:ext>
             </a:extLst>
           </p:cNvPr>
@@ -12127,7 +12127,7 @@
     </p:spTree>
     <p:extLst>
       <p:ext uri="{BB962C8B-B14F-4D97-AF65-F5344CB8AC3E}">
-        <p14:creationId xmlns:p14="http://schemas.microsoft.com/office/powerpoint/2010/main" val="1222811546"/>
+        <p14:creationId xmlns:p14="http://schemas.microsoft.com/office/powerpoint/2010/main" val="1902386995"/>
       </p:ext>
     </p:extLst>
   </p:cSld>
@@ -12158,7 +12158,7 @@
           <p:cNvPr id="13" name="ACT 0 · Repository 조사 관찰">
             <a:extLst xmlns:a="http://schemas.openxmlformats.org/drawingml/2006/main">
               <a:ext uri="{FF2B5EF4-FFF2-40B4-BE49-F238E27FC236}">
-                <a16:creationId xmlns:a16="http://schemas.microsoft.com/office/drawing/2014/main" id="{0C94E3FA-8A54-4FCF-AF0D-E8560DC5CC83}"/>
+                <a16:creationId xmlns:a16="http://schemas.microsoft.com/office/drawing/2014/main" id="{64525698-0BA4-4BB9-AED6-BDD0E969701C}"/>
               </a:ext>
             </a:extLst>
           </p:cNvPr>
@@ -12316,7 +12316,7 @@
           <p:cNvPr id="2" name="S04">
             <a:extLst xmlns:a="http://schemas.openxmlformats.org/drawingml/2006/main">
               <a:ext uri="{FF2B5EF4-FFF2-40B4-BE49-F238E27FC236}">
-                <a16:creationId xmlns:a16="http://schemas.microsoft.com/office/drawing/2014/main" id="{93425AA1-2B1D-4671-99D0-89126C0FD630}"/>
+                <a16:creationId xmlns:a16="http://schemas.microsoft.com/office/drawing/2014/main" id="{43C75485-654E-4921-BA76-ACBAB8B17686}"/>
               </a:ext>
             </a:extLst>
           </p:cNvPr>
@@ -12474,7 +12474,7 @@
           <p:cNvPr id="3" name="파일명을 주지 않으면 Agent는 어디부터 볼까?">
             <a:extLst xmlns:a="http://schemas.openxmlformats.org/drawingml/2006/main">
               <a:ext uri="{FF2B5EF4-FFF2-40B4-BE49-F238E27FC236}">
-                <a16:creationId xmlns:a16="http://schemas.microsoft.com/office/drawing/2014/main" id="{E89C87DE-7F44-4B7A-BFF0-8A2BF94733F6}"/>
+                <a16:creationId xmlns:a16="http://schemas.microsoft.com/office/drawing/2014/main" id="{9AB6660D-08AF-4F9A-A7E3-0C666C9F706D}"/>
               </a:ext>
             </a:extLst>
           </p:cNvPr>
@@ -12632,7 +12632,7 @@
           <p:cNvPr id="4" name="">
             <a:extLst xmlns:a="http://schemas.openxmlformats.org/drawingml/2006/main">
               <a:ext uri="{FF2B5EF4-FFF2-40B4-BE49-F238E27FC236}">
-                <a16:creationId xmlns:a16="http://schemas.microsoft.com/office/drawing/2014/main" id="{63BF2002-FA0F-4655-B6C4-ABDD379380C5}"/>
+                <a16:creationId xmlns:a16="http://schemas.microsoft.com/office/drawing/2014/main" id="{48408277-3ED1-4588-B6BC-985825F5AD0A}"/>
               </a:ext>
             </a:extLst>
           </p:cNvPr>
@@ -12663,7 +12663,7 @@
           <p:cNvPr id="5" name="TRIAL-001 실제 요청 발췌 · Codex CLI 0.154.0 · macOS · 읽기 전용">
             <a:extLst xmlns:a="http://schemas.openxmlformats.org/drawingml/2006/main">
               <a:ext uri="{FF2B5EF4-FFF2-40B4-BE49-F238E27FC236}">
-                <a16:creationId xmlns:a16="http://schemas.microsoft.com/office/drawing/2014/main" id="{1C8ABAD6-F002-4C43-806F-D96E636F02B6}"/>
+                <a16:creationId xmlns:a16="http://schemas.microsoft.com/office/drawing/2014/main" id="{7765DBDE-DF08-4930-8B87-5D9E045F3C67}"/>
               </a:ext>
             </a:extLst>
           </p:cNvPr>
@@ -12821,7 +12821,7 @@
           <p:cNvPr id="6" name="과거 단일 실행의 기록을 살펴봅니다. 현재 Desktop 동작은 미검증입니다.">
             <a:extLst xmlns:a="http://schemas.openxmlformats.org/drawingml/2006/main">
               <a:ext uri="{FF2B5EF4-FFF2-40B4-BE49-F238E27FC236}">
-                <a16:creationId xmlns:a16="http://schemas.microsoft.com/office/drawing/2014/main" id="{E7D748CC-038C-4EE7-9008-0C878149FEB3}"/>
+                <a16:creationId xmlns:a16="http://schemas.microsoft.com/office/drawing/2014/main" id="{1E85B68D-C84E-4C61-B32A-7998B8046285}"/>
               </a:ext>
             </a:extLst>
           </p:cNvPr>
@@ -12979,7 +12979,7 @@
           <p:cNvPr id="7" name="“현재 이 저장소에서 테스트 하나가 실패하고 있다.&#10;실패 원인을 조사해줘. 관련 구현과 호출 경로,&#10;실패하는">
             <a:extLst xmlns:a="http://schemas.openxmlformats.org/drawingml/2006/main">
               <a:ext uri="{FF2B5EF4-FFF2-40B4-BE49-F238E27FC236}">
-                <a16:creationId xmlns:a16="http://schemas.microsoft.com/office/drawing/2014/main" id="{F33304CB-EA6D-4D18-9FEF-10B2714AEE55}"/>
+                <a16:creationId xmlns:a16="http://schemas.microsoft.com/office/drawing/2014/main" id="{319D54FC-592C-4BAF-A0DC-7AB02C28A735}"/>
               </a:ext>
             </a:extLst>
           </p:cNvPr>
@@ -13206,7 +13206,7 @@
           <p:cNvPr id="8" name="">
             <a:extLst xmlns:a="http://schemas.openxmlformats.org/drawingml/2006/main">
               <a:ext uri="{FF2B5EF4-FFF2-40B4-BE49-F238E27FC236}">
-                <a16:creationId xmlns:a16="http://schemas.microsoft.com/office/drawing/2014/main" id="{3BDA4F60-1E1A-4795-916D-1A43BC8E48BE}"/>
+                <a16:creationId xmlns:a16="http://schemas.microsoft.com/office/drawing/2014/main" id="{AC2FEBAD-8ACB-46DE-91B8-1141D0CADE1B}"/>
               </a:ext>
             </a:extLst>
           </p:cNvPr>
@@ -13237,7 +13237,7 @@
           <p:cNvPr id="9" name="찾았는지 확인할 세 가지">
             <a:extLst xmlns:a="http://schemas.openxmlformats.org/drawingml/2006/main">
               <a:ext uri="{FF2B5EF4-FFF2-40B4-BE49-F238E27FC236}">
-                <a16:creationId xmlns:a16="http://schemas.microsoft.com/office/drawing/2014/main" id="{D9D3927F-54D8-44B6-A80C-0BE7384D5059}"/>
+                <a16:creationId xmlns:a16="http://schemas.microsoft.com/office/drawing/2014/main" id="{CC293402-743A-4E45-B286-308433944C37}"/>
               </a:ext>
             </a:extLst>
           </p:cNvPr>
@@ -13395,7 +13395,7 @@
           <p:cNvPr id="10" name="01  실패하는 테스트">
             <a:extLst xmlns:a="http://schemas.openxmlformats.org/drawingml/2006/main">
               <a:ext uri="{FF2B5EF4-FFF2-40B4-BE49-F238E27FC236}">
-                <a16:creationId xmlns:a16="http://schemas.microsoft.com/office/drawing/2014/main" id="{9F0FC140-FDE4-43AF-9684-75E807966FF4}"/>
+                <a16:creationId xmlns:a16="http://schemas.microsoft.com/office/drawing/2014/main" id="{7609FCA4-1EC8-4613-B371-4BE7037C8D93}"/>
               </a:ext>
             </a:extLst>
           </p:cNvPr>
@@ -13553,7 +13553,7 @@
           <p:cNvPr id="11" name="02  관련 구현">
             <a:extLst xmlns:a="http://schemas.openxmlformats.org/drawingml/2006/main">
               <a:ext uri="{FF2B5EF4-FFF2-40B4-BE49-F238E27FC236}">
-                <a16:creationId xmlns:a16="http://schemas.microsoft.com/office/drawing/2014/main" id="{285D67A6-2F13-4D13-A090-DC715DC50182}"/>
+                <a16:creationId xmlns:a16="http://schemas.microsoft.com/office/drawing/2014/main" id="{844D9765-016C-4515-8F65-D4257861ED8F}"/>
               </a:ext>
             </a:extLst>
           </p:cNvPr>
@@ -13711,7 +13711,7 @@
           <p:cNvPr id="12" name="03  제품의 호출 경로">
             <a:extLst xmlns:a="http://schemas.openxmlformats.org/drawingml/2006/main">
               <a:ext uri="{FF2B5EF4-FFF2-40B4-BE49-F238E27FC236}">
-                <a16:creationId xmlns:a16="http://schemas.microsoft.com/office/drawing/2014/main" id="{347F9352-DBDE-45F0-89EF-FA4CFCF091D5}"/>
+                <a16:creationId xmlns:a16="http://schemas.microsoft.com/office/drawing/2014/main" id="{4E7483B8-7D63-45DD-9C80-4AFBF9E53A68}"/>
               </a:ext>
             </a:extLst>
           </p:cNvPr>
@@ -13867,7 +13867,7 @@
     </p:spTree>
     <p:extLst>
       <p:ext uri="{BB962C8B-B14F-4D97-AF65-F5344CB8AC3E}">
-        <p14:creationId xmlns:p14="http://schemas.microsoft.com/office/powerpoint/2010/main" val="249993681"/>
+        <p14:creationId xmlns:p14="http://schemas.microsoft.com/office/powerpoint/2010/main" val="162951531"/>
       </p:ext>
     </p:extLst>
   </p:cSld>
@@ -13898,7 +13898,7 @@
           <p:cNvPr id="63" name="ACT 0  ·  Repository 탐색">
             <a:extLst xmlns:a="http://schemas.openxmlformats.org/drawingml/2006/main">
               <a:ext uri="{FF2B5EF4-FFF2-40B4-BE49-F238E27FC236}">
-                <a16:creationId xmlns:a16="http://schemas.microsoft.com/office/drawing/2014/main" id="{090F1E7B-AC3F-474E-AC57-6BBF7A36D465}"/>
+                <a16:creationId xmlns:a16="http://schemas.microsoft.com/office/drawing/2014/main" id="{A28C6163-8893-4324-8831-0B5B2D757019}"/>
               </a:ext>
             </a:extLst>
           </p:cNvPr>
@@ -14056,7 +14056,7 @@
           <p:cNvPr id="2" name="S05">
             <a:extLst xmlns:a="http://schemas.openxmlformats.org/drawingml/2006/main">
               <a:ext uri="{FF2B5EF4-FFF2-40B4-BE49-F238E27FC236}">
-                <a16:creationId xmlns:a16="http://schemas.microsoft.com/office/drawing/2014/main" id="{E2CFC4B5-B1EF-4E68-B7AE-C40E03220E09}"/>
+                <a16:creationId xmlns:a16="http://schemas.microsoft.com/office/drawing/2014/main" id="{85F57126-48EB-4E2F-B284-D3C4E3B3E112}"/>
               </a:ext>
             </a:extLst>
           </p:cNvPr>
@@ -14214,7 +14214,7 @@
           <p:cNvPr id="3" name="Agent가 Test와 호출 경로를 찾았다">
             <a:extLst xmlns:a="http://schemas.openxmlformats.org/drawingml/2006/main">
               <a:ext uri="{FF2B5EF4-FFF2-40B4-BE49-F238E27FC236}">
-                <a16:creationId xmlns:a16="http://schemas.microsoft.com/office/drawing/2014/main" id="{7D7864AB-A953-4429-9689-0084D5401266}"/>
+                <a16:creationId xmlns:a16="http://schemas.microsoft.com/office/drawing/2014/main" id="{CA07B924-8690-45E6-9F75-086D7833435E}"/>
               </a:ext>
             </a:extLst>
           </p:cNvPr>
@@ -14372,7 +14372,7 @@
           <p:cNvPr id="4" name="">
             <a:extLst xmlns:a="http://schemas.openxmlformats.org/drawingml/2006/main">
               <a:ext uri="{FF2B5EF4-FFF2-40B4-BE49-F238E27FC236}">
-                <a16:creationId xmlns:a16="http://schemas.microsoft.com/office/drawing/2014/main" id="{336FE0C9-A711-43A9-8CC6-359E3CE0CE72}"/>
+                <a16:creationId xmlns:a16="http://schemas.microsoft.com/office/drawing/2014/main" id="{F45E206B-4E85-4E23-87DE-BBC24C1FA338}"/>
               </a:ext>
             </a:extLst>
           </p:cNvPr>
@@ -14403,7 +14403,7 @@
           <p:cNvPr id="5" name="TRIAL-001 기록·STATE-00 테스트 재구성  |  Codex CLI 0.154.0 · 읽기 전용">
             <a:extLst xmlns:a="http://schemas.openxmlformats.org/drawingml/2006/main">
               <a:ext uri="{FF2B5EF4-FFF2-40B4-BE49-F238E27FC236}">
-                <a16:creationId xmlns:a16="http://schemas.microsoft.com/office/drawing/2014/main" id="{8EBB4BD6-7E05-45F6-9CF3-9B5718AE64A2}"/>
+                <a16:creationId xmlns:a16="http://schemas.microsoft.com/office/drawing/2014/main" id="{E64D3D26-4BC8-406A-98A8-15C73212A983}"/>
               </a:ext>
             </a:extLst>
           </p:cNvPr>
@@ -14561,7 +14561,7 @@
           <p:cNvPr id="6" name="실제 실행 화면이 아님 · 이 조사에서는 코드 수정 없음 · 현재 Desktop 동작 미검증">
             <a:extLst xmlns:a="http://schemas.openxmlformats.org/drawingml/2006/main">
               <a:ext uri="{FF2B5EF4-FFF2-40B4-BE49-F238E27FC236}">
-                <a16:creationId xmlns:a16="http://schemas.microsoft.com/office/drawing/2014/main" id="{BBC3DCE3-4C52-435E-82ED-6567189FA892}"/>
+                <a16:creationId xmlns:a16="http://schemas.microsoft.com/office/drawing/2014/main" id="{05145761-93BB-4F01-B5B9-F26BE0CA0F5B}"/>
               </a:ext>
             </a:extLst>
           </p:cNvPr>
@@ -14719,7 +14719,7 @@
           <p:cNvPr id="7" name="crop(image, 1, 3)">
             <a:extLst xmlns:a="http://schemas.openxmlformats.org/drawingml/2006/main">
               <a:ext uri="{FF2B5EF4-FFF2-40B4-BE49-F238E27FC236}">
-                <a16:creationId xmlns:a16="http://schemas.microsoft.com/office/drawing/2014/main" id="{6460E3CE-B598-443E-AFB3-5B07821FD00C}"/>
+                <a16:creationId xmlns:a16="http://schemas.microsoft.com/office/drawing/2014/main" id="{659A57B9-5AF9-4D2D-A57D-B60FFFF47483}"/>
               </a:ext>
             </a:extLst>
           </p:cNvPr>
@@ -14877,7 +14877,7 @@
           <p:cNvPr id="8" name="끝 좌표 3은 포함하지 않는 계약">
             <a:extLst xmlns:a="http://schemas.openxmlformats.org/drawingml/2006/main">
               <a:ext uri="{FF2B5EF4-FFF2-40B4-BE49-F238E27FC236}">
-                <a16:creationId xmlns:a16="http://schemas.microsoft.com/office/drawing/2014/main" id="{29A31DD0-D499-4D0D-B7BB-AB8450A1AF85}"/>
+                <a16:creationId xmlns:a16="http://schemas.microsoft.com/office/drawing/2014/main" id="{DE85840D-BFB1-449C-9B61-F6D1E9724C22}"/>
               </a:ext>
             </a:extLst>
           </p:cNvPr>
@@ -15035,7 +15035,7 @@
           <p:cNvPr id="9" name="입력">
             <a:extLst xmlns:a="http://schemas.openxmlformats.org/drawingml/2006/main">
               <a:ext uri="{FF2B5EF4-FFF2-40B4-BE49-F238E27FC236}">
-                <a16:creationId xmlns:a16="http://schemas.microsoft.com/office/drawing/2014/main" id="{656005C9-4127-40CA-BEC7-6DAF2A7A7807}"/>
+                <a16:creationId xmlns:a16="http://schemas.microsoft.com/office/drawing/2014/main" id="{93A71639-4101-4E8B-987E-2029D80F809B}"/>
               </a:ext>
             </a:extLst>
           </p:cNvPr>
@@ -15193,7 +15193,7 @@
           <p:cNvPr id="10" name="0">
             <a:extLst xmlns:a="http://schemas.openxmlformats.org/drawingml/2006/main">
               <a:ext uri="{FF2B5EF4-FFF2-40B4-BE49-F238E27FC236}">
-                <a16:creationId xmlns:a16="http://schemas.microsoft.com/office/drawing/2014/main" id="{8115D241-58CA-41A5-843B-20AF1EC8F022}"/>
+                <a16:creationId xmlns:a16="http://schemas.microsoft.com/office/drawing/2014/main" id="{B60F650D-AC26-441F-8D76-42A258EE5F89}"/>
               </a:ext>
             </a:extLst>
           </p:cNvPr>
@@ -15351,7 +15351,7 @@
           <p:cNvPr id="11" name="1">
             <a:extLst xmlns:a="http://schemas.openxmlformats.org/drawingml/2006/main">
               <a:ext uri="{FF2B5EF4-FFF2-40B4-BE49-F238E27FC236}">
-                <a16:creationId xmlns:a16="http://schemas.microsoft.com/office/drawing/2014/main" id="{83EFCE0B-F3EE-42BE-B320-15BE3F75771E}"/>
+                <a16:creationId xmlns:a16="http://schemas.microsoft.com/office/drawing/2014/main" id="{DD512365-3B82-4B97-85F9-F74966F8D60D}"/>
               </a:ext>
             </a:extLst>
           </p:cNvPr>
@@ -15509,7 +15509,7 @@
           <p:cNvPr id="12" name="2">
             <a:extLst xmlns:a="http://schemas.openxmlformats.org/drawingml/2006/main">
               <a:ext uri="{FF2B5EF4-FFF2-40B4-BE49-F238E27FC236}">
-                <a16:creationId xmlns:a16="http://schemas.microsoft.com/office/drawing/2014/main" id="{E3C82293-C0AF-43D4-B886-36D501B2C790}"/>
+                <a16:creationId xmlns:a16="http://schemas.microsoft.com/office/drawing/2014/main" id="{80A84589-66D7-4DE4-B3A7-9E2C9D973042}"/>
               </a:ext>
             </a:extLst>
           </p:cNvPr>
@@ -15667,7 +15667,7 @@
           <p:cNvPr id="13" name="3">
             <a:extLst xmlns:a="http://schemas.openxmlformats.org/drawingml/2006/main">
               <a:ext uri="{FF2B5EF4-FFF2-40B4-BE49-F238E27FC236}">
-                <a16:creationId xmlns:a16="http://schemas.microsoft.com/office/drawing/2014/main" id="{CCE1593C-8530-4113-ABB4-0B8DC21F0193}"/>
+                <a16:creationId xmlns:a16="http://schemas.microsoft.com/office/drawing/2014/main" id="{9E4F864A-FF94-453F-9DB5-B316F6E72D21}"/>
               </a:ext>
             </a:extLst>
           </p:cNvPr>
@@ -15825,7 +15825,7 @@
           <p:cNvPr id="14" name="">
             <a:extLst xmlns:a="http://schemas.openxmlformats.org/drawingml/2006/main">
               <a:ext uri="{FF2B5EF4-FFF2-40B4-BE49-F238E27FC236}">
-                <a16:creationId xmlns:a16="http://schemas.microsoft.com/office/drawing/2014/main" id="{8418689C-BE8F-4E87-A5C1-C4B08BE77565}"/>
+                <a16:creationId xmlns:a16="http://schemas.microsoft.com/office/drawing/2014/main" id="{3E3F6F4B-2BE1-46AE-A0F1-9ECA3142208D}"/>
               </a:ext>
             </a:extLst>
           </p:cNvPr>
@@ -15858,7 +15858,7 @@
           <p:cNvPr id="15" name="1">
             <a:extLst xmlns:a="http://schemas.openxmlformats.org/drawingml/2006/main">
               <a:ext uri="{FF2B5EF4-FFF2-40B4-BE49-F238E27FC236}">
-                <a16:creationId xmlns:a16="http://schemas.microsoft.com/office/drawing/2014/main" id="{C5E30B15-C5C6-4597-AB39-1D48E5455880}"/>
+                <a16:creationId xmlns:a16="http://schemas.microsoft.com/office/drawing/2014/main" id="{827587CE-20BB-4F4F-9012-A1F1F59000B5}"/>
               </a:ext>
             </a:extLst>
           </p:cNvPr>
@@ -16016,7 +16016,7 @@
           <p:cNvPr id="16" name="">
             <a:extLst xmlns:a="http://schemas.openxmlformats.org/drawingml/2006/main">
               <a:ext uri="{FF2B5EF4-FFF2-40B4-BE49-F238E27FC236}">
-                <a16:creationId xmlns:a16="http://schemas.microsoft.com/office/drawing/2014/main" id="{1FBAE4A4-D62E-4FBC-A250-CAA09D21E763}"/>
+                <a16:creationId xmlns:a16="http://schemas.microsoft.com/office/drawing/2014/main" id="{CDC07D59-129A-4499-982A-BE7D849620A1}"/>
               </a:ext>
             </a:extLst>
           </p:cNvPr>
@@ -16049,7 +16049,7 @@
           <p:cNvPr id="17" name="2">
             <a:extLst xmlns:a="http://schemas.openxmlformats.org/drawingml/2006/main">
               <a:ext uri="{FF2B5EF4-FFF2-40B4-BE49-F238E27FC236}">
-                <a16:creationId xmlns:a16="http://schemas.microsoft.com/office/drawing/2014/main" id="{1D788CAB-352A-4FAA-B7E5-80C21011EA3A}"/>
+                <a16:creationId xmlns:a16="http://schemas.microsoft.com/office/drawing/2014/main" id="{66D7AE24-2436-45B9-9D12-2245567E1D24}"/>
               </a:ext>
             </a:extLst>
           </p:cNvPr>
@@ -16207,7 +16207,7 @@
           <p:cNvPr id="18" name="">
             <a:extLst xmlns:a="http://schemas.openxmlformats.org/drawingml/2006/main">
               <a:ext uri="{FF2B5EF4-FFF2-40B4-BE49-F238E27FC236}">
-                <a16:creationId xmlns:a16="http://schemas.microsoft.com/office/drawing/2014/main" id="{F9080762-9141-4081-A626-61853B1A6A3C}"/>
+                <a16:creationId xmlns:a16="http://schemas.microsoft.com/office/drawing/2014/main" id="{8E6148B2-4256-4DC6-9CB4-99D972029635}"/>
               </a:ext>
             </a:extLst>
           </p:cNvPr>
@@ -16240,7 +16240,7 @@
           <p:cNvPr id="19" name="3">
             <a:extLst xmlns:a="http://schemas.openxmlformats.org/drawingml/2006/main">
               <a:ext uri="{FF2B5EF4-FFF2-40B4-BE49-F238E27FC236}">
-                <a16:creationId xmlns:a16="http://schemas.microsoft.com/office/drawing/2014/main" id="{1A42FC53-5F54-414F-9827-82C7D7159170}"/>
+                <a16:creationId xmlns:a16="http://schemas.microsoft.com/office/drawing/2014/main" id="{FDE9B079-5CFE-4C29-BA1D-0646D8421EF4}"/>
               </a:ext>
             </a:extLst>
           </p:cNvPr>
@@ -16398,7 +16398,7 @@
           <p:cNvPr id="20" name="">
             <a:extLst xmlns:a="http://schemas.openxmlformats.org/drawingml/2006/main">
               <a:ext uri="{FF2B5EF4-FFF2-40B4-BE49-F238E27FC236}">
-                <a16:creationId xmlns:a16="http://schemas.microsoft.com/office/drawing/2014/main" id="{7C82B4DF-4B13-4F7D-B414-5BF549794C9B}"/>
+                <a16:creationId xmlns:a16="http://schemas.microsoft.com/office/drawing/2014/main" id="{22E0DF92-D139-4F38-9DA3-BA574566E234}"/>
               </a:ext>
             </a:extLst>
           </p:cNvPr>
@@ -16431,7 +16431,7 @@
           <p:cNvPr id="21" name="4">
             <a:extLst xmlns:a="http://schemas.openxmlformats.org/drawingml/2006/main">
               <a:ext uri="{FF2B5EF4-FFF2-40B4-BE49-F238E27FC236}">
-                <a16:creationId xmlns:a16="http://schemas.microsoft.com/office/drawing/2014/main" id="{C1B0E5F4-EB34-44F4-B787-34187B62622D}"/>
+                <a16:creationId xmlns:a16="http://schemas.microsoft.com/office/drawing/2014/main" id="{686EEB9E-18D0-45EA-B084-E4D3BF919976}"/>
               </a:ext>
             </a:extLst>
           </p:cNvPr>
@@ -16589,7 +16589,7 @@
           <p:cNvPr id="22" name="">
             <a:extLst xmlns:a="http://schemas.openxmlformats.org/drawingml/2006/main">
               <a:ext uri="{FF2B5EF4-FFF2-40B4-BE49-F238E27FC236}">
-                <a16:creationId xmlns:a16="http://schemas.microsoft.com/office/drawing/2014/main" id="{CEC51832-DE41-4838-AB12-6FCB7C1778A4}"/>
+                <a16:creationId xmlns:a16="http://schemas.microsoft.com/office/drawing/2014/main" id="{B889F4D2-7BB5-493B-BEAC-305A1E8D3F10}"/>
               </a:ext>
             </a:extLst>
           </p:cNvPr>
@@ -16622,7 +16622,7 @@
           <p:cNvPr id="23" name="5">
             <a:extLst xmlns:a="http://schemas.openxmlformats.org/drawingml/2006/main">
               <a:ext uri="{FF2B5EF4-FFF2-40B4-BE49-F238E27FC236}">
-                <a16:creationId xmlns:a16="http://schemas.microsoft.com/office/drawing/2014/main" id="{A42E62B6-603C-4DB0-8B6B-550ED1C8F522}"/>
+                <a16:creationId xmlns:a16="http://schemas.microsoft.com/office/drawing/2014/main" id="{1F7801C6-BE9E-4325-B00E-FC6D162FFC15}"/>
               </a:ext>
             </a:extLst>
           </p:cNvPr>
@@ -16780,7 +16780,7 @@
           <p:cNvPr id="24" name="">
             <a:extLst xmlns:a="http://schemas.openxmlformats.org/drawingml/2006/main">
               <a:ext uri="{FF2B5EF4-FFF2-40B4-BE49-F238E27FC236}">
-                <a16:creationId xmlns:a16="http://schemas.microsoft.com/office/drawing/2014/main" id="{3EB64767-877B-4A19-968F-2090724BE4AC}"/>
+                <a16:creationId xmlns:a16="http://schemas.microsoft.com/office/drawing/2014/main" id="{7BFF0FDE-F58A-450F-9F2B-3086F96DDF53}"/>
               </a:ext>
             </a:extLst>
           </p:cNvPr>
@@ -16813,7 +16813,7 @@
           <p:cNvPr id="25" name="6">
             <a:extLst xmlns:a="http://schemas.openxmlformats.org/drawingml/2006/main">
               <a:ext uri="{FF2B5EF4-FFF2-40B4-BE49-F238E27FC236}">
-                <a16:creationId xmlns:a16="http://schemas.microsoft.com/office/drawing/2014/main" id="{F38596DA-F253-42C1-8185-91605B1FE62E}"/>
+                <a16:creationId xmlns:a16="http://schemas.microsoft.com/office/drawing/2014/main" id="{7F9B01B9-FCBB-487C-9B89-D3B7FDBB5A8B}"/>
               </a:ext>
             </a:extLst>
           </p:cNvPr>
@@ -16971,7 +16971,7 @@
           <p:cNvPr id="26" name="">
             <a:extLst xmlns:a="http://schemas.openxmlformats.org/drawingml/2006/main">
               <a:ext uri="{FF2B5EF4-FFF2-40B4-BE49-F238E27FC236}">
-                <a16:creationId xmlns:a16="http://schemas.microsoft.com/office/drawing/2014/main" id="{1F9655AD-D56F-4D51-BC4B-288BA1A76547}"/>
+                <a16:creationId xmlns:a16="http://schemas.microsoft.com/office/drawing/2014/main" id="{235944E3-CCA0-43FB-A331-524D624B7BA6}"/>
               </a:ext>
             </a:extLst>
           </p:cNvPr>
@@ -17004,7 +17004,7 @@
           <p:cNvPr id="27" name="7">
             <a:extLst xmlns:a="http://schemas.openxmlformats.org/drawingml/2006/main">
               <a:ext uri="{FF2B5EF4-FFF2-40B4-BE49-F238E27FC236}">
-                <a16:creationId xmlns:a16="http://schemas.microsoft.com/office/drawing/2014/main" id="{E0524178-0849-4876-9FE5-DAE2FC5FFA48}"/>
+                <a16:creationId xmlns:a16="http://schemas.microsoft.com/office/drawing/2014/main" id="{2B96941B-E676-4425-9EA4-3AE822E85741}"/>
               </a:ext>
             </a:extLst>
           </p:cNvPr>
@@ -17162,7 +17162,7 @@
           <p:cNvPr id="28" name="">
             <a:extLst xmlns:a="http://schemas.openxmlformats.org/drawingml/2006/main">
               <a:ext uri="{FF2B5EF4-FFF2-40B4-BE49-F238E27FC236}">
-                <a16:creationId xmlns:a16="http://schemas.microsoft.com/office/drawing/2014/main" id="{C5840843-6F69-4702-96DF-924F272D7918}"/>
+                <a16:creationId xmlns:a16="http://schemas.microsoft.com/office/drawing/2014/main" id="{C4F25686-B100-4C62-AA9E-1D73D544CA38}"/>
               </a:ext>
             </a:extLst>
           </p:cNvPr>
@@ -17195,7 +17195,7 @@
           <p:cNvPr id="29" name="8">
             <a:extLst xmlns:a="http://schemas.openxmlformats.org/drawingml/2006/main">
               <a:ext uri="{FF2B5EF4-FFF2-40B4-BE49-F238E27FC236}">
-                <a16:creationId xmlns:a16="http://schemas.microsoft.com/office/drawing/2014/main" id="{0F56AFBA-11A2-4D18-B114-57F257FC0B0A}"/>
+                <a16:creationId xmlns:a16="http://schemas.microsoft.com/office/drawing/2014/main" id="{E60E7160-4AEE-4B20-B782-A7629DD9133B}"/>
               </a:ext>
             </a:extLst>
           </p:cNvPr>
@@ -17353,7 +17353,7 @@
           <p:cNvPr id="30" name="열 index">
             <a:extLst xmlns:a="http://schemas.openxmlformats.org/drawingml/2006/main">
               <a:ext uri="{FF2B5EF4-FFF2-40B4-BE49-F238E27FC236}">
-                <a16:creationId xmlns:a16="http://schemas.microsoft.com/office/drawing/2014/main" id="{A4ECD5E3-1C72-420D-9BD3-869353E5B3E7}"/>
+                <a16:creationId xmlns:a16="http://schemas.microsoft.com/office/drawing/2014/main" id="{69F28F92-74DD-4F09-A20F-E65AEC112048}"/>
               </a:ext>
             </a:extLst>
           </p:cNvPr>
@@ -17511,7 +17511,7 @@
           <p:cNvPr id="31" name="기대">
             <a:extLst xmlns:a="http://schemas.openxmlformats.org/drawingml/2006/main">
               <a:ext uri="{FF2B5EF4-FFF2-40B4-BE49-F238E27FC236}">
-                <a16:creationId xmlns:a16="http://schemas.microsoft.com/office/drawing/2014/main" id="{462D7073-485C-4A26-950B-D66C0F8AC2D2}"/>
+                <a16:creationId xmlns:a16="http://schemas.microsoft.com/office/drawing/2014/main" id="{CDEBF285-2E54-44EA-AC93-BE5C112E52C2}"/>
               </a:ext>
             </a:extLst>
           </p:cNvPr>
@@ -17669,7 +17669,7 @@
           <p:cNvPr id="32" name="">
             <a:extLst xmlns:a="http://schemas.openxmlformats.org/drawingml/2006/main">
               <a:ext uri="{FF2B5EF4-FFF2-40B4-BE49-F238E27FC236}">
-                <a16:creationId xmlns:a16="http://schemas.microsoft.com/office/drawing/2014/main" id="{A7B0616E-A5E2-41E4-AFDD-35888CF4878A}"/>
+                <a16:creationId xmlns:a16="http://schemas.microsoft.com/office/drawing/2014/main" id="{DB158E8E-2E7D-4458-B369-E52BDC12FD3B}"/>
               </a:ext>
             </a:extLst>
           </p:cNvPr>
@@ -17702,7 +17702,7 @@
           <p:cNvPr id="33" name="2">
             <a:extLst xmlns:a="http://schemas.openxmlformats.org/drawingml/2006/main">
               <a:ext uri="{FF2B5EF4-FFF2-40B4-BE49-F238E27FC236}">
-                <a16:creationId xmlns:a16="http://schemas.microsoft.com/office/drawing/2014/main" id="{2313EDFB-7A10-48E0-A37F-9ACCFD8A01EC}"/>
+                <a16:creationId xmlns:a16="http://schemas.microsoft.com/office/drawing/2014/main" id="{FC238C07-99FE-466E-81BA-7F8A5692FA65}"/>
               </a:ext>
             </a:extLst>
           </p:cNvPr>
@@ -17860,7 +17860,7 @@
           <p:cNvPr id="34" name="">
             <a:extLst xmlns:a="http://schemas.openxmlformats.org/drawingml/2006/main">
               <a:ext uri="{FF2B5EF4-FFF2-40B4-BE49-F238E27FC236}">
-                <a16:creationId xmlns:a16="http://schemas.microsoft.com/office/drawing/2014/main" id="{A5002CE8-B117-42A9-9A9F-FA7407D5947A}"/>
+                <a16:creationId xmlns:a16="http://schemas.microsoft.com/office/drawing/2014/main" id="{5FC52A6C-1645-4F13-BB66-097B691055A9}"/>
               </a:ext>
             </a:extLst>
           </p:cNvPr>
@@ -17893,7 +17893,7 @@
           <p:cNvPr id="35" name="3">
             <a:extLst xmlns:a="http://schemas.openxmlformats.org/drawingml/2006/main">
               <a:ext uri="{FF2B5EF4-FFF2-40B4-BE49-F238E27FC236}">
-                <a16:creationId xmlns:a16="http://schemas.microsoft.com/office/drawing/2014/main" id="{15BE8618-4BD6-4F13-BB8F-17ABB8D7E3D7}"/>
+                <a16:creationId xmlns:a16="http://schemas.microsoft.com/office/drawing/2014/main" id="{1C31D1A1-8856-4381-AE62-E587AAF9D186}"/>
               </a:ext>
             </a:extLst>
           </p:cNvPr>
@@ -18051,7 +18051,7 @@
           <p:cNvPr id="36" name="">
             <a:extLst xmlns:a="http://schemas.openxmlformats.org/drawingml/2006/main">
               <a:ext uri="{FF2B5EF4-FFF2-40B4-BE49-F238E27FC236}">
-                <a16:creationId xmlns:a16="http://schemas.microsoft.com/office/drawing/2014/main" id="{2B9841AC-CF75-4D2F-85F1-A4FBADDE6212}"/>
+                <a16:creationId xmlns:a16="http://schemas.microsoft.com/office/drawing/2014/main" id="{30ACC7B0-EC87-4F5C-8097-C02B69197A8D}"/>
               </a:ext>
             </a:extLst>
           </p:cNvPr>
@@ -18084,7 +18084,7 @@
           <p:cNvPr id="37" name="6">
             <a:extLst xmlns:a="http://schemas.openxmlformats.org/drawingml/2006/main">
               <a:ext uri="{FF2B5EF4-FFF2-40B4-BE49-F238E27FC236}">
-                <a16:creationId xmlns:a16="http://schemas.microsoft.com/office/drawing/2014/main" id="{3D2DAF53-9205-4B3F-A9BC-4B78BFB210E7}"/>
+                <a16:creationId xmlns:a16="http://schemas.microsoft.com/office/drawing/2014/main" id="{F794AC6F-8310-47F8-9D32-7B3000DE61C5}"/>
               </a:ext>
             </a:extLst>
           </p:cNvPr>
@@ -18242,7 +18242,7 @@
           <p:cNvPr id="38" name="">
             <a:extLst xmlns:a="http://schemas.openxmlformats.org/drawingml/2006/main">
               <a:ext uri="{FF2B5EF4-FFF2-40B4-BE49-F238E27FC236}">
-                <a16:creationId xmlns:a16="http://schemas.microsoft.com/office/drawing/2014/main" id="{5E19EB09-CC62-497B-A00B-717345CECC52}"/>
+                <a16:creationId xmlns:a16="http://schemas.microsoft.com/office/drawing/2014/main" id="{4208037F-3133-461C-9080-41085FF9E9B1}"/>
               </a:ext>
             </a:extLst>
           </p:cNvPr>
@@ -18275,7 +18275,7 @@
           <p:cNvPr id="39" name="7">
             <a:extLst xmlns:a="http://schemas.openxmlformats.org/drawingml/2006/main">
               <a:ext uri="{FF2B5EF4-FFF2-40B4-BE49-F238E27FC236}">
-                <a16:creationId xmlns:a16="http://schemas.microsoft.com/office/drawing/2014/main" id="{7E11F8BA-4543-4E48-99D8-CE07B83FB98A}"/>
+                <a16:creationId xmlns:a16="http://schemas.microsoft.com/office/drawing/2014/main" id="{5BE96E4B-614C-436F-94E3-9DC48182C7C2}"/>
               </a:ext>
             </a:extLst>
           </p:cNvPr>
@@ -18433,7 +18433,7 @@
           <p:cNvPr id="40" name="구현 결과">
             <a:extLst xmlns:a="http://schemas.openxmlformats.org/drawingml/2006/main">
               <a:ext uri="{FF2B5EF4-FFF2-40B4-BE49-F238E27FC236}">
-                <a16:creationId xmlns:a16="http://schemas.microsoft.com/office/drawing/2014/main" id="{65E48E6F-00D7-4539-B0AC-FC891F66B808}"/>
+                <a16:creationId xmlns:a16="http://schemas.microsoft.com/office/drawing/2014/main" id="{D9231841-2614-4433-A9DF-0CF3BEB1026F}"/>
               </a:ext>
             </a:extLst>
           </p:cNvPr>
@@ -18591,7 +18591,7 @@
           <p:cNvPr id="41" name="">
             <a:extLst xmlns:a="http://schemas.openxmlformats.org/drawingml/2006/main">
               <a:ext uri="{FF2B5EF4-FFF2-40B4-BE49-F238E27FC236}">
-                <a16:creationId xmlns:a16="http://schemas.microsoft.com/office/drawing/2014/main" id="{094BD095-598D-4840-8C8F-BCC2D81893FC}"/>
+                <a16:creationId xmlns:a16="http://schemas.microsoft.com/office/drawing/2014/main" id="{E306A718-A7C2-4EDF-B06C-CD074E0470BB}"/>
               </a:ext>
             </a:extLst>
           </p:cNvPr>
@@ -18624,7 +18624,7 @@
           <p:cNvPr id="42" name="2">
             <a:extLst xmlns:a="http://schemas.openxmlformats.org/drawingml/2006/main">
               <a:ext uri="{FF2B5EF4-FFF2-40B4-BE49-F238E27FC236}">
-                <a16:creationId xmlns:a16="http://schemas.microsoft.com/office/drawing/2014/main" id="{6588BB52-AA11-4BA3-AC73-632961FAC18B}"/>
+                <a16:creationId xmlns:a16="http://schemas.microsoft.com/office/drawing/2014/main" id="{2CE5BF02-07B2-42AC-97E7-A5AF32232CDA}"/>
               </a:ext>
             </a:extLst>
           </p:cNvPr>
@@ -18782,7 +18782,7 @@
           <p:cNvPr id="43" name="">
             <a:extLst xmlns:a="http://schemas.openxmlformats.org/drawingml/2006/main">
               <a:ext uri="{FF2B5EF4-FFF2-40B4-BE49-F238E27FC236}">
-                <a16:creationId xmlns:a16="http://schemas.microsoft.com/office/drawing/2014/main" id="{063FA254-AA32-4B1B-B349-3A53659A9832}"/>
+                <a16:creationId xmlns:a16="http://schemas.microsoft.com/office/drawing/2014/main" id="{E82A4C9D-73F6-4A3F-90A0-8C19CEC8CCC4}"/>
               </a:ext>
             </a:extLst>
           </p:cNvPr>
@@ -18815,7 +18815,7 @@
           <p:cNvPr id="44" name="3">
             <a:extLst xmlns:a="http://schemas.openxmlformats.org/drawingml/2006/main">
               <a:ext uri="{FF2B5EF4-FFF2-40B4-BE49-F238E27FC236}">
-                <a16:creationId xmlns:a16="http://schemas.microsoft.com/office/drawing/2014/main" id="{E93124AD-E5B9-418A-A611-E4B0952E0470}"/>
+                <a16:creationId xmlns:a16="http://schemas.microsoft.com/office/drawing/2014/main" id="{564FCE95-307B-42B5-8693-640A52AEAE47}"/>
               </a:ext>
             </a:extLst>
           </p:cNvPr>
@@ -18973,7 +18973,7 @@
           <p:cNvPr id="45" name="">
             <a:extLst xmlns:a="http://schemas.openxmlformats.org/drawingml/2006/main">
               <a:ext uri="{FF2B5EF4-FFF2-40B4-BE49-F238E27FC236}">
-                <a16:creationId xmlns:a16="http://schemas.microsoft.com/office/drawing/2014/main" id="{97DFC535-4D87-4FD4-ADEC-E4457429C3D5}"/>
+                <a16:creationId xmlns:a16="http://schemas.microsoft.com/office/drawing/2014/main" id="{46184D81-0F4A-4296-B43E-A707EC233021}"/>
               </a:ext>
             </a:extLst>
           </p:cNvPr>
@@ -19006,7 +19006,7 @@
           <p:cNvPr id="46" name="4">
             <a:extLst xmlns:a="http://schemas.openxmlformats.org/drawingml/2006/main">
               <a:ext uri="{FF2B5EF4-FFF2-40B4-BE49-F238E27FC236}">
-                <a16:creationId xmlns:a16="http://schemas.microsoft.com/office/drawing/2014/main" id="{36F245BC-876B-4537-9BCE-AF9DA6D1D955}"/>
+                <a16:creationId xmlns:a16="http://schemas.microsoft.com/office/drawing/2014/main" id="{6F14C018-821A-4724-A845-0C4EA807B13F}"/>
               </a:ext>
             </a:extLst>
           </p:cNvPr>
@@ -19164,7 +19164,7 @@
           <p:cNvPr id="47" name="">
             <a:extLst xmlns:a="http://schemas.openxmlformats.org/drawingml/2006/main">
               <a:ext uri="{FF2B5EF4-FFF2-40B4-BE49-F238E27FC236}">
-                <a16:creationId xmlns:a16="http://schemas.microsoft.com/office/drawing/2014/main" id="{44215016-85A3-41B0-8955-42AEEECBEE49}"/>
+                <a16:creationId xmlns:a16="http://schemas.microsoft.com/office/drawing/2014/main" id="{0E45D62F-91A7-4EA0-A4E5-794D99960D84}"/>
               </a:ext>
             </a:extLst>
           </p:cNvPr>
@@ -19197,7 +19197,7 @@
           <p:cNvPr id="48" name="6">
             <a:extLst xmlns:a="http://schemas.openxmlformats.org/drawingml/2006/main">
               <a:ext uri="{FF2B5EF4-FFF2-40B4-BE49-F238E27FC236}">
-                <a16:creationId xmlns:a16="http://schemas.microsoft.com/office/drawing/2014/main" id="{C40DC2BB-466B-4DCE-8E34-7B1E56C0437C}"/>
+                <a16:creationId xmlns:a16="http://schemas.microsoft.com/office/drawing/2014/main" id="{C3340BCB-8DFF-4959-AE65-76EAA16F8D54}"/>
               </a:ext>
             </a:extLst>
           </p:cNvPr>
@@ -19355,7 +19355,7 @@
           <p:cNvPr id="49" name="">
             <a:extLst xmlns:a="http://schemas.openxmlformats.org/drawingml/2006/main">
               <a:ext uri="{FF2B5EF4-FFF2-40B4-BE49-F238E27FC236}">
-                <a16:creationId xmlns:a16="http://schemas.microsoft.com/office/drawing/2014/main" id="{5D22134E-A5DB-476A-9533-85C50F6412E5}"/>
+                <a16:creationId xmlns:a16="http://schemas.microsoft.com/office/drawing/2014/main" id="{DFB1C48E-5571-4F48-B6BB-EBAC555FB004}"/>
               </a:ext>
             </a:extLst>
           </p:cNvPr>
@@ -19388,7 +19388,7 @@
           <p:cNvPr id="50" name="7">
             <a:extLst xmlns:a="http://schemas.openxmlformats.org/drawingml/2006/main">
               <a:ext uri="{FF2B5EF4-FFF2-40B4-BE49-F238E27FC236}">
-                <a16:creationId xmlns:a16="http://schemas.microsoft.com/office/drawing/2014/main" id="{BC1BE0B9-F544-4424-84FC-F28EF2020BB9}"/>
+                <a16:creationId xmlns:a16="http://schemas.microsoft.com/office/drawing/2014/main" id="{8A561DD1-C76C-4E46-88FF-BB69076ECA85}"/>
               </a:ext>
             </a:extLst>
           </p:cNvPr>
@@ -19546,7 +19546,7 @@
           <p:cNvPr id="51" name="">
             <a:extLst xmlns:a="http://schemas.openxmlformats.org/drawingml/2006/main">
               <a:ext uri="{FF2B5EF4-FFF2-40B4-BE49-F238E27FC236}">
-                <a16:creationId xmlns:a16="http://schemas.microsoft.com/office/drawing/2014/main" id="{B3E59BC5-6E48-4B48-B28C-710764BC7C12}"/>
+                <a16:creationId xmlns:a16="http://schemas.microsoft.com/office/drawing/2014/main" id="{CA9A1938-32D2-49EF-8D7C-21DA2537A9F7}"/>
               </a:ext>
             </a:extLst>
           </p:cNvPr>
@@ -19579,7 +19579,7 @@
           <p:cNvPr id="52" name="8">
             <a:extLst xmlns:a="http://schemas.openxmlformats.org/drawingml/2006/main">
               <a:ext uri="{FF2B5EF4-FFF2-40B4-BE49-F238E27FC236}">
-                <a16:creationId xmlns:a16="http://schemas.microsoft.com/office/drawing/2014/main" id="{1B62E5B8-0B47-47FE-9438-F8FD208D288A}"/>
+                <a16:creationId xmlns:a16="http://schemas.microsoft.com/office/drawing/2014/main" id="{46A2B3E1-986F-459C-9885-CE65D267262E}"/>
               </a:ext>
             </a:extLst>
           </p:cNvPr>
@@ -19737,7 +19737,7 @@
           <p:cNvPr id="53" name="한 열이 더 포함됨">
             <a:extLst xmlns:a="http://schemas.openxmlformats.org/drawingml/2006/main">
               <a:ext uri="{FF2B5EF4-FFF2-40B4-BE49-F238E27FC236}">
-                <a16:creationId xmlns:a16="http://schemas.microsoft.com/office/drawing/2014/main" id="{3ED942C9-F930-4532-A542-FF74116B3A9C}"/>
+                <a16:creationId xmlns:a16="http://schemas.microsoft.com/office/drawing/2014/main" id="{043C1B4B-E6D4-4198-B261-9462EDC4277F}"/>
               </a:ext>
             </a:extLst>
           </p:cNvPr>
@@ -19895,7 +19895,7 @@
           <p:cNvPr id="54" name="">
             <a:extLst xmlns:a="http://schemas.openxmlformats.org/drawingml/2006/main">
               <a:ext uri="{FF2B5EF4-FFF2-40B4-BE49-F238E27FC236}">
-                <a16:creationId xmlns:a16="http://schemas.microsoft.com/office/drawing/2014/main" id="{6996C952-64D7-4B6B-834D-4E7BF00082B6}"/>
+                <a16:creationId xmlns:a16="http://schemas.microsoft.com/office/drawing/2014/main" id="{4E0BB297-85BD-4347-9F00-0BEFA21C8673}"/>
               </a:ext>
             </a:extLst>
           </p:cNvPr>
@@ -19926,7 +19926,7 @@
           <p:cNvPr id="55" name="조사에서 연결한 근거">
             <a:extLst xmlns:a="http://schemas.openxmlformats.org/drawingml/2006/main">
               <a:ext uri="{FF2B5EF4-FFF2-40B4-BE49-F238E27FC236}">
-                <a16:creationId xmlns:a16="http://schemas.microsoft.com/office/drawing/2014/main" id="{92FA8907-ED0F-4B84-8292-FC949057D154}"/>
+                <a16:creationId xmlns:a16="http://schemas.microsoft.com/office/drawing/2014/main" id="{C4154AE2-4B1B-4BC4-9129-3249F96C8B6D}"/>
               </a:ext>
             </a:extLst>
           </p:cNvPr>
@@ -20084,7 +20084,7 @@
           <p:cNvPr id="56" name="01  실패 테스트">
             <a:extLst xmlns:a="http://schemas.openxmlformats.org/drawingml/2006/main">
               <a:ext uri="{FF2B5EF4-FFF2-40B4-BE49-F238E27FC236}">
-                <a16:creationId xmlns:a16="http://schemas.microsoft.com/office/drawing/2014/main" id="{CEB216B4-1C24-4FA0-9789-667398868AA0}"/>
+                <a16:creationId xmlns:a16="http://schemas.microsoft.com/office/drawing/2014/main" id="{C4218ED4-8EF8-45AE-BE2F-A43CC7FA00EF}"/>
               </a:ext>
             </a:extLst>
           </p:cNvPr>
@@ -20242,7 +20242,7 @@
           <p:cNvPr id="57" name="test_crop_excludes_&#10;end_coordinate">
             <a:extLst xmlns:a="http://schemas.openxmlformats.org/drawingml/2006/main">
               <a:ext uri="{FF2B5EF4-FFF2-40B4-BE49-F238E27FC236}">
-                <a16:creationId xmlns:a16="http://schemas.microsoft.com/office/drawing/2014/main" id="{18FBE978-B234-422F-8756-C7EC1B873239}"/>
+                <a16:creationId xmlns:a16="http://schemas.microsoft.com/office/drawing/2014/main" id="{98F8FCF7-5D68-4DB1-A0CD-198DFA2AAFAF}"/>
               </a:ext>
             </a:extLst>
           </p:cNvPr>
@@ -20423,7 +20423,7 @@
           <p:cNvPr id="58" name="02  제품의 호출 경로">
             <a:extLst xmlns:a="http://schemas.openxmlformats.org/drawingml/2006/main">
               <a:ext uri="{FF2B5EF4-FFF2-40B4-BE49-F238E27FC236}">
-                <a16:creationId xmlns:a16="http://schemas.microsoft.com/office/drawing/2014/main" id="{A70E908C-8B80-41A3-B765-B817350F416A}"/>
+                <a16:creationId xmlns:a16="http://schemas.microsoft.com/office/drawing/2014/main" id="{8DF47607-2DC5-43B7-A97C-111ACB523496}"/>
               </a:ext>
             </a:extLst>
           </p:cNvPr>
@@ -20581,7 +20581,7 @@
           <p:cNvPr id="59" name="cli.main → process_image → crop">
             <a:extLst xmlns:a="http://schemas.openxmlformats.org/drawingml/2006/main">
               <a:ext uri="{FF2B5EF4-FFF2-40B4-BE49-F238E27FC236}">
-                <a16:creationId xmlns:a16="http://schemas.microsoft.com/office/drawing/2014/main" id="{A9549513-8CD6-41A0-A952-6E0B9F45DB8B}"/>
+                <a16:creationId xmlns:a16="http://schemas.microsoft.com/office/drawing/2014/main" id="{144A5F19-B05D-45F9-BD78-AB2C444A28E7}"/>
               </a:ext>
             </a:extLst>
           </p:cNvPr>
@@ -20739,7 +20739,7 @@
           <p:cNvPr id="60" name="03  계약과 다른 구현">
             <a:extLst xmlns:a="http://schemas.openxmlformats.org/drawingml/2006/main">
               <a:ext uri="{FF2B5EF4-FFF2-40B4-BE49-F238E27FC236}">
-                <a16:creationId xmlns:a16="http://schemas.microsoft.com/office/drawing/2014/main" id="{A2EC5EEE-86DB-42CF-9B34-10A1DA2750DF}"/>
+                <a16:creationId xmlns:a16="http://schemas.microsoft.com/office/drawing/2014/main" id="{A556D3A0-62CB-4BFB-B4AA-9AE86C33B8BA}"/>
               </a:ext>
             </a:extLst>
           </p:cNvPr>
@@ -20897,7 +20897,7 @@
           <p:cNvPr id="61" name="row[x_start : x_end + 1]">
             <a:extLst xmlns:a="http://schemas.openxmlformats.org/drawingml/2006/main">
               <a:ext uri="{FF2B5EF4-FFF2-40B4-BE49-F238E27FC236}">
-                <a16:creationId xmlns:a16="http://schemas.microsoft.com/office/drawing/2014/main" id="{6340E590-298C-4B57-A1D2-F8F3D16E7123}"/>
+                <a16:creationId xmlns:a16="http://schemas.microsoft.com/office/drawing/2014/main" id="{44372683-9E34-4CD6-9D8A-0C5226675748}"/>
               </a:ext>
             </a:extLst>
           </p:cNvPr>
@@ -21055,7 +21055,7 @@
           <p:cNvPr id="62" name="계약: [x_start, x_end)">
             <a:extLst xmlns:a="http://schemas.openxmlformats.org/drawingml/2006/main">
               <a:ext uri="{FF2B5EF4-FFF2-40B4-BE49-F238E27FC236}">
-                <a16:creationId xmlns:a16="http://schemas.microsoft.com/office/drawing/2014/main" id="{856CED10-E19A-4E82-B03F-C0F295370BF0}"/>
+                <a16:creationId xmlns:a16="http://schemas.microsoft.com/office/drawing/2014/main" id="{4332D0A5-E17D-46C3-9127-60E1326F9744}"/>
               </a:ext>
             </a:extLst>
           </p:cNvPr>
@@ -21211,7 +21211,7 @@
     </p:spTree>
     <p:extLst>
       <p:ext uri="{BB962C8B-B14F-4D97-AF65-F5344CB8AC3E}">
-        <p14:creationId xmlns:p14="http://schemas.microsoft.com/office/powerpoint/2010/main" val="365614759"/>
+        <p14:creationId xmlns:p14="http://schemas.microsoft.com/office/powerpoint/2010/main" val="1753789983"/>
       </p:ext>
     </p:extLst>
   </p:cSld>
@@ -21242,7 +21242,7 @@
           <p:cNvPr id="17" name="ACT 0 · 조사 결과 읽기">
             <a:extLst xmlns:a="http://schemas.openxmlformats.org/drawingml/2006/main">
               <a:ext uri="{FF2B5EF4-FFF2-40B4-BE49-F238E27FC236}">
-                <a16:creationId xmlns:a16="http://schemas.microsoft.com/office/drawing/2014/main" id="{061204E5-7505-4BAA-BE70-5A72058C10F3}"/>
+                <a16:creationId xmlns:a16="http://schemas.microsoft.com/office/drawing/2014/main" id="{3B864686-9B8F-4513-BD93-DE82A8E99978}"/>
               </a:ext>
             </a:extLst>
           </p:cNvPr>
@@ -21400,7 +21400,7 @@
           <p:cNvPr id="2" name="S06">
             <a:extLst xmlns:a="http://schemas.openxmlformats.org/drawingml/2006/main">
               <a:ext uri="{FF2B5EF4-FFF2-40B4-BE49-F238E27FC236}">
-                <a16:creationId xmlns:a16="http://schemas.microsoft.com/office/drawing/2014/main" id="{7C505121-B7E4-4F75-AB78-4869F663CA37}"/>
+                <a16:creationId xmlns:a16="http://schemas.microsoft.com/office/drawing/2014/main" id="{C44E7110-ADDB-432C-B5AB-8E44065F2668}"/>
               </a:ext>
             </a:extLst>
           </p:cNvPr>
@@ -21558,7 +21558,7 @@
           <p:cNvPr id="3" name="관찰 결과와 실행 제한을 분리한다">
             <a:extLst xmlns:a="http://schemas.openxmlformats.org/drawingml/2006/main">
               <a:ext uri="{FF2B5EF4-FFF2-40B4-BE49-F238E27FC236}">
-                <a16:creationId xmlns:a16="http://schemas.microsoft.com/office/drawing/2014/main" id="{E5AE4D75-9C63-43D9-903B-80D781B0A840}"/>
+                <a16:creationId xmlns:a16="http://schemas.microsoft.com/office/drawing/2014/main" id="{5755E4BE-05E2-46AD-845E-4346C9C497F6}"/>
               </a:ext>
             </a:extLst>
           </p:cNvPr>
@@ -21716,7 +21716,7 @@
           <p:cNvPr id="4" name="">
             <a:extLst xmlns:a="http://schemas.openxmlformats.org/drawingml/2006/main">
               <a:ext uri="{FF2B5EF4-FFF2-40B4-BE49-F238E27FC236}">
-                <a16:creationId xmlns:a16="http://schemas.microsoft.com/office/drawing/2014/main" id="{1A740151-9A07-4B91-A0EF-2CC2282403A8}"/>
+                <a16:creationId xmlns:a16="http://schemas.microsoft.com/office/drawing/2014/main" id="{C14160A9-DD94-46C7-B59E-3DA105C4F08C}"/>
               </a:ext>
             </a:extLst>
           </p:cNvPr>
@@ -21747,7 +21747,7 @@
           <p:cNvPr id="5" name="TRIAL-001 기록 재구성 · Codex CLI 0.154.0 · 단일 읽기 전용 조사">
             <a:extLst xmlns:a="http://schemas.openxmlformats.org/drawingml/2006/main">
               <a:ext uri="{FF2B5EF4-FFF2-40B4-BE49-F238E27FC236}">
-                <a16:creationId xmlns:a16="http://schemas.microsoft.com/office/drawing/2014/main" id="{C211EB60-46FA-4316-AD9E-25A3C4539C20}"/>
+                <a16:creationId xmlns:a16="http://schemas.microsoft.com/office/drawing/2014/main" id="{BAE60D57-6CF8-45AA-A8B7-640FFA3B8747}"/>
               </a:ext>
             </a:extLst>
           </p:cNvPr>
@@ -21905,7 +21905,7 @@
           <p:cNvPr id="6" name="환경 오류 3건은 crop 결함의 증거가 아닙니다. 이 조사에서 코드는 수정하지 않았습니다.">
             <a:extLst xmlns:a="http://schemas.openxmlformats.org/drawingml/2006/main">
               <a:ext uri="{FF2B5EF4-FFF2-40B4-BE49-F238E27FC236}">
-                <a16:creationId xmlns:a16="http://schemas.microsoft.com/office/drawing/2014/main" id="{C1822762-E6B5-4B54-8916-195736D8CF84}"/>
+                <a16:creationId xmlns:a16="http://schemas.microsoft.com/office/drawing/2014/main" id="{FFF6A0CC-B20F-421E-8047-F688273DA1BD}"/>
               </a:ext>
             </a:extLst>
           </p:cNvPr>
@@ -22063,7 +22063,7 @@
           <p:cNvPr id="7" name="코드에서 확인한 문제">
             <a:extLst xmlns:a="http://schemas.openxmlformats.org/drawingml/2006/main">
               <a:ext uri="{FF2B5EF4-FFF2-40B4-BE49-F238E27FC236}">
-                <a16:creationId xmlns:a16="http://schemas.microsoft.com/office/drawing/2014/main" id="{C3442315-78A5-44F8-895D-81508985A250}"/>
+                <a16:creationId xmlns:a16="http://schemas.microsoft.com/office/drawing/2014/main" id="{80B2CC0F-FC63-4F90-A2EA-7A7ED9A336CF}"/>
               </a:ext>
             </a:extLst>
           </p:cNvPr>
@@ -22221,7 +22221,7 @@
           <p:cNvPr id="8" name="실행 환경에서 생긴 제한">
             <a:extLst xmlns:a="http://schemas.openxmlformats.org/drawingml/2006/main">
               <a:ext uri="{FF2B5EF4-FFF2-40B4-BE49-F238E27FC236}">
-                <a16:creationId xmlns:a16="http://schemas.microsoft.com/office/drawing/2014/main" id="{5C6D6161-DCF6-4C50-9B35-E8499E460FDD}"/>
+                <a16:creationId xmlns:a16="http://schemas.microsoft.com/office/drawing/2014/main" id="{6B299B80-0487-40D8-9178-DB3A89CCE8F8}"/>
               </a:ext>
             </a:extLst>
           </p:cNvPr>
@@ -22379,7 +22379,7 @@
           <p:cNvPr id="9" name="">
             <a:extLst xmlns:a="http://schemas.openxmlformats.org/drawingml/2006/main">
               <a:ext uri="{FF2B5EF4-FFF2-40B4-BE49-F238E27FC236}">
-                <a16:creationId xmlns:a16="http://schemas.microsoft.com/office/drawing/2014/main" id="{F02E316E-7359-419B-8ED5-706F683A14F5}"/>
+                <a16:creationId xmlns:a16="http://schemas.microsoft.com/office/drawing/2014/main" id="{D7F0E53C-14B6-41FF-A217-C30E46E4BAEB}"/>
               </a:ext>
             </a:extLst>
           </p:cNvPr>
@@ -22412,7 +22412,7 @@
           <p:cNvPr id="10" name="">
             <a:extLst xmlns:a="http://schemas.openxmlformats.org/drawingml/2006/main">
               <a:ext uri="{FF2B5EF4-FFF2-40B4-BE49-F238E27FC236}">
-                <a16:creationId xmlns:a16="http://schemas.microsoft.com/office/drawing/2014/main" id="{67C16D64-73A7-4CFF-B515-17C613D7D32B}"/>
+                <a16:creationId xmlns:a16="http://schemas.microsoft.com/office/drawing/2014/main" id="{EA5BAE07-1E3D-45FE-8160-E730D90F6BCA}"/>
               </a:ext>
             </a:extLst>
           </p:cNvPr>
@@ -22443,7 +22443,7 @@
           <p:cNvPr id="11" name="crop에 한 열이 더 포함됨">
             <a:extLst xmlns:a="http://schemas.openxmlformats.org/drawingml/2006/main">
               <a:ext uri="{FF2B5EF4-FFF2-40B4-BE49-F238E27FC236}">
-                <a16:creationId xmlns:a16="http://schemas.microsoft.com/office/drawing/2014/main" id="{CC94824A-C8F8-42DC-983C-4013DE9A36E5}"/>
+                <a16:creationId xmlns:a16="http://schemas.microsoft.com/office/drawing/2014/main" id="{8FCB2624-28B2-4A4F-8EDC-8C61825A4780}"/>
               </a:ext>
             </a:extLst>
           </p:cNvPr>
@@ -22601,7 +22601,7 @@
           <p:cNvPr id="12" name="테스트·호출 경로·계약 연결&#10;원인 설명 / 코드 수정 없음">
             <a:extLst xmlns:a="http://schemas.openxmlformats.org/drawingml/2006/main">
               <a:ext uri="{FF2B5EF4-FFF2-40B4-BE49-F238E27FC236}">
-                <a16:creationId xmlns:a16="http://schemas.microsoft.com/office/drawing/2014/main" id="{6161DBBD-5A0B-4537-8306-3A9FEA4B8339}"/>
+                <a16:creationId xmlns:a16="http://schemas.microsoft.com/office/drawing/2014/main" id="{312C2044-8330-436E-83A2-52F518213AEB}"/>
               </a:ext>
             </a:extLst>
           </p:cNvPr>
@@ -22782,7 +22782,7 @@
           <p:cNvPr id="13" name="임시 디렉터리를 만들 수 없음">
             <a:extLst xmlns:a="http://schemas.openxmlformats.org/drawingml/2006/main">
               <a:ext uri="{FF2B5EF4-FFF2-40B4-BE49-F238E27FC236}">
-                <a16:creationId xmlns:a16="http://schemas.microsoft.com/office/drawing/2014/main" id="{B4D7F965-6598-4543-B93A-8F46642B602F}"/>
+                <a16:creationId xmlns:a16="http://schemas.microsoft.com/office/drawing/2014/main" id="{11EBB362-788F-4BC4-B6C5-EF31EC03FAA1}"/>
               </a:ext>
             </a:extLst>
           </p:cNvPr>
@@ -22940,7 +22940,7 @@
           <p:cNvPr id="14" name="읽기 전용 권한 때문에&#10;서로 다른 테스트 3건이 오류">
             <a:extLst xmlns:a="http://schemas.openxmlformats.org/drawingml/2006/main">
               <a:ext uri="{FF2B5EF4-FFF2-40B4-BE49-F238E27FC236}">
-                <a16:creationId xmlns:a16="http://schemas.microsoft.com/office/drawing/2014/main" id="{6C27689F-52D5-46C3-AD54-505585388ED9}"/>
+                <a16:creationId xmlns:a16="http://schemas.microsoft.com/office/drawing/2014/main" id="{32BA6164-4DE0-4EEE-9016-72C3147E531E}"/>
               </a:ext>
             </a:extLst>
           </p:cNvPr>
@@ -23121,7 +23121,7 @@
           <p:cNvPr id="15" name="">
             <a:extLst xmlns:a="http://schemas.openxmlformats.org/drawingml/2006/main">
               <a:ext uri="{FF2B5EF4-FFF2-40B4-BE49-F238E27FC236}">
-                <a16:creationId xmlns:a16="http://schemas.microsoft.com/office/drawing/2014/main" id="{34A29DBC-5C8C-4738-A809-D06ED5CF7D03}"/>
+                <a16:creationId xmlns:a16="http://schemas.microsoft.com/office/drawing/2014/main" id="{C1F55548-6F81-4341-843B-A3693956FC21}"/>
               </a:ext>
             </a:extLst>
           </p:cNvPr>
@@ -23152,7 +23152,7 @@
           <p:cNvPr id="16" name="전체 실행 기록: 7개 통과 + crop 실패 + 환경 오류 3건">
             <a:extLst xmlns:a="http://schemas.openxmlformats.org/drawingml/2006/main">
               <a:ext uri="{FF2B5EF4-FFF2-40B4-BE49-F238E27FC236}">
-                <a16:creationId xmlns:a16="http://schemas.microsoft.com/office/drawing/2014/main" id="{1DE94CDA-3614-4528-96B0-A8637DDCA81C}"/>
+                <a16:creationId xmlns:a16="http://schemas.microsoft.com/office/drawing/2014/main" id="{D2F95E94-7379-48C2-A363-6068F0A9525E}"/>
               </a:ext>
             </a:extLst>
           </p:cNvPr>
@@ -23308,7 +23308,7 @@
     </p:spTree>
     <p:extLst>
       <p:ext uri="{BB962C8B-B14F-4D97-AF65-F5344CB8AC3E}">
-        <p14:creationId xmlns:p14="http://schemas.microsoft.com/office/powerpoint/2010/main" val="53074992"/>
+        <p14:creationId xmlns:p14="http://schemas.microsoft.com/office/powerpoint/2010/main" val="78045899"/>
       </p:ext>
     </p:extLst>
   </p:cSld>
@@ -23339,7 +23339,7 @@
           <p:cNvPr id="12" name="ACT 0 · Context를 찾는 주체">
             <a:extLst xmlns:a="http://schemas.openxmlformats.org/drawingml/2006/main">
               <a:ext uri="{FF2B5EF4-FFF2-40B4-BE49-F238E27FC236}">
-                <a16:creationId xmlns:a16="http://schemas.microsoft.com/office/drawing/2014/main" id="{DF261AA8-ED77-46F7-B672-12D4935686C4}"/>
+                <a16:creationId xmlns:a16="http://schemas.microsoft.com/office/drawing/2014/main" id="{22BC5D49-9BA2-4801-A583-D705A22CB299}"/>
               </a:ext>
             </a:extLst>
           </p:cNvPr>
@@ -23497,7 +23497,7 @@
           <p:cNvPr id="2" name="S07">
             <a:extLst xmlns:a="http://schemas.openxmlformats.org/drawingml/2006/main">
               <a:ext uri="{FF2B5EF4-FFF2-40B4-BE49-F238E27FC236}">
-                <a16:creationId xmlns:a16="http://schemas.microsoft.com/office/drawing/2014/main" id="{ACEC01B8-67D5-4591-8A50-F356683974A6}"/>
+                <a16:creationId xmlns:a16="http://schemas.microsoft.com/office/drawing/2014/main" id="{34432BF5-5A81-4009-90D2-9DD7B12A5019}"/>
               </a:ext>
             </a:extLst>
           </p:cNvPr>
@@ -23655,7 +23655,7 @@
           <p:cNvPr id="3" name="코드를 AI에게 가져가는 대신&#10;AI를 Repository로 데려간다">
             <a:extLst xmlns:a="http://schemas.openxmlformats.org/drawingml/2006/main">
               <a:ext uri="{FF2B5EF4-FFF2-40B4-BE49-F238E27FC236}">
-                <a16:creationId xmlns:a16="http://schemas.microsoft.com/office/drawing/2014/main" id="{FD4A72AF-E326-4C6C-A7B7-A3086501A9DF}"/>
+                <a16:creationId xmlns:a16="http://schemas.microsoft.com/office/drawing/2014/main" id="{555743DE-921F-4463-AC5B-A6401A00FE5C}"/>
               </a:ext>
             </a:extLst>
           </p:cNvPr>
@@ -23836,7 +23836,7 @@
           <p:cNvPr id="4" name="">
             <a:extLst xmlns:a="http://schemas.openxmlformats.org/drawingml/2006/main">
               <a:ext uri="{FF2B5EF4-FFF2-40B4-BE49-F238E27FC236}">
-                <a16:creationId xmlns:a16="http://schemas.microsoft.com/office/drawing/2014/main" id="{CB75F9E7-F0AA-4EBB-A4E5-FBE748BF0B92}"/>
+                <a16:creationId xmlns:a16="http://schemas.microsoft.com/office/drawing/2014/main" id="{AFC5A4E3-EB0C-4CBD-B3EA-9DCB0DB12BAF}"/>
               </a:ext>
             </a:extLst>
           </p:cNvPr>
@@ -23867,7 +23867,7 @@
           <p:cNvPr id="5" name="교육 모델 · TRIAL-001 단일 CLI 관찰과 연결 · AI 생성 설명용 삽화">
             <a:extLst xmlns:a="http://schemas.openxmlformats.org/drawingml/2006/main">
               <a:ext uri="{FF2B5EF4-FFF2-40B4-BE49-F238E27FC236}">
-                <a16:creationId xmlns:a16="http://schemas.microsoft.com/office/drawing/2014/main" id="{8FC7F62C-6807-4AB6-B984-8FC595B8980C}"/>
+                <a16:creationId xmlns:a16="http://schemas.microsoft.com/office/drawing/2014/main" id="{4DBE7960-9800-4F61-9780-DFB1D4D5FCC9}"/>
               </a:ext>
             </a:extLst>
           </p:cNvPr>
@@ -24025,7 +24025,7 @@
           <p:cNvPr id="6" name="목표 설정과 근거 검토는 개발자에게 남습니다. Repository 접근이 Task 의도를 정하지는 않습니다.">
             <a:extLst xmlns:a="http://schemas.openxmlformats.org/drawingml/2006/main">
               <a:ext uri="{FF2B5EF4-FFF2-40B4-BE49-F238E27FC236}">
-                <a16:creationId xmlns:a16="http://schemas.microsoft.com/office/drawing/2014/main" id="{28AA34C9-8ECA-4507-89CF-57BAA80395B7}"/>
+                <a16:creationId xmlns:a16="http://schemas.microsoft.com/office/drawing/2014/main" id="{F1361B50-3F15-46C4-84BB-7B8BA7842B57}"/>
               </a:ext>
             </a:extLst>
           </p:cNvPr>
@@ -24183,7 +24183,7 @@
           <p:cNvPr id="7" name="내가 골라 전달하는 Context">
             <a:extLst xmlns:a="http://schemas.openxmlformats.org/drawingml/2006/main">
               <a:ext uri="{FF2B5EF4-FFF2-40B4-BE49-F238E27FC236}">
-                <a16:creationId xmlns:a16="http://schemas.microsoft.com/office/drawing/2014/main" id="{1C13C35E-77D9-4BC1-A6CE-51AE79E943DE}"/>
+                <a16:creationId xmlns:a16="http://schemas.microsoft.com/office/drawing/2014/main" id="{AC2F2314-CDFD-4AC3-99B7-3C3F14840EAD}"/>
               </a:ext>
             </a:extLst>
           </p:cNvPr>
@@ -24341,7 +24341,7 @@
           <p:cNvPr id="8" name="조사를 맡기고 근거를 확인">
             <a:extLst xmlns:a="http://schemas.openxmlformats.org/drawingml/2006/main">
               <a:ext uri="{FF2B5EF4-FFF2-40B4-BE49-F238E27FC236}">
-                <a16:creationId xmlns:a16="http://schemas.microsoft.com/office/drawing/2014/main" id="{7B450BA3-63B0-4C3D-A26A-FE4210293D8A}"/>
+                <a16:creationId xmlns:a16="http://schemas.microsoft.com/office/drawing/2014/main" id="{8B3662BF-91B8-43BB-81F5-42F9E5F736F3}"/>
               </a:ext>
             </a:extLst>
           </p:cNvPr>
@@ -24499,7 +24499,7 @@
           <p:cNvPr id="9" name="">
             <a:extLst xmlns:a="http://schemas.openxmlformats.org/drawingml/2006/main">
               <a:ext uri="{FF2B5EF4-FFF2-40B4-BE49-F238E27FC236}">
-                <a16:creationId xmlns:a16="http://schemas.microsoft.com/office/drawing/2014/main" id="{C4F72CA0-BE39-4180-84AA-C782D51FE60C}"/>
+                <a16:creationId xmlns:a16="http://schemas.microsoft.com/office/drawing/2014/main" id="{4387A1F4-6B27-471F-B367-77ACEDA01A67}"/>
               </a:ext>
             </a:extLst>
           </p:cNvPr>
@@ -24509,7 +24509,7 @@
           <p:nvPr/>
         </p:nvPicPr>
         <p:blipFill>
-          <a:blip xmlns:r="http://schemas.openxmlformats.org/officeDocument/2006/relationships" xmlns:a="http://schemas.openxmlformats.org/drawingml/2006/main" r:embed="Rf0977a8fc8ce46b4"/>
+          <a:blip xmlns:r="http://schemas.openxmlformats.org/officeDocument/2006/relationships" xmlns:a="http://schemas.openxmlformats.org/drawingml/2006/main" r:embed="R262508a418ae4203"/>
           <a:srcRect xmlns:a="http://schemas.openxmlformats.org/drawingml/2006/main" l="0" t="18000" r="0" b="15000"/>
           <a:stretch xmlns:a="http://schemas.openxmlformats.org/drawingml/2006/main"/>
         </p:blipFill>
@@ -24528,7 +24528,7 @@
           <p:cNvPr id="10" name="코드 조각을 선택·복사">
             <a:extLst xmlns:a="http://schemas.openxmlformats.org/drawingml/2006/main">
               <a:ext uri="{FF2B5EF4-FFF2-40B4-BE49-F238E27FC236}">
-                <a16:creationId xmlns:a16="http://schemas.microsoft.com/office/drawing/2014/main" id="{AC18A833-21FC-4EFA-BEA8-5DD9D7F58017}"/>
+                <a16:creationId xmlns:a16="http://schemas.microsoft.com/office/drawing/2014/main" id="{B6ACB744-A320-46CB-9B6A-932E740F15BA}"/>
               </a:ext>
             </a:extLst>
           </p:cNvPr>
@@ -24686,7 +24686,7 @@
           <p:cNvPr id="11" name="목표는 사람이, 탐색은 Agent와">
             <a:extLst xmlns:a="http://schemas.openxmlformats.org/drawingml/2006/main">
               <a:ext uri="{FF2B5EF4-FFF2-40B4-BE49-F238E27FC236}">
-                <a16:creationId xmlns:a16="http://schemas.microsoft.com/office/drawing/2014/main" id="{594D53E0-3778-4E4C-8AA6-45A3CA8FE13A}"/>
+                <a16:creationId xmlns:a16="http://schemas.microsoft.com/office/drawing/2014/main" id="{3069110F-8940-44F1-9637-CA7A5810769C}"/>
               </a:ext>
             </a:extLst>
           </p:cNvPr>
@@ -24842,7 +24842,7 @@
     </p:spTree>
     <p:extLst>
       <p:ext uri="{BB962C8B-B14F-4D97-AF65-F5344CB8AC3E}">
-        <p14:creationId xmlns:p14="http://schemas.microsoft.com/office/powerpoint/2010/main" val="1643376365"/>
+        <p14:creationId xmlns:p14="http://schemas.microsoft.com/office/powerpoint/2010/main" val="86831313"/>
       </p:ext>
     </p:extLst>
   </p:cSld>
@@ -24873,7 +24873,7 @@
           <p:cNvPr id="15" name="ACT 0 · 접근할 정보와 정할 목표">
             <a:extLst xmlns:a="http://schemas.openxmlformats.org/drawingml/2006/main">
               <a:ext uri="{FF2B5EF4-FFF2-40B4-BE49-F238E27FC236}">
-                <a16:creationId xmlns:a16="http://schemas.microsoft.com/office/drawing/2014/main" id="{E2BF1C1E-2682-4A05-90BF-202D7D9C0809}"/>
+                <a16:creationId xmlns:a16="http://schemas.microsoft.com/office/drawing/2014/main" id="{F1FAFA2D-C926-4583-9708-5E2339F2366E}"/>
               </a:ext>
             </a:extLst>
           </p:cNvPr>
@@ -25031,7 +25031,7 @@
           <p:cNvPr id="2" name="S08">
             <a:extLst xmlns:a="http://schemas.openxmlformats.org/drawingml/2006/main">
               <a:ext uri="{FF2B5EF4-FFF2-40B4-BE49-F238E27FC236}">
-                <a16:creationId xmlns:a16="http://schemas.microsoft.com/office/drawing/2014/main" id="{D136EF37-B68C-455C-9E48-9D217D6EAD60}"/>
+                <a16:creationId xmlns:a16="http://schemas.microsoft.com/office/drawing/2014/main" id="{32100E83-D6EE-488C-B86E-2A1FEBF4F39D}"/>
               </a:ext>
             </a:extLst>
           </p:cNvPr>
@@ -25189,7 +25189,7 @@
           <p:cNvPr id="3" name="Repository 접근과 Task 의도는 별개다">
             <a:extLst xmlns:a="http://schemas.openxmlformats.org/drawingml/2006/main">
               <a:ext uri="{FF2B5EF4-FFF2-40B4-BE49-F238E27FC236}">
-                <a16:creationId xmlns:a16="http://schemas.microsoft.com/office/drawing/2014/main" id="{C5E995D3-3939-4652-A8E7-5626163A662B}"/>
+                <a16:creationId xmlns:a16="http://schemas.microsoft.com/office/drawing/2014/main" id="{0936280A-0B56-4654-81C8-799884E33718}"/>
               </a:ext>
             </a:extLst>
           </p:cNvPr>
@@ -25347,7 +25347,7 @@
           <p:cNvPr id="4" name="">
             <a:extLst xmlns:a="http://schemas.openxmlformats.org/drawingml/2006/main">
               <a:ext uri="{FF2B5EF4-FFF2-40B4-BE49-F238E27FC236}">
-                <a16:creationId xmlns:a16="http://schemas.microsoft.com/office/drawing/2014/main" id="{AA364CE8-4531-45E3-B4BB-5FAA63521EAC}"/>
+                <a16:creationId xmlns:a16="http://schemas.microsoft.com/office/drawing/2014/main" id="{3285C100-8F17-4779-A3A0-F4068D9244ED}"/>
               </a:ext>
             </a:extLst>
           </p:cNvPr>
@@ -25378,7 +25378,7 @@
           <p:cNvPr id="5" name="이 과정의 교육 모델 · Repository 접근과 작업 의도의 관계">
             <a:extLst xmlns:a="http://schemas.openxmlformats.org/drawingml/2006/main">
               <a:ext uri="{FF2B5EF4-FFF2-40B4-BE49-F238E27FC236}">
-                <a16:creationId xmlns:a16="http://schemas.microsoft.com/office/drawing/2014/main" id="{D7AB7F99-DC2B-4F91-A05F-615638B09509}"/>
+                <a16:creationId xmlns:a16="http://schemas.microsoft.com/office/drawing/2014/main" id="{1F763618-1CED-4821-AFDC-CF0D4B9E8F53}"/>
               </a:ext>
             </a:extLst>
           </p:cNvPr>
@@ -25536,7 +25536,7 @@
           <p:cNvPr id="6" name="모든 제품이나 환경의 기능을 설명하는 공식 분류가 아닙니다.">
             <a:extLst xmlns:a="http://schemas.openxmlformats.org/drawingml/2006/main">
               <a:ext uri="{FF2B5EF4-FFF2-40B4-BE49-F238E27FC236}">
-                <a16:creationId xmlns:a16="http://schemas.microsoft.com/office/drawing/2014/main" id="{316C8112-E0E6-4809-92E5-EC48DD643AB5}"/>
+                <a16:creationId xmlns:a16="http://schemas.microsoft.com/office/drawing/2014/main" id="{3E4A0E48-5BA9-4B94-A404-0D2AF6FC8CAA}"/>
               </a:ext>
             </a:extLst>
           </p:cNvPr>
@@ -25694,7 +25694,7 @@
           <p:cNvPr id="7" name="볼 수 있는 것">
             <a:extLst xmlns:a="http://schemas.openxmlformats.org/drawingml/2006/main">
               <a:ext uri="{FF2B5EF4-FFF2-40B4-BE49-F238E27FC236}">
-                <a16:creationId xmlns:a16="http://schemas.microsoft.com/office/drawing/2014/main" id="{A3DC94D2-F3FA-4C0C-B64C-4E0C6694573F}"/>
+                <a16:creationId xmlns:a16="http://schemas.microsoft.com/office/drawing/2014/main" id="{14862882-3170-451E-8254-BF727D27BECC}"/>
               </a:ext>
             </a:extLst>
           </p:cNvPr>
@@ -25852,7 +25852,7 @@
           <p:cNvPr id="8" name="정해야 하는 것">
             <a:extLst xmlns:a="http://schemas.openxmlformats.org/drawingml/2006/main">
               <a:ext uri="{FF2B5EF4-FFF2-40B4-BE49-F238E27FC236}">
-                <a16:creationId xmlns:a16="http://schemas.microsoft.com/office/drawing/2014/main" id="{707F1DBA-02C1-4BA1-9AE0-55F4696DD5F8}"/>
+                <a16:creationId xmlns:a16="http://schemas.microsoft.com/office/drawing/2014/main" id="{B753E983-F6E0-4C89-9E70-BF41C420C413}"/>
               </a:ext>
             </a:extLst>
           </p:cNvPr>
@@ -26010,7 +26010,7 @@
           <p:cNvPr id="9" name="">
             <a:extLst xmlns:a="http://schemas.openxmlformats.org/drawingml/2006/main">
               <a:ext uri="{FF2B5EF4-FFF2-40B4-BE49-F238E27FC236}">
-                <a16:creationId xmlns:a16="http://schemas.microsoft.com/office/drawing/2014/main" id="{5A538ABC-7BEF-4DC1-B6FA-D5B09721F180}"/>
+                <a16:creationId xmlns:a16="http://schemas.microsoft.com/office/drawing/2014/main" id="{95D0ED03-9012-44A1-995D-0CA8DDA1C25A}"/>
               </a:ext>
             </a:extLst>
           </p:cNvPr>
@@ -26041,7 +26041,7 @@
           <p:cNvPr id="10" name="">
             <a:extLst xmlns:a="http://schemas.openxmlformats.org/drawingml/2006/main">
               <a:ext uri="{FF2B5EF4-FFF2-40B4-BE49-F238E27FC236}">
-                <a16:creationId xmlns:a16="http://schemas.microsoft.com/office/drawing/2014/main" id="{820BF176-6974-4D94-A527-624043348ECF}"/>
+                <a16:creationId xmlns:a16="http://schemas.microsoft.com/office/drawing/2014/main" id="{D74524AB-437E-4C03-94E1-F31DF7EC1437}"/>
               </a:ext>
             </a:extLst>
           </p:cNvPr>
@@ -26072,7 +26072,7 @@
           <p:cNvPr id="11" name="파일&#10;구현&#10;테스트">
             <a:extLst xmlns:a="http://schemas.openxmlformats.org/drawingml/2006/main">
               <a:ext uri="{FF2B5EF4-FFF2-40B4-BE49-F238E27FC236}">
-                <a16:creationId xmlns:a16="http://schemas.microsoft.com/office/drawing/2014/main" id="{226DF72D-27AC-4A69-82B7-BDE7F428DBA9}"/>
+                <a16:creationId xmlns:a16="http://schemas.microsoft.com/office/drawing/2014/main" id="{11FE6A99-8415-439A-8552-8353582F1743}"/>
               </a:ext>
             </a:extLst>
           </p:cNvPr>
@@ -26276,7 +26276,7 @@
           <p:cNvPr id="12" name="원하는 변화&#10;허용할 범위&#10;완료 판단">
             <a:extLst xmlns:a="http://schemas.openxmlformats.org/drawingml/2006/main">
               <a:ext uri="{FF2B5EF4-FFF2-40B4-BE49-F238E27FC236}">
-                <a16:creationId xmlns:a16="http://schemas.microsoft.com/office/drawing/2014/main" id="{82BAA65C-3D99-4A4B-A253-8FC278733F15}"/>
+                <a16:creationId xmlns:a16="http://schemas.microsoft.com/office/drawing/2014/main" id="{2A071D5C-81EA-43D3-891D-9757F1D3F117}"/>
               </a:ext>
             </a:extLst>
           </p:cNvPr>
@@ -26480,7 +26480,7 @@
           <p:cNvPr id="13" name="≠">
             <a:extLst xmlns:a="http://schemas.openxmlformats.org/drawingml/2006/main">
               <a:ext uri="{FF2B5EF4-FFF2-40B4-BE49-F238E27FC236}">
-                <a16:creationId xmlns:a16="http://schemas.microsoft.com/office/drawing/2014/main" id="{9BCA4971-33E6-44CF-B7B1-F5536C7980AF}"/>
+                <a16:creationId xmlns:a16="http://schemas.microsoft.com/office/drawing/2014/main" id="{82170E5B-E8FE-4C5D-85A8-0C2B5CD7E6B3}"/>
               </a:ext>
             </a:extLst>
           </p:cNvPr>
@@ -26638,7 +26638,7 @@
           <p:cNvPr id="14" name="코드가 보여도, 원하는 일은 따로 전달해야 한다.">
             <a:extLst xmlns:a="http://schemas.openxmlformats.org/drawingml/2006/main">
               <a:ext uri="{FF2B5EF4-FFF2-40B4-BE49-F238E27FC236}">
-                <a16:creationId xmlns:a16="http://schemas.microsoft.com/office/drawing/2014/main" id="{FB7130CE-9204-4DC1-B315-129107083A9C}"/>
+                <a16:creationId xmlns:a16="http://schemas.microsoft.com/office/drawing/2014/main" id="{FB32683E-E195-40A3-8895-2ED7B6E0FACB}"/>
               </a:ext>
             </a:extLst>
           </p:cNvPr>
@@ -26794,7 +26794,7 @@
     </p:spTree>
     <p:extLst>
       <p:ext uri="{BB962C8B-B14F-4D97-AF65-F5344CB8AC3E}">
-        <p14:creationId xmlns:p14="http://schemas.microsoft.com/office/powerpoint/2010/main" val="1575183741"/>
+        <p14:creationId xmlns:p14="http://schemas.microsoft.com/office/powerpoint/2010/main" val="1505983663"/>
       </p:ext>
     </p:extLst>
   </p:cSld>
@@ -26825,7 +26825,7 @@
           <p:cNvPr id="11" name="ACT 0 · 다음 질문">
             <a:extLst xmlns:a="http://schemas.openxmlformats.org/drawingml/2006/main">
               <a:ext uri="{FF2B5EF4-FFF2-40B4-BE49-F238E27FC236}">
-                <a16:creationId xmlns:a16="http://schemas.microsoft.com/office/drawing/2014/main" id="{0715B9A0-45A6-4958-99B4-1BDB162D32D8}"/>
+                <a16:creationId xmlns:a16="http://schemas.microsoft.com/office/drawing/2014/main" id="{5ADF2C27-5D43-4DEC-AE4A-B64E5FD69416}"/>
               </a:ext>
             </a:extLst>
           </p:cNvPr>
@@ -26983,7 +26983,7 @@
           <p:cNvPr id="2" name="S09">
             <a:extLst xmlns:a="http://schemas.openxmlformats.org/drawingml/2006/main">
               <a:ext uri="{FF2B5EF4-FFF2-40B4-BE49-F238E27FC236}">
-                <a16:creationId xmlns:a16="http://schemas.microsoft.com/office/drawing/2014/main" id="{C68B83E7-86AA-4194-BA87-E5377044B362}"/>
+                <a16:creationId xmlns:a16="http://schemas.microsoft.com/office/drawing/2014/main" id="{DCF5A65E-3D42-4870-B047-811D652BB2C9}"/>
               </a:ext>
             </a:extLst>
           </p:cNvPr>
@@ -27141,7 +27141,7 @@
           <p:cNvPr id="3" name="Repository를 보면 내가 원하는 것까지 알까?">
             <a:extLst xmlns:a="http://schemas.openxmlformats.org/drawingml/2006/main">
               <a:ext uri="{FF2B5EF4-FFF2-40B4-BE49-F238E27FC236}">
-                <a16:creationId xmlns:a16="http://schemas.microsoft.com/office/drawing/2014/main" id="{1E213C83-0153-4C08-96BB-46326CDF6832}"/>
+                <a16:creationId xmlns:a16="http://schemas.microsoft.com/office/drawing/2014/main" id="{CC95F8A8-75EB-4F8D-9545-53E6606D3328}"/>
               </a:ext>
             </a:extLst>
           </p:cNvPr>
@@ -27299,7 +27299,7 @@
           <p:cNvPr id="4" name="">
             <a:extLst xmlns:a="http://schemas.openxmlformats.org/drawingml/2006/main">
               <a:ext uri="{FF2B5EF4-FFF2-40B4-BE49-F238E27FC236}">
-                <a16:creationId xmlns:a16="http://schemas.microsoft.com/office/drawing/2014/main" id="{80728951-3F89-4D7C-83AF-C75DDD44FB02}"/>
+                <a16:creationId xmlns:a16="http://schemas.microsoft.com/office/drawing/2014/main" id="{7ACCCC14-1114-4CA8-B872-C1435CFEB9C7}"/>
               </a:ext>
             </a:extLst>
           </p:cNvPr>
@@ -27330,7 +27330,7 @@
           <p:cNvPr id="5" name="함께 생각해 보기 · 교육 모델">
             <a:extLst xmlns:a="http://schemas.openxmlformats.org/drawingml/2006/main">
               <a:ext uri="{FF2B5EF4-FFF2-40B4-BE49-F238E27FC236}">
-                <a16:creationId xmlns:a16="http://schemas.microsoft.com/office/drawing/2014/main" id="{0D81BD3E-91DF-46ED-999D-78BE3DD71DAC}"/>
+                <a16:creationId xmlns:a16="http://schemas.microsoft.com/office/drawing/2014/main" id="{FE1E7F69-9209-4296-A49D-E7E3A7A46FDE}"/>
               </a:ext>
             </a:extLst>
           </p:cNvPr>
@@ -27488,7 +27488,7 @@
           <p:cNvPr id="6" name="현재 맡기고 싶은 일을 떠올려 보세요. 질문과 경험 공유는 자발적으로 진행합니다.">
             <a:extLst xmlns:a="http://schemas.openxmlformats.org/drawingml/2006/main">
               <a:ext uri="{FF2B5EF4-FFF2-40B4-BE49-F238E27FC236}">
-                <a16:creationId xmlns:a16="http://schemas.microsoft.com/office/drawing/2014/main" id="{D409D152-2A2B-4ABF-B286-3DBD11B08DEF}"/>
+                <a16:creationId xmlns:a16="http://schemas.microsoft.com/office/drawing/2014/main" id="{AA90E931-42EC-46EE-AD2D-FA580C99A09F}"/>
               </a:ext>
             </a:extLst>
           </p:cNvPr>
@@ -27646,7 +27646,7 @@
           <p:cNvPr id="7" name="지금 이 저장소에&#10;어떤 일을 맡기고 싶으신가요?">
             <a:extLst xmlns:a="http://schemas.openxmlformats.org/drawingml/2006/main">
               <a:ext uri="{FF2B5EF4-FFF2-40B4-BE49-F238E27FC236}">
-                <a16:creationId xmlns:a16="http://schemas.microsoft.com/office/drawing/2014/main" id="{ED521D85-7A30-4169-90ED-191D3FBCE05D}"/>
+                <a16:creationId xmlns:a16="http://schemas.microsoft.com/office/drawing/2014/main" id="{5DEAA14E-00BA-4028-BCC9-CF0E88C03349}"/>
               </a:ext>
             </a:extLst>
           </p:cNvPr>
@@ -27827,7 +27827,7 @@
           <p:cNvPr id="8" name="?">
             <a:extLst xmlns:a="http://schemas.openxmlformats.org/drawingml/2006/main">
               <a:ext uri="{FF2B5EF4-FFF2-40B4-BE49-F238E27FC236}">
-                <a16:creationId xmlns:a16="http://schemas.microsoft.com/office/drawing/2014/main" id="{FA9A1F3D-E627-4190-894E-CF1CD514D720}"/>
+                <a16:creationId xmlns:a16="http://schemas.microsoft.com/office/drawing/2014/main" id="{7E277A2C-64E6-457B-9EF1-EC36B8112EBC}"/>
               </a:ext>
             </a:extLst>
           </p:cNvPr>
@@ -27985,7 +27985,7 @@
           <p:cNvPr id="9" name="">
             <a:extLst xmlns:a="http://schemas.openxmlformats.org/drawingml/2006/main">
               <a:ext uri="{FF2B5EF4-FFF2-40B4-BE49-F238E27FC236}">
-                <a16:creationId xmlns:a16="http://schemas.microsoft.com/office/drawing/2014/main" id="{5CA54179-2021-43E2-82F3-EDA96C5A6CE9}"/>
+                <a16:creationId xmlns:a16="http://schemas.microsoft.com/office/drawing/2014/main" id="{AA2027C2-D60B-45EC-82F4-C62F1C5E3FAF}"/>
               </a:ext>
             </a:extLst>
           </p:cNvPr>
@@ -28016,7 +28016,7 @@
           <p:cNvPr id="10" name="그 원하는 결과까지&#10;코드에 적혀 있을까요?">
             <a:extLst xmlns:a="http://schemas.openxmlformats.org/drawingml/2006/main">
               <a:ext uri="{FF2B5EF4-FFF2-40B4-BE49-F238E27FC236}">
-                <a16:creationId xmlns:a16="http://schemas.microsoft.com/office/drawing/2014/main" id="{E0982958-9045-405D-A133-A2A634935E56}"/>
+                <a16:creationId xmlns:a16="http://schemas.microsoft.com/office/drawing/2014/main" id="{56867C9B-7C1D-46FD-86C0-20BF17B77B25}"/>
               </a:ext>
             </a:extLst>
           </p:cNvPr>
@@ -28195,7 +28195,7 @@
     </p:spTree>
     <p:extLst>
       <p:ext uri="{BB962C8B-B14F-4D97-AF65-F5344CB8AC3E}">
-        <p14:creationId xmlns:p14="http://schemas.microsoft.com/office/powerpoint/2010/main" val="780849956"/>
+        <p14:creationId xmlns:p14="http://schemas.microsoft.com/office/powerpoint/2010/main" val="1367839002"/>
       </p:ext>
     </p:extLst>
   </p:cSld>

</xml_diff>

<commit_message>
feat(slides): improve full-deck narrative handoffs
Connect adjacent slides with clearer audience and presenter cues.
Preserve the approved story, evidence boundaries and course timing
while aligning the deck, Notes, Slide Map and local previews.
</commit_message>
<xml_diff>
--- a/production/ACT_0.pptx
+++ b/production/ACT_0.pptx
@@ -2,21 +2,21 @@
 <file path=ppt/presentation.xml><?xml version="1.0" encoding="utf-8"?>
 <p:presentation xmlns:p="http://schemas.openxmlformats.org/presentationml/2006/main">
   <p:sldMasterIdLst>
-    <p:sldMasterId xmlns:r="http://schemas.openxmlformats.org/officeDocument/2006/relationships" id="2147483648" r:id="Rbdbfeafa66684e10"/>
+    <p:sldMasterId xmlns:r="http://schemas.openxmlformats.org/officeDocument/2006/relationships" id="2147483648" r:id="R989e4991c2d548ea"/>
   </p:sldMasterIdLst>
   <p:notesMasterIdLst>
-    <p:notesMasterId xmlns:r="http://schemas.openxmlformats.org/officeDocument/2006/relationships" r:id="Rbde1282568e4442b"/>
+    <p:notesMasterId xmlns:r="http://schemas.openxmlformats.org/officeDocument/2006/relationships" r:id="Ra3ce76a09b3b476b"/>
   </p:notesMasterIdLst>
   <p:sldIdLst>
-    <p:sldId xmlns:r="http://schemas.openxmlformats.org/officeDocument/2006/relationships" id="256" r:id="Re25ba3eaa5e7449f"/>
-    <p:sldId xmlns:r="http://schemas.openxmlformats.org/officeDocument/2006/relationships" id="257" r:id="Rf86159611443443a"/>
-    <p:sldId xmlns:r="http://schemas.openxmlformats.org/officeDocument/2006/relationships" id="258" r:id="Ra0feeb9f4c4843d4"/>
-    <p:sldId xmlns:r="http://schemas.openxmlformats.org/officeDocument/2006/relationships" id="259" r:id="Re282c6bbb06a4c8d"/>
-    <p:sldId xmlns:r="http://schemas.openxmlformats.org/officeDocument/2006/relationships" id="260" r:id="R7f0ce758eaba4e2b"/>
-    <p:sldId xmlns:r="http://schemas.openxmlformats.org/officeDocument/2006/relationships" id="261" r:id="Rc20c590bffc44f96"/>
-    <p:sldId xmlns:r="http://schemas.openxmlformats.org/officeDocument/2006/relationships" id="262" r:id="Rc8df4fc184e04353"/>
-    <p:sldId xmlns:r="http://schemas.openxmlformats.org/officeDocument/2006/relationships" id="263" r:id="R870e1f9c893a401b"/>
-    <p:sldId xmlns:r="http://schemas.openxmlformats.org/officeDocument/2006/relationships" id="264" r:id="R0772e28dabd64f86"/>
+    <p:sldId xmlns:r="http://schemas.openxmlformats.org/officeDocument/2006/relationships" id="256" r:id="Rbe3edf4d711b4bef"/>
+    <p:sldId xmlns:r="http://schemas.openxmlformats.org/officeDocument/2006/relationships" id="257" r:id="R3813f64f3c1b4e70"/>
+    <p:sldId xmlns:r="http://schemas.openxmlformats.org/officeDocument/2006/relationships" id="258" r:id="Re40e8ac4f067479d"/>
+    <p:sldId xmlns:r="http://schemas.openxmlformats.org/officeDocument/2006/relationships" id="259" r:id="Ra5488453189044f8"/>
+    <p:sldId xmlns:r="http://schemas.openxmlformats.org/officeDocument/2006/relationships" id="260" r:id="R0fa2cb3c33054a26"/>
+    <p:sldId xmlns:r="http://schemas.openxmlformats.org/officeDocument/2006/relationships" id="261" r:id="Rf54b10b297d3491f"/>
+    <p:sldId xmlns:r="http://schemas.openxmlformats.org/officeDocument/2006/relationships" id="262" r:id="R3ba2099e54944792"/>
+    <p:sldId xmlns:r="http://schemas.openxmlformats.org/officeDocument/2006/relationships" id="263" r:id="R8e31cf9bacb94408"/>
+    <p:sldId xmlns:r="http://schemas.openxmlformats.org/officeDocument/2006/relationships" id="264" r:id="Rc0b894f1171d4565"/>
   </p:sldIdLst>
   <p:sldSz cx="12192000" cy="6858000"/>
   <p:notesSz cx="6858000" cy="9144000"/>
@@ -2520,7 +2520,7 @@
           </a:p>
           <a:p xmlns:a="http://schemas.openxmlformats.org/drawingml/2006/main">
             <a:r>
-              <a:t>3. **TRANSFER (1:30–2:00):** 가운데 ≠를 짚고 “코드가 보여도 원하는 일은 따로 전달해야 한다”로 마친다. ACT 1의 구체적인 요청 구조는 아직 소개하지 않는다.</a:t>
+              <a:t>3. **TRANSFER (1:30–2:00):** 가운데 ≠를 짚고 “코드가 보여도 원하는 일은 따로 전달해야 한다”로 정리한다. 이어 이 구분을 각자가 맡기고 싶은 작업에 대입할 질문을 남긴다. ACT 1의 구체적인 요청 구조는 아직 소개하지 않는다.</a:t>
             </a:r>
           </a:p>
           <a:p xmlns:a="http://schemas.openxmlformats.org/drawingml/2006/main">
@@ -2600,7 +2600,7 @@
           </a:p>
           <a:p xmlns:a="http://schemas.openxmlformats.org/drawingml/2006/main">
             <a:r>
-              <a:t>Transition: “그렇다면 Repository를 보면 내가 원하는 것까지 알까요?”라고 S09의 논의 질문을 연다.</a:t>
+              <a:t>Transition: “이 구분을 여러분이 지금 맡기고 싶은 일에 대입해 보겠습니다.”라고 S09의 개인 적용 질문을 연다.</a:t>
             </a:r>
           </a:p>
           <a:p xmlns:a="http://schemas.openxmlformats.org/drawingml/2006/main">
@@ -2770,7 +2770,7 @@
           </a:p>
           <a:p xmlns:a="http://schemas.openxmlformats.org/drawingml/2006/main">
             <a:r>
-              <a:t>Opening Question: “Repository를 볼 수 있으면 내가 원하는 것까지 알 수 있을까?”</a:t>
+              <a:t>Opening Question: “내가 지금 맡기고 싶은 일의 원하는 결과까지 코드에 적혀 있을까?”</a:t>
             </a:r>
           </a:p>
           <a:p xmlns:a="http://schemas.openxmlformats.org/drawingml/2006/main">
@@ -2790,7 +2790,7 @@
           </a:p>
           <a:p xmlns:a="http://schemas.openxmlformats.org/drawingml/2006/main">
             <a:r>
-              <a:t>1. **DISCUSS / TRANSITION (0:00–3:00):** “지금 이 저장소에 어떤 일을 맡기고 싶은가?”와 “그 원하는 결과까지 코드에 적혀 있는가?”를 차례로 읽는다. 답이나 다음 단계의 체크리스트를 제시하지 않는다.</a:t>
+              <a:t>1. **DISCUSS / TRANSITION (0:00–3:00):** 화면 상단의 “내 작업에 적용할 질문”을 짚고, 각자가 지금 맡기고 싶은 일 하나를 떠올리게 한다. “지금 이 저장소에 어떤 일을 맡기고 싶은가?”와 “그 원하는 결과까지 코드에 적혀 있는가?”를 차례로 읽는다. S08의 구분을 자기 작업에 대입하며 답이나 다음 단계의 체크리스트를 제시하지 않는다.</a:t>
             </a:r>
           </a:p>
           <a:p xmlns:a="http://schemas.openxmlformats.org/drawingml/2006/main">
@@ -2875,7 +2875,7 @@
           </a:p>
           <a:p xmlns:a="http://schemas.openxmlformats.org/drawingml/2006/main">
             <a:r>
-              <a:t>Transition: `Chatbot → Prompt`로 다음 ACT에 handoff한다. ACT 1의 내부 구조는 소개하지 않는다.</a:t>
+              <a:t>Transition: “방금 떠올린 원하는 결과를 작업 요청으로 전달하려면 무엇이 더 필요할까요?”라는 질문으로 `Chatbot → Prompt`를 handoff한다. ACT 1의 내부 구조는 소개하지 않는다.</a:t>
             </a:r>
           </a:p>
           <a:p xmlns:a="http://schemas.openxmlformats.org/drawingml/2006/main">
@@ -2952,7 +2952,7 @@
           <p:cNvPr id="3" name="Title">
             <a:extLst xmlns:a="http://schemas.openxmlformats.org/drawingml/2006/main">
               <a:ext uri="{FF2B5EF4-FFF2-40B4-BE49-F238E27FC236}">
-                <a16:creationId xmlns:a16="http://schemas.microsoft.com/office/drawing/2014/main" id="{56B82EC1-4702-4D17-ABC7-6FC1B9832792}"/>
+                <a16:creationId xmlns:a16="http://schemas.microsoft.com/office/drawing/2014/main" id="{A95267A7-CF47-4D92-BB0A-124F1BDB6E5A}"/>
               </a:ext>
             </a:extLst>
           </p:cNvPr>
@@ -3181,7 +3181,7 @@
           <p:cNvPr id="2" name="Subtitle">
             <a:extLst xmlns:a="http://schemas.openxmlformats.org/drawingml/2006/main">
               <a:ext uri="{FF2B5EF4-FFF2-40B4-BE49-F238E27FC236}">
-                <a16:creationId xmlns:a16="http://schemas.microsoft.com/office/drawing/2014/main" id="{B09A683E-4342-470B-8D9B-7BAA6D2F7BE6}"/>
+                <a16:creationId xmlns:a16="http://schemas.microsoft.com/office/drawing/2014/main" id="{0A521828-CFAB-4A98-A01A-D8542644EBB3}"/>
               </a:ext>
             </a:extLst>
           </p:cNvPr>
@@ -3427,7 +3427,7 @@
           <p:cNvPr id="2" name="Section title">
             <a:extLst xmlns:a="http://schemas.openxmlformats.org/drawingml/2006/main">
               <a:ext uri="{FF2B5EF4-FFF2-40B4-BE49-F238E27FC236}">
-                <a16:creationId xmlns:a16="http://schemas.microsoft.com/office/drawing/2014/main" id="{A9C251AF-C835-4DB8-92E8-52DCADAFD9CC}"/>
+                <a16:creationId xmlns:a16="http://schemas.microsoft.com/office/drawing/2014/main" id="{D6C87A90-95FA-4251-A027-F5C449E38396}"/>
               </a:ext>
             </a:extLst>
           </p:cNvPr>
@@ -3673,7 +3673,7 @@
           <p:cNvPr id="3" name="Title">
             <a:extLst xmlns:a="http://schemas.openxmlformats.org/drawingml/2006/main">
               <a:ext uri="{FF2B5EF4-FFF2-40B4-BE49-F238E27FC236}">
-                <a16:creationId xmlns:a16="http://schemas.microsoft.com/office/drawing/2014/main" id="{7AEAAD17-B335-48B9-8EA1-5304E3647D04}"/>
+                <a16:creationId xmlns:a16="http://schemas.microsoft.com/office/drawing/2014/main" id="{8FB009FD-BD3D-42D0-8E42-0D93D4B46AE7}"/>
               </a:ext>
             </a:extLst>
           </p:cNvPr>
@@ -3902,7 +3902,7 @@
           <p:cNvPr id="2" name="Body">
             <a:extLst xmlns:a="http://schemas.openxmlformats.org/drawingml/2006/main">
               <a:ext uri="{FF2B5EF4-FFF2-40B4-BE49-F238E27FC236}">
-                <a16:creationId xmlns:a16="http://schemas.microsoft.com/office/drawing/2014/main" id="{711547CA-25E8-4812-87AA-B975B12E9300}"/>
+                <a16:creationId xmlns:a16="http://schemas.microsoft.com/office/drawing/2014/main" id="{9D8BE5BC-80CA-4539-A8B5-02E23D6113D1}"/>
               </a:ext>
             </a:extLst>
           </p:cNvPr>
@@ -4148,7 +4148,7 @@
           <p:cNvPr id="4" name="Title">
             <a:extLst xmlns:a="http://schemas.openxmlformats.org/drawingml/2006/main">
               <a:ext uri="{FF2B5EF4-FFF2-40B4-BE49-F238E27FC236}">
-                <a16:creationId xmlns:a16="http://schemas.microsoft.com/office/drawing/2014/main" id="{069A56BA-2EF7-4D13-9EC1-B006E6A69479}"/>
+                <a16:creationId xmlns:a16="http://schemas.microsoft.com/office/drawing/2014/main" id="{BB9C8362-3D71-4BFA-BB8F-6E88A3F22045}"/>
               </a:ext>
             </a:extLst>
           </p:cNvPr>
@@ -4377,7 +4377,7 @@
           <p:cNvPr id="2" name="Left column">
             <a:extLst xmlns:a="http://schemas.openxmlformats.org/drawingml/2006/main">
               <a:ext uri="{FF2B5EF4-FFF2-40B4-BE49-F238E27FC236}">
-                <a16:creationId xmlns:a16="http://schemas.microsoft.com/office/drawing/2014/main" id="{8E71181F-D300-42FD-8582-8DFE40FCBF70}"/>
+                <a16:creationId xmlns:a16="http://schemas.microsoft.com/office/drawing/2014/main" id="{42DB8546-DA19-4562-85CD-1D53EFEA29F1}"/>
               </a:ext>
             </a:extLst>
           </p:cNvPr>
@@ -4606,7 +4606,7 @@
           <p:cNvPr id="3" name="Right column">
             <a:extLst xmlns:a="http://schemas.openxmlformats.org/drawingml/2006/main">
               <a:ext uri="{FF2B5EF4-FFF2-40B4-BE49-F238E27FC236}">
-                <a16:creationId xmlns:a16="http://schemas.microsoft.com/office/drawing/2014/main" id="{7AE94604-D544-41DF-A0DF-DC057E7FF1AC}"/>
+                <a16:creationId xmlns:a16="http://schemas.microsoft.com/office/drawing/2014/main" id="{CD74B3E9-6B31-4C4E-A33F-B2A38A82E784}"/>
               </a:ext>
             </a:extLst>
           </p:cNvPr>
@@ -4852,7 +4852,7 @@
           <p:cNvPr id="3" name="Title">
             <a:extLst xmlns:a="http://schemas.openxmlformats.org/drawingml/2006/main">
               <a:ext uri="{FF2B5EF4-FFF2-40B4-BE49-F238E27FC236}">
-                <a16:creationId xmlns:a16="http://schemas.microsoft.com/office/drawing/2014/main" id="{52D3C4D7-0563-45C3-BE24-42B315BFF3DF}"/>
+                <a16:creationId xmlns:a16="http://schemas.microsoft.com/office/drawing/2014/main" id="{88D851D8-68DF-4EE2-AC62-76F983F5800C}"/>
               </a:ext>
             </a:extLst>
           </p:cNvPr>
@@ -5081,7 +5081,7 @@
           <p:cNvPr id="2" name="Left column">
             <a:extLst xmlns:a="http://schemas.openxmlformats.org/drawingml/2006/main">
               <a:ext uri="{FF2B5EF4-FFF2-40B4-BE49-F238E27FC236}">
-                <a16:creationId xmlns:a16="http://schemas.microsoft.com/office/drawing/2014/main" id="{F6838C4E-3A01-4DB3-92B1-9476BB0F7B19}"/>
+                <a16:creationId xmlns:a16="http://schemas.microsoft.com/office/drawing/2014/main" id="{8E3A6D66-9369-4C58-84F4-8560B59E8139}"/>
               </a:ext>
             </a:extLst>
           </p:cNvPr>
@@ -5348,12 +5348,12 @@
   </p:cSld>
   <p:clrMap bg1="lt1" tx1="dk1" bg2="lt2" tx2="dk2" accent1="accent1" accent2="accent2" accent3="accent3" accent4="accent4" accent5="accent5" accent6="accent6" hlink="hlink" folHlink="folHlink"/>
   <p:sldLayoutIdLst>
-    <p:sldLayoutId xmlns:r="http://schemas.openxmlformats.org/officeDocument/2006/relationships" id="2147483649" r:id="R760eeeebe00e4854"/>
-    <p:sldLayoutId xmlns:r="http://schemas.openxmlformats.org/officeDocument/2006/relationships" id="2147483650" r:id="Rb89cff5448d849ef"/>
-    <p:sldLayoutId xmlns:r="http://schemas.openxmlformats.org/officeDocument/2006/relationships" id="2147483651" r:id="R3869a27fa66c42ac"/>
-    <p:sldLayoutId xmlns:r="http://schemas.openxmlformats.org/officeDocument/2006/relationships" id="2147483652" r:id="R4ab4eb98220b4dd1"/>
-    <p:sldLayoutId xmlns:r="http://schemas.openxmlformats.org/officeDocument/2006/relationships" id="2147483653" r:id="R5fdcce939a084bb4"/>
-    <p:sldLayoutId xmlns:r="http://schemas.openxmlformats.org/officeDocument/2006/relationships" id="2147483654" r:id="Rd21e8ce8c73348d7"/>
+    <p:sldLayoutId xmlns:r="http://schemas.openxmlformats.org/officeDocument/2006/relationships" id="2147483649" r:id="R1dd30c3f689d42d0"/>
+    <p:sldLayoutId xmlns:r="http://schemas.openxmlformats.org/officeDocument/2006/relationships" id="2147483650" r:id="R2cc305f1172d4cbd"/>
+    <p:sldLayoutId xmlns:r="http://schemas.openxmlformats.org/officeDocument/2006/relationships" id="2147483651" r:id="Rfd57267e9f5b4719"/>
+    <p:sldLayoutId xmlns:r="http://schemas.openxmlformats.org/officeDocument/2006/relationships" id="2147483652" r:id="R36c2362580c74212"/>
+    <p:sldLayoutId xmlns:r="http://schemas.openxmlformats.org/officeDocument/2006/relationships" id="2147483653" r:id="Rca3dd13ee4b04884"/>
+    <p:sldLayoutId xmlns:r="http://schemas.openxmlformats.org/officeDocument/2006/relationships" id="2147483654" r:id="R61b6fa0bfb914156"/>
   </p:sldLayoutIdLst>
   <p:txStyles>
     <p:titleStyle>
@@ -5904,7 +5904,7 @@
           <p:cNvPr id="12" name="ACT 0 · 익숙한 사용에서 시작하기">
             <a:extLst xmlns:a="http://schemas.openxmlformats.org/drawingml/2006/main">
               <a:ext uri="{FF2B5EF4-FFF2-40B4-BE49-F238E27FC236}">
-                <a16:creationId xmlns:a16="http://schemas.microsoft.com/office/drawing/2014/main" id="{B0E71037-44E2-4D2E-860B-04216000CEFD}"/>
+                <a16:creationId xmlns:a16="http://schemas.microsoft.com/office/drawing/2014/main" id="{3AADC76C-115B-4BE9-9130-6D1CD354E8D6}"/>
               </a:ext>
             </a:extLst>
           </p:cNvPr>
@@ -6062,7 +6062,7 @@
           <p:cNvPr id="2" name="S01">
             <a:extLst xmlns:a="http://schemas.openxmlformats.org/drawingml/2006/main">
               <a:ext uri="{FF2B5EF4-FFF2-40B4-BE49-F238E27FC236}">
-                <a16:creationId xmlns:a16="http://schemas.microsoft.com/office/drawing/2014/main" id="{59EE76F0-CFBA-4037-9619-BDDA16E10F2E}"/>
+                <a16:creationId xmlns:a16="http://schemas.microsoft.com/office/drawing/2014/main" id="{7EFAB365-A79A-41EF-97C3-162460057F68}"/>
               </a:ext>
             </a:extLst>
           </p:cNvPr>
@@ -6220,7 +6220,7 @@
           <p:cNvPr id="3" name="AI에게 지금 무엇을 맡기고 있는가?">
             <a:extLst xmlns:a="http://schemas.openxmlformats.org/drawingml/2006/main">
               <a:ext uri="{FF2B5EF4-FFF2-40B4-BE49-F238E27FC236}">
-                <a16:creationId xmlns:a16="http://schemas.microsoft.com/office/drawing/2014/main" id="{A7591E0F-2ACF-4232-854E-4CECA34CFF12}"/>
+                <a16:creationId xmlns:a16="http://schemas.microsoft.com/office/drawing/2014/main" id="{A520DE28-90DE-4EC9-8CCA-141D5D04E140}"/>
               </a:ext>
             </a:extLst>
           </p:cNvPr>
@@ -6378,7 +6378,7 @@
           <p:cNvPr id="4" name="">
             <a:extLst xmlns:a="http://schemas.openxmlformats.org/drawingml/2006/main">
               <a:ext uri="{FF2B5EF4-FFF2-40B4-BE49-F238E27FC236}">
-                <a16:creationId xmlns:a16="http://schemas.microsoft.com/office/drawing/2014/main" id="{DAFEEFB8-FA25-4212-AFDA-69C9791B95DA}"/>
+                <a16:creationId xmlns:a16="http://schemas.microsoft.com/office/drawing/2014/main" id="{F64453AC-C2C0-42B1-9E36-FEB6956888D7}"/>
               </a:ext>
             </a:extLst>
           </p:cNvPr>
@@ -6409,7 +6409,7 @@
           <p:cNvPr id="5" name="생각해 보기 · 이 과정의 교육 모델">
             <a:extLst xmlns:a="http://schemas.openxmlformats.org/drawingml/2006/main">
               <a:ext uri="{FF2B5EF4-FFF2-40B4-BE49-F238E27FC236}">
-                <a16:creationId xmlns:a16="http://schemas.microsoft.com/office/drawing/2014/main" id="{D09B0A56-2E9C-4838-A214-BB8BD60F8E50}"/>
+                <a16:creationId xmlns:a16="http://schemas.microsoft.com/office/drawing/2014/main" id="{97F9F82F-E969-4E47-9227-07C2A1E89132}"/>
               </a:ext>
             </a:extLst>
           </p:cNvPr>
@@ -6567,7 +6567,7 @@
           <p:cNvPr id="6" name="자신의 경험 하나만 떠올려 보세요. 사용 수준을 평가하는 질문이 아닙니다.">
             <a:extLst xmlns:a="http://schemas.openxmlformats.org/drawingml/2006/main">
               <a:ext uri="{FF2B5EF4-FFF2-40B4-BE49-F238E27FC236}">
-                <a16:creationId xmlns:a16="http://schemas.microsoft.com/office/drawing/2014/main" id="{29AB6231-4CA2-4F31-A542-219CA173BE7C}"/>
+                <a16:creationId xmlns:a16="http://schemas.microsoft.com/office/drawing/2014/main" id="{70DD41FF-7C8B-43EE-8260-C733E67B2FB3}"/>
               </a:ext>
             </a:extLst>
           </p:cNvPr>
@@ -6725,7 +6725,7 @@
           <p:cNvPr id="7" name="가장 최근에 AI에게 맡긴 일 하나">
             <a:extLst xmlns:a="http://schemas.openxmlformats.org/drawingml/2006/main">
               <a:ext uri="{FF2B5EF4-FFF2-40B4-BE49-F238E27FC236}">
-                <a16:creationId xmlns:a16="http://schemas.microsoft.com/office/drawing/2014/main" id="{B626279D-700C-4752-AAB4-7BDE5B5A2E39}"/>
+                <a16:creationId xmlns:a16="http://schemas.microsoft.com/office/drawing/2014/main" id="{9266A557-7961-4CCD-A200-9AEFD59E0AC3}"/>
               </a:ext>
             </a:extLst>
           </p:cNvPr>
@@ -6883,7 +6883,7 @@
           <p:cNvPr id="8" name="오류 설명을 들었나요?&#10;관련 코드를 조사하게 했나요?&#10;수정한 결과까지 확인하게 했나요?">
             <a:extLst xmlns:a="http://schemas.openxmlformats.org/drawingml/2006/main">
               <a:ext uri="{FF2B5EF4-FFF2-40B4-BE49-F238E27FC236}">
-                <a16:creationId xmlns:a16="http://schemas.microsoft.com/office/drawing/2014/main" id="{1DE8D726-A6BB-47F9-B477-D7BAF21DD1C8}"/>
+                <a16:creationId xmlns:a16="http://schemas.microsoft.com/office/drawing/2014/main" id="{543B52AB-03DC-4BB6-BEA8-91006F8B70EF}"/>
               </a:ext>
             </a:extLst>
           </p:cNvPr>
@@ -7087,7 +7087,7 @@
           <p:cNvPr id="9" name="">
             <a:extLst xmlns:a="http://schemas.openxmlformats.org/drawingml/2006/main">
               <a:ext uri="{FF2B5EF4-FFF2-40B4-BE49-F238E27FC236}">
-                <a16:creationId xmlns:a16="http://schemas.microsoft.com/office/drawing/2014/main" id="{01CFB95B-5A7D-4FFD-AF8D-C853A8BFC425}"/>
+                <a16:creationId xmlns:a16="http://schemas.microsoft.com/office/drawing/2014/main" id="{8321A8C4-A43A-48FE-8727-57446498EE64}"/>
               </a:ext>
             </a:extLst>
           </p:cNvPr>
@@ -7118,7 +7118,7 @@
           <p:cNvPr id="10" name="질문 · 생성&#10;조사 · 변경&#10;검증 · 작업 방식 개선">
             <a:extLst xmlns:a="http://schemas.openxmlformats.org/drawingml/2006/main">
               <a:ext uri="{FF2B5EF4-FFF2-40B4-BE49-F238E27FC236}">
-                <a16:creationId xmlns:a16="http://schemas.microsoft.com/office/drawing/2014/main" id="{35CC1EAD-0ED3-4339-9252-D507E540DA1F}"/>
+                <a16:creationId xmlns:a16="http://schemas.microsoft.com/office/drawing/2014/main" id="{A1108B2E-2085-4886-9D5B-97B571FFB41A}"/>
               </a:ext>
             </a:extLst>
           </p:cNvPr>
@@ -7322,7 +7322,7 @@
           <p:cNvPr id="11" name="익숙한 방식에서 출발해도 괜찮습니다.">
             <a:extLst xmlns:a="http://schemas.openxmlformats.org/drawingml/2006/main">
               <a:ext uri="{FF2B5EF4-FFF2-40B4-BE49-F238E27FC236}">
-                <a16:creationId xmlns:a16="http://schemas.microsoft.com/office/drawing/2014/main" id="{6BA06903-C1D5-48A2-9443-AA6C6EB1384A}"/>
+                <a16:creationId xmlns:a16="http://schemas.microsoft.com/office/drawing/2014/main" id="{50535BAB-B021-4CB1-A957-C5F98E960515}"/>
               </a:ext>
             </a:extLst>
           </p:cNvPr>
@@ -7478,7 +7478,7 @@
     </p:spTree>
     <p:extLst>
       <p:ext uri="{BB962C8B-B14F-4D97-AF65-F5344CB8AC3E}">
-        <p14:creationId xmlns:p14="http://schemas.microsoft.com/office/powerpoint/2010/main" val="643857892"/>
+        <p14:creationId xmlns:p14="http://schemas.microsoft.com/office/powerpoint/2010/main" val="1770550529"/>
       </p:ext>
     </p:extLst>
   </p:cSld>
@@ -7509,7 +7509,7 @@
           <p:cNvPr id="23" name="ACT 0 · 작은 코드 질문">
             <a:extLst xmlns:a="http://schemas.openxmlformats.org/drawingml/2006/main">
               <a:ext uri="{FF2B5EF4-FFF2-40B4-BE49-F238E27FC236}">
-                <a16:creationId xmlns:a16="http://schemas.microsoft.com/office/drawing/2014/main" id="{D4250985-CFB0-4A92-A960-7C2CA8A7356B}"/>
+                <a16:creationId xmlns:a16="http://schemas.microsoft.com/office/drawing/2014/main" id="{BEBA06D7-3F2E-4934-86D1-08852A8C7A7F}"/>
               </a:ext>
             </a:extLst>
           </p:cNvPr>
@@ -7667,7 +7667,7 @@
           <p:cNvPr id="2" name="S02">
             <a:extLst xmlns:a="http://schemas.openxmlformats.org/drawingml/2006/main">
               <a:ext uri="{FF2B5EF4-FFF2-40B4-BE49-F238E27FC236}">
-                <a16:creationId xmlns:a16="http://schemas.microsoft.com/office/drawing/2014/main" id="{F833CB1B-8FC1-4516-8417-CE54F25AF518}"/>
+                <a16:creationId xmlns:a16="http://schemas.microsoft.com/office/drawing/2014/main" id="{926FE628-6FAA-47C8-A570-92C8047C4ED9}"/>
               </a:ext>
             </a:extLst>
           </p:cNvPr>
@@ -7825,7 +7825,7 @@
           <p:cNvPr id="3" name="작은 질문에는 Chatbot이 유용하다">
             <a:extLst xmlns:a="http://schemas.openxmlformats.org/drawingml/2006/main">
               <a:ext uri="{FF2B5EF4-FFF2-40B4-BE49-F238E27FC236}">
-                <a16:creationId xmlns:a16="http://schemas.microsoft.com/office/drawing/2014/main" id="{E0AE5EA2-A16F-461A-B92D-85C55D3AA66F}"/>
+                <a16:creationId xmlns:a16="http://schemas.microsoft.com/office/drawing/2014/main" id="{03200FD3-10C7-45C0-8B7C-1553DEEEBAC5}"/>
               </a:ext>
             </a:extLst>
           </p:cNvPr>
@@ -7983,7 +7983,7 @@
           <p:cNvPr id="4" name="">
             <a:extLst xmlns:a="http://schemas.openxmlformats.org/drawingml/2006/main">
               <a:ext uri="{FF2B5EF4-FFF2-40B4-BE49-F238E27FC236}">
-                <a16:creationId xmlns:a16="http://schemas.microsoft.com/office/drawing/2014/main" id="{EAD31D19-9B29-40A2-80FD-0CE6C8E02B41}"/>
+                <a16:creationId xmlns:a16="http://schemas.microsoft.com/office/drawing/2014/main" id="{CAF9C324-2E45-469B-A91B-A36186107488}"/>
               </a:ext>
             </a:extLst>
           </p:cNvPr>
@@ -8014,7 +8014,7 @@
           <p:cNvPr id="5" name="교육용 예시 · 실제 ChatGPT 대화 캡처가 아님">
             <a:extLst xmlns:a="http://schemas.openxmlformats.org/drawingml/2006/main">
               <a:ext uri="{FF2B5EF4-FFF2-40B4-BE49-F238E27FC236}">
-                <a16:creationId xmlns:a16="http://schemas.microsoft.com/office/drawing/2014/main" id="{19727E38-45C0-4ABD-BFC9-47FE8178C40E}"/>
+                <a16:creationId xmlns:a16="http://schemas.microsoft.com/office/drawing/2014/main" id="{EE4C7340-1CDD-4F5E-860C-408D2E6A74AF}"/>
               </a:ext>
             </a:extLst>
           </p:cNvPr>
@@ -8172,7 +8172,7 @@
           <p:cNvPr id="6" name="일반적인 질문 흐름을 설명하며 특정 제품의 정확도나 우월성을 주장하지 않습니다.">
             <a:extLst xmlns:a="http://schemas.openxmlformats.org/drawingml/2006/main">
               <a:ext uri="{FF2B5EF4-FFF2-40B4-BE49-F238E27FC236}">
-                <a16:creationId xmlns:a16="http://schemas.microsoft.com/office/drawing/2014/main" id="{A34330F6-4345-4B40-8A49-0DE5010FA880}"/>
+                <a16:creationId xmlns:a16="http://schemas.microsoft.com/office/drawing/2014/main" id="{8D9F09A3-5424-4E24-8688-596EFD79E272}"/>
               </a:ext>
             </a:extLst>
           </p:cNvPr>
@@ -8330,7 +8330,7 @@
           <p:cNvPr id="7" name="“이 코드에서 무엇이 남을까?”">
             <a:extLst xmlns:a="http://schemas.openxmlformats.org/drawingml/2006/main">
               <a:ext uri="{FF2B5EF4-FFF2-40B4-BE49-F238E27FC236}">
-                <a16:creationId xmlns:a16="http://schemas.microsoft.com/office/drawing/2014/main" id="{F9383DBB-ACEC-432B-97F7-21C79447C244}"/>
+                <a16:creationId xmlns:a16="http://schemas.microsoft.com/office/drawing/2014/main" id="{50701A39-18B7-4115-815A-FDEA1C0AC53C}"/>
               </a:ext>
             </a:extLst>
           </p:cNvPr>
@@ -8488,7 +8488,7 @@
           <p:cNvPr id="8" name="">
             <a:extLst xmlns:a="http://schemas.openxmlformats.org/drawingml/2006/main">
               <a:ext uri="{FF2B5EF4-FFF2-40B4-BE49-F238E27FC236}">
-                <a16:creationId xmlns:a16="http://schemas.microsoft.com/office/drawing/2014/main" id="{3849AAD5-1CA3-49EB-8D83-EECB17F88314}"/>
+                <a16:creationId xmlns:a16="http://schemas.microsoft.com/office/drawing/2014/main" id="{C9D9B71C-836D-40B9-A45B-F0967E73A7F1}"/>
               </a:ext>
             </a:extLst>
           </p:cNvPr>
@@ -8519,7 +8519,7 @@
           <p:cNvPr id="9" name="row = [1, 2, 3, 4]&#10;row[1:3]">
             <a:extLst xmlns:a="http://schemas.openxmlformats.org/drawingml/2006/main">
               <a:ext uri="{FF2B5EF4-FFF2-40B4-BE49-F238E27FC236}">
-                <a16:creationId xmlns:a16="http://schemas.microsoft.com/office/drawing/2014/main" id="{86BD8B17-4C87-47E7-BE95-4497D634CB2C}"/>
+                <a16:creationId xmlns:a16="http://schemas.microsoft.com/office/drawing/2014/main" id="{A4BC6C82-CD1A-4DD7-944A-726DDAA80989}"/>
               </a:ext>
             </a:extLst>
           </p:cNvPr>
@@ -8700,7 +8700,7 @@
           <p:cNvPr id="10" name="">
             <a:extLst xmlns:a="http://schemas.openxmlformats.org/drawingml/2006/main">
               <a:ext uri="{FF2B5EF4-FFF2-40B4-BE49-F238E27FC236}">
-                <a16:creationId xmlns:a16="http://schemas.microsoft.com/office/drawing/2014/main" id="{3058AC4F-325A-440C-BB96-31818B32CDAC}"/>
+                <a16:creationId xmlns:a16="http://schemas.microsoft.com/office/drawing/2014/main" id="{222CCAD9-39F6-48D7-AA4F-4FE617CBE691}"/>
               </a:ext>
             </a:extLst>
           </p:cNvPr>
@@ -8730,7 +8730,7 @@
           <p:cNvPr id="11" name="[2, 3]">
             <a:extLst xmlns:a="http://schemas.openxmlformats.org/drawingml/2006/main">
               <a:ext uri="{FF2B5EF4-FFF2-40B4-BE49-F238E27FC236}">
-                <a16:creationId xmlns:a16="http://schemas.microsoft.com/office/drawing/2014/main" id="{7822315C-5EBF-4165-A77B-6BF8FE925D68}"/>
+                <a16:creationId xmlns:a16="http://schemas.microsoft.com/office/drawing/2014/main" id="{391FFD42-398B-4CFE-9C2A-12226C9E0A15}"/>
               </a:ext>
             </a:extLst>
           </p:cNvPr>
@@ -8888,7 +8888,7 @@
           <p:cNvPr id="12" name="끝 index 3은 포함하지 않습니다.">
             <a:extLst xmlns:a="http://schemas.openxmlformats.org/drawingml/2006/main">
               <a:ext uri="{FF2B5EF4-FFF2-40B4-BE49-F238E27FC236}">
-                <a16:creationId xmlns:a16="http://schemas.microsoft.com/office/drawing/2014/main" id="{1A55F59F-11E1-4D3E-A84E-77D28E48229D}"/>
+                <a16:creationId xmlns:a16="http://schemas.microsoft.com/office/drawing/2014/main" id="{8507E433-182A-4CDE-90E7-EF5F1963B649}"/>
               </a:ext>
             </a:extLst>
           </p:cNvPr>
@@ -9046,7 +9046,7 @@
           <p:cNvPr id="13" name="코드·오류">
             <a:extLst xmlns:a="http://schemas.openxmlformats.org/drawingml/2006/main">
               <a:ext uri="{FF2B5EF4-FFF2-40B4-BE49-F238E27FC236}">
-                <a16:creationId xmlns:a16="http://schemas.microsoft.com/office/drawing/2014/main" id="{E4446420-ECBA-48F7-BA36-A13D344AA09C}"/>
+                <a16:creationId xmlns:a16="http://schemas.microsoft.com/office/drawing/2014/main" id="{F88AB9CB-B7FC-4A71-9422-B85DE9D96010}"/>
               </a:ext>
             </a:extLst>
           </p:cNvPr>
@@ -9204,7 +9204,7 @@
           <p:cNvPr id="14" name="">
             <a:extLst xmlns:a="http://schemas.openxmlformats.org/drawingml/2006/main">
               <a:ext uri="{FF2B5EF4-FFF2-40B4-BE49-F238E27FC236}">
-                <a16:creationId xmlns:a16="http://schemas.microsoft.com/office/drawing/2014/main" id="{35989B9F-9C4C-45FA-927E-274982805298}"/>
+                <a16:creationId xmlns:a16="http://schemas.microsoft.com/office/drawing/2014/main" id="{6105A4C2-4977-4DE7-BEF9-FD86090CD94D}"/>
               </a:ext>
             </a:extLst>
           </p:cNvPr>
@@ -9234,7 +9234,7 @@
           <p:cNvPr id="15" name="복사">
             <a:extLst xmlns:a="http://schemas.openxmlformats.org/drawingml/2006/main">
               <a:ext uri="{FF2B5EF4-FFF2-40B4-BE49-F238E27FC236}">
-                <a16:creationId xmlns:a16="http://schemas.microsoft.com/office/drawing/2014/main" id="{F85ED7BB-4F8E-483C-92C7-ED71A02CF75E}"/>
+                <a16:creationId xmlns:a16="http://schemas.microsoft.com/office/drawing/2014/main" id="{3C19579A-F62E-47CD-8A93-180E78509BB9}"/>
               </a:ext>
             </a:extLst>
           </p:cNvPr>
@@ -9392,7 +9392,7 @@
           <p:cNvPr id="16" name="">
             <a:extLst xmlns:a="http://schemas.openxmlformats.org/drawingml/2006/main">
               <a:ext uri="{FF2B5EF4-FFF2-40B4-BE49-F238E27FC236}">
-                <a16:creationId xmlns:a16="http://schemas.microsoft.com/office/drawing/2014/main" id="{8B41D2D2-71DF-47DB-96BA-A5879297188C}"/>
+                <a16:creationId xmlns:a16="http://schemas.microsoft.com/office/drawing/2014/main" id="{210B8E70-A9BA-4F71-B2B9-0CB8E6364F08}"/>
               </a:ext>
             </a:extLst>
           </p:cNvPr>
@@ -9422,7 +9422,7 @@
           <p:cNvPr id="17" name="질문">
             <a:extLst xmlns:a="http://schemas.openxmlformats.org/drawingml/2006/main">
               <a:ext uri="{FF2B5EF4-FFF2-40B4-BE49-F238E27FC236}">
-                <a16:creationId xmlns:a16="http://schemas.microsoft.com/office/drawing/2014/main" id="{13E48595-F03E-4F16-804C-5C1ECCADA6A7}"/>
+                <a16:creationId xmlns:a16="http://schemas.microsoft.com/office/drawing/2014/main" id="{3233FB2F-01E3-4B4A-8EED-C46CB86E69DF}"/>
               </a:ext>
             </a:extLst>
           </p:cNvPr>
@@ -9580,7 +9580,7 @@
           <p:cNvPr id="18" name="">
             <a:extLst xmlns:a="http://schemas.openxmlformats.org/drawingml/2006/main">
               <a:ext uri="{FF2B5EF4-FFF2-40B4-BE49-F238E27FC236}">
-                <a16:creationId xmlns:a16="http://schemas.microsoft.com/office/drawing/2014/main" id="{2F5D97A5-BB1D-4BD3-89F4-FAABC382A967}"/>
+                <a16:creationId xmlns:a16="http://schemas.microsoft.com/office/drawing/2014/main" id="{278BC83E-DFD6-4EC1-8287-61E774DB8913}"/>
               </a:ext>
             </a:extLst>
           </p:cNvPr>
@@ -9610,7 +9610,7 @@
           <p:cNvPr id="19" name="답 확인">
             <a:extLst xmlns:a="http://schemas.openxmlformats.org/drawingml/2006/main">
               <a:ext uri="{FF2B5EF4-FFF2-40B4-BE49-F238E27FC236}">
-                <a16:creationId xmlns:a16="http://schemas.microsoft.com/office/drawing/2014/main" id="{E441FCA2-2E19-4B2C-B8B1-DD0E19724CE7}"/>
+                <a16:creationId xmlns:a16="http://schemas.microsoft.com/office/drawing/2014/main" id="{2305953F-269F-4778-8242-37A9DE8B2C52}"/>
               </a:ext>
             </a:extLst>
           </p:cNvPr>
@@ -9768,7 +9768,7 @@
           <p:cNvPr id="20" name="">
             <a:extLst xmlns:a="http://schemas.openxmlformats.org/drawingml/2006/main">
               <a:ext uri="{FF2B5EF4-FFF2-40B4-BE49-F238E27FC236}">
-                <a16:creationId xmlns:a16="http://schemas.microsoft.com/office/drawing/2014/main" id="{F240AE65-6744-4A7B-B356-7FAED59A57EA}"/>
+                <a16:creationId xmlns:a16="http://schemas.microsoft.com/office/drawing/2014/main" id="{B8FE87B7-1412-4677-80C0-DEAEA6D2A43A}"/>
               </a:ext>
             </a:extLst>
           </p:cNvPr>
@@ -9798,7 +9798,7 @@
           <p:cNvPr id="21" name="IDE로 복귀">
             <a:extLst xmlns:a="http://schemas.openxmlformats.org/drawingml/2006/main">
               <a:ext uri="{FF2B5EF4-FFF2-40B4-BE49-F238E27FC236}">
-                <a16:creationId xmlns:a16="http://schemas.microsoft.com/office/drawing/2014/main" id="{B47814E5-7E72-4625-827B-2EB24A04D2BA}"/>
+                <a16:creationId xmlns:a16="http://schemas.microsoft.com/office/drawing/2014/main" id="{537E04CE-794C-4C03-8D42-915BF356DB9B}"/>
               </a:ext>
             </a:extLst>
           </p:cNvPr>
@@ -9956,7 +9956,7 @@
           <p:cNvPr id="22" name="">
             <a:extLst xmlns:a="http://schemas.openxmlformats.org/drawingml/2006/main">
               <a:ext uri="{FF2B5EF4-FFF2-40B4-BE49-F238E27FC236}">
-                <a16:creationId xmlns:a16="http://schemas.microsoft.com/office/drawing/2014/main" id="{89C19AF1-013B-4FC6-897A-608504B363F4}"/>
+                <a16:creationId xmlns:a16="http://schemas.microsoft.com/office/drawing/2014/main" id="{1D0BEBEC-B96D-4BF4-85C4-691D1952DAF4}"/>
               </a:ext>
             </a:extLst>
           </p:cNvPr>
@@ -9985,7 +9985,7 @@
     </p:spTree>
     <p:extLst>
       <p:ext uri="{BB962C8B-B14F-4D97-AF65-F5344CB8AC3E}">
-        <p14:creationId xmlns:p14="http://schemas.microsoft.com/office/powerpoint/2010/main" val="1296655413"/>
+        <p14:creationId xmlns:p14="http://schemas.microsoft.com/office/powerpoint/2010/main" val="1781120492"/>
       </p:ext>
     </p:extLst>
   </p:cSld>
@@ -10016,7 +10016,7 @@
           <p:cNvPr id="16" name="ACT 0 · 여러 파일을 가로지르는 질문">
             <a:extLst xmlns:a="http://schemas.openxmlformats.org/drawingml/2006/main">
               <a:ext uri="{FF2B5EF4-FFF2-40B4-BE49-F238E27FC236}">
-                <a16:creationId xmlns:a16="http://schemas.microsoft.com/office/drawing/2014/main" id="{781825B7-CD47-46B0-B733-1B345B946DD4}"/>
+                <a16:creationId xmlns:a16="http://schemas.microsoft.com/office/drawing/2014/main" id="{E32EC5B5-CF0B-4E9C-9FF0-08D3CB3ED87E}"/>
               </a:ext>
             </a:extLst>
           </p:cNvPr>
@@ -10174,7 +10174,7 @@
           <p:cNvPr id="2" name="S03">
             <a:extLst xmlns:a="http://schemas.openxmlformats.org/drawingml/2006/main">
               <a:ext uri="{FF2B5EF4-FFF2-40B4-BE49-F238E27FC236}">
-                <a16:creationId xmlns:a16="http://schemas.microsoft.com/office/drawing/2014/main" id="{AE7B40F9-66F0-4FA4-B61E-97F81955E77B}"/>
+                <a16:creationId xmlns:a16="http://schemas.microsoft.com/office/drawing/2014/main" id="{1D02F321-B9EF-4624-BC85-F4C866873794}"/>
               </a:ext>
             </a:extLst>
           </p:cNvPr>
@@ -10332,7 +10332,7 @@
           <p:cNvPr id="3" name="질문이 커지면 Context를 모으는 일이 생긴다">
             <a:extLst xmlns:a="http://schemas.openxmlformats.org/drawingml/2006/main">
               <a:ext uri="{FF2B5EF4-FFF2-40B4-BE49-F238E27FC236}">
-                <a16:creationId xmlns:a16="http://schemas.microsoft.com/office/drawing/2014/main" id="{94C7CC41-B3FC-48B1-BA09-A4DACA1BCE2E}"/>
+                <a16:creationId xmlns:a16="http://schemas.microsoft.com/office/drawing/2014/main" id="{DA9FE124-4AA4-4DD8-9D1D-6BBA2733E8C2}"/>
               </a:ext>
             </a:extLst>
           </p:cNvPr>
@@ -10490,7 +10490,7 @@
           <p:cNvPr id="4" name="">
             <a:extLst xmlns:a="http://schemas.openxmlformats.org/drawingml/2006/main">
               <a:ext uri="{FF2B5EF4-FFF2-40B4-BE49-F238E27FC236}">
-                <a16:creationId xmlns:a16="http://schemas.microsoft.com/office/drawing/2014/main" id="{075B7535-7053-4A2D-BA25-5E08B61484B7}"/>
+                <a16:creationId xmlns:a16="http://schemas.microsoft.com/office/drawing/2014/main" id="{9C059CC0-A021-4F04-8FAC-A8A186D21797}"/>
               </a:ext>
             </a:extLst>
           </p:cNvPr>
@@ -10521,7 +10521,7 @@
           <p:cNvPr id="5" name="개념 사례 · 사람이 Context를 모으는 장면 · AI 생성 설명용 삽화">
             <a:extLst xmlns:a="http://schemas.openxmlformats.org/drawingml/2006/main">
               <a:ext uri="{FF2B5EF4-FFF2-40B4-BE49-F238E27FC236}">
-                <a16:creationId xmlns:a16="http://schemas.microsoft.com/office/drawing/2014/main" id="{541EAB7A-5813-478E-94B8-AF2FD15FAA17}"/>
+                <a16:creationId xmlns:a16="http://schemas.microsoft.com/office/drawing/2014/main" id="{4BF4598B-2D02-4CBF-BBBB-89E9502D0ED1}"/>
               </a:ext>
             </a:extLst>
           </p:cNvPr>
@@ -10679,7 +10679,7 @@
           <p:cNvPr id="6" name="특정 Trial에서 실제로 발생한 비용이나 실패를 뜻하지 않습니다.">
             <a:extLst xmlns:a="http://schemas.openxmlformats.org/drawingml/2006/main">
               <a:ext uri="{FF2B5EF4-FFF2-40B4-BE49-F238E27FC236}">
-                <a16:creationId xmlns:a16="http://schemas.microsoft.com/office/drawing/2014/main" id="{DCD3D4E0-B37F-4520-8ED4-98DD98DA571E}"/>
+                <a16:creationId xmlns:a16="http://schemas.microsoft.com/office/drawing/2014/main" id="{DD846C2A-6C66-4ED5-B225-69533FEAFC98}"/>
               </a:ext>
             </a:extLst>
           </p:cNvPr>
@@ -10837,7 +10837,7 @@
           <p:cNvPr id="7" name="“CLI 결과가 기대와 다른데, 어디서부터 봐야 할까?”">
             <a:extLst xmlns:a="http://schemas.openxmlformats.org/drawingml/2006/main">
               <a:ext uri="{FF2B5EF4-FFF2-40B4-BE49-F238E27FC236}">
-                <a16:creationId xmlns:a16="http://schemas.microsoft.com/office/drawing/2014/main" id="{8EDAF773-7FA9-474E-ADC3-11D3E5E7312E}"/>
+                <a16:creationId xmlns:a16="http://schemas.microsoft.com/office/drawing/2014/main" id="{17B68042-9365-493C-96BE-D75113A01E06}"/>
               </a:ext>
             </a:extLst>
           </p:cNvPr>
@@ -10995,7 +10995,7 @@
           <p:cNvPr id="8" name="">
             <a:extLst xmlns:a="http://schemas.openxmlformats.org/drawingml/2006/main">
               <a:ext uri="{FF2B5EF4-FFF2-40B4-BE49-F238E27FC236}">
-                <a16:creationId xmlns:a16="http://schemas.microsoft.com/office/drawing/2014/main" id="{2AA22F74-7536-423C-AEBC-5068EC2724BD}"/>
+                <a16:creationId xmlns:a16="http://schemas.microsoft.com/office/drawing/2014/main" id="{90F3B1DB-7BF8-472E-957A-BBC35327AFF1}"/>
               </a:ext>
             </a:extLst>
           </p:cNvPr>
@@ -11005,7 +11005,7 @@
           <p:nvPr/>
         </p:nvPicPr>
         <p:blipFill>
-          <a:blip xmlns:r="http://schemas.openxmlformats.org/officeDocument/2006/relationships" xmlns:a="http://schemas.openxmlformats.org/drawingml/2006/main" r:embed="Rb22c8ee1771e477c"/>
+          <a:blip xmlns:r="http://schemas.openxmlformats.org/officeDocument/2006/relationships" xmlns:a="http://schemas.openxmlformats.org/drawingml/2006/main" r:embed="R34c67a750acc4c48"/>
           <a:stretch xmlns:a="http://schemas.openxmlformats.org/drawingml/2006/main"/>
         </p:blipFill>
         <p:spPr>
@@ -11023,7 +11023,7 @@
           <p:cNvPr id="9" name="구현 · 호출 경로">
             <a:extLst xmlns:a="http://schemas.openxmlformats.org/drawingml/2006/main">
               <a:ext uri="{FF2B5EF4-FFF2-40B4-BE49-F238E27FC236}">
-                <a16:creationId xmlns:a16="http://schemas.microsoft.com/office/drawing/2014/main" id="{D3C7E384-8480-4F02-B736-C696FA471798}"/>
+                <a16:creationId xmlns:a16="http://schemas.microsoft.com/office/drawing/2014/main" id="{98092A52-5B30-4E66-B1FC-0D1353EB61BD}"/>
               </a:ext>
             </a:extLst>
           </p:cNvPr>
@@ -11181,7 +11181,7 @@
           <p:cNvPr id="10" name="CLI → 처리 흐름 → 연산">
             <a:extLst xmlns:a="http://schemas.openxmlformats.org/drawingml/2006/main">
               <a:ext uri="{FF2B5EF4-FFF2-40B4-BE49-F238E27FC236}">
-                <a16:creationId xmlns:a16="http://schemas.microsoft.com/office/drawing/2014/main" id="{441122E2-36AD-48F3-AD62-320CAF13F242}"/>
+                <a16:creationId xmlns:a16="http://schemas.microsoft.com/office/drawing/2014/main" id="{E1E24024-4084-43A0-889F-C73414A8559C}"/>
               </a:ext>
             </a:extLst>
           </p:cNvPr>
@@ -11339,7 +11339,7 @@
           <p:cNvPr id="11" name="테스트">
             <a:extLst xmlns:a="http://schemas.openxmlformats.org/drawingml/2006/main">
               <a:ext uri="{FF2B5EF4-FFF2-40B4-BE49-F238E27FC236}">
-                <a16:creationId xmlns:a16="http://schemas.microsoft.com/office/drawing/2014/main" id="{5C76FA18-B0E2-44DE-A22C-862857DA2208}"/>
+                <a16:creationId xmlns:a16="http://schemas.microsoft.com/office/drawing/2014/main" id="{DD485D76-4658-4F44-824F-FDCB8506B220}"/>
               </a:ext>
             </a:extLst>
           </p:cNvPr>
@@ -11497,7 +11497,7 @@
           <p:cNvPr id="12" name="어떤 조건에서 실패했나?">
             <a:extLst xmlns:a="http://schemas.openxmlformats.org/drawingml/2006/main">
               <a:ext uri="{FF2B5EF4-FFF2-40B4-BE49-F238E27FC236}">
-                <a16:creationId xmlns:a16="http://schemas.microsoft.com/office/drawing/2014/main" id="{2DD66CC1-4CC6-427C-98E8-053F1B7DAD19}"/>
+                <a16:creationId xmlns:a16="http://schemas.microsoft.com/office/drawing/2014/main" id="{10BC8032-4C71-4614-9ECE-2BCC52EAE42C}"/>
               </a:ext>
             </a:extLst>
           </p:cNvPr>
@@ -11655,7 +11655,7 @@
           <p:cNvPr id="13" name="계약">
             <a:extLst xmlns:a="http://schemas.openxmlformats.org/drawingml/2006/main">
               <a:ext uri="{FF2B5EF4-FFF2-40B4-BE49-F238E27FC236}">
-                <a16:creationId xmlns:a16="http://schemas.microsoft.com/office/drawing/2014/main" id="{0EA742D7-BE50-4A05-B050-972CBD2F5559}"/>
+                <a16:creationId xmlns:a16="http://schemas.microsoft.com/office/drawing/2014/main" id="{0C29D29D-97C8-4E47-B063-87429B734E45}"/>
               </a:ext>
             </a:extLst>
           </p:cNvPr>
@@ -11813,7 +11813,7 @@
           <p:cNvPr id="14" name="원래 기대한 동작은?">
             <a:extLst xmlns:a="http://schemas.openxmlformats.org/drawingml/2006/main">
               <a:ext uri="{FF2B5EF4-FFF2-40B4-BE49-F238E27FC236}">
-                <a16:creationId xmlns:a16="http://schemas.microsoft.com/office/drawing/2014/main" id="{692B0987-0C2D-4554-94FA-B65F08A0A9B6}"/>
+                <a16:creationId xmlns:a16="http://schemas.microsoft.com/office/drawing/2014/main" id="{A971205B-F7B8-4129-BA44-727F9BC1FDF5}"/>
               </a:ext>
             </a:extLst>
           </p:cNvPr>
@@ -11971,7 +11971,7 @@
           <p:cNvPr id="15" name="질문에 옮길 자료는?">
             <a:extLst xmlns:a="http://schemas.openxmlformats.org/drawingml/2006/main">
               <a:ext uri="{FF2B5EF4-FFF2-40B4-BE49-F238E27FC236}">
-                <a16:creationId xmlns:a16="http://schemas.microsoft.com/office/drawing/2014/main" id="{CC3D8A4F-4D56-4AA1-BB78-2FF306FBD3B8}"/>
+                <a16:creationId xmlns:a16="http://schemas.microsoft.com/office/drawing/2014/main" id="{1DCB780E-1F07-4E22-821A-E042F687EB5E}"/>
               </a:ext>
             </a:extLst>
           </p:cNvPr>
@@ -12127,7 +12127,7 @@
     </p:spTree>
     <p:extLst>
       <p:ext uri="{BB962C8B-B14F-4D97-AF65-F5344CB8AC3E}">
-        <p14:creationId xmlns:p14="http://schemas.microsoft.com/office/powerpoint/2010/main" val="1902386995"/>
+        <p14:creationId xmlns:p14="http://schemas.microsoft.com/office/powerpoint/2010/main" val="495378236"/>
       </p:ext>
     </p:extLst>
   </p:cSld>
@@ -12158,7 +12158,7 @@
           <p:cNvPr id="13" name="ACT 0 · Repository 조사 관찰">
             <a:extLst xmlns:a="http://schemas.openxmlformats.org/drawingml/2006/main">
               <a:ext uri="{FF2B5EF4-FFF2-40B4-BE49-F238E27FC236}">
-                <a16:creationId xmlns:a16="http://schemas.microsoft.com/office/drawing/2014/main" id="{64525698-0BA4-4BB9-AED6-BDD0E969701C}"/>
+                <a16:creationId xmlns:a16="http://schemas.microsoft.com/office/drawing/2014/main" id="{FDEDE37D-6F6A-46EF-A169-739CD4FD124A}"/>
               </a:ext>
             </a:extLst>
           </p:cNvPr>
@@ -12316,7 +12316,7 @@
           <p:cNvPr id="2" name="S04">
             <a:extLst xmlns:a="http://schemas.openxmlformats.org/drawingml/2006/main">
               <a:ext uri="{FF2B5EF4-FFF2-40B4-BE49-F238E27FC236}">
-                <a16:creationId xmlns:a16="http://schemas.microsoft.com/office/drawing/2014/main" id="{43C75485-654E-4921-BA76-ACBAB8B17686}"/>
+                <a16:creationId xmlns:a16="http://schemas.microsoft.com/office/drawing/2014/main" id="{FD7A7D32-827F-4CA3-BCAA-F5EAC5096B11}"/>
               </a:ext>
             </a:extLst>
           </p:cNvPr>
@@ -12474,7 +12474,7 @@
           <p:cNvPr id="3" name="파일명을 주지 않으면 Agent는 어디부터 볼까?">
             <a:extLst xmlns:a="http://schemas.openxmlformats.org/drawingml/2006/main">
               <a:ext uri="{FF2B5EF4-FFF2-40B4-BE49-F238E27FC236}">
-                <a16:creationId xmlns:a16="http://schemas.microsoft.com/office/drawing/2014/main" id="{9AB6660D-08AF-4F9A-A7E3-0C666C9F706D}"/>
+                <a16:creationId xmlns:a16="http://schemas.microsoft.com/office/drawing/2014/main" id="{2BC2B3E5-0697-467C-BA80-B3F00F85FD0B}"/>
               </a:ext>
             </a:extLst>
           </p:cNvPr>
@@ -12632,7 +12632,7 @@
           <p:cNvPr id="4" name="">
             <a:extLst xmlns:a="http://schemas.openxmlformats.org/drawingml/2006/main">
               <a:ext uri="{FF2B5EF4-FFF2-40B4-BE49-F238E27FC236}">
-                <a16:creationId xmlns:a16="http://schemas.microsoft.com/office/drawing/2014/main" id="{48408277-3ED1-4588-B6BC-985825F5AD0A}"/>
+                <a16:creationId xmlns:a16="http://schemas.microsoft.com/office/drawing/2014/main" id="{10BCA94E-8DD7-4897-AC34-1F4F9A9CF783}"/>
               </a:ext>
             </a:extLst>
           </p:cNvPr>
@@ -12663,7 +12663,7 @@
           <p:cNvPr id="5" name="TRIAL-001 실제 요청 발췌 · Codex CLI 0.154.0 · macOS · 읽기 전용">
             <a:extLst xmlns:a="http://schemas.openxmlformats.org/drawingml/2006/main">
               <a:ext uri="{FF2B5EF4-FFF2-40B4-BE49-F238E27FC236}">
-                <a16:creationId xmlns:a16="http://schemas.microsoft.com/office/drawing/2014/main" id="{7765DBDE-DF08-4930-8B87-5D9E045F3C67}"/>
+                <a16:creationId xmlns:a16="http://schemas.microsoft.com/office/drawing/2014/main" id="{94F4925B-2E64-4FD2-B4D0-AE2280B48953}"/>
               </a:ext>
             </a:extLst>
           </p:cNvPr>
@@ -12821,7 +12821,7 @@
           <p:cNvPr id="6" name="과거 단일 실행의 기록을 살펴봅니다. 현재 Desktop 동작은 미검증입니다.">
             <a:extLst xmlns:a="http://schemas.openxmlformats.org/drawingml/2006/main">
               <a:ext uri="{FF2B5EF4-FFF2-40B4-BE49-F238E27FC236}">
-                <a16:creationId xmlns:a16="http://schemas.microsoft.com/office/drawing/2014/main" id="{1E85B68D-C84E-4C61-B32A-7998B8046285}"/>
+                <a16:creationId xmlns:a16="http://schemas.microsoft.com/office/drawing/2014/main" id="{1B9E8C22-EEAD-405E-AE1D-2C73081E0E3E}"/>
               </a:ext>
             </a:extLst>
           </p:cNvPr>
@@ -12979,7 +12979,7 @@
           <p:cNvPr id="7" name="“현재 이 저장소에서 테스트 하나가 실패하고 있다.&#10;실패 원인을 조사해줘. 관련 구현과 호출 경로,&#10;실패하는">
             <a:extLst xmlns:a="http://schemas.openxmlformats.org/drawingml/2006/main">
               <a:ext uri="{FF2B5EF4-FFF2-40B4-BE49-F238E27FC236}">
-                <a16:creationId xmlns:a16="http://schemas.microsoft.com/office/drawing/2014/main" id="{319D54FC-592C-4BAF-A0DC-7AB02C28A735}"/>
+                <a16:creationId xmlns:a16="http://schemas.microsoft.com/office/drawing/2014/main" id="{541A9946-A504-4F48-90F4-12D8CEF434FC}"/>
               </a:ext>
             </a:extLst>
           </p:cNvPr>
@@ -13206,7 +13206,7 @@
           <p:cNvPr id="8" name="">
             <a:extLst xmlns:a="http://schemas.openxmlformats.org/drawingml/2006/main">
               <a:ext uri="{FF2B5EF4-FFF2-40B4-BE49-F238E27FC236}">
-                <a16:creationId xmlns:a16="http://schemas.microsoft.com/office/drawing/2014/main" id="{AC2FEBAD-8ACB-46DE-91B8-1141D0CADE1B}"/>
+                <a16:creationId xmlns:a16="http://schemas.microsoft.com/office/drawing/2014/main" id="{6BF05883-528A-42D0-BB13-FA7BAD6D515B}"/>
               </a:ext>
             </a:extLst>
           </p:cNvPr>
@@ -13237,7 +13237,7 @@
           <p:cNvPr id="9" name="찾았는지 확인할 세 가지">
             <a:extLst xmlns:a="http://schemas.openxmlformats.org/drawingml/2006/main">
               <a:ext uri="{FF2B5EF4-FFF2-40B4-BE49-F238E27FC236}">
-                <a16:creationId xmlns:a16="http://schemas.microsoft.com/office/drawing/2014/main" id="{CC293402-743A-4E45-B286-308433944C37}"/>
+                <a16:creationId xmlns:a16="http://schemas.microsoft.com/office/drawing/2014/main" id="{06FE472F-3B34-4CBD-BBDE-66FAFB0E4049}"/>
               </a:ext>
             </a:extLst>
           </p:cNvPr>
@@ -13395,7 +13395,7 @@
           <p:cNvPr id="10" name="01  실패하는 테스트">
             <a:extLst xmlns:a="http://schemas.openxmlformats.org/drawingml/2006/main">
               <a:ext uri="{FF2B5EF4-FFF2-40B4-BE49-F238E27FC236}">
-                <a16:creationId xmlns:a16="http://schemas.microsoft.com/office/drawing/2014/main" id="{7609FCA4-1EC8-4613-B371-4BE7037C8D93}"/>
+                <a16:creationId xmlns:a16="http://schemas.microsoft.com/office/drawing/2014/main" id="{6BD57DC0-1A84-4381-B6F0-DB39DA04E7FA}"/>
               </a:ext>
             </a:extLst>
           </p:cNvPr>
@@ -13553,7 +13553,7 @@
           <p:cNvPr id="11" name="02  관련 구현">
             <a:extLst xmlns:a="http://schemas.openxmlformats.org/drawingml/2006/main">
               <a:ext uri="{FF2B5EF4-FFF2-40B4-BE49-F238E27FC236}">
-                <a16:creationId xmlns:a16="http://schemas.microsoft.com/office/drawing/2014/main" id="{844D9765-016C-4515-8F65-D4257861ED8F}"/>
+                <a16:creationId xmlns:a16="http://schemas.microsoft.com/office/drawing/2014/main" id="{C5466243-39DA-401A-84A9-E924E6BBC795}"/>
               </a:ext>
             </a:extLst>
           </p:cNvPr>
@@ -13711,7 +13711,7 @@
           <p:cNvPr id="12" name="03  제품의 호출 경로">
             <a:extLst xmlns:a="http://schemas.openxmlformats.org/drawingml/2006/main">
               <a:ext uri="{FF2B5EF4-FFF2-40B4-BE49-F238E27FC236}">
-                <a16:creationId xmlns:a16="http://schemas.microsoft.com/office/drawing/2014/main" id="{4E7483B8-7D63-45DD-9C80-4AFBF9E53A68}"/>
+                <a16:creationId xmlns:a16="http://schemas.microsoft.com/office/drawing/2014/main" id="{4BA22D99-3739-4026-B9D0-778175CF8D5A}"/>
               </a:ext>
             </a:extLst>
           </p:cNvPr>
@@ -13867,7 +13867,7 @@
     </p:spTree>
     <p:extLst>
       <p:ext uri="{BB962C8B-B14F-4D97-AF65-F5344CB8AC3E}">
-        <p14:creationId xmlns:p14="http://schemas.microsoft.com/office/powerpoint/2010/main" val="162951531"/>
+        <p14:creationId xmlns:p14="http://schemas.microsoft.com/office/powerpoint/2010/main" val="1065014673"/>
       </p:ext>
     </p:extLst>
   </p:cSld>
@@ -13898,7 +13898,7 @@
           <p:cNvPr id="63" name="ACT 0  ·  Repository 탐색">
             <a:extLst xmlns:a="http://schemas.openxmlformats.org/drawingml/2006/main">
               <a:ext uri="{FF2B5EF4-FFF2-40B4-BE49-F238E27FC236}">
-                <a16:creationId xmlns:a16="http://schemas.microsoft.com/office/drawing/2014/main" id="{A28C6163-8893-4324-8831-0B5B2D757019}"/>
+                <a16:creationId xmlns:a16="http://schemas.microsoft.com/office/drawing/2014/main" id="{12A5DA8C-EC33-4556-8C1D-722A8E592990}"/>
               </a:ext>
             </a:extLst>
           </p:cNvPr>
@@ -14056,7 +14056,7 @@
           <p:cNvPr id="2" name="S05">
             <a:extLst xmlns:a="http://schemas.openxmlformats.org/drawingml/2006/main">
               <a:ext uri="{FF2B5EF4-FFF2-40B4-BE49-F238E27FC236}">
-                <a16:creationId xmlns:a16="http://schemas.microsoft.com/office/drawing/2014/main" id="{85F57126-48EB-4E2F-B284-D3C4E3B3E112}"/>
+                <a16:creationId xmlns:a16="http://schemas.microsoft.com/office/drawing/2014/main" id="{5EAB9181-2CB4-4D16-B062-E0A4E78C3F23}"/>
               </a:ext>
             </a:extLst>
           </p:cNvPr>
@@ -14214,7 +14214,7 @@
           <p:cNvPr id="3" name="Agent가 Test와 호출 경로를 찾았다">
             <a:extLst xmlns:a="http://schemas.openxmlformats.org/drawingml/2006/main">
               <a:ext uri="{FF2B5EF4-FFF2-40B4-BE49-F238E27FC236}">
-                <a16:creationId xmlns:a16="http://schemas.microsoft.com/office/drawing/2014/main" id="{CA07B924-8690-45E6-9F75-086D7833435E}"/>
+                <a16:creationId xmlns:a16="http://schemas.microsoft.com/office/drawing/2014/main" id="{45CCE3D3-1B68-4F40-9925-E161CE2F12D4}"/>
               </a:ext>
             </a:extLst>
           </p:cNvPr>
@@ -14372,7 +14372,7 @@
           <p:cNvPr id="4" name="">
             <a:extLst xmlns:a="http://schemas.openxmlformats.org/drawingml/2006/main">
               <a:ext uri="{FF2B5EF4-FFF2-40B4-BE49-F238E27FC236}">
-                <a16:creationId xmlns:a16="http://schemas.microsoft.com/office/drawing/2014/main" id="{F45E206B-4E85-4E23-87DE-BBC24C1FA338}"/>
+                <a16:creationId xmlns:a16="http://schemas.microsoft.com/office/drawing/2014/main" id="{34BD1638-7EF0-48D5-9AAD-33C0712635B7}"/>
               </a:ext>
             </a:extLst>
           </p:cNvPr>
@@ -14403,7 +14403,7 @@
           <p:cNvPr id="5" name="TRIAL-001 기록·STATE-00 테스트 재구성  |  Codex CLI 0.154.0 · 읽기 전용">
             <a:extLst xmlns:a="http://schemas.openxmlformats.org/drawingml/2006/main">
               <a:ext uri="{FF2B5EF4-FFF2-40B4-BE49-F238E27FC236}">
-                <a16:creationId xmlns:a16="http://schemas.microsoft.com/office/drawing/2014/main" id="{E64D3D26-4BC8-406A-98A8-15C73212A983}"/>
+                <a16:creationId xmlns:a16="http://schemas.microsoft.com/office/drawing/2014/main" id="{26596F36-AED1-4D60-9ED1-DA3BB8DCE5C4}"/>
               </a:ext>
             </a:extLst>
           </p:cNvPr>
@@ -14561,7 +14561,7 @@
           <p:cNvPr id="6" name="실제 실행 화면이 아님 · 이 조사에서는 코드 수정 없음 · 현재 Desktop 동작 미검증">
             <a:extLst xmlns:a="http://schemas.openxmlformats.org/drawingml/2006/main">
               <a:ext uri="{FF2B5EF4-FFF2-40B4-BE49-F238E27FC236}">
-                <a16:creationId xmlns:a16="http://schemas.microsoft.com/office/drawing/2014/main" id="{05145761-93BB-4F01-B5B9-F26BE0CA0F5B}"/>
+                <a16:creationId xmlns:a16="http://schemas.microsoft.com/office/drawing/2014/main" id="{33BC5ACA-F063-4F5C-A9C0-F8CD81C3C38B}"/>
               </a:ext>
             </a:extLst>
           </p:cNvPr>
@@ -14719,7 +14719,7 @@
           <p:cNvPr id="7" name="crop(image, 1, 3)">
             <a:extLst xmlns:a="http://schemas.openxmlformats.org/drawingml/2006/main">
               <a:ext uri="{FF2B5EF4-FFF2-40B4-BE49-F238E27FC236}">
-                <a16:creationId xmlns:a16="http://schemas.microsoft.com/office/drawing/2014/main" id="{659A57B9-5AF9-4D2D-A57D-B60FFFF47483}"/>
+                <a16:creationId xmlns:a16="http://schemas.microsoft.com/office/drawing/2014/main" id="{BCB92C82-56CD-484F-9406-326B8DC92A3E}"/>
               </a:ext>
             </a:extLst>
           </p:cNvPr>
@@ -14877,7 +14877,7 @@
           <p:cNvPr id="8" name="끝 좌표 3은 포함하지 않는 계약">
             <a:extLst xmlns:a="http://schemas.openxmlformats.org/drawingml/2006/main">
               <a:ext uri="{FF2B5EF4-FFF2-40B4-BE49-F238E27FC236}">
-                <a16:creationId xmlns:a16="http://schemas.microsoft.com/office/drawing/2014/main" id="{DE85840D-BFB1-449C-9B61-F6D1E9724C22}"/>
+                <a16:creationId xmlns:a16="http://schemas.microsoft.com/office/drawing/2014/main" id="{A89C020E-E1B6-4DAB-AB8E-A0FC008CE699}"/>
               </a:ext>
             </a:extLst>
           </p:cNvPr>
@@ -15035,7 +15035,7 @@
           <p:cNvPr id="9" name="입력">
             <a:extLst xmlns:a="http://schemas.openxmlformats.org/drawingml/2006/main">
               <a:ext uri="{FF2B5EF4-FFF2-40B4-BE49-F238E27FC236}">
-                <a16:creationId xmlns:a16="http://schemas.microsoft.com/office/drawing/2014/main" id="{93A71639-4101-4E8B-987E-2029D80F809B}"/>
+                <a16:creationId xmlns:a16="http://schemas.microsoft.com/office/drawing/2014/main" id="{4615F64B-A0FD-4C63-84E7-A516DAB9D87E}"/>
               </a:ext>
             </a:extLst>
           </p:cNvPr>
@@ -15193,7 +15193,7 @@
           <p:cNvPr id="10" name="0">
             <a:extLst xmlns:a="http://schemas.openxmlformats.org/drawingml/2006/main">
               <a:ext uri="{FF2B5EF4-FFF2-40B4-BE49-F238E27FC236}">
-                <a16:creationId xmlns:a16="http://schemas.microsoft.com/office/drawing/2014/main" id="{B60F650D-AC26-441F-8D76-42A258EE5F89}"/>
+                <a16:creationId xmlns:a16="http://schemas.microsoft.com/office/drawing/2014/main" id="{8063EA6A-6101-42E9-BB2A-98DE90192D4B}"/>
               </a:ext>
             </a:extLst>
           </p:cNvPr>
@@ -15351,7 +15351,7 @@
           <p:cNvPr id="11" name="1">
             <a:extLst xmlns:a="http://schemas.openxmlformats.org/drawingml/2006/main">
               <a:ext uri="{FF2B5EF4-FFF2-40B4-BE49-F238E27FC236}">
-                <a16:creationId xmlns:a16="http://schemas.microsoft.com/office/drawing/2014/main" id="{DD512365-3B82-4B97-85F9-F74966F8D60D}"/>
+                <a16:creationId xmlns:a16="http://schemas.microsoft.com/office/drawing/2014/main" id="{7EB327C5-9B31-4C27-8230-9BFE06DCE1A6}"/>
               </a:ext>
             </a:extLst>
           </p:cNvPr>
@@ -15509,7 +15509,7 @@
           <p:cNvPr id="12" name="2">
             <a:extLst xmlns:a="http://schemas.openxmlformats.org/drawingml/2006/main">
               <a:ext uri="{FF2B5EF4-FFF2-40B4-BE49-F238E27FC236}">
-                <a16:creationId xmlns:a16="http://schemas.microsoft.com/office/drawing/2014/main" id="{80A84589-66D7-4DE4-B3A7-9E2C9D973042}"/>
+                <a16:creationId xmlns:a16="http://schemas.microsoft.com/office/drawing/2014/main" id="{53E37CDF-B630-46DD-94E1-496AAD338856}"/>
               </a:ext>
             </a:extLst>
           </p:cNvPr>
@@ -15667,7 +15667,7 @@
           <p:cNvPr id="13" name="3">
             <a:extLst xmlns:a="http://schemas.openxmlformats.org/drawingml/2006/main">
               <a:ext uri="{FF2B5EF4-FFF2-40B4-BE49-F238E27FC236}">
-                <a16:creationId xmlns:a16="http://schemas.microsoft.com/office/drawing/2014/main" id="{9E4F864A-FF94-453F-9DB5-B316F6E72D21}"/>
+                <a16:creationId xmlns:a16="http://schemas.microsoft.com/office/drawing/2014/main" id="{2ADE90CC-7AFC-4953-842A-77C32C48CF9C}"/>
               </a:ext>
             </a:extLst>
           </p:cNvPr>
@@ -15825,7 +15825,7 @@
           <p:cNvPr id="14" name="">
             <a:extLst xmlns:a="http://schemas.openxmlformats.org/drawingml/2006/main">
               <a:ext uri="{FF2B5EF4-FFF2-40B4-BE49-F238E27FC236}">
-                <a16:creationId xmlns:a16="http://schemas.microsoft.com/office/drawing/2014/main" id="{3E3F6F4B-2BE1-46AE-A0F1-9ECA3142208D}"/>
+                <a16:creationId xmlns:a16="http://schemas.microsoft.com/office/drawing/2014/main" id="{06BD1C95-C3DE-43EB-86C9-692E7083B8AD}"/>
               </a:ext>
             </a:extLst>
           </p:cNvPr>
@@ -15858,7 +15858,7 @@
           <p:cNvPr id="15" name="1">
             <a:extLst xmlns:a="http://schemas.openxmlformats.org/drawingml/2006/main">
               <a:ext uri="{FF2B5EF4-FFF2-40B4-BE49-F238E27FC236}">
-                <a16:creationId xmlns:a16="http://schemas.microsoft.com/office/drawing/2014/main" id="{827587CE-20BB-4F4F-9012-A1F1F59000B5}"/>
+                <a16:creationId xmlns:a16="http://schemas.microsoft.com/office/drawing/2014/main" id="{82E41269-F7A4-4ECC-9266-38234C9002B4}"/>
               </a:ext>
             </a:extLst>
           </p:cNvPr>
@@ -16016,7 +16016,7 @@
           <p:cNvPr id="16" name="">
             <a:extLst xmlns:a="http://schemas.openxmlformats.org/drawingml/2006/main">
               <a:ext uri="{FF2B5EF4-FFF2-40B4-BE49-F238E27FC236}">
-                <a16:creationId xmlns:a16="http://schemas.microsoft.com/office/drawing/2014/main" id="{CDC07D59-129A-4499-982A-BE7D849620A1}"/>
+                <a16:creationId xmlns:a16="http://schemas.microsoft.com/office/drawing/2014/main" id="{C2E457FD-60A5-4ED2-A9F9-B334DFEC9739}"/>
               </a:ext>
             </a:extLst>
           </p:cNvPr>
@@ -16049,7 +16049,7 @@
           <p:cNvPr id="17" name="2">
             <a:extLst xmlns:a="http://schemas.openxmlformats.org/drawingml/2006/main">
               <a:ext uri="{FF2B5EF4-FFF2-40B4-BE49-F238E27FC236}">
-                <a16:creationId xmlns:a16="http://schemas.microsoft.com/office/drawing/2014/main" id="{66D7AE24-2436-45B9-9D12-2245567E1D24}"/>
+                <a16:creationId xmlns:a16="http://schemas.microsoft.com/office/drawing/2014/main" id="{D8E99907-1996-4076-9E03-AC97EAAED6E5}"/>
               </a:ext>
             </a:extLst>
           </p:cNvPr>
@@ -16207,7 +16207,7 @@
           <p:cNvPr id="18" name="">
             <a:extLst xmlns:a="http://schemas.openxmlformats.org/drawingml/2006/main">
               <a:ext uri="{FF2B5EF4-FFF2-40B4-BE49-F238E27FC236}">
-                <a16:creationId xmlns:a16="http://schemas.microsoft.com/office/drawing/2014/main" id="{8E6148B2-4256-4DC6-9CB4-99D972029635}"/>
+                <a16:creationId xmlns:a16="http://schemas.microsoft.com/office/drawing/2014/main" id="{C92EC8F8-9606-47C3-A7D5-0E0E2862BF73}"/>
               </a:ext>
             </a:extLst>
           </p:cNvPr>
@@ -16240,7 +16240,7 @@
           <p:cNvPr id="19" name="3">
             <a:extLst xmlns:a="http://schemas.openxmlformats.org/drawingml/2006/main">
               <a:ext uri="{FF2B5EF4-FFF2-40B4-BE49-F238E27FC236}">
-                <a16:creationId xmlns:a16="http://schemas.microsoft.com/office/drawing/2014/main" id="{FDE9B079-5CFE-4C29-BA1D-0646D8421EF4}"/>
+                <a16:creationId xmlns:a16="http://schemas.microsoft.com/office/drawing/2014/main" id="{2C75EB76-5574-4753-AF15-E64472C2B28C}"/>
               </a:ext>
             </a:extLst>
           </p:cNvPr>
@@ -16398,7 +16398,7 @@
           <p:cNvPr id="20" name="">
             <a:extLst xmlns:a="http://schemas.openxmlformats.org/drawingml/2006/main">
               <a:ext uri="{FF2B5EF4-FFF2-40B4-BE49-F238E27FC236}">
-                <a16:creationId xmlns:a16="http://schemas.microsoft.com/office/drawing/2014/main" id="{22E0DF92-D139-4F38-9DA3-BA574566E234}"/>
+                <a16:creationId xmlns:a16="http://schemas.microsoft.com/office/drawing/2014/main" id="{1EE5CC05-28E2-4DD6-A542-8EF233425BAB}"/>
               </a:ext>
             </a:extLst>
           </p:cNvPr>
@@ -16431,7 +16431,7 @@
           <p:cNvPr id="21" name="4">
             <a:extLst xmlns:a="http://schemas.openxmlformats.org/drawingml/2006/main">
               <a:ext uri="{FF2B5EF4-FFF2-40B4-BE49-F238E27FC236}">
-                <a16:creationId xmlns:a16="http://schemas.microsoft.com/office/drawing/2014/main" id="{686EEB9E-18D0-45EA-B084-E4D3BF919976}"/>
+                <a16:creationId xmlns:a16="http://schemas.microsoft.com/office/drawing/2014/main" id="{1A3EF5D8-BA1B-4B62-9179-E79DAC6D46D4}"/>
               </a:ext>
             </a:extLst>
           </p:cNvPr>
@@ -16589,7 +16589,7 @@
           <p:cNvPr id="22" name="">
             <a:extLst xmlns:a="http://schemas.openxmlformats.org/drawingml/2006/main">
               <a:ext uri="{FF2B5EF4-FFF2-40B4-BE49-F238E27FC236}">
-                <a16:creationId xmlns:a16="http://schemas.microsoft.com/office/drawing/2014/main" id="{B889F4D2-7BB5-493B-BEAC-305A1E8D3F10}"/>
+                <a16:creationId xmlns:a16="http://schemas.microsoft.com/office/drawing/2014/main" id="{BC021F57-380B-496F-9D66-D49D48D4E4C8}"/>
               </a:ext>
             </a:extLst>
           </p:cNvPr>
@@ -16622,7 +16622,7 @@
           <p:cNvPr id="23" name="5">
             <a:extLst xmlns:a="http://schemas.openxmlformats.org/drawingml/2006/main">
               <a:ext uri="{FF2B5EF4-FFF2-40B4-BE49-F238E27FC236}">
-                <a16:creationId xmlns:a16="http://schemas.microsoft.com/office/drawing/2014/main" id="{1F7801C6-BE9E-4325-B00E-FC6D162FFC15}"/>
+                <a16:creationId xmlns:a16="http://schemas.microsoft.com/office/drawing/2014/main" id="{943F4401-D8AF-4DE5-9E65-2CD179A2679C}"/>
               </a:ext>
             </a:extLst>
           </p:cNvPr>
@@ -16780,7 +16780,7 @@
           <p:cNvPr id="24" name="">
             <a:extLst xmlns:a="http://schemas.openxmlformats.org/drawingml/2006/main">
               <a:ext uri="{FF2B5EF4-FFF2-40B4-BE49-F238E27FC236}">
-                <a16:creationId xmlns:a16="http://schemas.microsoft.com/office/drawing/2014/main" id="{7BFF0FDE-F58A-450F-9F2B-3086F96DDF53}"/>
+                <a16:creationId xmlns:a16="http://schemas.microsoft.com/office/drawing/2014/main" id="{0F9266B4-F51A-4116-B310-830714AA86C1}"/>
               </a:ext>
             </a:extLst>
           </p:cNvPr>
@@ -16813,7 +16813,7 @@
           <p:cNvPr id="25" name="6">
             <a:extLst xmlns:a="http://schemas.openxmlformats.org/drawingml/2006/main">
               <a:ext uri="{FF2B5EF4-FFF2-40B4-BE49-F238E27FC236}">
-                <a16:creationId xmlns:a16="http://schemas.microsoft.com/office/drawing/2014/main" id="{7F9B01B9-FCBB-487C-9B89-D3B7FDBB5A8B}"/>
+                <a16:creationId xmlns:a16="http://schemas.microsoft.com/office/drawing/2014/main" id="{FE5789B1-EE64-47C1-A243-AC179C7A3435}"/>
               </a:ext>
             </a:extLst>
           </p:cNvPr>
@@ -16971,7 +16971,7 @@
           <p:cNvPr id="26" name="">
             <a:extLst xmlns:a="http://schemas.openxmlformats.org/drawingml/2006/main">
               <a:ext uri="{FF2B5EF4-FFF2-40B4-BE49-F238E27FC236}">
-                <a16:creationId xmlns:a16="http://schemas.microsoft.com/office/drawing/2014/main" id="{235944E3-CCA0-43FB-A331-524D624B7BA6}"/>
+                <a16:creationId xmlns:a16="http://schemas.microsoft.com/office/drawing/2014/main" id="{057D8FFB-BDE3-4820-AFC6-8089BDB15B4F}"/>
               </a:ext>
             </a:extLst>
           </p:cNvPr>
@@ -17004,7 +17004,7 @@
           <p:cNvPr id="27" name="7">
             <a:extLst xmlns:a="http://schemas.openxmlformats.org/drawingml/2006/main">
               <a:ext uri="{FF2B5EF4-FFF2-40B4-BE49-F238E27FC236}">
-                <a16:creationId xmlns:a16="http://schemas.microsoft.com/office/drawing/2014/main" id="{2B96941B-E676-4425-9EA4-3AE822E85741}"/>
+                <a16:creationId xmlns:a16="http://schemas.microsoft.com/office/drawing/2014/main" id="{FA12FE57-BFA5-4769-AA76-5C854BBD8B4B}"/>
               </a:ext>
             </a:extLst>
           </p:cNvPr>
@@ -17162,7 +17162,7 @@
           <p:cNvPr id="28" name="">
             <a:extLst xmlns:a="http://schemas.openxmlformats.org/drawingml/2006/main">
               <a:ext uri="{FF2B5EF4-FFF2-40B4-BE49-F238E27FC236}">
-                <a16:creationId xmlns:a16="http://schemas.microsoft.com/office/drawing/2014/main" id="{C4F25686-B100-4C62-AA9E-1D73D544CA38}"/>
+                <a16:creationId xmlns:a16="http://schemas.microsoft.com/office/drawing/2014/main" id="{06FAA3FC-691C-48C9-99E7-D1B9FFDFE7B3}"/>
               </a:ext>
             </a:extLst>
           </p:cNvPr>
@@ -17195,7 +17195,7 @@
           <p:cNvPr id="29" name="8">
             <a:extLst xmlns:a="http://schemas.openxmlformats.org/drawingml/2006/main">
               <a:ext uri="{FF2B5EF4-FFF2-40B4-BE49-F238E27FC236}">
-                <a16:creationId xmlns:a16="http://schemas.microsoft.com/office/drawing/2014/main" id="{E60E7160-4AEE-4B20-B782-A7629DD9133B}"/>
+                <a16:creationId xmlns:a16="http://schemas.microsoft.com/office/drawing/2014/main" id="{2F07EF8F-8C37-40FE-B63C-510E934698D1}"/>
               </a:ext>
             </a:extLst>
           </p:cNvPr>
@@ -17353,7 +17353,7 @@
           <p:cNvPr id="30" name="열 index">
             <a:extLst xmlns:a="http://schemas.openxmlformats.org/drawingml/2006/main">
               <a:ext uri="{FF2B5EF4-FFF2-40B4-BE49-F238E27FC236}">
-                <a16:creationId xmlns:a16="http://schemas.microsoft.com/office/drawing/2014/main" id="{69F28F92-74DD-4F09-A20F-E65AEC112048}"/>
+                <a16:creationId xmlns:a16="http://schemas.microsoft.com/office/drawing/2014/main" id="{7EC12473-2F3E-44C8-A5CC-EBB36A11BCBE}"/>
               </a:ext>
             </a:extLst>
           </p:cNvPr>
@@ -17511,7 +17511,7 @@
           <p:cNvPr id="31" name="기대">
             <a:extLst xmlns:a="http://schemas.openxmlformats.org/drawingml/2006/main">
               <a:ext uri="{FF2B5EF4-FFF2-40B4-BE49-F238E27FC236}">
-                <a16:creationId xmlns:a16="http://schemas.microsoft.com/office/drawing/2014/main" id="{CDEBF285-2E54-44EA-AC93-BE5C112E52C2}"/>
+                <a16:creationId xmlns:a16="http://schemas.microsoft.com/office/drawing/2014/main" id="{0B867AC5-8CBA-4B60-A5E6-A8F22CEC3ADC}"/>
               </a:ext>
             </a:extLst>
           </p:cNvPr>
@@ -17669,7 +17669,7 @@
           <p:cNvPr id="32" name="">
             <a:extLst xmlns:a="http://schemas.openxmlformats.org/drawingml/2006/main">
               <a:ext uri="{FF2B5EF4-FFF2-40B4-BE49-F238E27FC236}">
-                <a16:creationId xmlns:a16="http://schemas.microsoft.com/office/drawing/2014/main" id="{DB158E8E-2E7D-4458-B369-E52BDC12FD3B}"/>
+                <a16:creationId xmlns:a16="http://schemas.microsoft.com/office/drawing/2014/main" id="{F41B2CEB-44E4-4EA8-A2AD-727F3373DFA0}"/>
               </a:ext>
             </a:extLst>
           </p:cNvPr>
@@ -17702,7 +17702,7 @@
           <p:cNvPr id="33" name="2">
             <a:extLst xmlns:a="http://schemas.openxmlformats.org/drawingml/2006/main">
               <a:ext uri="{FF2B5EF4-FFF2-40B4-BE49-F238E27FC236}">
-                <a16:creationId xmlns:a16="http://schemas.microsoft.com/office/drawing/2014/main" id="{FC238C07-99FE-466E-81BA-7F8A5692FA65}"/>
+                <a16:creationId xmlns:a16="http://schemas.microsoft.com/office/drawing/2014/main" id="{45E8EA9B-F07E-4D4F-9C91-EA542BE2897F}"/>
               </a:ext>
             </a:extLst>
           </p:cNvPr>
@@ -17860,7 +17860,7 @@
           <p:cNvPr id="34" name="">
             <a:extLst xmlns:a="http://schemas.openxmlformats.org/drawingml/2006/main">
               <a:ext uri="{FF2B5EF4-FFF2-40B4-BE49-F238E27FC236}">
-                <a16:creationId xmlns:a16="http://schemas.microsoft.com/office/drawing/2014/main" id="{5FC52A6C-1645-4F13-BB66-097B691055A9}"/>
+                <a16:creationId xmlns:a16="http://schemas.microsoft.com/office/drawing/2014/main" id="{85EF2207-C3BF-46E5-9C07-0BA8743C183C}"/>
               </a:ext>
             </a:extLst>
           </p:cNvPr>
@@ -17893,7 +17893,7 @@
           <p:cNvPr id="35" name="3">
             <a:extLst xmlns:a="http://schemas.openxmlformats.org/drawingml/2006/main">
               <a:ext uri="{FF2B5EF4-FFF2-40B4-BE49-F238E27FC236}">
-                <a16:creationId xmlns:a16="http://schemas.microsoft.com/office/drawing/2014/main" id="{1C31D1A1-8856-4381-AE62-E587AAF9D186}"/>
+                <a16:creationId xmlns:a16="http://schemas.microsoft.com/office/drawing/2014/main" id="{42C5D0DA-0E24-4CFA-8DD7-F0E72435021E}"/>
               </a:ext>
             </a:extLst>
           </p:cNvPr>
@@ -18051,7 +18051,7 @@
           <p:cNvPr id="36" name="">
             <a:extLst xmlns:a="http://schemas.openxmlformats.org/drawingml/2006/main">
               <a:ext uri="{FF2B5EF4-FFF2-40B4-BE49-F238E27FC236}">
-                <a16:creationId xmlns:a16="http://schemas.microsoft.com/office/drawing/2014/main" id="{30ACC7B0-EC87-4F5C-8097-C02B69197A8D}"/>
+                <a16:creationId xmlns:a16="http://schemas.microsoft.com/office/drawing/2014/main" id="{73D98B00-C1D9-47B5-8451-8C7844F53BEC}"/>
               </a:ext>
             </a:extLst>
           </p:cNvPr>
@@ -18084,7 +18084,7 @@
           <p:cNvPr id="37" name="6">
             <a:extLst xmlns:a="http://schemas.openxmlformats.org/drawingml/2006/main">
               <a:ext uri="{FF2B5EF4-FFF2-40B4-BE49-F238E27FC236}">
-                <a16:creationId xmlns:a16="http://schemas.microsoft.com/office/drawing/2014/main" id="{F794AC6F-8310-47F8-9D32-7B3000DE61C5}"/>
+                <a16:creationId xmlns:a16="http://schemas.microsoft.com/office/drawing/2014/main" id="{828A5298-233E-4C99-B4E7-2107DEDD8215}"/>
               </a:ext>
             </a:extLst>
           </p:cNvPr>
@@ -18242,7 +18242,7 @@
           <p:cNvPr id="38" name="">
             <a:extLst xmlns:a="http://schemas.openxmlformats.org/drawingml/2006/main">
               <a:ext uri="{FF2B5EF4-FFF2-40B4-BE49-F238E27FC236}">
-                <a16:creationId xmlns:a16="http://schemas.microsoft.com/office/drawing/2014/main" id="{4208037F-3133-461C-9080-41085FF9E9B1}"/>
+                <a16:creationId xmlns:a16="http://schemas.microsoft.com/office/drawing/2014/main" id="{6A768BD2-710B-4D19-A15E-89769991BB00}"/>
               </a:ext>
             </a:extLst>
           </p:cNvPr>
@@ -18275,7 +18275,7 @@
           <p:cNvPr id="39" name="7">
             <a:extLst xmlns:a="http://schemas.openxmlformats.org/drawingml/2006/main">
               <a:ext uri="{FF2B5EF4-FFF2-40B4-BE49-F238E27FC236}">
-                <a16:creationId xmlns:a16="http://schemas.microsoft.com/office/drawing/2014/main" id="{5BE96E4B-614C-436F-94E3-9DC48182C7C2}"/>
+                <a16:creationId xmlns:a16="http://schemas.microsoft.com/office/drawing/2014/main" id="{F596A7BC-13C4-4889-BF33-6237EA2117C8}"/>
               </a:ext>
             </a:extLst>
           </p:cNvPr>
@@ -18433,7 +18433,7 @@
           <p:cNvPr id="40" name="구현 결과">
             <a:extLst xmlns:a="http://schemas.openxmlformats.org/drawingml/2006/main">
               <a:ext uri="{FF2B5EF4-FFF2-40B4-BE49-F238E27FC236}">
-                <a16:creationId xmlns:a16="http://schemas.microsoft.com/office/drawing/2014/main" id="{D9231841-2614-4433-A9DF-0CF3BEB1026F}"/>
+                <a16:creationId xmlns:a16="http://schemas.microsoft.com/office/drawing/2014/main" id="{7BE2C592-D8A4-4275-95BD-54A198C4DA77}"/>
               </a:ext>
             </a:extLst>
           </p:cNvPr>
@@ -18591,7 +18591,7 @@
           <p:cNvPr id="41" name="">
             <a:extLst xmlns:a="http://schemas.openxmlformats.org/drawingml/2006/main">
               <a:ext uri="{FF2B5EF4-FFF2-40B4-BE49-F238E27FC236}">
-                <a16:creationId xmlns:a16="http://schemas.microsoft.com/office/drawing/2014/main" id="{E306A718-A7C2-4EDF-B06C-CD074E0470BB}"/>
+                <a16:creationId xmlns:a16="http://schemas.microsoft.com/office/drawing/2014/main" id="{ABF1BC1F-F3D0-4826-94CB-291354B44D99}"/>
               </a:ext>
             </a:extLst>
           </p:cNvPr>
@@ -18624,7 +18624,7 @@
           <p:cNvPr id="42" name="2">
             <a:extLst xmlns:a="http://schemas.openxmlformats.org/drawingml/2006/main">
               <a:ext uri="{FF2B5EF4-FFF2-40B4-BE49-F238E27FC236}">
-                <a16:creationId xmlns:a16="http://schemas.microsoft.com/office/drawing/2014/main" id="{2CE5BF02-07B2-42AC-97E7-A5AF32232CDA}"/>
+                <a16:creationId xmlns:a16="http://schemas.microsoft.com/office/drawing/2014/main" id="{41A8DE41-10CA-4E0A-B822-33C83D657513}"/>
               </a:ext>
             </a:extLst>
           </p:cNvPr>
@@ -18782,7 +18782,7 @@
           <p:cNvPr id="43" name="">
             <a:extLst xmlns:a="http://schemas.openxmlformats.org/drawingml/2006/main">
               <a:ext uri="{FF2B5EF4-FFF2-40B4-BE49-F238E27FC236}">
-                <a16:creationId xmlns:a16="http://schemas.microsoft.com/office/drawing/2014/main" id="{E82A4C9D-73F6-4A3F-90A0-8C19CEC8CCC4}"/>
+                <a16:creationId xmlns:a16="http://schemas.microsoft.com/office/drawing/2014/main" id="{842528E0-6510-4992-A5AF-A9E1694D0CDB}"/>
               </a:ext>
             </a:extLst>
           </p:cNvPr>
@@ -18815,7 +18815,7 @@
           <p:cNvPr id="44" name="3">
             <a:extLst xmlns:a="http://schemas.openxmlformats.org/drawingml/2006/main">
               <a:ext uri="{FF2B5EF4-FFF2-40B4-BE49-F238E27FC236}">
-                <a16:creationId xmlns:a16="http://schemas.microsoft.com/office/drawing/2014/main" id="{564FCE95-307B-42B5-8693-640A52AEAE47}"/>
+                <a16:creationId xmlns:a16="http://schemas.microsoft.com/office/drawing/2014/main" id="{4015365F-186A-4D63-8A7B-57924780F169}"/>
               </a:ext>
             </a:extLst>
           </p:cNvPr>
@@ -18973,7 +18973,7 @@
           <p:cNvPr id="45" name="">
             <a:extLst xmlns:a="http://schemas.openxmlformats.org/drawingml/2006/main">
               <a:ext uri="{FF2B5EF4-FFF2-40B4-BE49-F238E27FC236}">
-                <a16:creationId xmlns:a16="http://schemas.microsoft.com/office/drawing/2014/main" id="{46184D81-0F4A-4296-B43E-A707EC233021}"/>
+                <a16:creationId xmlns:a16="http://schemas.microsoft.com/office/drawing/2014/main" id="{66E01B19-5ED3-4B2D-8B33-2FD7D0AD767A}"/>
               </a:ext>
             </a:extLst>
           </p:cNvPr>
@@ -19006,7 +19006,7 @@
           <p:cNvPr id="46" name="4">
             <a:extLst xmlns:a="http://schemas.openxmlformats.org/drawingml/2006/main">
               <a:ext uri="{FF2B5EF4-FFF2-40B4-BE49-F238E27FC236}">
-                <a16:creationId xmlns:a16="http://schemas.microsoft.com/office/drawing/2014/main" id="{6F14C018-821A-4724-A845-0C4EA807B13F}"/>
+                <a16:creationId xmlns:a16="http://schemas.microsoft.com/office/drawing/2014/main" id="{D6DD83FD-D7FC-4959-BCAF-2E1801DE8982}"/>
               </a:ext>
             </a:extLst>
           </p:cNvPr>
@@ -19164,7 +19164,7 @@
           <p:cNvPr id="47" name="">
             <a:extLst xmlns:a="http://schemas.openxmlformats.org/drawingml/2006/main">
               <a:ext uri="{FF2B5EF4-FFF2-40B4-BE49-F238E27FC236}">
-                <a16:creationId xmlns:a16="http://schemas.microsoft.com/office/drawing/2014/main" id="{0E45D62F-91A7-4EA0-A4E5-794D99960D84}"/>
+                <a16:creationId xmlns:a16="http://schemas.microsoft.com/office/drawing/2014/main" id="{5C564E35-BA00-45C3-9324-C2FAC57DCD24}"/>
               </a:ext>
             </a:extLst>
           </p:cNvPr>
@@ -19197,7 +19197,7 @@
           <p:cNvPr id="48" name="6">
             <a:extLst xmlns:a="http://schemas.openxmlformats.org/drawingml/2006/main">
               <a:ext uri="{FF2B5EF4-FFF2-40B4-BE49-F238E27FC236}">
-                <a16:creationId xmlns:a16="http://schemas.microsoft.com/office/drawing/2014/main" id="{C3340BCB-8DFF-4959-AE65-76EAA16F8D54}"/>
+                <a16:creationId xmlns:a16="http://schemas.microsoft.com/office/drawing/2014/main" id="{53128EEE-89ED-4312-913D-F424B383775B}"/>
               </a:ext>
             </a:extLst>
           </p:cNvPr>
@@ -19355,7 +19355,7 @@
           <p:cNvPr id="49" name="">
             <a:extLst xmlns:a="http://schemas.openxmlformats.org/drawingml/2006/main">
               <a:ext uri="{FF2B5EF4-FFF2-40B4-BE49-F238E27FC236}">
-                <a16:creationId xmlns:a16="http://schemas.microsoft.com/office/drawing/2014/main" id="{DFB1C48E-5571-4F48-B6BB-EBAC555FB004}"/>
+                <a16:creationId xmlns:a16="http://schemas.microsoft.com/office/drawing/2014/main" id="{BE279224-96D4-4D9B-9BD1-A13864E04845}"/>
               </a:ext>
             </a:extLst>
           </p:cNvPr>
@@ -19388,7 +19388,7 @@
           <p:cNvPr id="50" name="7">
             <a:extLst xmlns:a="http://schemas.openxmlformats.org/drawingml/2006/main">
               <a:ext uri="{FF2B5EF4-FFF2-40B4-BE49-F238E27FC236}">
-                <a16:creationId xmlns:a16="http://schemas.microsoft.com/office/drawing/2014/main" id="{8A561DD1-C76C-4E46-88FF-BB69076ECA85}"/>
+                <a16:creationId xmlns:a16="http://schemas.microsoft.com/office/drawing/2014/main" id="{533AD69C-4587-4E4B-A571-D8BB4D129192}"/>
               </a:ext>
             </a:extLst>
           </p:cNvPr>
@@ -19546,7 +19546,7 @@
           <p:cNvPr id="51" name="">
             <a:extLst xmlns:a="http://schemas.openxmlformats.org/drawingml/2006/main">
               <a:ext uri="{FF2B5EF4-FFF2-40B4-BE49-F238E27FC236}">
-                <a16:creationId xmlns:a16="http://schemas.microsoft.com/office/drawing/2014/main" id="{CA9A1938-32D2-49EF-8D7C-21DA2537A9F7}"/>
+                <a16:creationId xmlns:a16="http://schemas.microsoft.com/office/drawing/2014/main" id="{3E524C95-181A-4580-8EEF-9D50A4D3D8D4}"/>
               </a:ext>
             </a:extLst>
           </p:cNvPr>
@@ -19579,7 +19579,7 @@
           <p:cNvPr id="52" name="8">
             <a:extLst xmlns:a="http://schemas.openxmlformats.org/drawingml/2006/main">
               <a:ext uri="{FF2B5EF4-FFF2-40B4-BE49-F238E27FC236}">
-                <a16:creationId xmlns:a16="http://schemas.microsoft.com/office/drawing/2014/main" id="{46A2B3E1-986F-459C-9885-CE65D267262E}"/>
+                <a16:creationId xmlns:a16="http://schemas.microsoft.com/office/drawing/2014/main" id="{74581E97-EE16-4BE3-B75D-3145B5A5A038}"/>
               </a:ext>
             </a:extLst>
           </p:cNvPr>
@@ -19737,7 +19737,7 @@
           <p:cNvPr id="53" name="한 열이 더 포함됨">
             <a:extLst xmlns:a="http://schemas.openxmlformats.org/drawingml/2006/main">
               <a:ext uri="{FF2B5EF4-FFF2-40B4-BE49-F238E27FC236}">
-                <a16:creationId xmlns:a16="http://schemas.microsoft.com/office/drawing/2014/main" id="{043C1B4B-E6D4-4198-B261-9462EDC4277F}"/>
+                <a16:creationId xmlns:a16="http://schemas.microsoft.com/office/drawing/2014/main" id="{F12889A6-9D8B-4D98-A61D-5AB8ED8D3241}"/>
               </a:ext>
             </a:extLst>
           </p:cNvPr>
@@ -19895,7 +19895,7 @@
           <p:cNvPr id="54" name="">
             <a:extLst xmlns:a="http://schemas.openxmlformats.org/drawingml/2006/main">
               <a:ext uri="{FF2B5EF4-FFF2-40B4-BE49-F238E27FC236}">
-                <a16:creationId xmlns:a16="http://schemas.microsoft.com/office/drawing/2014/main" id="{4E0BB297-85BD-4347-9F00-0BEFA21C8673}"/>
+                <a16:creationId xmlns:a16="http://schemas.microsoft.com/office/drawing/2014/main" id="{11F0CE93-5773-4E02-A9BD-FDB48DDECFA6}"/>
               </a:ext>
             </a:extLst>
           </p:cNvPr>
@@ -19926,7 +19926,7 @@
           <p:cNvPr id="55" name="조사에서 연결한 근거">
             <a:extLst xmlns:a="http://schemas.openxmlformats.org/drawingml/2006/main">
               <a:ext uri="{FF2B5EF4-FFF2-40B4-BE49-F238E27FC236}">
-                <a16:creationId xmlns:a16="http://schemas.microsoft.com/office/drawing/2014/main" id="{C4154AE2-4B1B-4BC4-9129-3249F96C8B6D}"/>
+                <a16:creationId xmlns:a16="http://schemas.microsoft.com/office/drawing/2014/main" id="{8FC1E815-DB1C-457A-9E2A-1938D4A4AB67}"/>
               </a:ext>
             </a:extLst>
           </p:cNvPr>
@@ -20084,7 +20084,7 @@
           <p:cNvPr id="56" name="01  실패 테스트">
             <a:extLst xmlns:a="http://schemas.openxmlformats.org/drawingml/2006/main">
               <a:ext uri="{FF2B5EF4-FFF2-40B4-BE49-F238E27FC236}">
-                <a16:creationId xmlns:a16="http://schemas.microsoft.com/office/drawing/2014/main" id="{C4218ED4-8EF8-45AE-BE2F-A43CC7FA00EF}"/>
+                <a16:creationId xmlns:a16="http://schemas.microsoft.com/office/drawing/2014/main" id="{D32960B7-290C-417F-BFA6-F56BF94272E4}"/>
               </a:ext>
             </a:extLst>
           </p:cNvPr>
@@ -20242,7 +20242,7 @@
           <p:cNvPr id="57" name="test_crop_excludes_&#10;end_coordinate">
             <a:extLst xmlns:a="http://schemas.openxmlformats.org/drawingml/2006/main">
               <a:ext uri="{FF2B5EF4-FFF2-40B4-BE49-F238E27FC236}">
-                <a16:creationId xmlns:a16="http://schemas.microsoft.com/office/drawing/2014/main" id="{98F8FCF7-5D68-4DB1-A0CD-198DFA2AAFAF}"/>
+                <a16:creationId xmlns:a16="http://schemas.microsoft.com/office/drawing/2014/main" id="{88D91FCF-100B-473B-9C7B-765EB4A7E886}"/>
               </a:ext>
             </a:extLst>
           </p:cNvPr>
@@ -20423,7 +20423,7 @@
           <p:cNvPr id="58" name="02  제품의 호출 경로">
             <a:extLst xmlns:a="http://schemas.openxmlformats.org/drawingml/2006/main">
               <a:ext uri="{FF2B5EF4-FFF2-40B4-BE49-F238E27FC236}">
-                <a16:creationId xmlns:a16="http://schemas.microsoft.com/office/drawing/2014/main" id="{8DF47607-2DC5-43B7-A97C-111ACB523496}"/>
+                <a16:creationId xmlns:a16="http://schemas.microsoft.com/office/drawing/2014/main" id="{74425C27-DC90-4A4D-A6E8-792C5D5A1F09}"/>
               </a:ext>
             </a:extLst>
           </p:cNvPr>
@@ -20581,7 +20581,7 @@
           <p:cNvPr id="59" name="cli.main → process_image → crop">
             <a:extLst xmlns:a="http://schemas.openxmlformats.org/drawingml/2006/main">
               <a:ext uri="{FF2B5EF4-FFF2-40B4-BE49-F238E27FC236}">
-                <a16:creationId xmlns:a16="http://schemas.microsoft.com/office/drawing/2014/main" id="{144A5F19-B05D-45F9-BD78-AB2C444A28E7}"/>
+                <a16:creationId xmlns:a16="http://schemas.microsoft.com/office/drawing/2014/main" id="{CB3C743E-8383-4E95-941E-2D646CD7E602}"/>
               </a:ext>
             </a:extLst>
           </p:cNvPr>
@@ -20739,7 +20739,7 @@
           <p:cNvPr id="60" name="03  계약과 다른 구현">
             <a:extLst xmlns:a="http://schemas.openxmlformats.org/drawingml/2006/main">
               <a:ext uri="{FF2B5EF4-FFF2-40B4-BE49-F238E27FC236}">
-                <a16:creationId xmlns:a16="http://schemas.microsoft.com/office/drawing/2014/main" id="{A556D3A0-62CB-4BFB-B4AA-9AE86C33B8BA}"/>
+                <a16:creationId xmlns:a16="http://schemas.microsoft.com/office/drawing/2014/main" id="{214B7ED6-D33B-4708-8CF0-1523E75DB274}"/>
               </a:ext>
             </a:extLst>
           </p:cNvPr>
@@ -20897,7 +20897,7 @@
           <p:cNvPr id="61" name="row[x_start : x_end + 1]">
             <a:extLst xmlns:a="http://schemas.openxmlformats.org/drawingml/2006/main">
               <a:ext uri="{FF2B5EF4-FFF2-40B4-BE49-F238E27FC236}">
-                <a16:creationId xmlns:a16="http://schemas.microsoft.com/office/drawing/2014/main" id="{44372683-9E34-4CD6-9D8A-0C5226675748}"/>
+                <a16:creationId xmlns:a16="http://schemas.microsoft.com/office/drawing/2014/main" id="{26B41980-4D8D-476A-9BEC-CAF3560EC31A}"/>
               </a:ext>
             </a:extLst>
           </p:cNvPr>
@@ -21055,7 +21055,7 @@
           <p:cNvPr id="62" name="계약: [x_start, x_end)">
             <a:extLst xmlns:a="http://schemas.openxmlformats.org/drawingml/2006/main">
               <a:ext uri="{FF2B5EF4-FFF2-40B4-BE49-F238E27FC236}">
-                <a16:creationId xmlns:a16="http://schemas.microsoft.com/office/drawing/2014/main" id="{4332D0A5-E17D-46C3-9127-60E1326F9744}"/>
+                <a16:creationId xmlns:a16="http://schemas.microsoft.com/office/drawing/2014/main" id="{21B2993B-6B11-4C6B-8946-8221435773B2}"/>
               </a:ext>
             </a:extLst>
           </p:cNvPr>
@@ -21211,7 +21211,7 @@
     </p:spTree>
     <p:extLst>
       <p:ext uri="{BB962C8B-B14F-4D97-AF65-F5344CB8AC3E}">
-        <p14:creationId xmlns:p14="http://schemas.microsoft.com/office/powerpoint/2010/main" val="1753789983"/>
+        <p14:creationId xmlns:p14="http://schemas.microsoft.com/office/powerpoint/2010/main" val="1470115050"/>
       </p:ext>
     </p:extLst>
   </p:cSld>
@@ -21242,7 +21242,7 @@
           <p:cNvPr id="17" name="ACT 0 · 조사 결과 읽기">
             <a:extLst xmlns:a="http://schemas.openxmlformats.org/drawingml/2006/main">
               <a:ext uri="{FF2B5EF4-FFF2-40B4-BE49-F238E27FC236}">
-                <a16:creationId xmlns:a16="http://schemas.microsoft.com/office/drawing/2014/main" id="{3B864686-9B8F-4513-BD93-DE82A8E99978}"/>
+                <a16:creationId xmlns:a16="http://schemas.microsoft.com/office/drawing/2014/main" id="{8FB1803A-62DC-4595-8C9A-4DE716C6EA7E}"/>
               </a:ext>
             </a:extLst>
           </p:cNvPr>
@@ -21400,7 +21400,7 @@
           <p:cNvPr id="2" name="S06">
             <a:extLst xmlns:a="http://schemas.openxmlformats.org/drawingml/2006/main">
               <a:ext uri="{FF2B5EF4-FFF2-40B4-BE49-F238E27FC236}">
-                <a16:creationId xmlns:a16="http://schemas.microsoft.com/office/drawing/2014/main" id="{C44E7110-ADDB-432C-B5AB-8E44065F2668}"/>
+                <a16:creationId xmlns:a16="http://schemas.microsoft.com/office/drawing/2014/main" id="{559DF794-AB07-4218-8B4A-87D3BE98EA9F}"/>
               </a:ext>
             </a:extLst>
           </p:cNvPr>
@@ -21558,7 +21558,7 @@
           <p:cNvPr id="3" name="관찰 결과와 실행 제한을 분리한다">
             <a:extLst xmlns:a="http://schemas.openxmlformats.org/drawingml/2006/main">
               <a:ext uri="{FF2B5EF4-FFF2-40B4-BE49-F238E27FC236}">
-                <a16:creationId xmlns:a16="http://schemas.microsoft.com/office/drawing/2014/main" id="{5755E4BE-05E2-46AD-845E-4346C9C497F6}"/>
+                <a16:creationId xmlns:a16="http://schemas.microsoft.com/office/drawing/2014/main" id="{BB5CAA6F-470E-46A2-B5A8-85A1687AE682}"/>
               </a:ext>
             </a:extLst>
           </p:cNvPr>
@@ -21716,7 +21716,7 @@
           <p:cNvPr id="4" name="">
             <a:extLst xmlns:a="http://schemas.openxmlformats.org/drawingml/2006/main">
               <a:ext uri="{FF2B5EF4-FFF2-40B4-BE49-F238E27FC236}">
-                <a16:creationId xmlns:a16="http://schemas.microsoft.com/office/drawing/2014/main" id="{C14160A9-DD94-46C7-B59E-3DA105C4F08C}"/>
+                <a16:creationId xmlns:a16="http://schemas.microsoft.com/office/drawing/2014/main" id="{E855CD61-A384-4CB5-A4CB-5F4386FD67B6}"/>
               </a:ext>
             </a:extLst>
           </p:cNvPr>
@@ -21747,7 +21747,7 @@
           <p:cNvPr id="5" name="TRIAL-001 기록 재구성 · Codex CLI 0.154.0 · 단일 읽기 전용 조사">
             <a:extLst xmlns:a="http://schemas.openxmlformats.org/drawingml/2006/main">
               <a:ext uri="{FF2B5EF4-FFF2-40B4-BE49-F238E27FC236}">
-                <a16:creationId xmlns:a16="http://schemas.microsoft.com/office/drawing/2014/main" id="{BAE60D57-6CF8-45AA-A8B7-640FFA3B8747}"/>
+                <a16:creationId xmlns:a16="http://schemas.microsoft.com/office/drawing/2014/main" id="{4F722E5B-0872-486F-B368-6AE21DCB66C0}"/>
               </a:ext>
             </a:extLst>
           </p:cNvPr>
@@ -21905,7 +21905,7 @@
           <p:cNvPr id="6" name="환경 오류 3건은 crop 결함의 증거가 아닙니다. 이 조사에서 코드는 수정하지 않았습니다.">
             <a:extLst xmlns:a="http://schemas.openxmlformats.org/drawingml/2006/main">
               <a:ext uri="{FF2B5EF4-FFF2-40B4-BE49-F238E27FC236}">
-                <a16:creationId xmlns:a16="http://schemas.microsoft.com/office/drawing/2014/main" id="{FFF6A0CC-B20F-421E-8047-F688273DA1BD}"/>
+                <a16:creationId xmlns:a16="http://schemas.microsoft.com/office/drawing/2014/main" id="{93866C2D-A945-40C2-8930-ADD0F8FB1CD0}"/>
               </a:ext>
             </a:extLst>
           </p:cNvPr>
@@ -22063,7 +22063,7 @@
           <p:cNvPr id="7" name="코드에서 확인한 문제">
             <a:extLst xmlns:a="http://schemas.openxmlformats.org/drawingml/2006/main">
               <a:ext uri="{FF2B5EF4-FFF2-40B4-BE49-F238E27FC236}">
-                <a16:creationId xmlns:a16="http://schemas.microsoft.com/office/drawing/2014/main" id="{80B2CC0F-FC63-4F90-A2EA-7A7ED9A336CF}"/>
+                <a16:creationId xmlns:a16="http://schemas.microsoft.com/office/drawing/2014/main" id="{74242780-6E11-48BF-84FF-A51F3F1AFC48}"/>
               </a:ext>
             </a:extLst>
           </p:cNvPr>
@@ -22221,7 +22221,7 @@
           <p:cNvPr id="8" name="실행 환경에서 생긴 제한">
             <a:extLst xmlns:a="http://schemas.openxmlformats.org/drawingml/2006/main">
               <a:ext uri="{FF2B5EF4-FFF2-40B4-BE49-F238E27FC236}">
-                <a16:creationId xmlns:a16="http://schemas.microsoft.com/office/drawing/2014/main" id="{6B299B80-0487-40D8-9178-DB3A89CCE8F8}"/>
+                <a16:creationId xmlns:a16="http://schemas.microsoft.com/office/drawing/2014/main" id="{0D6ED851-9893-4703-A9FE-67652915AA0E}"/>
               </a:ext>
             </a:extLst>
           </p:cNvPr>
@@ -22379,7 +22379,7 @@
           <p:cNvPr id="9" name="">
             <a:extLst xmlns:a="http://schemas.openxmlformats.org/drawingml/2006/main">
               <a:ext uri="{FF2B5EF4-FFF2-40B4-BE49-F238E27FC236}">
-                <a16:creationId xmlns:a16="http://schemas.microsoft.com/office/drawing/2014/main" id="{D7F0E53C-14B6-41FF-A217-C30E46E4BAEB}"/>
+                <a16:creationId xmlns:a16="http://schemas.microsoft.com/office/drawing/2014/main" id="{8CC49B84-6C83-47DB-9216-1B3503B744A0}"/>
               </a:ext>
             </a:extLst>
           </p:cNvPr>
@@ -22412,7 +22412,7 @@
           <p:cNvPr id="10" name="">
             <a:extLst xmlns:a="http://schemas.openxmlformats.org/drawingml/2006/main">
               <a:ext uri="{FF2B5EF4-FFF2-40B4-BE49-F238E27FC236}">
-                <a16:creationId xmlns:a16="http://schemas.microsoft.com/office/drawing/2014/main" id="{EA5BAE07-1E3D-45FE-8160-E730D90F6BCA}"/>
+                <a16:creationId xmlns:a16="http://schemas.microsoft.com/office/drawing/2014/main" id="{2D471211-ECAF-4E0C-886A-5C381B2672B7}"/>
               </a:ext>
             </a:extLst>
           </p:cNvPr>
@@ -22443,7 +22443,7 @@
           <p:cNvPr id="11" name="crop에 한 열이 더 포함됨">
             <a:extLst xmlns:a="http://schemas.openxmlformats.org/drawingml/2006/main">
               <a:ext uri="{FF2B5EF4-FFF2-40B4-BE49-F238E27FC236}">
-                <a16:creationId xmlns:a16="http://schemas.microsoft.com/office/drawing/2014/main" id="{8FCB2624-28B2-4A4F-8EDC-8C61825A4780}"/>
+                <a16:creationId xmlns:a16="http://schemas.microsoft.com/office/drawing/2014/main" id="{E4B665C6-AFD1-4293-B2DE-B1DA1730987E}"/>
               </a:ext>
             </a:extLst>
           </p:cNvPr>
@@ -22601,7 +22601,7 @@
           <p:cNvPr id="12" name="테스트·호출 경로·계약 연결&#10;원인 설명 / 코드 수정 없음">
             <a:extLst xmlns:a="http://schemas.openxmlformats.org/drawingml/2006/main">
               <a:ext uri="{FF2B5EF4-FFF2-40B4-BE49-F238E27FC236}">
-                <a16:creationId xmlns:a16="http://schemas.microsoft.com/office/drawing/2014/main" id="{312C2044-8330-436E-83A2-52F518213AEB}"/>
+                <a16:creationId xmlns:a16="http://schemas.microsoft.com/office/drawing/2014/main" id="{4000687F-9CFC-4220-A9CB-63219E328D24}"/>
               </a:ext>
             </a:extLst>
           </p:cNvPr>
@@ -22782,7 +22782,7 @@
           <p:cNvPr id="13" name="임시 디렉터리를 만들 수 없음">
             <a:extLst xmlns:a="http://schemas.openxmlformats.org/drawingml/2006/main">
               <a:ext uri="{FF2B5EF4-FFF2-40B4-BE49-F238E27FC236}">
-                <a16:creationId xmlns:a16="http://schemas.microsoft.com/office/drawing/2014/main" id="{11EBB362-788F-4BC4-B6C5-EF31EC03FAA1}"/>
+                <a16:creationId xmlns:a16="http://schemas.microsoft.com/office/drawing/2014/main" id="{D11170B4-5388-429E-944E-895FB8428698}"/>
               </a:ext>
             </a:extLst>
           </p:cNvPr>
@@ -22940,7 +22940,7 @@
           <p:cNvPr id="14" name="읽기 전용 권한 때문에&#10;서로 다른 테스트 3건이 오류">
             <a:extLst xmlns:a="http://schemas.openxmlformats.org/drawingml/2006/main">
               <a:ext uri="{FF2B5EF4-FFF2-40B4-BE49-F238E27FC236}">
-                <a16:creationId xmlns:a16="http://schemas.microsoft.com/office/drawing/2014/main" id="{32BA6164-4DE0-4EEE-9016-72C3147E531E}"/>
+                <a16:creationId xmlns:a16="http://schemas.microsoft.com/office/drawing/2014/main" id="{30173CBE-D135-48E2-A2EB-C01C0D270B08}"/>
               </a:ext>
             </a:extLst>
           </p:cNvPr>
@@ -23121,7 +23121,7 @@
           <p:cNvPr id="15" name="">
             <a:extLst xmlns:a="http://schemas.openxmlformats.org/drawingml/2006/main">
               <a:ext uri="{FF2B5EF4-FFF2-40B4-BE49-F238E27FC236}">
-                <a16:creationId xmlns:a16="http://schemas.microsoft.com/office/drawing/2014/main" id="{C1F55548-6F81-4341-843B-A3693956FC21}"/>
+                <a16:creationId xmlns:a16="http://schemas.microsoft.com/office/drawing/2014/main" id="{97765F9F-A606-499D-9BFD-DFE2B8AA7121}"/>
               </a:ext>
             </a:extLst>
           </p:cNvPr>
@@ -23152,7 +23152,7 @@
           <p:cNvPr id="16" name="전체 실행 기록: 7개 통과 + crop 실패 + 환경 오류 3건">
             <a:extLst xmlns:a="http://schemas.openxmlformats.org/drawingml/2006/main">
               <a:ext uri="{FF2B5EF4-FFF2-40B4-BE49-F238E27FC236}">
-                <a16:creationId xmlns:a16="http://schemas.microsoft.com/office/drawing/2014/main" id="{D2F95E94-7379-48C2-A363-6068F0A9525E}"/>
+                <a16:creationId xmlns:a16="http://schemas.microsoft.com/office/drawing/2014/main" id="{621C5D12-5DD9-45AE-9A2E-AA8123689974}"/>
               </a:ext>
             </a:extLst>
           </p:cNvPr>
@@ -23308,7 +23308,7 @@
     </p:spTree>
     <p:extLst>
       <p:ext uri="{BB962C8B-B14F-4D97-AF65-F5344CB8AC3E}">
-        <p14:creationId xmlns:p14="http://schemas.microsoft.com/office/powerpoint/2010/main" val="78045899"/>
+        <p14:creationId xmlns:p14="http://schemas.microsoft.com/office/powerpoint/2010/main" val="119272415"/>
       </p:ext>
     </p:extLst>
   </p:cSld>
@@ -23339,7 +23339,7 @@
           <p:cNvPr id="12" name="ACT 0 · Context를 찾는 주체">
             <a:extLst xmlns:a="http://schemas.openxmlformats.org/drawingml/2006/main">
               <a:ext uri="{FF2B5EF4-FFF2-40B4-BE49-F238E27FC236}">
-                <a16:creationId xmlns:a16="http://schemas.microsoft.com/office/drawing/2014/main" id="{22BC5D49-9BA2-4801-A583-D705A22CB299}"/>
+                <a16:creationId xmlns:a16="http://schemas.microsoft.com/office/drawing/2014/main" id="{2C7072AD-F5F3-4730-94E1-FE5134DB00D5}"/>
               </a:ext>
             </a:extLst>
           </p:cNvPr>
@@ -23497,7 +23497,7 @@
           <p:cNvPr id="2" name="S07">
             <a:extLst xmlns:a="http://schemas.openxmlformats.org/drawingml/2006/main">
               <a:ext uri="{FF2B5EF4-FFF2-40B4-BE49-F238E27FC236}">
-                <a16:creationId xmlns:a16="http://schemas.microsoft.com/office/drawing/2014/main" id="{34432BF5-5A81-4009-90D2-9DD7B12A5019}"/>
+                <a16:creationId xmlns:a16="http://schemas.microsoft.com/office/drawing/2014/main" id="{4767C2B0-467D-413C-B591-16B2EA28B369}"/>
               </a:ext>
             </a:extLst>
           </p:cNvPr>
@@ -23655,7 +23655,7 @@
           <p:cNvPr id="3" name="코드를 AI에게 가져가는 대신&#10;AI를 Repository로 데려간다">
             <a:extLst xmlns:a="http://schemas.openxmlformats.org/drawingml/2006/main">
               <a:ext uri="{FF2B5EF4-FFF2-40B4-BE49-F238E27FC236}">
-                <a16:creationId xmlns:a16="http://schemas.microsoft.com/office/drawing/2014/main" id="{555743DE-921F-4463-AC5B-A6401A00FE5C}"/>
+                <a16:creationId xmlns:a16="http://schemas.microsoft.com/office/drawing/2014/main" id="{CE408362-7007-4570-982F-BBD94F1E952D}"/>
               </a:ext>
             </a:extLst>
           </p:cNvPr>
@@ -23836,7 +23836,7 @@
           <p:cNvPr id="4" name="">
             <a:extLst xmlns:a="http://schemas.openxmlformats.org/drawingml/2006/main">
               <a:ext uri="{FF2B5EF4-FFF2-40B4-BE49-F238E27FC236}">
-                <a16:creationId xmlns:a16="http://schemas.microsoft.com/office/drawing/2014/main" id="{AFC5A4E3-EB0C-4CBD-B3EA-9DCB0DB12BAF}"/>
+                <a16:creationId xmlns:a16="http://schemas.microsoft.com/office/drawing/2014/main" id="{51B5685D-99D0-4C75-9CF5-10309CDDE697}"/>
               </a:ext>
             </a:extLst>
           </p:cNvPr>
@@ -23867,7 +23867,7 @@
           <p:cNvPr id="5" name="교육 모델 · TRIAL-001 단일 CLI 관찰과 연결 · AI 생성 설명용 삽화">
             <a:extLst xmlns:a="http://schemas.openxmlformats.org/drawingml/2006/main">
               <a:ext uri="{FF2B5EF4-FFF2-40B4-BE49-F238E27FC236}">
-                <a16:creationId xmlns:a16="http://schemas.microsoft.com/office/drawing/2014/main" id="{4DBE7960-9800-4F61-9780-DFB1D4D5FCC9}"/>
+                <a16:creationId xmlns:a16="http://schemas.microsoft.com/office/drawing/2014/main" id="{679C787C-819F-4271-890D-D5F83009F861}"/>
               </a:ext>
             </a:extLst>
           </p:cNvPr>
@@ -24025,7 +24025,7 @@
           <p:cNvPr id="6" name="목표 설정과 근거 검토는 개발자에게 남습니다. Repository 접근이 Task 의도를 정하지는 않습니다.">
             <a:extLst xmlns:a="http://schemas.openxmlformats.org/drawingml/2006/main">
               <a:ext uri="{FF2B5EF4-FFF2-40B4-BE49-F238E27FC236}">
-                <a16:creationId xmlns:a16="http://schemas.microsoft.com/office/drawing/2014/main" id="{F1361B50-3F15-46C4-84BB-7B8BA7842B57}"/>
+                <a16:creationId xmlns:a16="http://schemas.microsoft.com/office/drawing/2014/main" id="{56F34592-A6BC-47A0-B2A2-7D74545E8BF0}"/>
               </a:ext>
             </a:extLst>
           </p:cNvPr>
@@ -24183,7 +24183,7 @@
           <p:cNvPr id="7" name="내가 골라 전달하는 Context">
             <a:extLst xmlns:a="http://schemas.openxmlformats.org/drawingml/2006/main">
               <a:ext uri="{FF2B5EF4-FFF2-40B4-BE49-F238E27FC236}">
-                <a16:creationId xmlns:a16="http://schemas.microsoft.com/office/drawing/2014/main" id="{AC2F2314-CDFD-4AC3-99B7-3C3F14840EAD}"/>
+                <a16:creationId xmlns:a16="http://schemas.microsoft.com/office/drawing/2014/main" id="{D513DEF8-60D9-4C4D-8581-3EF48D4995FD}"/>
               </a:ext>
             </a:extLst>
           </p:cNvPr>
@@ -24341,7 +24341,7 @@
           <p:cNvPr id="8" name="조사를 맡기고 근거를 확인">
             <a:extLst xmlns:a="http://schemas.openxmlformats.org/drawingml/2006/main">
               <a:ext uri="{FF2B5EF4-FFF2-40B4-BE49-F238E27FC236}">
-                <a16:creationId xmlns:a16="http://schemas.microsoft.com/office/drawing/2014/main" id="{8B3662BF-91B8-43BB-81F5-42F9E5F736F3}"/>
+                <a16:creationId xmlns:a16="http://schemas.microsoft.com/office/drawing/2014/main" id="{44E82618-1E8D-4F56-9273-129BFE37CE1D}"/>
               </a:ext>
             </a:extLst>
           </p:cNvPr>
@@ -24499,7 +24499,7 @@
           <p:cNvPr id="9" name="">
             <a:extLst xmlns:a="http://schemas.openxmlformats.org/drawingml/2006/main">
               <a:ext uri="{FF2B5EF4-FFF2-40B4-BE49-F238E27FC236}">
-                <a16:creationId xmlns:a16="http://schemas.microsoft.com/office/drawing/2014/main" id="{4387A1F4-6B27-471F-B367-77ACEDA01A67}"/>
+                <a16:creationId xmlns:a16="http://schemas.microsoft.com/office/drawing/2014/main" id="{DF953E15-79B3-411F-A783-09F0C01A6A53}"/>
               </a:ext>
             </a:extLst>
           </p:cNvPr>
@@ -24509,7 +24509,7 @@
           <p:nvPr/>
         </p:nvPicPr>
         <p:blipFill>
-          <a:blip xmlns:r="http://schemas.openxmlformats.org/officeDocument/2006/relationships" xmlns:a="http://schemas.openxmlformats.org/drawingml/2006/main" r:embed="R262508a418ae4203"/>
+          <a:blip xmlns:r="http://schemas.openxmlformats.org/officeDocument/2006/relationships" xmlns:a="http://schemas.openxmlformats.org/drawingml/2006/main" r:embed="Re64e844e08024e6f"/>
           <a:srcRect xmlns:a="http://schemas.openxmlformats.org/drawingml/2006/main" l="0" t="18000" r="0" b="15000"/>
           <a:stretch xmlns:a="http://schemas.openxmlformats.org/drawingml/2006/main"/>
         </p:blipFill>
@@ -24528,7 +24528,7 @@
           <p:cNvPr id="10" name="코드 조각을 선택·복사">
             <a:extLst xmlns:a="http://schemas.openxmlformats.org/drawingml/2006/main">
               <a:ext uri="{FF2B5EF4-FFF2-40B4-BE49-F238E27FC236}">
-                <a16:creationId xmlns:a16="http://schemas.microsoft.com/office/drawing/2014/main" id="{B6ACB744-A320-46CB-9B6A-932E740F15BA}"/>
+                <a16:creationId xmlns:a16="http://schemas.microsoft.com/office/drawing/2014/main" id="{FB237846-7700-4617-97BD-865154E854AB}"/>
               </a:ext>
             </a:extLst>
           </p:cNvPr>
@@ -24686,7 +24686,7 @@
           <p:cNvPr id="11" name="목표는 사람이, 탐색은 Agent와">
             <a:extLst xmlns:a="http://schemas.openxmlformats.org/drawingml/2006/main">
               <a:ext uri="{FF2B5EF4-FFF2-40B4-BE49-F238E27FC236}">
-                <a16:creationId xmlns:a16="http://schemas.microsoft.com/office/drawing/2014/main" id="{3069110F-8940-44F1-9637-CA7A5810769C}"/>
+                <a16:creationId xmlns:a16="http://schemas.microsoft.com/office/drawing/2014/main" id="{CB5A462D-A92C-4F96-9677-C40E4D0D519B}"/>
               </a:ext>
             </a:extLst>
           </p:cNvPr>
@@ -24842,7 +24842,7 @@
     </p:spTree>
     <p:extLst>
       <p:ext uri="{BB962C8B-B14F-4D97-AF65-F5344CB8AC3E}">
-        <p14:creationId xmlns:p14="http://schemas.microsoft.com/office/powerpoint/2010/main" val="86831313"/>
+        <p14:creationId xmlns:p14="http://schemas.microsoft.com/office/powerpoint/2010/main" val="207870649"/>
       </p:ext>
     </p:extLst>
   </p:cSld>
@@ -24873,7 +24873,7 @@
           <p:cNvPr id="15" name="ACT 0 · 접근할 정보와 정할 목표">
             <a:extLst xmlns:a="http://schemas.openxmlformats.org/drawingml/2006/main">
               <a:ext uri="{FF2B5EF4-FFF2-40B4-BE49-F238E27FC236}">
-                <a16:creationId xmlns:a16="http://schemas.microsoft.com/office/drawing/2014/main" id="{F1FAFA2D-C926-4583-9708-5E2339F2366E}"/>
+                <a16:creationId xmlns:a16="http://schemas.microsoft.com/office/drawing/2014/main" id="{C9C4537B-ECAF-4578-9049-333165B70239}"/>
               </a:ext>
             </a:extLst>
           </p:cNvPr>
@@ -25031,7 +25031,7 @@
           <p:cNvPr id="2" name="S08">
             <a:extLst xmlns:a="http://schemas.openxmlformats.org/drawingml/2006/main">
               <a:ext uri="{FF2B5EF4-FFF2-40B4-BE49-F238E27FC236}">
-                <a16:creationId xmlns:a16="http://schemas.microsoft.com/office/drawing/2014/main" id="{32100E83-D6EE-488C-B86E-2A1FEBF4F39D}"/>
+                <a16:creationId xmlns:a16="http://schemas.microsoft.com/office/drawing/2014/main" id="{5AC85863-87F6-43DB-B923-7CDAB00E5B40}"/>
               </a:ext>
             </a:extLst>
           </p:cNvPr>
@@ -25189,7 +25189,7 @@
           <p:cNvPr id="3" name="Repository 접근과 Task 의도는 별개다">
             <a:extLst xmlns:a="http://schemas.openxmlformats.org/drawingml/2006/main">
               <a:ext uri="{FF2B5EF4-FFF2-40B4-BE49-F238E27FC236}">
-                <a16:creationId xmlns:a16="http://schemas.microsoft.com/office/drawing/2014/main" id="{0936280A-0B56-4654-81C8-799884E33718}"/>
+                <a16:creationId xmlns:a16="http://schemas.microsoft.com/office/drawing/2014/main" id="{CC022088-675E-466B-A25D-84B8CD841C7F}"/>
               </a:ext>
             </a:extLst>
           </p:cNvPr>
@@ -25347,7 +25347,7 @@
           <p:cNvPr id="4" name="">
             <a:extLst xmlns:a="http://schemas.openxmlformats.org/drawingml/2006/main">
               <a:ext uri="{FF2B5EF4-FFF2-40B4-BE49-F238E27FC236}">
-                <a16:creationId xmlns:a16="http://schemas.microsoft.com/office/drawing/2014/main" id="{3285C100-8F17-4779-A3A0-F4068D9244ED}"/>
+                <a16:creationId xmlns:a16="http://schemas.microsoft.com/office/drawing/2014/main" id="{3C4938B8-368A-4828-880A-F1994864E3D6}"/>
               </a:ext>
             </a:extLst>
           </p:cNvPr>
@@ -25378,7 +25378,7 @@
           <p:cNvPr id="5" name="이 과정의 교육 모델 · Repository 접근과 작업 의도의 관계">
             <a:extLst xmlns:a="http://schemas.openxmlformats.org/drawingml/2006/main">
               <a:ext uri="{FF2B5EF4-FFF2-40B4-BE49-F238E27FC236}">
-                <a16:creationId xmlns:a16="http://schemas.microsoft.com/office/drawing/2014/main" id="{1F763618-1CED-4821-AFDC-CF0D4B9E8F53}"/>
+                <a16:creationId xmlns:a16="http://schemas.microsoft.com/office/drawing/2014/main" id="{587B8924-B1D1-4ED2-9932-586CAE8F20FE}"/>
               </a:ext>
             </a:extLst>
           </p:cNvPr>
@@ -25536,7 +25536,7 @@
           <p:cNvPr id="6" name="모든 제품이나 환경의 기능을 설명하는 공식 분류가 아닙니다.">
             <a:extLst xmlns:a="http://schemas.openxmlformats.org/drawingml/2006/main">
               <a:ext uri="{FF2B5EF4-FFF2-40B4-BE49-F238E27FC236}">
-                <a16:creationId xmlns:a16="http://schemas.microsoft.com/office/drawing/2014/main" id="{3E4A0E48-5BA9-4B94-A404-0D2AF6FC8CAA}"/>
+                <a16:creationId xmlns:a16="http://schemas.microsoft.com/office/drawing/2014/main" id="{17C7B65A-19AE-4436-BC89-2CC4A7A9961E}"/>
               </a:ext>
             </a:extLst>
           </p:cNvPr>
@@ -25694,7 +25694,7 @@
           <p:cNvPr id="7" name="볼 수 있는 것">
             <a:extLst xmlns:a="http://schemas.openxmlformats.org/drawingml/2006/main">
               <a:ext uri="{FF2B5EF4-FFF2-40B4-BE49-F238E27FC236}">
-                <a16:creationId xmlns:a16="http://schemas.microsoft.com/office/drawing/2014/main" id="{14862882-3170-451E-8254-BF727D27BECC}"/>
+                <a16:creationId xmlns:a16="http://schemas.microsoft.com/office/drawing/2014/main" id="{70D2132F-1245-4AFB-B6ED-20C7843DC60C}"/>
               </a:ext>
             </a:extLst>
           </p:cNvPr>
@@ -25852,7 +25852,7 @@
           <p:cNvPr id="8" name="정해야 하는 것">
             <a:extLst xmlns:a="http://schemas.openxmlformats.org/drawingml/2006/main">
               <a:ext uri="{FF2B5EF4-FFF2-40B4-BE49-F238E27FC236}">
-                <a16:creationId xmlns:a16="http://schemas.microsoft.com/office/drawing/2014/main" id="{B753E983-F6E0-4C89-9E70-BF41C420C413}"/>
+                <a16:creationId xmlns:a16="http://schemas.microsoft.com/office/drawing/2014/main" id="{8AA56CE4-62A4-4FC1-9872-FC8A1AAAACEB}"/>
               </a:ext>
             </a:extLst>
           </p:cNvPr>
@@ -26010,7 +26010,7 @@
           <p:cNvPr id="9" name="">
             <a:extLst xmlns:a="http://schemas.openxmlformats.org/drawingml/2006/main">
               <a:ext uri="{FF2B5EF4-FFF2-40B4-BE49-F238E27FC236}">
-                <a16:creationId xmlns:a16="http://schemas.microsoft.com/office/drawing/2014/main" id="{95D0ED03-9012-44A1-995D-0CA8DDA1C25A}"/>
+                <a16:creationId xmlns:a16="http://schemas.microsoft.com/office/drawing/2014/main" id="{2303AF2A-5314-4905-883A-9A3C566C5E0A}"/>
               </a:ext>
             </a:extLst>
           </p:cNvPr>
@@ -26041,7 +26041,7 @@
           <p:cNvPr id="10" name="">
             <a:extLst xmlns:a="http://schemas.openxmlformats.org/drawingml/2006/main">
               <a:ext uri="{FF2B5EF4-FFF2-40B4-BE49-F238E27FC236}">
-                <a16:creationId xmlns:a16="http://schemas.microsoft.com/office/drawing/2014/main" id="{D74524AB-437E-4C03-94E1-F31DF7EC1437}"/>
+                <a16:creationId xmlns:a16="http://schemas.microsoft.com/office/drawing/2014/main" id="{E59E61ED-9252-4254-ADF0-01C135A7AAB4}"/>
               </a:ext>
             </a:extLst>
           </p:cNvPr>
@@ -26072,7 +26072,7 @@
           <p:cNvPr id="11" name="파일&#10;구현&#10;테스트">
             <a:extLst xmlns:a="http://schemas.openxmlformats.org/drawingml/2006/main">
               <a:ext uri="{FF2B5EF4-FFF2-40B4-BE49-F238E27FC236}">
-                <a16:creationId xmlns:a16="http://schemas.microsoft.com/office/drawing/2014/main" id="{11FE6A99-8415-439A-8552-8353582F1743}"/>
+                <a16:creationId xmlns:a16="http://schemas.microsoft.com/office/drawing/2014/main" id="{6FA08858-F1F1-4096-993C-F352E87D0491}"/>
               </a:ext>
             </a:extLst>
           </p:cNvPr>
@@ -26276,7 +26276,7 @@
           <p:cNvPr id="12" name="원하는 변화&#10;허용할 범위&#10;완료 판단">
             <a:extLst xmlns:a="http://schemas.openxmlformats.org/drawingml/2006/main">
               <a:ext uri="{FF2B5EF4-FFF2-40B4-BE49-F238E27FC236}">
-                <a16:creationId xmlns:a16="http://schemas.microsoft.com/office/drawing/2014/main" id="{2A071D5C-81EA-43D3-891D-9757F1D3F117}"/>
+                <a16:creationId xmlns:a16="http://schemas.microsoft.com/office/drawing/2014/main" id="{890AA244-3627-44F2-ACCB-E6BF94F02389}"/>
               </a:ext>
             </a:extLst>
           </p:cNvPr>
@@ -26480,7 +26480,7 @@
           <p:cNvPr id="13" name="≠">
             <a:extLst xmlns:a="http://schemas.openxmlformats.org/drawingml/2006/main">
               <a:ext uri="{FF2B5EF4-FFF2-40B4-BE49-F238E27FC236}">
-                <a16:creationId xmlns:a16="http://schemas.microsoft.com/office/drawing/2014/main" id="{82170E5B-E8FE-4C5D-85A8-0C2B5CD7E6B3}"/>
+                <a16:creationId xmlns:a16="http://schemas.microsoft.com/office/drawing/2014/main" id="{F4BF25FF-87B8-43F6-95FE-E62E806B2383}"/>
               </a:ext>
             </a:extLst>
           </p:cNvPr>
@@ -26638,7 +26638,7 @@
           <p:cNvPr id="14" name="코드가 보여도, 원하는 일은 따로 전달해야 한다.">
             <a:extLst xmlns:a="http://schemas.openxmlformats.org/drawingml/2006/main">
               <a:ext uri="{FF2B5EF4-FFF2-40B4-BE49-F238E27FC236}">
-                <a16:creationId xmlns:a16="http://schemas.microsoft.com/office/drawing/2014/main" id="{FB32683E-E195-40A3-8895-2ED7B6E0FACB}"/>
+                <a16:creationId xmlns:a16="http://schemas.microsoft.com/office/drawing/2014/main" id="{8FB69391-44B2-4F42-8C17-8A800E77C195}"/>
               </a:ext>
             </a:extLst>
           </p:cNvPr>
@@ -26794,7 +26794,7 @@
     </p:spTree>
     <p:extLst>
       <p:ext uri="{BB962C8B-B14F-4D97-AF65-F5344CB8AC3E}">
-        <p14:creationId xmlns:p14="http://schemas.microsoft.com/office/powerpoint/2010/main" val="1505983663"/>
+        <p14:creationId xmlns:p14="http://schemas.microsoft.com/office/powerpoint/2010/main" val="1841214156"/>
       </p:ext>
     </p:extLst>
   </p:cSld>
@@ -26822,10 +26822,10 @@
       </p:grpSpPr>
       <p:sp>
         <p:nvSpPr>
-          <p:cNvPr id="11" name="ACT 0 · 다음 질문">
+          <p:cNvPr id="11" name="ACT 0 · 내 작업에 적용할 질문">
             <a:extLst xmlns:a="http://schemas.openxmlformats.org/drawingml/2006/main">
               <a:ext uri="{FF2B5EF4-FFF2-40B4-BE49-F238E27FC236}">
-                <a16:creationId xmlns:a16="http://schemas.microsoft.com/office/drawing/2014/main" id="{5ADF2C27-5D43-4DEC-AE4A-B64E5FD69416}"/>
+                <a16:creationId xmlns:a16="http://schemas.microsoft.com/office/drawing/2014/main" id="{FABC6482-F3BB-487D-BF50-7174F7FC097E}"/>
               </a:ext>
             </a:extLst>
           </p:cNvPr>
@@ -26973,7 +26973,7 @@
                 <a:ea typeface="Malgun Gothic"/>
                 <a:cs typeface="Malgun Gothic"/>
               </a:rPr>
-              <a:t>ACT 0 · 다음 질문</a:t>
+              <a:t>ACT 0 · 내 작업에 적용할 질문</a:t>
             </a:r>
           </a:p>
         </p:txBody>
@@ -26983,7 +26983,7 @@
           <p:cNvPr id="2" name="S09">
             <a:extLst xmlns:a="http://schemas.openxmlformats.org/drawingml/2006/main">
               <a:ext uri="{FF2B5EF4-FFF2-40B4-BE49-F238E27FC236}">
-                <a16:creationId xmlns:a16="http://schemas.microsoft.com/office/drawing/2014/main" id="{DCF5A65E-3D42-4870-B047-811D652BB2C9}"/>
+                <a16:creationId xmlns:a16="http://schemas.microsoft.com/office/drawing/2014/main" id="{4C75E311-3CF2-40BA-8E04-CB7E68E987C6}"/>
               </a:ext>
             </a:extLst>
           </p:cNvPr>
@@ -27141,7 +27141,7 @@
           <p:cNvPr id="3" name="Repository를 보면 내가 원하는 것까지 알까?">
             <a:extLst xmlns:a="http://schemas.openxmlformats.org/drawingml/2006/main">
               <a:ext uri="{FF2B5EF4-FFF2-40B4-BE49-F238E27FC236}">
-                <a16:creationId xmlns:a16="http://schemas.microsoft.com/office/drawing/2014/main" id="{CC95F8A8-75EB-4F8D-9545-53E6606D3328}"/>
+                <a16:creationId xmlns:a16="http://schemas.microsoft.com/office/drawing/2014/main" id="{38D2DC58-FABD-446C-9614-07FA30485C28}"/>
               </a:ext>
             </a:extLst>
           </p:cNvPr>
@@ -27299,7 +27299,7 @@
           <p:cNvPr id="4" name="">
             <a:extLst xmlns:a="http://schemas.openxmlformats.org/drawingml/2006/main">
               <a:ext uri="{FF2B5EF4-FFF2-40B4-BE49-F238E27FC236}">
-                <a16:creationId xmlns:a16="http://schemas.microsoft.com/office/drawing/2014/main" id="{7ACCCC14-1114-4CA8-B872-C1435CFEB9C7}"/>
+                <a16:creationId xmlns:a16="http://schemas.microsoft.com/office/drawing/2014/main" id="{09FE15A7-CE3B-4BAF-9EF5-0EC561E75EAE}"/>
               </a:ext>
             </a:extLst>
           </p:cNvPr>
@@ -27330,7 +27330,7 @@
           <p:cNvPr id="5" name="함께 생각해 보기 · 교육 모델">
             <a:extLst xmlns:a="http://schemas.openxmlformats.org/drawingml/2006/main">
               <a:ext uri="{FF2B5EF4-FFF2-40B4-BE49-F238E27FC236}">
-                <a16:creationId xmlns:a16="http://schemas.microsoft.com/office/drawing/2014/main" id="{FE1E7F69-9209-4296-A49D-E7E3A7A46FDE}"/>
+                <a16:creationId xmlns:a16="http://schemas.microsoft.com/office/drawing/2014/main" id="{4CD10FA1-2CFB-44F6-94AB-7CC57EC46791}"/>
               </a:ext>
             </a:extLst>
           </p:cNvPr>
@@ -27488,7 +27488,7 @@
           <p:cNvPr id="6" name="현재 맡기고 싶은 일을 떠올려 보세요. 질문과 경험 공유는 자발적으로 진행합니다.">
             <a:extLst xmlns:a="http://schemas.openxmlformats.org/drawingml/2006/main">
               <a:ext uri="{FF2B5EF4-FFF2-40B4-BE49-F238E27FC236}">
-                <a16:creationId xmlns:a16="http://schemas.microsoft.com/office/drawing/2014/main" id="{AA90E931-42EC-46EE-AD2D-FA580C99A09F}"/>
+                <a16:creationId xmlns:a16="http://schemas.microsoft.com/office/drawing/2014/main" id="{F2222AE9-76F0-4788-99D5-70C2653223D5}"/>
               </a:ext>
             </a:extLst>
           </p:cNvPr>
@@ -27646,7 +27646,7 @@
           <p:cNvPr id="7" name="지금 이 저장소에&#10;어떤 일을 맡기고 싶으신가요?">
             <a:extLst xmlns:a="http://schemas.openxmlformats.org/drawingml/2006/main">
               <a:ext uri="{FF2B5EF4-FFF2-40B4-BE49-F238E27FC236}">
-                <a16:creationId xmlns:a16="http://schemas.microsoft.com/office/drawing/2014/main" id="{5DEAA14E-00BA-4028-BCC9-CF0E88C03349}"/>
+                <a16:creationId xmlns:a16="http://schemas.microsoft.com/office/drawing/2014/main" id="{5AA74C95-A44F-4E49-AADE-27EA3BD49655}"/>
               </a:ext>
             </a:extLst>
           </p:cNvPr>
@@ -27827,7 +27827,7 @@
           <p:cNvPr id="8" name="?">
             <a:extLst xmlns:a="http://schemas.openxmlformats.org/drawingml/2006/main">
               <a:ext uri="{FF2B5EF4-FFF2-40B4-BE49-F238E27FC236}">
-                <a16:creationId xmlns:a16="http://schemas.microsoft.com/office/drawing/2014/main" id="{7E277A2C-64E6-457B-9EF1-EC36B8112EBC}"/>
+                <a16:creationId xmlns:a16="http://schemas.microsoft.com/office/drawing/2014/main" id="{F303C102-F5CC-4092-A2C7-FAA9FF715593}"/>
               </a:ext>
             </a:extLst>
           </p:cNvPr>
@@ -27985,7 +27985,7 @@
           <p:cNvPr id="9" name="">
             <a:extLst xmlns:a="http://schemas.openxmlformats.org/drawingml/2006/main">
               <a:ext uri="{FF2B5EF4-FFF2-40B4-BE49-F238E27FC236}">
-                <a16:creationId xmlns:a16="http://schemas.microsoft.com/office/drawing/2014/main" id="{AA2027C2-D60B-45EC-82F4-C62F1C5E3FAF}"/>
+                <a16:creationId xmlns:a16="http://schemas.microsoft.com/office/drawing/2014/main" id="{134F206F-7311-4FF5-9813-8E4F5B956915}"/>
               </a:ext>
             </a:extLst>
           </p:cNvPr>
@@ -28016,7 +28016,7 @@
           <p:cNvPr id="10" name="그 원하는 결과까지&#10;코드에 적혀 있을까요?">
             <a:extLst xmlns:a="http://schemas.openxmlformats.org/drawingml/2006/main">
               <a:ext uri="{FF2B5EF4-FFF2-40B4-BE49-F238E27FC236}">
-                <a16:creationId xmlns:a16="http://schemas.microsoft.com/office/drawing/2014/main" id="{56867C9B-7C1D-46FD-86C0-20BF17B77B25}"/>
+                <a16:creationId xmlns:a16="http://schemas.microsoft.com/office/drawing/2014/main" id="{8FC2890A-09E2-45F8-B4C6-8B1B3F587F02}"/>
               </a:ext>
             </a:extLst>
           </p:cNvPr>
@@ -28195,7 +28195,7 @@
     </p:spTree>
     <p:extLst>
       <p:ext uri="{BB962C8B-B14F-4D97-AF65-F5344CB8AC3E}">
-        <p14:creationId xmlns:p14="http://schemas.microsoft.com/office/powerpoint/2010/main" val="1367839002"/>
+        <p14:creationId xmlns:p14="http://schemas.microsoft.com/office/powerpoint/2010/main" val="1344863587"/>
       </p:ext>
     </p:extLst>
   </p:cSld>

</xml_diff>

<commit_message>
feat(slides): reinforce approved legacy teaching bridges
Add bounded teaching examples to four slides and align their notes.
Map legacy module relations in every footer while preserving the
80-slide, 360-minute story and existing evidence boundaries.
</commit_message>
<xml_diff>
--- a/production/ACT_0.pptx
+++ b/production/ACT_0.pptx
@@ -2,21 +2,21 @@
 <file path=ppt/presentation.xml><?xml version="1.0" encoding="utf-8"?>
 <p:presentation xmlns:p="http://schemas.openxmlformats.org/presentationml/2006/main">
   <p:sldMasterIdLst>
-    <p:sldMasterId xmlns:r="http://schemas.openxmlformats.org/officeDocument/2006/relationships" id="2147483648" r:id="R989e4991c2d548ea"/>
+    <p:sldMasterId xmlns:r="http://schemas.openxmlformats.org/officeDocument/2006/relationships" id="2147483648" r:id="Rd46ec42edbc74c1e"/>
   </p:sldMasterIdLst>
   <p:notesMasterIdLst>
-    <p:notesMasterId xmlns:r="http://schemas.openxmlformats.org/officeDocument/2006/relationships" r:id="Ra3ce76a09b3b476b"/>
+    <p:notesMasterId xmlns:r="http://schemas.openxmlformats.org/officeDocument/2006/relationships" r:id="R7bb78e93cea74500"/>
   </p:notesMasterIdLst>
   <p:sldIdLst>
-    <p:sldId xmlns:r="http://schemas.openxmlformats.org/officeDocument/2006/relationships" id="256" r:id="Rbe3edf4d711b4bef"/>
-    <p:sldId xmlns:r="http://schemas.openxmlformats.org/officeDocument/2006/relationships" id="257" r:id="R3813f64f3c1b4e70"/>
-    <p:sldId xmlns:r="http://schemas.openxmlformats.org/officeDocument/2006/relationships" id="258" r:id="Re40e8ac4f067479d"/>
-    <p:sldId xmlns:r="http://schemas.openxmlformats.org/officeDocument/2006/relationships" id="259" r:id="Ra5488453189044f8"/>
-    <p:sldId xmlns:r="http://schemas.openxmlformats.org/officeDocument/2006/relationships" id="260" r:id="R0fa2cb3c33054a26"/>
-    <p:sldId xmlns:r="http://schemas.openxmlformats.org/officeDocument/2006/relationships" id="261" r:id="Rf54b10b297d3491f"/>
-    <p:sldId xmlns:r="http://schemas.openxmlformats.org/officeDocument/2006/relationships" id="262" r:id="R3ba2099e54944792"/>
-    <p:sldId xmlns:r="http://schemas.openxmlformats.org/officeDocument/2006/relationships" id="263" r:id="R8e31cf9bacb94408"/>
-    <p:sldId xmlns:r="http://schemas.openxmlformats.org/officeDocument/2006/relationships" id="264" r:id="Rc0b894f1171d4565"/>
+    <p:sldId xmlns:r="http://schemas.openxmlformats.org/officeDocument/2006/relationships" id="256" r:id="Rbe7eef6ab00f4451"/>
+    <p:sldId xmlns:r="http://schemas.openxmlformats.org/officeDocument/2006/relationships" id="257" r:id="Ra905045b93f64bd8"/>
+    <p:sldId xmlns:r="http://schemas.openxmlformats.org/officeDocument/2006/relationships" id="258" r:id="Rb6005ade27554d69"/>
+    <p:sldId xmlns:r="http://schemas.openxmlformats.org/officeDocument/2006/relationships" id="259" r:id="Re422ca2cc9214935"/>
+    <p:sldId xmlns:r="http://schemas.openxmlformats.org/officeDocument/2006/relationships" id="260" r:id="R3a43a86e17f040e9"/>
+    <p:sldId xmlns:r="http://schemas.openxmlformats.org/officeDocument/2006/relationships" id="261" r:id="R7960d1e1573d4a3f"/>
+    <p:sldId xmlns:r="http://schemas.openxmlformats.org/officeDocument/2006/relationships" id="262" r:id="R1f7119be10814bf1"/>
+    <p:sldId xmlns:r="http://schemas.openxmlformats.org/officeDocument/2006/relationships" id="263" r:id="R509e585b25f14843"/>
+    <p:sldId xmlns:r="http://schemas.openxmlformats.org/officeDocument/2006/relationships" id="264" r:id="R9c1072b4a5e9469f"/>
   </p:sldIdLst>
   <p:sldSz cx="12192000" cy="6858000"/>
   <p:notesSz cx="6858000" cy="9144000"/>
@@ -2230,17 +2230,22 @@
           </a:p>
           <a:p xmlns:a="http://schemas.openxmlformats.org/drawingml/2006/main">
             <a:r>
-              <a:t>1. **CALL BACK (0:00–0:45):** 왼쪽 Repository → 개발자 선택·복사 → AI 관계로 S02를 짧게 회수한다.</a:t>
-            </a:r>
-          </a:p>
-          <a:p xmlns:a="http://schemas.openxmlformats.org/drawingml/2006/main">
-            <a:r>
-              <a:t>2. **TRANSFER (0:45–2:00):** 오른쪽 개발자 조사 요청 → Agent ↔ Repository로 시선을 옮긴다. 바뀌는 것은 Context를 찾는 주체의 일부이며 목표와 검증 책임을 전부 넘긴다는 뜻이 아니다.</a:t>
-            </a:r>
-          </a:p>
-          <a:p xmlns:a="http://schemas.openxmlformats.org/drawingml/2006/main">
-            <a:r>
-              <a:t>3. **TRANSFER / TRANSITION (2:00–3:00):** 필요하면 큰 C++ 저장소에서도 모듈·테스트·계약을 찾는 상황을 한 문장으로 연결한다. Repository 접근이 원하는 Task를 정하지는 않는다는 S08 질문으로 이동한다.</a:t>
+              <a:t>1. **CALL BACK (0:00–0:30):** 왼쪽 Repository → 개발자 선택·복사 → AI 관계로 S02를 짧게 회수한다.</a:t>
+            </a:r>
+          </a:p>
+          <a:p xmlns:a="http://schemas.openxmlformats.org/drawingml/2006/main">
+            <a:r>
+              <a:t>2. **TRANSFER (0:30–1:30):** 오른쪽 개발자 조사 요청 → Agent ↔ Repository로 시선을 옮긴다. 바뀌는 것은 Context를 찾는 주체의 일부이며 목표와 검증 책임을 전부 넘긴다는 뜻이 아니다.</a:t>
+            </a:r>
+          </a:p>
+          <a:p xmlns:a="http://schemas.openxmlformats.org/drawingml/2006/main">
+            <a:r>
+              <a:t>3. **ACCESS BOUNDARY (1:30–2:15):** Repository를 연결하거나 자료를 전달하기 전에 승인된 도구·계정, 입력 가능한 자료와 허용된 접근 권한 범위를 먼저 확인한다고 설명한다. 회사의 실제 허용·금지 목록과 승인 절차는 이 자료에서 확정하지 않았으므로 해당 조직의 정책을 확인해야 한다. 새로운 제품 설정이나 정책 목록을 가르치지 않는다.</a:t>
+            </a:r>
+          </a:p>
+          <a:p xmlns:a="http://schemas.openxmlformats.org/drawingml/2006/main">
+            <a:r>
+              <a:t>4. **TRANSFER / TRANSITION (2:15–3:00):** 필요하면 큰 C++ 저장소에서도 모듈·테스트·계약을 찾는 상황을 한 문장으로만 연결한다. Repository 접근이 원하는 Task를 정하지는 않는다는 S08 질문으로 이동한다.</a:t>
             </a:r>
           </a:p>
           <a:p xmlns:a="http://schemas.openxmlformats.org/drawingml/2006/main">
@@ -2260,7 +2265,7 @@
           </a:p>
           <a:p xmlns:a="http://schemas.openxmlformats.org/drawingml/2006/main">
             <a:r>
-              <a:t>Claim Boundary: 이 관찰은 CLI 한 번에 한정되며 제품의 보편적 성능·반복성 주장이 아니다. Repository 접근이 Task 의도나 성공을 자동으로 정한다는 뜻이 아니다.</a:t>
+              <a:t>Claim Boundary: 이 관찰은 CLI 한 번에 한정되며 제품의 보편적 성능·반복성 주장이 아니다. Repository 접근이 Task 의도나 성공을 자동으로 정한다는 뜻이 아니다. 도구·계정·자료·접근 권한의 사전 확인은 교육용 판단 지침이며 특정 회사의 허용·금지 정책이나 현재 제품의 보안 보장을 확인한 결과가 아니다.</a:t>
             </a:r>
           </a:p>
           <a:p xmlns:a="http://schemas.openxmlformats.org/drawingml/2006/main">
@@ -2330,7 +2335,7 @@
           </a:p>
           <a:p xmlns:a="http://schemas.openxmlformats.org/drawingml/2006/main">
             <a:r>
-              <a:t>Time Management: 좌·우 관계의 변화에 집중한다. Trial 상세와 수치를 반복하지 않는다. C++ 연결은 선택적인 한 문장이며 3분 안에 S08로 이동한다.</a:t>
+              <a:t>Time Management: 좌·우 관계의 변화에 집중한다. Trial 상세와 수치를 반복하지 않는다. 기존 관계 재설명과 선택적 C++ 해설을 줄여 접근 범위 확인 45초를 배치한다. C++ 연결은 선택적인 한 문장에 한정하고 Lecture 3분 안에 S08로 이동한다. 실제 시간 적합성은 리허설 전까지 UNVERIFIED다.</a:t>
             </a:r>
           </a:p>
           <a:p xmlns:a="http://schemas.openxmlformats.org/drawingml/2006/main">
@@ -2952,7 +2957,7 @@
           <p:cNvPr id="3" name="Title">
             <a:extLst xmlns:a="http://schemas.openxmlformats.org/drawingml/2006/main">
               <a:ext uri="{FF2B5EF4-FFF2-40B4-BE49-F238E27FC236}">
-                <a16:creationId xmlns:a16="http://schemas.microsoft.com/office/drawing/2014/main" id="{A95267A7-CF47-4D92-BB0A-124F1BDB6E5A}"/>
+                <a16:creationId xmlns:a16="http://schemas.microsoft.com/office/drawing/2014/main" id="{B04B6CCE-E6B7-4EF6-BA58-536BA3A8A043}"/>
               </a:ext>
             </a:extLst>
           </p:cNvPr>
@@ -3181,7 +3186,7 @@
           <p:cNvPr id="2" name="Subtitle">
             <a:extLst xmlns:a="http://schemas.openxmlformats.org/drawingml/2006/main">
               <a:ext uri="{FF2B5EF4-FFF2-40B4-BE49-F238E27FC236}">
-                <a16:creationId xmlns:a16="http://schemas.microsoft.com/office/drawing/2014/main" id="{0A521828-CFAB-4A98-A01A-D8542644EBB3}"/>
+                <a16:creationId xmlns:a16="http://schemas.microsoft.com/office/drawing/2014/main" id="{40BF02FF-EF7D-4880-841E-569E445DBAE8}"/>
               </a:ext>
             </a:extLst>
           </p:cNvPr>
@@ -3427,7 +3432,7 @@
           <p:cNvPr id="2" name="Section title">
             <a:extLst xmlns:a="http://schemas.openxmlformats.org/drawingml/2006/main">
               <a:ext uri="{FF2B5EF4-FFF2-40B4-BE49-F238E27FC236}">
-                <a16:creationId xmlns:a16="http://schemas.microsoft.com/office/drawing/2014/main" id="{D6C87A90-95FA-4251-A027-F5C449E38396}"/>
+                <a16:creationId xmlns:a16="http://schemas.microsoft.com/office/drawing/2014/main" id="{B3F3CDF8-BAB3-49A2-B6C9-C51F1CDEA9D9}"/>
               </a:ext>
             </a:extLst>
           </p:cNvPr>
@@ -3673,7 +3678,7 @@
           <p:cNvPr id="3" name="Title">
             <a:extLst xmlns:a="http://schemas.openxmlformats.org/drawingml/2006/main">
               <a:ext uri="{FF2B5EF4-FFF2-40B4-BE49-F238E27FC236}">
-                <a16:creationId xmlns:a16="http://schemas.microsoft.com/office/drawing/2014/main" id="{8FB009FD-BD3D-42D0-8E42-0D93D4B46AE7}"/>
+                <a16:creationId xmlns:a16="http://schemas.microsoft.com/office/drawing/2014/main" id="{99916697-06E3-47AC-8BBE-6EA973E60CD9}"/>
               </a:ext>
             </a:extLst>
           </p:cNvPr>
@@ -3902,7 +3907,7 @@
           <p:cNvPr id="2" name="Body">
             <a:extLst xmlns:a="http://schemas.openxmlformats.org/drawingml/2006/main">
               <a:ext uri="{FF2B5EF4-FFF2-40B4-BE49-F238E27FC236}">
-                <a16:creationId xmlns:a16="http://schemas.microsoft.com/office/drawing/2014/main" id="{9D8BE5BC-80CA-4539-A8B5-02E23D6113D1}"/>
+                <a16:creationId xmlns:a16="http://schemas.microsoft.com/office/drawing/2014/main" id="{3F5CDE66-F6CF-40E3-A4AE-B6EC9C5C3603}"/>
               </a:ext>
             </a:extLst>
           </p:cNvPr>
@@ -4148,7 +4153,7 @@
           <p:cNvPr id="4" name="Title">
             <a:extLst xmlns:a="http://schemas.openxmlformats.org/drawingml/2006/main">
               <a:ext uri="{FF2B5EF4-FFF2-40B4-BE49-F238E27FC236}">
-                <a16:creationId xmlns:a16="http://schemas.microsoft.com/office/drawing/2014/main" id="{BB9C8362-3D71-4BFA-BB8F-6E88A3F22045}"/>
+                <a16:creationId xmlns:a16="http://schemas.microsoft.com/office/drawing/2014/main" id="{62F06056-CE20-42B5-AF91-7A1303315626}"/>
               </a:ext>
             </a:extLst>
           </p:cNvPr>
@@ -4377,7 +4382,7 @@
           <p:cNvPr id="2" name="Left column">
             <a:extLst xmlns:a="http://schemas.openxmlformats.org/drawingml/2006/main">
               <a:ext uri="{FF2B5EF4-FFF2-40B4-BE49-F238E27FC236}">
-                <a16:creationId xmlns:a16="http://schemas.microsoft.com/office/drawing/2014/main" id="{42DB8546-DA19-4562-85CD-1D53EFEA29F1}"/>
+                <a16:creationId xmlns:a16="http://schemas.microsoft.com/office/drawing/2014/main" id="{8B827D0F-F6B0-4C7D-87F8-981EC5897A97}"/>
               </a:ext>
             </a:extLst>
           </p:cNvPr>
@@ -4606,7 +4611,7 @@
           <p:cNvPr id="3" name="Right column">
             <a:extLst xmlns:a="http://schemas.openxmlformats.org/drawingml/2006/main">
               <a:ext uri="{FF2B5EF4-FFF2-40B4-BE49-F238E27FC236}">
-                <a16:creationId xmlns:a16="http://schemas.microsoft.com/office/drawing/2014/main" id="{CD74B3E9-6B31-4C4E-A33F-B2A38A82E784}"/>
+                <a16:creationId xmlns:a16="http://schemas.microsoft.com/office/drawing/2014/main" id="{3DA10C1C-F51F-43AE-9354-76A164069C10}"/>
               </a:ext>
             </a:extLst>
           </p:cNvPr>
@@ -4852,7 +4857,7 @@
           <p:cNvPr id="3" name="Title">
             <a:extLst xmlns:a="http://schemas.openxmlformats.org/drawingml/2006/main">
               <a:ext uri="{FF2B5EF4-FFF2-40B4-BE49-F238E27FC236}">
-                <a16:creationId xmlns:a16="http://schemas.microsoft.com/office/drawing/2014/main" id="{88D851D8-68DF-4EE2-AC62-76F983F5800C}"/>
+                <a16:creationId xmlns:a16="http://schemas.microsoft.com/office/drawing/2014/main" id="{50833CA1-45A0-4AA9-B215-FE7A9A540485}"/>
               </a:ext>
             </a:extLst>
           </p:cNvPr>
@@ -5081,7 +5086,7 @@
           <p:cNvPr id="2" name="Left column">
             <a:extLst xmlns:a="http://schemas.openxmlformats.org/drawingml/2006/main">
               <a:ext uri="{FF2B5EF4-FFF2-40B4-BE49-F238E27FC236}">
-                <a16:creationId xmlns:a16="http://schemas.microsoft.com/office/drawing/2014/main" id="{8E3A6D66-9369-4C58-84F4-8560B59E8139}"/>
+                <a16:creationId xmlns:a16="http://schemas.microsoft.com/office/drawing/2014/main" id="{D92501DC-EA9D-4B8E-A1C4-6FFBCEF55E9A}"/>
               </a:ext>
             </a:extLst>
           </p:cNvPr>
@@ -5348,12 +5353,12 @@
   </p:cSld>
   <p:clrMap bg1="lt1" tx1="dk1" bg2="lt2" tx2="dk2" accent1="accent1" accent2="accent2" accent3="accent3" accent4="accent4" accent5="accent5" accent6="accent6" hlink="hlink" folHlink="folHlink"/>
   <p:sldLayoutIdLst>
-    <p:sldLayoutId xmlns:r="http://schemas.openxmlformats.org/officeDocument/2006/relationships" id="2147483649" r:id="R1dd30c3f689d42d0"/>
-    <p:sldLayoutId xmlns:r="http://schemas.openxmlformats.org/officeDocument/2006/relationships" id="2147483650" r:id="R2cc305f1172d4cbd"/>
-    <p:sldLayoutId xmlns:r="http://schemas.openxmlformats.org/officeDocument/2006/relationships" id="2147483651" r:id="Rfd57267e9f5b4719"/>
-    <p:sldLayoutId xmlns:r="http://schemas.openxmlformats.org/officeDocument/2006/relationships" id="2147483652" r:id="R36c2362580c74212"/>
-    <p:sldLayoutId xmlns:r="http://schemas.openxmlformats.org/officeDocument/2006/relationships" id="2147483653" r:id="Rca3dd13ee4b04884"/>
-    <p:sldLayoutId xmlns:r="http://schemas.openxmlformats.org/officeDocument/2006/relationships" id="2147483654" r:id="R61b6fa0bfb914156"/>
+    <p:sldLayoutId xmlns:r="http://schemas.openxmlformats.org/officeDocument/2006/relationships" id="2147483649" r:id="R983ab538b90e47a4"/>
+    <p:sldLayoutId xmlns:r="http://schemas.openxmlformats.org/officeDocument/2006/relationships" id="2147483650" r:id="R6039d398156549bf"/>
+    <p:sldLayoutId xmlns:r="http://schemas.openxmlformats.org/officeDocument/2006/relationships" id="2147483651" r:id="Rc86e3e5263d6479d"/>
+    <p:sldLayoutId xmlns:r="http://schemas.openxmlformats.org/officeDocument/2006/relationships" id="2147483652" r:id="R5d74c07f07c14e07"/>
+    <p:sldLayoutId xmlns:r="http://schemas.openxmlformats.org/officeDocument/2006/relationships" id="2147483653" r:id="R5379178709a64286"/>
+    <p:sldLayoutId xmlns:r="http://schemas.openxmlformats.org/officeDocument/2006/relationships" id="2147483654" r:id="R464a67b7448c4412"/>
   </p:sldLayoutIdLst>
   <p:txStyles>
     <p:titleStyle>
@@ -5901,10 +5906,10 @@
       </p:grpSpPr>
       <p:sp>
         <p:nvSpPr>
-          <p:cNvPr id="12" name="ACT 0 · 익숙한 사용에서 시작하기">
+          <p:cNvPr id="13" name="ACT 0 · 익숙한 사용에서 시작하기">
             <a:extLst xmlns:a="http://schemas.openxmlformats.org/drawingml/2006/main">
               <a:ext uri="{FF2B5EF4-FFF2-40B4-BE49-F238E27FC236}">
-                <a16:creationId xmlns:a16="http://schemas.microsoft.com/office/drawing/2014/main" id="{3AADC76C-115B-4BE9-9130-6D1CD354E8D6}"/>
+                <a16:creationId xmlns:a16="http://schemas.microsoft.com/office/drawing/2014/main" id="{423AA686-DBD9-41C7-A24E-E6CBA22446E7}"/>
               </a:ext>
             </a:extLst>
           </p:cNvPr>
@@ -6062,7 +6067,7 @@
           <p:cNvPr id="2" name="S01">
             <a:extLst xmlns:a="http://schemas.openxmlformats.org/drawingml/2006/main">
               <a:ext uri="{FF2B5EF4-FFF2-40B4-BE49-F238E27FC236}">
-                <a16:creationId xmlns:a16="http://schemas.microsoft.com/office/drawing/2014/main" id="{7EFAB365-A79A-41EF-97C3-162460057F68}"/>
+                <a16:creationId xmlns:a16="http://schemas.microsoft.com/office/drawing/2014/main" id="{36C2E773-5F02-491B-8F5B-765CDF62C3C0}"/>
               </a:ext>
             </a:extLst>
           </p:cNvPr>
@@ -6220,7 +6225,7 @@
           <p:cNvPr id="3" name="AI에게 지금 무엇을 맡기고 있는가?">
             <a:extLst xmlns:a="http://schemas.openxmlformats.org/drawingml/2006/main">
               <a:ext uri="{FF2B5EF4-FFF2-40B4-BE49-F238E27FC236}">
-                <a16:creationId xmlns:a16="http://schemas.microsoft.com/office/drawing/2014/main" id="{A520DE28-90DE-4EC9-8CCA-141D5D04E140}"/>
+                <a16:creationId xmlns:a16="http://schemas.microsoft.com/office/drawing/2014/main" id="{B68D01BE-08C5-4A1B-80FA-CB9A4D151BAD}"/>
               </a:ext>
             </a:extLst>
           </p:cNvPr>
@@ -6378,7 +6383,7 @@
           <p:cNvPr id="4" name="">
             <a:extLst xmlns:a="http://schemas.openxmlformats.org/drawingml/2006/main">
               <a:ext uri="{FF2B5EF4-FFF2-40B4-BE49-F238E27FC236}">
-                <a16:creationId xmlns:a16="http://schemas.microsoft.com/office/drawing/2014/main" id="{F64453AC-C2C0-42B1-9E36-FEB6956888D7}"/>
+                <a16:creationId xmlns:a16="http://schemas.microsoft.com/office/drawing/2014/main" id="{8381EB6D-FA2C-452E-B5F6-B828C7CE26FE}"/>
               </a:ext>
             </a:extLst>
           </p:cNvPr>
@@ -6389,7 +6394,7 @@
         </p:nvSpPr>
         <p:spPr>
           <a:xfrm xmlns:a="http://schemas.openxmlformats.org/drawingml/2006/main">
-            <a:off x="609600" y="5829300"/>
+            <a:off x="609600" y="5753100"/>
             <a:ext cx="10972800" cy="0"/>
           </a:xfrm>
           <a:prstGeom xmlns:a="http://schemas.openxmlformats.org/drawingml/2006/main" prst="line">
@@ -6409,7 +6414,7 @@
           <p:cNvPr id="5" name="생각해 보기 · 이 과정의 교육 모델">
             <a:extLst xmlns:a="http://schemas.openxmlformats.org/drawingml/2006/main">
               <a:ext uri="{FF2B5EF4-FFF2-40B4-BE49-F238E27FC236}">
-                <a16:creationId xmlns:a16="http://schemas.microsoft.com/office/drawing/2014/main" id="{97F9F82F-E969-4E47-9227-07C2A1E89132}"/>
+                <a16:creationId xmlns:a16="http://schemas.microsoft.com/office/drawing/2014/main" id="{865CF366-89E9-4355-905C-7FBB3C4D7799}"/>
               </a:ext>
             </a:extLst>
           </p:cNvPr>
@@ -6420,8 +6425,8 @@
         </p:nvSpPr>
         <p:spPr>
           <a:xfrm xmlns:a="http://schemas.openxmlformats.org/drawingml/2006/main">
-            <a:off x="609600" y="5915025"/>
-            <a:ext cx="10972800" cy="247650"/>
+            <a:off x="609600" y="5791200"/>
+            <a:ext cx="10972800" cy="228600"/>
           </a:xfrm>
           <a:prstGeom xmlns:a="http://schemas.openxmlformats.org/drawingml/2006/main" prst="rect">
             <a:avLst/>
@@ -6567,7 +6572,7 @@
           <p:cNvPr id="6" name="자신의 경험 하나만 떠올려 보세요. 사용 수준을 평가하는 질문이 아닙니다.">
             <a:extLst xmlns:a="http://schemas.openxmlformats.org/drawingml/2006/main">
               <a:ext uri="{FF2B5EF4-FFF2-40B4-BE49-F238E27FC236}">
-                <a16:creationId xmlns:a16="http://schemas.microsoft.com/office/drawing/2014/main" id="{70DD41FF-7C8B-43EE-8260-C733E67B2FB3}"/>
+                <a16:creationId xmlns:a16="http://schemas.microsoft.com/office/drawing/2014/main" id="{E580CF78-8EA9-40B0-BBD4-C407F64ED4A9}"/>
               </a:ext>
             </a:extLst>
           </p:cNvPr>
@@ -6578,7 +6583,7 @@
         </p:nvSpPr>
         <p:spPr>
           <a:xfrm xmlns:a="http://schemas.openxmlformats.org/drawingml/2006/main">
-            <a:off x="609600" y="6191250"/>
+            <a:off x="609600" y="6019800"/>
             <a:ext cx="10972800" cy="209550"/>
           </a:xfrm>
           <a:prstGeom xmlns:a="http://schemas.openxmlformats.org/drawingml/2006/main" prst="rect">
@@ -6725,7 +6730,7 @@
           <p:cNvPr id="7" name="가장 최근에 AI에게 맡긴 일 하나">
             <a:extLst xmlns:a="http://schemas.openxmlformats.org/drawingml/2006/main">
               <a:ext uri="{FF2B5EF4-FFF2-40B4-BE49-F238E27FC236}">
-                <a16:creationId xmlns:a16="http://schemas.microsoft.com/office/drawing/2014/main" id="{9266A557-7961-4CCD-A200-9AEFD59E0AC3}"/>
+                <a16:creationId xmlns:a16="http://schemas.microsoft.com/office/drawing/2014/main" id="{1380C1FE-E2EA-4197-B2D8-464C9E81F037}"/>
               </a:ext>
             </a:extLst>
           </p:cNvPr>
@@ -6883,7 +6888,7 @@
           <p:cNvPr id="8" name="오류 설명을 들었나요?&#10;관련 코드를 조사하게 했나요?&#10;수정한 결과까지 확인하게 했나요?">
             <a:extLst xmlns:a="http://schemas.openxmlformats.org/drawingml/2006/main">
               <a:ext uri="{FF2B5EF4-FFF2-40B4-BE49-F238E27FC236}">
-                <a16:creationId xmlns:a16="http://schemas.microsoft.com/office/drawing/2014/main" id="{543B52AB-03DC-4BB6-BEA8-91006F8B70EF}"/>
+                <a16:creationId xmlns:a16="http://schemas.microsoft.com/office/drawing/2014/main" id="{CE7747A6-8A70-41EB-84A8-E49BC16F2624}"/>
               </a:ext>
             </a:extLst>
           </p:cNvPr>
@@ -7087,7 +7092,7 @@
           <p:cNvPr id="9" name="">
             <a:extLst xmlns:a="http://schemas.openxmlformats.org/drawingml/2006/main">
               <a:ext uri="{FF2B5EF4-FFF2-40B4-BE49-F238E27FC236}">
-                <a16:creationId xmlns:a16="http://schemas.microsoft.com/office/drawing/2014/main" id="{8321A8C4-A43A-48FE-8727-57446498EE64}"/>
+                <a16:creationId xmlns:a16="http://schemas.microsoft.com/office/drawing/2014/main" id="{D098AD4D-86DE-4634-B106-2DF6AA79A94F}"/>
               </a:ext>
             </a:extLst>
           </p:cNvPr>
@@ -7118,7 +7123,7 @@
           <p:cNvPr id="10" name="질문 · 생성&#10;조사 · 변경&#10;검증 · 작업 방식 개선">
             <a:extLst xmlns:a="http://schemas.openxmlformats.org/drawingml/2006/main">
               <a:ext uri="{FF2B5EF4-FFF2-40B4-BE49-F238E27FC236}">
-                <a16:creationId xmlns:a16="http://schemas.microsoft.com/office/drawing/2014/main" id="{A1108B2E-2085-4886-9D5B-97B571FFB41A}"/>
+                <a16:creationId xmlns:a16="http://schemas.microsoft.com/office/drawing/2014/main" id="{FD8D0C66-CBB4-41C9-81B3-F5AF8E51A9D9}"/>
               </a:ext>
             </a:extLst>
           </p:cNvPr>
@@ -7322,7 +7327,7 @@
           <p:cNvPr id="11" name="익숙한 방식에서 출발해도 괜찮습니다.">
             <a:extLst xmlns:a="http://schemas.openxmlformats.org/drawingml/2006/main">
               <a:ext uri="{FF2B5EF4-FFF2-40B4-BE49-F238E27FC236}">
-                <a16:creationId xmlns:a16="http://schemas.microsoft.com/office/drawing/2014/main" id="{50535BAB-B021-4CB1-A957-C5F98E960515}"/>
+                <a16:creationId xmlns:a16="http://schemas.microsoft.com/office/drawing/2014/main" id="{C2D49ABE-F86F-4EAE-A4E1-756273A8394F}"/>
               </a:ext>
             </a:extLst>
           </p:cNvPr>
@@ -7475,10 +7480,168 @@
           </a:p>
         </p:txBody>
       </p:sp>
+      <p:sp>
+        <p:nvSpPr>
+          <p:cNvPr id="12" name="Legacy module connection">
+            <a:extLst xmlns:a="http://schemas.openxmlformats.org/drawingml/2006/main">
+              <a:ext uri="{FF2B5EF4-FFF2-40B4-BE49-F238E27FC236}">
+                <a16:creationId xmlns:a16="http://schemas.microsoft.com/office/drawing/2014/main" id="{ACF221DB-BBA4-48E9-A2D4-B247B81A5413}"/>
+              </a:ext>
+            </a:extLst>
+          </p:cNvPr>
+          <p:cNvSpPr>
+            <a:spLocks xmlns:a="http://schemas.openxmlformats.org/drawingml/2006/main" noGrp="1"/>
+          </p:cNvSpPr>
+          <p:nvPr/>
+        </p:nvSpPr>
+        <p:spPr>
+          <a:xfrm xmlns:a="http://schemas.openxmlformats.org/drawingml/2006/main">
+            <a:off x="609600" y="6229350"/>
+            <a:ext cx="10972800" cy="171450"/>
+          </a:xfrm>
+          <a:prstGeom xmlns:a="http://schemas.openxmlformats.org/drawingml/2006/main" prst="rect">
+            <a:avLst/>
+          </a:prstGeom>
+          <a:noFill xmlns:a="http://schemas.openxmlformats.org/drawingml/2006/main"/>
+          <a:ln xmlns:a="http://schemas.openxmlformats.org/drawingml/2006/main" w="0">
+            <a:noFill/>
+          </a:ln>
+        </p:spPr>
+        <p:txBody>
+          <a:bodyPr xmlns:a="http://schemas.openxmlformats.org/drawingml/2006/main" wrap="none" lIns="0" tIns="0" rIns="0" bIns="0" anchor="ctr">
+            <a:noAutofit/>
+          </a:bodyPr>
+          <a:lstStyle xmlns:a="http://schemas.openxmlformats.org/drawingml/2006/main">
+            <a:defPPr algn="r">
+              <a:defRPr sz="1200" b="0">
+                <a:solidFill>
+                  <a:srgbClr val="4D5A68"/>
+                </a:solidFill>
+                <a:latin typeface="Malgun Gothic"/>
+                <a:ea typeface="Malgun Gothic"/>
+                <a:cs typeface="Malgun Gothic"/>
+              </a:defRPr>
+            </a:defPPr>
+            <a:lvl1pPr algn="r">
+              <a:defRPr sz="1200" b="0">
+                <a:solidFill>
+                  <a:srgbClr val="4D5A68"/>
+                </a:solidFill>
+                <a:latin typeface="Malgun Gothic"/>
+                <a:ea typeface="Malgun Gothic"/>
+                <a:cs typeface="Malgun Gothic"/>
+              </a:defRPr>
+            </a:lvl1pPr>
+            <a:lvl2pPr algn="r">
+              <a:defRPr sz="1200" b="0">
+                <a:solidFill>
+                  <a:srgbClr val="4D5A68"/>
+                </a:solidFill>
+                <a:latin typeface="Malgun Gothic"/>
+                <a:ea typeface="Malgun Gothic"/>
+                <a:cs typeface="Malgun Gothic"/>
+              </a:defRPr>
+            </a:lvl2pPr>
+            <a:lvl3pPr algn="r">
+              <a:defRPr sz="1200" b="0">
+                <a:solidFill>
+                  <a:srgbClr val="4D5A68"/>
+                </a:solidFill>
+                <a:latin typeface="Malgun Gothic"/>
+                <a:ea typeface="Malgun Gothic"/>
+                <a:cs typeface="Malgun Gothic"/>
+              </a:defRPr>
+            </a:lvl3pPr>
+            <a:lvl4pPr algn="r">
+              <a:defRPr sz="1200" b="0">
+                <a:solidFill>
+                  <a:srgbClr val="4D5A68"/>
+                </a:solidFill>
+                <a:latin typeface="Malgun Gothic"/>
+                <a:ea typeface="Malgun Gothic"/>
+                <a:cs typeface="Malgun Gothic"/>
+              </a:defRPr>
+            </a:lvl4pPr>
+            <a:lvl5pPr algn="r">
+              <a:defRPr sz="1200" b="0">
+                <a:solidFill>
+                  <a:srgbClr val="4D5A68"/>
+                </a:solidFill>
+                <a:latin typeface="Malgun Gothic"/>
+                <a:ea typeface="Malgun Gothic"/>
+                <a:cs typeface="Malgun Gothic"/>
+              </a:defRPr>
+            </a:lvl5pPr>
+            <a:lvl6pPr algn="r">
+              <a:defRPr sz="1200" b="0">
+                <a:solidFill>
+                  <a:srgbClr val="4D5A68"/>
+                </a:solidFill>
+                <a:latin typeface="Malgun Gothic"/>
+                <a:ea typeface="Malgun Gothic"/>
+                <a:cs typeface="Malgun Gothic"/>
+              </a:defRPr>
+            </a:lvl6pPr>
+            <a:lvl7pPr algn="r">
+              <a:defRPr sz="1200" b="0">
+                <a:solidFill>
+                  <a:srgbClr val="4D5A68"/>
+                </a:solidFill>
+                <a:latin typeface="Malgun Gothic"/>
+                <a:ea typeface="Malgun Gothic"/>
+                <a:cs typeface="Malgun Gothic"/>
+              </a:defRPr>
+            </a:lvl7pPr>
+            <a:lvl8pPr algn="r">
+              <a:defRPr sz="1200" b="0">
+                <a:solidFill>
+                  <a:srgbClr val="4D5A68"/>
+                </a:solidFill>
+                <a:latin typeface="Malgun Gothic"/>
+                <a:ea typeface="Malgun Gothic"/>
+                <a:cs typeface="Malgun Gothic"/>
+              </a:defRPr>
+            </a:lvl8pPr>
+            <a:lvl9pPr algn="r">
+              <a:defRPr sz="1200" b="0">
+                <a:solidFill>
+                  <a:srgbClr val="4D5A68"/>
+                </a:solidFill>
+                <a:latin typeface="Malgun Gothic"/>
+                <a:ea typeface="Malgun Gothic"/>
+                <a:cs typeface="Malgun Gothic"/>
+              </a:defRPr>
+            </a:lvl9pPr>
+          </a:lstStyle>
+          <a:p xmlns:a="http://schemas.openxmlformats.org/drawingml/2006/main">
+            <a:pPr algn="r">
+              <a:defRPr sz="1200" b="0">
+                <a:solidFill>
+                  <a:srgbClr val="4D5A68"/>
+                </a:solidFill>
+                <a:latin typeface="Malgun Gothic"/>
+                <a:ea typeface="Malgun Gothic"/>
+                <a:cs typeface="Malgun Gothic"/>
+              </a:defRPr>
+            </a:pPr>
+            <a:r>
+              <a:rPr sz="1200" b="0">
+                <a:solidFill>
+                  <a:srgbClr val="4D5A68"/>
+                </a:solidFill>
+                <a:latin typeface="Malgun Gothic"/>
+                <a:ea typeface="Malgun Gothic"/>
+                <a:cs typeface="Malgun Gothic"/>
+              </a:rPr>
+              <a:t>M 연계 · M1</a:t>
+            </a:r>
+          </a:p>
+        </p:txBody>
+      </p:sp>
     </p:spTree>
     <p:extLst>
       <p:ext uri="{BB962C8B-B14F-4D97-AF65-F5344CB8AC3E}">
-        <p14:creationId xmlns:p14="http://schemas.microsoft.com/office/powerpoint/2010/main" val="1770550529"/>
+        <p14:creationId xmlns:p14="http://schemas.microsoft.com/office/powerpoint/2010/main" val="978292269"/>
       </p:ext>
     </p:extLst>
   </p:cSld>
@@ -7506,10 +7669,10 @@
       </p:grpSpPr>
       <p:sp>
         <p:nvSpPr>
-          <p:cNvPr id="23" name="ACT 0 · 작은 코드 질문">
+          <p:cNvPr id="24" name="ACT 0 · 작은 코드 질문">
             <a:extLst xmlns:a="http://schemas.openxmlformats.org/drawingml/2006/main">
               <a:ext uri="{FF2B5EF4-FFF2-40B4-BE49-F238E27FC236}">
-                <a16:creationId xmlns:a16="http://schemas.microsoft.com/office/drawing/2014/main" id="{BEBA06D7-3F2E-4934-86D1-08852A8C7A7F}"/>
+                <a16:creationId xmlns:a16="http://schemas.microsoft.com/office/drawing/2014/main" id="{48F5711D-2FD0-4138-AEF2-3D1349414598}"/>
               </a:ext>
             </a:extLst>
           </p:cNvPr>
@@ -7667,7 +7830,7 @@
           <p:cNvPr id="2" name="S02">
             <a:extLst xmlns:a="http://schemas.openxmlformats.org/drawingml/2006/main">
               <a:ext uri="{FF2B5EF4-FFF2-40B4-BE49-F238E27FC236}">
-                <a16:creationId xmlns:a16="http://schemas.microsoft.com/office/drawing/2014/main" id="{926FE628-6FAA-47C8-A570-92C8047C4ED9}"/>
+                <a16:creationId xmlns:a16="http://schemas.microsoft.com/office/drawing/2014/main" id="{7B9CC4B7-0DA5-4459-B4FC-8E67C50AF8A1}"/>
               </a:ext>
             </a:extLst>
           </p:cNvPr>
@@ -7825,7 +7988,7 @@
           <p:cNvPr id="3" name="작은 질문에는 Chatbot이 유용하다">
             <a:extLst xmlns:a="http://schemas.openxmlformats.org/drawingml/2006/main">
               <a:ext uri="{FF2B5EF4-FFF2-40B4-BE49-F238E27FC236}">
-                <a16:creationId xmlns:a16="http://schemas.microsoft.com/office/drawing/2014/main" id="{03200FD3-10C7-45C0-8B7C-1553DEEEBAC5}"/>
+                <a16:creationId xmlns:a16="http://schemas.microsoft.com/office/drawing/2014/main" id="{6F48A90C-988A-467D-9F3B-7A6C91FF03B0}"/>
               </a:ext>
             </a:extLst>
           </p:cNvPr>
@@ -7983,7 +8146,7 @@
           <p:cNvPr id="4" name="">
             <a:extLst xmlns:a="http://schemas.openxmlformats.org/drawingml/2006/main">
               <a:ext uri="{FF2B5EF4-FFF2-40B4-BE49-F238E27FC236}">
-                <a16:creationId xmlns:a16="http://schemas.microsoft.com/office/drawing/2014/main" id="{CAF9C324-2E45-469B-A91B-A36186107488}"/>
+                <a16:creationId xmlns:a16="http://schemas.microsoft.com/office/drawing/2014/main" id="{94C95CAA-8812-4B46-B71D-F7EBB9888808}"/>
               </a:ext>
             </a:extLst>
           </p:cNvPr>
@@ -7994,7 +8157,7 @@
         </p:nvSpPr>
         <p:spPr>
           <a:xfrm xmlns:a="http://schemas.openxmlformats.org/drawingml/2006/main">
-            <a:off x="609600" y="5829300"/>
+            <a:off x="609600" y="5753100"/>
             <a:ext cx="10972800" cy="0"/>
           </a:xfrm>
           <a:prstGeom xmlns:a="http://schemas.openxmlformats.org/drawingml/2006/main" prst="line">
@@ -8014,7 +8177,7 @@
           <p:cNvPr id="5" name="교육용 예시 · 실제 ChatGPT 대화 캡처가 아님">
             <a:extLst xmlns:a="http://schemas.openxmlformats.org/drawingml/2006/main">
               <a:ext uri="{FF2B5EF4-FFF2-40B4-BE49-F238E27FC236}">
-                <a16:creationId xmlns:a16="http://schemas.microsoft.com/office/drawing/2014/main" id="{EE4C7340-1CDD-4F5E-860C-408D2E6A74AF}"/>
+                <a16:creationId xmlns:a16="http://schemas.microsoft.com/office/drawing/2014/main" id="{B1DE9206-D581-463A-9175-04EB878496D0}"/>
               </a:ext>
             </a:extLst>
           </p:cNvPr>
@@ -8025,8 +8188,8 @@
         </p:nvSpPr>
         <p:spPr>
           <a:xfrm xmlns:a="http://schemas.openxmlformats.org/drawingml/2006/main">
-            <a:off x="609600" y="5915025"/>
-            <a:ext cx="10972800" cy="247650"/>
+            <a:off x="609600" y="5791200"/>
+            <a:ext cx="10972800" cy="228600"/>
           </a:xfrm>
           <a:prstGeom xmlns:a="http://schemas.openxmlformats.org/drawingml/2006/main" prst="rect">
             <a:avLst/>
@@ -8172,7 +8335,7 @@
           <p:cNvPr id="6" name="일반적인 질문 흐름을 설명하며 특정 제품의 정확도나 우월성을 주장하지 않습니다.">
             <a:extLst xmlns:a="http://schemas.openxmlformats.org/drawingml/2006/main">
               <a:ext uri="{FF2B5EF4-FFF2-40B4-BE49-F238E27FC236}">
-                <a16:creationId xmlns:a16="http://schemas.microsoft.com/office/drawing/2014/main" id="{8D9F09A3-5424-4E24-8688-596EFD79E272}"/>
+                <a16:creationId xmlns:a16="http://schemas.microsoft.com/office/drawing/2014/main" id="{4F498621-A3C5-4926-8CF3-0BECE48994AA}"/>
               </a:ext>
             </a:extLst>
           </p:cNvPr>
@@ -8183,7 +8346,7 @@
         </p:nvSpPr>
         <p:spPr>
           <a:xfrm xmlns:a="http://schemas.openxmlformats.org/drawingml/2006/main">
-            <a:off x="609600" y="6191250"/>
+            <a:off x="609600" y="6019800"/>
             <a:ext cx="10972800" cy="209550"/>
           </a:xfrm>
           <a:prstGeom xmlns:a="http://schemas.openxmlformats.org/drawingml/2006/main" prst="rect">
@@ -8330,7 +8493,7 @@
           <p:cNvPr id="7" name="“이 코드에서 무엇이 남을까?”">
             <a:extLst xmlns:a="http://schemas.openxmlformats.org/drawingml/2006/main">
               <a:ext uri="{FF2B5EF4-FFF2-40B4-BE49-F238E27FC236}">
-                <a16:creationId xmlns:a16="http://schemas.microsoft.com/office/drawing/2014/main" id="{50701A39-18B7-4115-815A-FDEA1C0AC53C}"/>
+                <a16:creationId xmlns:a16="http://schemas.microsoft.com/office/drawing/2014/main" id="{8412B5FC-C5A6-4FD7-BA85-B9F45F264296}"/>
               </a:ext>
             </a:extLst>
           </p:cNvPr>
@@ -8488,7 +8651,7 @@
           <p:cNvPr id="8" name="">
             <a:extLst xmlns:a="http://schemas.openxmlformats.org/drawingml/2006/main">
               <a:ext uri="{FF2B5EF4-FFF2-40B4-BE49-F238E27FC236}">
-                <a16:creationId xmlns:a16="http://schemas.microsoft.com/office/drawing/2014/main" id="{C9D9B71C-836D-40B9-A45B-F0967E73A7F1}"/>
+                <a16:creationId xmlns:a16="http://schemas.microsoft.com/office/drawing/2014/main" id="{8ED2E236-82DF-4C07-92A4-E5534DD00D8E}"/>
               </a:ext>
             </a:extLst>
           </p:cNvPr>
@@ -8519,7 +8682,7 @@
           <p:cNvPr id="9" name="row = [1, 2, 3, 4]&#10;row[1:3]">
             <a:extLst xmlns:a="http://schemas.openxmlformats.org/drawingml/2006/main">
               <a:ext uri="{FF2B5EF4-FFF2-40B4-BE49-F238E27FC236}">
-                <a16:creationId xmlns:a16="http://schemas.microsoft.com/office/drawing/2014/main" id="{A4BC6C82-CD1A-4DD7-944A-726DDAA80989}"/>
+                <a16:creationId xmlns:a16="http://schemas.microsoft.com/office/drawing/2014/main" id="{DFDFD2D4-6B5B-47CD-BDF3-0EA4A643259C}"/>
               </a:ext>
             </a:extLst>
           </p:cNvPr>
@@ -8700,7 +8863,7 @@
           <p:cNvPr id="10" name="">
             <a:extLst xmlns:a="http://schemas.openxmlformats.org/drawingml/2006/main">
               <a:ext uri="{FF2B5EF4-FFF2-40B4-BE49-F238E27FC236}">
-                <a16:creationId xmlns:a16="http://schemas.microsoft.com/office/drawing/2014/main" id="{222CCAD9-39F6-48D7-AA4F-4FE617CBE691}"/>
+                <a16:creationId xmlns:a16="http://schemas.microsoft.com/office/drawing/2014/main" id="{9AE35211-C085-49F3-854F-7735CFEA969C}"/>
               </a:ext>
             </a:extLst>
           </p:cNvPr>
@@ -8730,7 +8893,7 @@
           <p:cNvPr id="11" name="[2, 3]">
             <a:extLst xmlns:a="http://schemas.openxmlformats.org/drawingml/2006/main">
               <a:ext uri="{FF2B5EF4-FFF2-40B4-BE49-F238E27FC236}">
-                <a16:creationId xmlns:a16="http://schemas.microsoft.com/office/drawing/2014/main" id="{391FFD42-398B-4CFE-9C2A-12226C9E0A15}"/>
+                <a16:creationId xmlns:a16="http://schemas.microsoft.com/office/drawing/2014/main" id="{F6EEF706-461C-4B9E-A9F4-7C99DA04AC0E}"/>
               </a:ext>
             </a:extLst>
           </p:cNvPr>
@@ -8888,7 +9051,7 @@
           <p:cNvPr id="12" name="끝 index 3은 포함하지 않습니다.">
             <a:extLst xmlns:a="http://schemas.openxmlformats.org/drawingml/2006/main">
               <a:ext uri="{FF2B5EF4-FFF2-40B4-BE49-F238E27FC236}">
-                <a16:creationId xmlns:a16="http://schemas.microsoft.com/office/drawing/2014/main" id="{8507E433-182A-4CDE-90E7-EF5F1963B649}"/>
+                <a16:creationId xmlns:a16="http://schemas.microsoft.com/office/drawing/2014/main" id="{EA67853B-F7FD-483B-8146-96B350607127}"/>
               </a:ext>
             </a:extLst>
           </p:cNvPr>
@@ -9046,7 +9209,7 @@
           <p:cNvPr id="13" name="코드·오류">
             <a:extLst xmlns:a="http://schemas.openxmlformats.org/drawingml/2006/main">
               <a:ext uri="{FF2B5EF4-FFF2-40B4-BE49-F238E27FC236}">
-                <a16:creationId xmlns:a16="http://schemas.microsoft.com/office/drawing/2014/main" id="{F88AB9CB-B7FC-4A71-9422-B85DE9D96010}"/>
+                <a16:creationId xmlns:a16="http://schemas.microsoft.com/office/drawing/2014/main" id="{0C47247C-46F5-4BD9-8F82-8358A19FF22A}"/>
               </a:ext>
             </a:extLst>
           </p:cNvPr>
@@ -9204,7 +9367,7 @@
           <p:cNvPr id="14" name="">
             <a:extLst xmlns:a="http://schemas.openxmlformats.org/drawingml/2006/main">
               <a:ext uri="{FF2B5EF4-FFF2-40B4-BE49-F238E27FC236}">
-                <a16:creationId xmlns:a16="http://schemas.microsoft.com/office/drawing/2014/main" id="{6105A4C2-4977-4DE7-BEF9-FD86090CD94D}"/>
+                <a16:creationId xmlns:a16="http://schemas.microsoft.com/office/drawing/2014/main" id="{148B2BD5-103A-4F10-BE75-FB6CC1FEC700}"/>
               </a:ext>
             </a:extLst>
           </p:cNvPr>
@@ -9234,7 +9397,7 @@
           <p:cNvPr id="15" name="복사">
             <a:extLst xmlns:a="http://schemas.openxmlformats.org/drawingml/2006/main">
               <a:ext uri="{FF2B5EF4-FFF2-40B4-BE49-F238E27FC236}">
-                <a16:creationId xmlns:a16="http://schemas.microsoft.com/office/drawing/2014/main" id="{3C19579A-F62E-47CD-8A93-180E78509BB9}"/>
+                <a16:creationId xmlns:a16="http://schemas.microsoft.com/office/drawing/2014/main" id="{D997F5EB-CBFD-4991-92D4-F823FCA8AD9F}"/>
               </a:ext>
             </a:extLst>
           </p:cNvPr>
@@ -9392,7 +9555,7 @@
           <p:cNvPr id="16" name="">
             <a:extLst xmlns:a="http://schemas.openxmlformats.org/drawingml/2006/main">
               <a:ext uri="{FF2B5EF4-FFF2-40B4-BE49-F238E27FC236}">
-                <a16:creationId xmlns:a16="http://schemas.microsoft.com/office/drawing/2014/main" id="{210B8E70-A9BA-4F71-B2B9-0CB8E6364F08}"/>
+                <a16:creationId xmlns:a16="http://schemas.microsoft.com/office/drawing/2014/main" id="{193619EE-9D1A-4C7F-BC85-99549E2242EE}"/>
               </a:ext>
             </a:extLst>
           </p:cNvPr>
@@ -9422,7 +9585,7 @@
           <p:cNvPr id="17" name="질문">
             <a:extLst xmlns:a="http://schemas.openxmlformats.org/drawingml/2006/main">
               <a:ext uri="{FF2B5EF4-FFF2-40B4-BE49-F238E27FC236}">
-                <a16:creationId xmlns:a16="http://schemas.microsoft.com/office/drawing/2014/main" id="{3233FB2F-01E3-4B4A-8EED-C46CB86E69DF}"/>
+                <a16:creationId xmlns:a16="http://schemas.microsoft.com/office/drawing/2014/main" id="{3DB436B3-DA88-4BA6-B342-54ACB0A19BB6}"/>
               </a:ext>
             </a:extLst>
           </p:cNvPr>
@@ -9580,7 +9743,7 @@
           <p:cNvPr id="18" name="">
             <a:extLst xmlns:a="http://schemas.openxmlformats.org/drawingml/2006/main">
               <a:ext uri="{FF2B5EF4-FFF2-40B4-BE49-F238E27FC236}">
-                <a16:creationId xmlns:a16="http://schemas.microsoft.com/office/drawing/2014/main" id="{278BC83E-DFD6-4EC1-8287-61E774DB8913}"/>
+                <a16:creationId xmlns:a16="http://schemas.microsoft.com/office/drawing/2014/main" id="{2CA16A93-EBDF-405D-B09E-9A843122327F}"/>
               </a:ext>
             </a:extLst>
           </p:cNvPr>
@@ -9610,7 +9773,7 @@
           <p:cNvPr id="19" name="답 확인">
             <a:extLst xmlns:a="http://schemas.openxmlformats.org/drawingml/2006/main">
               <a:ext uri="{FF2B5EF4-FFF2-40B4-BE49-F238E27FC236}">
-                <a16:creationId xmlns:a16="http://schemas.microsoft.com/office/drawing/2014/main" id="{2305953F-269F-4778-8242-37A9DE8B2C52}"/>
+                <a16:creationId xmlns:a16="http://schemas.microsoft.com/office/drawing/2014/main" id="{45D76A0E-D43A-4C4B-8110-81E87FD9F8FC}"/>
               </a:ext>
             </a:extLst>
           </p:cNvPr>
@@ -9768,7 +9931,7 @@
           <p:cNvPr id="20" name="">
             <a:extLst xmlns:a="http://schemas.openxmlformats.org/drawingml/2006/main">
               <a:ext uri="{FF2B5EF4-FFF2-40B4-BE49-F238E27FC236}">
-                <a16:creationId xmlns:a16="http://schemas.microsoft.com/office/drawing/2014/main" id="{B8FE87B7-1412-4677-80C0-DEAEA6D2A43A}"/>
+                <a16:creationId xmlns:a16="http://schemas.microsoft.com/office/drawing/2014/main" id="{109C37F5-9A6E-4675-A3A2-03D8366576BA}"/>
               </a:ext>
             </a:extLst>
           </p:cNvPr>
@@ -9798,7 +9961,7 @@
           <p:cNvPr id="21" name="IDE로 복귀">
             <a:extLst xmlns:a="http://schemas.openxmlformats.org/drawingml/2006/main">
               <a:ext uri="{FF2B5EF4-FFF2-40B4-BE49-F238E27FC236}">
-                <a16:creationId xmlns:a16="http://schemas.microsoft.com/office/drawing/2014/main" id="{537E04CE-794C-4C03-8D42-915BF356DB9B}"/>
+                <a16:creationId xmlns:a16="http://schemas.microsoft.com/office/drawing/2014/main" id="{3B0D947A-6BAD-4B29-A332-28FBF538CEF0}"/>
               </a:ext>
             </a:extLst>
           </p:cNvPr>
@@ -9956,7 +10119,7 @@
           <p:cNvPr id="22" name="">
             <a:extLst xmlns:a="http://schemas.openxmlformats.org/drawingml/2006/main">
               <a:ext uri="{FF2B5EF4-FFF2-40B4-BE49-F238E27FC236}">
-                <a16:creationId xmlns:a16="http://schemas.microsoft.com/office/drawing/2014/main" id="{1D0BEBEC-B96D-4BF4-85C4-691D1952DAF4}"/>
+                <a16:creationId xmlns:a16="http://schemas.microsoft.com/office/drawing/2014/main" id="{73FEA8B4-C03C-45FC-A864-02A0E1476C41}"/>
               </a:ext>
             </a:extLst>
           </p:cNvPr>
@@ -9982,10 +10145,168 @@
           </a:ln>
         </p:spPr>
       </p:sp>
+      <p:sp>
+        <p:nvSpPr>
+          <p:cNvPr id="23" name="Legacy module connection">
+            <a:extLst xmlns:a="http://schemas.openxmlformats.org/drawingml/2006/main">
+              <a:ext uri="{FF2B5EF4-FFF2-40B4-BE49-F238E27FC236}">
+                <a16:creationId xmlns:a16="http://schemas.microsoft.com/office/drawing/2014/main" id="{9A080492-351E-4EBB-B651-07ABA853672C}"/>
+              </a:ext>
+            </a:extLst>
+          </p:cNvPr>
+          <p:cNvSpPr>
+            <a:spLocks xmlns:a="http://schemas.openxmlformats.org/drawingml/2006/main" noGrp="1"/>
+          </p:cNvSpPr>
+          <p:nvPr/>
+        </p:nvSpPr>
+        <p:spPr>
+          <a:xfrm xmlns:a="http://schemas.openxmlformats.org/drawingml/2006/main">
+            <a:off x="609600" y="6229350"/>
+            <a:ext cx="10972800" cy="171450"/>
+          </a:xfrm>
+          <a:prstGeom xmlns:a="http://schemas.openxmlformats.org/drawingml/2006/main" prst="rect">
+            <a:avLst/>
+          </a:prstGeom>
+          <a:noFill xmlns:a="http://schemas.openxmlformats.org/drawingml/2006/main"/>
+          <a:ln xmlns:a="http://schemas.openxmlformats.org/drawingml/2006/main" w="0">
+            <a:noFill/>
+          </a:ln>
+        </p:spPr>
+        <p:txBody>
+          <a:bodyPr xmlns:a="http://schemas.openxmlformats.org/drawingml/2006/main" wrap="none" lIns="0" tIns="0" rIns="0" bIns="0" anchor="ctr">
+            <a:noAutofit/>
+          </a:bodyPr>
+          <a:lstStyle xmlns:a="http://schemas.openxmlformats.org/drawingml/2006/main">
+            <a:defPPr algn="r">
+              <a:defRPr sz="1200" b="0">
+                <a:solidFill>
+                  <a:srgbClr val="4D5A68"/>
+                </a:solidFill>
+                <a:latin typeface="Malgun Gothic"/>
+                <a:ea typeface="Malgun Gothic"/>
+                <a:cs typeface="Malgun Gothic"/>
+              </a:defRPr>
+            </a:defPPr>
+            <a:lvl1pPr algn="r">
+              <a:defRPr sz="1200" b="0">
+                <a:solidFill>
+                  <a:srgbClr val="4D5A68"/>
+                </a:solidFill>
+                <a:latin typeface="Malgun Gothic"/>
+                <a:ea typeface="Malgun Gothic"/>
+                <a:cs typeface="Malgun Gothic"/>
+              </a:defRPr>
+            </a:lvl1pPr>
+            <a:lvl2pPr algn="r">
+              <a:defRPr sz="1200" b="0">
+                <a:solidFill>
+                  <a:srgbClr val="4D5A68"/>
+                </a:solidFill>
+                <a:latin typeface="Malgun Gothic"/>
+                <a:ea typeface="Malgun Gothic"/>
+                <a:cs typeface="Malgun Gothic"/>
+              </a:defRPr>
+            </a:lvl2pPr>
+            <a:lvl3pPr algn="r">
+              <a:defRPr sz="1200" b="0">
+                <a:solidFill>
+                  <a:srgbClr val="4D5A68"/>
+                </a:solidFill>
+                <a:latin typeface="Malgun Gothic"/>
+                <a:ea typeface="Malgun Gothic"/>
+                <a:cs typeface="Malgun Gothic"/>
+              </a:defRPr>
+            </a:lvl3pPr>
+            <a:lvl4pPr algn="r">
+              <a:defRPr sz="1200" b="0">
+                <a:solidFill>
+                  <a:srgbClr val="4D5A68"/>
+                </a:solidFill>
+                <a:latin typeface="Malgun Gothic"/>
+                <a:ea typeface="Malgun Gothic"/>
+                <a:cs typeface="Malgun Gothic"/>
+              </a:defRPr>
+            </a:lvl4pPr>
+            <a:lvl5pPr algn="r">
+              <a:defRPr sz="1200" b="0">
+                <a:solidFill>
+                  <a:srgbClr val="4D5A68"/>
+                </a:solidFill>
+                <a:latin typeface="Malgun Gothic"/>
+                <a:ea typeface="Malgun Gothic"/>
+                <a:cs typeface="Malgun Gothic"/>
+              </a:defRPr>
+            </a:lvl5pPr>
+            <a:lvl6pPr algn="r">
+              <a:defRPr sz="1200" b="0">
+                <a:solidFill>
+                  <a:srgbClr val="4D5A68"/>
+                </a:solidFill>
+                <a:latin typeface="Malgun Gothic"/>
+                <a:ea typeface="Malgun Gothic"/>
+                <a:cs typeface="Malgun Gothic"/>
+              </a:defRPr>
+            </a:lvl6pPr>
+            <a:lvl7pPr algn="r">
+              <a:defRPr sz="1200" b="0">
+                <a:solidFill>
+                  <a:srgbClr val="4D5A68"/>
+                </a:solidFill>
+                <a:latin typeface="Malgun Gothic"/>
+                <a:ea typeface="Malgun Gothic"/>
+                <a:cs typeface="Malgun Gothic"/>
+              </a:defRPr>
+            </a:lvl7pPr>
+            <a:lvl8pPr algn="r">
+              <a:defRPr sz="1200" b="0">
+                <a:solidFill>
+                  <a:srgbClr val="4D5A68"/>
+                </a:solidFill>
+                <a:latin typeface="Malgun Gothic"/>
+                <a:ea typeface="Malgun Gothic"/>
+                <a:cs typeface="Malgun Gothic"/>
+              </a:defRPr>
+            </a:lvl8pPr>
+            <a:lvl9pPr algn="r">
+              <a:defRPr sz="1200" b="0">
+                <a:solidFill>
+                  <a:srgbClr val="4D5A68"/>
+                </a:solidFill>
+                <a:latin typeface="Malgun Gothic"/>
+                <a:ea typeface="Malgun Gothic"/>
+                <a:cs typeface="Malgun Gothic"/>
+              </a:defRPr>
+            </a:lvl9pPr>
+          </a:lstStyle>
+          <a:p xmlns:a="http://schemas.openxmlformats.org/drawingml/2006/main">
+            <a:pPr algn="r">
+              <a:defRPr sz="1200" b="0">
+                <a:solidFill>
+                  <a:srgbClr val="4D5A68"/>
+                </a:solidFill>
+                <a:latin typeface="Malgun Gothic"/>
+                <a:ea typeface="Malgun Gothic"/>
+                <a:cs typeface="Malgun Gothic"/>
+              </a:defRPr>
+            </a:pPr>
+            <a:r>
+              <a:rPr sz="1200" b="0">
+                <a:solidFill>
+                  <a:srgbClr val="4D5A68"/>
+                </a:solidFill>
+                <a:latin typeface="Malgun Gothic"/>
+                <a:ea typeface="Malgun Gothic"/>
+                <a:cs typeface="Malgun Gothic"/>
+              </a:rPr>
+              <a:t>M 연계 · M1</a:t>
+            </a:r>
+          </a:p>
+        </p:txBody>
+      </p:sp>
     </p:spTree>
     <p:extLst>
       <p:ext uri="{BB962C8B-B14F-4D97-AF65-F5344CB8AC3E}">
-        <p14:creationId xmlns:p14="http://schemas.microsoft.com/office/powerpoint/2010/main" val="1781120492"/>
+        <p14:creationId xmlns:p14="http://schemas.microsoft.com/office/powerpoint/2010/main" val="1165911941"/>
       </p:ext>
     </p:extLst>
   </p:cSld>
@@ -10013,10 +10334,10 @@
       </p:grpSpPr>
       <p:sp>
         <p:nvSpPr>
-          <p:cNvPr id="16" name="ACT 0 · 여러 파일을 가로지르는 질문">
+          <p:cNvPr id="17" name="ACT 0 · 여러 파일을 가로지르는 질문">
             <a:extLst xmlns:a="http://schemas.openxmlformats.org/drawingml/2006/main">
               <a:ext uri="{FF2B5EF4-FFF2-40B4-BE49-F238E27FC236}">
-                <a16:creationId xmlns:a16="http://schemas.microsoft.com/office/drawing/2014/main" id="{E32EC5B5-CF0B-4E9C-9FF0-08D3CB3ED87E}"/>
+                <a16:creationId xmlns:a16="http://schemas.microsoft.com/office/drawing/2014/main" id="{D60ACA65-37E9-4BB9-8D88-37043D02511C}"/>
               </a:ext>
             </a:extLst>
           </p:cNvPr>
@@ -10174,7 +10495,7 @@
           <p:cNvPr id="2" name="S03">
             <a:extLst xmlns:a="http://schemas.openxmlformats.org/drawingml/2006/main">
               <a:ext uri="{FF2B5EF4-FFF2-40B4-BE49-F238E27FC236}">
-                <a16:creationId xmlns:a16="http://schemas.microsoft.com/office/drawing/2014/main" id="{1D02F321-B9EF-4624-BC85-F4C866873794}"/>
+                <a16:creationId xmlns:a16="http://schemas.microsoft.com/office/drawing/2014/main" id="{478AB67B-4CB2-4E0F-92CF-77761476BD5C}"/>
               </a:ext>
             </a:extLst>
           </p:cNvPr>
@@ -10332,7 +10653,7 @@
           <p:cNvPr id="3" name="질문이 커지면 Context를 모으는 일이 생긴다">
             <a:extLst xmlns:a="http://schemas.openxmlformats.org/drawingml/2006/main">
               <a:ext uri="{FF2B5EF4-FFF2-40B4-BE49-F238E27FC236}">
-                <a16:creationId xmlns:a16="http://schemas.microsoft.com/office/drawing/2014/main" id="{DA9FE124-4AA4-4DD8-9D1D-6BBA2733E8C2}"/>
+                <a16:creationId xmlns:a16="http://schemas.microsoft.com/office/drawing/2014/main" id="{6D2023FC-90B4-457F-84C6-44D6FD606CFD}"/>
               </a:ext>
             </a:extLst>
           </p:cNvPr>
@@ -10490,7 +10811,7 @@
           <p:cNvPr id="4" name="">
             <a:extLst xmlns:a="http://schemas.openxmlformats.org/drawingml/2006/main">
               <a:ext uri="{FF2B5EF4-FFF2-40B4-BE49-F238E27FC236}">
-                <a16:creationId xmlns:a16="http://schemas.microsoft.com/office/drawing/2014/main" id="{9C059CC0-A021-4F04-8FAC-A8A186D21797}"/>
+                <a16:creationId xmlns:a16="http://schemas.microsoft.com/office/drawing/2014/main" id="{3E32B17B-545C-49AC-8657-38C67E57A5ED}"/>
               </a:ext>
             </a:extLst>
           </p:cNvPr>
@@ -10501,7 +10822,7 @@
         </p:nvSpPr>
         <p:spPr>
           <a:xfrm xmlns:a="http://schemas.openxmlformats.org/drawingml/2006/main">
-            <a:off x="609600" y="5829300"/>
+            <a:off x="609600" y="5753100"/>
             <a:ext cx="10972800" cy="0"/>
           </a:xfrm>
           <a:prstGeom xmlns:a="http://schemas.openxmlformats.org/drawingml/2006/main" prst="line">
@@ -10521,7 +10842,7 @@
           <p:cNvPr id="5" name="개념 사례 · 사람이 Context를 모으는 장면 · AI 생성 설명용 삽화">
             <a:extLst xmlns:a="http://schemas.openxmlformats.org/drawingml/2006/main">
               <a:ext uri="{FF2B5EF4-FFF2-40B4-BE49-F238E27FC236}">
-                <a16:creationId xmlns:a16="http://schemas.microsoft.com/office/drawing/2014/main" id="{4BF4598B-2D02-4CBF-BBBB-89E9502D0ED1}"/>
+                <a16:creationId xmlns:a16="http://schemas.microsoft.com/office/drawing/2014/main" id="{62797A69-9E0E-4584-BCE9-B95978D5602B}"/>
               </a:ext>
             </a:extLst>
           </p:cNvPr>
@@ -10532,8 +10853,8 @@
         </p:nvSpPr>
         <p:spPr>
           <a:xfrm xmlns:a="http://schemas.openxmlformats.org/drawingml/2006/main">
-            <a:off x="609600" y="5915025"/>
-            <a:ext cx="10972800" cy="247650"/>
+            <a:off x="609600" y="5791200"/>
+            <a:ext cx="10972800" cy="228600"/>
           </a:xfrm>
           <a:prstGeom xmlns:a="http://schemas.openxmlformats.org/drawingml/2006/main" prst="rect">
             <a:avLst/>
@@ -10679,7 +11000,7 @@
           <p:cNvPr id="6" name="특정 Trial에서 실제로 발생한 비용이나 실패를 뜻하지 않습니다.">
             <a:extLst xmlns:a="http://schemas.openxmlformats.org/drawingml/2006/main">
               <a:ext uri="{FF2B5EF4-FFF2-40B4-BE49-F238E27FC236}">
-                <a16:creationId xmlns:a16="http://schemas.microsoft.com/office/drawing/2014/main" id="{DD846C2A-6C66-4ED5-B225-69533FEAFC98}"/>
+                <a16:creationId xmlns:a16="http://schemas.microsoft.com/office/drawing/2014/main" id="{B5C6DC98-DDA1-4A44-B847-47C4FFA54C5A}"/>
               </a:ext>
             </a:extLst>
           </p:cNvPr>
@@ -10690,8 +11011,8 @@
         </p:nvSpPr>
         <p:spPr>
           <a:xfrm xmlns:a="http://schemas.openxmlformats.org/drawingml/2006/main">
-            <a:off x="609600" y="6191250"/>
-            <a:ext cx="10972800" cy="285750"/>
+            <a:off x="609600" y="6019800"/>
+            <a:ext cx="10972800" cy="209550"/>
           </a:xfrm>
           <a:prstGeom xmlns:a="http://schemas.openxmlformats.org/drawingml/2006/main" prst="rect">
             <a:avLst/>
@@ -10837,7 +11158,7 @@
           <p:cNvPr id="7" name="“CLI 결과가 기대와 다른데, 어디서부터 봐야 할까?”">
             <a:extLst xmlns:a="http://schemas.openxmlformats.org/drawingml/2006/main">
               <a:ext uri="{FF2B5EF4-FFF2-40B4-BE49-F238E27FC236}">
-                <a16:creationId xmlns:a16="http://schemas.microsoft.com/office/drawing/2014/main" id="{17B68042-9365-493C-96BE-D75113A01E06}"/>
+                <a16:creationId xmlns:a16="http://schemas.microsoft.com/office/drawing/2014/main" id="{2FC0AF27-7E96-42C5-8755-A4C6CD25CCEC}"/>
               </a:ext>
             </a:extLst>
           </p:cNvPr>
@@ -10995,7 +11316,7 @@
           <p:cNvPr id="8" name="">
             <a:extLst xmlns:a="http://schemas.openxmlformats.org/drawingml/2006/main">
               <a:ext uri="{FF2B5EF4-FFF2-40B4-BE49-F238E27FC236}">
-                <a16:creationId xmlns:a16="http://schemas.microsoft.com/office/drawing/2014/main" id="{90F3B1DB-7BF8-472E-957A-BBC35327AFF1}"/>
+                <a16:creationId xmlns:a16="http://schemas.microsoft.com/office/drawing/2014/main" id="{7F3BE60F-8C6E-4A23-944D-AD4384782122}"/>
               </a:ext>
             </a:extLst>
           </p:cNvPr>
@@ -11005,7 +11326,7 @@
           <p:nvPr/>
         </p:nvPicPr>
         <p:blipFill>
-          <a:blip xmlns:r="http://schemas.openxmlformats.org/officeDocument/2006/relationships" xmlns:a="http://schemas.openxmlformats.org/drawingml/2006/main" r:embed="R34c67a750acc4c48"/>
+          <a:blip xmlns:r="http://schemas.openxmlformats.org/officeDocument/2006/relationships" xmlns:a="http://schemas.openxmlformats.org/drawingml/2006/main" r:embed="R4aaaad75f8ef4961"/>
           <a:stretch xmlns:a="http://schemas.openxmlformats.org/drawingml/2006/main"/>
         </p:blipFill>
         <p:spPr>
@@ -11023,7 +11344,7 @@
           <p:cNvPr id="9" name="구현 · 호출 경로">
             <a:extLst xmlns:a="http://schemas.openxmlformats.org/drawingml/2006/main">
               <a:ext uri="{FF2B5EF4-FFF2-40B4-BE49-F238E27FC236}">
-                <a16:creationId xmlns:a16="http://schemas.microsoft.com/office/drawing/2014/main" id="{98092A52-5B30-4E66-B1FC-0D1353EB61BD}"/>
+                <a16:creationId xmlns:a16="http://schemas.microsoft.com/office/drawing/2014/main" id="{C5414102-2071-4FAD-9A4A-D907FD589DBC}"/>
               </a:ext>
             </a:extLst>
           </p:cNvPr>
@@ -11181,7 +11502,7 @@
           <p:cNvPr id="10" name="CLI → 처리 흐름 → 연산">
             <a:extLst xmlns:a="http://schemas.openxmlformats.org/drawingml/2006/main">
               <a:ext uri="{FF2B5EF4-FFF2-40B4-BE49-F238E27FC236}">
-                <a16:creationId xmlns:a16="http://schemas.microsoft.com/office/drawing/2014/main" id="{E1E24024-4084-43A0-889F-C73414A8559C}"/>
+                <a16:creationId xmlns:a16="http://schemas.microsoft.com/office/drawing/2014/main" id="{072C5725-8FE7-4BC9-A43B-E88FA905B48E}"/>
               </a:ext>
             </a:extLst>
           </p:cNvPr>
@@ -11339,7 +11660,7 @@
           <p:cNvPr id="11" name="테스트">
             <a:extLst xmlns:a="http://schemas.openxmlformats.org/drawingml/2006/main">
               <a:ext uri="{FF2B5EF4-FFF2-40B4-BE49-F238E27FC236}">
-                <a16:creationId xmlns:a16="http://schemas.microsoft.com/office/drawing/2014/main" id="{DD485D76-4658-4F44-824F-FDCB8506B220}"/>
+                <a16:creationId xmlns:a16="http://schemas.microsoft.com/office/drawing/2014/main" id="{D8A81AEB-0C46-4544-83CE-011CA625B266}"/>
               </a:ext>
             </a:extLst>
           </p:cNvPr>
@@ -11497,7 +11818,7 @@
           <p:cNvPr id="12" name="어떤 조건에서 실패했나?">
             <a:extLst xmlns:a="http://schemas.openxmlformats.org/drawingml/2006/main">
               <a:ext uri="{FF2B5EF4-FFF2-40B4-BE49-F238E27FC236}">
-                <a16:creationId xmlns:a16="http://schemas.microsoft.com/office/drawing/2014/main" id="{10BC8032-4C71-4614-9ECE-2BCC52EAE42C}"/>
+                <a16:creationId xmlns:a16="http://schemas.microsoft.com/office/drawing/2014/main" id="{1B0BE875-5B90-4221-A120-FB1312EA07C4}"/>
               </a:ext>
             </a:extLst>
           </p:cNvPr>
@@ -11655,7 +11976,7 @@
           <p:cNvPr id="13" name="계약">
             <a:extLst xmlns:a="http://schemas.openxmlformats.org/drawingml/2006/main">
               <a:ext uri="{FF2B5EF4-FFF2-40B4-BE49-F238E27FC236}">
-                <a16:creationId xmlns:a16="http://schemas.microsoft.com/office/drawing/2014/main" id="{0C29D29D-97C8-4E47-B063-87429B734E45}"/>
+                <a16:creationId xmlns:a16="http://schemas.microsoft.com/office/drawing/2014/main" id="{4A229DCD-FA9D-4ACE-A537-D79290D45B1A}"/>
               </a:ext>
             </a:extLst>
           </p:cNvPr>
@@ -11813,7 +12134,7 @@
           <p:cNvPr id="14" name="원래 기대한 동작은?">
             <a:extLst xmlns:a="http://schemas.openxmlformats.org/drawingml/2006/main">
               <a:ext uri="{FF2B5EF4-FFF2-40B4-BE49-F238E27FC236}">
-                <a16:creationId xmlns:a16="http://schemas.microsoft.com/office/drawing/2014/main" id="{A971205B-F7B8-4129-BA44-727F9BC1FDF5}"/>
+                <a16:creationId xmlns:a16="http://schemas.microsoft.com/office/drawing/2014/main" id="{F97A8B2A-E556-4328-95C1-E6121BD2EB1B}"/>
               </a:ext>
             </a:extLst>
           </p:cNvPr>
@@ -11971,7 +12292,7 @@
           <p:cNvPr id="15" name="질문에 옮길 자료는?">
             <a:extLst xmlns:a="http://schemas.openxmlformats.org/drawingml/2006/main">
               <a:ext uri="{FF2B5EF4-FFF2-40B4-BE49-F238E27FC236}">
-                <a16:creationId xmlns:a16="http://schemas.microsoft.com/office/drawing/2014/main" id="{1DCB780E-1F07-4E22-821A-E042F687EB5E}"/>
+                <a16:creationId xmlns:a16="http://schemas.microsoft.com/office/drawing/2014/main" id="{14A748A3-42CA-41E1-8AF9-F853F895FA53}"/>
               </a:ext>
             </a:extLst>
           </p:cNvPr>
@@ -12124,10 +12445,168 @@
           </a:p>
         </p:txBody>
       </p:sp>
+      <p:sp>
+        <p:nvSpPr>
+          <p:cNvPr id="16" name="Legacy module connection">
+            <a:extLst xmlns:a="http://schemas.openxmlformats.org/drawingml/2006/main">
+              <a:ext uri="{FF2B5EF4-FFF2-40B4-BE49-F238E27FC236}">
+                <a16:creationId xmlns:a16="http://schemas.microsoft.com/office/drawing/2014/main" id="{B112591C-0A83-4D07-943E-401763C673B1}"/>
+              </a:ext>
+            </a:extLst>
+          </p:cNvPr>
+          <p:cNvSpPr>
+            <a:spLocks xmlns:a="http://schemas.openxmlformats.org/drawingml/2006/main" noGrp="1"/>
+          </p:cNvSpPr>
+          <p:nvPr/>
+        </p:nvSpPr>
+        <p:spPr>
+          <a:xfrm xmlns:a="http://schemas.openxmlformats.org/drawingml/2006/main">
+            <a:off x="609600" y="6229350"/>
+            <a:ext cx="10972800" cy="171450"/>
+          </a:xfrm>
+          <a:prstGeom xmlns:a="http://schemas.openxmlformats.org/drawingml/2006/main" prst="rect">
+            <a:avLst/>
+          </a:prstGeom>
+          <a:noFill xmlns:a="http://schemas.openxmlformats.org/drawingml/2006/main"/>
+          <a:ln xmlns:a="http://schemas.openxmlformats.org/drawingml/2006/main" w="0">
+            <a:noFill/>
+          </a:ln>
+        </p:spPr>
+        <p:txBody>
+          <a:bodyPr xmlns:a="http://schemas.openxmlformats.org/drawingml/2006/main" wrap="none" lIns="0" tIns="0" rIns="0" bIns="0" anchor="ctr">
+            <a:noAutofit/>
+          </a:bodyPr>
+          <a:lstStyle xmlns:a="http://schemas.openxmlformats.org/drawingml/2006/main">
+            <a:defPPr algn="r">
+              <a:defRPr sz="1200" b="0">
+                <a:solidFill>
+                  <a:srgbClr val="4D5A68"/>
+                </a:solidFill>
+                <a:latin typeface="Malgun Gothic"/>
+                <a:ea typeface="Malgun Gothic"/>
+                <a:cs typeface="Malgun Gothic"/>
+              </a:defRPr>
+            </a:defPPr>
+            <a:lvl1pPr algn="r">
+              <a:defRPr sz="1200" b="0">
+                <a:solidFill>
+                  <a:srgbClr val="4D5A68"/>
+                </a:solidFill>
+                <a:latin typeface="Malgun Gothic"/>
+                <a:ea typeface="Malgun Gothic"/>
+                <a:cs typeface="Malgun Gothic"/>
+              </a:defRPr>
+            </a:lvl1pPr>
+            <a:lvl2pPr algn="r">
+              <a:defRPr sz="1200" b="0">
+                <a:solidFill>
+                  <a:srgbClr val="4D5A68"/>
+                </a:solidFill>
+                <a:latin typeface="Malgun Gothic"/>
+                <a:ea typeface="Malgun Gothic"/>
+                <a:cs typeface="Malgun Gothic"/>
+              </a:defRPr>
+            </a:lvl2pPr>
+            <a:lvl3pPr algn="r">
+              <a:defRPr sz="1200" b="0">
+                <a:solidFill>
+                  <a:srgbClr val="4D5A68"/>
+                </a:solidFill>
+                <a:latin typeface="Malgun Gothic"/>
+                <a:ea typeface="Malgun Gothic"/>
+                <a:cs typeface="Malgun Gothic"/>
+              </a:defRPr>
+            </a:lvl3pPr>
+            <a:lvl4pPr algn="r">
+              <a:defRPr sz="1200" b="0">
+                <a:solidFill>
+                  <a:srgbClr val="4D5A68"/>
+                </a:solidFill>
+                <a:latin typeface="Malgun Gothic"/>
+                <a:ea typeface="Malgun Gothic"/>
+                <a:cs typeface="Malgun Gothic"/>
+              </a:defRPr>
+            </a:lvl4pPr>
+            <a:lvl5pPr algn="r">
+              <a:defRPr sz="1200" b="0">
+                <a:solidFill>
+                  <a:srgbClr val="4D5A68"/>
+                </a:solidFill>
+                <a:latin typeface="Malgun Gothic"/>
+                <a:ea typeface="Malgun Gothic"/>
+                <a:cs typeface="Malgun Gothic"/>
+              </a:defRPr>
+            </a:lvl5pPr>
+            <a:lvl6pPr algn="r">
+              <a:defRPr sz="1200" b="0">
+                <a:solidFill>
+                  <a:srgbClr val="4D5A68"/>
+                </a:solidFill>
+                <a:latin typeface="Malgun Gothic"/>
+                <a:ea typeface="Malgun Gothic"/>
+                <a:cs typeface="Malgun Gothic"/>
+              </a:defRPr>
+            </a:lvl6pPr>
+            <a:lvl7pPr algn="r">
+              <a:defRPr sz="1200" b="0">
+                <a:solidFill>
+                  <a:srgbClr val="4D5A68"/>
+                </a:solidFill>
+                <a:latin typeface="Malgun Gothic"/>
+                <a:ea typeface="Malgun Gothic"/>
+                <a:cs typeface="Malgun Gothic"/>
+              </a:defRPr>
+            </a:lvl7pPr>
+            <a:lvl8pPr algn="r">
+              <a:defRPr sz="1200" b="0">
+                <a:solidFill>
+                  <a:srgbClr val="4D5A68"/>
+                </a:solidFill>
+                <a:latin typeface="Malgun Gothic"/>
+                <a:ea typeface="Malgun Gothic"/>
+                <a:cs typeface="Malgun Gothic"/>
+              </a:defRPr>
+            </a:lvl8pPr>
+            <a:lvl9pPr algn="r">
+              <a:defRPr sz="1200" b="0">
+                <a:solidFill>
+                  <a:srgbClr val="4D5A68"/>
+                </a:solidFill>
+                <a:latin typeface="Malgun Gothic"/>
+                <a:ea typeface="Malgun Gothic"/>
+                <a:cs typeface="Malgun Gothic"/>
+              </a:defRPr>
+            </a:lvl9pPr>
+          </a:lstStyle>
+          <a:p xmlns:a="http://schemas.openxmlformats.org/drawingml/2006/main">
+            <a:pPr algn="r">
+              <a:defRPr sz="1200" b="0">
+                <a:solidFill>
+                  <a:srgbClr val="4D5A68"/>
+                </a:solidFill>
+                <a:latin typeface="Malgun Gothic"/>
+                <a:ea typeface="Malgun Gothic"/>
+                <a:cs typeface="Malgun Gothic"/>
+              </a:defRPr>
+            </a:pPr>
+            <a:r>
+              <a:rPr sz="1200" b="0">
+                <a:solidFill>
+                  <a:srgbClr val="4D5A68"/>
+                </a:solidFill>
+                <a:latin typeface="Malgun Gothic"/>
+                <a:ea typeface="Malgun Gothic"/>
+                <a:cs typeface="Malgun Gothic"/>
+              </a:rPr>
+              <a:t>M 연계 · M1 · M6</a:t>
+            </a:r>
+          </a:p>
+        </p:txBody>
+      </p:sp>
     </p:spTree>
     <p:extLst>
       <p:ext uri="{BB962C8B-B14F-4D97-AF65-F5344CB8AC3E}">
-        <p14:creationId xmlns:p14="http://schemas.microsoft.com/office/powerpoint/2010/main" val="495378236"/>
+        <p14:creationId xmlns:p14="http://schemas.microsoft.com/office/powerpoint/2010/main" val="111320051"/>
       </p:ext>
     </p:extLst>
   </p:cSld>
@@ -12155,10 +12634,10 @@
       </p:grpSpPr>
       <p:sp>
         <p:nvSpPr>
-          <p:cNvPr id="13" name="ACT 0 · Repository 조사 관찰">
+          <p:cNvPr id="14" name="ACT 0 · Repository 조사 관찰">
             <a:extLst xmlns:a="http://schemas.openxmlformats.org/drawingml/2006/main">
               <a:ext uri="{FF2B5EF4-FFF2-40B4-BE49-F238E27FC236}">
-                <a16:creationId xmlns:a16="http://schemas.microsoft.com/office/drawing/2014/main" id="{FDEDE37D-6F6A-46EF-A169-739CD4FD124A}"/>
+                <a16:creationId xmlns:a16="http://schemas.microsoft.com/office/drawing/2014/main" id="{4BAD9634-1B19-4260-B574-64D375C1E9CA}"/>
               </a:ext>
             </a:extLst>
           </p:cNvPr>
@@ -12316,7 +12795,7 @@
           <p:cNvPr id="2" name="S04">
             <a:extLst xmlns:a="http://schemas.openxmlformats.org/drawingml/2006/main">
               <a:ext uri="{FF2B5EF4-FFF2-40B4-BE49-F238E27FC236}">
-                <a16:creationId xmlns:a16="http://schemas.microsoft.com/office/drawing/2014/main" id="{FD7A7D32-827F-4CA3-BCAA-F5EAC5096B11}"/>
+                <a16:creationId xmlns:a16="http://schemas.microsoft.com/office/drawing/2014/main" id="{F414504B-BD96-45DA-B194-EACAFF0B5EE4}"/>
               </a:ext>
             </a:extLst>
           </p:cNvPr>
@@ -12474,7 +12953,7 @@
           <p:cNvPr id="3" name="파일명을 주지 않으면 Agent는 어디부터 볼까?">
             <a:extLst xmlns:a="http://schemas.openxmlformats.org/drawingml/2006/main">
               <a:ext uri="{FF2B5EF4-FFF2-40B4-BE49-F238E27FC236}">
-                <a16:creationId xmlns:a16="http://schemas.microsoft.com/office/drawing/2014/main" id="{2BC2B3E5-0697-467C-BA80-B3F00F85FD0B}"/>
+                <a16:creationId xmlns:a16="http://schemas.microsoft.com/office/drawing/2014/main" id="{E2C36EA0-861F-4203-8228-E7CE3C903FFC}"/>
               </a:ext>
             </a:extLst>
           </p:cNvPr>
@@ -12632,7 +13111,7 @@
           <p:cNvPr id="4" name="">
             <a:extLst xmlns:a="http://schemas.openxmlformats.org/drawingml/2006/main">
               <a:ext uri="{FF2B5EF4-FFF2-40B4-BE49-F238E27FC236}">
-                <a16:creationId xmlns:a16="http://schemas.microsoft.com/office/drawing/2014/main" id="{10BCA94E-8DD7-4897-AC34-1F4F9A9CF783}"/>
+                <a16:creationId xmlns:a16="http://schemas.microsoft.com/office/drawing/2014/main" id="{19B02C1E-7093-44FC-BC1D-6FDF864AE00F}"/>
               </a:ext>
             </a:extLst>
           </p:cNvPr>
@@ -12643,7 +13122,7 @@
         </p:nvSpPr>
         <p:spPr>
           <a:xfrm xmlns:a="http://schemas.openxmlformats.org/drawingml/2006/main">
-            <a:off x="609600" y="5829300"/>
+            <a:off x="609600" y="5753100"/>
             <a:ext cx="10972800" cy="0"/>
           </a:xfrm>
           <a:prstGeom xmlns:a="http://schemas.openxmlformats.org/drawingml/2006/main" prst="line">
@@ -12663,7 +13142,7 @@
           <p:cNvPr id="5" name="TRIAL-001 실제 요청 발췌 · Codex CLI 0.154.0 · macOS · 읽기 전용">
             <a:extLst xmlns:a="http://schemas.openxmlformats.org/drawingml/2006/main">
               <a:ext uri="{FF2B5EF4-FFF2-40B4-BE49-F238E27FC236}">
-                <a16:creationId xmlns:a16="http://schemas.microsoft.com/office/drawing/2014/main" id="{94F4925B-2E64-4FD2-B4D0-AE2280B48953}"/>
+                <a16:creationId xmlns:a16="http://schemas.microsoft.com/office/drawing/2014/main" id="{F133790D-72E6-4422-948B-5863A6B891B2}"/>
               </a:ext>
             </a:extLst>
           </p:cNvPr>
@@ -12674,8 +13153,8 @@
         </p:nvSpPr>
         <p:spPr>
           <a:xfrm xmlns:a="http://schemas.openxmlformats.org/drawingml/2006/main">
-            <a:off x="609600" y="5915025"/>
-            <a:ext cx="10972800" cy="247650"/>
+            <a:off x="609600" y="5791200"/>
+            <a:ext cx="10972800" cy="228600"/>
           </a:xfrm>
           <a:prstGeom xmlns:a="http://schemas.openxmlformats.org/drawingml/2006/main" prst="rect">
             <a:avLst/>
@@ -12821,7 +13300,7 @@
           <p:cNvPr id="6" name="과거 단일 실행의 기록을 살펴봅니다. 현재 Desktop 동작은 미검증입니다.">
             <a:extLst xmlns:a="http://schemas.openxmlformats.org/drawingml/2006/main">
               <a:ext uri="{FF2B5EF4-FFF2-40B4-BE49-F238E27FC236}">
-                <a16:creationId xmlns:a16="http://schemas.microsoft.com/office/drawing/2014/main" id="{1B9E8C22-EEAD-405E-AE1D-2C73081E0E3E}"/>
+                <a16:creationId xmlns:a16="http://schemas.microsoft.com/office/drawing/2014/main" id="{D3C1E44E-DF14-4287-AADC-71C61B3285FF}"/>
               </a:ext>
             </a:extLst>
           </p:cNvPr>
@@ -12832,7 +13311,7 @@
         </p:nvSpPr>
         <p:spPr>
           <a:xfrm xmlns:a="http://schemas.openxmlformats.org/drawingml/2006/main">
-            <a:off x="609600" y="6191250"/>
+            <a:off x="609600" y="6019800"/>
             <a:ext cx="10972800" cy="209550"/>
           </a:xfrm>
           <a:prstGeom xmlns:a="http://schemas.openxmlformats.org/drawingml/2006/main" prst="rect">
@@ -12979,7 +13458,7 @@
           <p:cNvPr id="7" name="“현재 이 저장소에서 테스트 하나가 실패하고 있다.&#10;실패 원인을 조사해줘. 관련 구현과 호출 경로,&#10;실패하는">
             <a:extLst xmlns:a="http://schemas.openxmlformats.org/drawingml/2006/main">
               <a:ext uri="{FF2B5EF4-FFF2-40B4-BE49-F238E27FC236}">
-                <a16:creationId xmlns:a16="http://schemas.microsoft.com/office/drawing/2014/main" id="{541A9946-A504-4F48-90F4-12D8CEF434FC}"/>
+                <a16:creationId xmlns:a16="http://schemas.microsoft.com/office/drawing/2014/main" id="{DDC4CEA4-236F-4C28-9D00-0F6C234DCEBB}"/>
               </a:ext>
             </a:extLst>
           </p:cNvPr>
@@ -13206,7 +13685,7 @@
           <p:cNvPr id="8" name="">
             <a:extLst xmlns:a="http://schemas.openxmlformats.org/drawingml/2006/main">
               <a:ext uri="{FF2B5EF4-FFF2-40B4-BE49-F238E27FC236}">
-                <a16:creationId xmlns:a16="http://schemas.microsoft.com/office/drawing/2014/main" id="{6BF05883-528A-42D0-BB13-FA7BAD6D515B}"/>
+                <a16:creationId xmlns:a16="http://schemas.microsoft.com/office/drawing/2014/main" id="{74E0DE5A-C8B7-46F9-9059-2A2EA4E11B4A}"/>
               </a:ext>
             </a:extLst>
           </p:cNvPr>
@@ -13237,7 +13716,7 @@
           <p:cNvPr id="9" name="찾았는지 확인할 세 가지">
             <a:extLst xmlns:a="http://schemas.openxmlformats.org/drawingml/2006/main">
               <a:ext uri="{FF2B5EF4-FFF2-40B4-BE49-F238E27FC236}">
-                <a16:creationId xmlns:a16="http://schemas.microsoft.com/office/drawing/2014/main" id="{06FE472F-3B34-4CBD-BBDE-66FAFB0E4049}"/>
+                <a16:creationId xmlns:a16="http://schemas.microsoft.com/office/drawing/2014/main" id="{4192E423-7DD3-4BC5-941A-B5BC09D4086F}"/>
               </a:ext>
             </a:extLst>
           </p:cNvPr>
@@ -13395,7 +13874,7 @@
           <p:cNvPr id="10" name="01  실패하는 테스트">
             <a:extLst xmlns:a="http://schemas.openxmlformats.org/drawingml/2006/main">
               <a:ext uri="{FF2B5EF4-FFF2-40B4-BE49-F238E27FC236}">
-                <a16:creationId xmlns:a16="http://schemas.microsoft.com/office/drawing/2014/main" id="{6BD57DC0-1A84-4381-B6F0-DB39DA04E7FA}"/>
+                <a16:creationId xmlns:a16="http://schemas.microsoft.com/office/drawing/2014/main" id="{98990F5D-06A0-46CB-8910-2EC473C99F64}"/>
               </a:ext>
             </a:extLst>
           </p:cNvPr>
@@ -13553,7 +14032,7 @@
           <p:cNvPr id="11" name="02  관련 구현">
             <a:extLst xmlns:a="http://schemas.openxmlformats.org/drawingml/2006/main">
               <a:ext uri="{FF2B5EF4-FFF2-40B4-BE49-F238E27FC236}">
-                <a16:creationId xmlns:a16="http://schemas.microsoft.com/office/drawing/2014/main" id="{C5466243-39DA-401A-84A9-E924E6BBC795}"/>
+                <a16:creationId xmlns:a16="http://schemas.microsoft.com/office/drawing/2014/main" id="{7C3C20FE-576C-4B79-A7B1-EFD000584996}"/>
               </a:ext>
             </a:extLst>
           </p:cNvPr>
@@ -13711,7 +14190,7 @@
           <p:cNvPr id="12" name="03  제품의 호출 경로">
             <a:extLst xmlns:a="http://schemas.openxmlformats.org/drawingml/2006/main">
               <a:ext uri="{FF2B5EF4-FFF2-40B4-BE49-F238E27FC236}">
-                <a16:creationId xmlns:a16="http://schemas.microsoft.com/office/drawing/2014/main" id="{4BA22D99-3739-4026-B9D0-778175CF8D5A}"/>
+                <a16:creationId xmlns:a16="http://schemas.microsoft.com/office/drawing/2014/main" id="{249E3405-A390-4AB7-A10A-434F80F68376}"/>
               </a:ext>
             </a:extLst>
           </p:cNvPr>
@@ -13864,10 +14343,168 @@
           </a:p>
         </p:txBody>
       </p:sp>
+      <p:sp>
+        <p:nvSpPr>
+          <p:cNvPr id="13" name="Legacy module connection">
+            <a:extLst xmlns:a="http://schemas.openxmlformats.org/drawingml/2006/main">
+              <a:ext uri="{FF2B5EF4-FFF2-40B4-BE49-F238E27FC236}">
+                <a16:creationId xmlns:a16="http://schemas.microsoft.com/office/drawing/2014/main" id="{94857329-0022-4D4A-8EE4-DF4D28E3E776}"/>
+              </a:ext>
+            </a:extLst>
+          </p:cNvPr>
+          <p:cNvSpPr>
+            <a:spLocks xmlns:a="http://schemas.openxmlformats.org/drawingml/2006/main" noGrp="1"/>
+          </p:cNvSpPr>
+          <p:nvPr/>
+        </p:nvSpPr>
+        <p:spPr>
+          <a:xfrm xmlns:a="http://schemas.openxmlformats.org/drawingml/2006/main">
+            <a:off x="609600" y="6229350"/>
+            <a:ext cx="10972800" cy="171450"/>
+          </a:xfrm>
+          <a:prstGeom xmlns:a="http://schemas.openxmlformats.org/drawingml/2006/main" prst="rect">
+            <a:avLst/>
+          </a:prstGeom>
+          <a:noFill xmlns:a="http://schemas.openxmlformats.org/drawingml/2006/main"/>
+          <a:ln xmlns:a="http://schemas.openxmlformats.org/drawingml/2006/main" w="0">
+            <a:noFill/>
+          </a:ln>
+        </p:spPr>
+        <p:txBody>
+          <a:bodyPr xmlns:a="http://schemas.openxmlformats.org/drawingml/2006/main" wrap="none" lIns="0" tIns="0" rIns="0" bIns="0" anchor="ctr">
+            <a:noAutofit/>
+          </a:bodyPr>
+          <a:lstStyle xmlns:a="http://schemas.openxmlformats.org/drawingml/2006/main">
+            <a:defPPr algn="r">
+              <a:defRPr sz="1200" b="0">
+                <a:solidFill>
+                  <a:srgbClr val="4D5A68"/>
+                </a:solidFill>
+                <a:latin typeface="Malgun Gothic"/>
+                <a:ea typeface="Malgun Gothic"/>
+                <a:cs typeface="Malgun Gothic"/>
+              </a:defRPr>
+            </a:defPPr>
+            <a:lvl1pPr algn="r">
+              <a:defRPr sz="1200" b="0">
+                <a:solidFill>
+                  <a:srgbClr val="4D5A68"/>
+                </a:solidFill>
+                <a:latin typeface="Malgun Gothic"/>
+                <a:ea typeface="Malgun Gothic"/>
+                <a:cs typeface="Malgun Gothic"/>
+              </a:defRPr>
+            </a:lvl1pPr>
+            <a:lvl2pPr algn="r">
+              <a:defRPr sz="1200" b="0">
+                <a:solidFill>
+                  <a:srgbClr val="4D5A68"/>
+                </a:solidFill>
+                <a:latin typeface="Malgun Gothic"/>
+                <a:ea typeface="Malgun Gothic"/>
+                <a:cs typeface="Malgun Gothic"/>
+              </a:defRPr>
+            </a:lvl2pPr>
+            <a:lvl3pPr algn="r">
+              <a:defRPr sz="1200" b="0">
+                <a:solidFill>
+                  <a:srgbClr val="4D5A68"/>
+                </a:solidFill>
+                <a:latin typeface="Malgun Gothic"/>
+                <a:ea typeface="Malgun Gothic"/>
+                <a:cs typeface="Malgun Gothic"/>
+              </a:defRPr>
+            </a:lvl3pPr>
+            <a:lvl4pPr algn="r">
+              <a:defRPr sz="1200" b="0">
+                <a:solidFill>
+                  <a:srgbClr val="4D5A68"/>
+                </a:solidFill>
+                <a:latin typeface="Malgun Gothic"/>
+                <a:ea typeface="Malgun Gothic"/>
+                <a:cs typeface="Malgun Gothic"/>
+              </a:defRPr>
+            </a:lvl4pPr>
+            <a:lvl5pPr algn="r">
+              <a:defRPr sz="1200" b="0">
+                <a:solidFill>
+                  <a:srgbClr val="4D5A68"/>
+                </a:solidFill>
+                <a:latin typeface="Malgun Gothic"/>
+                <a:ea typeface="Malgun Gothic"/>
+                <a:cs typeface="Malgun Gothic"/>
+              </a:defRPr>
+            </a:lvl5pPr>
+            <a:lvl6pPr algn="r">
+              <a:defRPr sz="1200" b="0">
+                <a:solidFill>
+                  <a:srgbClr val="4D5A68"/>
+                </a:solidFill>
+                <a:latin typeface="Malgun Gothic"/>
+                <a:ea typeface="Malgun Gothic"/>
+                <a:cs typeface="Malgun Gothic"/>
+              </a:defRPr>
+            </a:lvl6pPr>
+            <a:lvl7pPr algn="r">
+              <a:defRPr sz="1200" b="0">
+                <a:solidFill>
+                  <a:srgbClr val="4D5A68"/>
+                </a:solidFill>
+                <a:latin typeface="Malgun Gothic"/>
+                <a:ea typeface="Malgun Gothic"/>
+                <a:cs typeface="Malgun Gothic"/>
+              </a:defRPr>
+            </a:lvl7pPr>
+            <a:lvl8pPr algn="r">
+              <a:defRPr sz="1200" b="0">
+                <a:solidFill>
+                  <a:srgbClr val="4D5A68"/>
+                </a:solidFill>
+                <a:latin typeface="Malgun Gothic"/>
+                <a:ea typeface="Malgun Gothic"/>
+                <a:cs typeface="Malgun Gothic"/>
+              </a:defRPr>
+            </a:lvl8pPr>
+            <a:lvl9pPr algn="r">
+              <a:defRPr sz="1200" b="0">
+                <a:solidFill>
+                  <a:srgbClr val="4D5A68"/>
+                </a:solidFill>
+                <a:latin typeface="Malgun Gothic"/>
+                <a:ea typeface="Malgun Gothic"/>
+                <a:cs typeface="Malgun Gothic"/>
+              </a:defRPr>
+            </a:lvl9pPr>
+          </a:lstStyle>
+          <a:p xmlns:a="http://schemas.openxmlformats.org/drawingml/2006/main">
+            <a:pPr algn="r">
+              <a:defRPr sz="1200" b="0">
+                <a:solidFill>
+                  <a:srgbClr val="4D5A68"/>
+                </a:solidFill>
+                <a:latin typeface="Malgun Gothic"/>
+                <a:ea typeface="Malgun Gothic"/>
+                <a:cs typeface="Malgun Gothic"/>
+              </a:defRPr>
+            </a:pPr>
+            <a:r>
+              <a:rPr sz="1200" b="0">
+                <a:solidFill>
+                  <a:srgbClr val="4D5A68"/>
+                </a:solidFill>
+                <a:latin typeface="Malgun Gothic"/>
+                <a:ea typeface="Malgun Gothic"/>
+                <a:cs typeface="Malgun Gothic"/>
+              </a:rPr>
+              <a:t>M 연계 · M6</a:t>
+            </a:r>
+          </a:p>
+        </p:txBody>
+      </p:sp>
     </p:spTree>
     <p:extLst>
       <p:ext uri="{BB962C8B-B14F-4D97-AF65-F5344CB8AC3E}">
-        <p14:creationId xmlns:p14="http://schemas.microsoft.com/office/powerpoint/2010/main" val="1065014673"/>
+        <p14:creationId xmlns:p14="http://schemas.microsoft.com/office/powerpoint/2010/main" val="404181943"/>
       </p:ext>
     </p:extLst>
   </p:cSld>
@@ -13895,10 +14532,10 @@
       </p:grpSpPr>
       <p:sp>
         <p:nvSpPr>
-          <p:cNvPr id="63" name="ACT 0  ·  Repository 탐색">
+          <p:cNvPr id="64" name="ACT 0  ·  Repository 탐색">
             <a:extLst xmlns:a="http://schemas.openxmlformats.org/drawingml/2006/main">
               <a:ext uri="{FF2B5EF4-FFF2-40B4-BE49-F238E27FC236}">
-                <a16:creationId xmlns:a16="http://schemas.microsoft.com/office/drawing/2014/main" id="{12A5DA8C-EC33-4556-8C1D-722A8E592990}"/>
+                <a16:creationId xmlns:a16="http://schemas.microsoft.com/office/drawing/2014/main" id="{84AC7136-05F0-44C6-A9A2-B305A3E6873D}"/>
               </a:ext>
             </a:extLst>
           </p:cNvPr>
@@ -14056,7 +14693,7 @@
           <p:cNvPr id="2" name="S05">
             <a:extLst xmlns:a="http://schemas.openxmlformats.org/drawingml/2006/main">
               <a:ext uri="{FF2B5EF4-FFF2-40B4-BE49-F238E27FC236}">
-                <a16:creationId xmlns:a16="http://schemas.microsoft.com/office/drawing/2014/main" id="{5EAB9181-2CB4-4D16-B062-E0A4E78C3F23}"/>
+                <a16:creationId xmlns:a16="http://schemas.microsoft.com/office/drawing/2014/main" id="{435F6478-92E5-4339-BD54-D850952540FD}"/>
               </a:ext>
             </a:extLst>
           </p:cNvPr>
@@ -14214,7 +14851,7 @@
           <p:cNvPr id="3" name="Agent가 Test와 호출 경로를 찾았다">
             <a:extLst xmlns:a="http://schemas.openxmlformats.org/drawingml/2006/main">
               <a:ext uri="{FF2B5EF4-FFF2-40B4-BE49-F238E27FC236}">
-                <a16:creationId xmlns:a16="http://schemas.microsoft.com/office/drawing/2014/main" id="{45CCE3D3-1B68-4F40-9925-E161CE2F12D4}"/>
+                <a16:creationId xmlns:a16="http://schemas.microsoft.com/office/drawing/2014/main" id="{9B19921F-47D9-468C-9D8F-5FA88DC03150}"/>
               </a:ext>
             </a:extLst>
           </p:cNvPr>
@@ -14372,7 +15009,7 @@
           <p:cNvPr id="4" name="">
             <a:extLst xmlns:a="http://schemas.openxmlformats.org/drawingml/2006/main">
               <a:ext uri="{FF2B5EF4-FFF2-40B4-BE49-F238E27FC236}">
-                <a16:creationId xmlns:a16="http://schemas.microsoft.com/office/drawing/2014/main" id="{34BD1638-7EF0-48D5-9AAD-33C0712635B7}"/>
+                <a16:creationId xmlns:a16="http://schemas.microsoft.com/office/drawing/2014/main" id="{5B5A9757-0499-49F7-BBDE-D0E7559620F2}"/>
               </a:ext>
             </a:extLst>
           </p:cNvPr>
@@ -14383,7 +15020,7 @@
         </p:nvSpPr>
         <p:spPr>
           <a:xfrm xmlns:a="http://schemas.openxmlformats.org/drawingml/2006/main">
-            <a:off x="609600" y="5829300"/>
+            <a:off x="609600" y="5753100"/>
             <a:ext cx="10972800" cy="0"/>
           </a:xfrm>
           <a:prstGeom xmlns:a="http://schemas.openxmlformats.org/drawingml/2006/main" prst="line">
@@ -14403,7 +15040,7 @@
           <p:cNvPr id="5" name="TRIAL-001 기록·STATE-00 테스트 재구성  |  Codex CLI 0.154.0 · 읽기 전용">
             <a:extLst xmlns:a="http://schemas.openxmlformats.org/drawingml/2006/main">
               <a:ext uri="{FF2B5EF4-FFF2-40B4-BE49-F238E27FC236}">
-                <a16:creationId xmlns:a16="http://schemas.microsoft.com/office/drawing/2014/main" id="{26596F36-AED1-4D60-9ED1-DA3BB8DCE5C4}"/>
+                <a16:creationId xmlns:a16="http://schemas.microsoft.com/office/drawing/2014/main" id="{F5521CFB-E0B7-4DC9-BA55-094028A1322C}"/>
               </a:ext>
             </a:extLst>
           </p:cNvPr>
@@ -14414,8 +15051,8 @@
         </p:nvSpPr>
         <p:spPr>
           <a:xfrm xmlns:a="http://schemas.openxmlformats.org/drawingml/2006/main">
-            <a:off x="609600" y="5915025"/>
-            <a:ext cx="10972800" cy="247650"/>
+            <a:off x="609600" y="5791200"/>
+            <a:ext cx="10972800" cy="228600"/>
           </a:xfrm>
           <a:prstGeom xmlns:a="http://schemas.openxmlformats.org/drawingml/2006/main" prst="rect">
             <a:avLst/>
@@ -14561,7 +15198,7 @@
           <p:cNvPr id="6" name="실제 실행 화면이 아님 · 이 조사에서는 코드 수정 없음 · 현재 Desktop 동작 미검증">
             <a:extLst xmlns:a="http://schemas.openxmlformats.org/drawingml/2006/main">
               <a:ext uri="{FF2B5EF4-FFF2-40B4-BE49-F238E27FC236}">
-                <a16:creationId xmlns:a16="http://schemas.microsoft.com/office/drawing/2014/main" id="{33BC5ACA-F063-4F5C-A9C0-F8CD81C3C38B}"/>
+                <a16:creationId xmlns:a16="http://schemas.microsoft.com/office/drawing/2014/main" id="{7391F311-9D35-4DD1-BE43-98972F654871}"/>
               </a:ext>
             </a:extLst>
           </p:cNvPr>
@@ -14572,7 +15209,7 @@
         </p:nvSpPr>
         <p:spPr>
           <a:xfrm xmlns:a="http://schemas.openxmlformats.org/drawingml/2006/main">
-            <a:off x="609600" y="6191250"/>
+            <a:off x="609600" y="6019800"/>
             <a:ext cx="10972800" cy="209550"/>
           </a:xfrm>
           <a:prstGeom xmlns:a="http://schemas.openxmlformats.org/drawingml/2006/main" prst="rect">
@@ -14719,7 +15356,7 @@
           <p:cNvPr id="7" name="crop(image, 1, 3)">
             <a:extLst xmlns:a="http://schemas.openxmlformats.org/drawingml/2006/main">
               <a:ext uri="{FF2B5EF4-FFF2-40B4-BE49-F238E27FC236}">
-                <a16:creationId xmlns:a16="http://schemas.microsoft.com/office/drawing/2014/main" id="{BCB92C82-56CD-484F-9406-326B8DC92A3E}"/>
+                <a16:creationId xmlns:a16="http://schemas.microsoft.com/office/drawing/2014/main" id="{2C0D2F52-8862-4084-B50A-DB7B4CECC760}"/>
               </a:ext>
             </a:extLst>
           </p:cNvPr>
@@ -14877,7 +15514,7 @@
           <p:cNvPr id="8" name="끝 좌표 3은 포함하지 않는 계약">
             <a:extLst xmlns:a="http://schemas.openxmlformats.org/drawingml/2006/main">
               <a:ext uri="{FF2B5EF4-FFF2-40B4-BE49-F238E27FC236}">
-                <a16:creationId xmlns:a16="http://schemas.microsoft.com/office/drawing/2014/main" id="{A89C020E-E1B6-4DAB-AB8E-A0FC008CE699}"/>
+                <a16:creationId xmlns:a16="http://schemas.microsoft.com/office/drawing/2014/main" id="{0AB58E16-742F-47EB-A096-D57D052AC18B}"/>
               </a:ext>
             </a:extLst>
           </p:cNvPr>
@@ -15035,7 +15672,7 @@
           <p:cNvPr id="9" name="입력">
             <a:extLst xmlns:a="http://schemas.openxmlformats.org/drawingml/2006/main">
               <a:ext uri="{FF2B5EF4-FFF2-40B4-BE49-F238E27FC236}">
-                <a16:creationId xmlns:a16="http://schemas.microsoft.com/office/drawing/2014/main" id="{4615F64B-A0FD-4C63-84E7-A516DAB9D87E}"/>
+                <a16:creationId xmlns:a16="http://schemas.microsoft.com/office/drawing/2014/main" id="{E5119863-A906-4A6E-AD2A-E60D7B94C8B5}"/>
               </a:ext>
             </a:extLst>
           </p:cNvPr>
@@ -15193,7 +15830,7 @@
           <p:cNvPr id="10" name="0">
             <a:extLst xmlns:a="http://schemas.openxmlformats.org/drawingml/2006/main">
               <a:ext uri="{FF2B5EF4-FFF2-40B4-BE49-F238E27FC236}">
-                <a16:creationId xmlns:a16="http://schemas.microsoft.com/office/drawing/2014/main" id="{8063EA6A-6101-42E9-BB2A-98DE90192D4B}"/>
+                <a16:creationId xmlns:a16="http://schemas.microsoft.com/office/drawing/2014/main" id="{AC6B8CF3-3A9E-4C5F-8C8B-4AF6FC5D988D}"/>
               </a:ext>
             </a:extLst>
           </p:cNvPr>
@@ -15351,7 +15988,7 @@
           <p:cNvPr id="11" name="1">
             <a:extLst xmlns:a="http://schemas.openxmlformats.org/drawingml/2006/main">
               <a:ext uri="{FF2B5EF4-FFF2-40B4-BE49-F238E27FC236}">
-                <a16:creationId xmlns:a16="http://schemas.microsoft.com/office/drawing/2014/main" id="{7EB327C5-9B31-4C27-8230-9BFE06DCE1A6}"/>
+                <a16:creationId xmlns:a16="http://schemas.microsoft.com/office/drawing/2014/main" id="{C6A6EB16-C34D-41CA-B764-E47DEE956AA9}"/>
               </a:ext>
             </a:extLst>
           </p:cNvPr>
@@ -15509,7 +16146,7 @@
           <p:cNvPr id="12" name="2">
             <a:extLst xmlns:a="http://schemas.openxmlformats.org/drawingml/2006/main">
               <a:ext uri="{FF2B5EF4-FFF2-40B4-BE49-F238E27FC236}">
-                <a16:creationId xmlns:a16="http://schemas.microsoft.com/office/drawing/2014/main" id="{53E37CDF-B630-46DD-94E1-496AAD338856}"/>
+                <a16:creationId xmlns:a16="http://schemas.microsoft.com/office/drawing/2014/main" id="{9227887E-09BD-4D0C-9DA7-029BA9CF137A}"/>
               </a:ext>
             </a:extLst>
           </p:cNvPr>
@@ -15667,7 +16304,7 @@
           <p:cNvPr id="13" name="3">
             <a:extLst xmlns:a="http://schemas.openxmlformats.org/drawingml/2006/main">
               <a:ext uri="{FF2B5EF4-FFF2-40B4-BE49-F238E27FC236}">
-                <a16:creationId xmlns:a16="http://schemas.microsoft.com/office/drawing/2014/main" id="{2ADE90CC-7AFC-4953-842A-77C32C48CF9C}"/>
+                <a16:creationId xmlns:a16="http://schemas.microsoft.com/office/drawing/2014/main" id="{541E0378-6F7F-41F0-BD9B-4DA1A99C2721}"/>
               </a:ext>
             </a:extLst>
           </p:cNvPr>
@@ -15825,7 +16462,7 @@
           <p:cNvPr id="14" name="">
             <a:extLst xmlns:a="http://schemas.openxmlformats.org/drawingml/2006/main">
               <a:ext uri="{FF2B5EF4-FFF2-40B4-BE49-F238E27FC236}">
-                <a16:creationId xmlns:a16="http://schemas.microsoft.com/office/drawing/2014/main" id="{06BD1C95-C3DE-43EB-86C9-692E7083B8AD}"/>
+                <a16:creationId xmlns:a16="http://schemas.microsoft.com/office/drawing/2014/main" id="{5AB90F58-5364-49E7-9226-1F1F2FDEB9FA}"/>
               </a:ext>
             </a:extLst>
           </p:cNvPr>
@@ -15858,7 +16495,7 @@
           <p:cNvPr id="15" name="1">
             <a:extLst xmlns:a="http://schemas.openxmlformats.org/drawingml/2006/main">
               <a:ext uri="{FF2B5EF4-FFF2-40B4-BE49-F238E27FC236}">
-                <a16:creationId xmlns:a16="http://schemas.microsoft.com/office/drawing/2014/main" id="{82E41269-F7A4-4ECC-9266-38234C9002B4}"/>
+                <a16:creationId xmlns:a16="http://schemas.microsoft.com/office/drawing/2014/main" id="{DF1CB3B2-2F12-4785-8E26-14E2A82CA927}"/>
               </a:ext>
             </a:extLst>
           </p:cNvPr>
@@ -16016,7 +16653,7 @@
           <p:cNvPr id="16" name="">
             <a:extLst xmlns:a="http://schemas.openxmlformats.org/drawingml/2006/main">
               <a:ext uri="{FF2B5EF4-FFF2-40B4-BE49-F238E27FC236}">
-                <a16:creationId xmlns:a16="http://schemas.microsoft.com/office/drawing/2014/main" id="{C2E457FD-60A5-4ED2-A9F9-B334DFEC9739}"/>
+                <a16:creationId xmlns:a16="http://schemas.microsoft.com/office/drawing/2014/main" id="{A765B4D7-436C-4A7E-B3EE-B96703BC74E6}"/>
               </a:ext>
             </a:extLst>
           </p:cNvPr>
@@ -16049,7 +16686,7 @@
           <p:cNvPr id="17" name="2">
             <a:extLst xmlns:a="http://schemas.openxmlformats.org/drawingml/2006/main">
               <a:ext uri="{FF2B5EF4-FFF2-40B4-BE49-F238E27FC236}">
-                <a16:creationId xmlns:a16="http://schemas.microsoft.com/office/drawing/2014/main" id="{D8E99907-1996-4076-9E03-AC97EAAED6E5}"/>
+                <a16:creationId xmlns:a16="http://schemas.microsoft.com/office/drawing/2014/main" id="{58ED2734-2949-4E10-989A-25E3AF417A1F}"/>
               </a:ext>
             </a:extLst>
           </p:cNvPr>
@@ -16207,7 +16844,7 @@
           <p:cNvPr id="18" name="">
             <a:extLst xmlns:a="http://schemas.openxmlformats.org/drawingml/2006/main">
               <a:ext uri="{FF2B5EF4-FFF2-40B4-BE49-F238E27FC236}">
-                <a16:creationId xmlns:a16="http://schemas.microsoft.com/office/drawing/2014/main" id="{C92EC8F8-9606-47C3-A7D5-0E0E2862BF73}"/>
+                <a16:creationId xmlns:a16="http://schemas.microsoft.com/office/drawing/2014/main" id="{D0FA3A17-FC68-42E4-A724-7A5F90411339}"/>
               </a:ext>
             </a:extLst>
           </p:cNvPr>
@@ -16240,7 +16877,7 @@
           <p:cNvPr id="19" name="3">
             <a:extLst xmlns:a="http://schemas.openxmlformats.org/drawingml/2006/main">
               <a:ext uri="{FF2B5EF4-FFF2-40B4-BE49-F238E27FC236}">
-                <a16:creationId xmlns:a16="http://schemas.microsoft.com/office/drawing/2014/main" id="{2C75EB76-5574-4753-AF15-E64472C2B28C}"/>
+                <a16:creationId xmlns:a16="http://schemas.microsoft.com/office/drawing/2014/main" id="{D75F3553-518E-4F5A-9C7D-EE444AA81118}"/>
               </a:ext>
             </a:extLst>
           </p:cNvPr>
@@ -16398,7 +17035,7 @@
           <p:cNvPr id="20" name="">
             <a:extLst xmlns:a="http://schemas.openxmlformats.org/drawingml/2006/main">
               <a:ext uri="{FF2B5EF4-FFF2-40B4-BE49-F238E27FC236}">
-                <a16:creationId xmlns:a16="http://schemas.microsoft.com/office/drawing/2014/main" id="{1EE5CC05-28E2-4DD6-A542-8EF233425BAB}"/>
+                <a16:creationId xmlns:a16="http://schemas.microsoft.com/office/drawing/2014/main" id="{5B9B09E0-A26D-4624-9F0D-C301216499AC}"/>
               </a:ext>
             </a:extLst>
           </p:cNvPr>
@@ -16431,7 +17068,7 @@
           <p:cNvPr id="21" name="4">
             <a:extLst xmlns:a="http://schemas.openxmlformats.org/drawingml/2006/main">
               <a:ext uri="{FF2B5EF4-FFF2-40B4-BE49-F238E27FC236}">
-                <a16:creationId xmlns:a16="http://schemas.microsoft.com/office/drawing/2014/main" id="{1A3EF5D8-BA1B-4B62-9179-E79DAC6D46D4}"/>
+                <a16:creationId xmlns:a16="http://schemas.microsoft.com/office/drawing/2014/main" id="{A6F8ADA3-A797-480D-A64F-BB15A5DC4323}"/>
               </a:ext>
             </a:extLst>
           </p:cNvPr>
@@ -16589,7 +17226,7 @@
           <p:cNvPr id="22" name="">
             <a:extLst xmlns:a="http://schemas.openxmlformats.org/drawingml/2006/main">
               <a:ext uri="{FF2B5EF4-FFF2-40B4-BE49-F238E27FC236}">
-                <a16:creationId xmlns:a16="http://schemas.microsoft.com/office/drawing/2014/main" id="{BC021F57-380B-496F-9D66-D49D48D4E4C8}"/>
+                <a16:creationId xmlns:a16="http://schemas.microsoft.com/office/drawing/2014/main" id="{1EF45531-AE50-4D0E-ADF3-2266D4B83EDA}"/>
               </a:ext>
             </a:extLst>
           </p:cNvPr>
@@ -16622,7 +17259,7 @@
           <p:cNvPr id="23" name="5">
             <a:extLst xmlns:a="http://schemas.openxmlformats.org/drawingml/2006/main">
               <a:ext uri="{FF2B5EF4-FFF2-40B4-BE49-F238E27FC236}">
-                <a16:creationId xmlns:a16="http://schemas.microsoft.com/office/drawing/2014/main" id="{943F4401-D8AF-4DE5-9E65-2CD179A2679C}"/>
+                <a16:creationId xmlns:a16="http://schemas.microsoft.com/office/drawing/2014/main" id="{4AB2E513-053B-425E-A309-F03B1BF0234A}"/>
               </a:ext>
             </a:extLst>
           </p:cNvPr>
@@ -16780,7 +17417,7 @@
           <p:cNvPr id="24" name="">
             <a:extLst xmlns:a="http://schemas.openxmlformats.org/drawingml/2006/main">
               <a:ext uri="{FF2B5EF4-FFF2-40B4-BE49-F238E27FC236}">
-                <a16:creationId xmlns:a16="http://schemas.microsoft.com/office/drawing/2014/main" id="{0F9266B4-F51A-4116-B310-830714AA86C1}"/>
+                <a16:creationId xmlns:a16="http://schemas.microsoft.com/office/drawing/2014/main" id="{CBAEC953-5F94-4B9D-ACB5-FB1A0BFAFF16}"/>
               </a:ext>
             </a:extLst>
           </p:cNvPr>
@@ -16813,7 +17450,7 @@
           <p:cNvPr id="25" name="6">
             <a:extLst xmlns:a="http://schemas.openxmlformats.org/drawingml/2006/main">
               <a:ext uri="{FF2B5EF4-FFF2-40B4-BE49-F238E27FC236}">
-                <a16:creationId xmlns:a16="http://schemas.microsoft.com/office/drawing/2014/main" id="{FE5789B1-EE64-47C1-A243-AC179C7A3435}"/>
+                <a16:creationId xmlns:a16="http://schemas.microsoft.com/office/drawing/2014/main" id="{3C3AF4AB-18BB-4CDC-B99D-ADD5C9E6C2E1}"/>
               </a:ext>
             </a:extLst>
           </p:cNvPr>
@@ -16971,7 +17608,7 @@
           <p:cNvPr id="26" name="">
             <a:extLst xmlns:a="http://schemas.openxmlformats.org/drawingml/2006/main">
               <a:ext uri="{FF2B5EF4-FFF2-40B4-BE49-F238E27FC236}">
-                <a16:creationId xmlns:a16="http://schemas.microsoft.com/office/drawing/2014/main" id="{057D8FFB-BDE3-4820-AFC6-8089BDB15B4F}"/>
+                <a16:creationId xmlns:a16="http://schemas.microsoft.com/office/drawing/2014/main" id="{8759923B-E9CA-4085-B684-3B1D431D12E6}"/>
               </a:ext>
             </a:extLst>
           </p:cNvPr>
@@ -17004,7 +17641,7 @@
           <p:cNvPr id="27" name="7">
             <a:extLst xmlns:a="http://schemas.openxmlformats.org/drawingml/2006/main">
               <a:ext uri="{FF2B5EF4-FFF2-40B4-BE49-F238E27FC236}">
-                <a16:creationId xmlns:a16="http://schemas.microsoft.com/office/drawing/2014/main" id="{FA12FE57-BFA5-4769-AA76-5C854BBD8B4B}"/>
+                <a16:creationId xmlns:a16="http://schemas.microsoft.com/office/drawing/2014/main" id="{1BF94BA5-C38C-48FF-AEC7-DC45214E5AC9}"/>
               </a:ext>
             </a:extLst>
           </p:cNvPr>
@@ -17162,7 +17799,7 @@
           <p:cNvPr id="28" name="">
             <a:extLst xmlns:a="http://schemas.openxmlformats.org/drawingml/2006/main">
               <a:ext uri="{FF2B5EF4-FFF2-40B4-BE49-F238E27FC236}">
-                <a16:creationId xmlns:a16="http://schemas.microsoft.com/office/drawing/2014/main" id="{06FAA3FC-691C-48C9-99E7-D1B9FFDFE7B3}"/>
+                <a16:creationId xmlns:a16="http://schemas.microsoft.com/office/drawing/2014/main" id="{EBFAF6D8-6AA5-471F-999F-283D0E71856D}"/>
               </a:ext>
             </a:extLst>
           </p:cNvPr>
@@ -17195,7 +17832,7 @@
           <p:cNvPr id="29" name="8">
             <a:extLst xmlns:a="http://schemas.openxmlformats.org/drawingml/2006/main">
               <a:ext uri="{FF2B5EF4-FFF2-40B4-BE49-F238E27FC236}">
-                <a16:creationId xmlns:a16="http://schemas.microsoft.com/office/drawing/2014/main" id="{2F07EF8F-8C37-40FE-B63C-510E934698D1}"/>
+                <a16:creationId xmlns:a16="http://schemas.microsoft.com/office/drawing/2014/main" id="{460706B0-10E2-43A4-864D-CFD60E36C387}"/>
               </a:ext>
             </a:extLst>
           </p:cNvPr>
@@ -17353,7 +17990,7 @@
           <p:cNvPr id="30" name="열 index">
             <a:extLst xmlns:a="http://schemas.openxmlformats.org/drawingml/2006/main">
               <a:ext uri="{FF2B5EF4-FFF2-40B4-BE49-F238E27FC236}">
-                <a16:creationId xmlns:a16="http://schemas.microsoft.com/office/drawing/2014/main" id="{7EC12473-2F3E-44C8-A5CC-EBB36A11BCBE}"/>
+                <a16:creationId xmlns:a16="http://schemas.microsoft.com/office/drawing/2014/main" id="{23CD3CEF-FCED-4220-BA6D-65DF0B31FB4A}"/>
               </a:ext>
             </a:extLst>
           </p:cNvPr>
@@ -17511,7 +18148,7 @@
           <p:cNvPr id="31" name="기대">
             <a:extLst xmlns:a="http://schemas.openxmlformats.org/drawingml/2006/main">
               <a:ext uri="{FF2B5EF4-FFF2-40B4-BE49-F238E27FC236}">
-                <a16:creationId xmlns:a16="http://schemas.microsoft.com/office/drawing/2014/main" id="{0B867AC5-8CBA-4B60-A5E6-A8F22CEC3ADC}"/>
+                <a16:creationId xmlns:a16="http://schemas.microsoft.com/office/drawing/2014/main" id="{B7922327-70F4-47B5-B976-2F56FFF90CC9}"/>
               </a:ext>
             </a:extLst>
           </p:cNvPr>
@@ -17669,7 +18306,7 @@
           <p:cNvPr id="32" name="">
             <a:extLst xmlns:a="http://schemas.openxmlformats.org/drawingml/2006/main">
               <a:ext uri="{FF2B5EF4-FFF2-40B4-BE49-F238E27FC236}">
-                <a16:creationId xmlns:a16="http://schemas.microsoft.com/office/drawing/2014/main" id="{F41B2CEB-44E4-4EA8-A2AD-727F3373DFA0}"/>
+                <a16:creationId xmlns:a16="http://schemas.microsoft.com/office/drawing/2014/main" id="{BC182384-448D-493F-AE3E-794632904362}"/>
               </a:ext>
             </a:extLst>
           </p:cNvPr>
@@ -17702,7 +18339,7 @@
           <p:cNvPr id="33" name="2">
             <a:extLst xmlns:a="http://schemas.openxmlformats.org/drawingml/2006/main">
               <a:ext uri="{FF2B5EF4-FFF2-40B4-BE49-F238E27FC236}">
-                <a16:creationId xmlns:a16="http://schemas.microsoft.com/office/drawing/2014/main" id="{45E8EA9B-F07E-4D4F-9C91-EA542BE2897F}"/>
+                <a16:creationId xmlns:a16="http://schemas.microsoft.com/office/drawing/2014/main" id="{DFF70AB1-6926-4581-AE4F-D3A751B81E34}"/>
               </a:ext>
             </a:extLst>
           </p:cNvPr>
@@ -17860,7 +18497,7 @@
           <p:cNvPr id="34" name="">
             <a:extLst xmlns:a="http://schemas.openxmlformats.org/drawingml/2006/main">
               <a:ext uri="{FF2B5EF4-FFF2-40B4-BE49-F238E27FC236}">
-                <a16:creationId xmlns:a16="http://schemas.microsoft.com/office/drawing/2014/main" id="{85EF2207-C3BF-46E5-9C07-0BA8743C183C}"/>
+                <a16:creationId xmlns:a16="http://schemas.microsoft.com/office/drawing/2014/main" id="{22FC284B-675B-4CD1-986A-33946002628F}"/>
               </a:ext>
             </a:extLst>
           </p:cNvPr>
@@ -17893,7 +18530,7 @@
           <p:cNvPr id="35" name="3">
             <a:extLst xmlns:a="http://schemas.openxmlformats.org/drawingml/2006/main">
               <a:ext uri="{FF2B5EF4-FFF2-40B4-BE49-F238E27FC236}">
-                <a16:creationId xmlns:a16="http://schemas.microsoft.com/office/drawing/2014/main" id="{42C5D0DA-0E24-4CFA-8DD7-F0E72435021E}"/>
+                <a16:creationId xmlns:a16="http://schemas.microsoft.com/office/drawing/2014/main" id="{33E34EA7-DE2D-42B1-B7BE-43962D965F0A}"/>
               </a:ext>
             </a:extLst>
           </p:cNvPr>
@@ -18051,7 +18688,7 @@
           <p:cNvPr id="36" name="">
             <a:extLst xmlns:a="http://schemas.openxmlformats.org/drawingml/2006/main">
               <a:ext uri="{FF2B5EF4-FFF2-40B4-BE49-F238E27FC236}">
-                <a16:creationId xmlns:a16="http://schemas.microsoft.com/office/drawing/2014/main" id="{73D98B00-C1D9-47B5-8451-8C7844F53BEC}"/>
+                <a16:creationId xmlns:a16="http://schemas.microsoft.com/office/drawing/2014/main" id="{BEEC9E11-2049-4ABD-85AB-909DE58BD6F2}"/>
               </a:ext>
             </a:extLst>
           </p:cNvPr>
@@ -18084,7 +18721,7 @@
           <p:cNvPr id="37" name="6">
             <a:extLst xmlns:a="http://schemas.openxmlformats.org/drawingml/2006/main">
               <a:ext uri="{FF2B5EF4-FFF2-40B4-BE49-F238E27FC236}">
-                <a16:creationId xmlns:a16="http://schemas.microsoft.com/office/drawing/2014/main" id="{828A5298-233E-4C99-B4E7-2107DEDD8215}"/>
+                <a16:creationId xmlns:a16="http://schemas.microsoft.com/office/drawing/2014/main" id="{6874B7AE-8E95-4C73-8424-DBB244258C50}"/>
               </a:ext>
             </a:extLst>
           </p:cNvPr>
@@ -18242,7 +18879,7 @@
           <p:cNvPr id="38" name="">
             <a:extLst xmlns:a="http://schemas.openxmlformats.org/drawingml/2006/main">
               <a:ext uri="{FF2B5EF4-FFF2-40B4-BE49-F238E27FC236}">
-                <a16:creationId xmlns:a16="http://schemas.microsoft.com/office/drawing/2014/main" id="{6A768BD2-710B-4D19-A15E-89769991BB00}"/>
+                <a16:creationId xmlns:a16="http://schemas.microsoft.com/office/drawing/2014/main" id="{B6E83861-1096-4750-B1D5-0000D1BB654E}"/>
               </a:ext>
             </a:extLst>
           </p:cNvPr>
@@ -18275,7 +18912,7 @@
           <p:cNvPr id="39" name="7">
             <a:extLst xmlns:a="http://schemas.openxmlformats.org/drawingml/2006/main">
               <a:ext uri="{FF2B5EF4-FFF2-40B4-BE49-F238E27FC236}">
-                <a16:creationId xmlns:a16="http://schemas.microsoft.com/office/drawing/2014/main" id="{F596A7BC-13C4-4889-BF33-6237EA2117C8}"/>
+                <a16:creationId xmlns:a16="http://schemas.microsoft.com/office/drawing/2014/main" id="{AB0244F9-6015-4A5F-8945-7C07BE674E69}"/>
               </a:ext>
             </a:extLst>
           </p:cNvPr>
@@ -18433,7 +19070,7 @@
           <p:cNvPr id="40" name="구현 결과">
             <a:extLst xmlns:a="http://schemas.openxmlformats.org/drawingml/2006/main">
               <a:ext uri="{FF2B5EF4-FFF2-40B4-BE49-F238E27FC236}">
-                <a16:creationId xmlns:a16="http://schemas.microsoft.com/office/drawing/2014/main" id="{7BE2C592-D8A4-4275-95BD-54A198C4DA77}"/>
+                <a16:creationId xmlns:a16="http://schemas.microsoft.com/office/drawing/2014/main" id="{91CAAAD0-9848-4B64-8EDC-6A69D18A412B}"/>
               </a:ext>
             </a:extLst>
           </p:cNvPr>
@@ -18591,7 +19228,7 @@
           <p:cNvPr id="41" name="">
             <a:extLst xmlns:a="http://schemas.openxmlformats.org/drawingml/2006/main">
               <a:ext uri="{FF2B5EF4-FFF2-40B4-BE49-F238E27FC236}">
-                <a16:creationId xmlns:a16="http://schemas.microsoft.com/office/drawing/2014/main" id="{ABF1BC1F-F3D0-4826-94CB-291354B44D99}"/>
+                <a16:creationId xmlns:a16="http://schemas.microsoft.com/office/drawing/2014/main" id="{52596742-9E92-4CBB-8CF3-920A1465E7D3}"/>
               </a:ext>
             </a:extLst>
           </p:cNvPr>
@@ -18624,7 +19261,7 @@
           <p:cNvPr id="42" name="2">
             <a:extLst xmlns:a="http://schemas.openxmlformats.org/drawingml/2006/main">
               <a:ext uri="{FF2B5EF4-FFF2-40B4-BE49-F238E27FC236}">
-                <a16:creationId xmlns:a16="http://schemas.microsoft.com/office/drawing/2014/main" id="{41A8DE41-10CA-4E0A-B822-33C83D657513}"/>
+                <a16:creationId xmlns:a16="http://schemas.microsoft.com/office/drawing/2014/main" id="{BA703FA2-B3D2-4899-9295-F57D279FF667}"/>
               </a:ext>
             </a:extLst>
           </p:cNvPr>
@@ -18782,7 +19419,7 @@
           <p:cNvPr id="43" name="">
             <a:extLst xmlns:a="http://schemas.openxmlformats.org/drawingml/2006/main">
               <a:ext uri="{FF2B5EF4-FFF2-40B4-BE49-F238E27FC236}">
-                <a16:creationId xmlns:a16="http://schemas.microsoft.com/office/drawing/2014/main" id="{842528E0-6510-4992-A5AF-A9E1694D0CDB}"/>
+                <a16:creationId xmlns:a16="http://schemas.microsoft.com/office/drawing/2014/main" id="{591F6F03-D798-4F2A-8020-99B4F5CD1690}"/>
               </a:ext>
             </a:extLst>
           </p:cNvPr>
@@ -18815,7 +19452,7 @@
           <p:cNvPr id="44" name="3">
             <a:extLst xmlns:a="http://schemas.openxmlformats.org/drawingml/2006/main">
               <a:ext uri="{FF2B5EF4-FFF2-40B4-BE49-F238E27FC236}">
-                <a16:creationId xmlns:a16="http://schemas.microsoft.com/office/drawing/2014/main" id="{4015365F-186A-4D63-8A7B-57924780F169}"/>
+                <a16:creationId xmlns:a16="http://schemas.microsoft.com/office/drawing/2014/main" id="{FAD40835-8959-4864-8CAD-FDB0E051AAE9}"/>
               </a:ext>
             </a:extLst>
           </p:cNvPr>
@@ -18973,7 +19610,7 @@
           <p:cNvPr id="45" name="">
             <a:extLst xmlns:a="http://schemas.openxmlformats.org/drawingml/2006/main">
               <a:ext uri="{FF2B5EF4-FFF2-40B4-BE49-F238E27FC236}">
-                <a16:creationId xmlns:a16="http://schemas.microsoft.com/office/drawing/2014/main" id="{66E01B19-5ED3-4B2D-8B33-2FD7D0AD767A}"/>
+                <a16:creationId xmlns:a16="http://schemas.microsoft.com/office/drawing/2014/main" id="{B3177E27-B9EF-4BE3-8273-538251FEEC5B}"/>
               </a:ext>
             </a:extLst>
           </p:cNvPr>
@@ -19006,7 +19643,7 @@
           <p:cNvPr id="46" name="4">
             <a:extLst xmlns:a="http://schemas.openxmlformats.org/drawingml/2006/main">
               <a:ext uri="{FF2B5EF4-FFF2-40B4-BE49-F238E27FC236}">
-                <a16:creationId xmlns:a16="http://schemas.microsoft.com/office/drawing/2014/main" id="{D6DD83FD-D7FC-4959-BCAF-2E1801DE8982}"/>
+                <a16:creationId xmlns:a16="http://schemas.microsoft.com/office/drawing/2014/main" id="{DC735CF5-1F1A-42F5-82EC-BD1A6307DD5A}"/>
               </a:ext>
             </a:extLst>
           </p:cNvPr>
@@ -19164,7 +19801,7 @@
           <p:cNvPr id="47" name="">
             <a:extLst xmlns:a="http://schemas.openxmlformats.org/drawingml/2006/main">
               <a:ext uri="{FF2B5EF4-FFF2-40B4-BE49-F238E27FC236}">
-                <a16:creationId xmlns:a16="http://schemas.microsoft.com/office/drawing/2014/main" id="{5C564E35-BA00-45C3-9324-C2FAC57DCD24}"/>
+                <a16:creationId xmlns:a16="http://schemas.microsoft.com/office/drawing/2014/main" id="{95E98B1C-EEB7-4665-B9DE-9756D9EDB1FB}"/>
               </a:ext>
             </a:extLst>
           </p:cNvPr>
@@ -19197,7 +19834,7 @@
           <p:cNvPr id="48" name="6">
             <a:extLst xmlns:a="http://schemas.openxmlformats.org/drawingml/2006/main">
               <a:ext uri="{FF2B5EF4-FFF2-40B4-BE49-F238E27FC236}">
-                <a16:creationId xmlns:a16="http://schemas.microsoft.com/office/drawing/2014/main" id="{53128EEE-89ED-4312-913D-F424B383775B}"/>
+                <a16:creationId xmlns:a16="http://schemas.microsoft.com/office/drawing/2014/main" id="{38A203BD-E7FA-4B0D-8EE8-77A00A2C3CFD}"/>
               </a:ext>
             </a:extLst>
           </p:cNvPr>
@@ -19355,7 +19992,7 @@
           <p:cNvPr id="49" name="">
             <a:extLst xmlns:a="http://schemas.openxmlformats.org/drawingml/2006/main">
               <a:ext uri="{FF2B5EF4-FFF2-40B4-BE49-F238E27FC236}">
-                <a16:creationId xmlns:a16="http://schemas.microsoft.com/office/drawing/2014/main" id="{BE279224-96D4-4D9B-9BD1-A13864E04845}"/>
+                <a16:creationId xmlns:a16="http://schemas.microsoft.com/office/drawing/2014/main" id="{DF08531C-512B-4B2E-B3A7-C0C9EDD921D9}"/>
               </a:ext>
             </a:extLst>
           </p:cNvPr>
@@ -19388,7 +20025,7 @@
           <p:cNvPr id="50" name="7">
             <a:extLst xmlns:a="http://schemas.openxmlformats.org/drawingml/2006/main">
               <a:ext uri="{FF2B5EF4-FFF2-40B4-BE49-F238E27FC236}">
-                <a16:creationId xmlns:a16="http://schemas.microsoft.com/office/drawing/2014/main" id="{533AD69C-4587-4E4B-A571-D8BB4D129192}"/>
+                <a16:creationId xmlns:a16="http://schemas.microsoft.com/office/drawing/2014/main" id="{08A5D51A-B027-4D8A-82CE-F1976A49B8BC}"/>
               </a:ext>
             </a:extLst>
           </p:cNvPr>
@@ -19546,7 +20183,7 @@
           <p:cNvPr id="51" name="">
             <a:extLst xmlns:a="http://schemas.openxmlformats.org/drawingml/2006/main">
               <a:ext uri="{FF2B5EF4-FFF2-40B4-BE49-F238E27FC236}">
-                <a16:creationId xmlns:a16="http://schemas.microsoft.com/office/drawing/2014/main" id="{3E524C95-181A-4580-8EEF-9D50A4D3D8D4}"/>
+                <a16:creationId xmlns:a16="http://schemas.microsoft.com/office/drawing/2014/main" id="{BB00271F-4214-46F3-9C52-7F1605F5759E}"/>
               </a:ext>
             </a:extLst>
           </p:cNvPr>
@@ -19579,7 +20216,7 @@
           <p:cNvPr id="52" name="8">
             <a:extLst xmlns:a="http://schemas.openxmlformats.org/drawingml/2006/main">
               <a:ext uri="{FF2B5EF4-FFF2-40B4-BE49-F238E27FC236}">
-                <a16:creationId xmlns:a16="http://schemas.microsoft.com/office/drawing/2014/main" id="{74581E97-EE16-4BE3-B75D-3145B5A5A038}"/>
+                <a16:creationId xmlns:a16="http://schemas.microsoft.com/office/drawing/2014/main" id="{A5CF0F58-8356-4E4D-B59F-0269FF19D351}"/>
               </a:ext>
             </a:extLst>
           </p:cNvPr>
@@ -19737,7 +20374,7 @@
           <p:cNvPr id="53" name="한 열이 더 포함됨">
             <a:extLst xmlns:a="http://schemas.openxmlformats.org/drawingml/2006/main">
               <a:ext uri="{FF2B5EF4-FFF2-40B4-BE49-F238E27FC236}">
-                <a16:creationId xmlns:a16="http://schemas.microsoft.com/office/drawing/2014/main" id="{F12889A6-9D8B-4D98-A61D-5AB8ED8D3241}"/>
+                <a16:creationId xmlns:a16="http://schemas.microsoft.com/office/drawing/2014/main" id="{DDB5DC87-8E62-40C8-AC3A-71C21C585171}"/>
               </a:ext>
             </a:extLst>
           </p:cNvPr>
@@ -19895,7 +20532,7 @@
           <p:cNvPr id="54" name="">
             <a:extLst xmlns:a="http://schemas.openxmlformats.org/drawingml/2006/main">
               <a:ext uri="{FF2B5EF4-FFF2-40B4-BE49-F238E27FC236}">
-                <a16:creationId xmlns:a16="http://schemas.microsoft.com/office/drawing/2014/main" id="{11F0CE93-5773-4E02-A9BD-FDB48DDECFA6}"/>
+                <a16:creationId xmlns:a16="http://schemas.microsoft.com/office/drawing/2014/main" id="{506211F5-1C31-41E9-BE48-62A7143F5177}"/>
               </a:ext>
             </a:extLst>
           </p:cNvPr>
@@ -19926,7 +20563,7 @@
           <p:cNvPr id="55" name="조사에서 연결한 근거">
             <a:extLst xmlns:a="http://schemas.openxmlformats.org/drawingml/2006/main">
               <a:ext uri="{FF2B5EF4-FFF2-40B4-BE49-F238E27FC236}">
-                <a16:creationId xmlns:a16="http://schemas.microsoft.com/office/drawing/2014/main" id="{8FC1E815-DB1C-457A-9E2A-1938D4A4AB67}"/>
+                <a16:creationId xmlns:a16="http://schemas.microsoft.com/office/drawing/2014/main" id="{123DED55-4AFE-4C76-BDF3-C381C84CEFE9}"/>
               </a:ext>
             </a:extLst>
           </p:cNvPr>
@@ -20084,7 +20721,7 @@
           <p:cNvPr id="56" name="01  실패 테스트">
             <a:extLst xmlns:a="http://schemas.openxmlformats.org/drawingml/2006/main">
               <a:ext uri="{FF2B5EF4-FFF2-40B4-BE49-F238E27FC236}">
-                <a16:creationId xmlns:a16="http://schemas.microsoft.com/office/drawing/2014/main" id="{D32960B7-290C-417F-BFA6-F56BF94272E4}"/>
+                <a16:creationId xmlns:a16="http://schemas.microsoft.com/office/drawing/2014/main" id="{81DB0144-66F1-48E7-B0ED-B7EBBB87CD25}"/>
               </a:ext>
             </a:extLst>
           </p:cNvPr>
@@ -20242,7 +20879,7 @@
           <p:cNvPr id="57" name="test_crop_excludes_&#10;end_coordinate">
             <a:extLst xmlns:a="http://schemas.openxmlformats.org/drawingml/2006/main">
               <a:ext uri="{FF2B5EF4-FFF2-40B4-BE49-F238E27FC236}">
-                <a16:creationId xmlns:a16="http://schemas.microsoft.com/office/drawing/2014/main" id="{88D91FCF-100B-473B-9C7B-765EB4A7E886}"/>
+                <a16:creationId xmlns:a16="http://schemas.microsoft.com/office/drawing/2014/main" id="{3E6B3CCF-E056-4E6C-9C20-FB75DACB52BC}"/>
               </a:ext>
             </a:extLst>
           </p:cNvPr>
@@ -20423,7 +21060,7 @@
           <p:cNvPr id="58" name="02  제품의 호출 경로">
             <a:extLst xmlns:a="http://schemas.openxmlformats.org/drawingml/2006/main">
               <a:ext uri="{FF2B5EF4-FFF2-40B4-BE49-F238E27FC236}">
-                <a16:creationId xmlns:a16="http://schemas.microsoft.com/office/drawing/2014/main" id="{74425C27-DC90-4A4D-A6E8-792C5D5A1F09}"/>
+                <a16:creationId xmlns:a16="http://schemas.microsoft.com/office/drawing/2014/main" id="{619E73A9-A98C-40F1-A37C-F5B12B50CBD0}"/>
               </a:ext>
             </a:extLst>
           </p:cNvPr>
@@ -20581,7 +21218,7 @@
           <p:cNvPr id="59" name="cli.main → process_image → crop">
             <a:extLst xmlns:a="http://schemas.openxmlformats.org/drawingml/2006/main">
               <a:ext uri="{FF2B5EF4-FFF2-40B4-BE49-F238E27FC236}">
-                <a16:creationId xmlns:a16="http://schemas.microsoft.com/office/drawing/2014/main" id="{CB3C743E-8383-4E95-941E-2D646CD7E602}"/>
+                <a16:creationId xmlns:a16="http://schemas.microsoft.com/office/drawing/2014/main" id="{07A1F37C-58D2-470F-B21F-17A94B520DE6}"/>
               </a:ext>
             </a:extLst>
           </p:cNvPr>
@@ -20739,7 +21376,7 @@
           <p:cNvPr id="60" name="03  계약과 다른 구현">
             <a:extLst xmlns:a="http://schemas.openxmlformats.org/drawingml/2006/main">
               <a:ext uri="{FF2B5EF4-FFF2-40B4-BE49-F238E27FC236}">
-                <a16:creationId xmlns:a16="http://schemas.microsoft.com/office/drawing/2014/main" id="{214B7ED6-D33B-4708-8CF0-1523E75DB274}"/>
+                <a16:creationId xmlns:a16="http://schemas.microsoft.com/office/drawing/2014/main" id="{CAB17B27-C025-42BA-9FE3-7A39E8EBA5C3}"/>
               </a:ext>
             </a:extLst>
           </p:cNvPr>
@@ -20897,7 +21534,7 @@
           <p:cNvPr id="61" name="row[x_start : x_end + 1]">
             <a:extLst xmlns:a="http://schemas.openxmlformats.org/drawingml/2006/main">
               <a:ext uri="{FF2B5EF4-FFF2-40B4-BE49-F238E27FC236}">
-                <a16:creationId xmlns:a16="http://schemas.microsoft.com/office/drawing/2014/main" id="{26B41980-4D8D-476A-9BEC-CAF3560EC31A}"/>
+                <a16:creationId xmlns:a16="http://schemas.microsoft.com/office/drawing/2014/main" id="{FCBB739B-D2BD-4F06-9CB5-9A6CB1D377C9}"/>
               </a:ext>
             </a:extLst>
           </p:cNvPr>
@@ -21055,7 +21692,7 @@
           <p:cNvPr id="62" name="계약: [x_start, x_end)">
             <a:extLst xmlns:a="http://schemas.openxmlformats.org/drawingml/2006/main">
               <a:ext uri="{FF2B5EF4-FFF2-40B4-BE49-F238E27FC236}">
-                <a16:creationId xmlns:a16="http://schemas.microsoft.com/office/drawing/2014/main" id="{21B2993B-6B11-4C6B-8946-8221435773B2}"/>
+                <a16:creationId xmlns:a16="http://schemas.microsoft.com/office/drawing/2014/main" id="{6ACBC565-CAA9-4B0A-9F14-46C2605CF475}"/>
               </a:ext>
             </a:extLst>
           </p:cNvPr>
@@ -21208,10 +21845,168 @@
           </a:p>
         </p:txBody>
       </p:sp>
+      <p:sp>
+        <p:nvSpPr>
+          <p:cNvPr id="63" name="Legacy module connection">
+            <a:extLst xmlns:a="http://schemas.openxmlformats.org/drawingml/2006/main">
+              <a:ext uri="{FF2B5EF4-FFF2-40B4-BE49-F238E27FC236}">
+                <a16:creationId xmlns:a16="http://schemas.microsoft.com/office/drawing/2014/main" id="{0B98CFA3-BA6F-48BA-95FB-6685BD787959}"/>
+              </a:ext>
+            </a:extLst>
+          </p:cNvPr>
+          <p:cNvSpPr>
+            <a:spLocks xmlns:a="http://schemas.openxmlformats.org/drawingml/2006/main" noGrp="1"/>
+          </p:cNvSpPr>
+          <p:nvPr/>
+        </p:nvSpPr>
+        <p:spPr>
+          <a:xfrm xmlns:a="http://schemas.openxmlformats.org/drawingml/2006/main">
+            <a:off x="609600" y="6229350"/>
+            <a:ext cx="10972800" cy="171450"/>
+          </a:xfrm>
+          <a:prstGeom xmlns:a="http://schemas.openxmlformats.org/drawingml/2006/main" prst="rect">
+            <a:avLst/>
+          </a:prstGeom>
+          <a:noFill xmlns:a="http://schemas.openxmlformats.org/drawingml/2006/main"/>
+          <a:ln xmlns:a="http://schemas.openxmlformats.org/drawingml/2006/main" w="0">
+            <a:noFill/>
+          </a:ln>
+        </p:spPr>
+        <p:txBody>
+          <a:bodyPr xmlns:a="http://schemas.openxmlformats.org/drawingml/2006/main" wrap="none" lIns="0" tIns="0" rIns="0" bIns="0" anchor="ctr">
+            <a:noAutofit/>
+          </a:bodyPr>
+          <a:lstStyle xmlns:a="http://schemas.openxmlformats.org/drawingml/2006/main">
+            <a:defPPr algn="r">
+              <a:defRPr sz="1200" b="0">
+                <a:solidFill>
+                  <a:srgbClr val="4D5A68"/>
+                </a:solidFill>
+                <a:latin typeface="Malgun Gothic"/>
+                <a:ea typeface="Malgun Gothic"/>
+                <a:cs typeface="Malgun Gothic"/>
+              </a:defRPr>
+            </a:defPPr>
+            <a:lvl1pPr algn="r">
+              <a:defRPr sz="1200" b="0">
+                <a:solidFill>
+                  <a:srgbClr val="4D5A68"/>
+                </a:solidFill>
+                <a:latin typeface="Malgun Gothic"/>
+                <a:ea typeface="Malgun Gothic"/>
+                <a:cs typeface="Malgun Gothic"/>
+              </a:defRPr>
+            </a:lvl1pPr>
+            <a:lvl2pPr algn="r">
+              <a:defRPr sz="1200" b="0">
+                <a:solidFill>
+                  <a:srgbClr val="4D5A68"/>
+                </a:solidFill>
+                <a:latin typeface="Malgun Gothic"/>
+                <a:ea typeface="Malgun Gothic"/>
+                <a:cs typeface="Malgun Gothic"/>
+              </a:defRPr>
+            </a:lvl2pPr>
+            <a:lvl3pPr algn="r">
+              <a:defRPr sz="1200" b="0">
+                <a:solidFill>
+                  <a:srgbClr val="4D5A68"/>
+                </a:solidFill>
+                <a:latin typeface="Malgun Gothic"/>
+                <a:ea typeface="Malgun Gothic"/>
+                <a:cs typeface="Malgun Gothic"/>
+              </a:defRPr>
+            </a:lvl3pPr>
+            <a:lvl4pPr algn="r">
+              <a:defRPr sz="1200" b="0">
+                <a:solidFill>
+                  <a:srgbClr val="4D5A68"/>
+                </a:solidFill>
+                <a:latin typeface="Malgun Gothic"/>
+                <a:ea typeface="Malgun Gothic"/>
+                <a:cs typeface="Malgun Gothic"/>
+              </a:defRPr>
+            </a:lvl4pPr>
+            <a:lvl5pPr algn="r">
+              <a:defRPr sz="1200" b="0">
+                <a:solidFill>
+                  <a:srgbClr val="4D5A68"/>
+                </a:solidFill>
+                <a:latin typeface="Malgun Gothic"/>
+                <a:ea typeface="Malgun Gothic"/>
+                <a:cs typeface="Malgun Gothic"/>
+              </a:defRPr>
+            </a:lvl5pPr>
+            <a:lvl6pPr algn="r">
+              <a:defRPr sz="1200" b="0">
+                <a:solidFill>
+                  <a:srgbClr val="4D5A68"/>
+                </a:solidFill>
+                <a:latin typeface="Malgun Gothic"/>
+                <a:ea typeface="Malgun Gothic"/>
+                <a:cs typeface="Malgun Gothic"/>
+              </a:defRPr>
+            </a:lvl6pPr>
+            <a:lvl7pPr algn="r">
+              <a:defRPr sz="1200" b="0">
+                <a:solidFill>
+                  <a:srgbClr val="4D5A68"/>
+                </a:solidFill>
+                <a:latin typeface="Malgun Gothic"/>
+                <a:ea typeface="Malgun Gothic"/>
+                <a:cs typeface="Malgun Gothic"/>
+              </a:defRPr>
+            </a:lvl7pPr>
+            <a:lvl8pPr algn="r">
+              <a:defRPr sz="1200" b="0">
+                <a:solidFill>
+                  <a:srgbClr val="4D5A68"/>
+                </a:solidFill>
+                <a:latin typeface="Malgun Gothic"/>
+                <a:ea typeface="Malgun Gothic"/>
+                <a:cs typeface="Malgun Gothic"/>
+              </a:defRPr>
+            </a:lvl8pPr>
+            <a:lvl9pPr algn="r">
+              <a:defRPr sz="1200" b="0">
+                <a:solidFill>
+                  <a:srgbClr val="4D5A68"/>
+                </a:solidFill>
+                <a:latin typeface="Malgun Gothic"/>
+                <a:ea typeface="Malgun Gothic"/>
+                <a:cs typeface="Malgun Gothic"/>
+              </a:defRPr>
+            </a:lvl9pPr>
+          </a:lstStyle>
+          <a:p xmlns:a="http://schemas.openxmlformats.org/drawingml/2006/main">
+            <a:pPr algn="r">
+              <a:defRPr sz="1200" b="0">
+                <a:solidFill>
+                  <a:srgbClr val="4D5A68"/>
+                </a:solidFill>
+                <a:latin typeface="Malgun Gothic"/>
+                <a:ea typeface="Malgun Gothic"/>
+                <a:cs typeface="Malgun Gothic"/>
+              </a:defRPr>
+            </a:pPr>
+            <a:r>
+              <a:rPr sz="1200" b="0">
+                <a:solidFill>
+                  <a:srgbClr val="4D5A68"/>
+                </a:solidFill>
+                <a:latin typeface="Malgun Gothic"/>
+                <a:ea typeface="Malgun Gothic"/>
+                <a:cs typeface="Malgun Gothic"/>
+              </a:rPr>
+              <a:t>M 연계 · M5 · M6</a:t>
+            </a:r>
+          </a:p>
+        </p:txBody>
+      </p:sp>
     </p:spTree>
     <p:extLst>
       <p:ext uri="{BB962C8B-B14F-4D97-AF65-F5344CB8AC3E}">
-        <p14:creationId xmlns:p14="http://schemas.microsoft.com/office/powerpoint/2010/main" val="1470115050"/>
+        <p14:creationId xmlns:p14="http://schemas.microsoft.com/office/powerpoint/2010/main" val="1562077318"/>
       </p:ext>
     </p:extLst>
   </p:cSld>
@@ -21239,10 +22034,10 @@
       </p:grpSpPr>
       <p:sp>
         <p:nvSpPr>
-          <p:cNvPr id="17" name="ACT 0 · 조사 결과 읽기">
+          <p:cNvPr id="18" name="ACT 0 · 조사 결과 읽기">
             <a:extLst xmlns:a="http://schemas.openxmlformats.org/drawingml/2006/main">
               <a:ext uri="{FF2B5EF4-FFF2-40B4-BE49-F238E27FC236}">
-                <a16:creationId xmlns:a16="http://schemas.microsoft.com/office/drawing/2014/main" id="{8FB1803A-62DC-4595-8C9A-4DE716C6EA7E}"/>
+                <a16:creationId xmlns:a16="http://schemas.microsoft.com/office/drawing/2014/main" id="{F27897F9-AB3C-434A-9BB6-E050ADC48C96}"/>
               </a:ext>
             </a:extLst>
           </p:cNvPr>
@@ -21400,7 +22195,7 @@
           <p:cNvPr id="2" name="S06">
             <a:extLst xmlns:a="http://schemas.openxmlformats.org/drawingml/2006/main">
               <a:ext uri="{FF2B5EF4-FFF2-40B4-BE49-F238E27FC236}">
-                <a16:creationId xmlns:a16="http://schemas.microsoft.com/office/drawing/2014/main" id="{559DF794-AB07-4218-8B4A-87D3BE98EA9F}"/>
+                <a16:creationId xmlns:a16="http://schemas.microsoft.com/office/drawing/2014/main" id="{FF9B136A-6549-4152-AE86-BC8FFB5534A1}"/>
               </a:ext>
             </a:extLst>
           </p:cNvPr>
@@ -21558,7 +22353,7 @@
           <p:cNvPr id="3" name="관찰 결과와 실행 제한을 분리한다">
             <a:extLst xmlns:a="http://schemas.openxmlformats.org/drawingml/2006/main">
               <a:ext uri="{FF2B5EF4-FFF2-40B4-BE49-F238E27FC236}">
-                <a16:creationId xmlns:a16="http://schemas.microsoft.com/office/drawing/2014/main" id="{BB5CAA6F-470E-46A2-B5A8-85A1687AE682}"/>
+                <a16:creationId xmlns:a16="http://schemas.microsoft.com/office/drawing/2014/main" id="{668BE7BF-75A4-4485-90B1-32C6C8929835}"/>
               </a:ext>
             </a:extLst>
           </p:cNvPr>
@@ -21716,7 +22511,7 @@
           <p:cNvPr id="4" name="">
             <a:extLst xmlns:a="http://schemas.openxmlformats.org/drawingml/2006/main">
               <a:ext uri="{FF2B5EF4-FFF2-40B4-BE49-F238E27FC236}">
-                <a16:creationId xmlns:a16="http://schemas.microsoft.com/office/drawing/2014/main" id="{E855CD61-A384-4CB5-A4CB-5F4386FD67B6}"/>
+                <a16:creationId xmlns:a16="http://schemas.microsoft.com/office/drawing/2014/main" id="{44913FAB-4985-40CF-9091-BDEBD6DCAB85}"/>
               </a:ext>
             </a:extLst>
           </p:cNvPr>
@@ -21727,7 +22522,7 @@
         </p:nvSpPr>
         <p:spPr>
           <a:xfrm xmlns:a="http://schemas.openxmlformats.org/drawingml/2006/main">
-            <a:off x="609600" y="5829300"/>
+            <a:off x="609600" y="5753100"/>
             <a:ext cx="10972800" cy="0"/>
           </a:xfrm>
           <a:prstGeom xmlns:a="http://schemas.openxmlformats.org/drawingml/2006/main" prst="line">
@@ -21747,7 +22542,7 @@
           <p:cNvPr id="5" name="TRIAL-001 기록 재구성 · Codex CLI 0.154.0 · 단일 읽기 전용 조사">
             <a:extLst xmlns:a="http://schemas.openxmlformats.org/drawingml/2006/main">
               <a:ext uri="{FF2B5EF4-FFF2-40B4-BE49-F238E27FC236}">
-                <a16:creationId xmlns:a16="http://schemas.microsoft.com/office/drawing/2014/main" id="{4F722E5B-0872-486F-B368-6AE21DCB66C0}"/>
+                <a16:creationId xmlns:a16="http://schemas.microsoft.com/office/drawing/2014/main" id="{D9959EFB-1CA7-4EC7-891C-085DB2F2A3F6}"/>
               </a:ext>
             </a:extLst>
           </p:cNvPr>
@@ -21758,8 +22553,8 @@
         </p:nvSpPr>
         <p:spPr>
           <a:xfrm xmlns:a="http://schemas.openxmlformats.org/drawingml/2006/main">
-            <a:off x="609600" y="5915025"/>
-            <a:ext cx="10972800" cy="247650"/>
+            <a:off x="609600" y="5791200"/>
+            <a:ext cx="10972800" cy="228600"/>
           </a:xfrm>
           <a:prstGeom xmlns:a="http://schemas.openxmlformats.org/drawingml/2006/main" prst="rect">
             <a:avLst/>
@@ -21905,7 +22700,7 @@
           <p:cNvPr id="6" name="환경 오류 3건은 crop 결함의 증거가 아닙니다. 이 조사에서 코드는 수정하지 않았습니다.">
             <a:extLst xmlns:a="http://schemas.openxmlformats.org/drawingml/2006/main">
               <a:ext uri="{FF2B5EF4-FFF2-40B4-BE49-F238E27FC236}">
-                <a16:creationId xmlns:a16="http://schemas.microsoft.com/office/drawing/2014/main" id="{93866C2D-A945-40C2-8930-ADD0F8FB1CD0}"/>
+                <a16:creationId xmlns:a16="http://schemas.microsoft.com/office/drawing/2014/main" id="{4B67AAF0-E311-4016-819E-A7694D4C90B0}"/>
               </a:ext>
             </a:extLst>
           </p:cNvPr>
@@ -21916,7 +22711,7 @@
         </p:nvSpPr>
         <p:spPr>
           <a:xfrm xmlns:a="http://schemas.openxmlformats.org/drawingml/2006/main">
-            <a:off x="609600" y="6191250"/>
+            <a:off x="609600" y="6019800"/>
             <a:ext cx="10972800" cy="209550"/>
           </a:xfrm>
           <a:prstGeom xmlns:a="http://schemas.openxmlformats.org/drawingml/2006/main" prst="rect">
@@ -22063,7 +22858,7 @@
           <p:cNvPr id="7" name="코드에서 확인한 문제">
             <a:extLst xmlns:a="http://schemas.openxmlformats.org/drawingml/2006/main">
               <a:ext uri="{FF2B5EF4-FFF2-40B4-BE49-F238E27FC236}">
-                <a16:creationId xmlns:a16="http://schemas.microsoft.com/office/drawing/2014/main" id="{74242780-6E11-48BF-84FF-A51F3F1AFC48}"/>
+                <a16:creationId xmlns:a16="http://schemas.microsoft.com/office/drawing/2014/main" id="{BBDA64F0-F822-40C0-BCA9-8DF26E14EB25}"/>
               </a:ext>
             </a:extLst>
           </p:cNvPr>
@@ -22221,7 +23016,7 @@
           <p:cNvPr id="8" name="실행 환경에서 생긴 제한">
             <a:extLst xmlns:a="http://schemas.openxmlformats.org/drawingml/2006/main">
               <a:ext uri="{FF2B5EF4-FFF2-40B4-BE49-F238E27FC236}">
-                <a16:creationId xmlns:a16="http://schemas.microsoft.com/office/drawing/2014/main" id="{0D6ED851-9893-4703-A9FE-67652915AA0E}"/>
+                <a16:creationId xmlns:a16="http://schemas.microsoft.com/office/drawing/2014/main" id="{7A20EA63-D5D6-4777-A7F3-26C4F1EE3B34}"/>
               </a:ext>
             </a:extLst>
           </p:cNvPr>
@@ -22379,7 +23174,7 @@
           <p:cNvPr id="9" name="">
             <a:extLst xmlns:a="http://schemas.openxmlformats.org/drawingml/2006/main">
               <a:ext uri="{FF2B5EF4-FFF2-40B4-BE49-F238E27FC236}">
-                <a16:creationId xmlns:a16="http://schemas.microsoft.com/office/drawing/2014/main" id="{8CC49B84-6C83-47DB-9216-1B3503B744A0}"/>
+                <a16:creationId xmlns:a16="http://schemas.microsoft.com/office/drawing/2014/main" id="{C51F26C1-9D59-45D9-BC93-BB314C151DAC}"/>
               </a:ext>
             </a:extLst>
           </p:cNvPr>
@@ -22412,7 +23207,7 @@
           <p:cNvPr id="10" name="">
             <a:extLst xmlns:a="http://schemas.openxmlformats.org/drawingml/2006/main">
               <a:ext uri="{FF2B5EF4-FFF2-40B4-BE49-F238E27FC236}">
-                <a16:creationId xmlns:a16="http://schemas.microsoft.com/office/drawing/2014/main" id="{2D471211-ECAF-4E0C-886A-5C381B2672B7}"/>
+                <a16:creationId xmlns:a16="http://schemas.microsoft.com/office/drawing/2014/main" id="{D29BA189-1125-49C7-9E1B-CABBEE8DF014}"/>
               </a:ext>
             </a:extLst>
           </p:cNvPr>
@@ -22443,7 +23238,7 @@
           <p:cNvPr id="11" name="crop에 한 열이 더 포함됨">
             <a:extLst xmlns:a="http://schemas.openxmlformats.org/drawingml/2006/main">
               <a:ext uri="{FF2B5EF4-FFF2-40B4-BE49-F238E27FC236}">
-                <a16:creationId xmlns:a16="http://schemas.microsoft.com/office/drawing/2014/main" id="{E4B665C6-AFD1-4293-B2DE-B1DA1730987E}"/>
+                <a16:creationId xmlns:a16="http://schemas.microsoft.com/office/drawing/2014/main" id="{874321DA-51F7-45CD-B3E7-EE3096097B39}"/>
               </a:ext>
             </a:extLst>
           </p:cNvPr>
@@ -22601,7 +23396,7 @@
           <p:cNvPr id="12" name="테스트·호출 경로·계약 연결&#10;원인 설명 / 코드 수정 없음">
             <a:extLst xmlns:a="http://schemas.openxmlformats.org/drawingml/2006/main">
               <a:ext uri="{FF2B5EF4-FFF2-40B4-BE49-F238E27FC236}">
-                <a16:creationId xmlns:a16="http://schemas.microsoft.com/office/drawing/2014/main" id="{4000687F-9CFC-4220-A9CB-63219E328D24}"/>
+                <a16:creationId xmlns:a16="http://schemas.microsoft.com/office/drawing/2014/main" id="{05012E6F-8A04-4460-BE75-F5C58C78C151}"/>
               </a:ext>
             </a:extLst>
           </p:cNvPr>
@@ -22782,7 +23577,7 @@
           <p:cNvPr id="13" name="임시 디렉터리를 만들 수 없음">
             <a:extLst xmlns:a="http://schemas.openxmlformats.org/drawingml/2006/main">
               <a:ext uri="{FF2B5EF4-FFF2-40B4-BE49-F238E27FC236}">
-                <a16:creationId xmlns:a16="http://schemas.microsoft.com/office/drawing/2014/main" id="{D11170B4-5388-429E-944E-895FB8428698}"/>
+                <a16:creationId xmlns:a16="http://schemas.microsoft.com/office/drawing/2014/main" id="{76FE49E3-E79C-4807-B157-C1E5243B4DA6}"/>
               </a:ext>
             </a:extLst>
           </p:cNvPr>
@@ -22940,7 +23735,7 @@
           <p:cNvPr id="14" name="읽기 전용 권한 때문에&#10;서로 다른 테스트 3건이 오류">
             <a:extLst xmlns:a="http://schemas.openxmlformats.org/drawingml/2006/main">
               <a:ext uri="{FF2B5EF4-FFF2-40B4-BE49-F238E27FC236}">
-                <a16:creationId xmlns:a16="http://schemas.microsoft.com/office/drawing/2014/main" id="{30173CBE-D135-48E2-A2EB-C01C0D270B08}"/>
+                <a16:creationId xmlns:a16="http://schemas.microsoft.com/office/drawing/2014/main" id="{6AFE3F3B-8D10-4E5E-A677-7CE7D542C973}"/>
               </a:ext>
             </a:extLst>
           </p:cNvPr>
@@ -23121,7 +23916,7 @@
           <p:cNvPr id="15" name="">
             <a:extLst xmlns:a="http://schemas.openxmlformats.org/drawingml/2006/main">
               <a:ext uri="{FF2B5EF4-FFF2-40B4-BE49-F238E27FC236}">
-                <a16:creationId xmlns:a16="http://schemas.microsoft.com/office/drawing/2014/main" id="{97765F9F-A606-499D-9BFD-DFE2B8AA7121}"/>
+                <a16:creationId xmlns:a16="http://schemas.microsoft.com/office/drawing/2014/main" id="{B2F074A9-F540-48F8-A68B-635B16269112}"/>
               </a:ext>
             </a:extLst>
           </p:cNvPr>
@@ -23152,7 +23947,7 @@
           <p:cNvPr id="16" name="전체 실행 기록: 7개 통과 + crop 실패 + 환경 오류 3건">
             <a:extLst xmlns:a="http://schemas.openxmlformats.org/drawingml/2006/main">
               <a:ext uri="{FF2B5EF4-FFF2-40B4-BE49-F238E27FC236}">
-                <a16:creationId xmlns:a16="http://schemas.microsoft.com/office/drawing/2014/main" id="{621C5D12-5DD9-45AE-9A2E-AA8123689974}"/>
+                <a16:creationId xmlns:a16="http://schemas.microsoft.com/office/drawing/2014/main" id="{A9D182C0-750E-4067-A0B6-C8C8AACB622B}"/>
               </a:ext>
             </a:extLst>
           </p:cNvPr>
@@ -23305,10 +24100,168 @@
           </a:p>
         </p:txBody>
       </p:sp>
+      <p:sp>
+        <p:nvSpPr>
+          <p:cNvPr id="17" name="Legacy module connection">
+            <a:extLst xmlns:a="http://schemas.openxmlformats.org/drawingml/2006/main">
+              <a:ext uri="{FF2B5EF4-FFF2-40B4-BE49-F238E27FC236}">
+                <a16:creationId xmlns:a16="http://schemas.microsoft.com/office/drawing/2014/main" id="{407DBDA1-88E2-4E57-8C50-F320194F3AE8}"/>
+              </a:ext>
+            </a:extLst>
+          </p:cNvPr>
+          <p:cNvSpPr>
+            <a:spLocks xmlns:a="http://schemas.openxmlformats.org/drawingml/2006/main" noGrp="1"/>
+          </p:cNvSpPr>
+          <p:nvPr/>
+        </p:nvSpPr>
+        <p:spPr>
+          <a:xfrm xmlns:a="http://schemas.openxmlformats.org/drawingml/2006/main">
+            <a:off x="609600" y="6229350"/>
+            <a:ext cx="10972800" cy="171450"/>
+          </a:xfrm>
+          <a:prstGeom xmlns:a="http://schemas.openxmlformats.org/drawingml/2006/main" prst="rect">
+            <a:avLst/>
+          </a:prstGeom>
+          <a:noFill xmlns:a="http://schemas.openxmlformats.org/drawingml/2006/main"/>
+          <a:ln xmlns:a="http://schemas.openxmlformats.org/drawingml/2006/main" w="0">
+            <a:noFill/>
+          </a:ln>
+        </p:spPr>
+        <p:txBody>
+          <a:bodyPr xmlns:a="http://schemas.openxmlformats.org/drawingml/2006/main" wrap="none" lIns="0" tIns="0" rIns="0" bIns="0" anchor="ctr">
+            <a:noAutofit/>
+          </a:bodyPr>
+          <a:lstStyle xmlns:a="http://schemas.openxmlformats.org/drawingml/2006/main">
+            <a:defPPr algn="r">
+              <a:defRPr sz="1200" b="0">
+                <a:solidFill>
+                  <a:srgbClr val="4D5A68"/>
+                </a:solidFill>
+                <a:latin typeface="Malgun Gothic"/>
+                <a:ea typeface="Malgun Gothic"/>
+                <a:cs typeface="Malgun Gothic"/>
+              </a:defRPr>
+            </a:defPPr>
+            <a:lvl1pPr algn="r">
+              <a:defRPr sz="1200" b="0">
+                <a:solidFill>
+                  <a:srgbClr val="4D5A68"/>
+                </a:solidFill>
+                <a:latin typeface="Malgun Gothic"/>
+                <a:ea typeface="Malgun Gothic"/>
+                <a:cs typeface="Malgun Gothic"/>
+              </a:defRPr>
+            </a:lvl1pPr>
+            <a:lvl2pPr algn="r">
+              <a:defRPr sz="1200" b="0">
+                <a:solidFill>
+                  <a:srgbClr val="4D5A68"/>
+                </a:solidFill>
+                <a:latin typeface="Malgun Gothic"/>
+                <a:ea typeface="Malgun Gothic"/>
+                <a:cs typeface="Malgun Gothic"/>
+              </a:defRPr>
+            </a:lvl2pPr>
+            <a:lvl3pPr algn="r">
+              <a:defRPr sz="1200" b="0">
+                <a:solidFill>
+                  <a:srgbClr val="4D5A68"/>
+                </a:solidFill>
+                <a:latin typeface="Malgun Gothic"/>
+                <a:ea typeface="Malgun Gothic"/>
+                <a:cs typeface="Malgun Gothic"/>
+              </a:defRPr>
+            </a:lvl3pPr>
+            <a:lvl4pPr algn="r">
+              <a:defRPr sz="1200" b="0">
+                <a:solidFill>
+                  <a:srgbClr val="4D5A68"/>
+                </a:solidFill>
+                <a:latin typeface="Malgun Gothic"/>
+                <a:ea typeface="Malgun Gothic"/>
+                <a:cs typeface="Malgun Gothic"/>
+              </a:defRPr>
+            </a:lvl4pPr>
+            <a:lvl5pPr algn="r">
+              <a:defRPr sz="1200" b="0">
+                <a:solidFill>
+                  <a:srgbClr val="4D5A68"/>
+                </a:solidFill>
+                <a:latin typeface="Malgun Gothic"/>
+                <a:ea typeface="Malgun Gothic"/>
+                <a:cs typeface="Malgun Gothic"/>
+              </a:defRPr>
+            </a:lvl5pPr>
+            <a:lvl6pPr algn="r">
+              <a:defRPr sz="1200" b="0">
+                <a:solidFill>
+                  <a:srgbClr val="4D5A68"/>
+                </a:solidFill>
+                <a:latin typeface="Malgun Gothic"/>
+                <a:ea typeface="Malgun Gothic"/>
+                <a:cs typeface="Malgun Gothic"/>
+              </a:defRPr>
+            </a:lvl6pPr>
+            <a:lvl7pPr algn="r">
+              <a:defRPr sz="1200" b="0">
+                <a:solidFill>
+                  <a:srgbClr val="4D5A68"/>
+                </a:solidFill>
+                <a:latin typeface="Malgun Gothic"/>
+                <a:ea typeface="Malgun Gothic"/>
+                <a:cs typeface="Malgun Gothic"/>
+              </a:defRPr>
+            </a:lvl7pPr>
+            <a:lvl8pPr algn="r">
+              <a:defRPr sz="1200" b="0">
+                <a:solidFill>
+                  <a:srgbClr val="4D5A68"/>
+                </a:solidFill>
+                <a:latin typeface="Malgun Gothic"/>
+                <a:ea typeface="Malgun Gothic"/>
+                <a:cs typeface="Malgun Gothic"/>
+              </a:defRPr>
+            </a:lvl8pPr>
+            <a:lvl9pPr algn="r">
+              <a:defRPr sz="1200" b="0">
+                <a:solidFill>
+                  <a:srgbClr val="4D5A68"/>
+                </a:solidFill>
+                <a:latin typeface="Malgun Gothic"/>
+                <a:ea typeface="Malgun Gothic"/>
+                <a:cs typeface="Malgun Gothic"/>
+              </a:defRPr>
+            </a:lvl9pPr>
+          </a:lstStyle>
+          <a:p xmlns:a="http://schemas.openxmlformats.org/drawingml/2006/main">
+            <a:pPr algn="r">
+              <a:defRPr sz="1200" b="0">
+                <a:solidFill>
+                  <a:srgbClr val="4D5A68"/>
+                </a:solidFill>
+                <a:latin typeface="Malgun Gothic"/>
+                <a:ea typeface="Malgun Gothic"/>
+                <a:cs typeface="Malgun Gothic"/>
+              </a:defRPr>
+            </a:pPr>
+            <a:r>
+              <a:rPr sz="1200" b="0">
+                <a:solidFill>
+                  <a:srgbClr val="4D5A68"/>
+                </a:solidFill>
+                <a:latin typeface="Malgun Gothic"/>
+                <a:ea typeface="Malgun Gothic"/>
+                <a:cs typeface="Malgun Gothic"/>
+              </a:rPr>
+              <a:t>M 연계 · M6</a:t>
+            </a:r>
+          </a:p>
+        </p:txBody>
+      </p:sp>
     </p:spTree>
     <p:extLst>
       <p:ext uri="{BB962C8B-B14F-4D97-AF65-F5344CB8AC3E}">
-        <p14:creationId xmlns:p14="http://schemas.microsoft.com/office/powerpoint/2010/main" val="119272415"/>
+        <p14:creationId xmlns:p14="http://schemas.microsoft.com/office/powerpoint/2010/main" val="1968831839"/>
       </p:ext>
     </p:extLst>
   </p:cSld>
@@ -23336,10 +24289,10 @@
       </p:grpSpPr>
       <p:sp>
         <p:nvSpPr>
-          <p:cNvPr id="12" name="ACT 0 · Context를 찾는 주체">
+          <p:cNvPr id="14" name="ACT 0 · Context를 찾는 주체">
             <a:extLst xmlns:a="http://schemas.openxmlformats.org/drawingml/2006/main">
               <a:ext uri="{FF2B5EF4-FFF2-40B4-BE49-F238E27FC236}">
-                <a16:creationId xmlns:a16="http://schemas.microsoft.com/office/drawing/2014/main" id="{2C7072AD-F5F3-4730-94E1-FE5134DB00D5}"/>
+                <a16:creationId xmlns:a16="http://schemas.microsoft.com/office/drawing/2014/main" id="{696ECCBD-DCFD-4CBD-8678-0FB3017D7AB2}"/>
               </a:ext>
             </a:extLst>
           </p:cNvPr>
@@ -23497,7 +24450,7 @@
           <p:cNvPr id="2" name="S07">
             <a:extLst xmlns:a="http://schemas.openxmlformats.org/drawingml/2006/main">
               <a:ext uri="{FF2B5EF4-FFF2-40B4-BE49-F238E27FC236}">
-                <a16:creationId xmlns:a16="http://schemas.microsoft.com/office/drawing/2014/main" id="{4767C2B0-467D-413C-B591-16B2EA28B369}"/>
+                <a16:creationId xmlns:a16="http://schemas.microsoft.com/office/drawing/2014/main" id="{AB0519F4-FF7F-458A-8378-6BB738C94565}"/>
               </a:ext>
             </a:extLst>
           </p:cNvPr>
@@ -23655,7 +24608,7 @@
           <p:cNvPr id="3" name="코드를 AI에게 가져가는 대신&#10;AI를 Repository로 데려간다">
             <a:extLst xmlns:a="http://schemas.openxmlformats.org/drawingml/2006/main">
               <a:ext uri="{FF2B5EF4-FFF2-40B4-BE49-F238E27FC236}">
-                <a16:creationId xmlns:a16="http://schemas.microsoft.com/office/drawing/2014/main" id="{CE408362-7007-4570-982F-BBD94F1E952D}"/>
+                <a16:creationId xmlns:a16="http://schemas.microsoft.com/office/drawing/2014/main" id="{B50686A5-B5FF-457C-8519-705A71F92986}"/>
               </a:ext>
             </a:extLst>
           </p:cNvPr>
@@ -23836,7 +24789,7 @@
           <p:cNvPr id="4" name="">
             <a:extLst xmlns:a="http://schemas.openxmlformats.org/drawingml/2006/main">
               <a:ext uri="{FF2B5EF4-FFF2-40B4-BE49-F238E27FC236}">
-                <a16:creationId xmlns:a16="http://schemas.microsoft.com/office/drawing/2014/main" id="{51B5685D-99D0-4C75-9CF5-10309CDDE697}"/>
+                <a16:creationId xmlns:a16="http://schemas.microsoft.com/office/drawing/2014/main" id="{EC0EEC3B-BA55-4FEC-8C5E-BB14ED3E01A3}"/>
               </a:ext>
             </a:extLst>
           </p:cNvPr>
@@ -23847,7 +24800,7 @@
         </p:nvSpPr>
         <p:spPr>
           <a:xfrm xmlns:a="http://schemas.openxmlformats.org/drawingml/2006/main">
-            <a:off x="609600" y="5829300"/>
+            <a:off x="609600" y="5753100"/>
             <a:ext cx="10972800" cy="0"/>
           </a:xfrm>
           <a:prstGeom xmlns:a="http://schemas.openxmlformats.org/drawingml/2006/main" prst="line">
@@ -23867,7 +24820,7 @@
           <p:cNvPr id="5" name="교육 모델 · TRIAL-001 단일 CLI 관찰과 연결 · AI 생성 설명용 삽화">
             <a:extLst xmlns:a="http://schemas.openxmlformats.org/drawingml/2006/main">
               <a:ext uri="{FF2B5EF4-FFF2-40B4-BE49-F238E27FC236}">
-                <a16:creationId xmlns:a16="http://schemas.microsoft.com/office/drawing/2014/main" id="{679C787C-819F-4271-890D-D5F83009F861}"/>
+                <a16:creationId xmlns:a16="http://schemas.microsoft.com/office/drawing/2014/main" id="{E0BA2F5D-59EA-47DE-8C15-B61B8F924A77}"/>
               </a:ext>
             </a:extLst>
           </p:cNvPr>
@@ -23878,8 +24831,8 @@
         </p:nvSpPr>
         <p:spPr>
           <a:xfrm xmlns:a="http://schemas.openxmlformats.org/drawingml/2006/main">
-            <a:off x="609600" y="5915025"/>
-            <a:ext cx="10972800" cy="247650"/>
+            <a:off x="609600" y="5791200"/>
+            <a:ext cx="10972800" cy="228600"/>
           </a:xfrm>
           <a:prstGeom xmlns:a="http://schemas.openxmlformats.org/drawingml/2006/main" prst="rect">
             <a:avLst/>
@@ -24025,7 +24978,7 @@
           <p:cNvPr id="6" name="목표 설정과 근거 검토는 개발자에게 남습니다. Repository 접근이 Task 의도를 정하지는 않습니다.">
             <a:extLst xmlns:a="http://schemas.openxmlformats.org/drawingml/2006/main">
               <a:ext uri="{FF2B5EF4-FFF2-40B4-BE49-F238E27FC236}">
-                <a16:creationId xmlns:a16="http://schemas.microsoft.com/office/drawing/2014/main" id="{56F34592-A6BC-47A0-B2A2-7D74545E8BF0}"/>
+                <a16:creationId xmlns:a16="http://schemas.microsoft.com/office/drawing/2014/main" id="{941B4F4A-1B74-412C-AD39-6CE271D03A38}"/>
               </a:ext>
             </a:extLst>
           </p:cNvPr>
@@ -24036,7 +24989,7 @@
         </p:nvSpPr>
         <p:spPr>
           <a:xfrm xmlns:a="http://schemas.openxmlformats.org/drawingml/2006/main">
-            <a:off x="609600" y="6191250"/>
+            <a:off x="609600" y="6019800"/>
             <a:ext cx="10972800" cy="209550"/>
           </a:xfrm>
           <a:prstGeom xmlns:a="http://schemas.openxmlformats.org/drawingml/2006/main" prst="rect">
@@ -24183,7 +25136,7 @@
           <p:cNvPr id="7" name="내가 골라 전달하는 Context">
             <a:extLst xmlns:a="http://schemas.openxmlformats.org/drawingml/2006/main">
               <a:ext uri="{FF2B5EF4-FFF2-40B4-BE49-F238E27FC236}">
-                <a16:creationId xmlns:a16="http://schemas.microsoft.com/office/drawing/2014/main" id="{D513DEF8-60D9-4C4D-8581-3EF48D4995FD}"/>
+                <a16:creationId xmlns:a16="http://schemas.microsoft.com/office/drawing/2014/main" id="{6E032D8E-C056-4D05-8402-6792CCC35389}"/>
               </a:ext>
             </a:extLst>
           </p:cNvPr>
@@ -24341,7 +25294,7 @@
           <p:cNvPr id="8" name="조사를 맡기고 근거를 확인">
             <a:extLst xmlns:a="http://schemas.openxmlformats.org/drawingml/2006/main">
               <a:ext uri="{FF2B5EF4-FFF2-40B4-BE49-F238E27FC236}">
-                <a16:creationId xmlns:a16="http://schemas.microsoft.com/office/drawing/2014/main" id="{44E82618-1E8D-4F56-9273-129BFE37CE1D}"/>
+                <a16:creationId xmlns:a16="http://schemas.microsoft.com/office/drawing/2014/main" id="{55CEA4DE-1C81-478D-9624-510B6178D00D}"/>
               </a:ext>
             </a:extLst>
           </p:cNvPr>
@@ -24499,7 +25452,7 @@
           <p:cNvPr id="9" name="">
             <a:extLst xmlns:a="http://schemas.openxmlformats.org/drawingml/2006/main">
               <a:ext uri="{FF2B5EF4-FFF2-40B4-BE49-F238E27FC236}">
-                <a16:creationId xmlns:a16="http://schemas.microsoft.com/office/drawing/2014/main" id="{DF953E15-79B3-411F-A783-09F0C01A6A53}"/>
+                <a16:creationId xmlns:a16="http://schemas.microsoft.com/office/drawing/2014/main" id="{2603A427-BAB7-4D45-85C8-C8A5DCD9EFCF}"/>
               </a:ext>
             </a:extLst>
           </p:cNvPr>
@@ -24509,14 +25462,14 @@
           <p:nvPr/>
         </p:nvPicPr>
         <p:blipFill>
-          <a:blip xmlns:r="http://schemas.openxmlformats.org/officeDocument/2006/relationships" xmlns:a="http://schemas.openxmlformats.org/drawingml/2006/main" r:embed="Re64e844e08024e6f"/>
+          <a:blip xmlns:r="http://schemas.openxmlformats.org/officeDocument/2006/relationships" xmlns:a="http://schemas.openxmlformats.org/drawingml/2006/main" r:embed="Rbcb8206f499d43bd"/>
           <a:srcRect xmlns:a="http://schemas.openxmlformats.org/drawingml/2006/main" l="0" t="18000" r="0" b="15000"/>
           <a:stretch xmlns:a="http://schemas.openxmlformats.org/drawingml/2006/main"/>
         </p:blipFill>
         <p:spPr>
           <a:xfrm xmlns:a="http://schemas.openxmlformats.org/drawingml/2006/main">
-            <a:off x="1562100" y="2343150"/>
-            <a:ext cx="9067800" cy="3038475"/>
+            <a:off x="2371725" y="2343150"/>
+            <a:ext cx="7448550" cy="2495550"/>
           </a:xfrm>
           <a:prstGeom xmlns:a="http://schemas.openxmlformats.org/drawingml/2006/main" prst="rect">
             <a:avLst/>
@@ -24528,7 +25481,7 @@
           <p:cNvPr id="10" name="코드 조각을 선택·복사">
             <a:extLst xmlns:a="http://schemas.openxmlformats.org/drawingml/2006/main">
               <a:ext uri="{FF2B5EF4-FFF2-40B4-BE49-F238E27FC236}">
-                <a16:creationId xmlns:a16="http://schemas.microsoft.com/office/drawing/2014/main" id="{FB237846-7700-4617-97BD-865154E854AB}"/>
+                <a16:creationId xmlns:a16="http://schemas.microsoft.com/office/drawing/2014/main" id="{1C83D286-A9F3-4509-968E-011D91101EB2}"/>
               </a:ext>
             </a:extLst>
           </p:cNvPr>
@@ -24539,7 +25492,7 @@
         </p:nvSpPr>
         <p:spPr>
           <a:xfrm xmlns:a="http://schemas.openxmlformats.org/drawingml/2006/main">
-            <a:off x="609600" y="5314950"/>
+            <a:off x="609600" y="4886325"/>
             <a:ext cx="5238750" cy="342900"/>
           </a:xfrm>
           <a:prstGeom xmlns:a="http://schemas.openxmlformats.org/drawingml/2006/main" prst="rect">
@@ -24686,7 +25639,7 @@
           <p:cNvPr id="11" name="목표는 사람이, 탐색은 Agent와">
             <a:extLst xmlns:a="http://schemas.openxmlformats.org/drawingml/2006/main">
               <a:ext uri="{FF2B5EF4-FFF2-40B4-BE49-F238E27FC236}">
-                <a16:creationId xmlns:a16="http://schemas.microsoft.com/office/drawing/2014/main" id="{CB5A462D-A92C-4F96-9677-C40E4D0D519B}"/>
+                <a16:creationId xmlns:a16="http://schemas.microsoft.com/office/drawing/2014/main" id="{C64E5284-174C-4400-B53A-DF747037667C}"/>
               </a:ext>
             </a:extLst>
           </p:cNvPr>
@@ -24697,7 +25650,7 @@
         </p:nvSpPr>
         <p:spPr>
           <a:xfrm xmlns:a="http://schemas.openxmlformats.org/drawingml/2006/main">
-            <a:off x="6381750" y="5314950"/>
+            <a:off x="6381750" y="4886325"/>
             <a:ext cx="5200650" cy="342900"/>
           </a:xfrm>
           <a:prstGeom xmlns:a="http://schemas.openxmlformats.org/drawingml/2006/main" prst="rect">
@@ -24839,10 +25792,326 @@
           </a:p>
         </p:txBody>
       </p:sp>
+      <p:sp>
+        <p:nvSpPr>
+          <p:cNvPr id="12" name="접근 전: 승인된 도구·계정·자료·권한 범위를 확인한다.">
+            <a:extLst xmlns:a="http://schemas.openxmlformats.org/drawingml/2006/main">
+              <a:ext uri="{FF2B5EF4-FFF2-40B4-BE49-F238E27FC236}">
+                <a16:creationId xmlns:a16="http://schemas.microsoft.com/office/drawing/2014/main" id="{CFC09BEB-3EB3-4D68-83F7-57E748E89FA1}"/>
+              </a:ext>
+            </a:extLst>
+          </p:cNvPr>
+          <p:cNvSpPr>
+            <a:spLocks xmlns:a="http://schemas.openxmlformats.org/drawingml/2006/main" noGrp="1"/>
+          </p:cNvSpPr>
+          <p:nvPr/>
+        </p:nvSpPr>
+        <p:spPr>
+          <a:xfrm xmlns:a="http://schemas.openxmlformats.org/drawingml/2006/main">
+            <a:off x="609600" y="5343525"/>
+            <a:ext cx="10972800" cy="314325"/>
+          </a:xfrm>
+          <a:prstGeom xmlns:a="http://schemas.openxmlformats.org/drawingml/2006/main" prst="rect">
+            <a:avLst/>
+          </a:prstGeom>
+          <a:noFill xmlns:a="http://schemas.openxmlformats.org/drawingml/2006/main"/>
+          <a:ln xmlns:a="http://schemas.openxmlformats.org/drawingml/2006/main" w="0">
+            <a:noFill/>
+          </a:ln>
+        </p:spPr>
+        <p:txBody>
+          <a:bodyPr xmlns:a="http://schemas.openxmlformats.org/drawingml/2006/main" wrap="none" lIns="0" tIns="0" rIns="0" bIns="0" anchor="ctr">
+            <a:noAutofit/>
+          </a:bodyPr>
+          <a:lstStyle xmlns:a="http://schemas.openxmlformats.org/drawingml/2006/main">
+            <a:defPPr algn="l">
+              <a:defRPr sz="1875" b="0">
+                <a:solidFill>
+                  <a:srgbClr val="4D5A68"/>
+                </a:solidFill>
+                <a:latin typeface="Malgun Gothic"/>
+                <a:ea typeface="Malgun Gothic"/>
+                <a:cs typeface="Malgun Gothic"/>
+              </a:defRPr>
+            </a:defPPr>
+            <a:lvl1pPr algn="l">
+              <a:defRPr sz="1875" b="0">
+                <a:solidFill>
+                  <a:srgbClr val="4D5A68"/>
+                </a:solidFill>
+                <a:latin typeface="Malgun Gothic"/>
+                <a:ea typeface="Malgun Gothic"/>
+                <a:cs typeface="Malgun Gothic"/>
+              </a:defRPr>
+            </a:lvl1pPr>
+            <a:lvl2pPr algn="l">
+              <a:defRPr sz="1875" b="0">
+                <a:solidFill>
+                  <a:srgbClr val="4D5A68"/>
+                </a:solidFill>
+                <a:latin typeface="Malgun Gothic"/>
+                <a:ea typeface="Malgun Gothic"/>
+                <a:cs typeface="Malgun Gothic"/>
+              </a:defRPr>
+            </a:lvl2pPr>
+            <a:lvl3pPr algn="l">
+              <a:defRPr sz="1875" b="0">
+                <a:solidFill>
+                  <a:srgbClr val="4D5A68"/>
+                </a:solidFill>
+                <a:latin typeface="Malgun Gothic"/>
+                <a:ea typeface="Malgun Gothic"/>
+                <a:cs typeface="Malgun Gothic"/>
+              </a:defRPr>
+            </a:lvl3pPr>
+            <a:lvl4pPr algn="l">
+              <a:defRPr sz="1875" b="0">
+                <a:solidFill>
+                  <a:srgbClr val="4D5A68"/>
+                </a:solidFill>
+                <a:latin typeface="Malgun Gothic"/>
+                <a:ea typeface="Malgun Gothic"/>
+                <a:cs typeface="Malgun Gothic"/>
+              </a:defRPr>
+            </a:lvl4pPr>
+            <a:lvl5pPr algn="l">
+              <a:defRPr sz="1875" b="0">
+                <a:solidFill>
+                  <a:srgbClr val="4D5A68"/>
+                </a:solidFill>
+                <a:latin typeface="Malgun Gothic"/>
+                <a:ea typeface="Malgun Gothic"/>
+                <a:cs typeface="Malgun Gothic"/>
+              </a:defRPr>
+            </a:lvl5pPr>
+            <a:lvl6pPr algn="l">
+              <a:defRPr sz="1875" b="0">
+                <a:solidFill>
+                  <a:srgbClr val="4D5A68"/>
+                </a:solidFill>
+                <a:latin typeface="Malgun Gothic"/>
+                <a:ea typeface="Malgun Gothic"/>
+                <a:cs typeface="Malgun Gothic"/>
+              </a:defRPr>
+            </a:lvl6pPr>
+            <a:lvl7pPr algn="l">
+              <a:defRPr sz="1875" b="0">
+                <a:solidFill>
+                  <a:srgbClr val="4D5A68"/>
+                </a:solidFill>
+                <a:latin typeface="Malgun Gothic"/>
+                <a:ea typeface="Malgun Gothic"/>
+                <a:cs typeface="Malgun Gothic"/>
+              </a:defRPr>
+            </a:lvl7pPr>
+            <a:lvl8pPr algn="l">
+              <a:defRPr sz="1875" b="0">
+                <a:solidFill>
+                  <a:srgbClr val="4D5A68"/>
+                </a:solidFill>
+                <a:latin typeface="Malgun Gothic"/>
+                <a:ea typeface="Malgun Gothic"/>
+                <a:cs typeface="Malgun Gothic"/>
+              </a:defRPr>
+            </a:lvl8pPr>
+            <a:lvl9pPr algn="l">
+              <a:defRPr sz="1875" b="0">
+                <a:solidFill>
+                  <a:srgbClr val="4D5A68"/>
+                </a:solidFill>
+                <a:latin typeface="Malgun Gothic"/>
+                <a:ea typeface="Malgun Gothic"/>
+                <a:cs typeface="Malgun Gothic"/>
+              </a:defRPr>
+            </a:lvl9pPr>
+          </a:lstStyle>
+          <a:p xmlns:a="http://schemas.openxmlformats.org/drawingml/2006/main">
+            <a:pPr algn="l">
+              <a:defRPr sz="1875" b="0">
+                <a:solidFill>
+                  <a:srgbClr val="4D5A68"/>
+                </a:solidFill>
+                <a:latin typeface="Malgun Gothic"/>
+                <a:ea typeface="Malgun Gothic"/>
+                <a:cs typeface="Malgun Gothic"/>
+              </a:defRPr>
+            </a:pPr>
+            <a:r>
+              <a:rPr sz="1875" b="0">
+                <a:solidFill>
+                  <a:srgbClr val="4D5A68"/>
+                </a:solidFill>
+                <a:latin typeface="Malgun Gothic"/>
+                <a:ea typeface="Malgun Gothic"/>
+                <a:cs typeface="Malgun Gothic"/>
+              </a:rPr>
+              <a:t>접근 전: 승인된 도구·계정·자료·권한 범위를 확인한다.</a:t>
+            </a:r>
+          </a:p>
+        </p:txBody>
+      </p:sp>
+      <p:sp>
+        <p:nvSpPr>
+          <p:cNvPr id="13" name="Legacy module connection">
+            <a:extLst xmlns:a="http://schemas.openxmlformats.org/drawingml/2006/main">
+              <a:ext uri="{FF2B5EF4-FFF2-40B4-BE49-F238E27FC236}">
+                <a16:creationId xmlns:a16="http://schemas.microsoft.com/office/drawing/2014/main" id="{0BDAE7B8-9617-4350-82BB-349E8D98AD75}"/>
+              </a:ext>
+            </a:extLst>
+          </p:cNvPr>
+          <p:cNvSpPr>
+            <a:spLocks xmlns:a="http://schemas.openxmlformats.org/drawingml/2006/main" noGrp="1"/>
+          </p:cNvSpPr>
+          <p:nvPr/>
+        </p:nvSpPr>
+        <p:spPr>
+          <a:xfrm xmlns:a="http://schemas.openxmlformats.org/drawingml/2006/main">
+            <a:off x="609600" y="6229350"/>
+            <a:ext cx="10972800" cy="171450"/>
+          </a:xfrm>
+          <a:prstGeom xmlns:a="http://schemas.openxmlformats.org/drawingml/2006/main" prst="rect">
+            <a:avLst/>
+          </a:prstGeom>
+          <a:noFill xmlns:a="http://schemas.openxmlformats.org/drawingml/2006/main"/>
+          <a:ln xmlns:a="http://schemas.openxmlformats.org/drawingml/2006/main" w="0">
+            <a:noFill/>
+          </a:ln>
+        </p:spPr>
+        <p:txBody>
+          <a:bodyPr xmlns:a="http://schemas.openxmlformats.org/drawingml/2006/main" wrap="none" lIns="0" tIns="0" rIns="0" bIns="0" anchor="ctr">
+            <a:noAutofit/>
+          </a:bodyPr>
+          <a:lstStyle xmlns:a="http://schemas.openxmlformats.org/drawingml/2006/main">
+            <a:defPPr algn="r">
+              <a:defRPr sz="1200" b="0">
+                <a:solidFill>
+                  <a:srgbClr val="4D5A68"/>
+                </a:solidFill>
+                <a:latin typeface="Malgun Gothic"/>
+                <a:ea typeface="Malgun Gothic"/>
+                <a:cs typeface="Malgun Gothic"/>
+              </a:defRPr>
+            </a:defPPr>
+            <a:lvl1pPr algn="r">
+              <a:defRPr sz="1200" b="0">
+                <a:solidFill>
+                  <a:srgbClr val="4D5A68"/>
+                </a:solidFill>
+                <a:latin typeface="Malgun Gothic"/>
+                <a:ea typeface="Malgun Gothic"/>
+                <a:cs typeface="Malgun Gothic"/>
+              </a:defRPr>
+            </a:lvl1pPr>
+            <a:lvl2pPr algn="r">
+              <a:defRPr sz="1200" b="0">
+                <a:solidFill>
+                  <a:srgbClr val="4D5A68"/>
+                </a:solidFill>
+                <a:latin typeface="Malgun Gothic"/>
+                <a:ea typeface="Malgun Gothic"/>
+                <a:cs typeface="Malgun Gothic"/>
+              </a:defRPr>
+            </a:lvl2pPr>
+            <a:lvl3pPr algn="r">
+              <a:defRPr sz="1200" b="0">
+                <a:solidFill>
+                  <a:srgbClr val="4D5A68"/>
+                </a:solidFill>
+                <a:latin typeface="Malgun Gothic"/>
+                <a:ea typeface="Malgun Gothic"/>
+                <a:cs typeface="Malgun Gothic"/>
+              </a:defRPr>
+            </a:lvl3pPr>
+            <a:lvl4pPr algn="r">
+              <a:defRPr sz="1200" b="0">
+                <a:solidFill>
+                  <a:srgbClr val="4D5A68"/>
+                </a:solidFill>
+                <a:latin typeface="Malgun Gothic"/>
+                <a:ea typeface="Malgun Gothic"/>
+                <a:cs typeface="Malgun Gothic"/>
+              </a:defRPr>
+            </a:lvl4pPr>
+            <a:lvl5pPr algn="r">
+              <a:defRPr sz="1200" b="0">
+                <a:solidFill>
+                  <a:srgbClr val="4D5A68"/>
+                </a:solidFill>
+                <a:latin typeface="Malgun Gothic"/>
+                <a:ea typeface="Malgun Gothic"/>
+                <a:cs typeface="Malgun Gothic"/>
+              </a:defRPr>
+            </a:lvl5pPr>
+            <a:lvl6pPr algn="r">
+              <a:defRPr sz="1200" b="0">
+                <a:solidFill>
+                  <a:srgbClr val="4D5A68"/>
+                </a:solidFill>
+                <a:latin typeface="Malgun Gothic"/>
+                <a:ea typeface="Malgun Gothic"/>
+                <a:cs typeface="Malgun Gothic"/>
+              </a:defRPr>
+            </a:lvl6pPr>
+            <a:lvl7pPr algn="r">
+              <a:defRPr sz="1200" b="0">
+                <a:solidFill>
+                  <a:srgbClr val="4D5A68"/>
+                </a:solidFill>
+                <a:latin typeface="Malgun Gothic"/>
+                <a:ea typeface="Malgun Gothic"/>
+                <a:cs typeface="Malgun Gothic"/>
+              </a:defRPr>
+            </a:lvl7pPr>
+            <a:lvl8pPr algn="r">
+              <a:defRPr sz="1200" b="0">
+                <a:solidFill>
+                  <a:srgbClr val="4D5A68"/>
+                </a:solidFill>
+                <a:latin typeface="Malgun Gothic"/>
+                <a:ea typeface="Malgun Gothic"/>
+                <a:cs typeface="Malgun Gothic"/>
+              </a:defRPr>
+            </a:lvl8pPr>
+            <a:lvl9pPr algn="r">
+              <a:defRPr sz="1200" b="0">
+                <a:solidFill>
+                  <a:srgbClr val="4D5A68"/>
+                </a:solidFill>
+                <a:latin typeface="Malgun Gothic"/>
+                <a:ea typeface="Malgun Gothic"/>
+                <a:cs typeface="Malgun Gothic"/>
+              </a:defRPr>
+            </a:lvl9pPr>
+          </a:lstStyle>
+          <a:p xmlns:a="http://schemas.openxmlformats.org/drawingml/2006/main">
+            <a:pPr algn="r">
+              <a:defRPr sz="1200" b="0">
+                <a:solidFill>
+                  <a:srgbClr val="4D5A68"/>
+                </a:solidFill>
+                <a:latin typeface="Malgun Gothic"/>
+                <a:ea typeface="Malgun Gothic"/>
+                <a:cs typeface="Malgun Gothic"/>
+              </a:defRPr>
+            </a:pPr>
+            <a:r>
+              <a:rPr sz="1200" b="0">
+                <a:solidFill>
+                  <a:srgbClr val="4D5A68"/>
+                </a:solidFill>
+                <a:latin typeface="Malgun Gothic"/>
+                <a:ea typeface="Malgun Gothic"/>
+                <a:cs typeface="Malgun Gothic"/>
+              </a:rPr>
+              <a:t>M 연계 · M1</a:t>
+            </a:r>
+          </a:p>
+        </p:txBody>
+      </p:sp>
     </p:spTree>
     <p:extLst>
       <p:ext uri="{BB962C8B-B14F-4D97-AF65-F5344CB8AC3E}">
-        <p14:creationId xmlns:p14="http://schemas.microsoft.com/office/powerpoint/2010/main" val="207870649"/>
+        <p14:creationId xmlns:p14="http://schemas.microsoft.com/office/powerpoint/2010/main" val="1084761041"/>
       </p:ext>
     </p:extLst>
   </p:cSld>
@@ -24870,10 +26139,10 @@
       </p:grpSpPr>
       <p:sp>
         <p:nvSpPr>
-          <p:cNvPr id="15" name="ACT 0 · 접근할 정보와 정할 목표">
+          <p:cNvPr id="16" name="ACT 0 · 접근할 정보와 정할 목표">
             <a:extLst xmlns:a="http://schemas.openxmlformats.org/drawingml/2006/main">
               <a:ext uri="{FF2B5EF4-FFF2-40B4-BE49-F238E27FC236}">
-                <a16:creationId xmlns:a16="http://schemas.microsoft.com/office/drawing/2014/main" id="{C9C4537B-ECAF-4578-9049-333165B70239}"/>
+                <a16:creationId xmlns:a16="http://schemas.microsoft.com/office/drawing/2014/main" id="{C3C5F600-962D-400A-A285-C995AF81AC05}"/>
               </a:ext>
             </a:extLst>
           </p:cNvPr>
@@ -25031,7 +26300,7 @@
           <p:cNvPr id="2" name="S08">
             <a:extLst xmlns:a="http://schemas.openxmlformats.org/drawingml/2006/main">
               <a:ext uri="{FF2B5EF4-FFF2-40B4-BE49-F238E27FC236}">
-                <a16:creationId xmlns:a16="http://schemas.microsoft.com/office/drawing/2014/main" id="{5AC85863-87F6-43DB-B923-7CDAB00E5B40}"/>
+                <a16:creationId xmlns:a16="http://schemas.microsoft.com/office/drawing/2014/main" id="{D6F39F33-7BCB-4CC5-AAD8-51DC4B08F0B7}"/>
               </a:ext>
             </a:extLst>
           </p:cNvPr>
@@ -25189,7 +26458,7 @@
           <p:cNvPr id="3" name="Repository 접근과 Task 의도는 별개다">
             <a:extLst xmlns:a="http://schemas.openxmlformats.org/drawingml/2006/main">
               <a:ext uri="{FF2B5EF4-FFF2-40B4-BE49-F238E27FC236}">
-                <a16:creationId xmlns:a16="http://schemas.microsoft.com/office/drawing/2014/main" id="{CC022088-675E-466B-A25D-84B8CD841C7F}"/>
+                <a16:creationId xmlns:a16="http://schemas.microsoft.com/office/drawing/2014/main" id="{4CF63798-6A3B-4B22-B79A-E3C0653E5D0B}"/>
               </a:ext>
             </a:extLst>
           </p:cNvPr>
@@ -25347,7 +26616,7 @@
           <p:cNvPr id="4" name="">
             <a:extLst xmlns:a="http://schemas.openxmlformats.org/drawingml/2006/main">
               <a:ext uri="{FF2B5EF4-FFF2-40B4-BE49-F238E27FC236}">
-                <a16:creationId xmlns:a16="http://schemas.microsoft.com/office/drawing/2014/main" id="{3C4938B8-368A-4828-880A-F1994864E3D6}"/>
+                <a16:creationId xmlns:a16="http://schemas.microsoft.com/office/drawing/2014/main" id="{001E05E4-E855-4894-9086-2589F783C478}"/>
               </a:ext>
             </a:extLst>
           </p:cNvPr>
@@ -25358,7 +26627,7 @@
         </p:nvSpPr>
         <p:spPr>
           <a:xfrm xmlns:a="http://schemas.openxmlformats.org/drawingml/2006/main">
-            <a:off x="609600" y="5829300"/>
+            <a:off x="609600" y="5753100"/>
             <a:ext cx="10972800" cy="0"/>
           </a:xfrm>
           <a:prstGeom xmlns:a="http://schemas.openxmlformats.org/drawingml/2006/main" prst="line">
@@ -25378,7 +26647,7 @@
           <p:cNvPr id="5" name="이 과정의 교육 모델 · Repository 접근과 작업 의도의 관계">
             <a:extLst xmlns:a="http://schemas.openxmlformats.org/drawingml/2006/main">
               <a:ext uri="{FF2B5EF4-FFF2-40B4-BE49-F238E27FC236}">
-                <a16:creationId xmlns:a16="http://schemas.microsoft.com/office/drawing/2014/main" id="{587B8924-B1D1-4ED2-9932-586CAE8F20FE}"/>
+                <a16:creationId xmlns:a16="http://schemas.microsoft.com/office/drawing/2014/main" id="{3E15C6B6-3945-45BC-B80D-5DDC51F4CB7C}"/>
               </a:ext>
             </a:extLst>
           </p:cNvPr>
@@ -25389,8 +26658,8 @@
         </p:nvSpPr>
         <p:spPr>
           <a:xfrm xmlns:a="http://schemas.openxmlformats.org/drawingml/2006/main">
-            <a:off x="609600" y="5915025"/>
-            <a:ext cx="10972800" cy="247650"/>
+            <a:off x="609600" y="5791200"/>
+            <a:ext cx="10972800" cy="228600"/>
           </a:xfrm>
           <a:prstGeom xmlns:a="http://schemas.openxmlformats.org/drawingml/2006/main" prst="rect">
             <a:avLst/>
@@ -25536,7 +26805,7 @@
           <p:cNvPr id="6" name="모든 제품이나 환경의 기능을 설명하는 공식 분류가 아닙니다.">
             <a:extLst xmlns:a="http://schemas.openxmlformats.org/drawingml/2006/main">
               <a:ext uri="{FF2B5EF4-FFF2-40B4-BE49-F238E27FC236}">
-                <a16:creationId xmlns:a16="http://schemas.microsoft.com/office/drawing/2014/main" id="{17C7B65A-19AE-4436-BC89-2CC4A7A9961E}"/>
+                <a16:creationId xmlns:a16="http://schemas.microsoft.com/office/drawing/2014/main" id="{2BBDA07F-BD3C-471A-92F1-0810978B86DE}"/>
               </a:ext>
             </a:extLst>
           </p:cNvPr>
@@ -25547,7 +26816,7 @@
         </p:nvSpPr>
         <p:spPr>
           <a:xfrm xmlns:a="http://schemas.openxmlformats.org/drawingml/2006/main">
-            <a:off x="609600" y="6191250"/>
+            <a:off x="609600" y="6019800"/>
             <a:ext cx="10972800" cy="209550"/>
           </a:xfrm>
           <a:prstGeom xmlns:a="http://schemas.openxmlformats.org/drawingml/2006/main" prst="rect">
@@ -25694,7 +26963,7 @@
           <p:cNvPr id="7" name="볼 수 있는 것">
             <a:extLst xmlns:a="http://schemas.openxmlformats.org/drawingml/2006/main">
               <a:ext uri="{FF2B5EF4-FFF2-40B4-BE49-F238E27FC236}">
-                <a16:creationId xmlns:a16="http://schemas.microsoft.com/office/drawing/2014/main" id="{70D2132F-1245-4AFB-B6ED-20C7843DC60C}"/>
+                <a16:creationId xmlns:a16="http://schemas.microsoft.com/office/drawing/2014/main" id="{EF5D98F0-86AE-4617-B3AD-A086E1C64734}"/>
               </a:ext>
             </a:extLst>
           </p:cNvPr>
@@ -25852,7 +27121,7 @@
           <p:cNvPr id="8" name="정해야 하는 것">
             <a:extLst xmlns:a="http://schemas.openxmlformats.org/drawingml/2006/main">
               <a:ext uri="{FF2B5EF4-FFF2-40B4-BE49-F238E27FC236}">
-                <a16:creationId xmlns:a16="http://schemas.microsoft.com/office/drawing/2014/main" id="{8AA56CE4-62A4-4FC1-9872-FC8A1AAAACEB}"/>
+                <a16:creationId xmlns:a16="http://schemas.microsoft.com/office/drawing/2014/main" id="{73362E6D-C34F-40B9-B5C2-A25BCE59E15C}"/>
               </a:ext>
             </a:extLst>
           </p:cNvPr>
@@ -26010,7 +27279,7 @@
           <p:cNvPr id="9" name="">
             <a:extLst xmlns:a="http://schemas.openxmlformats.org/drawingml/2006/main">
               <a:ext uri="{FF2B5EF4-FFF2-40B4-BE49-F238E27FC236}">
-                <a16:creationId xmlns:a16="http://schemas.microsoft.com/office/drawing/2014/main" id="{2303AF2A-5314-4905-883A-9A3C566C5E0A}"/>
+                <a16:creationId xmlns:a16="http://schemas.microsoft.com/office/drawing/2014/main" id="{FDB3DB39-82B0-42BA-BA6C-5B08EFE951B1}"/>
               </a:ext>
             </a:extLst>
           </p:cNvPr>
@@ -26041,7 +27310,7 @@
           <p:cNvPr id="10" name="">
             <a:extLst xmlns:a="http://schemas.openxmlformats.org/drawingml/2006/main">
               <a:ext uri="{FF2B5EF4-FFF2-40B4-BE49-F238E27FC236}">
-                <a16:creationId xmlns:a16="http://schemas.microsoft.com/office/drawing/2014/main" id="{E59E61ED-9252-4254-ADF0-01C135A7AAB4}"/>
+                <a16:creationId xmlns:a16="http://schemas.microsoft.com/office/drawing/2014/main" id="{FA8E3A8D-3EBB-41E2-8FD3-4C28222E61D2}"/>
               </a:ext>
             </a:extLst>
           </p:cNvPr>
@@ -26072,7 +27341,7 @@
           <p:cNvPr id="11" name="파일&#10;구현&#10;테스트">
             <a:extLst xmlns:a="http://schemas.openxmlformats.org/drawingml/2006/main">
               <a:ext uri="{FF2B5EF4-FFF2-40B4-BE49-F238E27FC236}">
-                <a16:creationId xmlns:a16="http://schemas.microsoft.com/office/drawing/2014/main" id="{6FA08858-F1F1-4096-993C-F352E87D0491}"/>
+                <a16:creationId xmlns:a16="http://schemas.microsoft.com/office/drawing/2014/main" id="{87794A5B-7582-46E0-89B7-6717E8FD0A11}"/>
               </a:ext>
             </a:extLst>
           </p:cNvPr>
@@ -26276,7 +27545,7 @@
           <p:cNvPr id="12" name="원하는 변화&#10;허용할 범위&#10;완료 판단">
             <a:extLst xmlns:a="http://schemas.openxmlformats.org/drawingml/2006/main">
               <a:ext uri="{FF2B5EF4-FFF2-40B4-BE49-F238E27FC236}">
-                <a16:creationId xmlns:a16="http://schemas.microsoft.com/office/drawing/2014/main" id="{890AA244-3627-44F2-ACCB-E6BF94F02389}"/>
+                <a16:creationId xmlns:a16="http://schemas.microsoft.com/office/drawing/2014/main" id="{65FC7C99-AC75-48F2-A214-B26A52771C7D}"/>
               </a:ext>
             </a:extLst>
           </p:cNvPr>
@@ -26480,7 +27749,7 @@
           <p:cNvPr id="13" name="≠">
             <a:extLst xmlns:a="http://schemas.openxmlformats.org/drawingml/2006/main">
               <a:ext uri="{FF2B5EF4-FFF2-40B4-BE49-F238E27FC236}">
-                <a16:creationId xmlns:a16="http://schemas.microsoft.com/office/drawing/2014/main" id="{F4BF25FF-87B8-43F6-95FE-E62E806B2383}"/>
+                <a16:creationId xmlns:a16="http://schemas.microsoft.com/office/drawing/2014/main" id="{4FF2C88A-2459-44DC-9A27-FD15AEAECCAD}"/>
               </a:ext>
             </a:extLst>
           </p:cNvPr>
@@ -26638,7 +27907,7 @@
           <p:cNvPr id="14" name="코드가 보여도, 원하는 일은 따로 전달해야 한다.">
             <a:extLst xmlns:a="http://schemas.openxmlformats.org/drawingml/2006/main">
               <a:ext uri="{FF2B5EF4-FFF2-40B4-BE49-F238E27FC236}">
-                <a16:creationId xmlns:a16="http://schemas.microsoft.com/office/drawing/2014/main" id="{8FB69391-44B2-4F42-8C17-8A800E77C195}"/>
+                <a16:creationId xmlns:a16="http://schemas.microsoft.com/office/drawing/2014/main" id="{48390CEA-10C4-44F6-A157-3D4CECB3E2DC}"/>
               </a:ext>
             </a:extLst>
           </p:cNvPr>
@@ -26791,10 +28060,168 @@
           </a:p>
         </p:txBody>
       </p:sp>
+      <p:sp>
+        <p:nvSpPr>
+          <p:cNvPr id="15" name="Legacy module connection">
+            <a:extLst xmlns:a="http://schemas.openxmlformats.org/drawingml/2006/main">
+              <a:ext uri="{FF2B5EF4-FFF2-40B4-BE49-F238E27FC236}">
+                <a16:creationId xmlns:a16="http://schemas.microsoft.com/office/drawing/2014/main" id="{BC789C25-541B-416C-A0B7-6A40F4C1AD27}"/>
+              </a:ext>
+            </a:extLst>
+          </p:cNvPr>
+          <p:cNvSpPr>
+            <a:spLocks xmlns:a="http://schemas.openxmlformats.org/drawingml/2006/main" noGrp="1"/>
+          </p:cNvSpPr>
+          <p:nvPr/>
+        </p:nvSpPr>
+        <p:spPr>
+          <a:xfrm xmlns:a="http://schemas.openxmlformats.org/drawingml/2006/main">
+            <a:off x="609600" y="6229350"/>
+            <a:ext cx="10972800" cy="171450"/>
+          </a:xfrm>
+          <a:prstGeom xmlns:a="http://schemas.openxmlformats.org/drawingml/2006/main" prst="rect">
+            <a:avLst/>
+          </a:prstGeom>
+          <a:noFill xmlns:a="http://schemas.openxmlformats.org/drawingml/2006/main"/>
+          <a:ln xmlns:a="http://schemas.openxmlformats.org/drawingml/2006/main" w="0">
+            <a:noFill/>
+          </a:ln>
+        </p:spPr>
+        <p:txBody>
+          <a:bodyPr xmlns:a="http://schemas.openxmlformats.org/drawingml/2006/main" wrap="none" lIns="0" tIns="0" rIns="0" bIns="0" anchor="ctr">
+            <a:noAutofit/>
+          </a:bodyPr>
+          <a:lstStyle xmlns:a="http://schemas.openxmlformats.org/drawingml/2006/main">
+            <a:defPPr algn="r">
+              <a:defRPr sz="1200" b="0">
+                <a:solidFill>
+                  <a:srgbClr val="4D5A68"/>
+                </a:solidFill>
+                <a:latin typeface="Malgun Gothic"/>
+                <a:ea typeface="Malgun Gothic"/>
+                <a:cs typeface="Malgun Gothic"/>
+              </a:defRPr>
+            </a:defPPr>
+            <a:lvl1pPr algn="r">
+              <a:defRPr sz="1200" b="0">
+                <a:solidFill>
+                  <a:srgbClr val="4D5A68"/>
+                </a:solidFill>
+                <a:latin typeface="Malgun Gothic"/>
+                <a:ea typeface="Malgun Gothic"/>
+                <a:cs typeface="Malgun Gothic"/>
+              </a:defRPr>
+            </a:lvl1pPr>
+            <a:lvl2pPr algn="r">
+              <a:defRPr sz="1200" b="0">
+                <a:solidFill>
+                  <a:srgbClr val="4D5A68"/>
+                </a:solidFill>
+                <a:latin typeface="Malgun Gothic"/>
+                <a:ea typeface="Malgun Gothic"/>
+                <a:cs typeface="Malgun Gothic"/>
+              </a:defRPr>
+            </a:lvl2pPr>
+            <a:lvl3pPr algn="r">
+              <a:defRPr sz="1200" b="0">
+                <a:solidFill>
+                  <a:srgbClr val="4D5A68"/>
+                </a:solidFill>
+                <a:latin typeface="Malgun Gothic"/>
+                <a:ea typeface="Malgun Gothic"/>
+                <a:cs typeface="Malgun Gothic"/>
+              </a:defRPr>
+            </a:lvl3pPr>
+            <a:lvl4pPr algn="r">
+              <a:defRPr sz="1200" b="0">
+                <a:solidFill>
+                  <a:srgbClr val="4D5A68"/>
+                </a:solidFill>
+                <a:latin typeface="Malgun Gothic"/>
+                <a:ea typeface="Malgun Gothic"/>
+                <a:cs typeface="Malgun Gothic"/>
+              </a:defRPr>
+            </a:lvl4pPr>
+            <a:lvl5pPr algn="r">
+              <a:defRPr sz="1200" b="0">
+                <a:solidFill>
+                  <a:srgbClr val="4D5A68"/>
+                </a:solidFill>
+                <a:latin typeface="Malgun Gothic"/>
+                <a:ea typeface="Malgun Gothic"/>
+                <a:cs typeface="Malgun Gothic"/>
+              </a:defRPr>
+            </a:lvl5pPr>
+            <a:lvl6pPr algn="r">
+              <a:defRPr sz="1200" b="0">
+                <a:solidFill>
+                  <a:srgbClr val="4D5A68"/>
+                </a:solidFill>
+                <a:latin typeface="Malgun Gothic"/>
+                <a:ea typeface="Malgun Gothic"/>
+                <a:cs typeface="Malgun Gothic"/>
+              </a:defRPr>
+            </a:lvl6pPr>
+            <a:lvl7pPr algn="r">
+              <a:defRPr sz="1200" b="0">
+                <a:solidFill>
+                  <a:srgbClr val="4D5A68"/>
+                </a:solidFill>
+                <a:latin typeface="Malgun Gothic"/>
+                <a:ea typeface="Malgun Gothic"/>
+                <a:cs typeface="Malgun Gothic"/>
+              </a:defRPr>
+            </a:lvl7pPr>
+            <a:lvl8pPr algn="r">
+              <a:defRPr sz="1200" b="0">
+                <a:solidFill>
+                  <a:srgbClr val="4D5A68"/>
+                </a:solidFill>
+                <a:latin typeface="Malgun Gothic"/>
+                <a:ea typeface="Malgun Gothic"/>
+                <a:cs typeface="Malgun Gothic"/>
+              </a:defRPr>
+            </a:lvl8pPr>
+            <a:lvl9pPr algn="r">
+              <a:defRPr sz="1200" b="0">
+                <a:solidFill>
+                  <a:srgbClr val="4D5A68"/>
+                </a:solidFill>
+                <a:latin typeface="Malgun Gothic"/>
+                <a:ea typeface="Malgun Gothic"/>
+                <a:cs typeface="Malgun Gothic"/>
+              </a:defRPr>
+            </a:lvl9pPr>
+          </a:lstStyle>
+          <a:p xmlns:a="http://schemas.openxmlformats.org/drawingml/2006/main">
+            <a:pPr algn="r">
+              <a:defRPr sz="1200" b="0">
+                <a:solidFill>
+                  <a:srgbClr val="4D5A68"/>
+                </a:solidFill>
+                <a:latin typeface="Malgun Gothic"/>
+                <a:ea typeface="Malgun Gothic"/>
+                <a:cs typeface="Malgun Gothic"/>
+              </a:defRPr>
+            </a:pPr>
+            <a:r>
+              <a:rPr sz="1200" b="0">
+                <a:solidFill>
+                  <a:srgbClr val="4D5A68"/>
+                </a:solidFill>
+                <a:latin typeface="Malgun Gothic"/>
+                <a:ea typeface="Malgun Gothic"/>
+                <a:cs typeface="Malgun Gothic"/>
+              </a:rPr>
+              <a:t>M 연계 · M1 · M2</a:t>
+            </a:r>
+          </a:p>
+        </p:txBody>
+      </p:sp>
     </p:spTree>
     <p:extLst>
       <p:ext uri="{BB962C8B-B14F-4D97-AF65-F5344CB8AC3E}">
-        <p14:creationId xmlns:p14="http://schemas.microsoft.com/office/powerpoint/2010/main" val="1841214156"/>
+        <p14:creationId xmlns:p14="http://schemas.microsoft.com/office/powerpoint/2010/main" val="2003669124"/>
       </p:ext>
     </p:extLst>
   </p:cSld>
@@ -26822,10 +28249,10 @@
       </p:grpSpPr>
       <p:sp>
         <p:nvSpPr>
-          <p:cNvPr id="11" name="ACT 0 · 내 작업에 적용할 질문">
+          <p:cNvPr id="12" name="ACT 0 · 내 작업에 적용할 질문">
             <a:extLst xmlns:a="http://schemas.openxmlformats.org/drawingml/2006/main">
               <a:ext uri="{FF2B5EF4-FFF2-40B4-BE49-F238E27FC236}">
-                <a16:creationId xmlns:a16="http://schemas.microsoft.com/office/drawing/2014/main" id="{FABC6482-F3BB-487D-BF50-7174F7FC097E}"/>
+                <a16:creationId xmlns:a16="http://schemas.microsoft.com/office/drawing/2014/main" id="{545FAA95-6DC7-4296-BFA5-CA892D601F21}"/>
               </a:ext>
             </a:extLst>
           </p:cNvPr>
@@ -26983,7 +28410,7 @@
           <p:cNvPr id="2" name="S09">
             <a:extLst xmlns:a="http://schemas.openxmlformats.org/drawingml/2006/main">
               <a:ext uri="{FF2B5EF4-FFF2-40B4-BE49-F238E27FC236}">
-                <a16:creationId xmlns:a16="http://schemas.microsoft.com/office/drawing/2014/main" id="{4C75E311-3CF2-40BA-8E04-CB7E68E987C6}"/>
+                <a16:creationId xmlns:a16="http://schemas.microsoft.com/office/drawing/2014/main" id="{266C4A78-D914-4833-8100-BA1D685360ED}"/>
               </a:ext>
             </a:extLst>
           </p:cNvPr>
@@ -27141,7 +28568,7 @@
           <p:cNvPr id="3" name="Repository를 보면 내가 원하는 것까지 알까?">
             <a:extLst xmlns:a="http://schemas.openxmlformats.org/drawingml/2006/main">
               <a:ext uri="{FF2B5EF4-FFF2-40B4-BE49-F238E27FC236}">
-                <a16:creationId xmlns:a16="http://schemas.microsoft.com/office/drawing/2014/main" id="{38D2DC58-FABD-446C-9614-07FA30485C28}"/>
+                <a16:creationId xmlns:a16="http://schemas.microsoft.com/office/drawing/2014/main" id="{48CFF8B9-FA11-4C94-98EF-B3947B5E3FE9}"/>
               </a:ext>
             </a:extLst>
           </p:cNvPr>
@@ -27299,7 +28726,7 @@
           <p:cNvPr id="4" name="">
             <a:extLst xmlns:a="http://schemas.openxmlformats.org/drawingml/2006/main">
               <a:ext uri="{FF2B5EF4-FFF2-40B4-BE49-F238E27FC236}">
-                <a16:creationId xmlns:a16="http://schemas.microsoft.com/office/drawing/2014/main" id="{09FE15A7-CE3B-4BAF-9EF5-0EC561E75EAE}"/>
+                <a16:creationId xmlns:a16="http://schemas.microsoft.com/office/drawing/2014/main" id="{13781463-00FA-43C9-A85E-8351594CE687}"/>
               </a:ext>
             </a:extLst>
           </p:cNvPr>
@@ -27310,7 +28737,7 @@
         </p:nvSpPr>
         <p:spPr>
           <a:xfrm xmlns:a="http://schemas.openxmlformats.org/drawingml/2006/main">
-            <a:off x="609600" y="5829300"/>
+            <a:off x="609600" y="5753100"/>
             <a:ext cx="10972800" cy="0"/>
           </a:xfrm>
           <a:prstGeom xmlns:a="http://schemas.openxmlformats.org/drawingml/2006/main" prst="line">
@@ -27330,7 +28757,7 @@
           <p:cNvPr id="5" name="함께 생각해 보기 · 교육 모델">
             <a:extLst xmlns:a="http://schemas.openxmlformats.org/drawingml/2006/main">
               <a:ext uri="{FF2B5EF4-FFF2-40B4-BE49-F238E27FC236}">
-                <a16:creationId xmlns:a16="http://schemas.microsoft.com/office/drawing/2014/main" id="{4CD10FA1-2CFB-44F6-94AB-7CC57EC46791}"/>
+                <a16:creationId xmlns:a16="http://schemas.microsoft.com/office/drawing/2014/main" id="{E82DD95C-9385-4EB0-A651-42434C312521}"/>
               </a:ext>
             </a:extLst>
           </p:cNvPr>
@@ -27341,8 +28768,8 @@
         </p:nvSpPr>
         <p:spPr>
           <a:xfrm xmlns:a="http://schemas.openxmlformats.org/drawingml/2006/main">
-            <a:off x="609600" y="5915025"/>
-            <a:ext cx="10972800" cy="247650"/>
+            <a:off x="609600" y="5791200"/>
+            <a:ext cx="10972800" cy="228600"/>
           </a:xfrm>
           <a:prstGeom xmlns:a="http://schemas.openxmlformats.org/drawingml/2006/main" prst="rect">
             <a:avLst/>
@@ -27488,7 +28915,7 @@
           <p:cNvPr id="6" name="현재 맡기고 싶은 일을 떠올려 보세요. 질문과 경험 공유는 자발적으로 진행합니다.">
             <a:extLst xmlns:a="http://schemas.openxmlformats.org/drawingml/2006/main">
               <a:ext uri="{FF2B5EF4-FFF2-40B4-BE49-F238E27FC236}">
-                <a16:creationId xmlns:a16="http://schemas.microsoft.com/office/drawing/2014/main" id="{F2222AE9-76F0-4788-99D5-70C2653223D5}"/>
+                <a16:creationId xmlns:a16="http://schemas.microsoft.com/office/drawing/2014/main" id="{7157A8E5-37DD-444E-8C5F-025B8E1A7F13}"/>
               </a:ext>
             </a:extLst>
           </p:cNvPr>
@@ -27499,7 +28926,7 @@
         </p:nvSpPr>
         <p:spPr>
           <a:xfrm xmlns:a="http://schemas.openxmlformats.org/drawingml/2006/main">
-            <a:off x="609600" y="6191250"/>
+            <a:off x="609600" y="6019800"/>
             <a:ext cx="10972800" cy="209550"/>
           </a:xfrm>
           <a:prstGeom xmlns:a="http://schemas.openxmlformats.org/drawingml/2006/main" prst="rect">
@@ -27646,7 +29073,7 @@
           <p:cNvPr id="7" name="지금 이 저장소에&#10;어떤 일을 맡기고 싶으신가요?">
             <a:extLst xmlns:a="http://schemas.openxmlformats.org/drawingml/2006/main">
               <a:ext uri="{FF2B5EF4-FFF2-40B4-BE49-F238E27FC236}">
-                <a16:creationId xmlns:a16="http://schemas.microsoft.com/office/drawing/2014/main" id="{5AA74C95-A44F-4E49-AADE-27EA3BD49655}"/>
+                <a16:creationId xmlns:a16="http://schemas.microsoft.com/office/drawing/2014/main" id="{4D6FFDC8-E637-4FB0-849E-1CED67F81FED}"/>
               </a:ext>
             </a:extLst>
           </p:cNvPr>
@@ -27827,7 +29254,7 @@
           <p:cNvPr id="8" name="?">
             <a:extLst xmlns:a="http://schemas.openxmlformats.org/drawingml/2006/main">
               <a:ext uri="{FF2B5EF4-FFF2-40B4-BE49-F238E27FC236}">
-                <a16:creationId xmlns:a16="http://schemas.microsoft.com/office/drawing/2014/main" id="{F303C102-F5CC-4092-A2C7-FAA9FF715593}"/>
+                <a16:creationId xmlns:a16="http://schemas.microsoft.com/office/drawing/2014/main" id="{72776F5E-CA2E-4090-9595-BE007046E4E8}"/>
               </a:ext>
             </a:extLst>
           </p:cNvPr>
@@ -27985,7 +29412,7 @@
           <p:cNvPr id="9" name="">
             <a:extLst xmlns:a="http://schemas.openxmlformats.org/drawingml/2006/main">
               <a:ext uri="{FF2B5EF4-FFF2-40B4-BE49-F238E27FC236}">
-                <a16:creationId xmlns:a16="http://schemas.microsoft.com/office/drawing/2014/main" id="{134F206F-7311-4FF5-9813-8E4F5B956915}"/>
+                <a16:creationId xmlns:a16="http://schemas.microsoft.com/office/drawing/2014/main" id="{1393A6A6-E3CF-4660-875B-7BB51AF7C367}"/>
               </a:ext>
             </a:extLst>
           </p:cNvPr>
@@ -28016,7 +29443,7 @@
           <p:cNvPr id="10" name="그 원하는 결과까지&#10;코드에 적혀 있을까요?">
             <a:extLst xmlns:a="http://schemas.openxmlformats.org/drawingml/2006/main">
               <a:ext uri="{FF2B5EF4-FFF2-40B4-BE49-F238E27FC236}">
-                <a16:creationId xmlns:a16="http://schemas.microsoft.com/office/drawing/2014/main" id="{8FC2890A-09E2-45F8-B4C6-8B1B3F587F02}"/>
+                <a16:creationId xmlns:a16="http://schemas.microsoft.com/office/drawing/2014/main" id="{96EA1588-2553-449B-B9D2-29ADA07869F7}"/>
               </a:ext>
             </a:extLst>
           </p:cNvPr>
@@ -28192,10 +29619,168 @@
           </a:p>
         </p:txBody>
       </p:sp>
+      <p:sp>
+        <p:nvSpPr>
+          <p:cNvPr id="11" name="Legacy module connection">
+            <a:extLst xmlns:a="http://schemas.openxmlformats.org/drawingml/2006/main">
+              <a:ext uri="{FF2B5EF4-FFF2-40B4-BE49-F238E27FC236}">
+                <a16:creationId xmlns:a16="http://schemas.microsoft.com/office/drawing/2014/main" id="{07A842BA-E007-4F94-B981-ED610D8C8659}"/>
+              </a:ext>
+            </a:extLst>
+          </p:cNvPr>
+          <p:cNvSpPr>
+            <a:spLocks xmlns:a="http://schemas.openxmlformats.org/drawingml/2006/main" noGrp="1"/>
+          </p:cNvSpPr>
+          <p:nvPr/>
+        </p:nvSpPr>
+        <p:spPr>
+          <a:xfrm xmlns:a="http://schemas.openxmlformats.org/drawingml/2006/main">
+            <a:off x="609600" y="6229350"/>
+            <a:ext cx="10972800" cy="171450"/>
+          </a:xfrm>
+          <a:prstGeom xmlns:a="http://schemas.openxmlformats.org/drawingml/2006/main" prst="rect">
+            <a:avLst/>
+          </a:prstGeom>
+          <a:noFill xmlns:a="http://schemas.openxmlformats.org/drawingml/2006/main"/>
+          <a:ln xmlns:a="http://schemas.openxmlformats.org/drawingml/2006/main" w="0">
+            <a:noFill/>
+          </a:ln>
+        </p:spPr>
+        <p:txBody>
+          <a:bodyPr xmlns:a="http://schemas.openxmlformats.org/drawingml/2006/main" wrap="none" lIns="0" tIns="0" rIns="0" bIns="0" anchor="ctr">
+            <a:noAutofit/>
+          </a:bodyPr>
+          <a:lstStyle xmlns:a="http://schemas.openxmlformats.org/drawingml/2006/main">
+            <a:defPPr algn="r">
+              <a:defRPr sz="1200" b="0">
+                <a:solidFill>
+                  <a:srgbClr val="4D5A68"/>
+                </a:solidFill>
+                <a:latin typeface="Malgun Gothic"/>
+                <a:ea typeface="Malgun Gothic"/>
+                <a:cs typeface="Malgun Gothic"/>
+              </a:defRPr>
+            </a:defPPr>
+            <a:lvl1pPr algn="r">
+              <a:defRPr sz="1200" b="0">
+                <a:solidFill>
+                  <a:srgbClr val="4D5A68"/>
+                </a:solidFill>
+                <a:latin typeface="Malgun Gothic"/>
+                <a:ea typeface="Malgun Gothic"/>
+                <a:cs typeface="Malgun Gothic"/>
+              </a:defRPr>
+            </a:lvl1pPr>
+            <a:lvl2pPr algn="r">
+              <a:defRPr sz="1200" b="0">
+                <a:solidFill>
+                  <a:srgbClr val="4D5A68"/>
+                </a:solidFill>
+                <a:latin typeface="Malgun Gothic"/>
+                <a:ea typeface="Malgun Gothic"/>
+                <a:cs typeface="Malgun Gothic"/>
+              </a:defRPr>
+            </a:lvl2pPr>
+            <a:lvl3pPr algn="r">
+              <a:defRPr sz="1200" b="0">
+                <a:solidFill>
+                  <a:srgbClr val="4D5A68"/>
+                </a:solidFill>
+                <a:latin typeface="Malgun Gothic"/>
+                <a:ea typeface="Malgun Gothic"/>
+                <a:cs typeface="Malgun Gothic"/>
+              </a:defRPr>
+            </a:lvl3pPr>
+            <a:lvl4pPr algn="r">
+              <a:defRPr sz="1200" b="0">
+                <a:solidFill>
+                  <a:srgbClr val="4D5A68"/>
+                </a:solidFill>
+                <a:latin typeface="Malgun Gothic"/>
+                <a:ea typeface="Malgun Gothic"/>
+                <a:cs typeface="Malgun Gothic"/>
+              </a:defRPr>
+            </a:lvl4pPr>
+            <a:lvl5pPr algn="r">
+              <a:defRPr sz="1200" b="0">
+                <a:solidFill>
+                  <a:srgbClr val="4D5A68"/>
+                </a:solidFill>
+                <a:latin typeface="Malgun Gothic"/>
+                <a:ea typeface="Malgun Gothic"/>
+                <a:cs typeface="Malgun Gothic"/>
+              </a:defRPr>
+            </a:lvl5pPr>
+            <a:lvl6pPr algn="r">
+              <a:defRPr sz="1200" b="0">
+                <a:solidFill>
+                  <a:srgbClr val="4D5A68"/>
+                </a:solidFill>
+                <a:latin typeface="Malgun Gothic"/>
+                <a:ea typeface="Malgun Gothic"/>
+                <a:cs typeface="Malgun Gothic"/>
+              </a:defRPr>
+            </a:lvl6pPr>
+            <a:lvl7pPr algn="r">
+              <a:defRPr sz="1200" b="0">
+                <a:solidFill>
+                  <a:srgbClr val="4D5A68"/>
+                </a:solidFill>
+                <a:latin typeface="Malgun Gothic"/>
+                <a:ea typeface="Malgun Gothic"/>
+                <a:cs typeface="Malgun Gothic"/>
+              </a:defRPr>
+            </a:lvl7pPr>
+            <a:lvl8pPr algn="r">
+              <a:defRPr sz="1200" b="0">
+                <a:solidFill>
+                  <a:srgbClr val="4D5A68"/>
+                </a:solidFill>
+                <a:latin typeface="Malgun Gothic"/>
+                <a:ea typeface="Malgun Gothic"/>
+                <a:cs typeface="Malgun Gothic"/>
+              </a:defRPr>
+            </a:lvl8pPr>
+            <a:lvl9pPr algn="r">
+              <a:defRPr sz="1200" b="0">
+                <a:solidFill>
+                  <a:srgbClr val="4D5A68"/>
+                </a:solidFill>
+                <a:latin typeface="Malgun Gothic"/>
+                <a:ea typeface="Malgun Gothic"/>
+                <a:cs typeface="Malgun Gothic"/>
+              </a:defRPr>
+            </a:lvl9pPr>
+          </a:lstStyle>
+          <a:p xmlns:a="http://schemas.openxmlformats.org/drawingml/2006/main">
+            <a:pPr algn="r">
+              <a:defRPr sz="1200" b="0">
+                <a:solidFill>
+                  <a:srgbClr val="4D5A68"/>
+                </a:solidFill>
+                <a:latin typeface="Malgun Gothic"/>
+                <a:ea typeface="Malgun Gothic"/>
+                <a:cs typeface="Malgun Gothic"/>
+              </a:defRPr>
+            </a:pPr>
+            <a:r>
+              <a:rPr sz="1200" b="0">
+                <a:solidFill>
+                  <a:srgbClr val="4D5A68"/>
+                </a:solidFill>
+                <a:latin typeface="Malgun Gothic"/>
+                <a:ea typeface="Malgun Gothic"/>
+                <a:cs typeface="Malgun Gothic"/>
+              </a:rPr>
+              <a:t>M 연계 · M1 · M2</a:t>
+            </a:r>
+          </a:p>
+        </p:txBody>
+      </p:sp>
     </p:spTree>
     <p:extLst>
       <p:ext uri="{BB962C8B-B14F-4D97-AF65-F5344CB8AC3E}">
-        <p14:creationId xmlns:p14="http://schemas.microsoft.com/office/powerpoint/2010/main" val="1344863587"/>
+        <p14:creationId xmlns:p14="http://schemas.microsoft.com/office/powerpoint/2010/main" val="2103535252"/>
       </p:ext>
     </p:extLst>
   </p:cSld>

</xml_diff>

<commit_message>
feat(slides): show prompt ambiguity through alternate timelines
Make underspecified requests concrete with prompt inputs and one agent.
Add a scoped-request example and migrate downstream slide references.
Preserve the six-hour schedule and separate teaching visuals from
observed trials and measured resource claims.
</commit_message>
<xml_diff>
--- a/production/ACT_0.pptx
+++ b/production/ACT_0.pptx
@@ -2,22 +2,22 @@
 <file path=ppt/presentation.xml><?xml version="1.0" encoding="utf-8"?>
 <p:presentation xmlns:p="http://schemas.openxmlformats.org/presentationml/2006/main">
   <p:sldMasterIdLst>
-    <p:sldMasterId xmlns:r="http://schemas.openxmlformats.org/officeDocument/2006/relationships" id="2147483648" r:id="Rd21c0e335b05427d"/>
+    <p:sldMasterId xmlns:r="http://schemas.openxmlformats.org/officeDocument/2006/relationships" id="2147483648" r:id="R7b503061bad14a9a"/>
   </p:sldMasterIdLst>
   <p:notesMasterIdLst>
-    <p:notesMasterId xmlns:r="http://schemas.openxmlformats.org/officeDocument/2006/relationships" r:id="R212af61a6c534ba5"/>
+    <p:notesMasterId xmlns:r="http://schemas.openxmlformats.org/officeDocument/2006/relationships" r:id="Rbf632ae761ac46b7"/>
   </p:notesMasterIdLst>
   <p:sldIdLst>
-    <p:sldId xmlns:r="http://schemas.openxmlformats.org/officeDocument/2006/relationships" id="256" r:id="R9dcc8b90814f45f6"/>
-    <p:sldId xmlns:r="http://schemas.openxmlformats.org/officeDocument/2006/relationships" id="257" r:id="R0c3dc8b9838b4bcb"/>
-    <p:sldId xmlns:r="http://schemas.openxmlformats.org/officeDocument/2006/relationships" id="258" r:id="R0dd6bea19eff4160"/>
-    <p:sldId xmlns:r="http://schemas.openxmlformats.org/officeDocument/2006/relationships" id="259" r:id="Rff13f22c6170482e"/>
-    <p:sldId xmlns:r="http://schemas.openxmlformats.org/officeDocument/2006/relationships" id="260" r:id="R64fa2bdef36d4ecc"/>
-    <p:sldId xmlns:r="http://schemas.openxmlformats.org/officeDocument/2006/relationships" id="261" r:id="R47a09a89c4bd4e66"/>
-    <p:sldId xmlns:r="http://schemas.openxmlformats.org/officeDocument/2006/relationships" id="262" r:id="R91a6163563ce4339"/>
-    <p:sldId xmlns:r="http://schemas.openxmlformats.org/officeDocument/2006/relationships" id="263" r:id="R488156db55fd4180"/>
-    <p:sldId xmlns:r="http://schemas.openxmlformats.org/officeDocument/2006/relationships" id="264" r:id="R470c8e76a56d4414"/>
-    <p:sldId xmlns:r="http://schemas.openxmlformats.org/officeDocument/2006/relationships" id="265" r:id="R082c427b9c1b49f7"/>
+    <p:sldId xmlns:r="http://schemas.openxmlformats.org/officeDocument/2006/relationships" id="256" r:id="Rb413ea074c654570"/>
+    <p:sldId xmlns:r="http://schemas.openxmlformats.org/officeDocument/2006/relationships" id="257" r:id="Ree6a9ef2e68645ef"/>
+    <p:sldId xmlns:r="http://schemas.openxmlformats.org/officeDocument/2006/relationships" id="258" r:id="R4e8a267d045740d2"/>
+    <p:sldId xmlns:r="http://schemas.openxmlformats.org/officeDocument/2006/relationships" id="259" r:id="R922ec6cfa5174481"/>
+    <p:sldId xmlns:r="http://schemas.openxmlformats.org/officeDocument/2006/relationships" id="260" r:id="Red4b09779a114552"/>
+    <p:sldId xmlns:r="http://schemas.openxmlformats.org/officeDocument/2006/relationships" id="261" r:id="Rb9fa55a59dfd431e"/>
+    <p:sldId xmlns:r="http://schemas.openxmlformats.org/officeDocument/2006/relationships" id="262" r:id="R02ee9a3428284af7"/>
+    <p:sldId xmlns:r="http://schemas.openxmlformats.org/officeDocument/2006/relationships" id="263" r:id="Rd14f07b7acca46a9"/>
+    <p:sldId xmlns:r="http://schemas.openxmlformats.org/officeDocument/2006/relationships" id="264" r:id="R198007770edf4695"/>
+    <p:sldId xmlns:r="http://schemas.openxmlformats.org/officeDocument/2006/relationships" id="265" r:id="R8855662ab81a4ca4"/>
   </p:sldIdLst>
   <p:sldSz cx="12192000" cy="6858000"/>
   <p:notesSz cx="6858000" cy="9144000"/>
@@ -3348,7 +3348,7 @@
           <p:cNvPr id="3" name="Title">
             <a:extLst xmlns:a="http://schemas.openxmlformats.org/drawingml/2006/main">
               <a:ext uri="{FF2B5EF4-FFF2-40B4-BE49-F238E27FC236}">
-                <a16:creationId xmlns:a16="http://schemas.microsoft.com/office/drawing/2014/main" id="{BB12AAE9-4F03-4A3F-948F-00455E9A267E}"/>
+                <a16:creationId xmlns:a16="http://schemas.microsoft.com/office/drawing/2014/main" id="{A87967E9-CE00-4F13-8074-A8B4DA63D6DE}"/>
               </a:ext>
             </a:extLst>
           </p:cNvPr>
@@ -3577,7 +3577,7 @@
           <p:cNvPr id="2" name="Subtitle">
             <a:extLst xmlns:a="http://schemas.openxmlformats.org/drawingml/2006/main">
               <a:ext uri="{FF2B5EF4-FFF2-40B4-BE49-F238E27FC236}">
-                <a16:creationId xmlns:a16="http://schemas.microsoft.com/office/drawing/2014/main" id="{56818308-4910-47B1-BCD1-0301CF024674}"/>
+                <a16:creationId xmlns:a16="http://schemas.microsoft.com/office/drawing/2014/main" id="{D2D3805D-8F16-4D5A-A016-87885B939255}"/>
               </a:ext>
             </a:extLst>
           </p:cNvPr>
@@ -3823,7 +3823,7 @@
           <p:cNvPr id="2" name="Section title">
             <a:extLst xmlns:a="http://schemas.openxmlformats.org/drawingml/2006/main">
               <a:ext uri="{FF2B5EF4-FFF2-40B4-BE49-F238E27FC236}">
-                <a16:creationId xmlns:a16="http://schemas.microsoft.com/office/drawing/2014/main" id="{FE58B822-3E8F-4139-9889-F6E6C02C0C8B}"/>
+                <a16:creationId xmlns:a16="http://schemas.microsoft.com/office/drawing/2014/main" id="{CEC774DC-867D-48FE-AEDA-B5AC367AFBCF}"/>
               </a:ext>
             </a:extLst>
           </p:cNvPr>
@@ -4069,7 +4069,7 @@
           <p:cNvPr id="3" name="Title">
             <a:extLst xmlns:a="http://schemas.openxmlformats.org/drawingml/2006/main">
               <a:ext uri="{FF2B5EF4-FFF2-40B4-BE49-F238E27FC236}">
-                <a16:creationId xmlns:a16="http://schemas.microsoft.com/office/drawing/2014/main" id="{09848AD8-5AD2-4E3B-8EF7-124DD0517DF1}"/>
+                <a16:creationId xmlns:a16="http://schemas.microsoft.com/office/drawing/2014/main" id="{107C3EBA-9490-4C82-A78A-11D7A7235673}"/>
               </a:ext>
             </a:extLst>
           </p:cNvPr>
@@ -4298,7 +4298,7 @@
           <p:cNvPr id="2" name="Body">
             <a:extLst xmlns:a="http://schemas.openxmlformats.org/drawingml/2006/main">
               <a:ext uri="{FF2B5EF4-FFF2-40B4-BE49-F238E27FC236}">
-                <a16:creationId xmlns:a16="http://schemas.microsoft.com/office/drawing/2014/main" id="{1D036850-FD55-4E39-8176-CA984C3BF2F8}"/>
+                <a16:creationId xmlns:a16="http://schemas.microsoft.com/office/drawing/2014/main" id="{09E71A97-F9B8-4DE7-9AC3-EB71A32744CF}"/>
               </a:ext>
             </a:extLst>
           </p:cNvPr>
@@ -4544,7 +4544,7 @@
           <p:cNvPr id="4" name="Title">
             <a:extLst xmlns:a="http://schemas.openxmlformats.org/drawingml/2006/main">
               <a:ext uri="{FF2B5EF4-FFF2-40B4-BE49-F238E27FC236}">
-                <a16:creationId xmlns:a16="http://schemas.microsoft.com/office/drawing/2014/main" id="{F240B7AC-0300-4999-BABD-27310984A7CF}"/>
+                <a16:creationId xmlns:a16="http://schemas.microsoft.com/office/drawing/2014/main" id="{9A7D215F-93F4-4295-9736-6A75F1B96934}"/>
               </a:ext>
             </a:extLst>
           </p:cNvPr>
@@ -4773,7 +4773,7 @@
           <p:cNvPr id="2" name="Left column">
             <a:extLst xmlns:a="http://schemas.openxmlformats.org/drawingml/2006/main">
               <a:ext uri="{FF2B5EF4-FFF2-40B4-BE49-F238E27FC236}">
-                <a16:creationId xmlns:a16="http://schemas.microsoft.com/office/drawing/2014/main" id="{915E2170-3EC5-4D3B-8DF8-C6B9BACB37C7}"/>
+                <a16:creationId xmlns:a16="http://schemas.microsoft.com/office/drawing/2014/main" id="{3A9BF37E-A57C-4C62-9D5B-609A3F48C4E5}"/>
               </a:ext>
             </a:extLst>
           </p:cNvPr>
@@ -5002,7 +5002,7 @@
           <p:cNvPr id="3" name="Right column">
             <a:extLst xmlns:a="http://schemas.openxmlformats.org/drawingml/2006/main">
               <a:ext uri="{FF2B5EF4-FFF2-40B4-BE49-F238E27FC236}">
-                <a16:creationId xmlns:a16="http://schemas.microsoft.com/office/drawing/2014/main" id="{6A7AB39F-155C-49CA-953A-8913E5BB7C93}"/>
+                <a16:creationId xmlns:a16="http://schemas.microsoft.com/office/drawing/2014/main" id="{07C67491-FF12-40CF-86D8-5112108B986D}"/>
               </a:ext>
             </a:extLst>
           </p:cNvPr>
@@ -5248,7 +5248,7 @@
           <p:cNvPr id="3" name="Title">
             <a:extLst xmlns:a="http://schemas.openxmlformats.org/drawingml/2006/main">
               <a:ext uri="{FF2B5EF4-FFF2-40B4-BE49-F238E27FC236}">
-                <a16:creationId xmlns:a16="http://schemas.microsoft.com/office/drawing/2014/main" id="{168561EF-FA87-4BA0-AA49-3CF74926EA14}"/>
+                <a16:creationId xmlns:a16="http://schemas.microsoft.com/office/drawing/2014/main" id="{D45BE578-3C64-41D4-89EA-5800E659F9EE}"/>
               </a:ext>
             </a:extLst>
           </p:cNvPr>
@@ -5477,7 +5477,7 @@
           <p:cNvPr id="2" name="Left column">
             <a:extLst xmlns:a="http://schemas.openxmlformats.org/drawingml/2006/main">
               <a:ext uri="{FF2B5EF4-FFF2-40B4-BE49-F238E27FC236}">
-                <a16:creationId xmlns:a16="http://schemas.microsoft.com/office/drawing/2014/main" id="{3DD01500-0CD5-46C1-A122-B1B51317B37A}"/>
+                <a16:creationId xmlns:a16="http://schemas.microsoft.com/office/drawing/2014/main" id="{E468BB0B-86F7-4ECF-8A58-67CD0BCBD6FF}"/>
               </a:ext>
             </a:extLst>
           </p:cNvPr>
@@ -5744,12 +5744,12 @@
   </p:cSld>
   <p:clrMap bg1="lt1" tx1="dk1" bg2="lt2" tx2="dk2" accent1="accent1" accent2="accent2" accent3="accent3" accent4="accent4" accent5="accent5" accent6="accent6" hlink="hlink" folHlink="folHlink"/>
   <p:sldLayoutIdLst>
-    <p:sldLayoutId xmlns:r="http://schemas.openxmlformats.org/officeDocument/2006/relationships" id="2147483649" r:id="Rd1dc6d2eeb5a4834"/>
-    <p:sldLayoutId xmlns:r="http://schemas.openxmlformats.org/officeDocument/2006/relationships" id="2147483650" r:id="R55c4714d26d44b3f"/>
-    <p:sldLayoutId xmlns:r="http://schemas.openxmlformats.org/officeDocument/2006/relationships" id="2147483651" r:id="R16543eab65bc4792"/>
-    <p:sldLayoutId xmlns:r="http://schemas.openxmlformats.org/officeDocument/2006/relationships" id="2147483652" r:id="Rd22564c724e04d6a"/>
-    <p:sldLayoutId xmlns:r="http://schemas.openxmlformats.org/officeDocument/2006/relationships" id="2147483653" r:id="Rbf1c6752f804471a"/>
-    <p:sldLayoutId xmlns:r="http://schemas.openxmlformats.org/officeDocument/2006/relationships" id="2147483654" r:id="Rad7f9495680a4e77"/>
+    <p:sldLayoutId xmlns:r="http://schemas.openxmlformats.org/officeDocument/2006/relationships" id="2147483649" r:id="R5c2a8b30e0c74212"/>
+    <p:sldLayoutId xmlns:r="http://schemas.openxmlformats.org/officeDocument/2006/relationships" id="2147483650" r:id="R415f65ef029f4634"/>
+    <p:sldLayoutId xmlns:r="http://schemas.openxmlformats.org/officeDocument/2006/relationships" id="2147483651" r:id="R823a656a7ba24cea"/>
+    <p:sldLayoutId xmlns:r="http://schemas.openxmlformats.org/officeDocument/2006/relationships" id="2147483652" r:id="Ra7e87f1a204e4b19"/>
+    <p:sldLayoutId xmlns:r="http://schemas.openxmlformats.org/officeDocument/2006/relationships" id="2147483653" r:id="Rc333de3f7a63413a"/>
+    <p:sldLayoutId xmlns:r="http://schemas.openxmlformats.org/officeDocument/2006/relationships" id="2147483654" r:id="R56de90e2db384296"/>
   </p:sldLayoutIdLst>
   <p:txStyles>
     <p:titleStyle>
@@ -6300,7 +6300,7 @@
           <p:cNvPr id="13" name="ACT 0 · 익숙한 사용에서 출발하기">
             <a:extLst xmlns:a="http://schemas.openxmlformats.org/drawingml/2006/main">
               <a:ext uri="{FF2B5EF4-FFF2-40B4-BE49-F238E27FC236}">
-                <a16:creationId xmlns:a16="http://schemas.microsoft.com/office/drawing/2014/main" id="{5BFB7079-867F-4219-A9A9-D9FD8B4B4E6A}"/>
+                <a16:creationId xmlns:a16="http://schemas.microsoft.com/office/drawing/2014/main" id="{594C153E-A6CD-4EB7-8868-62C3449E164A}"/>
               </a:ext>
             </a:extLst>
           </p:cNvPr>
@@ -6458,7 +6458,7 @@
           <p:cNvPr id="2" name="S01">
             <a:extLst xmlns:a="http://schemas.openxmlformats.org/drawingml/2006/main">
               <a:ext uri="{FF2B5EF4-FFF2-40B4-BE49-F238E27FC236}">
-                <a16:creationId xmlns:a16="http://schemas.microsoft.com/office/drawing/2014/main" id="{2861F305-4315-4EAD-99F6-D9F1C62F7E70}"/>
+                <a16:creationId xmlns:a16="http://schemas.microsoft.com/office/drawing/2014/main" id="{4DA600C7-DA0A-4BFD-B705-5FF11C98D2CA}"/>
               </a:ext>
             </a:extLst>
           </p:cNvPr>
@@ -6616,7 +6616,7 @@
           <p:cNvPr id="3" name="AI에게 지금 무엇을 맡기고 있는가?">
             <a:extLst xmlns:a="http://schemas.openxmlformats.org/drawingml/2006/main">
               <a:ext uri="{FF2B5EF4-FFF2-40B4-BE49-F238E27FC236}">
-                <a16:creationId xmlns:a16="http://schemas.microsoft.com/office/drawing/2014/main" id="{702D7808-7C74-4A41-A8F4-D0CE42C91B44}"/>
+                <a16:creationId xmlns:a16="http://schemas.microsoft.com/office/drawing/2014/main" id="{B13CC443-D740-497D-9D1A-660624E98ADD}"/>
               </a:ext>
             </a:extLst>
           </p:cNvPr>
@@ -6774,7 +6774,7 @@
           <p:cNvPr id="4" name="">
             <a:extLst xmlns:a="http://schemas.openxmlformats.org/drawingml/2006/main">
               <a:ext uri="{FF2B5EF4-FFF2-40B4-BE49-F238E27FC236}">
-                <a16:creationId xmlns:a16="http://schemas.microsoft.com/office/drawing/2014/main" id="{3EE8A7EA-DFAD-4702-8F4E-7D46A0D5D4D2}"/>
+                <a16:creationId xmlns:a16="http://schemas.microsoft.com/office/drawing/2014/main" id="{AF2FAB5B-6877-46DE-8C21-564F8A27C85D}"/>
               </a:ext>
             </a:extLst>
           </p:cNvPr>
@@ -6805,7 +6805,7 @@
           <p:cNvPr id="5" name="교육용 사례 삽화 · AI 생성 이미지 · 실제 제품 실행 화면 아님">
             <a:extLst xmlns:a="http://schemas.openxmlformats.org/drawingml/2006/main">
               <a:ext uri="{FF2B5EF4-FFF2-40B4-BE49-F238E27FC236}">
-                <a16:creationId xmlns:a16="http://schemas.microsoft.com/office/drawing/2014/main" id="{9A83816A-B0D8-4769-862F-FA9A31B11E20}"/>
+                <a16:creationId xmlns:a16="http://schemas.microsoft.com/office/drawing/2014/main" id="{17CB425D-8219-4DC3-A814-C3C3B1A26ED5}"/>
               </a:ext>
             </a:extLst>
           </p:cNvPr>
@@ -6963,7 +6963,7 @@
           <p:cNvPr id="6" name="자신의 경험 하나만 떠올려 보세요. 사용 수준을 평가하는 질문이 아닙니다.">
             <a:extLst xmlns:a="http://schemas.openxmlformats.org/drawingml/2006/main">
               <a:ext uri="{FF2B5EF4-FFF2-40B4-BE49-F238E27FC236}">
-                <a16:creationId xmlns:a16="http://schemas.microsoft.com/office/drawing/2014/main" id="{B4B6DE4E-F379-4420-BA67-F0CB8185DE7A}"/>
+                <a16:creationId xmlns:a16="http://schemas.microsoft.com/office/drawing/2014/main" id="{723FE28F-CAAB-48B0-BED0-5BE1D6165782}"/>
               </a:ext>
             </a:extLst>
           </p:cNvPr>
@@ -7121,7 +7121,7 @@
           <p:cNvPr id="7" name="최근 AI에 맡긴 일 하나를 떠올려 보세요.">
             <a:extLst xmlns:a="http://schemas.openxmlformats.org/drawingml/2006/main">
               <a:ext uri="{FF2B5EF4-FFF2-40B4-BE49-F238E27FC236}">
-                <a16:creationId xmlns:a16="http://schemas.microsoft.com/office/drawing/2014/main" id="{284942B1-C98C-43D3-B325-78535F9D8736}"/>
+                <a16:creationId xmlns:a16="http://schemas.microsoft.com/office/drawing/2014/main" id="{2DDC4A5E-0650-48A4-B73D-28D42FC7DA17}"/>
               </a:ext>
             </a:extLst>
           </p:cNvPr>
@@ -7279,7 +7279,7 @@
           <p:cNvPr id="8" name="">
             <a:extLst xmlns:a="http://schemas.openxmlformats.org/drawingml/2006/main">
               <a:ext uri="{FF2B5EF4-FFF2-40B4-BE49-F238E27FC236}">
-                <a16:creationId xmlns:a16="http://schemas.microsoft.com/office/drawing/2014/main" id="{3A6348F9-37EB-4A3E-8ACC-08C9FDC5F5F6}"/>
+                <a16:creationId xmlns:a16="http://schemas.microsoft.com/office/drawing/2014/main" id="{74E2ADAF-A3ED-472A-822B-7800E1B1E0A8}"/>
               </a:ext>
             </a:extLst>
           </p:cNvPr>
@@ -7289,7 +7289,7 @@
           <p:nvPr/>
         </p:nvPicPr>
         <p:blipFill>
-          <a:blip xmlns:r="http://schemas.openxmlformats.org/officeDocument/2006/relationships" xmlns:a="http://schemas.openxmlformats.org/drawingml/2006/main" r:embed="Rd82d1b50a6524915"/>
+          <a:blip xmlns:r="http://schemas.openxmlformats.org/officeDocument/2006/relationships" xmlns:a="http://schemas.openxmlformats.org/drawingml/2006/main" r:embed="R55d56c2e3eb14754"/>
           <a:stretch xmlns:a="http://schemas.openxmlformats.org/drawingml/2006/main"/>
         </p:blipFill>
         <p:spPr>
@@ -7307,7 +7307,7 @@
           <p:cNvPr id="9" name="설명 받기">
             <a:extLst xmlns:a="http://schemas.openxmlformats.org/drawingml/2006/main">
               <a:ext uri="{FF2B5EF4-FFF2-40B4-BE49-F238E27FC236}">
-                <a16:creationId xmlns:a16="http://schemas.microsoft.com/office/drawing/2014/main" id="{2BD3E86E-E916-4026-BC82-F041625190D0}"/>
+                <a16:creationId xmlns:a16="http://schemas.microsoft.com/office/drawing/2014/main" id="{1B36E821-22BD-440A-AB76-DD16E6B67F4A}"/>
               </a:ext>
             </a:extLst>
           </p:cNvPr>
@@ -7465,7 +7465,7 @@
           <p:cNvPr id="10" name="조사 맡기기">
             <a:extLst xmlns:a="http://schemas.openxmlformats.org/drawingml/2006/main">
               <a:ext uri="{FF2B5EF4-FFF2-40B4-BE49-F238E27FC236}">
-                <a16:creationId xmlns:a16="http://schemas.microsoft.com/office/drawing/2014/main" id="{80995DB1-D372-425A-9F23-EE6E7E7807C6}"/>
+                <a16:creationId xmlns:a16="http://schemas.microsoft.com/office/drawing/2014/main" id="{CD4661BD-8544-4D29-89A6-2F7137C8AFA2}"/>
               </a:ext>
             </a:extLst>
           </p:cNvPr>
@@ -7623,7 +7623,7 @@
           <p:cNvPr id="11" name="결과 확인">
             <a:extLst xmlns:a="http://schemas.openxmlformats.org/drawingml/2006/main">
               <a:ext uri="{FF2B5EF4-FFF2-40B4-BE49-F238E27FC236}">
-                <a16:creationId xmlns:a16="http://schemas.microsoft.com/office/drawing/2014/main" id="{E6E4CB83-D8D0-41E4-8940-5A8F00F3F8D4}"/>
+                <a16:creationId xmlns:a16="http://schemas.microsoft.com/office/drawing/2014/main" id="{B74EC7A2-AF70-473A-B24D-63DBF89714BA}"/>
               </a:ext>
             </a:extLst>
           </p:cNvPr>
@@ -7781,7 +7781,7 @@
           <p:cNvPr id="12" name="Legacy module connection">
             <a:extLst xmlns:a="http://schemas.openxmlformats.org/drawingml/2006/main">
               <a:ext uri="{FF2B5EF4-FFF2-40B4-BE49-F238E27FC236}">
-                <a16:creationId xmlns:a16="http://schemas.microsoft.com/office/drawing/2014/main" id="{DC4C5CE1-60E2-4DB2-ABC4-F21BDD0D39C4}"/>
+                <a16:creationId xmlns:a16="http://schemas.microsoft.com/office/drawing/2014/main" id="{F87D9EFA-63E5-4A66-A674-79525EED7F07}"/>
               </a:ext>
             </a:extLst>
           </p:cNvPr>
@@ -7937,7 +7937,7 @@
     </p:spTree>
     <p:extLst>
       <p:ext uri="{BB962C8B-B14F-4D97-AF65-F5344CB8AC3E}">
-        <p14:creationId xmlns:p14="http://schemas.microsoft.com/office/powerpoint/2010/main" val="655351876"/>
+        <p14:creationId xmlns:p14="http://schemas.microsoft.com/office/powerpoint/2010/main" val="1450970759"/>
       </p:ext>
     </p:extLst>
   </p:cSld>
@@ -7968,7 +7968,7 @@
           <p:cNvPr id="62" name="ACT 0 · 제조 라인 검사 Task로 이어지는 질문">
             <a:extLst xmlns:a="http://schemas.openxmlformats.org/drawingml/2006/main">
               <a:ext uri="{FF2B5EF4-FFF2-40B4-BE49-F238E27FC236}">
-                <a16:creationId xmlns:a16="http://schemas.microsoft.com/office/drawing/2014/main" id="{43E63D0E-F149-43D4-9A92-C03C30ABEC72}"/>
+                <a16:creationId xmlns:a16="http://schemas.microsoft.com/office/drawing/2014/main" id="{2CC5C3CD-2538-4113-93E7-41DBAE42F809}"/>
               </a:ext>
             </a:extLst>
           </p:cNvPr>
@@ -8126,7 +8126,7 @@
           <p:cNvPr id="2" name="S10">
             <a:extLst xmlns:a="http://schemas.openxmlformats.org/drawingml/2006/main">
               <a:ext uri="{FF2B5EF4-FFF2-40B4-BE49-F238E27FC236}">
-                <a16:creationId xmlns:a16="http://schemas.microsoft.com/office/drawing/2014/main" id="{E673DE90-48ED-488E-BE14-B171ED82BFA4}"/>
+                <a16:creationId xmlns:a16="http://schemas.microsoft.com/office/drawing/2014/main" id="{B436F4F8-84F6-45FF-8397-123BF8EC1AD5}"/>
               </a:ext>
             </a:extLst>
           </p:cNvPr>
@@ -8284,7 +8284,7 @@
           <p:cNvPr id="3" name="Repository를 보면 내가 원하는 것까지 알까?">
             <a:extLst xmlns:a="http://schemas.openxmlformats.org/drawingml/2006/main">
               <a:ext uri="{FF2B5EF4-FFF2-40B4-BE49-F238E27FC236}">
-                <a16:creationId xmlns:a16="http://schemas.microsoft.com/office/drawing/2014/main" id="{B08E957C-C912-4933-B306-467BFB608543}"/>
+                <a16:creationId xmlns:a16="http://schemas.microsoft.com/office/drawing/2014/main" id="{C1EFB966-BF99-44F5-B097-1E19A059B54B}"/>
               </a:ext>
             </a:extLst>
           </p:cNvPr>
@@ -8442,7 +8442,7 @@
           <p:cNvPr id="4" name="">
             <a:extLst xmlns:a="http://schemas.openxmlformats.org/drawingml/2006/main">
               <a:ext uri="{FF2B5EF4-FFF2-40B4-BE49-F238E27FC236}">
-                <a16:creationId xmlns:a16="http://schemas.microsoft.com/office/drawing/2014/main" id="{1C1C6B67-ACD5-4A53-9192-98A284138397}"/>
+                <a16:creationId xmlns:a16="http://schemas.microsoft.com/office/drawing/2014/main" id="{82F2431E-B520-4806-94B1-DB3E1CB8CE22}"/>
               </a:ext>
             </a:extLst>
           </p:cNvPr>
@@ -8473,7 +8473,7 @@
           <p:cNvPr id="5" name="교육용 검사 Task 가정 · 점선은 추가 정의·연결 범위 · 실제 실행 결과 아님">
             <a:extLst xmlns:a="http://schemas.openxmlformats.org/drawingml/2006/main">
               <a:ext uri="{FF2B5EF4-FFF2-40B4-BE49-F238E27FC236}">
-                <a16:creationId xmlns:a16="http://schemas.microsoft.com/office/drawing/2014/main" id="{C72FA2B0-33E4-4384-92A2-C73E60D7D322}"/>
+                <a16:creationId xmlns:a16="http://schemas.microsoft.com/office/drawing/2014/main" id="{BEA4D98C-C5D6-4880-9766-2ECAE8FD0DDC}"/>
               </a:ext>
             </a:extLst>
           </p:cNvPr>
@@ -8631,7 +8631,7 @@
           <p:cNvPr id="6" name="실제 저장소에는 후속 함수도 있습니다. 도식은 실제 실행 순서나 함수의 미구현 상태를 재현하지 않습니다.">
             <a:extLst xmlns:a="http://schemas.openxmlformats.org/drawingml/2006/main">
               <a:ext uri="{FF2B5EF4-FFF2-40B4-BE49-F238E27FC236}">
-                <a16:creationId xmlns:a16="http://schemas.microsoft.com/office/drawing/2014/main" id="{E072576E-FCF2-41DE-84AD-160B878679A5}"/>
+                <a16:creationId xmlns:a16="http://schemas.microsoft.com/office/drawing/2014/main" id="{87652552-17E7-4BE9-AA5D-C812F75F0B85}"/>
               </a:ext>
             </a:extLst>
           </p:cNvPr>
@@ -8789,7 +8789,7 @@
           <p:cNvPr id="7" name="제조 라인 검사장비로 확장한다면?">
             <a:extLst xmlns:a="http://schemas.openxmlformats.org/drawingml/2006/main">
               <a:ext uri="{FF2B5EF4-FFF2-40B4-BE49-F238E27FC236}">
-                <a16:creationId xmlns:a16="http://schemas.microsoft.com/office/drawing/2014/main" id="{B426B943-2D29-4FA1-B92B-FD8F94133BE0}"/>
+                <a16:creationId xmlns:a16="http://schemas.microsoft.com/office/drawing/2014/main" id="{784E91F6-04B4-49AA-98D1-F91C391874C3}"/>
               </a:ext>
             </a:extLst>
           </p:cNvPr>
@@ -8947,7 +8947,7 @@
           <p:cNvPr id="8" name="앞서 살펴본 기존 구현">
             <a:extLst xmlns:a="http://schemas.openxmlformats.org/drawingml/2006/main">
               <a:ext uri="{FF2B5EF4-FFF2-40B4-BE49-F238E27FC236}">
-                <a16:creationId xmlns:a16="http://schemas.microsoft.com/office/drawing/2014/main" id="{AF80D5D8-6A79-41D5-AED2-683E35F00367}"/>
+                <a16:creationId xmlns:a16="http://schemas.microsoft.com/office/drawing/2014/main" id="{FEEF320D-D41B-4851-9A5F-93E2FA169DB0}"/>
               </a:ext>
             </a:extLst>
           </p:cNvPr>
@@ -9105,7 +9105,7 @@
           <p:cNvPr id="9" name="검사 흐름으로 추가 정의·연결할 범위">
             <a:extLst xmlns:a="http://schemas.openxmlformats.org/drawingml/2006/main">
               <a:ext uri="{FF2B5EF4-FFF2-40B4-BE49-F238E27FC236}">
-                <a16:creationId xmlns:a16="http://schemas.microsoft.com/office/drawing/2014/main" id="{0F088E82-8341-45A7-B536-530EC72B7B08}"/>
+                <a16:creationId xmlns:a16="http://schemas.microsoft.com/office/drawing/2014/main" id="{06108055-9606-42CB-B25C-D32C763640C3}"/>
               </a:ext>
             </a:extLst>
           </p:cNvPr>
@@ -9263,7 +9263,7 @@
           <p:cNvPr id="10" name="">
             <a:extLst xmlns:a="http://schemas.openxmlformats.org/drawingml/2006/main">
               <a:ext uri="{FF2B5EF4-FFF2-40B4-BE49-F238E27FC236}">
-                <a16:creationId xmlns:a16="http://schemas.microsoft.com/office/drawing/2014/main" id="{B08BE84A-FAB8-4DF4-B07D-76A95512987C}"/>
+                <a16:creationId xmlns:a16="http://schemas.microsoft.com/office/drawing/2014/main" id="{517B47D6-6B11-4A1C-BAC2-4DBEE23A04B9}"/>
               </a:ext>
             </a:extLst>
           </p:cNvPr>
@@ -9296,7 +9296,7 @@
           <p:cNvPr id="11" name="촬영 이미지">
             <a:extLst xmlns:a="http://schemas.openxmlformats.org/drawingml/2006/main">
               <a:ext uri="{FF2B5EF4-FFF2-40B4-BE49-F238E27FC236}">
-                <a16:creationId xmlns:a16="http://schemas.microsoft.com/office/drawing/2014/main" id="{B14C043A-BAA2-46D9-9EAE-2FB0511760D6}"/>
+                <a16:creationId xmlns:a16="http://schemas.microsoft.com/office/drawing/2014/main" id="{EAFC6E86-1963-4717-AB20-5B2DB3677E42}"/>
               </a:ext>
             </a:extLst>
           </p:cNvPr>
@@ -9454,7 +9454,7 @@
           <p:cNvPr id="12" name="Input">
             <a:extLst xmlns:a="http://schemas.openxmlformats.org/drawingml/2006/main">
               <a:ext uri="{FF2B5EF4-FFF2-40B4-BE49-F238E27FC236}">
-                <a16:creationId xmlns:a16="http://schemas.microsoft.com/office/drawing/2014/main" id="{E4823BDC-E3B0-4FAB-B9E6-7D526F6F71F3}"/>
+                <a16:creationId xmlns:a16="http://schemas.microsoft.com/office/drawing/2014/main" id="{0C17008D-4CAD-47F9-9189-48728B5D498A}"/>
               </a:ext>
             </a:extLst>
           </p:cNvPr>
@@ -9612,7 +9612,7 @@
           <p:cNvPr id="13" name="">
             <a:extLst xmlns:a="http://schemas.openxmlformats.org/drawingml/2006/main">
               <a:ext uri="{FF2B5EF4-FFF2-40B4-BE49-F238E27FC236}">
-                <a16:creationId xmlns:a16="http://schemas.microsoft.com/office/drawing/2014/main" id="{280290AA-BF1F-4504-B05F-9942B24F6F75}"/>
+                <a16:creationId xmlns:a16="http://schemas.microsoft.com/office/drawing/2014/main" id="{7DD604E8-EF13-495C-B622-F4E1B49C0B9B}"/>
               </a:ext>
             </a:extLst>
           </p:cNvPr>
@@ -9642,7 +9642,7 @@
           <p:cNvPr id="14" name="">
             <a:extLst xmlns:a="http://schemas.openxmlformats.org/drawingml/2006/main">
               <a:ext uri="{FF2B5EF4-FFF2-40B4-BE49-F238E27FC236}">
-                <a16:creationId xmlns:a16="http://schemas.microsoft.com/office/drawing/2014/main" id="{F5C2DDB9-51C1-4745-A5B8-DA06625BFB32}"/>
+                <a16:creationId xmlns:a16="http://schemas.microsoft.com/office/drawing/2014/main" id="{C4407D82-C4C6-409F-B44B-97B0D7A87891}"/>
               </a:ext>
             </a:extLst>
           </p:cNvPr>
@@ -9675,7 +9675,7 @@
           <p:cNvPr id="15" name="ROI crop">
             <a:extLst xmlns:a="http://schemas.openxmlformats.org/drawingml/2006/main">
               <a:ext uri="{FF2B5EF4-FFF2-40B4-BE49-F238E27FC236}">
-                <a16:creationId xmlns:a16="http://schemas.microsoft.com/office/drawing/2014/main" id="{C78078DB-D3E4-4DBA-9E4D-3346E9FCD8DA}"/>
+                <a16:creationId xmlns:a16="http://schemas.microsoft.com/office/drawing/2014/main" id="{0F2F27B3-1D37-4CB9-AA6C-2E92AB15F8FE}"/>
               </a:ext>
             </a:extLst>
           </p:cNvPr>
@@ -9833,7 +9833,7 @@
           <p:cNvPr id="16" name="기존 구현 · 조사한 범위">
             <a:extLst xmlns:a="http://schemas.openxmlformats.org/drawingml/2006/main">
               <a:ext uri="{FF2B5EF4-FFF2-40B4-BE49-F238E27FC236}">
-                <a16:creationId xmlns:a16="http://schemas.microsoft.com/office/drawing/2014/main" id="{ED4F0AED-00E2-40FC-AC63-E60CA969EF4E}"/>
+                <a16:creationId xmlns:a16="http://schemas.microsoft.com/office/drawing/2014/main" id="{28EF576F-5C40-426E-BCE8-891B9D1328C3}"/>
               </a:ext>
             </a:extLst>
           </p:cNvPr>
@@ -9991,7 +9991,7 @@
           <p:cNvPr id="17" name="">
             <a:extLst xmlns:a="http://schemas.openxmlformats.org/drawingml/2006/main">
               <a:ext uri="{FF2B5EF4-FFF2-40B4-BE49-F238E27FC236}">
-                <a16:creationId xmlns:a16="http://schemas.microsoft.com/office/drawing/2014/main" id="{06ABCF5C-D2EB-4EA2-997A-6F2E32A22CCE}"/>
+                <a16:creationId xmlns:a16="http://schemas.microsoft.com/office/drawing/2014/main" id="{7D721129-50F8-40CA-8E14-5E2A77EC79BA}"/>
               </a:ext>
             </a:extLst>
           </p:cNvPr>
@@ -10022,7 +10022,7 @@
           <p:cNvPr id="18" name="">
             <a:extLst xmlns:a="http://schemas.openxmlformats.org/drawingml/2006/main">
               <a:ext uri="{FF2B5EF4-FFF2-40B4-BE49-F238E27FC236}">
-                <a16:creationId xmlns:a16="http://schemas.microsoft.com/office/drawing/2014/main" id="{4AA8D995-4E32-4459-A411-8F08E1C56397}"/>
+                <a16:creationId xmlns:a16="http://schemas.microsoft.com/office/drawing/2014/main" id="{7B719E07-0DCB-436A-84FB-AA33AB8C846D}"/>
               </a:ext>
             </a:extLst>
           </p:cNvPr>
@@ -10052,7 +10052,7 @@
           <p:cNvPr id="19" name="">
             <a:extLst xmlns:a="http://schemas.openxmlformats.org/drawingml/2006/main">
               <a:ext uri="{FF2B5EF4-FFF2-40B4-BE49-F238E27FC236}">
-                <a16:creationId xmlns:a16="http://schemas.microsoft.com/office/drawing/2014/main" id="{DE44527D-B83E-48D8-8591-7860EAD8285E}"/>
+                <a16:creationId xmlns:a16="http://schemas.microsoft.com/office/drawing/2014/main" id="{B6199C8B-8375-45E8-86C8-9910AF5E7F33}"/>
               </a:ext>
             </a:extLst>
           </p:cNvPr>
@@ -10085,7 +10085,7 @@
           <p:cNvPr id="20" name="밝기 정규화">
             <a:extLst xmlns:a="http://schemas.openxmlformats.org/drawingml/2006/main">
               <a:ext uri="{FF2B5EF4-FFF2-40B4-BE49-F238E27FC236}">
-                <a16:creationId xmlns:a16="http://schemas.microsoft.com/office/drawing/2014/main" id="{9EC835B1-D3E9-4FAC-8420-06FAA14FBEBB}"/>
+                <a16:creationId xmlns:a16="http://schemas.microsoft.com/office/drawing/2014/main" id="{B63921B8-3A66-4242-B89E-91B43DB84BAC}"/>
               </a:ext>
             </a:extLst>
           </p:cNvPr>
@@ -10243,7 +10243,7 @@
           <p:cNvPr id="21" name="Normalize">
             <a:extLst xmlns:a="http://schemas.openxmlformats.org/drawingml/2006/main">
               <a:ext uri="{FF2B5EF4-FFF2-40B4-BE49-F238E27FC236}">
-                <a16:creationId xmlns:a16="http://schemas.microsoft.com/office/drawing/2014/main" id="{3F02C3E1-3038-4045-9BC8-4B5F48A70452}"/>
+                <a16:creationId xmlns:a16="http://schemas.microsoft.com/office/drawing/2014/main" id="{8637BA32-02A1-4312-B0AB-14F36902C759}"/>
               </a:ext>
             </a:extLst>
           </p:cNvPr>
@@ -10401,7 +10401,7 @@
           <p:cNvPr id="22" name="">
             <a:extLst xmlns:a="http://schemas.openxmlformats.org/drawingml/2006/main">
               <a:ext uri="{FF2B5EF4-FFF2-40B4-BE49-F238E27FC236}">
-                <a16:creationId xmlns:a16="http://schemas.microsoft.com/office/drawing/2014/main" id="{4480DF54-BD58-4EB3-AAAC-AF1733C1A8C3}"/>
+                <a16:creationId xmlns:a16="http://schemas.microsoft.com/office/drawing/2014/main" id="{BEAE6D30-2F63-41C0-8CB5-EEAC4A7EF657}"/>
               </a:ext>
             </a:extLst>
           </p:cNvPr>
@@ -10432,7 +10432,7 @@
           <p:cNvPr id="23" name="">
             <a:extLst xmlns:a="http://schemas.openxmlformats.org/drawingml/2006/main">
               <a:ext uri="{FF2B5EF4-FFF2-40B4-BE49-F238E27FC236}">
-                <a16:creationId xmlns:a16="http://schemas.microsoft.com/office/drawing/2014/main" id="{FC200A3B-3439-4124-BEAD-9C925CA45431}"/>
+                <a16:creationId xmlns:a16="http://schemas.microsoft.com/office/drawing/2014/main" id="{424F236E-F2CC-4C28-AFCB-3ACA5DA009CB}"/>
               </a:ext>
             </a:extLst>
           </p:cNvPr>
@@ -10462,7 +10462,7 @@
           <p:cNvPr id="24" name="">
             <a:extLst xmlns:a="http://schemas.openxmlformats.org/drawingml/2006/main">
               <a:ext uri="{FF2B5EF4-FFF2-40B4-BE49-F238E27FC236}">
-                <a16:creationId xmlns:a16="http://schemas.microsoft.com/office/drawing/2014/main" id="{A1E9EEDB-FAD9-40B9-9D14-E0220905E1E9}"/>
+                <a16:creationId xmlns:a16="http://schemas.microsoft.com/office/drawing/2014/main" id="{23C5EF28-5CE9-4E5B-9F7D-EE6EC7887175}"/>
               </a:ext>
             </a:extLst>
           </p:cNvPr>
@@ -10495,7 +10495,7 @@
           <p:cNvPr id="25" name="크기 맞춤">
             <a:extLst xmlns:a="http://schemas.openxmlformats.org/drawingml/2006/main">
               <a:ext uri="{FF2B5EF4-FFF2-40B4-BE49-F238E27FC236}">
-                <a16:creationId xmlns:a16="http://schemas.microsoft.com/office/drawing/2014/main" id="{98ECF4FC-4F50-4BE0-B9C6-7AD807FF12EE}"/>
+                <a16:creationId xmlns:a16="http://schemas.microsoft.com/office/drawing/2014/main" id="{20865AC5-B6FF-4467-BAC6-476E708F824F}"/>
               </a:ext>
             </a:extLst>
           </p:cNvPr>
@@ -10653,7 +10653,7 @@
           <p:cNvPr id="26" name="Resize">
             <a:extLst xmlns:a="http://schemas.openxmlformats.org/drawingml/2006/main">
               <a:ext uri="{FF2B5EF4-FFF2-40B4-BE49-F238E27FC236}">
-                <a16:creationId xmlns:a16="http://schemas.microsoft.com/office/drawing/2014/main" id="{76581C25-01E6-4B4D-9515-74B602DF5AE4}"/>
+                <a16:creationId xmlns:a16="http://schemas.microsoft.com/office/drawing/2014/main" id="{6635C51B-081D-4AD4-A06B-E321C6A83D57}"/>
               </a:ext>
             </a:extLst>
           </p:cNvPr>
@@ -10811,7 +10811,7 @@
           <p:cNvPr id="27" name="">
             <a:extLst xmlns:a="http://schemas.openxmlformats.org/drawingml/2006/main">
               <a:ext uri="{FF2B5EF4-FFF2-40B4-BE49-F238E27FC236}">
-                <a16:creationId xmlns:a16="http://schemas.microsoft.com/office/drawing/2014/main" id="{6DC6DD99-D521-404C-9BB8-D1F71E2FCB4E}"/>
+                <a16:creationId xmlns:a16="http://schemas.microsoft.com/office/drawing/2014/main" id="{60FB264E-2F85-488F-8A94-DFB007D33B75}"/>
               </a:ext>
             </a:extLst>
           </p:cNvPr>
@@ -10842,7 +10842,7 @@
           <p:cNvPr id="28" name="">
             <a:extLst xmlns:a="http://schemas.openxmlformats.org/drawingml/2006/main">
               <a:ext uri="{FF2B5EF4-FFF2-40B4-BE49-F238E27FC236}">
-                <a16:creationId xmlns:a16="http://schemas.microsoft.com/office/drawing/2014/main" id="{2695DD46-58F5-4A88-B1F0-185C825F3312}"/>
+                <a16:creationId xmlns:a16="http://schemas.microsoft.com/office/drawing/2014/main" id="{7E5E1544-4EA0-415B-B9CD-C0231B606A7E}"/>
               </a:ext>
             </a:extLst>
           </p:cNvPr>
@@ -10872,7 +10872,7 @@
           <p:cNvPr id="29" name="">
             <a:extLst xmlns:a="http://schemas.openxmlformats.org/drawingml/2006/main">
               <a:ext uri="{FF2B5EF4-FFF2-40B4-BE49-F238E27FC236}">
-                <a16:creationId xmlns:a16="http://schemas.microsoft.com/office/drawing/2014/main" id="{62AE0C6D-8F40-4776-8F53-5491CA98FED4}"/>
+                <a16:creationId xmlns:a16="http://schemas.microsoft.com/office/drawing/2014/main" id="{C986F04B-5784-4478-ADCC-116B0C8A02D6}"/>
               </a:ext>
             </a:extLst>
           </p:cNvPr>
@@ -10905,7 +10905,7 @@
           <p:cNvPr id="30" name="통계·특징">
             <a:extLst xmlns:a="http://schemas.openxmlformats.org/drawingml/2006/main">
               <a:ext uri="{FF2B5EF4-FFF2-40B4-BE49-F238E27FC236}">
-                <a16:creationId xmlns:a16="http://schemas.microsoft.com/office/drawing/2014/main" id="{AFB4C3BF-7310-48FB-A71C-AF51F5BDDF63}"/>
+                <a16:creationId xmlns:a16="http://schemas.microsoft.com/office/drawing/2014/main" id="{2BB14F24-5C06-49F1-8EEA-F76000F7D31D}"/>
               </a:ext>
             </a:extLst>
           </p:cNvPr>
@@ -11063,7 +11063,7 @@
           <p:cNvPr id="31" name="Statistics">
             <a:extLst xmlns:a="http://schemas.openxmlformats.org/drawingml/2006/main">
               <a:ext uri="{FF2B5EF4-FFF2-40B4-BE49-F238E27FC236}">
-                <a16:creationId xmlns:a16="http://schemas.microsoft.com/office/drawing/2014/main" id="{6B057464-3354-4A8E-8221-9BEBA5154775}"/>
+                <a16:creationId xmlns:a16="http://schemas.microsoft.com/office/drawing/2014/main" id="{60A55D3C-55FA-4F4C-A468-F417361545F7}"/>
               </a:ext>
             </a:extLst>
           </p:cNvPr>
@@ -11221,7 +11221,7 @@
           <p:cNvPr id="32" name="">
             <a:extLst xmlns:a="http://schemas.openxmlformats.org/drawingml/2006/main">
               <a:ext uri="{FF2B5EF4-FFF2-40B4-BE49-F238E27FC236}">
-                <a16:creationId xmlns:a16="http://schemas.microsoft.com/office/drawing/2014/main" id="{AA62C983-F230-4E87-BD8A-CDF4024F55DF}"/>
+                <a16:creationId xmlns:a16="http://schemas.microsoft.com/office/drawing/2014/main" id="{0860E1D2-ED9D-4999-82FC-04B0A3295670}"/>
               </a:ext>
             </a:extLst>
           </p:cNvPr>
@@ -11252,7 +11252,7 @@
           <p:cNvPr id="33" name="">
             <a:extLst xmlns:a="http://schemas.openxmlformats.org/drawingml/2006/main">
               <a:ext uri="{FF2B5EF4-FFF2-40B4-BE49-F238E27FC236}">
-                <a16:creationId xmlns:a16="http://schemas.microsoft.com/office/drawing/2014/main" id="{1A5D653F-D13F-4875-9952-36F6CF0A7907}"/>
+                <a16:creationId xmlns:a16="http://schemas.microsoft.com/office/drawing/2014/main" id="{3862CCF9-5193-4FDA-9BC9-5A6985CD10BB}"/>
               </a:ext>
             </a:extLst>
           </p:cNvPr>
@@ -11282,7 +11282,7 @@
           <p:cNvPr id="34" name="">
             <a:extLst xmlns:a="http://schemas.openxmlformats.org/drawingml/2006/main">
               <a:ext uri="{FF2B5EF4-FFF2-40B4-BE49-F238E27FC236}">
-                <a16:creationId xmlns:a16="http://schemas.microsoft.com/office/drawing/2014/main" id="{EAC3029F-9A7F-4E0E-8F82-F3673CDA1AC0}"/>
+                <a16:creationId xmlns:a16="http://schemas.microsoft.com/office/drawing/2014/main" id="{7E8CF722-C702-4EB3-841C-B36E4C37DCEF}"/>
               </a:ext>
             </a:extLst>
           </p:cNvPr>
@@ -11315,7 +11315,7 @@
           <p:cNvPr id="35" name="양불 판정">
             <a:extLst xmlns:a="http://schemas.openxmlformats.org/drawingml/2006/main">
               <a:ext uri="{FF2B5EF4-FFF2-40B4-BE49-F238E27FC236}">
-                <a16:creationId xmlns:a16="http://schemas.microsoft.com/office/drawing/2014/main" id="{F4567BEF-14C5-4A2A-80C1-39F35671782D}"/>
+                <a16:creationId xmlns:a16="http://schemas.microsoft.com/office/drawing/2014/main" id="{DFDD0944-E0CF-45F4-A035-50A7FE8D1BBC}"/>
               </a:ext>
             </a:extLst>
           </p:cNvPr>
@@ -11473,7 +11473,7 @@
           <p:cNvPr id="36" name="기준 미정">
             <a:extLst xmlns:a="http://schemas.openxmlformats.org/drawingml/2006/main">
               <a:ext uri="{FF2B5EF4-FFF2-40B4-BE49-F238E27FC236}">
-                <a16:creationId xmlns:a16="http://schemas.microsoft.com/office/drawing/2014/main" id="{3F0280D1-8371-4D0C-AD50-3D76138A4594}"/>
+                <a16:creationId xmlns:a16="http://schemas.microsoft.com/office/drawing/2014/main" id="{C7B81BDA-68CE-40E8-9449-3965A6BD8AF0}"/>
               </a:ext>
             </a:extLst>
           </p:cNvPr>
@@ -11631,7 +11631,7 @@
           <p:cNvPr id="37" name="">
             <a:extLst xmlns:a="http://schemas.openxmlformats.org/drawingml/2006/main">
               <a:ext uri="{FF2B5EF4-FFF2-40B4-BE49-F238E27FC236}">
-                <a16:creationId xmlns:a16="http://schemas.microsoft.com/office/drawing/2014/main" id="{F24F2BD5-5128-4E03-947D-2C8C5C59EC76}"/>
+                <a16:creationId xmlns:a16="http://schemas.microsoft.com/office/drawing/2014/main" id="{540F3912-9E77-4CC0-896B-D4803F127F0D}"/>
               </a:ext>
             </a:extLst>
           </p:cNvPr>
@@ -11664,7 +11664,7 @@
           <p:cNvPr id="38" name="">
             <a:extLst xmlns:a="http://schemas.openxmlformats.org/drawingml/2006/main">
               <a:ext uri="{FF2B5EF4-FFF2-40B4-BE49-F238E27FC236}">
-                <a16:creationId xmlns:a16="http://schemas.microsoft.com/office/drawing/2014/main" id="{7EE3C757-51A3-44C5-8573-2D707A43769E}"/>
+                <a16:creationId xmlns:a16="http://schemas.microsoft.com/office/drawing/2014/main" id="{531E7D6F-7379-4C7F-9500-9F6CAB5A3A30}"/>
               </a:ext>
             </a:extLst>
           </p:cNvPr>
@@ -11694,7 +11694,7 @@
           <p:cNvPr id="39" name="">
             <a:extLst xmlns:a="http://schemas.openxmlformats.org/drawingml/2006/main">
               <a:ext uri="{FF2B5EF4-FFF2-40B4-BE49-F238E27FC236}">
-                <a16:creationId xmlns:a16="http://schemas.microsoft.com/office/drawing/2014/main" id="{18BD3F55-8526-4922-BF16-35D2BB0962EF}"/>
+                <a16:creationId xmlns:a16="http://schemas.microsoft.com/office/drawing/2014/main" id="{19EF31C5-EC08-4B3D-A254-1F827911B39B}"/>
               </a:ext>
             </a:extLst>
           </p:cNvPr>
@@ -11724,7 +11724,7 @@
           <p:cNvPr id="40" name="">
             <a:extLst xmlns:a="http://schemas.openxmlformats.org/drawingml/2006/main">
               <a:ext uri="{FF2B5EF4-FFF2-40B4-BE49-F238E27FC236}">
-                <a16:creationId xmlns:a16="http://schemas.microsoft.com/office/drawing/2014/main" id="{A12DF1A4-14E9-4317-9DB7-F35B56D7D119}"/>
+                <a16:creationId xmlns:a16="http://schemas.microsoft.com/office/drawing/2014/main" id="{C92DC19F-D62F-4F23-8850-567313862869}"/>
               </a:ext>
             </a:extLst>
           </p:cNvPr>
@@ -11754,7 +11754,7 @@
           <p:cNvPr id="41" name="">
             <a:extLst xmlns:a="http://schemas.openxmlformats.org/drawingml/2006/main">
               <a:ext uri="{FF2B5EF4-FFF2-40B4-BE49-F238E27FC236}">
-                <a16:creationId xmlns:a16="http://schemas.microsoft.com/office/drawing/2014/main" id="{0C37A0F8-CD7F-4E19-AFC6-B191318926C1}"/>
+                <a16:creationId xmlns:a16="http://schemas.microsoft.com/office/drawing/2014/main" id="{E40F9763-1A99-479C-9524-80B896C5BE75}"/>
               </a:ext>
             </a:extLst>
           </p:cNvPr>
@@ -11784,7 +11784,7 @@
           <p:cNvPr id="42" name="">
             <a:extLst xmlns:a="http://schemas.openxmlformats.org/drawingml/2006/main">
               <a:ext uri="{FF2B5EF4-FFF2-40B4-BE49-F238E27FC236}">
-                <a16:creationId xmlns:a16="http://schemas.microsoft.com/office/drawing/2014/main" id="{0E6E110F-021E-4C43-B1EA-ADA802AC27AF}"/>
+                <a16:creationId xmlns:a16="http://schemas.microsoft.com/office/drawing/2014/main" id="{10D639E9-EB9C-4FF2-8B90-3E724E25E145}"/>
               </a:ext>
             </a:extLst>
           </p:cNvPr>
@@ -11815,7 +11815,7 @@
           <p:cNvPr id="43" name="">
             <a:extLst xmlns:a="http://schemas.openxmlformats.org/drawingml/2006/main">
               <a:ext uri="{FF2B5EF4-FFF2-40B4-BE49-F238E27FC236}">
-                <a16:creationId xmlns:a16="http://schemas.microsoft.com/office/drawing/2014/main" id="{0C992D56-E6F4-458F-B97E-3A51A8D3E5AB}"/>
+                <a16:creationId xmlns:a16="http://schemas.microsoft.com/office/drawing/2014/main" id="{0306DBEE-9737-4DB2-8C1B-6D5C9B58CE92}"/>
               </a:ext>
             </a:extLst>
           </p:cNvPr>
@@ -11848,7 +11848,7 @@
           <p:cNvPr id="44" name="">
             <a:extLst xmlns:a="http://schemas.openxmlformats.org/drawingml/2006/main">
               <a:ext uri="{FF2B5EF4-FFF2-40B4-BE49-F238E27FC236}">
-                <a16:creationId xmlns:a16="http://schemas.microsoft.com/office/drawing/2014/main" id="{A9AA6B2C-D4D9-4DFF-8772-60A0F74BA950}"/>
+                <a16:creationId xmlns:a16="http://schemas.microsoft.com/office/drawing/2014/main" id="{F5FA104A-E258-436B-9252-8DB0DF014D47}"/>
               </a:ext>
             </a:extLst>
           </p:cNvPr>
@@ -11878,7 +11878,7 @@
           <p:cNvPr id="45" name="">
             <a:extLst xmlns:a="http://schemas.openxmlformats.org/drawingml/2006/main">
               <a:ext uri="{FF2B5EF4-FFF2-40B4-BE49-F238E27FC236}">
-                <a16:creationId xmlns:a16="http://schemas.microsoft.com/office/drawing/2014/main" id="{A2D1BE9C-B995-45F9-85A0-B355FE6B0028}"/>
+                <a16:creationId xmlns:a16="http://schemas.microsoft.com/office/drawing/2014/main" id="{A8F6B8C9-DA74-460A-A58C-ED6BA262C57F}"/>
               </a:ext>
             </a:extLst>
           </p:cNvPr>
@@ -11908,7 +11908,7 @@
           <p:cNvPr id="46" name="">
             <a:extLst xmlns:a="http://schemas.openxmlformats.org/drawingml/2006/main">
               <a:ext uri="{FF2B5EF4-FFF2-40B4-BE49-F238E27FC236}">
-                <a16:creationId xmlns:a16="http://schemas.microsoft.com/office/drawing/2014/main" id="{00FA9953-B804-41B2-9962-AC2F9B951910}"/>
+                <a16:creationId xmlns:a16="http://schemas.microsoft.com/office/drawing/2014/main" id="{C25B5AED-E9EA-4A1F-B379-8ACF5AA5D061}"/>
               </a:ext>
             </a:extLst>
           </p:cNvPr>
@@ -11939,7 +11939,7 @@
           <p:cNvPr id="47" name="">
             <a:extLst xmlns:a="http://schemas.openxmlformats.org/drawingml/2006/main">
               <a:ext uri="{FF2B5EF4-FFF2-40B4-BE49-F238E27FC236}">
-                <a16:creationId xmlns:a16="http://schemas.microsoft.com/office/drawing/2014/main" id="{126A376D-6DA6-4138-8E0C-CEA1976C0C1B}"/>
+                <a16:creationId xmlns:a16="http://schemas.microsoft.com/office/drawing/2014/main" id="{AC857804-FEF3-4F08-B0D4-F62CA1CF6CF3}"/>
               </a:ext>
             </a:extLst>
           </p:cNvPr>
@@ -11970,7 +11970,7 @@
           <p:cNvPr id="48" name="">
             <a:extLst xmlns:a="http://schemas.openxmlformats.org/drawingml/2006/main">
               <a:ext uri="{FF2B5EF4-FFF2-40B4-BE49-F238E27FC236}">
-                <a16:creationId xmlns:a16="http://schemas.microsoft.com/office/drawing/2014/main" id="{BB80F20D-1B33-4B5B-9844-284E9642BEBE}"/>
+                <a16:creationId xmlns:a16="http://schemas.microsoft.com/office/drawing/2014/main" id="{0AC3B10F-F4C1-4649-8953-AD252F71D88F}"/>
               </a:ext>
             </a:extLst>
           </p:cNvPr>
@@ -12001,7 +12001,7 @@
           <p:cNvPr id="49" name="">
             <a:extLst xmlns:a="http://schemas.openxmlformats.org/drawingml/2006/main">
               <a:ext uri="{FF2B5EF4-FFF2-40B4-BE49-F238E27FC236}">
-                <a16:creationId xmlns:a16="http://schemas.microsoft.com/office/drawing/2014/main" id="{16973979-891E-4FFB-87F3-34E3E73D70B4}"/>
+                <a16:creationId xmlns:a16="http://schemas.microsoft.com/office/drawing/2014/main" id="{9C04E42F-3940-4231-BECE-EC65BEA6A0E4}"/>
               </a:ext>
             </a:extLst>
           </p:cNvPr>
@@ -12032,7 +12032,7 @@
           <p:cNvPr id="50" name="">
             <a:extLst xmlns:a="http://schemas.openxmlformats.org/drawingml/2006/main">
               <a:ext uri="{FF2B5EF4-FFF2-40B4-BE49-F238E27FC236}">
-                <a16:creationId xmlns:a16="http://schemas.microsoft.com/office/drawing/2014/main" id="{C1BB6F5C-6BE8-4975-B331-2AD278821A45}"/>
+                <a16:creationId xmlns:a16="http://schemas.microsoft.com/office/drawing/2014/main" id="{72795BBC-6D12-41A3-92ED-FCF13EF60E77}"/>
               </a:ext>
             </a:extLst>
           </p:cNvPr>
@@ -12063,7 +12063,7 @@
           <p:cNvPr id="51" name="">
             <a:extLst xmlns:a="http://schemas.openxmlformats.org/drawingml/2006/main">
               <a:ext uri="{FF2B5EF4-FFF2-40B4-BE49-F238E27FC236}">
-                <a16:creationId xmlns:a16="http://schemas.microsoft.com/office/drawing/2014/main" id="{F4618585-2127-434C-888A-96FA5221FABA}"/>
+                <a16:creationId xmlns:a16="http://schemas.microsoft.com/office/drawing/2014/main" id="{D6DCBC04-0E1B-4E64-9489-E8D668307562}"/>
               </a:ext>
             </a:extLst>
           </p:cNvPr>
@@ -12093,7 +12093,7 @@
           <p:cNvPr id="52" name="">
             <a:extLst xmlns:a="http://schemas.openxmlformats.org/drawingml/2006/main">
               <a:ext uri="{FF2B5EF4-FFF2-40B4-BE49-F238E27FC236}">
-                <a16:creationId xmlns:a16="http://schemas.microsoft.com/office/drawing/2014/main" id="{117FAC9A-C029-4197-A3EB-1EA2600D3369}"/>
+                <a16:creationId xmlns:a16="http://schemas.microsoft.com/office/drawing/2014/main" id="{9DA34BC3-CEAC-464A-9FC2-92530DEF0D0E}"/>
               </a:ext>
             </a:extLst>
           </p:cNvPr>
@@ -12124,7 +12124,7 @@
           <p:cNvPr id="53" name="">
             <a:extLst xmlns:a="http://schemas.openxmlformats.org/drawingml/2006/main">
               <a:ext uri="{FF2B5EF4-FFF2-40B4-BE49-F238E27FC236}">
-                <a16:creationId xmlns:a16="http://schemas.microsoft.com/office/drawing/2014/main" id="{10870B03-D571-41C5-82A5-7B630C49CE30}"/>
+                <a16:creationId xmlns:a16="http://schemas.microsoft.com/office/drawing/2014/main" id="{FF04586E-AEBB-4F8E-B9B7-3272F7D33D6E}"/>
               </a:ext>
             </a:extLst>
           </p:cNvPr>
@@ -12155,7 +12155,7 @@
           <p:cNvPr id="54" name="">
             <a:extLst xmlns:a="http://schemas.openxmlformats.org/drawingml/2006/main">
               <a:ext uri="{FF2B5EF4-FFF2-40B4-BE49-F238E27FC236}">
-                <a16:creationId xmlns:a16="http://schemas.microsoft.com/office/drawing/2014/main" id="{374F9D00-9D7D-4E0F-8D1F-737303EC41EE}"/>
+                <a16:creationId xmlns:a16="http://schemas.microsoft.com/office/drawing/2014/main" id="{0D8EA713-106A-4334-8811-8B072288F955}"/>
               </a:ext>
             </a:extLst>
           </p:cNvPr>
@@ -12186,7 +12186,7 @@
           <p:cNvPr id="55" name="">
             <a:extLst xmlns:a="http://schemas.openxmlformats.org/drawingml/2006/main">
               <a:ext uri="{FF2B5EF4-FFF2-40B4-BE49-F238E27FC236}">
-                <a16:creationId xmlns:a16="http://schemas.microsoft.com/office/drawing/2014/main" id="{0DCF7844-36EF-45DF-AC9D-66D146D57170}"/>
+                <a16:creationId xmlns:a16="http://schemas.microsoft.com/office/drawing/2014/main" id="{17A56523-6FB0-4B3E-91CC-49A635C0B849}"/>
               </a:ext>
             </a:extLst>
           </p:cNvPr>
@@ -12217,7 +12217,7 @@
           <p:cNvPr id="56" name="">
             <a:extLst xmlns:a="http://schemas.openxmlformats.org/drawingml/2006/main">
               <a:ext uri="{FF2B5EF4-FFF2-40B4-BE49-F238E27FC236}">
-                <a16:creationId xmlns:a16="http://schemas.microsoft.com/office/drawing/2014/main" id="{BFAA720B-7439-43B5-A9B9-B52646AFDE1F}"/>
+                <a16:creationId xmlns:a16="http://schemas.microsoft.com/office/drawing/2014/main" id="{5D4B71EB-1164-4983-B230-9C614633C0F0}"/>
               </a:ext>
             </a:extLst>
           </p:cNvPr>
@@ -12248,7 +12248,7 @@
           <p:cNvPr id="57" name="">
             <a:extLst xmlns:a="http://schemas.openxmlformats.org/drawingml/2006/main">
               <a:ext uri="{FF2B5EF4-FFF2-40B4-BE49-F238E27FC236}">
-                <a16:creationId xmlns:a16="http://schemas.microsoft.com/office/drawing/2014/main" id="{1B98CFA3-268A-4DB7-A30F-04EFE99D541C}"/>
+                <a16:creationId xmlns:a16="http://schemas.microsoft.com/office/drawing/2014/main" id="{931F18F9-C437-458C-9FFF-84B92DB39672}"/>
               </a:ext>
             </a:extLst>
           </p:cNvPr>
@@ -12279,7 +12279,7 @@
           <p:cNvPr id="58" name="?">
             <a:extLst xmlns:a="http://schemas.openxmlformats.org/drawingml/2006/main">
               <a:ext uri="{FF2B5EF4-FFF2-40B4-BE49-F238E27FC236}">
-                <a16:creationId xmlns:a16="http://schemas.microsoft.com/office/drawing/2014/main" id="{F6D09D70-F51A-446F-A944-F566446FA279}"/>
+                <a16:creationId xmlns:a16="http://schemas.microsoft.com/office/drawing/2014/main" id="{67315D5F-1AAE-4FF3-A8AA-01DB38DF4790}"/>
               </a:ext>
             </a:extLst>
           </p:cNvPr>
@@ -12437,7 +12437,7 @@
           <p:cNvPr id="59" name="지금 이 저장소에 어떤 일을 맡기고 싶으신가요?">
             <a:extLst xmlns:a="http://schemas.openxmlformats.org/drawingml/2006/main">
               <a:ext uri="{FF2B5EF4-FFF2-40B4-BE49-F238E27FC236}">
-                <a16:creationId xmlns:a16="http://schemas.microsoft.com/office/drawing/2014/main" id="{702444B2-E698-4FBE-8FED-B9F19FBA1466}"/>
+                <a16:creationId xmlns:a16="http://schemas.microsoft.com/office/drawing/2014/main" id="{EE9BC914-10BC-471F-81F9-24F02AC43A3E}"/>
               </a:ext>
             </a:extLst>
           </p:cNvPr>
@@ -12595,7 +12595,7 @@
           <p:cNvPr id="60" name="그 원하는 결과까지 코드에 적혀 있을까요?">
             <a:extLst xmlns:a="http://schemas.openxmlformats.org/drawingml/2006/main">
               <a:ext uri="{FF2B5EF4-FFF2-40B4-BE49-F238E27FC236}">
-                <a16:creationId xmlns:a16="http://schemas.microsoft.com/office/drawing/2014/main" id="{958D9EF8-A678-4178-934D-65408DD135AF}"/>
+                <a16:creationId xmlns:a16="http://schemas.microsoft.com/office/drawing/2014/main" id="{505FE0A6-6FD7-448F-A435-0E6B15064BF2}"/>
               </a:ext>
             </a:extLst>
           </p:cNvPr>
@@ -12753,7 +12753,7 @@
           <p:cNvPr id="61" name="Legacy module connection">
             <a:extLst xmlns:a="http://schemas.openxmlformats.org/drawingml/2006/main">
               <a:ext uri="{FF2B5EF4-FFF2-40B4-BE49-F238E27FC236}">
-                <a16:creationId xmlns:a16="http://schemas.microsoft.com/office/drawing/2014/main" id="{964CA0D2-A223-47BD-87ED-9AA788B0231E}"/>
+                <a16:creationId xmlns:a16="http://schemas.microsoft.com/office/drawing/2014/main" id="{9AE9B55F-C2E8-4C47-9299-9E7224BC5599}"/>
               </a:ext>
             </a:extLst>
           </p:cNvPr>
@@ -12909,7 +12909,7 @@
     </p:spTree>
     <p:extLst>
       <p:ext uri="{BB962C8B-B14F-4D97-AF65-F5344CB8AC3E}">
-        <p14:creationId xmlns:p14="http://schemas.microsoft.com/office/powerpoint/2010/main" val="438720705"/>
+        <p14:creationId xmlns:p14="http://schemas.microsoft.com/office/powerpoint/2010/main" val="1652702882"/>
       </p:ext>
     </p:extLst>
   </p:cSld>
@@ -12940,7 +12940,7 @@
           <p:cNvPr id="39" name="ACT 0 · 혼동하기 쉬운 C++ 초기화">
             <a:extLst xmlns:a="http://schemas.openxmlformats.org/drawingml/2006/main">
               <a:ext uri="{FF2B5EF4-FFF2-40B4-BE49-F238E27FC236}">
-                <a16:creationId xmlns:a16="http://schemas.microsoft.com/office/drawing/2014/main" id="{F7DF16A5-0B3F-4246-9E06-0AC267644240}"/>
+                <a16:creationId xmlns:a16="http://schemas.microsoft.com/office/drawing/2014/main" id="{E7C4D560-007C-44BD-95A0-2FBB2D36BF45}"/>
               </a:ext>
             </a:extLst>
           </p:cNvPr>
@@ -13098,7 +13098,7 @@
           <p:cNvPr id="2" name="S02">
             <a:extLst xmlns:a="http://schemas.openxmlformats.org/drawingml/2006/main">
               <a:ext uri="{FF2B5EF4-FFF2-40B4-BE49-F238E27FC236}">
-                <a16:creationId xmlns:a16="http://schemas.microsoft.com/office/drawing/2014/main" id="{FEC1E5DF-9B12-4AB2-9FF8-EE7D260DA87D}"/>
+                <a16:creationId xmlns:a16="http://schemas.microsoft.com/office/drawing/2014/main" id="{A28DB6C9-232A-44DA-BDF6-533E89CD6173}"/>
               </a:ext>
             </a:extLst>
           </p:cNvPr>
@@ -13256,7 +13256,7 @@
           <p:cNvPr id="3" name="작은 질문에는 Chatbot이 유용하다">
             <a:extLst xmlns:a="http://schemas.openxmlformats.org/drawingml/2006/main">
               <a:ext uri="{FF2B5EF4-FFF2-40B4-BE49-F238E27FC236}">
-                <a16:creationId xmlns:a16="http://schemas.microsoft.com/office/drawing/2014/main" id="{956E677D-AFED-4DAC-80D4-C75C2F1AD211}"/>
+                <a16:creationId xmlns:a16="http://schemas.microsoft.com/office/drawing/2014/main" id="{74227F49-691E-4786-88C4-ADB825F5A63A}"/>
               </a:ext>
             </a:extLst>
           </p:cNvPr>
@@ -13414,7 +13414,7 @@
           <p:cNvPr id="4" name="">
             <a:extLst xmlns:a="http://schemas.openxmlformats.org/drawingml/2006/main">
               <a:ext uri="{FF2B5EF4-FFF2-40B4-BE49-F238E27FC236}">
-                <a16:creationId xmlns:a16="http://schemas.microsoft.com/office/drawing/2014/main" id="{DB03FC7C-3571-4268-A81B-6FA45C278369}"/>
+                <a16:creationId xmlns:a16="http://schemas.microsoft.com/office/drawing/2014/main" id="{66A28079-39F0-47CA-9CA0-57188040ABA4}"/>
               </a:ext>
             </a:extLst>
           </p:cNvPr>
@@ -13445,7 +13445,7 @@
           <p:cNvPr id="5" name="Microsoft C++ 문서 기반 교육 예시 · 실제 ChatGPT 대화·실행 화면 아님">
             <a:extLst xmlns:a="http://schemas.openxmlformats.org/drawingml/2006/main">
               <a:ext uri="{FF2B5EF4-FFF2-40B4-BE49-F238E27FC236}">
-                <a16:creationId xmlns:a16="http://schemas.microsoft.com/office/drawing/2014/main" id="{9EA10140-AAF0-49EE-8D8A-E63F4619F932}"/>
+                <a16:creationId xmlns:a16="http://schemas.microsoft.com/office/drawing/2014/main" id="{BF197D97-3E59-4528-B447-C7377EDF6079}"/>
               </a:ext>
             </a:extLst>
           </p:cNvPr>
@@ -13603,7 +13603,7 @@
           <p:cNvPr id="6" name="괄호는 개수·값 생성자, 중괄호는 이 예시의 initializer_list 생성자를 사용합니다.">
             <a:extLst xmlns:a="http://schemas.openxmlformats.org/drawingml/2006/main">
               <a:ext uri="{FF2B5EF4-FFF2-40B4-BE49-F238E27FC236}">
-                <a16:creationId xmlns:a16="http://schemas.microsoft.com/office/drawing/2014/main" id="{B451C5C7-8522-4F4D-A130-F4E4187410E7}"/>
+                <a16:creationId xmlns:a16="http://schemas.microsoft.com/office/drawing/2014/main" id="{695889E9-4A11-4143-A065-DC2CAF84621B}"/>
               </a:ext>
             </a:extLst>
           </p:cNvPr>
@@ -13761,7 +13761,7 @@
           <p:cNvPr id="7" name="괄호만 바뀌었는데, 같은 Vector일까?">
             <a:extLst xmlns:a="http://schemas.openxmlformats.org/drawingml/2006/main">
               <a:ext uri="{FF2B5EF4-FFF2-40B4-BE49-F238E27FC236}">
-                <a16:creationId xmlns:a16="http://schemas.microsoft.com/office/drawing/2014/main" id="{0EEA73EB-F935-43EC-AEA9-855FDC2DA90C}"/>
+                <a16:creationId xmlns:a16="http://schemas.microsoft.com/office/drawing/2014/main" id="{C54CD5F5-51B1-4A03-BAE6-DF7298BD4712}"/>
               </a:ext>
             </a:extLst>
           </p:cNvPr>
@@ -13919,7 +13919,7 @@
           <p:cNvPr id="8" name="">
             <a:extLst xmlns:a="http://schemas.openxmlformats.org/drawingml/2006/main">
               <a:ext uri="{FF2B5EF4-FFF2-40B4-BE49-F238E27FC236}">
-                <a16:creationId xmlns:a16="http://schemas.microsoft.com/office/drawing/2014/main" id="{950C06F1-BAA5-44BE-A4E0-F76ABAABCB34}"/>
+                <a16:creationId xmlns:a16="http://schemas.microsoft.com/office/drawing/2014/main" id="{2D100C14-0FF8-411D-AD50-6A31B1F85420}"/>
               </a:ext>
             </a:extLst>
           </p:cNvPr>
@@ -13950,7 +13950,7 @@
           <p:cNvPr id="9" name="std::vector&lt;int&gt; a(3, 1);">
             <a:extLst xmlns:a="http://schemas.openxmlformats.org/drawingml/2006/main">
               <a:ext uri="{FF2B5EF4-FFF2-40B4-BE49-F238E27FC236}">
-                <a16:creationId xmlns:a16="http://schemas.microsoft.com/office/drawing/2014/main" id="{91EE8607-D8E5-4C18-9A16-238FD196970F}"/>
+                <a16:creationId xmlns:a16="http://schemas.microsoft.com/office/drawing/2014/main" id="{542CC1E4-25C8-409A-9CE9-5706C38F2109}"/>
               </a:ext>
             </a:extLst>
           </p:cNvPr>
@@ -14108,7 +14108,7 @@
           <p:cNvPr id="10" name="">
             <a:extLst xmlns:a="http://schemas.openxmlformats.org/drawingml/2006/main">
               <a:ext uri="{FF2B5EF4-FFF2-40B4-BE49-F238E27FC236}">
-                <a16:creationId xmlns:a16="http://schemas.microsoft.com/office/drawing/2014/main" id="{29414C1A-E9F8-47E2-8F46-D1B5FBA5F872}"/>
+                <a16:creationId xmlns:a16="http://schemas.microsoft.com/office/drawing/2014/main" id="{F8E5D9A0-444C-4E9E-A5BC-6207AAD56B38}"/>
               </a:ext>
             </a:extLst>
           </p:cNvPr>
@@ -14138,7 +14138,7 @@
           <p:cNvPr id="11" name="">
             <a:extLst xmlns:a="http://schemas.openxmlformats.org/drawingml/2006/main">
               <a:ext uri="{FF2B5EF4-FFF2-40B4-BE49-F238E27FC236}">
-                <a16:creationId xmlns:a16="http://schemas.microsoft.com/office/drawing/2014/main" id="{01F92893-0C74-42E4-8765-7FB0E3F415A8}"/>
+                <a16:creationId xmlns:a16="http://schemas.microsoft.com/office/drawing/2014/main" id="{B1BC83CC-B84F-4BC9-9C58-EB7CBF9201FD}"/>
               </a:ext>
             </a:extLst>
           </p:cNvPr>
@@ -14171,7 +14171,7 @@
           <p:cNvPr id="12" name="1">
             <a:extLst xmlns:a="http://schemas.openxmlformats.org/drawingml/2006/main">
               <a:ext uri="{FF2B5EF4-FFF2-40B4-BE49-F238E27FC236}">
-                <a16:creationId xmlns:a16="http://schemas.microsoft.com/office/drawing/2014/main" id="{FE51E0F0-4B26-463A-8D33-41576F036B29}"/>
+                <a16:creationId xmlns:a16="http://schemas.microsoft.com/office/drawing/2014/main" id="{5C3F25C9-FA22-4E3F-8AEF-BDC231EE8B62}"/>
               </a:ext>
             </a:extLst>
           </p:cNvPr>
@@ -14329,7 +14329,7 @@
           <p:cNvPr id="13" name="">
             <a:extLst xmlns:a="http://schemas.openxmlformats.org/drawingml/2006/main">
               <a:ext uri="{FF2B5EF4-FFF2-40B4-BE49-F238E27FC236}">
-                <a16:creationId xmlns:a16="http://schemas.microsoft.com/office/drawing/2014/main" id="{CF44E809-3DC6-4393-8987-2F77A5FBE978}"/>
+                <a16:creationId xmlns:a16="http://schemas.microsoft.com/office/drawing/2014/main" id="{DD14CCDA-4A9F-4E26-87EE-7EB034DBAAE0}"/>
               </a:ext>
             </a:extLst>
           </p:cNvPr>
@@ -14362,7 +14362,7 @@
           <p:cNvPr id="14" name="1">
             <a:extLst xmlns:a="http://schemas.openxmlformats.org/drawingml/2006/main">
               <a:ext uri="{FF2B5EF4-FFF2-40B4-BE49-F238E27FC236}">
-                <a16:creationId xmlns:a16="http://schemas.microsoft.com/office/drawing/2014/main" id="{06DA1528-C005-4DBB-A3E3-EB99BEF8426A}"/>
+                <a16:creationId xmlns:a16="http://schemas.microsoft.com/office/drawing/2014/main" id="{BA186E4C-EC55-4232-AF25-7E652DAA8D25}"/>
               </a:ext>
             </a:extLst>
           </p:cNvPr>
@@ -14520,7 +14520,7 @@
           <p:cNvPr id="15" name="">
             <a:extLst xmlns:a="http://schemas.openxmlformats.org/drawingml/2006/main">
               <a:ext uri="{FF2B5EF4-FFF2-40B4-BE49-F238E27FC236}">
-                <a16:creationId xmlns:a16="http://schemas.microsoft.com/office/drawing/2014/main" id="{FA9B90AD-4586-4098-9D48-AC6EE24AC87C}"/>
+                <a16:creationId xmlns:a16="http://schemas.microsoft.com/office/drawing/2014/main" id="{D5ACEA9F-AC79-4F4F-B0B3-02E10BEF7C19}"/>
               </a:ext>
             </a:extLst>
           </p:cNvPr>
@@ -14553,7 +14553,7 @@
           <p:cNvPr id="16" name="1">
             <a:extLst xmlns:a="http://schemas.openxmlformats.org/drawingml/2006/main">
               <a:ext uri="{FF2B5EF4-FFF2-40B4-BE49-F238E27FC236}">
-                <a16:creationId xmlns:a16="http://schemas.microsoft.com/office/drawing/2014/main" id="{C1CB7B67-2E5C-49E8-9E72-C6F0B994C298}"/>
+                <a16:creationId xmlns:a16="http://schemas.microsoft.com/office/drawing/2014/main" id="{9FF9E4F4-52E6-41B6-9C50-2C8D3F7BA7DB}"/>
               </a:ext>
             </a:extLst>
           </p:cNvPr>
@@ -14711,7 +14711,7 @@
           <p:cNvPr id="17" name="3개">
             <a:extLst xmlns:a="http://schemas.openxmlformats.org/drawingml/2006/main">
               <a:ext uri="{FF2B5EF4-FFF2-40B4-BE49-F238E27FC236}">
-                <a16:creationId xmlns:a16="http://schemas.microsoft.com/office/drawing/2014/main" id="{221ECE66-96C3-4828-BCF4-D75F6AEF4EAF}"/>
+                <a16:creationId xmlns:a16="http://schemas.microsoft.com/office/drawing/2014/main" id="{4D71D1A4-2A48-4E98-9701-F29F1A0E803C}"/>
               </a:ext>
             </a:extLst>
           </p:cNvPr>
@@ -14869,7 +14869,7 @@
           <p:cNvPr id="18" name="">
             <a:extLst xmlns:a="http://schemas.openxmlformats.org/drawingml/2006/main">
               <a:ext uri="{FF2B5EF4-FFF2-40B4-BE49-F238E27FC236}">
-                <a16:creationId xmlns:a16="http://schemas.microsoft.com/office/drawing/2014/main" id="{C1DAB3FF-50B7-4DE5-B371-1D0B8791E3BB}"/>
+                <a16:creationId xmlns:a16="http://schemas.microsoft.com/office/drawing/2014/main" id="{555E6C16-7A99-4243-AB60-8CFB874F1F37}"/>
               </a:ext>
             </a:extLst>
           </p:cNvPr>
@@ -14900,7 +14900,7 @@
           <p:cNvPr id="19" name="std::vector&lt;int&gt; b{3, 1};">
             <a:extLst xmlns:a="http://schemas.openxmlformats.org/drawingml/2006/main">
               <a:ext uri="{FF2B5EF4-FFF2-40B4-BE49-F238E27FC236}">
-                <a16:creationId xmlns:a16="http://schemas.microsoft.com/office/drawing/2014/main" id="{06EA873B-EF83-4538-9154-F5DF9ABAB1D4}"/>
+                <a16:creationId xmlns:a16="http://schemas.microsoft.com/office/drawing/2014/main" id="{8054FB06-6159-4A22-B91F-C610A57E867F}"/>
               </a:ext>
             </a:extLst>
           </p:cNvPr>
@@ -15058,7 +15058,7 @@
           <p:cNvPr id="20" name="">
             <a:extLst xmlns:a="http://schemas.openxmlformats.org/drawingml/2006/main">
               <a:ext uri="{FF2B5EF4-FFF2-40B4-BE49-F238E27FC236}">
-                <a16:creationId xmlns:a16="http://schemas.microsoft.com/office/drawing/2014/main" id="{81357C4F-4C44-4E15-B24C-E4D248A2BAB7}"/>
+                <a16:creationId xmlns:a16="http://schemas.microsoft.com/office/drawing/2014/main" id="{FDC07E7B-9C91-4459-A0AB-50D979A9DAD3}"/>
               </a:ext>
             </a:extLst>
           </p:cNvPr>
@@ -15088,7 +15088,7 @@
           <p:cNvPr id="21" name="">
             <a:extLst xmlns:a="http://schemas.openxmlformats.org/drawingml/2006/main">
               <a:ext uri="{FF2B5EF4-FFF2-40B4-BE49-F238E27FC236}">
-                <a16:creationId xmlns:a16="http://schemas.microsoft.com/office/drawing/2014/main" id="{B5F9FAB3-122D-4799-B56D-B730C08D363F}"/>
+                <a16:creationId xmlns:a16="http://schemas.microsoft.com/office/drawing/2014/main" id="{ACA1F68D-C575-49F8-A8CC-3EAFF47F058C}"/>
               </a:ext>
             </a:extLst>
           </p:cNvPr>
@@ -15121,7 +15121,7 @@
           <p:cNvPr id="22" name="3">
             <a:extLst xmlns:a="http://schemas.openxmlformats.org/drawingml/2006/main">
               <a:ext uri="{FF2B5EF4-FFF2-40B4-BE49-F238E27FC236}">
-                <a16:creationId xmlns:a16="http://schemas.microsoft.com/office/drawing/2014/main" id="{9CCCDE2D-1714-4F7E-A915-89664E4669A4}"/>
+                <a16:creationId xmlns:a16="http://schemas.microsoft.com/office/drawing/2014/main" id="{7EA0474F-585F-458F-BD07-DF58F20E50CA}"/>
               </a:ext>
             </a:extLst>
           </p:cNvPr>
@@ -15279,7 +15279,7 @@
           <p:cNvPr id="23" name="">
             <a:extLst xmlns:a="http://schemas.openxmlformats.org/drawingml/2006/main">
               <a:ext uri="{FF2B5EF4-FFF2-40B4-BE49-F238E27FC236}">
-                <a16:creationId xmlns:a16="http://schemas.microsoft.com/office/drawing/2014/main" id="{5A71DB17-9FD4-465E-89E6-94F23A8BC312}"/>
+                <a16:creationId xmlns:a16="http://schemas.microsoft.com/office/drawing/2014/main" id="{75130F1E-1ACF-4E0E-AC82-9F535EB1D5F6}"/>
               </a:ext>
             </a:extLst>
           </p:cNvPr>
@@ -15312,7 +15312,7 @@
           <p:cNvPr id="24" name="1">
             <a:extLst xmlns:a="http://schemas.openxmlformats.org/drawingml/2006/main">
               <a:ext uri="{FF2B5EF4-FFF2-40B4-BE49-F238E27FC236}">
-                <a16:creationId xmlns:a16="http://schemas.microsoft.com/office/drawing/2014/main" id="{B6BEFC60-3713-40B7-9BA5-44847C8B1E7E}"/>
+                <a16:creationId xmlns:a16="http://schemas.microsoft.com/office/drawing/2014/main" id="{2B35E502-048D-43E2-A7BE-C055D848A561}"/>
               </a:ext>
             </a:extLst>
           </p:cNvPr>
@@ -15470,7 +15470,7 @@
           <p:cNvPr id="25" name="2개">
             <a:extLst xmlns:a="http://schemas.openxmlformats.org/drawingml/2006/main">
               <a:ext uri="{FF2B5EF4-FFF2-40B4-BE49-F238E27FC236}">
-                <a16:creationId xmlns:a16="http://schemas.microsoft.com/office/drawing/2014/main" id="{8D88B992-7CBE-41EF-952B-B70ACA490915}"/>
+                <a16:creationId xmlns:a16="http://schemas.microsoft.com/office/drawing/2014/main" id="{BA411FB1-7734-49AC-9734-834BCC44EDB3}"/>
               </a:ext>
             </a:extLst>
           </p:cNvPr>
@@ -15628,7 +15628,7 @@
           <p:cNvPr id="26" name="">
             <a:extLst xmlns:a="http://schemas.openxmlformats.org/drawingml/2006/main">
               <a:ext uri="{FF2B5EF4-FFF2-40B4-BE49-F238E27FC236}">
-                <a16:creationId xmlns:a16="http://schemas.microsoft.com/office/drawing/2014/main" id="{2B888D21-8B71-4ECD-A805-06870BA03129}"/>
+                <a16:creationId xmlns:a16="http://schemas.microsoft.com/office/drawing/2014/main" id="{E0B0FC56-ED99-4E3B-AA00-D56F48A43F34}"/>
               </a:ext>
             </a:extLst>
           </p:cNvPr>
@@ -15661,7 +15661,7 @@
           <p:cNvPr id="27" name="IDE">
             <a:extLst xmlns:a="http://schemas.openxmlformats.org/drawingml/2006/main">
               <a:ext uri="{FF2B5EF4-FFF2-40B4-BE49-F238E27FC236}">
-                <a16:creationId xmlns:a16="http://schemas.microsoft.com/office/drawing/2014/main" id="{87264392-3F92-4631-96B1-E715D57A0613}"/>
+                <a16:creationId xmlns:a16="http://schemas.microsoft.com/office/drawing/2014/main" id="{F42A61CC-C3CC-44DB-8D8D-C36FCA361C6C}"/>
               </a:ext>
             </a:extLst>
           </p:cNvPr>
@@ -15819,7 +15819,7 @@
           <p:cNvPr id="28" name="코드 선택·복사">
             <a:extLst xmlns:a="http://schemas.openxmlformats.org/drawingml/2006/main">
               <a:ext uri="{FF2B5EF4-FFF2-40B4-BE49-F238E27FC236}">
-                <a16:creationId xmlns:a16="http://schemas.microsoft.com/office/drawing/2014/main" id="{65A7C16F-05E0-41C0-832C-B8374F750F88}"/>
+                <a16:creationId xmlns:a16="http://schemas.microsoft.com/office/drawing/2014/main" id="{6CF7DA55-F27B-4E3C-85A1-72403B48086C}"/>
               </a:ext>
             </a:extLst>
           </p:cNvPr>
@@ -15977,7 +15977,7 @@
           <p:cNvPr id="29" name="">
             <a:extLst xmlns:a="http://schemas.openxmlformats.org/drawingml/2006/main">
               <a:ext uri="{FF2B5EF4-FFF2-40B4-BE49-F238E27FC236}">
-                <a16:creationId xmlns:a16="http://schemas.microsoft.com/office/drawing/2014/main" id="{4ECC28EB-73CA-48F7-9945-049034661056}"/>
+                <a16:creationId xmlns:a16="http://schemas.microsoft.com/office/drawing/2014/main" id="{9DC77F6E-DF38-4ED2-B89A-0C0CB4B3E08A}"/>
               </a:ext>
             </a:extLst>
           </p:cNvPr>
@@ -16010,7 +16010,7 @@
           <p:cNvPr id="30" name="Chatbot">
             <a:extLst xmlns:a="http://schemas.openxmlformats.org/drawingml/2006/main">
               <a:ext uri="{FF2B5EF4-FFF2-40B4-BE49-F238E27FC236}">
-                <a16:creationId xmlns:a16="http://schemas.microsoft.com/office/drawing/2014/main" id="{C88A1F7C-8DE9-433F-8653-5BFE7ECA9CB2}"/>
+                <a16:creationId xmlns:a16="http://schemas.microsoft.com/office/drawing/2014/main" id="{D0D42039-7748-4363-B42A-A90F6D3F6668}"/>
               </a:ext>
             </a:extLst>
           </p:cNvPr>
@@ -16168,7 +16168,7 @@
           <p:cNvPr id="31" name="붙여넣고 질문">
             <a:extLst xmlns:a="http://schemas.openxmlformats.org/drawingml/2006/main">
               <a:ext uri="{FF2B5EF4-FFF2-40B4-BE49-F238E27FC236}">
-                <a16:creationId xmlns:a16="http://schemas.microsoft.com/office/drawing/2014/main" id="{7CE5B206-3AEC-4342-8167-4D6675063A93}"/>
+                <a16:creationId xmlns:a16="http://schemas.microsoft.com/office/drawing/2014/main" id="{A5311214-9858-4DA3-8579-6C6B21D9754E}"/>
               </a:ext>
             </a:extLst>
           </p:cNvPr>
@@ -16326,7 +16326,7 @@
           <p:cNvPr id="32" name="">
             <a:extLst xmlns:a="http://schemas.openxmlformats.org/drawingml/2006/main">
               <a:ext uri="{FF2B5EF4-FFF2-40B4-BE49-F238E27FC236}">
-                <a16:creationId xmlns:a16="http://schemas.microsoft.com/office/drawing/2014/main" id="{D6181BCD-7DC2-4A20-833D-FC58DA9EC013}"/>
+                <a16:creationId xmlns:a16="http://schemas.microsoft.com/office/drawing/2014/main" id="{0D2257B4-1EF0-4104-9722-46C3F56757F3}"/>
               </a:ext>
             </a:extLst>
           </p:cNvPr>
@@ -16359,7 +16359,7 @@
           <p:cNvPr id="33" name="IDE">
             <a:extLst xmlns:a="http://schemas.openxmlformats.org/drawingml/2006/main">
               <a:ext uri="{FF2B5EF4-FFF2-40B4-BE49-F238E27FC236}">
-                <a16:creationId xmlns:a16="http://schemas.microsoft.com/office/drawing/2014/main" id="{17030D43-726B-4B26-8639-7C268C22B9CD}"/>
+                <a16:creationId xmlns:a16="http://schemas.microsoft.com/office/drawing/2014/main" id="{65D67679-5325-4D7F-B074-21A3FEE3B839}"/>
               </a:ext>
             </a:extLst>
           </p:cNvPr>
@@ -16517,7 +16517,7 @@
           <p:cNvPr id="34" name="답 확인·적용">
             <a:extLst xmlns:a="http://schemas.openxmlformats.org/drawingml/2006/main">
               <a:ext uri="{FF2B5EF4-FFF2-40B4-BE49-F238E27FC236}">
-                <a16:creationId xmlns:a16="http://schemas.microsoft.com/office/drawing/2014/main" id="{C4072FCD-DBA3-4F4F-968C-832DC66F1342}"/>
+                <a16:creationId xmlns:a16="http://schemas.microsoft.com/office/drawing/2014/main" id="{987F23DC-E029-4C0B-BDAC-28D8C1FA5CE6}"/>
               </a:ext>
             </a:extLst>
           </p:cNvPr>
@@ -16675,7 +16675,7 @@
           <p:cNvPr id="35" name="">
             <a:extLst xmlns:a="http://schemas.openxmlformats.org/drawingml/2006/main">
               <a:ext uri="{FF2B5EF4-FFF2-40B4-BE49-F238E27FC236}">
-                <a16:creationId xmlns:a16="http://schemas.microsoft.com/office/drawing/2014/main" id="{9F47F7B9-372C-4244-B65F-934A5F6D31E8}"/>
+                <a16:creationId xmlns:a16="http://schemas.microsoft.com/office/drawing/2014/main" id="{4455F1D1-0103-4BCC-9C4F-373E4D19F8B5}"/>
               </a:ext>
             </a:extLst>
           </p:cNvPr>
@@ -16705,7 +16705,7 @@
           <p:cNvPr id="36" name="">
             <a:extLst xmlns:a="http://schemas.openxmlformats.org/drawingml/2006/main">
               <a:ext uri="{FF2B5EF4-FFF2-40B4-BE49-F238E27FC236}">
-                <a16:creationId xmlns:a16="http://schemas.microsoft.com/office/drawing/2014/main" id="{BA9380C6-057A-45B9-B9FD-60B77D5CBCC7}"/>
+                <a16:creationId xmlns:a16="http://schemas.microsoft.com/office/drawing/2014/main" id="{7596027D-51E5-4011-B748-63CDC9E8191B}"/>
               </a:ext>
             </a:extLst>
           </p:cNvPr>
@@ -16735,7 +16735,7 @@
           <p:cNvPr id="37" name="필요한 코드와 맥락을 사람이 골라 전달한다.">
             <a:extLst xmlns:a="http://schemas.openxmlformats.org/drawingml/2006/main">
               <a:ext uri="{FF2B5EF4-FFF2-40B4-BE49-F238E27FC236}">
-                <a16:creationId xmlns:a16="http://schemas.microsoft.com/office/drawing/2014/main" id="{3630A13C-7E88-43FC-814D-8C7FA64CC3D8}"/>
+                <a16:creationId xmlns:a16="http://schemas.microsoft.com/office/drawing/2014/main" id="{22F3FE67-FC3F-4CE3-A7E0-1BEB7EB37A36}"/>
               </a:ext>
             </a:extLst>
           </p:cNvPr>
@@ -16893,7 +16893,7 @@
           <p:cNvPr id="38" name="Legacy module connection">
             <a:extLst xmlns:a="http://schemas.openxmlformats.org/drawingml/2006/main">
               <a:ext uri="{FF2B5EF4-FFF2-40B4-BE49-F238E27FC236}">
-                <a16:creationId xmlns:a16="http://schemas.microsoft.com/office/drawing/2014/main" id="{890EA394-3F4E-4EE1-9ACD-0F265D6DC843}"/>
+                <a16:creationId xmlns:a16="http://schemas.microsoft.com/office/drawing/2014/main" id="{1EDC1405-F495-4236-B3CA-FCDD03EFC241}"/>
               </a:ext>
             </a:extLst>
           </p:cNvPr>
@@ -17049,7 +17049,7 @@
     </p:spTree>
     <p:extLst>
       <p:ext uri="{BB962C8B-B14F-4D97-AF65-F5344CB8AC3E}">
-        <p14:creationId xmlns:p14="http://schemas.microsoft.com/office/powerpoint/2010/main" val="258440049"/>
+        <p14:creationId xmlns:p14="http://schemas.microsoft.com/office/powerpoint/2010/main" val="945526523"/>
       </p:ext>
     </p:extLst>
   </p:cSld>
@@ -17080,7 +17080,7 @@
           <p:cNvPr id="34" name="ACT 0 · Visual Studio에서 디버깅할 때 살펴보던 정보">
             <a:extLst xmlns:a="http://schemas.openxmlformats.org/drawingml/2006/main">
               <a:ext uri="{FF2B5EF4-FFF2-40B4-BE49-F238E27FC236}">
-                <a16:creationId xmlns:a16="http://schemas.microsoft.com/office/drawing/2014/main" id="{7E80D56F-B434-4CB2-A526-724F9E98BB55}"/>
+                <a16:creationId xmlns:a16="http://schemas.microsoft.com/office/drawing/2014/main" id="{1C65D2C4-E563-44D0-8B84-7CB9F858265D}"/>
               </a:ext>
             </a:extLst>
           </p:cNvPr>
@@ -17238,7 +17238,7 @@
           <p:cNvPr id="2" name="S03">
             <a:extLst xmlns:a="http://schemas.openxmlformats.org/drawingml/2006/main">
               <a:ext uri="{FF2B5EF4-FFF2-40B4-BE49-F238E27FC236}">
-                <a16:creationId xmlns:a16="http://schemas.microsoft.com/office/drawing/2014/main" id="{C2FA008A-7721-4D42-B3E2-86996E56627E}"/>
+                <a16:creationId xmlns:a16="http://schemas.microsoft.com/office/drawing/2014/main" id="{CEF5DFD9-F843-4588-85C5-023233E05E77}"/>
               </a:ext>
             </a:extLst>
           </p:cNvPr>
@@ -17396,7 +17396,7 @@
           <p:cNvPr id="3" name="질문이 커지면 Context를 모으는 일이 생긴다">
             <a:extLst xmlns:a="http://schemas.openxmlformats.org/drawingml/2006/main">
               <a:ext uri="{FF2B5EF4-FFF2-40B4-BE49-F238E27FC236}">
-                <a16:creationId xmlns:a16="http://schemas.microsoft.com/office/drawing/2014/main" id="{BEE0C68C-DAA5-4BFA-97A8-E602439B48B3}"/>
+                <a16:creationId xmlns:a16="http://schemas.microsoft.com/office/drawing/2014/main" id="{097645AF-E60C-4113-AD44-27D26B004BFE}"/>
               </a:ext>
             </a:extLst>
           </p:cNvPr>
@@ -17554,7 +17554,7 @@
           <p:cNvPr id="4" name="">
             <a:extLst xmlns:a="http://schemas.openxmlformats.org/drawingml/2006/main">
               <a:ext uri="{FF2B5EF4-FFF2-40B4-BE49-F238E27FC236}">
-                <a16:creationId xmlns:a16="http://schemas.microsoft.com/office/drawing/2014/main" id="{E0A075C0-A062-45CB-BF53-52D2D5BDE013}"/>
+                <a16:creationId xmlns:a16="http://schemas.microsoft.com/office/drawing/2014/main" id="{A1D57FED-3B6A-4EDD-9BAD-646D802574C9}"/>
               </a:ext>
             </a:extLst>
           </p:cNvPr>
@@ -17585,7 +17585,7 @@
           <p:cNvPr id="5" name="Visual Studio 사용자의 디버깅 정보를 설명하는 교육용 병렬 도식">
             <a:extLst xmlns:a="http://schemas.openxmlformats.org/drawingml/2006/main">
               <a:ext uri="{FF2B5EF4-FFF2-40B4-BE49-F238E27FC236}">
-                <a16:creationId xmlns:a16="http://schemas.microsoft.com/office/drawing/2014/main" id="{5267E447-B7C3-4521-A98B-38D4BAAA59C3}"/>
+                <a16:creationId xmlns:a16="http://schemas.microsoft.com/office/drawing/2014/main" id="{D8E7B281-43D8-40B4-AAF0-898EE306B40D}"/>
               </a:ext>
             </a:extLst>
           </p:cNvPr>
@@ -17743,7 +17743,7 @@
           <p:cNvPr id="6" name="특정 Trial의 실제 화면이 아닙니다. 명세서는 IDE 밖에서도 함께 참고하는 문서입니다.">
             <a:extLst xmlns:a="http://schemas.openxmlformats.org/drawingml/2006/main">
               <a:ext uri="{FF2B5EF4-FFF2-40B4-BE49-F238E27FC236}">
-                <a16:creationId xmlns:a16="http://schemas.microsoft.com/office/drawing/2014/main" id="{1F6CE01D-4CB7-490A-9239-2D46933B78F3}"/>
+                <a16:creationId xmlns:a16="http://schemas.microsoft.com/office/drawing/2014/main" id="{DB2993D4-A091-4376-96BE-126E92A3871C}"/>
               </a:ext>
             </a:extLst>
           </p:cNvPr>
@@ -17901,7 +17901,7 @@
           <p:cNvPr id="7" name="“결과가 기대와 다르다” — 우리는 어디를 살펴볼까?">
             <a:extLst xmlns:a="http://schemas.openxmlformats.org/drawingml/2006/main">
               <a:ext uri="{FF2B5EF4-FFF2-40B4-BE49-F238E27FC236}">
-                <a16:creationId xmlns:a16="http://schemas.microsoft.com/office/drawing/2014/main" id="{8A1D2229-0159-44EC-B3EE-5D680783BBDC}"/>
+                <a16:creationId xmlns:a16="http://schemas.microsoft.com/office/drawing/2014/main" id="{12CA5012-57E0-4C6F-B6AE-FF1350721927}"/>
               </a:ext>
             </a:extLst>
           </p:cNvPr>
@@ -18059,7 +18059,7 @@
           <p:cNvPr id="8" name="">
             <a:extLst xmlns:a="http://schemas.openxmlformats.org/drawingml/2006/main">
               <a:ext uri="{FF2B5EF4-FFF2-40B4-BE49-F238E27FC236}">
-                <a16:creationId xmlns:a16="http://schemas.microsoft.com/office/drawing/2014/main" id="{435FFF8C-D2A2-4939-9C4C-62C56EE5A17A}"/>
+                <a16:creationId xmlns:a16="http://schemas.microsoft.com/office/drawing/2014/main" id="{BB1599F4-3696-4E94-B569-FE7F16B223DA}"/>
               </a:ext>
             </a:extLst>
           </p:cNvPr>
@@ -18092,7 +18092,7 @@
           <p:cNvPr id="9" name="테스트 탐색기">
             <a:extLst xmlns:a="http://schemas.openxmlformats.org/drawingml/2006/main">
               <a:ext uri="{FF2B5EF4-FFF2-40B4-BE49-F238E27FC236}">
-                <a16:creationId xmlns:a16="http://schemas.microsoft.com/office/drawing/2014/main" id="{4C0CF85D-4287-4725-98EF-ECB54B8E3D5D}"/>
+                <a16:creationId xmlns:a16="http://schemas.microsoft.com/office/drawing/2014/main" id="{755DB715-3A0E-4B49-9924-ABE272BD4EE2}"/>
               </a:ext>
             </a:extLst>
           </p:cNvPr>
@@ -18250,7 +18250,7 @@
           <p:cNvPr id="10" name="">
             <a:extLst xmlns:a="http://schemas.openxmlformats.org/drawingml/2006/main">
               <a:ext uri="{FF2B5EF4-FFF2-40B4-BE49-F238E27FC236}">
-                <a16:creationId xmlns:a16="http://schemas.microsoft.com/office/drawing/2014/main" id="{EECC26C0-FA8B-4467-90E4-F50C1ED36481}"/>
+                <a16:creationId xmlns:a16="http://schemas.microsoft.com/office/drawing/2014/main" id="{189B8389-9F0E-4D13-A771-138347AE6E39}"/>
               </a:ext>
             </a:extLst>
           </p:cNvPr>
@@ -18281,7 +18281,7 @@
           <p:cNvPr id="11" name="실패한 테스트&#10;기대값과 실제값">
             <a:extLst xmlns:a="http://schemas.openxmlformats.org/drawingml/2006/main">
               <a:ext uri="{FF2B5EF4-FFF2-40B4-BE49-F238E27FC236}">
-                <a16:creationId xmlns:a16="http://schemas.microsoft.com/office/drawing/2014/main" id="{A4C8533A-8E5C-49E4-9F39-97CFB44E3424}"/>
+                <a16:creationId xmlns:a16="http://schemas.microsoft.com/office/drawing/2014/main" id="{10EA7AD5-0037-4B29-A033-8034FF8A3777}"/>
               </a:ext>
             </a:extLst>
           </p:cNvPr>
@@ -18462,7 +18462,7 @@
           <p:cNvPr id="12" name="">
             <a:extLst xmlns:a="http://schemas.openxmlformats.org/drawingml/2006/main">
               <a:ext uri="{FF2B5EF4-FFF2-40B4-BE49-F238E27FC236}">
-                <a16:creationId xmlns:a16="http://schemas.microsoft.com/office/drawing/2014/main" id="{5B19FCFB-F056-4548-BA14-F5C00268BDDA}"/>
+                <a16:creationId xmlns:a16="http://schemas.microsoft.com/office/drawing/2014/main" id="{0D18839E-E881-45F8-B12D-2D7F36C320AE}"/>
               </a:ext>
             </a:extLst>
           </p:cNvPr>
@@ -18495,7 +18495,7 @@
           <p:cNvPr id="13" name="호출 스택">
             <a:extLst xmlns:a="http://schemas.openxmlformats.org/drawingml/2006/main">
               <a:ext uri="{FF2B5EF4-FFF2-40B4-BE49-F238E27FC236}">
-                <a16:creationId xmlns:a16="http://schemas.microsoft.com/office/drawing/2014/main" id="{ED264802-30E3-4BAD-AFA8-ECF1BDC178FD}"/>
+                <a16:creationId xmlns:a16="http://schemas.microsoft.com/office/drawing/2014/main" id="{97D4A88F-73B6-4B3B-B436-6FE74128E6F3}"/>
               </a:ext>
             </a:extLst>
           </p:cNvPr>
@@ -18653,7 +18653,7 @@
           <p:cNvPr id="14" name="">
             <a:extLst xmlns:a="http://schemas.openxmlformats.org/drawingml/2006/main">
               <a:ext uri="{FF2B5EF4-FFF2-40B4-BE49-F238E27FC236}">
-                <a16:creationId xmlns:a16="http://schemas.microsoft.com/office/drawing/2014/main" id="{016FB87A-14EF-49E3-8F4B-9705AB42A8D1}"/>
+                <a16:creationId xmlns:a16="http://schemas.microsoft.com/office/drawing/2014/main" id="{E2CCF500-A140-40FB-A6CB-FEB7443107F8}"/>
               </a:ext>
             </a:extLst>
           </p:cNvPr>
@@ -18684,7 +18684,7 @@
           <p:cNvPr id="15" name="어디서 호출됐나?&#10;함수와 호출 순서">
             <a:extLst xmlns:a="http://schemas.openxmlformats.org/drawingml/2006/main">
               <a:ext uri="{FF2B5EF4-FFF2-40B4-BE49-F238E27FC236}">
-                <a16:creationId xmlns:a16="http://schemas.microsoft.com/office/drawing/2014/main" id="{319DE529-89D3-40CC-847F-67F7913D443F}"/>
+                <a16:creationId xmlns:a16="http://schemas.microsoft.com/office/drawing/2014/main" id="{E7C48E7D-9B52-47DC-9607-CA4E654E54C9}"/>
               </a:ext>
             </a:extLst>
           </p:cNvPr>
@@ -18865,7 +18865,7 @@
           <p:cNvPr id="16" name="">
             <a:extLst xmlns:a="http://schemas.openxmlformats.org/drawingml/2006/main">
               <a:ext uri="{FF2B5EF4-FFF2-40B4-BE49-F238E27FC236}">
-                <a16:creationId xmlns:a16="http://schemas.microsoft.com/office/drawing/2014/main" id="{D4DEF035-DB80-47FC-BE73-50C5D1711071}"/>
+                <a16:creationId xmlns:a16="http://schemas.microsoft.com/office/drawing/2014/main" id="{CDE8077F-CBB9-4F46-BA59-73A0ADA1247F}"/>
               </a:ext>
             </a:extLst>
           </p:cNvPr>
@@ -18898,7 +18898,7 @@
           <p:cNvPr id="17" name="소스·참조">
             <a:extLst xmlns:a="http://schemas.openxmlformats.org/drawingml/2006/main">
               <a:ext uri="{FF2B5EF4-FFF2-40B4-BE49-F238E27FC236}">
-                <a16:creationId xmlns:a16="http://schemas.microsoft.com/office/drawing/2014/main" id="{2600AFF5-98D2-4E3E-B8C3-746CA9260DDC}"/>
+                <a16:creationId xmlns:a16="http://schemas.microsoft.com/office/drawing/2014/main" id="{0957E164-D438-4758-A74C-F6D62A0A2459}"/>
               </a:ext>
             </a:extLst>
           </p:cNvPr>
@@ -19056,7 +19056,7 @@
           <p:cNvPr id="18" name="">
             <a:extLst xmlns:a="http://schemas.openxmlformats.org/drawingml/2006/main">
               <a:ext uri="{FF2B5EF4-FFF2-40B4-BE49-F238E27FC236}">
-                <a16:creationId xmlns:a16="http://schemas.microsoft.com/office/drawing/2014/main" id="{A614124E-ABEE-4779-9C16-6A126E1E09D0}"/>
+                <a16:creationId xmlns:a16="http://schemas.microsoft.com/office/drawing/2014/main" id="{C99C06D3-D3D4-4B37-BE96-5FF70D21B8C4}"/>
               </a:ext>
             </a:extLst>
           </p:cNvPr>
@@ -19087,7 +19087,7 @@
           <p:cNvPr id="19" name="관련 구현과 호출부&#10;코드의 분기">
             <a:extLst xmlns:a="http://schemas.openxmlformats.org/drawingml/2006/main">
               <a:ext uri="{FF2B5EF4-FFF2-40B4-BE49-F238E27FC236}">
-                <a16:creationId xmlns:a16="http://schemas.microsoft.com/office/drawing/2014/main" id="{58A35564-0452-4652-8028-D9C58FBB48E2}"/>
+                <a16:creationId xmlns:a16="http://schemas.microsoft.com/office/drawing/2014/main" id="{E6D53CDD-EE4C-452D-9ED3-1CA729E32CA2}"/>
               </a:ext>
             </a:extLst>
           </p:cNvPr>
@@ -19268,7 +19268,7 @@
           <p:cNvPr id="20" name="">
             <a:extLst xmlns:a="http://schemas.openxmlformats.org/drawingml/2006/main">
               <a:ext uri="{FF2B5EF4-FFF2-40B4-BE49-F238E27FC236}">
-                <a16:creationId xmlns:a16="http://schemas.microsoft.com/office/drawing/2014/main" id="{B42EE497-054C-46AF-92C7-0CC237990547}"/>
+                <a16:creationId xmlns:a16="http://schemas.microsoft.com/office/drawing/2014/main" id="{96759C14-4674-471A-8AC9-1D7D1FB3719F}"/>
               </a:ext>
             </a:extLst>
           </p:cNvPr>
@@ -19301,7 +19301,7 @@
           <p:cNvPr id="21" name="지역 변수·조사식">
             <a:extLst xmlns:a="http://schemas.openxmlformats.org/drawingml/2006/main">
               <a:ext uri="{FF2B5EF4-FFF2-40B4-BE49-F238E27FC236}">
-                <a16:creationId xmlns:a16="http://schemas.microsoft.com/office/drawing/2014/main" id="{FE1D9C61-234A-4CA7-9C57-5D8191F713E7}"/>
+                <a16:creationId xmlns:a16="http://schemas.microsoft.com/office/drawing/2014/main" id="{420F9DEF-DFE9-4BCF-8C73-0A31E5E3A797}"/>
               </a:ext>
             </a:extLst>
           </p:cNvPr>
@@ -19459,7 +19459,7 @@
           <p:cNvPr id="22" name="">
             <a:extLst xmlns:a="http://schemas.openxmlformats.org/drawingml/2006/main">
               <a:ext uri="{FF2B5EF4-FFF2-40B4-BE49-F238E27FC236}">
-                <a16:creationId xmlns:a16="http://schemas.microsoft.com/office/drawing/2014/main" id="{A211BF7A-DB4B-4991-AB1D-1CF999FCB819}"/>
+                <a16:creationId xmlns:a16="http://schemas.microsoft.com/office/drawing/2014/main" id="{D4C3C276-AE1B-47C9-8147-A78251EFE700}"/>
               </a:ext>
             </a:extLst>
           </p:cNvPr>
@@ -19490,7 +19490,7 @@
           <p:cNvPr id="23" name="멈춘 지점의 입력&#10;변수의 실제 값">
             <a:extLst xmlns:a="http://schemas.openxmlformats.org/drawingml/2006/main">
               <a:ext uri="{FF2B5EF4-FFF2-40B4-BE49-F238E27FC236}">
-                <a16:creationId xmlns:a16="http://schemas.microsoft.com/office/drawing/2014/main" id="{264A9E73-77AF-445C-8A10-F3D128E26838}"/>
+                <a16:creationId xmlns:a16="http://schemas.microsoft.com/office/drawing/2014/main" id="{1C152841-880C-487E-B802-274B8C60FE1A}"/>
               </a:ext>
             </a:extLst>
           </p:cNvPr>
@@ -19671,7 +19671,7 @@
           <p:cNvPr id="24" name="">
             <a:extLst xmlns:a="http://schemas.openxmlformats.org/drawingml/2006/main">
               <a:ext uri="{FF2B5EF4-FFF2-40B4-BE49-F238E27FC236}">
-                <a16:creationId xmlns:a16="http://schemas.microsoft.com/office/drawing/2014/main" id="{6154BCC2-927A-44B4-919D-852B94FB6DBA}"/>
+                <a16:creationId xmlns:a16="http://schemas.microsoft.com/office/drawing/2014/main" id="{3C430CD5-7267-4A6A-B8E1-317D7263F69C}"/>
               </a:ext>
             </a:extLst>
           </p:cNvPr>
@@ -19704,7 +19704,7 @@
           <p:cNvPr id="25" name="출력·로그">
             <a:extLst xmlns:a="http://schemas.openxmlformats.org/drawingml/2006/main">
               <a:ext uri="{FF2B5EF4-FFF2-40B4-BE49-F238E27FC236}">
-                <a16:creationId xmlns:a16="http://schemas.microsoft.com/office/drawing/2014/main" id="{D2134C43-5D62-4F96-8605-C21CC0C26BE1}"/>
+                <a16:creationId xmlns:a16="http://schemas.microsoft.com/office/drawing/2014/main" id="{9FDD7691-84DD-4717-876F-BF56F8055AEE}"/>
               </a:ext>
             </a:extLst>
           </p:cNvPr>
@@ -19862,7 +19862,7 @@
           <p:cNvPr id="26" name="">
             <a:extLst xmlns:a="http://schemas.openxmlformats.org/drawingml/2006/main">
               <a:ext uri="{FF2B5EF4-FFF2-40B4-BE49-F238E27FC236}">
-                <a16:creationId xmlns:a16="http://schemas.microsoft.com/office/drawing/2014/main" id="{7548EBE3-A426-40A8-9283-C01E090C7024}"/>
+                <a16:creationId xmlns:a16="http://schemas.microsoft.com/office/drawing/2014/main" id="{401488A4-20CD-45C9-BCED-B4037FFF3093}"/>
               </a:ext>
             </a:extLst>
           </p:cNvPr>
@@ -19893,7 +19893,7 @@
           <p:cNvPr id="27" name="빌드·실행 메시지&#10;오류가 난 시점">
             <a:extLst xmlns:a="http://schemas.openxmlformats.org/drawingml/2006/main">
               <a:ext uri="{FF2B5EF4-FFF2-40B4-BE49-F238E27FC236}">
-                <a16:creationId xmlns:a16="http://schemas.microsoft.com/office/drawing/2014/main" id="{970C8694-5079-4017-8191-180BD273F766}"/>
+                <a16:creationId xmlns:a16="http://schemas.microsoft.com/office/drawing/2014/main" id="{B6C55ADA-C674-4E12-B2F1-1E19C45D6B81}"/>
               </a:ext>
             </a:extLst>
           </p:cNvPr>
@@ -20074,7 +20074,7 @@
           <p:cNvPr id="28" name="">
             <a:extLst xmlns:a="http://schemas.openxmlformats.org/drawingml/2006/main">
               <a:ext uri="{FF2B5EF4-FFF2-40B4-BE49-F238E27FC236}">
-                <a16:creationId xmlns:a16="http://schemas.microsoft.com/office/drawing/2014/main" id="{60721826-E9E0-45E1-9947-1C36AD3419BA}"/>
+                <a16:creationId xmlns:a16="http://schemas.microsoft.com/office/drawing/2014/main" id="{E9006F02-3750-416A-9DD8-23B81728BC41}"/>
               </a:ext>
             </a:extLst>
           </p:cNvPr>
@@ -20107,7 +20107,7 @@
           <p:cNvPr id="29" name="명세서 · 외부 문서">
             <a:extLst xmlns:a="http://schemas.openxmlformats.org/drawingml/2006/main">
               <a:ext uri="{FF2B5EF4-FFF2-40B4-BE49-F238E27FC236}">
-                <a16:creationId xmlns:a16="http://schemas.microsoft.com/office/drawing/2014/main" id="{E2918C47-6C6F-4ABB-A415-77EC4FA328CB}"/>
+                <a16:creationId xmlns:a16="http://schemas.microsoft.com/office/drawing/2014/main" id="{2325265E-F106-4F35-A67F-9969E613B6D5}"/>
               </a:ext>
             </a:extLst>
           </p:cNvPr>
@@ -20265,7 +20265,7 @@
           <p:cNvPr id="30" name="">
             <a:extLst xmlns:a="http://schemas.openxmlformats.org/drawingml/2006/main">
               <a:ext uri="{FF2B5EF4-FFF2-40B4-BE49-F238E27FC236}">
-                <a16:creationId xmlns:a16="http://schemas.microsoft.com/office/drawing/2014/main" id="{8C865D03-54D4-4A7B-A941-CEF06393CD6A}"/>
+                <a16:creationId xmlns:a16="http://schemas.microsoft.com/office/drawing/2014/main" id="{B409F2D3-687C-4183-9EFC-F4668D33E634}"/>
               </a:ext>
             </a:extLst>
           </p:cNvPr>
@@ -20296,7 +20296,7 @@
           <p:cNvPr id="31" name="기대하는 동작&#10;입력 범위·예외 조건">
             <a:extLst xmlns:a="http://schemas.openxmlformats.org/drawingml/2006/main">
               <a:ext uri="{FF2B5EF4-FFF2-40B4-BE49-F238E27FC236}">
-                <a16:creationId xmlns:a16="http://schemas.microsoft.com/office/drawing/2014/main" id="{5925B204-F806-4315-A670-F809934EA26B}"/>
+                <a16:creationId xmlns:a16="http://schemas.microsoft.com/office/drawing/2014/main" id="{FF73E69D-133F-4967-BB3A-F5077E6C1093}"/>
               </a:ext>
             </a:extLst>
           </p:cNvPr>
@@ -20477,7 +20477,7 @@
           <p:cNvPr id="32" name="이 정보 하나하나가 Context다.">
             <a:extLst xmlns:a="http://schemas.openxmlformats.org/drawingml/2006/main">
               <a:ext uri="{FF2B5EF4-FFF2-40B4-BE49-F238E27FC236}">
-                <a16:creationId xmlns:a16="http://schemas.microsoft.com/office/drawing/2014/main" id="{158E01A5-B2B8-49F2-BABC-D1D563DEC47F}"/>
+                <a16:creationId xmlns:a16="http://schemas.microsoft.com/office/drawing/2014/main" id="{806BF3D4-4BFB-4E8E-90EA-F19F378B3541}"/>
               </a:ext>
             </a:extLst>
           </p:cNvPr>
@@ -20635,7 +20635,7 @@
           <p:cNvPr id="33" name="Legacy module connection">
             <a:extLst xmlns:a="http://schemas.openxmlformats.org/drawingml/2006/main">
               <a:ext uri="{FF2B5EF4-FFF2-40B4-BE49-F238E27FC236}">
-                <a16:creationId xmlns:a16="http://schemas.microsoft.com/office/drawing/2014/main" id="{3B05764A-DC2E-410A-AD04-08F542BE270D}"/>
+                <a16:creationId xmlns:a16="http://schemas.microsoft.com/office/drawing/2014/main" id="{D2EDD01A-DCE6-4FA8-AD4F-FA463D1C4413}"/>
               </a:ext>
             </a:extLst>
           </p:cNvPr>
@@ -20791,7 +20791,7 @@
     </p:spTree>
     <p:extLst>
       <p:ext uri="{BB962C8B-B14F-4D97-AF65-F5344CB8AC3E}">
-        <p14:creationId xmlns:p14="http://schemas.microsoft.com/office/powerpoint/2010/main" val="1165927641"/>
+        <p14:creationId xmlns:p14="http://schemas.microsoft.com/office/powerpoint/2010/main" val="743680388"/>
       </p:ext>
     </p:extLst>
   </p:cSld>
@@ -20822,7 +20822,7 @@
           <p:cNvPr id="20" name="ACT 0 · Repository 조사 관찰">
             <a:extLst xmlns:a="http://schemas.openxmlformats.org/drawingml/2006/main">
               <a:ext uri="{FF2B5EF4-FFF2-40B4-BE49-F238E27FC236}">
-                <a16:creationId xmlns:a16="http://schemas.microsoft.com/office/drawing/2014/main" id="{857A41F7-383A-47E1-BF56-126037DA4DDF}"/>
+                <a16:creationId xmlns:a16="http://schemas.microsoft.com/office/drawing/2014/main" id="{30AC6D7A-A4EF-435E-991E-0D416CDD3A34}"/>
               </a:ext>
             </a:extLst>
           </p:cNvPr>
@@ -20980,7 +20980,7 @@
           <p:cNvPr id="2" name="S04">
             <a:extLst xmlns:a="http://schemas.openxmlformats.org/drawingml/2006/main">
               <a:ext uri="{FF2B5EF4-FFF2-40B4-BE49-F238E27FC236}">
-                <a16:creationId xmlns:a16="http://schemas.microsoft.com/office/drawing/2014/main" id="{C252F760-F5F8-47EF-AE20-508FD2AAFC7E}"/>
+                <a16:creationId xmlns:a16="http://schemas.microsoft.com/office/drawing/2014/main" id="{7291F6F1-6757-482D-ADE7-74BF13EC9FEC}"/>
               </a:ext>
             </a:extLst>
           </p:cNvPr>
@@ -21138,7 +21138,7 @@
           <p:cNvPr id="3" name="파일명을 주지 않으면 Agent는 어디부터 볼까?">
             <a:extLst xmlns:a="http://schemas.openxmlformats.org/drawingml/2006/main">
               <a:ext uri="{FF2B5EF4-FFF2-40B4-BE49-F238E27FC236}">
-                <a16:creationId xmlns:a16="http://schemas.microsoft.com/office/drawing/2014/main" id="{7D21E2B6-A4BE-495C-B9C4-AC4FF9D3138D}"/>
+                <a16:creationId xmlns:a16="http://schemas.microsoft.com/office/drawing/2014/main" id="{78E3BC2A-3D13-4713-8568-0371E32CD7F5}"/>
               </a:ext>
             </a:extLst>
           </p:cNvPr>
@@ -21296,7 +21296,7 @@
           <p:cNvPr id="4" name="">
             <a:extLst xmlns:a="http://schemas.openxmlformats.org/drawingml/2006/main">
               <a:ext uri="{FF2B5EF4-FFF2-40B4-BE49-F238E27FC236}">
-                <a16:creationId xmlns:a16="http://schemas.microsoft.com/office/drawing/2014/main" id="{82BEF6D0-823C-47E9-94C8-0AF5608AE734}"/>
+                <a16:creationId xmlns:a16="http://schemas.microsoft.com/office/drawing/2014/main" id="{380963C2-E7F5-42D8-9DFE-313B0142348E}"/>
               </a:ext>
             </a:extLst>
           </p:cNvPr>
@@ -21327,7 +21327,7 @@
           <p:cNvPr id="5" name="실제 요청: TRIAL-001 · Codex CLI 0.154.0 · macOS · 읽기 전용">
             <a:extLst xmlns:a="http://schemas.openxmlformats.org/drawingml/2006/main">
               <a:ext uri="{FF2B5EF4-FFF2-40B4-BE49-F238E27FC236}">
-                <a16:creationId xmlns:a16="http://schemas.microsoft.com/office/drawing/2014/main" id="{12B2E7D5-7FFE-405E-8B87-3EFE93D38BBD}"/>
+                <a16:creationId xmlns:a16="http://schemas.microsoft.com/office/drawing/2014/main" id="{7684966C-A7F8-45A6-B01C-C8A8F514C3B1}"/>
               </a:ext>
             </a:extLst>
           </p:cNvPr>
@@ -21485,7 +21485,7 @@
           <p:cNvPr id="6" name="우측은 가상 GoogleTest 예시 · 실제 Trial은 Python unittest · 현재 Deskto">
             <a:extLst xmlns:a="http://schemas.openxmlformats.org/drawingml/2006/main">
               <a:ext uri="{FF2B5EF4-FFF2-40B4-BE49-F238E27FC236}">
-                <a16:creationId xmlns:a16="http://schemas.microsoft.com/office/drawing/2014/main" id="{DE6B1670-ACB9-48C4-8E7D-CA817AE8AAF3}"/>
+                <a16:creationId xmlns:a16="http://schemas.microsoft.com/office/drawing/2014/main" id="{74F41429-F0FB-4040-A515-F59E9E15B316}"/>
               </a:ext>
             </a:extLst>
           </p:cNvPr>
@@ -21643,7 +21643,7 @@
           <p:cNvPr id="7" name="TRIAL-001의 실제 조사 요청">
             <a:extLst xmlns:a="http://schemas.openxmlformats.org/drawingml/2006/main">
               <a:ext uri="{FF2B5EF4-FFF2-40B4-BE49-F238E27FC236}">
-                <a16:creationId xmlns:a16="http://schemas.microsoft.com/office/drawing/2014/main" id="{25279297-05EE-43C3-9CD3-47417B833A71}"/>
+                <a16:creationId xmlns:a16="http://schemas.microsoft.com/office/drawing/2014/main" id="{06D45293-70BD-47E0-9C4B-4BDD29D16CC0}"/>
               </a:ext>
             </a:extLst>
           </p:cNvPr>
@@ -21801,7 +21801,7 @@
           <p:cNvPr id="8" name="실패 하나가 있는 상황">
             <a:extLst xmlns:a="http://schemas.openxmlformats.org/drawingml/2006/main">
               <a:ext uri="{FF2B5EF4-FFF2-40B4-BE49-F238E27FC236}">
-                <a16:creationId xmlns:a16="http://schemas.microsoft.com/office/drawing/2014/main" id="{6F330B3F-B7E7-4A60-B613-453C812EE278}"/>
+                <a16:creationId xmlns:a16="http://schemas.microsoft.com/office/drawing/2014/main" id="{A8784F17-BCD4-4ECF-8325-83B5765513A2}"/>
               </a:ext>
             </a:extLst>
           </p:cNvPr>
@@ -21959,7 +21959,7 @@
           <p:cNvPr id="9" name="C++ 설명용 가상 화면">
             <a:extLst xmlns:a="http://schemas.openxmlformats.org/drawingml/2006/main">
               <a:ext uri="{FF2B5EF4-FFF2-40B4-BE49-F238E27FC236}">
-                <a16:creationId xmlns:a16="http://schemas.microsoft.com/office/drawing/2014/main" id="{5E11DEDE-9425-4F19-8B8B-2E62D197BC8F}"/>
+                <a16:creationId xmlns:a16="http://schemas.microsoft.com/office/drawing/2014/main" id="{5A0C4A17-3109-4680-9CF7-936F4E7FF692}"/>
               </a:ext>
             </a:extLst>
           </p:cNvPr>
@@ -22117,7 +22117,7 @@
           <p:cNvPr id="10" name="">
             <a:extLst xmlns:a="http://schemas.openxmlformats.org/drawingml/2006/main">
               <a:ext uri="{FF2B5EF4-FFF2-40B4-BE49-F238E27FC236}">
-                <a16:creationId xmlns:a16="http://schemas.microsoft.com/office/drawing/2014/main" id="{CE85DF5C-39A0-4DCC-AAD5-BB144EE080EF}"/>
+                <a16:creationId xmlns:a16="http://schemas.microsoft.com/office/drawing/2014/main" id="{7B28FFEC-E503-4C73-8C91-F69C20DD6FF1}"/>
               </a:ext>
             </a:extLst>
           </p:cNvPr>
@@ -22150,7 +22150,7 @@
           <p:cNvPr id="11" name="조사 요청 · 입력창 형태로 재구성">
             <a:extLst xmlns:a="http://schemas.openxmlformats.org/drawingml/2006/main">
               <a:ext uri="{FF2B5EF4-FFF2-40B4-BE49-F238E27FC236}">
-                <a16:creationId xmlns:a16="http://schemas.microsoft.com/office/drawing/2014/main" id="{1C58C749-F28C-4C90-BCD0-CB1C7CE5E17B}"/>
+                <a16:creationId xmlns:a16="http://schemas.microsoft.com/office/drawing/2014/main" id="{1878EC91-79C2-4C05-8A2E-06B300975281}"/>
               </a:ext>
             </a:extLst>
           </p:cNvPr>
@@ -22308,7 +22308,7 @@
           <p:cNvPr id="12" name="">
             <a:extLst xmlns:a="http://schemas.openxmlformats.org/drawingml/2006/main">
               <a:ext uri="{FF2B5EF4-FFF2-40B4-BE49-F238E27FC236}">
-                <a16:creationId xmlns:a16="http://schemas.microsoft.com/office/drawing/2014/main" id="{F020E54B-9BA2-44AC-BEB5-96034E583963}"/>
+                <a16:creationId xmlns:a16="http://schemas.microsoft.com/office/drawing/2014/main" id="{6732D1BE-929A-4127-8D7E-BBCD4C0CB254}"/>
               </a:ext>
             </a:extLst>
           </p:cNvPr>
@@ -22339,7 +22339,7 @@
           <p:cNvPr id="13" name="현재 이 저장소에서 테스트 하나가&#10;실패하고 있다. 실패 원인을 조사해줘.&#10;관련 구현과 호출 경로, 실패하는&#10;">
             <a:extLst xmlns:a="http://schemas.openxmlformats.org/drawingml/2006/main">
               <a:ext uri="{FF2B5EF4-FFF2-40B4-BE49-F238E27FC236}">
-                <a16:creationId xmlns:a16="http://schemas.microsoft.com/office/drawing/2014/main" id="{ADCFC511-2402-4C0D-8321-001477C8FF3E}"/>
+                <a16:creationId xmlns:a16="http://schemas.microsoft.com/office/drawing/2014/main" id="{3F90EA79-2771-4265-B1E9-6B7E2EA21A38}"/>
               </a:ext>
             </a:extLst>
           </p:cNvPr>
@@ -22612,7 +22612,7 @@
           <p:cNvPr id="14" name="＋">
             <a:extLst xmlns:a="http://schemas.openxmlformats.org/drawingml/2006/main">
               <a:ext uri="{FF2B5EF4-FFF2-40B4-BE49-F238E27FC236}">
-                <a16:creationId xmlns:a16="http://schemas.microsoft.com/office/drawing/2014/main" id="{CE71FCF4-6FB2-479F-865D-32CBB98180BC}"/>
+                <a16:creationId xmlns:a16="http://schemas.microsoft.com/office/drawing/2014/main" id="{5E7645BA-C259-4FC5-8337-9D886C847D58}"/>
               </a:ext>
             </a:extLst>
           </p:cNvPr>
@@ -22770,7 +22770,7 @@
           <p:cNvPr id="15" name="">
             <a:extLst xmlns:a="http://schemas.openxmlformats.org/drawingml/2006/main">
               <a:ext uri="{FF2B5EF4-FFF2-40B4-BE49-F238E27FC236}">
-                <a16:creationId xmlns:a16="http://schemas.microsoft.com/office/drawing/2014/main" id="{2148F5EA-16DE-4B0A-861D-E13FE7CB97DD}"/>
+                <a16:creationId xmlns:a16="http://schemas.microsoft.com/office/drawing/2014/main" id="{A9231E9F-1662-40D5-9264-0E199983FD80}"/>
               </a:ext>
             </a:extLst>
           </p:cNvPr>
@@ -22800,7 +22800,7 @@
           <p:cNvPr id="16" name="↑">
             <a:extLst xmlns:a="http://schemas.openxmlformats.org/drawingml/2006/main">
               <a:ext uri="{FF2B5EF4-FFF2-40B4-BE49-F238E27FC236}">
-                <a16:creationId xmlns:a16="http://schemas.microsoft.com/office/drawing/2014/main" id="{147CF43A-71B0-44B0-9E5C-19C23EBD02F5}"/>
+                <a16:creationId xmlns:a16="http://schemas.microsoft.com/office/drawing/2014/main" id="{778A3FAD-2850-41C2-8D81-BDA3FBE4C31B}"/>
               </a:ext>
             </a:extLst>
           </p:cNvPr>
@@ -22958,7 +22958,7 @@
           <p:cNvPr id="17" name="">
             <a:extLst xmlns:a="http://schemas.openxmlformats.org/drawingml/2006/main">
               <a:ext uri="{FF2B5EF4-FFF2-40B4-BE49-F238E27FC236}">
-                <a16:creationId xmlns:a16="http://schemas.microsoft.com/office/drawing/2014/main" id="{BECAA12E-3780-414F-95A7-4656E7F0359C}"/>
+                <a16:creationId xmlns:a16="http://schemas.microsoft.com/office/drawing/2014/main" id="{2982FE31-2CB1-4D5C-B93E-E7F9C0390941}"/>
               </a:ext>
             </a:extLst>
           </p:cNvPr>
@@ -22968,7 +22968,7 @@
           <p:nvPr/>
         </p:nvPicPr>
         <p:blipFill>
-          <a:blip xmlns:r="http://schemas.openxmlformats.org/officeDocument/2006/relationships" xmlns:a="http://schemas.openxmlformats.org/drawingml/2006/main" r:embed="R2dd38606307b4e4e"/>
+          <a:blip xmlns:r="http://schemas.openxmlformats.org/officeDocument/2006/relationships" xmlns:a="http://schemas.openxmlformats.org/drawingml/2006/main" r:embed="R80873e927b3f4864"/>
           <a:stretch xmlns:a="http://schemas.openxmlformats.org/drawingml/2006/main"/>
         </p:blipFill>
         <p:spPr>
@@ -22986,7 +22986,7 @@
           <p:cNvPr id="18" name="관찰할 것    실패 테스트  ·  관련 구현  ·  호출 경로">
             <a:extLst xmlns:a="http://schemas.openxmlformats.org/drawingml/2006/main">
               <a:ext uri="{FF2B5EF4-FFF2-40B4-BE49-F238E27FC236}">
-                <a16:creationId xmlns:a16="http://schemas.microsoft.com/office/drawing/2014/main" id="{2B15B1DF-DF75-4B09-9C38-CCE7FE736259}"/>
+                <a16:creationId xmlns:a16="http://schemas.microsoft.com/office/drawing/2014/main" id="{DEB5BC95-40A1-4283-BA9C-9BFBB1393750}"/>
               </a:ext>
             </a:extLst>
           </p:cNvPr>
@@ -23144,7 +23144,7 @@
           <p:cNvPr id="19" name="Legacy module connection">
             <a:extLst xmlns:a="http://schemas.openxmlformats.org/drawingml/2006/main">
               <a:ext uri="{FF2B5EF4-FFF2-40B4-BE49-F238E27FC236}">
-                <a16:creationId xmlns:a16="http://schemas.microsoft.com/office/drawing/2014/main" id="{18AFB3E6-73C0-4825-93C3-69D75B5DB607}"/>
+                <a16:creationId xmlns:a16="http://schemas.microsoft.com/office/drawing/2014/main" id="{8016AB59-962E-402D-B5C1-0F36C41EDD38}"/>
               </a:ext>
             </a:extLst>
           </p:cNvPr>
@@ -23300,7 +23300,7 @@
     </p:spTree>
     <p:extLst>
       <p:ext uri="{BB962C8B-B14F-4D97-AF65-F5344CB8AC3E}">
-        <p14:creationId xmlns:p14="http://schemas.microsoft.com/office/powerpoint/2010/main" val="2060138080"/>
+        <p14:creationId xmlns:p14="http://schemas.microsoft.com/office/powerpoint/2010/main" val="1063834454"/>
       </p:ext>
     </p:extLst>
   </p:cSld>
@@ -23331,7 +23331,7 @@
           <p:cNvPr id="46" name="ACT 0  ·  Repository 탐색">
             <a:extLst xmlns:a="http://schemas.openxmlformats.org/drawingml/2006/main">
               <a:ext uri="{FF2B5EF4-FFF2-40B4-BE49-F238E27FC236}">
-                <a16:creationId xmlns:a16="http://schemas.microsoft.com/office/drawing/2014/main" id="{D07CF29C-6D72-464F-A071-0F79D109EBA0}"/>
+                <a16:creationId xmlns:a16="http://schemas.microsoft.com/office/drawing/2014/main" id="{172804D2-6298-46D8-B1B0-798A247E439C}"/>
               </a:ext>
             </a:extLst>
           </p:cNvPr>
@@ -23489,7 +23489,7 @@
           <p:cNvPr id="2" name="S05">
             <a:extLst xmlns:a="http://schemas.openxmlformats.org/drawingml/2006/main">
               <a:ext uri="{FF2B5EF4-FFF2-40B4-BE49-F238E27FC236}">
-                <a16:creationId xmlns:a16="http://schemas.microsoft.com/office/drawing/2014/main" id="{B66C1C3A-E96F-4286-BA5B-8FC811D0E682}"/>
+                <a16:creationId xmlns:a16="http://schemas.microsoft.com/office/drawing/2014/main" id="{4B577F45-79B5-4105-863A-38621B44BEE2}"/>
               </a:ext>
             </a:extLst>
           </p:cNvPr>
@@ -23647,7 +23647,7 @@
           <p:cNvPr id="3" name="Agent가 Test와 호출 경로를 찾았다">
             <a:extLst xmlns:a="http://schemas.openxmlformats.org/drawingml/2006/main">
               <a:ext uri="{FF2B5EF4-FFF2-40B4-BE49-F238E27FC236}">
-                <a16:creationId xmlns:a16="http://schemas.microsoft.com/office/drawing/2014/main" id="{D425B4FB-FE2F-4B4E-AD0D-8A72F2324B56}"/>
+                <a16:creationId xmlns:a16="http://schemas.microsoft.com/office/drawing/2014/main" id="{31132F76-3C15-46BC-A8E0-F988A69E48CA}"/>
               </a:ext>
             </a:extLst>
           </p:cNvPr>
@@ -23805,7 +23805,7 @@
           <p:cNvPr id="4" name="">
             <a:extLst xmlns:a="http://schemas.openxmlformats.org/drawingml/2006/main">
               <a:ext uri="{FF2B5EF4-FFF2-40B4-BE49-F238E27FC236}">
-                <a16:creationId xmlns:a16="http://schemas.microsoft.com/office/drawing/2014/main" id="{23DD38AE-825A-4AF1-9E02-687E61781402}"/>
+                <a16:creationId xmlns:a16="http://schemas.microsoft.com/office/drawing/2014/main" id="{8B36D3AA-6631-4150-BCE7-9FC93076C4B8}"/>
               </a:ext>
             </a:extLst>
           </p:cNvPr>
@@ -23836,7 +23836,7 @@
           <p:cNvPr id="5" name="TRIAL-001 기록·STATE-00 테스트 재구성  |  Codex CLI 0.154.0 · 읽기 전용">
             <a:extLst xmlns:a="http://schemas.openxmlformats.org/drawingml/2006/main">
               <a:ext uri="{FF2B5EF4-FFF2-40B4-BE49-F238E27FC236}">
-                <a16:creationId xmlns:a16="http://schemas.microsoft.com/office/drawing/2014/main" id="{AB137EC4-9898-4AB3-A19F-85A1D2BC9C66}"/>
+                <a16:creationId xmlns:a16="http://schemas.microsoft.com/office/drawing/2014/main" id="{22221BE9-563C-4F8D-8290-C26F497814E3}"/>
               </a:ext>
             </a:extLst>
           </p:cNvPr>
@@ -23994,7 +23994,7 @@
           <p:cNvPr id="6" name="실제 실행 화면이 아님 · 이 조사에서는 코드 수정 없음 · 현재 Desktop 동작 미검증">
             <a:extLst xmlns:a="http://schemas.openxmlformats.org/drawingml/2006/main">
               <a:ext uri="{FF2B5EF4-FFF2-40B4-BE49-F238E27FC236}">
-                <a16:creationId xmlns:a16="http://schemas.microsoft.com/office/drawing/2014/main" id="{22D0D0F8-B69E-48E6-BF7A-A12B50C9660D}"/>
+                <a16:creationId xmlns:a16="http://schemas.microsoft.com/office/drawing/2014/main" id="{1B555973-5547-4BD7-8251-7B1BC177AFE1}"/>
               </a:ext>
             </a:extLst>
           </p:cNvPr>
@@ -24152,7 +24152,7 @@
           <p:cNvPr id="7" name="의도한 폭과 실제로 포함된 열 수가 달랐다">
             <a:extLst xmlns:a="http://schemas.openxmlformats.org/drawingml/2006/main">
               <a:ext uri="{FF2B5EF4-FFF2-40B4-BE49-F238E27FC236}">
-                <a16:creationId xmlns:a16="http://schemas.microsoft.com/office/drawing/2014/main" id="{CD4E7373-364F-4263-8FB8-98689ED60843}"/>
+                <a16:creationId xmlns:a16="http://schemas.microsoft.com/office/drawing/2014/main" id="{41181A5E-890C-471D-A999-9D440611D277}"/>
               </a:ext>
             </a:extLst>
           </p:cNvPr>
@@ -24310,7 +24310,7 @@
           <p:cNvPr id="8" name="crop(image, 1, 3)">
             <a:extLst xmlns:a="http://schemas.openxmlformats.org/drawingml/2006/main">
               <a:ext uri="{FF2B5EF4-FFF2-40B4-BE49-F238E27FC236}">
-                <a16:creationId xmlns:a16="http://schemas.microsoft.com/office/drawing/2014/main" id="{3F394FEE-F260-4891-B60F-501B06AA7FE0}"/>
+                <a16:creationId xmlns:a16="http://schemas.microsoft.com/office/drawing/2014/main" id="{F664D057-860A-48A5-B3AC-FB5F378DC268}"/>
               </a:ext>
             </a:extLst>
           </p:cNvPr>
@@ -24468,7 +24468,7 @@
           <p:cNvPr id="9" name="명세: 끝 좌표 3은 제외">
             <a:extLst xmlns:a="http://schemas.openxmlformats.org/drawingml/2006/main">
               <a:ext uri="{FF2B5EF4-FFF2-40B4-BE49-F238E27FC236}">
-                <a16:creationId xmlns:a16="http://schemas.microsoft.com/office/drawing/2014/main" id="{0CB67AC1-C2E2-4C2D-9E6E-44ADA9579BB0}"/>
+                <a16:creationId xmlns:a16="http://schemas.microsoft.com/office/drawing/2014/main" id="{6D06C0A2-E752-4C2B-A00A-E25FE0997965}"/>
               </a:ext>
             </a:extLst>
           </p:cNvPr>
@@ -24626,7 +24626,7 @@
           <p:cNvPr id="10" name="입력">
             <a:extLst xmlns:a="http://schemas.openxmlformats.org/drawingml/2006/main">
               <a:ext uri="{FF2B5EF4-FFF2-40B4-BE49-F238E27FC236}">
-                <a16:creationId xmlns:a16="http://schemas.microsoft.com/office/drawing/2014/main" id="{1D1136D9-D140-44A5-9C4F-115A3E39BF47}"/>
+                <a16:creationId xmlns:a16="http://schemas.microsoft.com/office/drawing/2014/main" id="{D84C4044-B0C6-484A-A5DB-E42056732CD9}"/>
               </a:ext>
             </a:extLst>
           </p:cNvPr>
@@ -24784,7 +24784,7 @@
           <p:cNvPr id="11" name="0">
             <a:extLst xmlns:a="http://schemas.openxmlformats.org/drawingml/2006/main">
               <a:ext uri="{FF2B5EF4-FFF2-40B4-BE49-F238E27FC236}">
-                <a16:creationId xmlns:a16="http://schemas.microsoft.com/office/drawing/2014/main" id="{64678901-3124-472F-B97A-645AA3E49C9A}"/>
+                <a16:creationId xmlns:a16="http://schemas.microsoft.com/office/drawing/2014/main" id="{CCEC763C-6881-4FC0-809A-1CF9F5D5EF80}"/>
               </a:ext>
             </a:extLst>
           </p:cNvPr>
@@ -24942,7 +24942,7 @@
           <p:cNvPr id="12" name="1">
             <a:extLst xmlns:a="http://schemas.openxmlformats.org/drawingml/2006/main">
               <a:ext uri="{FF2B5EF4-FFF2-40B4-BE49-F238E27FC236}">
-                <a16:creationId xmlns:a16="http://schemas.microsoft.com/office/drawing/2014/main" id="{9B57128B-FFE6-4E7B-84FC-0E5D6B9700E7}"/>
+                <a16:creationId xmlns:a16="http://schemas.microsoft.com/office/drawing/2014/main" id="{0A1BB00D-731C-4599-82DC-07E7AABCEBE1}"/>
               </a:ext>
             </a:extLst>
           </p:cNvPr>
@@ -25100,7 +25100,7 @@
           <p:cNvPr id="13" name="2">
             <a:extLst xmlns:a="http://schemas.openxmlformats.org/drawingml/2006/main">
               <a:ext uri="{FF2B5EF4-FFF2-40B4-BE49-F238E27FC236}">
-                <a16:creationId xmlns:a16="http://schemas.microsoft.com/office/drawing/2014/main" id="{9E6002E0-BC51-448B-8685-20D388894D7E}"/>
+                <a16:creationId xmlns:a16="http://schemas.microsoft.com/office/drawing/2014/main" id="{8C93C108-FA44-4295-9A3B-C5988333C087}"/>
               </a:ext>
             </a:extLst>
           </p:cNvPr>
@@ -25258,7 +25258,7 @@
           <p:cNvPr id="14" name="3">
             <a:extLst xmlns:a="http://schemas.openxmlformats.org/drawingml/2006/main">
               <a:ext uri="{FF2B5EF4-FFF2-40B4-BE49-F238E27FC236}">
-                <a16:creationId xmlns:a16="http://schemas.microsoft.com/office/drawing/2014/main" id="{191E7978-877E-4956-9A89-0907B4882F14}"/>
+                <a16:creationId xmlns:a16="http://schemas.microsoft.com/office/drawing/2014/main" id="{E9F4433A-2846-4BFF-89FA-E5C0ACECAE7F}"/>
               </a:ext>
             </a:extLst>
           </p:cNvPr>
@@ -25416,7 +25416,7 @@
           <p:cNvPr id="15" name="">
             <a:extLst xmlns:a="http://schemas.openxmlformats.org/drawingml/2006/main">
               <a:ext uri="{FF2B5EF4-FFF2-40B4-BE49-F238E27FC236}">
-                <a16:creationId xmlns:a16="http://schemas.microsoft.com/office/drawing/2014/main" id="{4F5F73E3-24DD-4722-AD41-EE9397E74DC4}"/>
+                <a16:creationId xmlns:a16="http://schemas.microsoft.com/office/drawing/2014/main" id="{6A514F5F-ACDB-4EDE-BC1A-BF2CEC8A0CCA}"/>
               </a:ext>
             </a:extLst>
           </p:cNvPr>
@@ -25449,7 +25449,7 @@
           <p:cNvPr id="16" name="1">
             <a:extLst xmlns:a="http://schemas.openxmlformats.org/drawingml/2006/main">
               <a:ext uri="{FF2B5EF4-FFF2-40B4-BE49-F238E27FC236}">
-                <a16:creationId xmlns:a16="http://schemas.microsoft.com/office/drawing/2014/main" id="{0E54EC95-DE0D-43A9-9123-208B16380EB4}"/>
+                <a16:creationId xmlns:a16="http://schemas.microsoft.com/office/drawing/2014/main" id="{B021CCBC-873D-4EAD-A5E4-D4FFB422D381}"/>
               </a:ext>
             </a:extLst>
           </p:cNvPr>
@@ -25607,7 +25607,7 @@
           <p:cNvPr id="17" name="">
             <a:extLst xmlns:a="http://schemas.openxmlformats.org/drawingml/2006/main">
               <a:ext uri="{FF2B5EF4-FFF2-40B4-BE49-F238E27FC236}">
-                <a16:creationId xmlns:a16="http://schemas.microsoft.com/office/drawing/2014/main" id="{5BFA8511-0642-46AA-98AE-D515623010F5}"/>
+                <a16:creationId xmlns:a16="http://schemas.microsoft.com/office/drawing/2014/main" id="{8CF37F7E-A514-450C-AD1D-354077897AAD}"/>
               </a:ext>
             </a:extLst>
           </p:cNvPr>
@@ -25640,7 +25640,7 @@
           <p:cNvPr id="18" name="2">
             <a:extLst xmlns:a="http://schemas.openxmlformats.org/drawingml/2006/main">
               <a:ext uri="{FF2B5EF4-FFF2-40B4-BE49-F238E27FC236}">
-                <a16:creationId xmlns:a16="http://schemas.microsoft.com/office/drawing/2014/main" id="{B38AF030-4BFB-4215-9668-BAC6E0B257F8}"/>
+                <a16:creationId xmlns:a16="http://schemas.microsoft.com/office/drawing/2014/main" id="{B9591D06-A998-48A8-B54E-22216D0F4A76}"/>
               </a:ext>
             </a:extLst>
           </p:cNvPr>
@@ -25798,7 +25798,7 @@
           <p:cNvPr id="19" name="">
             <a:extLst xmlns:a="http://schemas.openxmlformats.org/drawingml/2006/main">
               <a:ext uri="{FF2B5EF4-FFF2-40B4-BE49-F238E27FC236}">
-                <a16:creationId xmlns:a16="http://schemas.microsoft.com/office/drawing/2014/main" id="{FB35193A-CF87-4F0B-8506-139AFDBA4089}"/>
+                <a16:creationId xmlns:a16="http://schemas.microsoft.com/office/drawing/2014/main" id="{A0656FD3-2EF5-41B4-B2A9-7F13E7457A62}"/>
               </a:ext>
             </a:extLst>
           </p:cNvPr>
@@ -25831,7 +25831,7 @@
           <p:cNvPr id="20" name="3">
             <a:extLst xmlns:a="http://schemas.openxmlformats.org/drawingml/2006/main">
               <a:ext uri="{FF2B5EF4-FFF2-40B4-BE49-F238E27FC236}">
-                <a16:creationId xmlns:a16="http://schemas.microsoft.com/office/drawing/2014/main" id="{81FE13E8-C723-440C-A273-ACB8D78E54BA}"/>
+                <a16:creationId xmlns:a16="http://schemas.microsoft.com/office/drawing/2014/main" id="{69EAB949-EBEB-4BD9-8FA4-B40063EAE388}"/>
               </a:ext>
             </a:extLst>
           </p:cNvPr>
@@ -25989,7 +25989,7 @@
           <p:cNvPr id="21" name="">
             <a:extLst xmlns:a="http://schemas.openxmlformats.org/drawingml/2006/main">
               <a:ext uri="{FF2B5EF4-FFF2-40B4-BE49-F238E27FC236}">
-                <a16:creationId xmlns:a16="http://schemas.microsoft.com/office/drawing/2014/main" id="{63419E5D-BD86-424A-A083-E05A4FA25D54}"/>
+                <a16:creationId xmlns:a16="http://schemas.microsoft.com/office/drawing/2014/main" id="{91AC0C5B-6EDA-4684-9296-AB7872F19218}"/>
               </a:ext>
             </a:extLst>
           </p:cNvPr>
@@ -26022,7 +26022,7 @@
           <p:cNvPr id="22" name="4">
             <a:extLst xmlns:a="http://schemas.openxmlformats.org/drawingml/2006/main">
               <a:ext uri="{FF2B5EF4-FFF2-40B4-BE49-F238E27FC236}">
-                <a16:creationId xmlns:a16="http://schemas.microsoft.com/office/drawing/2014/main" id="{AE2B528B-DD03-47AE-B535-7CED7491507F}"/>
+                <a16:creationId xmlns:a16="http://schemas.microsoft.com/office/drawing/2014/main" id="{BFCE75AA-DEB9-4F0E-AA7E-7615BB5F44C7}"/>
               </a:ext>
             </a:extLst>
           </p:cNvPr>
@@ -26180,7 +26180,7 @@
           <p:cNvPr id="23" name="첫 행만 표시">
             <a:extLst xmlns:a="http://schemas.openxmlformats.org/drawingml/2006/main">
               <a:ext uri="{FF2B5EF4-FFF2-40B4-BE49-F238E27FC236}">
-                <a16:creationId xmlns:a16="http://schemas.microsoft.com/office/drawing/2014/main" id="{BA792EE3-3AD7-44F6-9231-F024FD333D4F}"/>
+                <a16:creationId xmlns:a16="http://schemas.microsoft.com/office/drawing/2014/main" id="{F4094F29-5494-48A2-BDFE-54A4C6808AD3}"/>
               </a:ext>
             </a:extLst>
           </p:cNvPr>
@@ -26338,7 +26338,7 @@
           <p:cNvPr id="24" name="명세 · 폭 2">
             <a:extLst xmlns:a="http://schemas.openxmlformats.org/drawingml/2006/main">
               <a:ext uri="{FF2B5EF4-FFF2-40B4-BE49-F238E27FC236}">
-                <a16:creationId xmlns:a16="http://schemas.microsoft.com/office/drawing/2014/main" id="{A993DBC7-FC4B-4563-A94B-43499B4E80DD}"/>
+                <a16:creationId xmlns:a16="http://schemas.microsoft.com/office/drawing/2014/main" id="{F2851C49-6CDF-4DB0-826B-E3C57BD78C43}"/>
               </a:ext>
             </a:extLst>
           </p:cNvPr>
@@ -26496,7 +26496,7 @@
           <p:cNvPr id="25" name="구현 · 폭 3">
             <a:extLst xmlns:a="http://schemas.openxmlformats.org/drawingml/2006/main">
               <a:ext uri="{FF2B5EF4-FFF2-40B4-BE49-F238E27FC236}">
-                <a16:creationId xmlns:a16="http://schemas.microsoft.com/office/drawing/2014/main" id="{0B693FBE-30EB-4770-8643-CFD4E8C9CA95}"/>
+                <a16:creationId xmlns:a16="http://schemas.microsoft.com/office/drawing/2014/main" id="{8830846D-436E-4813-9A4E-ADD7A293FF8C}"/>
               </a:ext>
             </a:extLst>
           </p:cNvPr>
@@ -26654,7 +26654,7 @@
           <p:cNvPr id="26" name="">
             <a:extLst xmlns:a="http://schemas.openxmlformats.org/drawingml/2006/main">
               <a:ext uri="{FF2B5EF4-FFF2-40B4-BE49-F238E27FC236}">
-                <a16:creationId xmlns:a16="http://schemas.microsoft.com/office/drawing/2014/main" id="{73CDEB15-7051-47F8-AC8D-787F20581DCD}"/>
+                <a16:creationId xmlns:a16="http://schemas.microsoft.com/office/drawing/2014/main" id="{E8BEEDA2-DA02-40E9-8B4F-726721EEAEFA}"/>
               </a:ext>
             </a:extLst>
           </p:cNvPr>
@@ -26687,7 +26687,7 @@
           <p:cNvPr id="27" name="2">
             <a:extLst xmlns:a="http://schemas.openxmlformats.org/drawingml/2006/main">
               <a:ext uri="{FF2B5EF4-FFF2-40B4-BE49-F238E27FC236}">
-                <a16:creationId xmlns:a16="http://schemas.microsoft.com/office/drawing/2014/main" id="{D2E84B1A-47B8-4487-A0B6-512825B47559}"/>
+                <a16:creationId xmlns:a16="http://schemas.microsoft.com/office/drawing/2014/main" id="{7BC4F6BB-F772-4FB2-8461-38415CCC6EB4}"/>
               </a:ext>
             </a:extLst>
           </p:cNvPr>
@@ -26845,7 +26845,7 @@
           <p:cNvPr id="28" name="">
             <a:extLst xmlns:a="http://schemas.openxmlformats.org/drawingml/2006/main">
               <a:ext uri="{FF2B5EF4-FFF2-40B4-BE49-F238E27FC236}">
-                <a16:creationId xmlns:a16="http://schemas.microsoft.com/office/drawing/2014/main" id="{AA0268CC-2310-4020-89A0-48F013FA25EB}"/>
+                <a16:creationId xmlns:a16="http://schemas.microsoft.com/office/drawing/2014/main" id="{70BF5D03-E567-4269-881C-767D2CE2C31F}"/>
               </a:ext>
             </a:extLst>
           </p:cNvPr>
@@ -26878,7 +26878,7 @@
           <p:cNvPr id="29" name="3">
             <a:extLst xmlns:a="http://schemas.openxmlformats.org/drawingml/2006/main">
               <a:ext uri="{FF2B5EF4-FFF2-40B4-BE49-F238E27FC236}">
-                <a16:creationId xmlns:a16="http://schemas.microsoft.com/office/drawing/2014/main" id="{11DF6B74-E4E5-45FB-9029-274AA6C60CD2}"/>
+                <a16:creationId xmlns:a16="http://schemas.microsoft.com/office/drawing/2014/main" id="{746E9999-B214-4FE2-9EF5-5D678FD14738}"/>
               </a:ext>
             </a:extLst>
           </p:cNvPr>
@@ -27036,7 +27036,7 @@
           <p:cNvPr id="30" name="">
             <a:extLst xmlns:a="http://schemas.openxmlformats.org/drawingml/2006/main">
               <a:ext uri="{FF2B5EF4-FFF2-40B4-BE49-F238E27FC236}">
-                <a16:creationId xmlns:a16="http://schemas.microsoft.com/office/drawing/2014/main" id="{6C9926D3-3430-4095-BE51-47B6A9E3B78A}"/>
+                <a16:creationId xmlns:a16="http://schemas.microsoft.com/office/drawing/2014/main" id="{BDF3A618-ABC8-4660-8023-B81DCCDEE179}"/>
               </a:ext>
             </a:extLst>
           </p:cNvPr>
@@ -27069,7 +27069,7 @@
           <p:cNvPr id="31" name="2">
             <a:extLst xmlns:a="http://schemas.openxmlformats.org/drawingml/2006/main">
               <a:ext uri="{FF2B5EF4-FFF2-40B4-BE49-F238E27FC236}">
-                <a16:creationId xmlns:a16="http://schemas.microsoft.com/office/drawing/2014/main" id="{0E44ACEA-255E-421A-BD81-09FD7DF1FEFD}"/>
+                <a16:creationId xmlns:a16="http://schemas.microsoft.com/office/drawing/2014/main" id="{99DC1A43-2EE7-4727-9033-1B983FC04FC2}"/>
               </a:ext>
             </a:extLst>
           </p:cNvPr>
@@ -27227,7 +27227,7 @@
           <p:cNvPr id="32" name="">
             <a:extLst xmlns:a="http://schemas.openxmlformats.org/drawingml/2006/main">
               <a:ext uri="{FF2B5EF4-FFF2-40B4-BE49-F238E27FC236}">
-                <a16:creationId xmlns:a16="http://schemas.microsoft.com/office/drawing/2014/main" id="{B01E2645-6F3A-4B98-80D0-107A8A7D1690}"/>
+                <a16:creationId xmlns:a16="http://schemas.microsoft.com/office/drawing/2014/main" id="{49A654CD-2B04-468F-9962-99A8901B1C8A}"/>
               </a:ext>
             </a:extLst>
           </p:cNvPr>
@@ -27260,7 +27260,7 @@
           <p:cNvPr id="33" name="3">
             <a:extLst xmlns:a="http://schemas.openxmlformats.org/drawingml/2006/main">
               <a:ext uri="{FF2B5EF4-FFF2-40B4-BE49-F238E27FC236}">
-                <a16:creationId xmlns:a16="http://schemas.microsoft.com/office/drawing/2014/main" id="{E87579F1-B7EF-4120-A1EB-5C0BC15B68C0}"/>
+                <a16:creationId xmlns:a16="http://schemas.microsoft.com/office/drawing/2014/main" id="{CDF0929E-EEAC-4DE8-B5B6-03799E21FAF6}"/>
               </a:ext>
             </a:extLst>
           </p:cNvPr>
@@ -27418,7 +27418,7 @@
           <p:cNvPr id="34" name="">
             <a:extLst xmlns:a="http://schemas.openxmlformats.org/drawingml/2006/main">
               <a:ext uri="{FF2B5EF4-FFF2-40B4-BE49-F238E27FC236}">
-                <a16:creationId xmlns:a16="http://schemas.microsoft.com/office/drawing/2014/main" id="{107A4DB8-313E-4A93-BB8C-74EC3A6C0592}"/>
+                <a16:creationId xmlns:a16="http://schemas.microsoft.com/office/drawing/2014/main" id="{1F356C0B-3A5D-4B75-B19E-D0D66A867D00}"/>
               </a:ext>
             </a:extLst>
           </p:cNvPr>
@@ -27451,7 +27451,7 @@
           <p:cNvPr id="35" name="4">
             <a:extLst xmlns:a="http://schemas.openxmlformats.org/drawingml/2006/main">
               <a:ext uri="{FF2B5EF4-FFF2-40B4-BE49-F238E27FC236}">
-                <a16:creationId xmlns:a16="http://schemas.microsoft.com/office/drawing/2014/main" id="{BFDC4969-B4E4-41C8-9408-4265B1A4D92C}"/>
+                <a16:creationId xmlns:a16="http://schemas.microsoft.com/office/drawing/2014/main" id="{18E84BDA-4AE3-451F-8969-809B8E955A5D}"/>
               </a:ext>
             </a:extLst>
           </p:cNvPr>
@@ -27609,7 +27609,7 @@
           <p:cNvPr id="36" name="명세와 구현의 범위 불일치">
             <a:extLst xmlns:a="http://schemas.openxmlformats.org/drawingml/2006/main">
               <a:ext uri="{FF2B5EF4-FFF2-40B4-BE49-F238E27FC236}">
-                <a16:creationId xmlns:a16="http://schemas.microsoft.com/office/drawing/2014/main" id="{C954F54F-065F-4BFB-A989-E445894B93B4}"/>
+                <a16:creationId xmlns:a16="http://schemas.microsoft.com/office/drawing/2014/main" id="{83EC8D19-7C54-4A09-BFF5-77AF4BEDC69F}"/>
               </a:ext>
             </a:extLst>
           </p:cNvPr>
@@ -27767,7 +27767,7 @@
           <p:cNvPr id="37" name="">
             <a:extLst xmlns:a="http://schemas.openxmlformats.org/drawingml/2006/main">
               <a:ext uri="{FF2B5EF4-FFF2-40B4-BE49-F238E27FC236}">
-                <a16:creationId xmlns:a16="http://schemas.microsoft.com/office/drawing/2014/main" id="{70E7C3B7-BC86-4052-9C2D-3950DE9F6BE6}"/>
+                <a16:creationId xmlns:a16="http://schemas.microsoft.com/office/drawing/2014/main" id="{3621E306-F5CD-489B-83FA-B92630B768C2}"/>
               </a:ext>
             </a:extLst>
           </p:cNvPr>
@@ -27798,7 +27798,7 @@
           <p:cNvPr id="38" name="조사에서 연결한 근거">
             <a:extLst xmlns:a="http://schemas.openxmlformats.org/drawingml/2006/main">
               <a:ext uri="{FF2B5EF4-FFF2-40B4-BE49-F238E27FC236}">
-                <a16:creationId xmlns:a16="http://schemas.microsoft.com/office/drawing/2014/main" id="{4651904A-6853-455B-9F95-D7B0D583335F}"/>
+                <a16:creationId xmlns:a16="http://schemas.microsoft.com/office/drawing/2014/main" id="{EB7F9088-5CD2-423D-A907-4605C488C79A}"/>
               </a:ext>
             </a:extLst>
           </p:cNvPr>
@@ -27956,7 +27956,7 @@
           <p:cNvPr id="39" name="01  실패 테스트">
             <a:extLst xmlns:a="http://schemas.openxmlformats.org/drawingml/2006/main">
               <a:ext uri="{FF2B5EF4-FFF2-40B4-BE49-F238E27FC236}">
-                <a16:creationId xmlns:a16="http://schemas.microsoft.com/office/drawing/2014/main" id="{367FCC86-84A2-477D-AB95-8CB636C632A2}"/>
+                <a16:creationId xmlns:a16="http://schemas.microsoft.com/office/drawing/2014/main" id="{9639F4B4-6DB0-4245-9C0D-D0FCE2940307}"/>
               </a:ext>
             </a:extLst>
           </p:cNvPr>
@@ -28114,7 +28114,7 @@
           <p:cNvPr id="40" name="test_crop_excludes_&#10;end_coordinate">
             <a:extLst xmlns:a="http://schemas.openxmlformats.org/drawingml/2006/main">
               <a:ext uri="{FF2B5EF4-FFF2-40B4-BE49-F238E27FC236}">
-                <a16:creationId xmlns:a16="http://schemas.microsoft.com/office/drawing/2014/main" id="{E2238661-F43A-460C-A7FC-E87B3318D7CF}"/>
+                <a16:creationId xmlns:a16="http://schemas.microsoft.com/office/drawing/2014/main" id="{472302B6-ED97-4466-BC9A-E02EA1592794}"/>
               </a:ext>
             </a:extLst>
           </p:cNvPr>
@@ -28295,7 +28295,7 @@
           <p:cNvPr id="41" name="02  제품의 호출 경로">
             <a:extLst xmlns:a="http://schemas.openxmlformats.org/drawingml/2006/main">
               <a:ext uri="{FF2B5EF4-FFF2-40B4-BE49-F238E27FC236}">
-                <a16:creationId xmlns:a16="http://schemas.microsoft.com/office/drawing/2014/main" id="{49504AF7-EADF-4EE3-931D-65E99D639D4B}"/>
+                <a16:creationId xmlns:a16="http://schemas.microsoft.com/office/drawing/2014/main" id="{70B343F7-D86F-4121-BF1D-7B1F92F0EE3C}"/>
               </a:ext>
             </a:extLst>
           </p:cNvPr>
@@ -28453,7 +28453,7 @@
           <p:cNvPr id="42" name="cli.main → process_image → crop">
             <a:extLst xmlns:a="http://schemas.openxmlformats.org/drawingml/2006/main">
               <a:ext uri="{FF2B5EF4-FFF2-40B4-BE49-F238E27FC236}">
-                <a16:creationId xmlns:a16="http://schemas.microsoft.com/office/drawing/2014/main" id="{A028C526-0FB6-4E81-B4F3-229CAC846447}"/>
+                <a16:creationId xmlns:a16="http://schemas.microsoft.com/office/drawing/2014/main" id="{868A3C0C-4C17-46AA-BEA0-00CFD00B51B4}"/>
               </a:ext>
             </a:extLst>
           </p:cNvPr>
@@ -28611,7 +28611,7 @@
           <p:cNvPr id="43" name="03  끝 좌표까지 포함한 구현">
             <a:extLst xmlns:a="http://schemas.openxmlformats.org/drawingml/2006/main">
               <a:ext uri="{FF2B5EF4-FFF2-40B4-BE49-F238E27FC236}">
-                <a16:creationId xmlns:a16="http://schemas.microsoft.com/office/drawing/2014/main" id="{D572E39D-2260-40E5-8C35-F2EF426E5EF5}"/>
+                <a16:creationId xmlns:a16="http://schemas.microsoft.com/office/drawing/2014/main" id="{54DC4CCE-54C7-42E6-8B31-120ACE142B47}"/>
               </a:ext>
             </a:extLst>
           </p:cNvPr>
@@ -28769,7 +28769,7 @@
           <p:cNvPr id="44" name="row[x_start : x_end + 1]">
             <a:extLst xmlns:a="http://schemas.openxmlformats.org/drawingml/2006/main">
               <a:ext uri="{FF2B5EF4-FFF2-40B4-BE49-F238E27FC236}">
-                <a16:creationId xmlns:a16="http://schemas.microsoft.com/office/drawing/2014/main" id="{78DB29F3-F3FE-47FB-A679-84466DE9B662}"/>
+                <a16:creationId xmlns:a16="http://schemas.microsoft.com/office/drawing/2014/main" id="{B5E05278-CE87-487D-B08B-F961878E9BBE}"/>
               </a:ext>
             </a:extLst>
           </p:cNvPr>
@@ -28927,7 +28927,7 @@
           <p:cNvPr id="45" name="Legacy module connection">
             <a:extLst xmlns:a="http://schemas.openxmlformats.org/drawingml/2006/main">
               <a:ext uri="{FF2B5EF4-FFF2-40B4-BE49-F238E27FC236}">
-                <a16:creationId xmlns:a16="http://schemas.microsoft.com/office/drawing/2014/main" id="{9FD84B87-EDE7-4DCD-991A-3A7BD4358784}"/>
+                <a16:creationId xmlns:a16="http://schemas.microsoft.com/office/drawing/2014/main" id="{440374AB-B574-433C-BACD-AC1287E3D0C1}"/>
               </a:ext>
             </a:extLst>
           </p:cNvPr>
@@ -29083,7 +29083,7 @@
     </p:spTree>
     <p:extLst>
       <p:ext uri="{BB962C8B-B14F-4D97-AF65-F5344CB8AC3E}">
-        <p14:creationId xmlns:p14="http://schemas.microsoft.com/office/powerpoint/2010/main" val="508572483"/>
+        <p14:creationId xmlns:p14="http://schemas.microsoft.com/office/powerpoint/2010/main" val="1858312699"/>
       </p:ext>
     </p:extLst>
   </p:cSld>
@@ -29114,7 +29114,7 @@
           <p:cNvPr id="21" name="ACT 0 · 전달한 Context와 실행 환경">
             <a:extLst xmlns:a="http://schemas.openxmlformats.org/drawingml/2006/main">
               <a:ext uri="{FF2B5EF4-FFF2-40B4-BE49-F238E27FC236}">
-                <a16:creationId xmlns:a16="http://schemas.microsoft.com/office/drawing/2014/main" id="{82F6E077-6829-4684-98C5-46E15BAB5EA1}"/>
+                <a16:creationId xmlns:a16="http://schemas.microsoft.com/office/drawing/2014/main" id="{8D5D59E8-9711-4541-9152-8939575C4048}"/>
               </a:ext>
             </a:extLst>
           </p:cNvPr>
@@ -29272,7 +29272,7 @@
           <p:cNvPr id="2" name="S06">
             <a:extLst xmlns:a="http://schemas.openxmlformats.org/drawingml/2006/main">
               <a:ext uri="{FF2B5EF4-FFF2-40B4-BE49-F238E27FC236}">
-                <a16:creationId xmlns:a16="http://schemas.microsoft.com/office/drawing/2014/main" id="{D684F20D-B6DB-42E0-9C0A-DCF28EA9CB28}"/>
+                <a16:creationId xmlns:a16="http://schemas.microsoft.com/office/drawing/2014/main" id="{FC5F89E4-6064-46CE-8742-A2AE6C4A4EA3}"/>
               </a:ext>
             </a:extLst>
           </p:cNvPr>
@@ -29430,7 +29430,7 @@
           <p:cNvPr id="3" name="관찰 결과와 실행 제한을 분리한다">
             <a:extLst xmlns:a="http://schemas.openxmlformats.org/drawingml/2006/main">
               <a:ext uri="{FF2B5EF4-FFF2-40B4-BE49-F238E27FC236}">
-                <a16:creationId xmlns:a16="http://schemas.microsoft.com/office/drawing/2014/main" id="{FC3FCF4F-D0D0-4F3D-9215-8B9E0FF8E093}"/>
+                <a16:creationId xmlns:a16="http://schemas.microsoft.com/office/drawing/2014/main" id="{69642D9B-ED6A-4C75-93C2-55045211A926}"/>
               </a:ext>
             </a:extLst>
           </p:cNvPr>
@@ -29588,7 +29588,7 @@
           <p:cNvPr id="4" name="">
             <a:extLst xmlns:a="http://schemas.openxmlformats.org/drawingml/2006/main">
               <a:ext uri="{FF2B5EF4-FFF2-40B4-BE49-F238E27FC236}">
-                <a16:creationId xmlns:a16="http://schemas.microsoft.com/office/drawing/2014/main" id="{6D77DB4B-9699-4A95-A48F-C33361129C49}"/>
+                <a16:creationId xmlns:a16="http://schemas.microsoft.com/office/drawing/2014/main" id="{FF4E1FAC-4042-448E-95CB-7733EE110D09}"/>
               </a:ext>
             </a:extLst>
           </p:cNvPr>
@@ -29619,7 +29619,7 @@
           <p:cNvPr id="5" name="TRIAL-001 관찰 + Context 범위의 교육용 해석 · Codex CLI 0.154.0 · 읽기 전">
             <a:extLst xmlns:a="http://schemas.openxmlformats.org/drawingml/2006/main">
               <a:ext uri="{FF2B5EF4-FFF2-40B4-BE49-F238E27FC236}">
-                <a16:creationId xmlns:a16="http://schemas.microsoft.com/office/drawing/2014/main" id="{98DF5AC9-7DA8-4178-8562-DE9952891E65}"/>
+                <a16:creationId xmlns:a16="http://schemas.microsoft.com/office/drawing/2014/main" id="{F18BF8B9-7DF8-4255-8F64-E2D898DC4F8D}"/>
               </a:ext>
             </a:extLst>
           </p:cNvPr>
@@ -29777,7 +29777,7 @@
           <p:cNvPr id="6" name="Chatbot과의 비교 실험 아님 · 이 Trial에서 코드 수정·읽기 전용 권한 해제 없음">
             <a:extLst xmlns:a="http://schemas.openxmlformats.org/drawingml/2006/main">
               <a:ext uri="{FF2B5EF4-FFF2-40B4-BE49-F238E27FC236}">
-                <a16:creationId xmlns:a16="http://schemas.microsoft.com/office/drawing/2014/main" id="{71FEC99C-50CA-4E2B-88D4-20073568E0AC}"/>
+                <a16:creationId xmlns:a16="http://schemas.microsoft.com/office/drawing/2014/main" id="{1C3EED1C-C3BE-466E-9947-990F6AEE2491}"/>
               </a:ext>
             </a:extLst>
           </p:cNvPr>
@@ -29935,7 +29935,7 @@
           <p:cNvPr id="7" name="Chatbot에 코드·명세만 골라 넣었다면?">
             <a:extLst xmlns:a="http://schemas.openxmlformats.org/drawingml/2006/main">
               <a:ext uri="{FF2B5EF4-FFF2-40B4-BE49-F238E27FC236}">
-                <a16:creationId xmlns:a16="http://schemas.microsoft.com/office/drawing/2014/main" id="{DD2F223D-C826-4356-B889-2A2882BE374A}"/>
+                <a16:creationId xmlns:a16="http://schemas.microsoft.com/office/drawing/2014/main" id="{3A00AD3C-B080-4DAD-B6BA-3DF61288740D}"/>
               </a:ext>
             </a:extLst>
           </p:cNvPr>
@@ -30093,7 +30093,7 @@
           <p:cNvPr id="8" name="코드 Context로 논의할 수 있는 부분">
             <a:extLst xmlns:a="http://schemas.openxmlformats.org/drawingml/2006/main">
               <a:ext uri="{FF2B5EF4-FFF2-40B4-BE49-F238E27FC236}">
-                <a16:creationId xmlns:a16="http://schemas.microsoft.com/office/drawing/2014/main" id="{D6455478-D1CB-4E2F-8575-EA972A7A0C27}"/>
+                <a16:creationId xmlns:a16="http://schemas.microsoft.com/office/drawing/2014/main" id="{3961DA31-4B1C-48DB-B84D-126672159E04}"/>
               </a:ext>
             </a:extLst>
           </p:cNvPr>
@@ -30251,7 +30251,7 @@
           <p:cNvPr id="9" name="함께 전달하지 않은 실행 환경">
             <a:extLst xmlns:a="http://schemas.openxmlformats.org/drawingml/2006/main">
               <a:ext uri="{FF2B5EF4-FFF2-40B4-BE49-F238E27FC236}">
-                <a16:creationId xmlns:a16="http://schemas.microsoft.com/office/drawing/2014/main" id="{C68EF714-64F0-4C5C-82C1-2C2F6AAF019F}"/>
+                <a16:creationId xmlns:a16="http://schemas.microsoft.com/office/drawing/2014/main" id="{EA09520C-6A70-4354-B2F9-0D565019EC90}"/>
               </a:ext>
             </a:extLst>
           </p:cNvPr>
@@ -30409,7 +30409,7 @@
           <p:cNvPr id="10" name="">
             <a:extLst xmlns:a="http://schemas.openxmlformats.org/drawingml/2006/main">
               <a:ext uri="{FF2B5EF4-FFF2-40B4-BE49-F238E27FC236}">
-                <a16:creationId xmlns:a16="http://schemas.microsoft.com/office/drawing/2014/main" id="{0510C80F-9B33-427F-A52C-66C6446ABD38}"/>
+                <a16:creationId xmlns:a16="http://schemas.microsoft.com/office/drawing/2014/main" id="{BE18DE0F-C42A-4083-B435-88A1C0D9E1EC}"/>
               </a:ext>
             </a:extLst>
           </p:cNvPr>
@@ -30442,7 +30442,7 @@
           <p:cNvPr id="11" name="">
             <a:extLst xmlns:a="http://schemas.openxmlformats.org/drawingml/2006/main">
               <a:ext uri="{FF2B5EF4-FFF2-40B4-BE49-F238E27FC236}">
-                <a16:creationId xmlns:a16="http://schemas.microsoft.com/office/drawing/2014/main" id="{7A56F872-34FA-44EE-96FC-3CEE13C4FDB6}"/>
+                <a16:creationId xmlns:a16="http://schemas.microsoft.com/office/drawing/2014/main" id="{DCEB6BB5-C417-42A1-A1A8-DF69B37D1E92}"/>
               </a:ext>
             </a:extLst>
           </p:cNvPr>
@@ -30473,7 +30473,7 @@
           <p:cNvPr id="12" name="기대 폭 2 ↔ 포함 폭 3">
             <a:extLst xmlns:a="http://schemas.openxmlformats.org/drawingml/2006/main">
               <a:ext uri="{FF2B5EF4-FFF2-40B4-BE49-F238E27FC236}">
-                <a16:creationId xmlns:a16="http://schemas.microsoft.com/office/drawing/2014/main" id="{FDC9B1B0-7D03-4279-97EF-FE2534C6957B}"/>
+                <a16:creationId xmlns:a16="http://schemas.microsoft.com/office/drawing/2014/main" id="{4C795BF4-C2E0-4B6D-A013-BA120C2CB821}"/>
               </a:ext>
             </a:extLst>
           </p:cNvPr>
@@ -30631,7 +30631,7 @@
           <p:cNvPr id="13" name="명세·테스트·구현을 비교&#10;추가된 열의 원인을 추론">
             <a:extLst xmlns:a="http://schemas.openxmlformats.org/drawingml/2006/main">
               <a:ext uri="{FF2B5EF4-FFF2-40B4-BE49-F238E27FC236}">
-                <a16:creationId xmlns:a16="http://schemas.microsoft.com/office/drawing/2014/main" id="{7142A857-2340-4B5C-A0E4-2AC776F6B1EB}"/>
+                <a16:creationId xmlns:a16="http://schemas.microsoft.com/office/drawing/2014/main" id="{FF1CE221-42A4-4D88-A191-EB0C1A445AF8}"/>
               </a:ext>
             </a:extLst>
           </p:cNvPr>
@@ -30812,7 +30812,7 @@
           <p:cNvPr id="14" name="TRIAL-001: 원인 설명·코드 미수정">
             <a:extLst xmlns:a="http://schemas.openxmlformats.org/drawingml/2006/main">
               <a:ext uri="{FF2B5EF4-FFF2-40B4-BE49-F238E27FC236}">
-                <a16:creationId xmlns:a16="http://schemas.microsoft.com/office/drawing/2014/main" id="{761758F4-3F3B-4C38-AA4D-E86F2521E351}"/>
+                <a16:creationId xmlns:a16="http://schemas.microsoft.com/office/drawing/2014/main" id="{37090A12-0B08-4533-8AFD-009AAB8FA551}"/>
               </a:ext>
             </a:extLst>
           </p:cNvPr>
@@ -30970,7 +30970,7 @@
           <p:cNvPr id="15" name="읽기 전용 · 임시 디렉터리 제한">
             <a:extLst xmlns:a="http://schemas.openxmlformats.org/drawingml/2006/main">
               <a:ext uri="{FF2B5EF4-FFF2-40B4-BE49-F238E27FC236}">
-                <a16:creationId xmlns:a16="http://schemas.microsoft.com/office/drawing/2014/main" id="{036A4FC7-0009-47F6-B753-E63440D413A8}"/>
+                <a16:creationId xmlns:a16="http://schemas.microsoft.com/office/drawing/2014/main" id="{55053B0F-2B5A-49CC-80AE-1CE9306F5E0A}"/>
               </a:ext>
             </a:extLst>
           </p:cNvPr>
@@ -31128,7 +31128,7 @@
           <p:cNvPr id="16" name="코드만으로는 부족&#10;실행 로그·권한 정보도 필요">
             <a:extLst xmlns:a="http://schemas.openxmlformats.org/drawingml/2006/main">
               <a:ext uri="{FF2B5EF4-FFF2-40B4-BE49-F238E27FC236}">
-                <a16:creationId xmlns:a16="http://schemas.microsoft.com/office/drawing/2014/main" id="{AE0406FB-F4FB-406B-8CE9-65FA8404563D}"/>
+                <a16:creationId xmlns:a16="http://schemas.microsoft.com/office/drawing/2014/main" id="{DCCBC51A-F7A2-4A61-B26B-5A3BEC110276}"/>
               </a:ext>
             </a:extLst>
           </p:cNvPr>
@@ -31309,7 +31309,7 @@
           <p:cNvPr id="17" name="TRIAL-001도 환경 오류 3건">
             <a:extLst xmlns:a="http://schemas.openxmlformats.org/drawingml/2006/main">
               <a:ext uri="{FF2B5EF4-FFF2-40B4-BE49-F238E27FC236}">
-                <a16:creationId xmlns:a16="http://schemas.microsoft.com/office/drawing/2014/main" id="{F5EA2909-DB57-431D-8AEE-838AF7691FBD}"/>
+                <a16:creationId xmlns:a16="http://schemas.microsoft.com/office/drawing/2014/main" id="{0EFFEFFB-BF6F-4092-A0DD-3296D3F6E69C}"/>
               </a:ext>
             </a:extLst>
           </p:cNvPr>
@@ -31467,7 +31467,7 @@
           <p:cNvPr id="18" name="코드만 옮기면, 실행 환경의 단서는 빠진다.">
             <a:extLst xmlns:a="http://schemas.openxmlformats.org/drawingml/2006/main">
               <a:ext uri="{FF2B5EF4-FFF2-40B4-BE49-F238E27FC236}">
-                <a16:creationId xmlns:a16="http://schemas.microsoft.com/office/drawing/2014/main" id="{B5203234-039E-4653-88EE-DCE078CC2F4E}"/>
+                <a16:creationId xmlns:a16="http://schemas.microsoft.com/office/drawing/2014/main" id="{5336042B-EE12-4B96-8CC7-48F0B1DF541B}"/>
               </a:ext>
             </a:extLst>
           </p:cNvPr>
@@ -31625,7 +31625,7 @@
           <p:cNvPr id="19" name="실제 전체 기록: 7개 통과 · crop 실패 1건 · 환경 오류 3건">
             <a:extLst xmlns:a="http://schemas.openxmlformats.org/drawingml/2006/main">
               <a:ext uri="{FF2B5EF4-FFF2-40B4-BE49-F238E27FC236}">
-                <a16:creationId xmlns:a16="http://schemas.microsoft.com/office/drawing/2014/main" id="{60475873-2738-4523-B9EF-F1B8633898CC}"/>
+                <a16:creationId xmlns:a16="http://schemas.microsoft.com/office/drawing/2014/main" id="{895A5D9D-3B46-4190-854F-F8A2BAF55C5E}"/>
               </a:ext>
             </a:extLst>
           </p:cNvPr>
@@ -31783,7 +31783,7 @@
           <p:cNvPr id="20" name="Legacy module connection">
             <a:extLst xmlns:a="http://schemas.openxmlformats.org/drawingml/2006/main">
               <a:ext uri="{FF2B5EF4-FFF2-40B4-BE49-F238E27FC236}">
-                <a16:creationId xmlns:a16="http://schemas.microsoft.com/office/drawing/2014/main" id="{B2C4D231-4584-4BB7-8629-8C3C5461B4B6}"/>
+                <a16:creationId xmlns:a16="http://schemas.microsoft.com/office/drawing/2014/main" id="{E27658DC-EB98-4F8D-AA06-4B2BE70DBD4F}"/>
               </a:ext>
             </a:extLst>
           </p:cNvPr>
@@ -31939,7 +31939,7 @@
     </p:spTree>
     <p:extLst>
       <p:ext uri="{BB962C8B-B14F-4D97-AF65-F5344CB8AC3E}">
-        <p14:creationId xmlns:p14="http://schemas.microsoft.com/office/powerpoint/2010/main" val="491149811"/>
+        <p14:creationId xmlns:p14="http://schemas.microsoft.com/office/powerpoint/2010/main" val="1464108301"/>
       </p:ext>
     </p:extLst>
   </p:cSld>
@@ -31970,7 +31970,7 @@
           <p:cNvPr id="14" name="ACT 0 · Context를 찾는 주체">
             <a:extLst xmlns:a="http://schemas.openxmlformats.org/drawingml/2006/main">
               <a:ext uri="{FF2B5EF4-FFF2-40B4-BE49-F238E27FC236}">
-                <a16:creationId xmlns:a16="http://schemas.microsoft.com/office/drawing/2014/main" id="{CDD76895-44D1-42D3-B73F-D8A8A0366273}"/>
+                <a16:creationId xmlns:a16="http://schemas.microsoft.com/office/drawing/2014/main" id="{32744688-D77C-422F-BE54-D0C2A8A862FD}"/>
               </a:ext>
             </a:extLst>
           </p:cNvPr>
@@ -32128,7 +32128,7 @@
           <p:cNvPr id="2" name="S07">
             <a:extLst xmlns:a="http://schemas.openxmlformats.org/drawingml/2006/main">
               <a:ext uri="{FF2B5EF4-FFF2-40B4-BE49-F238E27FC236}">
-                <a16:creationId xmlns:a16="http://schemas.microsoft.com/office/drawing/2014/main" id="{8CE3AC64-9410-4596-BCC0-784C02F54911}"/>
+                <a16:creationId xmlns:a16="http://schemas.microsoft.com/office/drawing/2014/main" id="{A745B1E3-0748-4F26-A87E-9C79B5AAF6AB}"/>
               </a:ext>
             </a:extLst>
           </p:cNvPr>
@@ -32286,7 +32286,7 @@
           <p:cNvPr id="3" name="코드를 AI에게 가져가는 대신&#10;AI를 Repository로 데려간다">
             <a:extLst xmlns:a="http://schemas.openxmlformats.org/drawingml/2006/main">
               <a:ext uri="{FF2B5EF4-FFF2-40B4-BE49-F238E27FC236}">
-                <a16:creationId xmlns:a16="http://schemas.microsoft.com/office/drawing/2014/main" id="{11E6D027-EF0D-4DC3-846C-0F18733CD09C}"/>
+                <a16:creationId xmlns:a16="http://schemas.microsoft.com/office/drawing/2014/main" id="{E07310EF-AC9F-45F4-9BD2-2AB998BA222C}"/>
               </a:ext>
             </a:extLst>
           </p:cNvPr>
@@ -32467,7 +32467,7 @@
           <p:cNvPr id="4" name="">
             <a:extLst xmlns:a="http://schemas.openxmlformats.org/drawingml/2006/main">
               <a:ext uri="{FF2B5EF4-FFF2-40B4-BE49-F238E27FC236}">
-                <a16:creationId xmlns:a16="http://schemas.microsoft.com/office/drawing/2014/main" id="{0BF35155-E330-4681-BA6A-5F58C91FA3E8}"/>
+                <a16:creationId xmlns:a16="http://schemas.microsoft.com/office/drawing/2014/main" id="{F2827210-7918-48FF-9F63-C74234B662F4}"/>
               </a:ext>
             </a:extLst>
           </p:cNvPr>
@@ -32498,7 +32498,7 @@
           <p:cNvPr id="5" name="교육 모델 · TRIAL-001 단일 CLI 관찰과 연결 · AI 생성 설명용 삽화">
             <a:extLst xmlns:a="http://schemas.openxmlformats.org/drawingml/2006/main">
               <a:ext uri="{FF2B5EF4-FFF2-40B4-BE49-F238E27FC236}">
-                <a16:creationId xmlns:a16="http://schemas.microsoft.com/office/drawing/2014/main" id="{56A1431C-CE7A-4FCC-836A-5C9E7F35476C}"/>
+                <a16:creationId xmlns:a16="http://schemas.microsoft.com/office/drawing/2014/main" id="{8623F5A5-7B65-4515-8D22-847B2CFC5BA1}"/>
               </a:ext>
             </a:extLst>
           </p:cNvPr>
@@ -32656,7 +32656,7 @@
           <p:cNvPr id="6" name="목표 설정과 근거 검토는 개발자에게 남습니다. Repository 접근이 Task 의도를 정하지는 않습니다.">
             <a:extLst xmlns:a="http://schemas.openxmlformats.org/drawingml/2006/main">
               <a:ext uri="{FF2B5EF4-FFF2-40B4-BE49-F238E27FC236}">
-                <a16:creationId xmlns:a16="http://schemas.microsoft.com/office/drawing/2014/main" id="{4B4690AA-72C5-4B2D-BB16-9F7559814979}"/>
+                <a16:creationId xmlns:a16="http://schemas.microsoft.com/office/drawing/2014/main" id="{1764A970-6CFF-4F6B-BDFB-E06A85251D2F}"/>
               </a:ext>
             </a:extLst>
           </p:cNvPr>
@@ -32814,7 +32814,7 @@
           <p:cNvPr id="7" name="내가 골라 전달하는 Context">
             <a:extLst xmlns:a="http://schemas.openxmlformats.org/drawingml/2006/main">
               <a:ext uri="{FF2B5EF4-FFF2-40B4-BE49-F238E27FC236}">
-                <a16:creationId xmlns:a16="http://schemas.microsoft.com/office/drawing/2014/main" id="{9E547050-3E6F-486B-B6E4-5CB6A967CCD0}"/>
+                <a16:creationId xmlns:a16="http://schemas.microsoft.com/office/drawing/2014/main" id="{7751ED79-E2F4-4557-92A5-EB28269CF383}"/>
               </a:ext>
             </a:extLst>
           </p:cNvPr>
@@ -32972,7 +32972,7 @@
           <p:cNvPr id="8" name="조사를 맡기고 근거를 확인">
             <a:extLst xmlns:a="http://schemas.openxmlformats.org/drawingml/2006/main">
               <a:ext uri="{FF2B5EF4-FFF2-40B4-BE49-F238E27FC236}">
-                <a16:creationId xmlns:a16="http://schemas.microsoft.com/office/drawing/2014/main" id="{0935FC97-E26E-43B2-867C-8F839DCFAD02}"/>
+                <a16:creationId xmlns:a16="http://schemas.microsoft.com/office/drawing/2014/main" id="{672AAC44-56DD-4BA5-9D0A-D2DAEEB6DDED}"/>
               </a:ext>
             </a:extLst>
           </p:cNvPr>
@@ -33130,7 +33130,7 @@
           <p:cNvPr id="9" name="">
             <a:extLst xmlns:a="http://schemas.openxmlformats.org/drawingml/2006/main">
               <a:ext uri="{FF2B5EF4-FFF2-40B4-BE49-F238E27FC236}">
-                <a16:creationId xmlns:a16="http://schemas.microsoft.com/office/drawing/2014/main" id="{333E9F70-E035-4A2B-9AD5-E88C851EC63C}"/>
+                <a16:creationId xmlns:a16="http://schemas.microsoft.com/office/drawing/2014/main" id="{DAC6F3F6-43D4-4D7B-BE97-042F5F3CDA17}"/>
               </a:ext>
             </a:extLst>
           </p:cNvPr>
@@ -33140,7 +33140,7 @@
           <p:nvPr/>
         </p:nvPicPr>
         <p:blipFill>
-          <a:blip xmlns:r="http://schemas.openxmlformats.org/officeDocument/2006/relationships" xmlns:a="http://schemas.openxmlformats.org/drawingml/2006/main" r:embed="Rc129d9b542e44e9b"/>
+          <a:blip xmlns:r="http://schemas.openxmlformats.org/officeDocument/2006/relationships" xmlns:a="http://schemas.openxmlformats.org/drawingml/2006/main" r:embed="Rc715b2d3fc024084"/>
           <a:srcRect xmlns:a="http://schemas.openxmlformats.org/drawingml/2006/main" l="0" t="18000" r="0" b="15000"/>
           <a:stretch xmlns:a="http://schemas.openxmlformats.org/drawingml/2006/main"/>
         </p:blipFill>
@@ -33159,7 +33159,7 @@
           <p:cNvPr id="10" name="코드 조각을 선택·복사">
             <a:extLst xmlns:a="http://schemas.openxmlformats.org/drawingml/2006/main">
               <a:ext uri="{FF2B5EF4-FFF2-40B4-BE49-F238E27FC236}">
-                <a16:creationId xmlns:a16="http://schemas.microsoft.com/office/drawing/2014/main" id="{3259BBB2-B705-4017-A1D1-33438648D3F5}"/>
+                <a16:creationId xmlns:a16="http://schemas.microsoft.com/office/drawing/2014/main" id="{25E7E4A9-FBC6-44DB-9674-3DB354805E7B}"/>
               </a:ext>
             </a:extLst>
           </p:cNvPr>
@@ -33317,7 +33317,7 @@
           <p:cNvPr id="11" name="목표는 사람이, 탐색은 Agent와">
             <a:extLst xmlns:a="http://schemas.openxmlformats.org/drawingml/2006/main">
               <a:ext uri="{FF2B5EF4-FFF2-40B4-BE49-F238E27FC236}">
-                <a16:creationId xmlns:a16="http://schemas.microsoft.com/office/drawing/2014/main" id="{CCF2363E-1ACF-477F-9C7E-8D2FE3FA11D1}"/>
+                <a16:creationId xmlns:a16="http://schemas.microsoft.com/office/drawing/2014/main" id="{15F8B7B9-539F-4E0E-83B8-C8B6B7FD2549}"/>
               </a:ext>
             </a:extLst>
           </p:cNvPr>
@@ -33475,7 +33475,7 @@
           <p:cNvPr id="12" name="접근 전: 승인된 도구·계정·자료·권한 범위를 확인한다.">
             <a:extLst xmlns:a="http://schemas.openxmlformats.org/drawingml/2006/main">
               <a:ext uri="{FF2B5EF4-FFF2-40B4-BE49-F238E27FC236}">
-                <a16:creationId xmlns:a16="http://schemas.microsoft.com/office/drawing/2014/main" id="{F9E2E2A9-E061-4087-99BB-C3F6C6DEC220}"/>
+                <a16:creationId xmlns:a16="http://schemas.microsoft.com/office/drawing/2014/main" id="{34D4D375-EA63-43BB-A830-E7AAA8438845}"/>
               </a:ext>
             </a:extLst>
           </p:cNvPr>
@@ -33633,7 +33633,7 @@
           <p:cNvPr id="13" name="Legacy module connection">
             <a:extLst xmlns:a="http://schemas.openxmlformats.org/drawingml/2006/main">
               <a:ext uri="{FF2B5EF4-FFF2-40B4-BE49-F238E27FC236}">
-                <a16:creationId xmlns:a16="http://schemas.microsoft.com/office/drawing/2014/main" id="{D2A07D3A-8C66-4A37-812F-0879DDFA47DB}"/>
+                <a16:creationId xmlns:a16="http://schemas.microsoft.com/office/drawing/2014/main" id="{FCDF9806-244B-4778-A497-41CFC1F5D298}"/>
               </a:ext>
             </a:extLst>
           </p:cNvPr>
@@ -33789,7 +33789,7 @@
     </p:spTree>
     <p:extLst>
       <p:ext uri="{BB962C8B-B14F-4D97-AF65-F5344CB8AC3E}">
-        <p14:creationId xmlns:p14="http://schemas.microsoft.com/office/powerpoint/2010/main" val="1399103392"/>
+        <p14:creationId xmlns:p14="http://schemas.microsoft.com/office/powerpoint/2010/main" val="472577355"/>
       </p:ext>
     </p:extLst>
   </p:cSld>
@@ -33820,7 +33820,7 @@
           <p:cNvPr id="29" name="ACT 0 · ChatGPT 데스크톱 앱의 진입 경로">
             <a:extLst xmlns:a="http://schemas.openxmlformats.org/drawingml/2006/main">
               <a:ext uri="{FF2B5EF4-FFF2-40B4-BE49-F238E27FC236}">
-                <a16:creationId xmlns:a16="http://schemas.microsoft.com/office/drawing/2014/main" id="{B41BCBD1-8E77-44FE-B854-901A42EBAD51}"/>
+                <a16:creationId xmlns:a16="http://schemas.microsoft.com/office/drawing/2014/main" id="{6A43ED3F-C5C6-4396-BDA7-E7D2406D6DF8}"/>
               </a:ext>
             </a:extLst>
           </p:cNvPr>
@@ -33978,7 +33978,7 @@
           <p:cNvPr id="2" name="S08">
             <a:extLst xmlns:a="http://schemas.openxmlformats.org/drawingml/2006/main">
               <a:ext uri="{FF2B5EF4-FFF2-40B4-BE49-F238E27FC236}">
-                <a16:creationId xmlns:a16="http://schemas.microsoft.com/office/drawing/2014/main" id="{448C57EC-4657-4181-A789-7CEB77CED468}"/>
+                <a16:creationId xmlns:a16="http://schemas.microsoft.com/office/drawing/2014/main" id="{E05AB2D8-61DC-4B44-AEC7-739CE5CA07C4}"/>
               </a:ext>
             </a:extLst>
           </p:cNvPr>
@@ -34136,7 +34136,7 @@
           <p:cNvPr id="3" name="Repository 작업은 Codex에서 시작한다">
             <a:extLst xmlns:a="http://schemas.openxmlformats.org/drawingml/2006/main">
               <a:ext uri="{FF2B5EF4-FFF2-40B4-BE49-F238E27FC236}">
-                <a16:creationId xmlns:a16="http://schemas.microsoft.com/office/drawing/2014/main" id="{2C1860AE-B75B-4418-BEF9-3425071D9C32}"/>
+                <a16:creationId xmlns:a16="http://schemas.microsoft.com/office/drawing/2014/main" id="{1F22B3E8-2913-4DE5-BCF9-A7C77757621D}"/>
               </a:ext>
             </a:extLst>
           </p:cNvPr>
@@ -34294,7 +34294,7 @@
           <p:cNvPr id="4" name="">
             <a:extLst xmlns:a="http://schemas.openxmlformats.org/drawingml/2006/main">
               <a:ext uri="{FF2B5EF4-FFF2-40B4-BE49-F238E27FC236}">
-                <a16:creationId xmlns:a16="http://schemas.microsoft.com/office/drawing/2014/main" id="{0AB69364-76E2-49EB-BAAC-624E2E684425}"/>
+                <a16:creationId xmlns:a16="http://schemas.microsoft.com/office/drawing/2014/main" id="{7D00EAB3-DE42-4AD1-BFB1-07E434571132}"/>
               </a:ext>
             </a:extLst>
           </p:cNvPr>
@@ -34325,7 +34325,7 @@
           <p:cNvPr id="5" name="OpenAI Quickstart · 공식 문서 2026-10-21 확인 · 앱 전환 메뉴 재구성">
             <a:extLst xmlns:a="http://schemas.openxmlformats.org/drawingml/2006/main">
               <a:ext uri="{FF2B5EF4-FFF2-40B4-BE49-F238E27FC236}">
-                <a16:creationId xmlns:a16="http://schemas.microsoft.com/office/drawing/2014/main" id="{9CD2DDD2-0E90-4E45-A5CE-AAE878D0E442}"/>
+                <a16:creationId xmlns:a16="http://schemas.microsoft.com/office/drawing/2014/main" id="{E0D295F1-F1DC-432C-AC7D-C428252C7680}"/>
               </a:ext>
             </a:extLst>
           </p:cNvPr>
@@ -34483,7 +34483,7 @@
           <p:cNvPr id="6" name="교육용 도식입니다. 앱 버전·계정별 표시와 접근 권한은 발표 환경에서 확인합니다.">
             <a:extLst xmlns:a="http://schemas.openxmlformats.org/drawingml/2006/main">
               <a:ext uri="{FF2B5EF4-FFF2-40B4-BE49-F238E27FC236}">
-                <a16:creationId xmlns:a16="http://schemas.microsoft.com/office/drawing/2014/main" id="{894A2CFF-7D14-4040-910E-682F4E1792BD}"/>
+                <a16:creationId xmlns:a16="http://schemas.microsoft.com/office/drawing/2014/main" id="{3DF7B0A5-E55B-49FA-B123-E1D8F7FC2FE8}"/>
               </a:ext>
             </a:extLst>
           </p:cNvPr>
@@ -34641,7 +34641,7 @@
           <p:cNvPr id="7" name="앱 좌측 상단에서 ChatGPT → Codex 선택">
             <a:extLst xmlns:a="http://schemas.openxmlformats.org/drawingml/2006/main">
               <a:ext uri="{FF2B5EF4-FFF2-40B4-BE49-F238E27FC236}">
-                <a16:creationId xmlns:a16="http://schemas.microsoft.com/office/drawing/2014/main" id="{D1BF53B2-E2A9-4BF2-BDE2-7B9584C96ECB}"/>
+                <a16:creationId xmlns:a16="http://schemas.microsoft.com/office/drawing/2014/main" id="{FE0BBC04-E562-4CE8-87E8-A81C8684678E}"/>
               </a:ext>
             </a:extLst>
           </p:cNvPr>
@@ -34799,7 +34799,7 @@
           <p:cNvPr id="8" name="">
             <a:extLst xmlns:a="http://schemas.openxmlformats.org/drawingml/2006/main">
               <a:ext uri="{FF2B5EF4-FFF2-40B4-BE49-F238E27FC236}">
-                <a16:creationId xmlns:a16="http://schemas.microsoft.com/office/drawing/2014/main" id="{F7C6949F-E045-4413-917D-90479C0EB648}"/>
+                <a16:creationId xmlns:a16="http://schemas.microsoft.com/office/drawing/2014/main" id="{95E39F32-42B1-4BF8-AC3A-8F1DCBD98819}"/>
               </a:ext>
             </a:extLst>
           </p:cNvPr>
@@ -34832,7 +34832,7 @@
           <p:cNvPr id="9" name="ChatGPT">
             <a:extLst xmlns:a="http://schemas.openxmlformats.org/drawingml/2006/main">
               <a:ext uri="{FF2B5EF4-FFF2-40B4-BE49-F238E27FC236}">
-                <a16:creationId xmlns:a16="http://schemas.microsoft.com/office/drawing/2014/main" id="{6C799162-29CF-4D69-8A84-C8120BBC989C}"/>
+                <a16:creationId xmlns:a16="http://schemas.microsoft.com/office/drawing/2014/main" id="{D9A55E25-6792-4D24-9859-7AEAC900A884}"/>
               </a:ext>
             </a:extLst>
           </p:cNvPr>
@@ -34990,7 +34990,7 @@
           <p:cNvPr id="10" name="▾">
             <a:extLst xmlns:a="http://schemas.openxmlformats.org/drawingml/2006/main">
               <a:ext uri="{FF2B5EF4-FFF2-40B4-BE49-F238E27FC236}">
-                <a16:creationId xmlns:a16="http://schemas.microsoft.com/office/drawing/2014/main" id="{564B875D-9E1C-4A40-A82B-F8ED0A320CAA}"/>
+                <a16:creationId xmlns:a16="http://schemas.microsoft.com/office/drawing/2014/main" id="{0198F75B-2DD9-4CC2-9C6F-35ED33D20C77}"/>
               </a:ext>
             </a:extLst>
           </p:cNvPr>
@@ -35148,7 +35148,7 @@
           <p:cNvPr id="11" name="">
             <a:extLst xmlns:a="http://schemas.openxmlformats.org/drawingml/2006/main">
               <a:ext uri="{FF2B5EF4-FFF2-40B4-BE49-F238E27FC236}">
-                <a16:creationId xmlns:a16="http://schemas.microsoft.com/office/drawing/2014/main" id="{77675BD2-A5BC-4639-9DDD-490E48A10BAD}"/>
+                <a16:creationId xmlns:a16="http://schemas.microsoft.com/office/drawing/2014/main" id="{DF02D369-248C-4CE6-B06A-D741E552718D}"/>
               </a:ext>
             </a:extLst>
           </p:cNvPr>
@@ -35181,7 +35181,7 @@
           <p:cNvPr id="12" name="ChatGPT">
             <a:extLst xmlns:a="http://schemas.openxmlformats.org/drawingml/2006/main">
               <a:ext uri="{FF2B5EF4-FFF2-40B4-BE49-F238E27FC236}">
-                <a16:creationId xmlns:a16="http://schemas.microsoft.com/office/drawing/2014/main" id="{02D52EF6-7B79-48A6-BB2C-A52D3E00991A}"/>
+                <a16:creationId xmlns:a16="http://schemas.microsoft.com/office/drawing/2014/main" id="{EB03EC81-1AB7-4616-B428-A77941FE4C05}"/>
               </a:ext>
             </a:extLst>
           </p:cNvPr>
@@ -35339,7 +35339,7 @@
           <p:cNvPr id="13" name="">
             <a:extLst xmlns:a="http://schemas.openxmlformats.org/drawingml/2006/main">
               <a:ext uri="{FF2B5EF4-FFF2-40B4-BE49-F238E27FC236}">
-                <a16:creationId xmlns:a16="http://schemas.microsoft.com/office/drawing/2014/main" id="{E1D9FA99-95A6-40F4-A460-C801701E5EE5}"/>
+                <a16:creationId xmlns:a16="http://schemas.microsoft.com/office/drawing/2014/main" id="{E98E2D24-C86E-4A59-8826-DE0AE13A99E9}"/>
               </a:ext>
             </a:extLst>
           </p:cNvPr>
@@ -35370,7 +35370,7 @@
           <p:cNvPr id="14" name="Codex">
             <a:extLst xmlns:a="http://schemas.openxmlformats.org/drawingml/2006/main">
               <a:ext uri="{FF2B5EF4-FFF2-40B4-BE49-F238E27FC236}">
-                <a16:creationId xmlns:a16="http://schemas.microsoft.com/office/drawing/2014/main" id="{28F6457E-A0D0-44DF-AB3D-5A633657EE7D}"/>
+                <a16:creationId xmlns:a16="http://schemas.microsoft.com/office/drawing/2014/main" id="{43F03706-5ACB-4476-8A4F-3BA9EABF8830}"/>
               </a:ext>
             </a:extLst>
           </p:cNvPr>
@@ -35528,7 +35528,7 @@
           <p:cNvPr id="15" name="✓">
             <a:extLst xmlns:a="http://schemas.openxmlformats.org/drawingml/2006/main">
               <a:ext uri="{FF2B5EF4-FFF2-40B4-BE49-F238E27FC236}">
-                <a16:creationId xmlns:a16="http://schemas.microsoft.com/office/drawing/2014/main" id="{D785E15E-3A43-41A2-A005-019FFED85DB4}"/>
+                <a16:creationId xmlns:a16="http://schemas.microsoft.com/office/drawing/2014/main" id="{3A2A7CD8-32E7-4BBC-BC76-93ABF612B0ED}"/>
               </a:ext>
             </a:extLst>
           </p:cNvPr>
@@ -35686,7 +35686,7 @@
           <p:cNvPr id="16" name="전환 메뉴 재구성">
             <a:extLst xmlns:a="http://schemas.openxmlformats.org/drawingml/2006/main">
               <a:ext uri="{FF2B5EF4-FFF2-40B4-BE49-F238E27FC236}">
-                <a16:creationId xmlns:a16="http://schemas.microsoft.com/office/drawing/2014/main" id="{37D05F64-959E-4B9B-A753-A534CEC854F2}"/>
+                <a16:creationId xmlns:a16="http://schemas.microsoft.com/office/drawing/2014/main" id="{8BD81E4A-494E-4E53-8FBC-63CB81538969}"/>
               </a:ext>
             </a:extLst>
           </p:cNvPr>
@@ -35844,7 +35844,7 @@
           <p:cNvPr id="17" name="">
             <a:extLst xmlns:a="http://schemas.openxmlformats.org/drawingml/2006/main">
               <a:ext uri="{FF2B5EF4-FFF2-40B4-BE49-F238E27FC236}">
-                <a16:creationId xmlns:a16="http://schemas.microsoft.com/office/drawing/2014/main" id="{F15ECBA3-EDCE-476F-82F2-A8F451723CCB}"/>
+                <a16:creationId xmlns:a16="http://schemas.microsoft.com/office/drawing/2014/main" id="{FAB5CDA8-0FAA-4816-A9BE-242BBF61190F}"/>
               </a:ext>
             </a:extLst>
           </p:cNvPr>
@@ -35874,7 +35874,7 @@
           <p:cNvPr id="18" name="01">
             <a:extLst xmlns:a="http://schemas.openxmlformats.org/drawingml/2006/main">
               <a:ext uri="{FF2B5EF4-FFF2-40B4-BE49-F238E27FC236}">
-                <a16:creationId xmlns:a16="http://schemas.microsoft.com/office/drawing/2014/main" id="{D49DEE7F-9EED-42AA-ADCC-4C31546CB05E}"/>
+                <a16:creationId xmlns:a16="http://schemas.microsoft.com/office/drawing/2014/main" id="{5688DC14-99EB-486A-83C4-07D80487A138}"/>
               </a:ext>
             </a:extLst>
           </p:cNvPr>
@@ -36032,7 +36032,7 @@
           <p:cNvPr id="19" name="Codex 선택">
             <a:extLst xmlns:a="http://schemas.openxmlformats.org/drawingml/2006/main">
               <a:ext uri="{FF2B5EF4-FFF2-40B4-BE49-F238E27FC236}">
-                <a16:creationId xmlns:a16="http://schemas.microsoft.com/office/drawing/2014/main" id="{FC3F511E-B127-40B8-9C87-D597C6B5AC94}"/>
+                <a16:creationId xmlns:a16="http://schemas.microsoft.com/office/drawing/2014/main" id="{AC199F40-62D8-473F-83C2-469BF07E65F9}"/>
               </a:ext>
             </a:extLst>
           </p:cNvPr>
@@ -36190,7 +36190,7 @@
           <p:cNvPr id="20" name="개발 작업으로 전환">
             <a:extLst xmlns:a="http://schemas.openxmlformats.org/drawingml/2006/main">
               <a:ext uri="{FF2B5EF4-FFF2-40B4-BE49-F238E27FC236}">
-                <a16:creationId xmlns:a16="http://schemas.microsoft.com/office/drawing/2014/main" id="{AE239B8A-C180-42E6-B0BE-0381BDBCFC03}"/>
+                <a16:creationId xmlns:a16="http://schemas.microsoft.com/office/drawing/2014/main" id="{EF29303A-FCDA-4F9B-B11F-C40BD1F16E6E}"/>
               </a:ext>
             </a:extLst>
           </p:cNvPr>
@@ -36348,7 +36348,7 @@
           <p:cNvPr id="21" name="02">
             <a:extLst xmlns:a="http://schemas.openxmlformats.org/drawingml/2006/main">
               <a:ext uri="{FF2B5EF4-FFF2-40B4-BE49-F238E27FC236}">
-                <a16:creationId xmlns:a16="http://schemas.microsoft.com/office/drawing/2014/main" id="{DCA40723-2037-4C71-96E0-810F71EE4F32}"/>
+                <a16:creationId xmlns:a16="http://schemas.microsoft.com/office/drawing/2014/main" id="{999FA16A-F939-4665-922C-C1C45C21C5F1}"/>
               </a:ext>
             </a:extLst>
           </p:cNvPr>
@@ -36506,7 +36506,7 @@
           <p:cNvPr id="22" name="Repository 폴더 열기">
             <a:extLst xmlns:a="http://schemas.openxmlformats.org/drawingml/2006/main">
               <a:ext uri="{FF2B5EF4-FFF2-40B4-BE49-F238E27FC236}">
-                <a16:creationId xmlns:a16="http://schemas.microsoft.com/office/drawing/2014/main" id="{BECB7593-CF52-4A36-A769-94424A0F3231}"/>
+                <a16:creationId xmlns:a16="http://schemas.microsoft.com/office/drawing/2014/main" id="{7751711B-4C2D-4EA4-A55A-1B46549638C7}"/>
               </a:ext>
             </a:extLst>
           </p:cNvPr>
@@ -36664,7 +36664,7 @@
           <p:cNvPr id="23" name="코드가 있는 폴더를 작업 위치로">
             <a:extLst xmlns:a="http://schemas.openxmlformats.org/drawingml/2006/main">
               <a:ext uri="{FF2B5EF4-FFF2-40B4-BE49-F238E27FC236}">
-                <a16:creationId xmlns:a16="http://schemas.microsoft.com/office/drawing/2014/main" id="{84BB70E4-3EBA-4851-A120-72B637C8699F}"/>
+                <a16:creationId xmlns:a16="http://schemas.microsoft.com/office/drawing/2014/main" id="{3CE296C3-2ADF-40A5-BC20-A8DF39069818}"/>
               </a:ext>
             </a:extLst>
           </p:cNvPr>
@@ -36822,7 +36822,7 @@
           <p:cNvPr id="24" name="03">
             <a:extLst xmlns:a="http://schemas.openxmlformats.org/drawingml/2006/main">
               <a:ext uri="{FF2B5EF4-FFF2-40B4-BE49-F238E27FC236}">
-                <a16:creationId xmlns:a16="http://schemas.microsoft.com/office/drawing/2014/main" id="{3B4C0848-3078-41FC-8BDC-DFCE32D69BA3}"/>
+                <a16:creationId xmlns:a16="http://schemas.microsoft.com/office/drawing/2014/main" id="{0DD22202-E733-4290-9100-BEF9153583DB}"/>
               </a:ext>
             </a:extLst>
           </p:cNvPr>
@@ -36980,7 +36980,7 @@
           <p:cNvPr id="25" name="수정 전에 조사부터 요청">
             <a:extLst xmlns:a="http://schemas.openxmlformats.org/drawingml/2006/main">
               <a:ext uri="{FF2B5EF4-FFF2-40B4-BE49-F238E27FC236}">
-                <a16:creationId xmlns:a16="http://schemas.microsoft.com/office/drawing/2014/main" id="{FB0AE7CA-F31B-4590-82A3-E78D67EBE4AD}"/>
+                <a16:creationId xmlns:a16="http://schemas.microsoft.com/office/drawing/2014/main" id="{FDC8E571-2076-40CA-BC7A-420FF66D64A7}"/>
               </a:ext>
             </a:extLst>
           </p:cNvPr>
@@ -37138,7 +37138,7 @@
           <p:cNvPr id="26" name="찾은 파일과 근거를 함께 확인">
             <a:extLst xmlns:a="http://schemas.openxmlformats.org/drawingml/2006/main">
               <a:ext uri="{FF2B5EF4-FFF2-40B4-BE49-F238E27FC236}">
-                <a16:creationId xmlns:a16="http://schemas.microsoft.com/office/drawing/2014/main" id="{69CF603D-FD08-40E0-A631-AB55CEEFAC2A}"/>
+                <a16:creationId xmlns:a16="http://schemas.microsoft.com/office/drawing/2014/main" id="{2969FE89-CB59-4CFE-B77D-11118C82A6CE}"/>
               </a:ext>
             </a:extLst>
           </p:cNvPr>
@@ -37296,7 +37296,7 @@
           <p:cNvPr id="27" name="이 교육의 Repository 조사는 Codex로 진행한다.">
             <a:extLst xmlns:a="http://schemas.openxmlformats.org/drawingml/2006/main">
               <a:ext uri="{FF2B5EF4-FFF2-40B4-BE49-F238E27FC236}">
-                <a16:creationId xmlns:a16="http://schemas.microsoft.com/office/drawing/2014/main" id="{31E2610B-4493-487E-B587-00F5CAD40363}"/>
+                <a16:creationId xmlns:a16="http://schemas.microsoft.com/office/drawing/2014/main" id="{F8F17E9D-E93A-4B11-8E69-BAF72E5330CB}"/>
               </a:ext>
             </a:extLst>
           </p:cNvPr>
@@ -37454,7 +37454,7 @@
           <p:cNvPr id="28" name="Legacy module connection">
             <a:extLst xmlns:a="http://schemas.openxmlformats.org/drawingml/2006/main">
               <a:ext uri="{FF2B5EF4-FFF2-40B4-BE49-F238E27FC236}">
-                <a16:creationId xmlns:a16="http://schemas.microsoft.com/office/drawing/2014/main" id="{F98E22E1-7297-4145-9839-328F7028C01D}"/>
+                <a16:creationId xmlns:a16="http://schemas.microsoft.com/office/drawing/2014/main" id="{DA0A1830-2422-4C61-BB57-F809B89CB854}"/>
               </a:ext>
             </a:extLst>
           </p:cNvPr>
@@ -37610,7 +37610,7 @@
     </p:spTree>
     <p:extLst>
       <p:ext uri="{BB962C8B-B14F-4D97-AF65-F5344CB8AC3E}">
-        <p14:creationId xmlns:p14="http://schemas.microsoft.com/office/powerpoint/2010/main" val="1108679959"/>
+        <p14:creationId xmlns:p14="http://schemas.microsoft.com/office/powerpoint/2010/main" val="853599474"/>
       </p:ext>
     </p:extLst>
   </p:cSld>
@@ -37641,7 +37641,7 @@
           <p:cNvPr id="23" name="ACT 0 · 누가 볼 수 있고, 누가 정하는가">
             <a:extLst xmlns:a="http://schemas.openxmlformats.org/drawingml/2006/main">
               <a:ext uri="{FF2B5EF4-FFF2-40B4-BE49-F238E27FC236}">
-                <a16:creationId xmlns:a16="http://schemas.microsoft.com/office/drawing/2014/main" id="{76C2D97F-913C-47B1-B7B1-8A5B727CAD00}"/>
+                <a16:creationId xmlns:a16="http://schemas.microsoft.com/office/drawing/2014/main" id="{E7CF2A50-9A00-4C44-AAD0-95EBC82130A7}"/>
               </a:ext>
             </a:extLst>
           </p:cNvPr>
@@ -37799,7 +37799,7 @@
           <p:cNvPr id="2" name="S09">
             <a:extLst xmlns:a="http://schemas.openxmlformats.org/drawingml/2006/main">
               <a:ext uri="{FF2B5EF4-FFF2-40B4-BE49-F238E27FC236}">
-                <a16:creationId xmlns:a16="http://schemas.microsoft.com/office/drawing/2014/main" id="{82EF5DBB-AC88-4134-817D-4AD6D4A42B4F}"/>
+                <a16:creationId xmlns:a16="http://schemas.microsoft.com/office/drawing/2014/main" id="{07D24D06-22CA-41B4-B501-2E17D03BC9C3}"/>
               </a:ext>
             </a:extLst>
           </p:cNvPr>
@@ -37957,7 +37957,7 @@
           <p:cNvPr id="3" name="Repository 접근과 Task 의도는 별개다">
             <a:extLst xmlns:a="http://schemas.openxmlformats.org/drawingml/2006/main">
               <a:ext uri="{FF2B5EF4-FFF2-40B4-BE49-F238E27FC236}">
-                <a16:creationId xmlns:a16="http://schemas.microsoft.com/office/drawing/2014/main" id="{187CB010-E89B-40E1-96DD-A5FAF9EA5056}"/>
+                <a16:creationId xmlns:a16="http://schemas.microsoft.com/office/drawing/2014/main" id="{062B98E2-EE75-4CC6-BB49-E12BD6CF9949}"/>
               </a:ext>
             </a:extLst>
           </p:cNvPr>
@@ -38115,7 +38115,7 @@
           <p:cNvPr id="4" name="">
             <a:extLst xmlns:a="http://schemas.openxmlformats.org/drawingml/2006/main">
               <a:ext uri="{FF2B5EF4-FFF2-40B4-BE49-F238E27FC236}">
-                <a16:creationId xmlns:a16="http://schemas.microsoft.com/office/drawing/2014/main" id="{7228D747-AEAF-4811-9ABF-547724B25077}"/>
+                <a16:creationId xmlns:a16="http://schemas.microsoft.com/office/drawing/2014/main" id="{8AD08F56-C064-40BF-B361-D68C7BB69312}"/>
               </a:ext>
             </a:extLst>
           </p:cNvPr>
@@ -38146,7 +38146,7 @@
           <p:cNvPr id="5" name="이 과정의 교육 모델 · 정보 접근과 최종 결정 책임의 구분 · AI 생성 역할 아이콘">
             <a:extLst xmlns:a="http://schemas.openxmlformats.org/drawingml/2006/main">
               <a:ext uri="{FF2B5EF4-FFF2-40B4-BE49-F238E27FC236}">
-                <a16:creationId xmlns:a16="http://schemas.microsoft.com/office/drawing/2014/main" id="{DCC59BB5-B97A-4A52-86E0-011ABF57D27A}"/>
+                <a16:creationId xmlns:a16="http://schemas.microsoft.com/office/drawing/2014/main" id="{FFBEC498-D059-4225-8C0C-39E96EB72BDB}"/>
               </a:ext>
             </a:extLst>
           </p:cNvPr>
@@ -38304,7 +38304,7 @@
           <p:cNvPr id="6" name="Agent는 조사·제안을 할 수 있습니다. 목표·허용 범위·완료 수용의 최종 결정과 책임은 사람에게 있습니다">
             <a:extLst xmlns:a="http://schemas.openxmlformats.org/drawingml/2006/main">
               <a:ext uri="{FF2B5EF4-FFF2-40B4-BE49-F238E27FC236}">
-                <a16:creationId xmlns:a16="http://schemas.microsoft.com/office/drawing/2014/main" id="{2DA91476-C0FD-4814-BA01-FA09DE0C7615}"/>
+                <a16:creationId xmlns:a16="http://schemas.microsoft.com/office/drawing/2014/main" id="{C23CF6DC-2917-4203-9209-633691246D56}"/>
               </a:ext>
             </a:extLst>
           </p:cNvPr>
@@ -38462,7 +38462,7 @@
           <p:cNvPr id="7" name="볼 수 있는 것">
             <a:extLst xmlns:a="http://schemas.openxmlformats.org/drawingml/2006/main">
               <a:ext uri="{FF2B5EF4-FFF2-40B4-BE49-F238E27FC236}">
-                <a16:creationId xmlns:a16="http://schemas.microsoft.com/office/drawing/2014/main" id="{A712F77D-9AB2-4EDD-996C-E904F6DCF99C}"/>
+                <a16:creationId xmlns:a16="http://schemas.microsoft.com/office/drawing/2014/main" id="{0A959750-E5CB-4C97-9D1B-DBA07A3A5557}"/>
               </a:ext>
             </a:extLst>
           </p:cNvPr>
@@ -38620,7 +38620,7 @@
           <p:cNvPr id="8" name="정해야 하는 것">
             <a:extLst xmlns:a="http://schemas.openxmlformats.org/drawingml/2006/main">
               <a:ext uri="{FF2B5EF4-FFF2-40B4-BE49-F238E27FC236}">
-                <a16:creationId xmlns:a16="http://schemas.microsoft.com/office/drawing/2014/main" id="{EDA324CC-F7F4-4FE2-8FD8-4E9F583F3197}"/>
+                <a16:creationId xmlns:a16="http://schemas.microsoft.com/office/drawing/2014/main" id="{1FA215F9-E904-44E5-95D2-CB6E29C5253A}"/>
               </a:ext>
             </a:extLst>
           </p:cNvPr>
@@ -38778,7 +38778,7 @@
           <p:cNvPr id="9" name="">
             <a:extLst xmlns:a="http://schemas.openxmlformats.org/drawingml/2006/main">
               <a:ext uri="{FF2B5EF4-FFF2-40B4-BE49-F238E27FC236}">
-                <a16:creationId xmlns:a16="http://schemas.microsoft.com/office/drawing/2014/main" id="{5BD0DCB8-4B41-4D4D-AA46-5FE1C9584005}"/>
+                <a16:creationId xmlns:a16="http://schemas.microsoft.com/office/drawing/2014/main" id="{82F41231-79E4-47DB-8202-28DC30062933}"/>
               </a:ext>
             </a:extLst>
           </p:cNvPr>
@@ -38788,7 +38788,7 @@
           <p:nvPr/>
         </p:nvPicPr>
         <p:blipFill>
-          <a:blip xmlns:r="http://schemas.openxmlformats.org/officeDocument/2006/relationships" xmlns:a="http://schemas.openxmlformats.org/drawingml/2006/main" r:embed="Rb1ff7ec016cc4f1c"/>
+          <a:blip xmlns:r="http://schemas.openxmlformats.org/officeDocument/2006/relationships" xmlns:a="http://schemas.openxmlformats.org/drawingml/2006/main" r:embed="R84c1cf23ebdf4e32"/>
           <a:srcRect xmlns:a="http://schemas.openxmlformats.org/drawingml/2006/main" l="0" t="0" r="50000" b="0"/>
           <a:stretch xmlns:a="http://schemas.openxmlformats.org/drawingml/2006/main"/>
         </p:blipFill>
@@ -38807,7 +38807,7 @@
           <p:cNvPr id="10" name="사람">
             <a:extLst xmlns:a="http://schemas.openxmlformats.org/drawingml/2006/main">
               <a:ext uri="{FF2B5EF4-FFF2-40B4-BE49-F238E27FC236}">
-                <a16:creationId xmlns:a16="http://schemas.microsoft.com/office/drawing/2014/main" id="{7D993301-82F9-44CD-9789-404F3086C966}"/>
+                <a16:creationId xmlns:a16="http://schemas.microsoft.com/office/drawing/2014/main" id="{46A92308-087D-4B04-95CE-195E86B66EEC}"/>
               </a:ext>
             </a:extLst>
           </p:cNvPr>
@@ -38965,7 +38965,7 @@
           <p:cNvPr id="11" name="+">
             <a:extLst xmlns:a="http://schemas.openxmlformats.org/drawingml/2006/main">
               <a:ext uri="{FF2B5EF4-FFF2-40B4-BE49-F238E27FC236}">
-                <a16:creationId xmlns:a16="http://schemas.microsoft.com/office/drawing/2014/main" id="{16280007-4782-4D16-A162-FBF43D5A9922}"/>
+                <a16:creationId xmlns:a16="http://schemas.microsoft.com/office/drawing/2014/main" id="{4FBB311C-44DE-4CFA-BD99-ECA63CEA86DD}"/>
               </a:ext>
             </a:extLst>
           </p:cNvPr>
@@ -39123,7 +39123,7 @@
           <p:cNvPr id="12" name="">
             <a:extLst xmlns:a="http://schemas.openxmlformats.org/drawingml/2006/main">
               <a:ext uri="{FF2B5EF4-FFF2-40B4-BE49-F238E27FC236}">
-                <a16:creationId xmlns:a16="http://schemas.microsoft.com/office/drawing/2014/main" id="{4A53060F-7C1C-4B4D-ACC5-8621BC269EE9}"/>
+                <a16:creationId xmlns:a16="http://schemas.microsoft.com/office/drawing/2014/main" id="{EB4283DC-72A8-43FB-994D-46AED2A752B5}"/>
               </a:ext>
             </a:extLst>
           </p:cNvPr>
@@ -39133,7 +39133,7 @@
           <p:nvPr/>
         </p:nvPicPr>
         <p:blipFill>
-          <a:blip xmlns:r="http://schemas.openxmlformats.org/officeDocument/2006/relationships" xmlns:a="http://schemas.openxmlformats.org/drawingml/2006/main" r:embed="Rec852667cd7e42e0"/>
+          <a:blip xmlns:r="http://schemas.openxmlformats.org/officeDocument/2006/relationships" xmlns:a="http://schemas.openxmlformats.org/drawingml/2006/main" r:embed="R27f3203907bb4d9a"/>
           <a:srcRect xmlns:a="http://schemas.openxmlformats.org/drawingml/2006/main" l="50000" t="0" r="0" b="0"/>
           <a:stretch xmlns:a="http://schemas.openxmlformats.org/drawingml/2006/main"/>
         </p:blipFill>
@@ -39152,7 +39152,7 @@
           <p:cNvPr id="13" name="AI Agent">
             <a:extLst xmlns:a="http://schemas.openxmlformats.org/drawingml/2006/main">
               <a:ext uri="{FF2B5EF4-FFF2-40B4-BE49-F238E27FC236}">
-                <a16:creationId xmlns:a16="http://schemas.microsoft.com/office/drawing/2014/main" id="{85E72FC0-6C5A-4879-9043-ED39014B0C1A}"/>
+                <a16:creationId xmlns:a16="http://schemas.microsoft.com/office/drawing/2014/main" id="{88B0B95C-3304-4D41-A24C-CD91ACC4B6F7}"/>
               </a:ext>
             </a:extLst>
           </p:cNvPr>
@@ -39310,7 +39310,7 @@
           <p:cNvPr id="14" name="">
             <a:extLst xmlns:a="http://schemas.openxmlformats.org/drawingml/2006/main">
               <a:ext uri="{FF2B5EF4-FFF2-40B4-BE49-F238E27FC236}">
-                <a16:creationId xmlns:a16="http://schemas.microsoft.com/office/drawing/2014/main" id="{F81CD32C-653A-4F34-BFDE-B2850CB45864}"/>
+                <a16:creationId xmlns:a16="http://schemas.microsoft.com/office/drawing/2014/main" id="{38334F17-1C21-4FEC-8C35-735CE980ED0E}"/>
               </a:ext>
             </a:extLst>
           </p:cNvPr>
@@ -39320,7 +39320,7 @@
           <p:nvPr/>
         </p:nvPicPr>
         <p:blipFill>
-          <a:blip xmlns:r="http://schemas.openxmlformats.org/officeDocument/2006/relationships" xmlns:a="http://schemas.openxmlformats.org/drawingml/2006/main" r:embed="Rf5f1e9b1cd44403f"/>
+          <a:blip xmlns:r="http://schemas.openxmlformats.org/officeDocument/2006/relationships" xmlns:a="http://schemas.openxmlformats.org/drawingml/2006/main" r:embed="R66db9b1d90584764"/>
           <a:srcRect xmlns:a="http://schemas.openxmlformats.org/drawingml/2006/main" l="0" t="0" r="50000" b="0"/>
           <a:stretch xmlns:a="http://schemas.openxmlformats.org/drawingml/2006/main"/>
         </p:blipFill>
@@ -39339,7 +39339,7 @@
           <p:cNvPr id="15" name="사람이 최종 결정">
             <a:extLst xmlns:a="http://schemas.openxmlformats.org/drawingml/2006/main">
               <a:ext uri="{FF2B5EF4-FFF2-40B4-BE49-F238E27FC236}">
-                <a16:creationId xmlns:a16="http://schemas.microsoft.com/office/drawing/2014/main" id="{72E1A7EA-047F-4B86-8189-19444A598C38}"/>
+                <a16:creationId xmlns:a16="http://schemas.microsoft.com/office/drawing/2014/main" id="{378A83EB-8041-43BD-A43A-223AFFFCE68E}"/>
               </a:ext>
             </a:extLst>
           </p:cNvPr>
@@ -39497,7 +39497,7 @@
           <p:cNvPr id="16" name="">
             <a:extLst xmlns:a="http://schemas.openxmlformats.org/drawingml/2006/main">
               <a:ext uri="{FF2B5EF4-FFF2-40B4-BE49-F238E27FC236}">
-                <a16:creationId xmlns:a16="http://schemas.microsoft.com/office/drawing/2014/main" id="{6BFAD040-0503-46CC-A095-15A4DEA7147E}"/>
+                <a16:creationId xmlns:a16="http://schemas.microsoft.com/office/drawing/2014/main" id="{C74F2A51-AF72-4EA4-B9B9-7140F41ADE85}"/>
               </a:ext>
             </a:extLst>
           </p:cNvPr>
@@ -39528,7 +39528,7 @@
           <p:cNvPr id="17" name="">
             <a:extLst xmlns:a="http://schemas.openxmlformats.org/drawingml/2006/main">
               <a:ext uri="{FF2B5EF4-FFF2-40B4-BE49-F238E27FC236}">
-                <a16:creationId xmlns:a16="http://schemas.microsoft.com/office/drawing/2014/main" id="{84E90CD8-A359-449D-BE65-E9D51E770973}"/>
+                <a16:creationId xmlns:a16="http://schemas.microsoft.com/office/drawing/2014/main" id="{FD243211-71C8-473A-AD5A-E39470456D12}"/>
               </a:ext>
             </a:extLst>
           </p:cNvPr>
@@ -39559,7 +39559,7 @@
           <p:cNvPr id="18" name="파일&#10;구현&#10;테스트">
             <a:extLst xmlns:a="http://schemas.openxmlformats.org/drawingml/2006/main">
               <a:ext uri="{FF2B5EF4-FFF2-40B4-BE49-F238E27FC236}">
-                <a16:creationId xmlns:a16="http://schemas.microsoft.com/office/drawing/2014/main" id="{8760371F-825E-41CA-A555-17DAEF84751B}"/>
+                <a16:creationId xmlns:a16="http://schemas.microsoft.com/office/drawing/2014/main" id="{1366B219-BB32-484C-960D-C4A469CD6482}"/>
               </a:ext>
             </a:extLst>
           </p:cNvPr>
@@ -39763,7 +39763,7 @@
           <p:cNvPr id="19" name="원하는 결과&#10;허용할 범위&#10;완료 수용">
             <a:extLst xmlns:a="http://schemas.openxmlformats.org/drawingml/2006/main">
               <a:ext uri="{FF2B5EF4-FFF2-40B4-BE49-F238E27FC236}">
-                <a16:creationId xmlns:a16="http://schemas.microsoft.com/office/drawing/2014/main" id="{8534EA5D-30BD-4ADA-8239-D6116BAFDDD1}"/>
+                <a16:creationId xmlns:a16="http://schemas.microsoft.com/office/drawing/2014/main" id="{9434ACF1-F61A-4516-8E69-E51D2539FDE3}"/>
               </a:ext>
             </a:extLst>
           </p:cNvPr>
@@ -39967,7 +39967,7 @@
           <p:cNvPr id="20" name="≠">
             <a:extLst xmlns:a="http://schemas.openxmlformats.org/drawingml/2006/main">
               <a:ext uri="{FF2B5EF4-FFF2-40B4-BE49-F238E27FC236}">
-                <a16:creationId xmlns:a16="http://schemas.microsoft.com/office/drawing/2014/main" id="{A957E588-6BAE-4E4B-99EE-02E27875E93A}"/>
+                <a16:creationId xmlns:a16="http://schemas.microsoft.com/office/drawing/2014/main" id="{EAABE29D-F7E0-4E3B-9EC7-CD6CBE851D73}"/>
               </a:ext>
             </a:extLst>
           </p:cNvPr>
@@ -40125,7 +40125,7 @@
           <p:cNvPr id="21" name="Agent는 제안하고, 사람은 최종 선택·승인한다.">
             <a:extLst xmlns:a="http://schemas.openxmlformats.org/drawingml/2006/main">
               <a:ext uri="{FF2B5EF4-FFF2-40B4-BE49-F238E27FC236}">
-                <a16:creationId xmlns:a16="http://schemas.microsoft.com/office/drawing/2014/main" id="{89ECAF14-AD53-4A94-827D-823186A1FE45}"/>
+                <a16:creationId xmlns:a16="http://schemas.microsoft.com/office/drawing/2014/main" id="{C836268E-CA39-4821-87DD-3B83CFE01BA6}"/>
               </a:ext>
             </a:extLst>
           </p:cNvPr>
@@ -40283,7 +40283,7 @@
           <p:cNvPr id="22" name="Legacy module connection">
             <a:extLst xmlns:a="http://schemas.openxmlformats.org/drawingml/2006/main">
               <a:ext uri="{FF2B5EF4-FFF2-40B4-BE49-F238E27FC236}">
-                <a16:creationId xmlns:a16="http://schemas.microsoft.com/office/drawing/2014/main" id="{B0E3D0A3-8A86-4866-A473-32AFE70987B3}"/>
+                <a16:creationId xmlns:a16="http://schemas.microsoft.com/office/drawing/2014/main" id="{45C0B6AD-6CF4-4991-8F50-7C2D24AFA6A2}"/>
               </a:ext>
             </a:extLst>
           </p:cNvPr>
@@ -40439,7 +40439,7 @@
     </p:spTree>
     <p:extLst>
       <p:ext uri="{BB962C8B-B14F-4D97-AF65-F5344CB8AC3E}">
-        <p14:creationId xmlns:p14="http://schemas.microsoft.com/office/powerpoint/2010/main" val="955057490"/>
+        <p14:creationId xmlns:p14="http://schemas.microsoft.com/office/powerpoint/2010/main" val="32565854"/>
       </p:ext>
     </p:extLst>
   </p:cSld>

</xml_diff>